<commit_message>
No Conformidades: corte 03-08-2026
438 registros. Las abiertas bajan de 30 a 19 y el cierre global sube de 93,1%
a 95,7%.

Talabre cerró 13 hallazgos en la semana, entre ellos 6 de las internas de
Adquisiciones que superaban los 100 días —una llevaba 385—. Las abiertas
internas caen de 11 a 5 y las que superan 100 días, de 16 a 7. El frente pasa
de Crítico a Atención.

Solo entró un hallazgo nuevo: Talabre N°241, externa del cliente, CALIDAD.

Lo que queda de deuda antigua está concentrado: 3 de las 5 internas abiertas
son de Expeditoría en Talabre —392, 328 y 224 días, todas «Iniciado» y del
mismo responsable—.

Co-Authored-By: Claude Opus 5 <noreply@anthropic.com>
Claude-Session: https://claude.ai/code/session_011SHyPcub1TtjA2kTAsaPFu
</commit_message>
<xml_diff>
--- a/modulo_nc/Panel_No_Conformidades.pptx
+++ b/modulo_nc/Panel_No_Conformidades.pptx
@@ -216,28 +216,28 @@
                 <c:ptCount val="8"/>
                 <c:lvl>
                   <c:pt idx="0">
-                    <c:v>02-06</c:v>
+                    <c:v>09-06</c:v>
                   </c:pt>
                   <c:pt idx="1">
-                    <c:v>09-06</c:v>
+                    <c:v>16-06</c:v>
                   </c:pt>
                   <c:pt idx="2">
-                    <c:v>16-06</c:v>
+                    <c:v>23-06</c:v>
                   </c:pt>
                   <c:pt idx="3">
-                    <c:v>23-06</c:v>
+                    <c:v>30-06</c:v>
                   </c:pt>
                   <c:pt idx="4">
-                    <c:v>30-06</c:v>
+                    <c:v>07-07</c:v>
                   </c:pt>
                   <c:pt idx="5">
-                    <c:v>07-07</c:v>
+                    <c:v>14-07</c:v>
                   </c:pt>
                   <c:pt idx="6">
-                    <c:v>14-07</c:v>
+                    <c:v>21-07</c:v>
                   </c:pt>
                   <c:pt idx="7">
-                    <c:v>21-07</c:v>
+                    <c:v>28-07</c:v>
                   </c:pt>
                 </c:lvl>
               </c:multiLvlStrCache>
@@ -250,28 +250,28 @@
                 <c:formatCode>General</c:formatCode>
                 <c:ptCount val="8"/>
                 <c:pt idx="0">
-                  <c:v/>
+                  <c:v>2</c:v>
                 </c:pt>
                 <c:pt idx="1">
-                  <c:v>2</c:v>
+                  <c:v/>
                 </c:pt>
                 <c:pt idx="2">
                   <c:v/>
                 </c:pt>
                 <c:pt idx="3">
+                  <c:v>2</c:v>
+                </c:pt>
+                <c:pt idx="4">
                   <c:v>1</c:v>
                 </c:pt>
-                <c:pt idx="4">
+                <c:pt idx="5">
+                  <c:v/>
+                </c:pt>
+                <c:pt idx="6">
                   <c:v>4</c:v>
                 </c:pt>
-                <c:pt idx="5">
+                <c:pt idx="7">
                   <c:v>1</c:v>
-                </c:pt>
-                <c:pt idx="6">
-                  <c:v/>
-                </c:pt>
-                <c:pt idx="7">
-                  <c:v>4</c:v>
                 </c:pt>
               </c:numCache>
             </c:numRef>
@@ -330,28 +330,28 @@
                 <c:ptCount val="8"/>
                 <c:lvl>
                   <c:pt idx="0">
-                    <c:v>02-06</c:v>
+                    <c:v>09-06</c:v>
                   </c:pt>
                   <c:pt idx="1">
-                    <c:v>09-06</c:v>
+                    <c:v>16-06</c:v>
                   </c:pt>
                   <c:pt idx="2">
-                    <c:v>16-06</c:v>
+                    <c:v>23-06</c:v>
                   </c:pt>
                   <c:pt idx="3">
-                    <c:v>23-06</c:v>
+                    <c:v>30-06</c:v>
                   </c:pt>
                   <c:pt idx="4">
-                    <c:v>30-06</c:v>
+                    <c:v>07-07</c:v>
                   </c:pt>
                   <c:pt idx="5">
-                    <c:v>07-07</c:v>
+                    <c:v>14-07</c:v>
                   </c:pt>
                   <c:pt idx="6">
-                    <c:v>14-07</c:v>
+                    <c:v>21-07</c:v>
                   </c:pt>
                   <c:pt idx="7">
-                    <c:v>21-07</c:v>
+                    <c:v>28-07</c:v>
                   </c:pt>
                 </c:lvl>
               </c:multiLvlStrCache>
@@ -364,16 +364,16 @@
                 <c:formatCode>General</c:formatCode>
                 <c:ptCount val="8"/>
                 <c:pt idx="0">
-                  <c:v>1</c:v>
+                  <c:v>2</c:v>
                 </c:pt>
                 <c:pt idx="1">
+                  <c:v/>
+                </c:pt>
+                <c:pt idx="2">
                   <c:v>2</c:v>
                 </c:pt>
-                <c:pt idx="2">
-                  <c:v/>
-                </c:pt>
                 <c:pt idx="3">
-                  <c:v>1</c:v>
+                  <c:v>2</c:v>
                 </c:pt>
                 <c:pt idx="4">
                   <c:v/>
@@ -382,7 +382,7 @@
                   <c:v/>
                 </c:pt>
                 <c:pt idx="6">
-                  <c:v/>
+                  <c:v>1</c:v>
                 </c:pt>
                 <c:pt idx="7">
                   <c:v/>
@@ -757,7 +757,7 @@
                   <c:v>30</c:v>
                 </c:pt>
                 <c:pt idx="1">
-                  <c:v>186</c:v>
+                  <c:v>188</c:v>
                 </c:pt>
                 <c:pt idx="2">
                   <c:v>1</c:v>
@@ -1225,10 +1225,10 @@
                 <c:formatCode>General</c:formatCode>
                 <c:ptCount val="5"/>
                 <c:pt idx="0">
-                  <c:v>255</c:v>
+                  <c:v>266</c:v>
                 </c:pt>
                 <c:pt idx="1">
-                  <c:v>114</c:v>
+                  <c:v>116</c:v>
                 </c:pt>
                 <c:pt idx="2">
                   <c:v>23</c:v>
@@ -1321,10 +1321,10 @@
                 <c:formatCode>General</c:formatCode>
                 <c:ptCount val="5"/>
                 <c:pt idx="0">
-                  <c:v>24</c:v>
+                  <c:v>14</c:v>
                 </c:pt>
                 <c:pt idx="1">
-                  <c:v>5</c:v>
+                  <c:v>4</c:v>
                 </c:pt>
                 <c:pt idx="2">
                   <c:v/>
@@ -1522,7 +1522,7 @@
                 </a:solidFill>
                 <a:latin typeface="Calibri"/>
               </a:rPr>
-              <a:t>Antigüedad de los 30 hallazgos abiertos</a:t>
+              <a:t>Antigüedad de los 19 hallazgos abiertos</a:t>
             </a:r>
           </a:p>
         </c:rich>
@@ -1603,7 +1603,7 @@
                 <c:formatCode>General</c:formatCode>
                 <c:ptCount val="1"/>
                 <c:pt idx="0">
-                  <c:v>9</c:v>
+                  <c:v>7</c:v>
                 </c:pt>
               </c:numCache>
             </c:numRef>
@@ -1747,7 +1747,7 @@
                 <c:formatCode>General</c:formatCode>
                 <c:ptCount val="1"/>
                 <c:pt idx="0">
-                  <c:v>9</c:v>
+                  <c:v>4</c:v>
                 </c:pt>
               </c:numCache>
             </c:numRef>
@@ -1819,7 +1819,7 @@
                 <c:formatCode>General</c:formatCode>
                 <c:ptCount val="1"/>
                 <c:pt idx="0">
-                  <c:v>5</c:v>
+                  <c:v>2</c:v>
                 </c:pt>
               </c:numCache>
             </c:numRef>
@@ -1891,7 +1891,7 @@
                 <c:formatCode>General</c:formatCode>
                 <c:ptCount val="1"/>
                 <c:pt idx="0">
-                  <c:v>2</c:v>
+                  <c:v>1</c:v>
                 </c:pt>
               </c:numCache>
             </c:numRef>
@@ -2608,25 +2608,25 @@
                 <c:formatCode>General</c:formatCode>
                 <c:ptCount val="8"/>
                 <c:pt idx="0">
-                  <c:v>127</c:v>
+                  <c:v>131</c:v>
                 </c:pt>
                 <c:pt idx="1">
                   <c:v>23</c:v>
                 </c:pt>
                 <c:pt idx="2">
-                  <c:v>15</c:v>
+                  <c:v>16</c:v>
                 </c:pt>
                 <c:pt idx="3">
-                  <c:v>10</c:v>
+                  <c:v>11</c:v>
                 </c:pt>
                 <c:pt idx="4">
                   <c:v>9</c:v>
                 </c:pt>
                 <c:pt idx="5">
-                  <c:v>7</c:v>
+                  <c:v>8</c:v>
                 </c:pt>
                 <c:pt idx="6">
-                  <c:v>2</c:v>
+                  <c:v>8</c:v>
                 </c:pt>
                 <c:pt idx="7">
                   <c:v>8</c:v>
@@ -2722,25 +2722,25 @@
                 <c:formatCode>General</c:formatCode>
                 <c:ptCount val="8"/>
                 <c:pt idx="0">
-                  <c:v>12</c:v>
+                  <c:v>9</c:v>
                 </c:pt>
                 <c:pt idx="1">
-                  <c:v>2</c:v>
+                  <c:v>3</c:v>
                 </c:pt>
                 <c:pt idx="2">
-                  <c:v>1</c:v>
+                  <c:v/>
                 </c:pt>
                 <c:pt idx="3">
-                  <c:v>1</c:v>
+                  <c:v/>
                 </c:pt>
                 <c:pt idx="4">
                   <c:v/>
                 </c:pt>
                 <c:pt idx="5">
-                  <c:v>1</c:v>
+                  <c:v/>
                 </c:pt>
                 <c:pt idx="6">
-                  <c:v>6</c:v>
+                  <c:v/>
                 </c:pt>
                 <c:pt idx="7">
                   <c:v/>
@@ -5657,7 +5657,7 @@
                 <a:ea typeface="Calibri" pitchFamily="34" charset="-122"/>
                 <a:cs typeface="Calibri" pitchFamily="34" charset="-120"/>
               </a:rPr>
-              <a:t>436 hallazgos levantados entre 10-02-2023 y 27-07-2026 (Desaladora 95 · Talabre 239 · Arqueros 94 · Oficina Central 8).</a:t>
+              <a:t>438 hallazgos levantados entre 10-02-2023 y 28-07-2026 (Desaladora 95 · Talabre 241 · Arqueros 94 · Oficina Central 8).</a:t>
             </a:r>
             <a:endParaRPr lang="en-US" sz="1350" dirty="0"/>
           </a:p>
@@ -5716,7 +5716,7 @@
                 <a:ea typeface="Cambria" pitchFamily="34" charset="-122"/>
                 <a:cs typeface="Cambria" pitchFamily="34" charset="-120"/>
               </a:rPr>
-              <a:t>93,1%</a:t>
+              <a:t>95,7%</a:t>
             </a:r>
             <a:endParaRPr lang="en-US" sz="3400" dirty="0"/>
           </a:p>
@@ -5794,7 +5794,7 @@
                 <a:ea typeface="Cambria" pitchFamily="34" charset="-122"/>
                 <a:cs typeface="Cambria" pitchFamily="34" charset="-120"/>
               </a:rPr>
-              <a:t>30</a:t>
+              <a:t>19</a:t>
             </a:r>
             <a:endParaRPr lang="en-US" sz="3400" dirty="0"/>
           </a:p>
@@ -6028,7 +6028,7 @@
                 <a:ea typeface="Calibri" pitchFamily="34" charset="-122"/>
                 <a:cs typeface="Calibri" pitchFamily="34" charset="-120"/>
               </a:rPr>
-              <a:t>Corte: 27-07-2026</a:t>
+              <a:t>Corte: 03-08-2026</a:t>
             </a:r>
             <a:endParaRPr lang="en-US" sz="1100" dirty="0"/>
           </a:p>
@@ -6067,7 +6067,7 @@
                 <a:ea typeface="Calibri" pitchFamily="34" charset="-122"/>
                 <a:cs typeface="Calibri" pitchFamily="34" charset="-120"/>
               </a:rPr>
-              <a:t>Fuente: 5640140e-Data_NCR_1.xlsx — hoja «Observaciones» · Corte 27-07-2026 · 436 registros desde 10-02-2023</a:t>
+              <a:t>Fuente: 1e73482e-Data_NCR03082026.xlsx — hoja «Observaciones» · Corte 03-08-2026 · 438 registros desde 10-02-2023</a:t>
             </a:r>
             <a:endParaRPr lang="en-US" sz="850" dirty="0"/>
           </a:p>
@@ -6887,7 +6887,7 @@
                 <a:ea typeface="Calibri" pitchFamily="34" charset="-122"/>
                 <a:cs typeface="Calibri" pitchFamily="34" charset="-120"/>
               </a:rPr>
-              <a:t>76</a:t>
+              <a:t>83</a:t>
             </a:r>
             <a:endParaRPr lang="en-US" sz="1050" dirty="0"/>
           </a:p>
@@ -7242,7 +7242,7 @@
                 <a:ea typeface="Calibri" pitchFamily="34" charset="-122"/>
                 <a:cs typeface="Calibri" pitchFamily="34" charset="-120"/>
               </a:rPr>
-              <a:t>21</a:t>
+              <a:t>28</a:t>
             </a:r>
             <a:endParaRPr lang="en-US" sz="1050" dirty="0"/>
           </a:p>
@@ -7577,7 +7577,7 @@
                 <a:ea typeface="Calibri" pitchFamily="34" charset="-122"/>
                 <a:cs typeface="Calibri" pitchFamily="34" charset="-120"/>
               </a:rPr>
-              <a:t>0</a:t>
+              <a:t>7</a:t>
             </a:r>
             <a:endParaRPr lang="en-US" sz="1050" dirty="0"/>
           </a:p>
@@ -7662,7 +7662,7 @@
             </a:avLst>
           </a:prstGeom>
           <a:solidFill>
-            <a:srgbClr val="12233B"/>
+            <a:srgbClr val="E9EDF2"/>
           </a:solidFill>
           <a:ln/>
         </p:spPr>
@@ -7694,13 +7694,13 @@
             <a:r>
               <a:rPr lang="en-US" sz="1000" b="1" spc="100" kern="0" dirty="0">
                 <a:solidFill>
-                  <a:srgbClr val="E3A55B"/>
-                </a:solidFill>
-                <a:latin typeface="Calibri" pitchFamily="34" charset="0"/>
-                <a:ea typeface="Calibri" pitchFamily="34" charset="-122"/>
-                <a:cs typeface="Calibri" pitchFamily="34" charset="-120"/>
-              </a:rPr>
-              <a:t>SEMANA 21-07-2026 — 27-07-2026</a:t>
+                  <a:srgbClr val="56606E"/>
+                </a:solidFill>
+                <a:latin typeface="Calibri" pitchFamily="34" charset="0"/>
+                <a:ea typeface="Calibri" pitchFamily="34" charset="-122"/>
+                <a:cs typeface="Calibri" pitchFamily="34" charset="-120"/>
+              </a:rPr>
+              <a:t>SEMANA 28-07-2026 — 03-08-2026</a:t>
             </a:r>
             <a:endParaRPr lang="en-US" sz="1000" dirty="0"/>
           </a:p>
@@ -7733,13 +7733,13 @@
             <a:r>
               <a:rPr lang="en-US" sz="1150" dirty="0">
                 <a:solidFill>
-                  <a:srgbClr val="FFFFFF"/>
-                </a:solidFill>
-                <a:latin typeface="Calibri" pitchFamily="34" charset="0"/>
-                <a:ea typeface="Calibri" pitchFamily="34" charset="-122"/>
-                <a:cs typeface="Calibri" pitchFamily="34" charset="-120"/>
-              </a:rPr>
-              <a:t>1 hallazgo nuevo · 0 internos y 1 externo · MECÁNICA 1 · 1 sigue abierto</a:t>
+                  <a:srgbClr val="56606E"/>
+                </a:solidFill>
+                <a:latin typeface="Calibri" pitchFamily="34" charset="0"/>
+                <a:ea typeface="Calibri" pitchFamily="34" charset="-122"/>
+                <a:cs typeface="Calibri" pitchFamily="34" charset="-120"/>
+              </a:rPr>
+              <a:t>Sin hallazgos nuevos en el período.</a:t>
             </a:r>
             <a:endParaRPr lang="en-US" sz="1150" dirty="0"/>
           </a:p>
@@ -7778,7 +7778,7 @@
                 <a:ea typeface="Calibri" pitchFamily="34" charset="-122"/>
                 <a:cs typeface="Calibri" pitchFamily="34" charset="-120"/>
               </a:rPr>
-              <a:t>Fuente: 5640140e-Data_NCR_1.xlsx — hoja «Observaciones» · Corte 27-07-2026 · 436 registros desde 10-02-2023</a:t>
+              <a:t>Fuente: 1e73482e-Data_NCR03082026.xlsx — hoja «Observaciones» · Corte 03-08-2026 · 438 registros desde 10-02-2023</a:t>
             </a:r>
             <a:endParaRPr lang="en-US" sz="850" dirty="0"/>
           </a:p>
@@ -8131,7 +8131,7 @@
                 <a:ea typeface="Calibri" pitchFamily="34" charset="-122"/>
                 <a:cs typeface="Calibri" pitchFamily="34" charset="-120"/>
               </a:rPr>
-              <a:t>239 hallazgos levantados · 53 internos y 186 externos · 12 especialidades involucradas.</a:t>
+              <a:t>241 hallazgos levantados · 53 internos y 188 externos · 12 especialidades involucradas.</a:t>
             </a:r>
             <a:endParaRPr lang="en-US" sz="1350" dirty="0"/>
           </a:p>
@@ -8190,7 +8190,7 @@
                 <a:ea typeface="Cambria" pitchFamily="34" charset="-122"/>
                 <a:cs typeface="Cambria" pitchFamily="34" charset="-120"/>
               </a:rPr>
-              <a:t>89,1%</a:t>
+              <a:t>93,8%</a:t>
             </a:r>
             <a:endParaRPr lang="en-US" sz="3400" dirty="0"/>
           </a:p>
@@ -8268,7 +8268,7 @@
                 <a:ea typeface="Cambria" pitchFamily="34" charset="-122"/>
                 <a:cs typeface="Cambria" pitchFamily="34" charset="-120"/>
               </a:rPr>
-              <a:t>26</a:t>
+              <a:t>15</a:t>
             </a:r>
             <a:endParaRPr lang="en-US" sz="3400" dirty="0"/>
           </a:p>
@@ -8346,7 +8346,7 @@
                 <a:ea typeface="Cambria" pitchFamily="34" charset="-122"/>
                 <a:cs typeface="Cambria" pitchFamily="34" charset="-120"/>
               </a:rPr>
-              <a:t>22 d</a:t>
+              <a:t>23 d</a:t>
             </a:r>
             <a:endParaRPr lang="en-US" sz="3400" dirty="0"/>
           </a:p>
@@ -8424,7 +8424,7 @@
                 <a:ea typeface="Cambria" pitchFamily="34" charset="-122"/>
                 <a:cs typeface="Cambria" pitchFamily="34" charset="-120"/>
               </a:rPr>
-              <a:t>22,2%</a:t>
+              <a:t>22%</a:t>
             </a:r>
             <a:endParaRPr lang="en-US" sz="3400" dirty="0"/>
           </a:p>
@@ -8502,7 +8502,7 @@
                 <a:ea typeface="Calibri" pitchFamily="34" charset="-122"/>
                 <a:cs typeface="Calibri" pitchFamily="34" charset="-120"/>
               </a:rPr>
-              <a:t>Corte: 27-07-2026</a:t>
+              <a:t>Corte: 03-08-2026</a:t>
             </a:r>
             <a:endParaRPr lang="en-US" sz="1100" dirty="0"/>
           </a:p>
@@ -8541,7 +8541,7 @@
                 <a:ea typeface="Calibri" pitchFamily="34" charset="-122"/>
                 <a:cs typeface="Calibri" pitchFamily="34" charset="-120"/>
               </a:rPr>
-              <a:t>Fuente: 5640140e-Data_NCR_1.xlsx — hoja «Observaciones» · Corte 27-07-2026 · 436 registros desde 10-02-2023</a:t>
+              <a:t>Fuente: 1e73482e-Data_NCR03082026.xlsx — hoja «Observaciones» · Corte 03-08-2026 · 438 registros desde 10-02-2023</a:t>
             </a:r>
             <a:endParaRPr lang="en-US" sz="850" dirty="0"/>
           </a:p>
@@ -8807,7 +8807,7 @@
                 <a:ea typeface="Cambria" pitchFamily="34" charset="-122"/>
                 <a:cs typeface="Cambria" pitchFamily="34" charset="-120"/>
               </a:rPr>
-              <a:t>239</a:t>
+              <a:t>241</a:t>
             </a:r>
             <a:endParaRPr lang="en-US" sz="4000" dirty="0"/>
           </a:p>
@@ -8846,7 +8846,7 @@
                 <a:ea typeface="Calibri" pitchFamily="34" charset="-122"/>
                 <a:cs typeface="Calibri" pitchFamily="34" charset="-120"/>
               </a:rPr>
-              <a:t>213 cerrados</a:t>
+              <a:t>226 cerrados</a:t>
             </a:r>
             <a:endParaRPr lang="en-US" sz="1400" dirty="0"/>
           </a:p>
@@ -8924,7 +8924,7 @@
                 <a:ea typeface="Calibri" pitchFamily="34" charset="-122"/>
                 <a:cs typeface="Calibri" pitchFamily="34" charset="-120"/>
               </a:rPr>
-              <a:t>53 internos · 186 externos</a:t>
+              <a:t>53 internos · 188 externos</a:t>
             </a:r>
             <a:endParaRPr lang="en-US" sz="950" dirty="0"/>
           </a:p>
@@ -9017,7 +9017,7 @@
                 <a:ea typeface="Cambria" pitchFamily="34" charset="-122"/>
                 <a:cs typeface="Cambria" pitchFamily="34" charset="-120"/>
               </a:rPr>
-              <a:t>89,1%</a:t>
+              <a:t>93,8%</a:t>
             </a:r>
             <a:endParaRPr lang="en-US" sz="4000" dirty="0"/>
           </a:p>
@@ -9056,7 +9056,7 @@
                 <a:ea typeface="Calibri" pitchFamily="34" charset="-122"/>
                 <a:cs typeface="Calibri" pitchFamily="34" charset="-120"/>
               </a:rPr>
-              <a:t>213/239</a:t>
+              <a:t>226/241</a:t>
             </a:r>
             <a:endParaRPr lang="en-US" sz="1400" dirty="0"/>
           </a:p>
@@ -9134,7 +9134,7 @@
                 <a:ea typeface="Calibri" pitchFamily="34" charset="-122"/>
                 <a:cs typeface="Calibri" pitchFamily="34" charset="-120"/>
               </a:rPr>
-              <a:t>Global del módulo: 93,1%</a:t>
+              <a:t>Global del módulo: 95,7%</a:t>
             </a:r>
             <a:endParaRPr lang="en-US" sz="950" dirty="0"/>
           </a:p>
@@ -9227,7 +9227,7 @@
                 <a:ea typeface="Cambria" pitchFamily="34" charset="-122"/>
                 <a:cs typeface="Cambria" pitchFamily="34" charset="-120"/>
               </a:rPr>
-              <a:t>26</a:t>
+              <a:t>15</a:t>
             </a:r>
             <a:endParaRPr lang="en-US" sz="4000" dirty="0"/>
           </a:p>
@@ -9344,7 +9344,7 @@
                 <a:ea typeface="Calibri" pitchFamily="34" charset="-122"/>
                 <a:cs typeface="Calibri" pitchFamily="34" charset="-120"/>
               </a:rPr>
-              <a:t>6 no aceptado · 16 iniciado · 4 listo para revisión</a:t>
+              <a:t>12 iniciado · 1 no aceptado · 2 listo para revisión</a:t>
             </a:r>
             <a:endParaRPr lang="en-US" sz="950" dirty="0"/>
           </a:p>
@@ -9437,7 +9437,7 @@
                 <a:ea typeface="Cambria" pitchFamily="34" charset="-122"/>
                 <a:cs typeface="Cambria" pitchFamily="34" charset="-120"/>
               </a:rPr>
-              <a:t>22</a:t>
+              <a:t>23</a:t>
             </a:r>
             <a:endParaRPr lang="en-US" sz="4000" dirty="0"/>
           </a:p>
@@ -9554,7 +9554,7 @@
                 <a:ea typeface="Calibri" pitchFamily="34" charset="-122"/>
                 <a:cs typeface="Calibri" pitchFamily="34" charset="-120"/>
               </a:rPr>
-              <a:t>el más lento tomó 269 días</a:t>
+              <a:t>el más lento tomó 389 días</a:t>
             </a:r>
             <a:endParaRPr lang="en-US" sz="950" dirty="0"/>
           </a:p>
@@ -9670,7 +9670,7 @@
                 <a:ea typeface="Cambria" pitchFamily="34" charset="-122"/>
                 <a:cs typeface="Cambria" pitchFamily="34" charset="-120"/>
               </a:rPr>
-              <a:t>22,2%</a:t>
+              <a:t>22%</a:t>
             </a:r>
             <a:endParaRPr lang="en-US" sz="2600" dirty="0"/>
           </a:p>
@@ -9732,7 +9732,7 @@
                 <a:ea typeface="Calibri" pitchFamily="34" charset="-122"/>
                 <a:cs typeface="Calibri" pitchFamily="34" charset="-120"/>
               </a:rPr>
-              <a:t>global del módulo 37,9%</a:t>
+              <a:t>global del módulo 37,8%</a:t>
             </a:r>
             <a:endParaRPr lang="en-US" sz="1000" dirty="0"/>
           </a:p>
@@ -9853,7 +9853,7 @@
                 <a:ea typeface="Calibri" pitchFamily="34" charset="-122"/>
                 <a:cs typeface="Calibri" pitchFamily="34" charset="-120"/>
               </a:rPr>
-              <a:t>9 ab.</a:t>
+              <a:t>3 ab.</a:t>
             </a:r>
             <a:endParaRPr lang="en-US" sz="950" dirty="0"/>
           </a:p>
@@ -9990,7 +9990,7 @@
                 <a:ea typeface="Calibri" pitchFamily="34" charset="-122"/>
                 <a:cs typeface="Calibri" pitchFamily="34" charset="-120"/>
               </a:rPr>
-              <a:t>17 ab.</a:t>
+              <a:t>12 ab.</a:t>
             </a:r>
             <a:endParaRPr lang="en-US" sz="950" dirty="0"/>
           </a:p>
@@ -10029,7 +10029,7 @@
                 <a:ea typeface="Cambria" pitchFamily="34" charset="-122"/>
                 <a:cs typeface="Cambria" pitchFamily="34" charset="-120"/>
               </a:rPr>
-              <a:t>186</a:t>
+              <a:t>188</a:t>
             </a:r>
             <a:endParaRPr lang="en-US" sz="1600" dirty="0"/>
           </a:p>
@@ -10068,7 +10068,7 @@
                 <a:ea typeface="Calibri" pitchFamily="34" charset="-122"/>
                 <a:cs typeface="Calibri" pitchFamily="34" charset="-120"/>
               </a:rPr>
-              <a:t>Fuente: 5640140e-Data_NCR_1.xlsx — hoja «Observaciones» · Corte 27-07-2026 · 436 registros desde 10-02-2023</a:t>
+              <a:t>Fuente: 1e73482e-Data_NCR03082026.xlsx — hoja «Observaciones» · Corte 03-08-2026 · 438 registros desde 10-02-2023</a:t>
             </a:r>
             <a:endParaRPr lang="en-US" sz="850" dirty="0"/>
           </a:p>
@@ -10319,7 +10319,7 @@
                 <a:ea typeface="Calibri" pitchFamily="34" charset="-122"/>
                 <a:cs typeface="Calibri" pitchFamily="34" charset="-120"/>
               </a:rPr>
-              <a:t>26 hallazgos siguen abiertos; 7 con más de 180 días. Se listan del más antiguo al más reciente.</a:t>
+              <a:t>15 hallazgos siguen abiertos; 3 con más de 180 días. Se listan del más antiguo al más reciente.</a:t>
             </a:r>
             <a:endParaRPr lang="en-US" sz="1350" dirty="0"/>
           </a:p>
@@ -10693,7 +10693,7 @@
                 <a:ea typeface="Calibri" pitchFamily="34" charset="-122"/>
                 <a:cs typeface="Calibri" pitchFamily="34" charset="-120"/>
               </a:rPr>
-              <a:t>20</a:t>
+              <a:t>21</a:t>
             </a:r>
             <a:endParaRPr lang="en-US" sz="1050" dirty="0"/>
           </a:p>
@@ -10810,7 +10810,7 @@
                 <a:ea typeface="Calibri" pitchFamily="34" charset="-122"/>
                 <a:cs typeface="Calibri" pitchFamily="34" charset="-120"/>
               </a:rPr>
-              <a:t>ADQUISICIONES</a:t>
+              <a:t>EXPEDITORÍA</a:t>
             </a:r>
             <a:endParaRPr lang="en-US" sz="1050" dirty="0"/>
           </a:p>
@@ -10849,7 +10849,7 @@
                 <a:ea typeface="Calibri" pitchFamily="34" charset="-122"/>
                 <a:cs typeface="Calibri" pitchFamily="34" charset="-120"/>
               </a:rPr>
-              <a:t>Alejandro Rivera G.</a:t>
+              <a:t>Alvaro Cortés V.</a:t>
             </a:r>
             <a:endParaRPr lang="en-US" sz="1050" dirty="0"/>
           </a:p>
@@ -10888,7 +10888,7 @@
                 <a:ea typeface="Calibri" pitchFamily="34" charset="-122"/>
                 <a:cs typeface="Calibri" pitchFamily="34" charset="-120"/>
               </a:rPr>
-              <a:t>No aceptado</a:t>
+              <a:t>Iniciado</a:t>
             </a:r>
             <a:endParaRPr lang="en-US" sz="1050" dirty="0"/>
           </a:p>
@@ -10927,7 +10927,7 @@
                 <a:ea typeface="Calibri" pitchFamily="34" charset="-122"/>
                 <a:cs typeface="Calibri" pitchFamily="34" charset="-120"/>
               </a:rPr>
-              <a:t>385</a:t>
+              <a:t>392</a:t>
             </a:r>
             <a:endParaRPr lang="en-US" sz="1050" dirty="0"/>
           </a:p>
@@ -11048,7 +11048,7 @@
                 <a:ea typeface="Calibri" pitchFamily="34" charset="-122"/>
                 <a:cs typeface="Calibri" pitchFamily="34" charset="-120"/>
               </a:rPr>
-              <a:t>21</a:t>
+              <a:t>72</a:t>
             </a:r>
             <a:endParaRPr lang="en-US" sz="1050" dirty="0"/>
           </a:p>
@@ -11282,7 +11282,7 @@
                 <a:ea typeface="Calibri" pitchFamily="34" charset="-122"/>
                 <a:cs typeface="Calibri" pitchFamily="34" charset="-120"/>
               </a:rPr>
-              <a:t>385</a:t>
+              <a:t>328</a:t>
             </a:r>
             <a:endParaRPr lang="en-US" sz="1050" dirty="0"/>
           </a:p>
@@ -11321,7 +11321,7 @@
                 <a:ea typeface="Calibri" pitchFamily="34" charset="-122"/>
                 <a:cs typeface="Calibri" pitchFamily="34" charset="-120"/>
               </a:rPr>
-              <a:t>Incumplimiento a Plan de Calidad de…</a:t>
+              <a:t>Incumplimiento a la recepción de ma…</a:t>
             </a:r>
             <a:endParaRPr lang="en-US" sz="1000" dirty="0"/>
           </a:p>
@@ -11383,7 +11383,7 @@
                 <a:ea typeface="Calibri" pitchFamily="34" charset="-122"/>
                 <a:cs typeface="Calibri" pitchFamily="34" charset="-120"/>
               </a:rPr>
-              <a:t>71</a:t>
+              <a:t>142</a:t>
             </a:r>
             <a:endParaRPr lang="en-US" sz="1050" dirty="0"/>
           </a:p>
@@ -11500,7 +11500,7 @@
                 <a:ea typeface="Calibri" pitchFamily="34" charset="-122"/>
                 <a:cs typeface="Calibri" pitchFamily="34" charset="-120"/>
               </a:rPr>
-              <a:t>ADQUISICIONES</a:t>
+              <a:t>EXPEDITORÍA</a:t>
             </a:r>
             <a:endParaRPr lang="en-US" sz="1050" dirty="0"/>
           </a:p>
@@ -11539,7 +11539,7 @@
                 <a:ea typeface="Calibri" pitchFamily="34" charset="-122"/>
                 <a:cs typeface="Calibri" pitchFamily="34" charset="-120"/>
               </a:rPr>
-              <a:t>Alejandro Rivera G.</a:t>
+              <a:t>Alvaro Cortés V.</a:t>
             </a:r>
             <a:endParaRPr lang="en-US" sz="1050" dirty="0"/>
           </a:p>
@@ -11578,7 +11578,7 @@
                 <a:ea typeface="Calibri" pitchFamily="34" charset="-122"/>
                 <a:cs typeface="Calibri" pitchFamily="34" charset="-120"/>
               </a:rPr>
-              <a:t>No aceptado</a:t>
+              <a:t>Iniciado</a:t>
             </a:r>
             <a:endParaRPr lang="en-US" sz="1050" dirty="0"/>
           </a:p>
@@ -11617,7 +11617,7 @@
                 <a:ea typeface="Calibri" pitchFamily="34" charset="-122"/>
                 <a:cs typeface="Calibri" pitchFamily="34" charset="-120"/>
               </a:rPr>
-              <a:t>321</a:t>
+              <a:t>224</a:t>
             </a:r>
             <a:endParaRPr lang="en-US" sz="1050" dirty="0"/>
           </a:p>
@@ -11656,7 +11656,7 @@
                 <a:ea typeface="Calibri" pitchFamily="34" charset="-122"/>
                 <a:cs typeface="Calibri" pitchFamily="34" charset="-120"/>
               </a:rPr>
-              <a:t>Incumplimiento pto. 6.1 PIE maestra…</a:t>
+              <a:t>Daños manguerotes en recepción/desc…</a:t>
             </a:r>
             <a:endParaRPr lang="en-US" sz="1000" dirty="0"/>
           </a:p>
@@ -11738,7 +11738,7 @@
                 <a:ea typeface="Calibri" pitchFamily="34" charset="-122"/>
                 <a:cs typeface="Calibri" pitchFamily="34" charset="-120"/>
               </a:rPr>
-              <a:t>72</a:t>
+              <a:t>192</a:t>
             </a:r>
             <a:endParaRPr lang="en-US" sz="1050" dirty="0"/>
           </a:p>
@@ -11810,13 +11810,13 @@
             <a:r>
               <a:rPr lang="en-US" sz="1050" b="1" dirty="0">
                 <a:solidFill>
-                  <a:srgbClr val="2E6FB5"/>
-                </a:solidFill>
-                <a:latin typeface="Calibri" pitchFamily="34" charset="0"/>
-                <a:ea typeface="Calibri" pitchFamily="34" charset="-122"/>
-                <a:cs typeface="Calibri" pitchFamily="34" charset="-120"/>
-              </a:rPr>
-              <a:t>Interna (Besalco)</a:t>
+                  <a:srgbClr val="C87A32"/>
+                </a:solidFill>
+                <a:latin typeface="Calibri" pitchFamily="34" charset="0"/>
+                <a:ea typeface="Calibri" pitchFamily="34" charset="-122"/>
+                <a:cs typeface="Calibri" pitchFamily="34" charset="-120"/>
+              </a:rPr>
+              <a:t>Externa · Cliente</a:t>
             </a:r>
             <a:endParaRPr lang="en-US" sz="1050" dirty="0"/>
           </a:p>
@@ -11855,7 +11855,7 @@
                 <a:ea typeface="Calibri" pitchFamily="34" charset="-122"/>
                 <a:cs typeface="Calibri" pitchFamily="34" charset="-120"/>
               </a:rPr>
-              <a:t>EXPEDITORÍA</a:t>
+              <a:t>OO.CC</a:t>
             </a:r>
             <a:endParaRPr lang="en-US" sz="1050" dirty="0"/>
           </a:p>
@@ -11894,7 +11894,7 @@
                 <a:ea typeface="Calibri" pitchFamily="34" charset="-122"/>
                 <a:cs typeface="Calibri" pitchFamily="34" charset="-120"/>
               </a:rPr>
-              <a:t>Alvaro Cortés V.</a:t>
+              <a:t>Sebastián Ramos</a:t>
             </a:r>
             <a:endParaRPr lang="en-US" sz="1050" dirty="0"/>
           </a:p>
@@ -11964,15 +11964,15 @@
               <a:buNone/>
             </a:pPr>
             <a:r>
-              <a:rPr lang="en-US" sz="1050" b="1" dirty="0">
-                <a:solidFill>
-                  <a:srgbClr val="C0392B"/>
-                </a:solidFill>
-                <a:latin typeface="Calibri" pitchFamily="34" charset="0"/>
-                <a:ea typeface="Calibri" pitchFamily="34" charset="-122"/>
-                <a:cs typeface="Calibri" pitchFamily="34" charset="-120"/>
-              </a:rPr>
-              <a:t>321</a:t>
+              <a:rPr lang="en-US" sz="1050" dirty="0">
+                <a:solidFill>
+                  <a:srgbClr val="1A2433"/>
+                </a:solidFill>
+                <a:latin typeface="Calibri" pitchFamily="34" charset="0"/>
+                <a:ea typeface="Calibri" pitchFamily="34" charset="-122"/>
+                <a:cs typeface="Calibri" pitchFamily="34" charset="-120"/>
+              </a:rPr>
+              <a:t>139</a:t>
             </a:r>
             <a:endParaRPr lang="en-US" sz="1050" dirty="0"/>
           </a:p>
@@ -12011,7 +12011,7 @@
                 <a:ea typeface="Calibri" pitchFamily="34" charset="-122"/>
                 <a:cs typeface="Calibri" pitchFamily="34" charset="-120"/>
               </a:rPr>
-              <a:t>Incumplimiento a la recepción de ma…</a:t>
+              <a:t>Fundaciones sin relleno estructural…</a:t>
             </a:r>
             <a:endParaRPr lang="en-US" sz="1000" dirty="0"/>
           </a:p>
@@ -12073,7 +12073,7 @@
                 <a:ea typeface="Calibri" pitchFamily="34" charset="-122"/>
                 <a:cs typeface="Calibri" pitchFamily="34" charset="-120"/>
               </a:rPr>
-              <a:t>86</a:t>
+              <a:t>198</a:t>
             </a:r>
             <a:endParaRPr lang="en-US" sz="1050" dirty="0"/>
           </a:p>
@@ -12112,7 +12112,7 @@
                 <a:ea typeface="Calibri" pitchFamily="34" charset="-122"/>
                 <a:cs typeface="Calibri" pitchFamily="34" charset="-120"/>
               </a:rPr>
-              <a:t>No Conformidad</a:t>
+              <a:t>Producto No Conforme</a:t>
             </a:r>
             <a:endParaRPr lang="en-US" sz="1050" dirty="0"/>
           </a:p>
@@ -12145,13 +12145,13 @@
             <a:r>
               <a:rPr lang="en-US" sz="1050" b="1" dirty="0">
                 <a:solidFill>
-                  <a:srgbClr val="2E6FB5"/>
-                </a:solidFill>
-                <a:latin typeface="Calibri" pitchFamily="34" charset="0"/>
-                <a:ea typeface="Calibri" pitchFamily="34" charset="-122"/>
-                <a:cs typeface="Calibri" pitchFamily="34" charset="-120"/>
-              </a:rPr>
-              <a:t>Interna (Besalco)</a:t>
+                  <a:srgbClr val="C87A32"/>
+                </a:solidFill>
+                <a:latin typeface="Calibri" pitchFamily="34" charset="0"/>
+                <a:ea typeface="Calibri" pitchFamily="34" charset="-122"/>
+                <a:cs typeface="Calibri" pitchFamily="34" charset="-120"/>
+              </a:rPr>
+              <a:t>Externa · Cliente</a:t>
             </a:r>
             <a:endParaRPr lang="en-US" sz="1050" dirty="0"/>
           </a:p>
@@ -12190,7 +12190,7 @@
                 <a:ea typeface="Calibri" pitchFamily="34" charset="-122"/>
                 <a:cs typeface="Calibri" pitchFamily="34" charset="-120"/>
               </a:rPr>
-              <a:t>ADQUISICIONES</a:t>
+              <a:t>OO.CC</a:t>
             </a:r>
             <a:endParaRPr lang="en-US" sz="1050" dirty="0"/>
           </a:p>
@@ -12229,7 +12229,7 @@
                 <a:ea typeface="Calibri" pitchFamily="34" charset="-122"/>
                 <a:cs typeface="Calibri" pitchFamily="34" charset="-120"/>
               </a:rPr>
-              <a:t>Alejandro Rivera G.</a:t>
+              <a:t>Wladimir Carvajal …</a:t>
             </a:r>
             <a:endParaRPr lang="en-US" sz="1050" dirty="0"/>
           </a:p>
@@ -12268,7 +12268,7 @@
                 <a:ea typeface="Calibri" pitchFamily="34" charset="-122"/>
                 <a:cs typeface="Calibri" pitchFamily="34" charset="-120"/>
               </a:rPr>
-              <a:t>No aceptado</a:t>
+              <a:t>Iniciado</a:t>
             </a:r>
             <a:endParaRPr lang="en-US" sz="1050" dirty="0"/>
           </a:p>
@@ -12299,15 +12299,15 @@
               <a:buNone/>
             </a:pPr>
             <a:r>
-              <a:rPr lang="en-US" sz="1050" b="1" dirty="0">
-                <a:solidFill>
-                  <a:srgbClr val="C0392B"/>
-                </a:solidFill>
-                <a:latin typeface="Calibri" pitchFamily="34" charset="0"/>
-                <a:ea typeface="Calibri" pitchFamily="34" charset="-122"/>
-                <a:cs typeface="Calibri" pitchFamily="34" charset="-120"/>
-              </a:rPr>
-              <a:t>298</a:t>
+              <a:rPr lang="en-US" sz="1050" dirty="0">
+                <a:solidFill>
+                  <a:srgbClr val="1A2433"/>
+                </a:solidFill>
+                <a:latin typeface="Calibri" pitchFamily="34" charset="0"/>
+                <a:ea typeface="Calibri" pitchFamily="34" charset="-122"/>
+                <a:cs typeface="Calibri" pitchFamily="34" charset="-120"/>
+              </a:rPr>
+              <a:t>133</a:t>
             </a:r>
             <a:endParaRPr lang="en-US" sz="1050" dirty="0"/>
           </a:p>
@@ -12346,7 +12346,7 @@
                 <a:ea typeface="Calibri" pitchFamily="34" charset="-122"/>
                 <a:cs typeface="Calibri" pitchFamily="34" charset="-120"/>
               </a:rPr>
-              <a:t>Incumplimiento liberación suministr…</a:t>
+              <a:t>Corte en geomembrana HDPE instalada…</a:t>
             </a:r>
             <a:endParaRPr lang="en-US" sz="1000" dirty="0"/>
           </a:p>
@@ -12428,7 +12428,7 @@
                 <a:ea typeface="Calibri" pitchFamily="34" charset="-122"/>
                 <a:cs typeface="Calibri" pitchFamily="34" charset="-120"/>
               </a:rPr>
-              <a:t>140</a:t>
+              <a:t>205</a:t>
             </a:r>
             <a:endParaRPr lang="en-US" sz="1050" dirty="0"/>
           </a:p>
@@ -12467,7 +12467,7 @@
                 <a:ea typeface="Calibri" pitchFamily="34" charset="-122"/>
                 <a:cs typeface="Calibri" pitchFamily="34" charset="-120"/>
               </a:rPr>
-              <a:t>No Conformidad</a:t>
+              <a:t>Producto No Conforme</a:t>
             </a:r>
             <a:endParaRPr lang="en-US" sz="1050" dirty="0"/>
           </a:p>
@@ -12500,13 +12500,13 @@
             <a:r>
               <a:rPr lang="en-US" sz="1050" b="1" dirty="0">
                 <a:solidFill>
-                  <a:srgbClr val="2E6FB5"/>
-                </a:solidFill>
-                <a:latin typeface="Calibri" pitchFamily="34" charset="0"/>
-                <a:ea typeface="Calibri" pitchFamily="34" charset="-122"/>
-                <a:cs typeface="Calibri" pitchFamily="34" charset="-120"/>
-              </a:rPr>
-              <a:t>Interna (Besalco)</a:t>
+                  <a:srgbClr val="C87A32"/>
+                </a:solidFill>
+                <a:latin typeface="Calibri" pitchFamily="34" charset="0"/>
+                <a:ea typeface="Calibri" pitchFamily="34" charset="-122"/>
+                <a:cs typeface="Calibri" pitchFamily="34" charset="-120"/>
+              </a:rPr>
+              <a:t>Externa · Cliente</a:t>
             </a:r>
             <a:endParaRPr lang="en-US" sz="1050" dirty="0"/>
           </a:p>
@@ -12545,7 +12545,7 @@
                 <a:ea typeface="Calibri" pitchFamily="34" charset="-122"/>
                 <a:cs typeface="Calibri" pitchFamily="34" charset="-120"/>
               </a:rPr>
-              <a:t>ADQUISICIONES</a:t>
+              <a:t>OO.CC</a:t>
             </a:r>
             <a:endParaRPr lang="en-US" sz="1050" dirty="0"/>
           </a:p>
@@ -12584,7 +12584,7 @@
                 <a:ea typeface="Calibri" pitchFamily="34" charset="-122"/>
                 <a:cs typeface="Calibri" pitchFamily="34" charset="-120"/>
               </a:rPr>
-              <a:t>Alejandro Rivera G.</a:t>
+              <a:t>Sebastián Ramos</a:t>
             </a:r>
             <a:endParaRPr lang="en-US" sz="1050" dirty="0"/>
           </a:p>
@@ -12654,15 +12654,15 @@
               <a:buNone/>
             </a:pPr>
             <a:r>
-              <a:rPr lang="en-US" sz="1050" b="1" dirty="0">
-                <a:solidFill>
-                  <a:srgbClr val="C0392B"/>
-                </a:solidFill>
-                <a:latin typeface="Calibri" pitchFamily="34" charset="0"/>
-                <a:ea typeface="Calibri" pitchFamily="34" charset="-122"/>
-                <a:cs typeface="Calibri" pitchFamily="34" charset="-120"/>
-              </a:rPr>
-              <a:t>222</a:t>
+              <a:rPr lang="en-US" sz="1050" dirty="0">
+                <a:solidFill>
+                  <a:srgbClr val="1A2433"/>
+                </a:solidFill>
+                <a:latin typeface="Calibri" pitchFamily="34" charset="0"/>
+                <a:ea typeface="Calibri" pitchFamily="34" charset="-122"/>
+                <a:cs typeface="Calibri" pitchFamily="34" charset="-120"/>
+              </a:rPr>
+              <a:t>119</a:t>
             </a:r>
             <a:endParaRPr lang="en-US" sz="1050" dirty="0"/>
           </a:p>
@@ -12701,7 +12701,7 @@
                 <a:ea typeface="Calibri" pitchFamily="34" charset="-122"/>
                 <a:cs typeface="Calibri" pitchFamily="34" charset="-120"/>
               </a:rPr>
-              <a:t>Incumplimiento al PIE subcontrato S…</a:t>
+              <a:t>Solución proyectada asociada al ele…</a:t>
             </a:r>
             <a:endParaRPr lang="en-US" sz="1000" dirty="0"/>
           </a:p>
@@ -12763,7 +12763,7 @@
                 <a:ea typeface="Calibri" pitchFamily="34" charset="-122"/>
                 <a:cs typeface="Calibri" pitchFamily="34" charset="-120"/>
               </a:rPr>
-              <a:t>142</a:t>
+              <a:t>209</a:t>
             </a:r>
             <a:endParaRPr lang="en-US" sz="1050" dirty="0"/>
           </a:p>
@@ -12835,13 +12835,13 @@
             <a:r>
               <a:rPr lang="en-US" sz="1050" b="1" dirty="0">
                 <a:solidFill>
-                  <a:srgbClr val="2E6FB5"/>
-                </a:solidFill>
-                <a:latin typeface="Calibri" pitchFamily="34" charset="0"/>
-                <a:ea typeface="Calibri" pitchFamily="34" charset="-122"/>
-                <a:cs typeface="Calibri" pitchFamily="34" charset="-120"/>
-              </a:rPr>
-              <a:t>Interna (Besalco)</a:t>
+                  <a:srgbClr val="C87A32"/>
+                </a:solidFill>
+                <a:latin typeface="Calibri" pitchFamily="34" charset="0"/>
+                <a:ea typeface="Calibri" pitchFamily="34" charset="-122"/>
+                <a:cs typeface="Calibri" pitchFamily="34" charset="-120"/>
+              </a:rPr>
+              <a:t>Externa · Cliente</a:t>
             </a:r>
             <a:endParaRPr lang="en-US" sz="1050" dirty="0"/>
           </a:p>
@@ -12880,7 +12880,7 @@
                 <a:ea typeface="Calibri" pitchFamily="34" charset="-122"/>
                 <a:cs typeface="Calibri" pitchFamily="34" charset="-120"/>
               </a:rPr>
-              <a:t>EXPEDITORÍA</a:t>
+              <a:t>OO.CC</a:t>
             </a:r>
             <a:endParaRPr lang="en-US" sz="1050" dirty="0"/>
           </a:p>
@@ -12919,7 +12919,7 @@
                 <a:ea typeface="Calibri" pitchFamily="34" charset="-122"/>
                 <a:cs typeface="Calibri" pitchFamily="34" charset="-120"/>
               </a:rPr>
-              <a:t>Alvaro Cortés V.</a:t>
+              <a:t>Sebastián Ramos</a:t>
             </a:r>
             <a:endParaRPr lang="en-US" sz="1050" dirty="0"/>
           </a:p>
@@ -12989,15 +12989,15 @@
               <a:buNone/>
             </a:pPr>
             <a:r>
-              <a:rPr lang="en-US" sz="1050" b="1" dirty="0">
-                <a:solidFill>
-                  <a:srgbClr val="C0392B"/>
-                </a:solidFill>
-                <a:latin typeface="Calibri" pitchFamily="34" charset="0"/>
-                <a:ea typeface="Calibri" pitchFamily="34" charset="-122"/>
-                <a:cs typeface="Calibri" pitchFamily="34" charset="-120"/>
-              </a:rPr>
-              <a:t>217</a:t>
+              <a:rPr lang="en-US" sz="1050" dirty="0">
+                <a:solidFill>
+                  <a:srgbClr val="1A2433"/>
+                </a:solidFill>
+                <a:latin typeface="Calibri" pitchFamily="34" charset="0"/>
+                <a:ea typeface="Calibri" pitchFamily="34" charset="-122"/>
+                <a:cs typeface="Calibri" pitchFamily="34" charset="-120"/>
+              </a:rPr>
+              <a:t>111</a:t>
             </a:r>
             <a:endParaRPr lang="en-US" sz="1050" dirty="0"/>
           </a:p>
@@ -13036,7 +13036,7 @@
                 <a:ea typeface="Calibri" pitchFamily="34" charset="-122"/>
                 <a:cs typeface="Calibri" pitchFamily="34" charset="-120"/>
               </a:rPr>
-              <a:t>Daños manguerotes en recepción/desc…</a:t>
+              <a:t>Sector Manifold EBMS, Fundaciones F…</a:t>
             </a:r>
             <a:endParaRPr lang="en-US" sz="1000" dirty="0"/>
           </a:p>
@@ -13118,7 +13118,7 @@
                 <a:ea typeface="Calibri" pitchFamily="34" charset="-122"/>
                 <a:cs typeface="Calibri" pitchFamily="34" charset="-120"/>
               </a:rPr>
-              <a:t>182</a:t>
+              <a:t>228</a:t>
             </a:r>
             <a:endParaRPr lang="en-US" sz="1050" dirty="0"/>
           </a:p>
@@ -13157,7 +13157,7 @@
                 <a:ea typeface="Calibri" pitchFamily="34" charset="-122"/>
                 <a:cs typeface="Calibri" pitchFamily="34" charset="-120"/>
               </a:rPr>
-              <a:t>Producto No Conforme</a:t>
+              <a:t>No Conformidad</a:t>
             </a:r>
             <a:endParaRPr lang="en-US" sz="1050" dirty="0"/>
           </a:p>
@@ -13235,7 +13235,7 @@
                 <a:ea typeface="Calibri" pitchFamily="34" charset="-122"/>
                 <a:cs typeface="Calibri" pitchFamily="34" charset="-120"/>
               </a:rPr>
-              <a:t>OO.CC</a:t>
+              <a:t>CALIDAD</a:t>
             </a:r>
             <a:endParaRPr lang="en-US" sz="1050" dirty="0"/>
           </a:p>
@@ -13274,7 +13274,7 @@
                 <a:ea typeface="Calibri" pitchFamily="34" charset="-122"/>
                 <a:cs typeface="Calibri" pitchFamily="34" charset="-120"/>
               </a:rPr>
-              <a:t>Sebastián Ramos</a:t>
+              <a:t>Mauricio Soto B.</a:t>
             </a:r>
             <a:endParaRPr lang="en-US" sz="1050" dirty="0"/>
           </a:p>
@@ -13313,7 +13313,7 @@
                 <a:ea typeface="Calibri" pitchFamily="34" charset="-122"/>
                 <a:cs typeface="Calibri" pitchFamily="34" charset="-120"/>
               </a:rPr>
-              <a:t>Iniciado</a:t>
+              <a:t>Listo para revisi…</a:t>
             </a:r>
             <a:endParaRPr lang="en-US" sz="1050" dirty="0"/>
           </a:p>
@@ -13352,7 +13352,7 @@
                 <a:ea typeface="Calibri" pitchFamily="34" charset="-122"/>
                 <a:cs typeface="Calibri" pitchFamily="34" charset="-120"/>
               </a:rPr>
-              <a:t>160</a:t>
+              <a:t>55</a:t>
             </a:r>
             <a:endParaRPr lang="en-US" sz="1050" dirty="0"/>
           </a:p>
@@ -13391,7 +13391,7 @@
                 <a:ea typeface="Calibri" pitchFamily="34" charset="-122"/>
                 <a:cs typeface="Calibri" pitchFamily="34" charset="-120"/>
               </a:rPr>
-              <a:t>Postes en esquinas eje B/1 y eje B/…</a:t>
+              <a:t>Durante la auditoría se identificar…</a:t>
             </a:r>
             <a:endParaRPr lang="en-US" sz="1000" dirty="0"/>
           </a:p>
@@ -13453,7 +13453,7 @@
                 <a:ea typeface="Calibri" pitchFamily="34" charset="-122"/>
                 <a:cs typeface="Calibri" pitchFamily="34" charset="-120"/>
               </a:rPr>
-              <a:t>192</a:t>
+              <a:t>230</a:t>
             </a:r>
             <a:endParaRPr lang="en-US" sz="1050" dirty="0"/>
           </a:p>
@@ -13570,7 +13570,7 @@
                 <a:ea typeface="Calibri" pitchFamily="34" charset="-122"/>
                 <a:cs typeface="Calibri" pitchFamily="34" charset="-120"/>
               </a:rPr>
-              <a:t>OO.CC</a:t>
+              <a:t>CALIDAD</a:t>
             </a:r>
             <a:endParaRPr lang="en-US" sz="1050" dirty="0"/>
           </a:p>
@@ -13609,7 +13609,7 @@
                 <a:ea typeface="Calibri" pitchFamily="34" charset="-122"/>
                 <a:cs typeface="Calibri" pitchFamily="34" charset="-120"/>
               </a:rPr>
-              <a:t>Sebastián Ramos</a:t>
+              <a:t>Mauricio Soto B.</a:t>
             </a:r>
             <a:endParaRPr lang="en-US" sz="1050" dirty="0"/>
           </a:p>
@@ -13687,7 +13687,7 @@
                 <a:ea typeface="Calibri" pitchFamily="34" charset="-122"/>
                 <a:cs typeface="Calibri" pitchFamily="34" charset="-120"/>
               </a:rPr>
-              <a:t>132</a:t>
+              <a:t>55</a:t>
             </a:r>
             <a:endParaRPr lang="en-US" sz="1050" dirty="0"/>
           </a:p>
@@ -13726,7 +13726,7 @@
                 <a:ea typeface="Calibri" pitchFamily="34" charset="-122"/>
                 <a:cs typeface="Calibri" pitchFamily="34" charset="-120"/>
               </a:rPr>
-              <a:t>Fundaciones sin relleno estructural…</a:t>
+              <a:t>No se evidenció un Plan de Cierre d…</a:t>
             </a:r>
             <a:endParaRPr lang="en-US" sz="1000" dirty="0"/>
           </a:p>
@@ -13788,7 +13788,7 @@
                 <a:ea typeface="Calibri" pitchFamily="34" charset="-122"/>
                 <a:cs typeface="Calibri" pitchFamily="34" charset="-120"/>
               </a:rPr>
-              <a:t>Se listan los 9 más antiguos de 26 abiertos; el detalle completo está en el panel.</a:t>
+              <a:t>Se listan los 9 más antiguos de 15 abiertos; el detalle completo está en el panel.</a:t>
             </a:r>
             <a:endParaRPr lang="en-US" sz="950" dirty="0"/>
           </a:p>
@@ -13849,7 +13849,7 @@
                 <a:ea typeface="Calibri" pitchFamily="34" charset="-122"/>
                 <a:cs typeface="Calibri" pitchFamily="34" charset="-120"/>
               </a:rPr>
-              <a:t>SEMANA 21-07-2026 — 27-07-2026</a:t>
+              <a:t>SEMANA 28-07-2026 — 03-08-2026</a:t>
             </a:r>
             <a:endParaRPr lang="en-US" sz="1000" dirty="0"/>
           </a:p>
@@ -13888,7 +13888,7 @@
                 <a:ea typeface="Calibri" pitchFamily="34" charset="-122"/>
                 <a:cs typeface="Calibri" pitchFamily="34" charset="-120"/>
               </a:rPr>
-              <a:t>3 hallazgos nuevos · 0 internos y 3 externos · OO.CC 3 · 3 siguen abiertos</a:t>
+              <a:t>1 hallazgo nuevo · 0 internos y 1 externo · CALIDAD 1 · 1 sigue abierto</a:t>
             </a:r>
             <a:endParaRPr lang="en-US" sz="1150" dirty="0"/>
           </a:p>
@@ -13927,7 +13927,7 @@
                 <a:ea typeface="Calibri" pitchFamily="34" charset="-122"/>
                 <a:cs typeface="Calibri" pitchFamily="34" charset="-120"/>
               </a:rPr>
-              <a:t>Fuente: 5640140e-Data_NCR_1.xlsx — hoja «Observaciones» · Corte 27-07-2026 · 436 registros desde 10-02-2023</a:t>
+              <a:t>Fuente: 1e73482e-Data_NCR03082026.xlsx — hoja «Observaciones» · Corte 03-08-2026 · 438 registros desde 10-02-2023</a:t>
             </a:r>
             <a:endParaRPr lang="en-US" sz="850" dirty="0"/>
           </a:p>
@@ -14651,7 +14651,7 @@
                 <a:ea typeface="Calibri" pitchFamily="34" charset="-122"/>
                 <a:cs typeface="Calibri" pitchFamily="34" charset="-120"/>
               </a:rPr>
-              <a:t>Corte: 27-07-2026</a:t>
+              <a:t>Corte: 03-08-2026</a:t>
             </a:r>
             <a:endParaRPr lang="en-US" sz="1100" dirty="0"/>
           </a:p>
@@ -14690,7 +14690,7 @@
                 <a:ea typeface="Calibri" pitchFamily="34" charset="-122"/>
                 <a:cs typeface="Calibri" pitchFamily="34" charset="-120"/>
               </a:rPr>
-              <a:t>Fuente: 5640140e-Data_NCR_1.xlsx — hoja «Observaciones» · Corte 27-07-2026 · 436 registros desde 10-02-2023</a:t>
+              <a:t>Fuente: 1e73482e-Data_NCR03082026.xlsx — hoja «Observaciones» · Corte 03-08-2026 · 438 registros desde 10-02-2023</a:t>
             </a:r>
             <a:endParaRPr lang="en-US" sz="850" dirty="0"/>
           </a:p>
@@ -15283,7 +15283,7 @@
                 <a:ea typeface="Calibri" pitchFamily="34" charset="-122"/>
                 <a:cs typeface="Calibri" pitchFamily="34" charset="-120"/>
               </a:rPr>
-              <a:t>Global del módulo: 93,1%</a:t>
+              <a:t>Global del módulo: 95,7%</a:t>
             </a:r>
             <a:endParaRPr lang="en-US" sz="950" dirty="0"/>
           </a:p>
@@ -15881,7 +15881,7 @@
                 <a:ea typeface="Calibri" pitchFamily="34" charset="-122"/>
                 <a:cs typeface="Calibri" pitchFamily="34" charset="-120"/>
               </a:rPr>
-              <a:t>global del módulo 37,9%</a:t>
+              <a:t>global del módulo 37,8%</a:t>
             </a:r>
             <a:endParaRPr lang="en-US" sz="1000" dirty="0"/>
           </a:p>
@@ -16354,7 +16354,7 @@
                 <a:ea typeface="Calibri" pitchFamily="34" charset="-122"/>
                 <a:cs typeface="Calibri" pitchFamily="34" charset="-120"/>
               </a:rPr>
-              <a:t>Fuente: 5640140e-Data_NCR_1.xlsx — hoja «Observaciones» · Corte 27-07-2026 · 436 registros desde 10-02-2023</a:t>
+              <a:t>Fuente: 1e73482e-Data_NCR03082026.xlsx — hoja «Observaciones» · Corte 03-08-2026 · 438 registros desde 10-02-2023</a:t>
             </a:r>
             <a:endParaRPr lang="en-US" sz="850" dirty="0"/>
           </a:p>
@@ -17213,7 +17213,7 @@
                 <a:ea typeface="Calibri" pitchFamily="34" charset="-122"/>
                 <a:cs typeface="Calibri" pitchFamily="34" charset="-120"/>
               </a:rPr>
-              <a:t>63</a:t>
+              <a:t>70</a:t>
             </a:r>
             <a:endParaRPr lang="en-US" sz="1050" dirty="0"/>
           </a:p>
@@ -17336,7 +17336,7 @@
                 <a:ea typeface="Calibri" pitchFamily="34" charset="-122"/>
                 <a:cs typeface="Calibri" pitchFamily="34" charset="-120"/>
               </a:rPr>
-              <a:t>SEMANA 21-07-2026 — 27-07-2026</a:t>
+              <a:t>SEMANA 28-07-2026 — 03-08-2026</a:t>
             </a:r>
             <a:endParaRPr lang="en-US" sz="1000" dirty="0"/>
           </a:p>
@@ -17414,7 +17414,7 @@
                 <a:ea typeface="Calibri" pitchFamily="34" charset="-122"/>
                 <a:cs typeface="Calibri" pitchFamily="34" charset="-120"/>
               </a:rPr>
-              <a:t>Fuente: 5640140e-Data_NCR_1.xlsx — hoja «Observaciones» · Corte 27-07-2026 · 436 registros desde 10-02-2023</a:t>
+              <a:t>Fuente: 1e73482e-Data_NCR03082026.xlsx — hoja «Observaciones» · Corte 03-08-2026 · 438 registros desde 10-02-2023</a:t>
             </a:r>
             <a:endParaRPr lang="en-US" sz="850" dirty="0"/>
           </a:p>
@@ -17719,7 +17719,7 @@
                 <a:ea typeface="Cambria" pitchFamily="34" charset="-122"/>
                 <a:cs typeface="Cambria" pitchFamily="34" charset="-120"/>
               </a:rPr>
-              <a:t>93,1%</a:t>
+              <a:t>95,7%</a:t>
             </a:r>
             <a:endParaRPr lang="en-US" sz="4000" dirty="0"/>
           </a:p>
@@ -17758,7 +17758,7 @@
                 <a:ea typeface="Calibri" pitchFamily="34" charset="-122"/>
                 <a:cs typeface="Calibri" pitchFamily="34" charset="-120"/>
               </a:rPr>
-              <a:t>406/436</a:t>
+              <a:t>419/438</a:t>
             </a:r>
             <a:endParaRPr lang="en-US" sz="1400" dirty="0"/>
           </a:p>
@@ -17836,7 +17836,7 @@
                 <a:ea typeface="Calibri" pitchFamily="34" charset="-122"/>
                 <a:cs typeface="Calibri" pitchFamily="34" charset="-120"/>
               </a:rPr>
-              <a:t>30 abiertos · 7 con más de 180 días</a:t>
+              <a:t>19 abiertos · 3 con más de 180 días</a:t>
             </a:r>
             <a:endParaRPr lang="en-US" sz="950" dirty="0"/>
           </a:p>
@@ -17929,7 +17929,7 @@
                 <a:ea typeface="Cambria" pitchFamily="34" charset="-122"/>
                 <a:cs typeface="Cambria" pitchFamily="34" charset="-120"/>
               </a:rPr>
-              <a:t>30</a:t>
+              <a:t>19</a:t>
             </a:r>
             <a:endParaRPr lang="en-US" sz="4000" dirty="0"/>
           </a:p>
@@ -17968,7 +17968,7 @@
                 <a:ea typeface="Calibri" pitchFamily="34" charset="-122"/>
                 <a:cs typeface="Calibri" pitchFamily="34" charset="-120"/>
               </a:rPr>
-              <a:t>de 436 levantados</a:t>
+              <a:t>de 438 levantados</a:t>
             </a:r>
             <a:endParaRPr lang="en-US" sz="1400" dirty="0"/>
           </a:p>
@@ -18046,7 +18046,7 @@
                 <a:ea typeface="Calibri" pitchFamily="34" charset="-122"/>
                 <a:cs typeface="Calibri" pitchFamily="34" charset="-120"/>
               </a:rPr>
-              <a:t>6 no aceptado · 19 iniciado · 5 listo para revisión</a:t>
+              <a:t>15 iniciado · 1 no aceptado · 3 listo para revisión</a:t>
             </a:r>
             <a:endParaRPr lang="en-US" sz="950" dirty="0"/>
           </a:p>
@@ -18139,7 +18139,7 @@
                 <a:ea typeface="Cambria" pitchFamily="34" charset="-122"/>
                 <a:cs typeface="Cambria" pitchFamily="34" charset="-120"/>
               </a:rPr>
-              <a:t>37,9%</a:t>
+              <a:t>37,8%</a:t>
             </a:r>
             <a:endParaRPr lang="en-US" sz="4000" dirty="0"/>
           </a:p>
@@ -18178,7 +18178,7 @@
                 <a:ea typeface="Calibri" pitchFamily="34" charset="-122"/>
                 <a:cs typeface="Calibri" pitchFamily="34" charset="-120"/>
               </a:rPr>
-              <a:t>162/427 clasificados</a:t>
+              <a:t>162/429 clasificados</a:t>
             </a:r>
             <a:endParaRPr lang="en-US" sz="1400" dirty="0"/>
           </a:p>
@@ -18388,7 +18388,7 @@
                 <a:ea typeface="Calibri" pitchFamily="34" charset="-122"/>
                 <a:cs typeface="Calibri" pitchFamily="34" charset="-120"/>
               </a:rPr>
-              <a:t>256 de 436 con costo</a:t>
+              <a:t>256 de 438 con costo</a:t>
             </a:r>
             <a:endParaRPr lang="en-US" sz="1400" dirty="0"/>
           </a:p>
@@ -18466,7 +18466,7 @@
                 <a:ea typeface="Calibri" pitchFamily="34" charset="-122"/>
                 <a:cs typeface="Calibri" pitchFamily="34" charset="-120"/>
               </a:rPr>
-              <a:t>180 hallazgos no declaran costo: la cifra es un piso</a:t>
+              <a:t>182 hallazgos no declaran costo: la cifra es un piso</a:t>
             </a:r>
             <a:endParaRPr lang="en-US" sz="950" dirty="0"/>
           </a:p>
@@ -18606,7 +18606,7 @@
                 <a:ea typeface="Calibri" pitchFamily="34" charset="-122"/>
                 <a:cs typeface="Calibri" pitchFamily="34" charset="-120"/>
               </a:rPr>
-              <a:t>26 de los 30 hallazgos abiertos (86,7%), y es el único frente donde el cliente levanta más de lo que detecta Besalco (186 externas contra 53 internas).</a:t>
+              <a:t>15 de los 19 hallazgos abiertos (78,9%), y es el único frente donde el cliente levanta más de lo que detecta Besalco (188 externas contra 53 internas).</a:t>
             </a:r>
             <a:endParaRPr lang="en-US" sz="1250" dirty="0"/>
           </a:p>
@@ -18668,7 +18668,7 @@
                 <a:ea typeface="Calibri" pitchFamily="34" charset="-122"/>
                 <a:cs typeface="Calibri" pitchFamily="34" charset="-120"/>
               </a:rPr>
-              <a:t>La semana trajo 4 hallazgos nuevos, ninguno de autodetección.  </a:t>
+              <a:t>La semana trajo 1 hallazgo nuevo, ninguno de autodetección.  </a:t>
             </a:r>
             <a:pPr indent="0" marL="0">
               <a:lnSpc>
@@ -18685,7 +18685,7 @@
                 <a:ea typeface="Calibri" pitchFamily="34" charset="-122"/>
                 <a:cs typeface="Calibri" pitchFamily="34" charset="-120"/>
               </a:rPr>
-              <a:t>21-07-2026 al 27-07-2026: 4 del cliente en OO.CC (3) y MECÁNICA (1). Todos siguen abiertos; la semana anterior entraron 0.</a:t>
+              <a:t>28-07-2026 al 03-08-2026: 1 del cliente en CALIDAD (1). Todos siguen abiertos; la semana anterior entraron 5.</a:t>
             </a:r>
             <a:endParaRPr lang="en-US" sz="1250" dirty="0"/>
           </a:p>
@@ -18764,7 +18764,7 @@
                 <a:ea typeface="Calibri" pitchFamily="34" charset="-122"/>
                 <a:cs typeface="Calibri" pitchFamily="34" charset="-120"/>
               </a:rPr>
-              <a:t>Ninguno de los 30 abiertos trae fecha comprometida —la columna «Fecha De Cierre» solo se llena al cerrar—, así que se reporta la antigüedad: 7 llevan más de 180 días y 2 más de un año.</a:t>
+              <a:t>Ninguno de los 19 abiertos trae fecha comprometida —la columna «Fecha De Cierre» solo se llena al cerrar—, así que se reporta la antigüedad: 3 llevan más de 180 días y 1 más de un año.</a:t>
             </a:r>
             <a:endParaRPr lang="en-US" sz="1250" dirty="0"/>
           </a:p>
@@ -18803,7 +18803,7 @@
                 <a:ea typeface="Calibri" pitchFamily="34" charset="-122"/>
                 <a:cs typeface="Calibri" pitchFamily="34" charset="-120"/>
               </a:rPr>
-              <a:t>Fuente: 5640140e-Data_NCR_1.xlsx — hoja «Observaciones» · Corte 27-07-2026 · 436 registros desde 10-02-2023</a:t>
+              <a:t>Fuente: 1e73482e-Data_NCR03082026.xlsx — hoja «Observaciones» · Corte 03-08-2026 · 438 registros desde 10-02-2023</a:t>
             </a:r>
             <a:endParaRPr lang="en-US" sz="850" dirty="0"/>
           </a:p>
@@ -20000,7 +20000,7 @@
                 <a:ea typeface="Calibri" pitchFamily="34" charset="-122"/>
                 <a:cs typeface="Calibri" pitchFamily="34" charset="-120"/>
               </a:rPr>
-              <a:t>239</a:t>
+              <a:t>241</a:t>
             </a:r>
             <a:endParaRPr lang="en-US" sz="1300" dirty="0"/>
           </a:p>
@@ -20039,7 +20039,7 @@
                 <a:ea typeface="Calibri" pitchFamily="34" charset="-122"/>
                 <a:cs typeface="Calibri" pitchFamily="34" charset="-120"/>
               </a:rPr>
-              <a:t>213</a:t>
+              <a:t>226</a:t>
             </a:r>
             <a:endParaRPr lang="en-US" sz="1300" dirty="0"/>
           </a:p>
@@ -20072,13 +20072,13 @@
             <a:r>
               <a:rPr lang="en-US" sz="1300" dirty="0">
                 <a:solidFill>
-                  <a:srgbClr val="C0392B"/>
-                </a:solidFill>
-                <a:latin typeface="Calibri" pitchFamily="34" charset="0"/>
-                <a:ea typeface="Calibri" pitchFamily="34" charset="-122"/>
-                <a:cs typeface="Calibri" pitchFamily="34" charset="-120"/>
-              </a:rPr>
-              <a:t>26</a:t>
+                  <a:srgbClr val="1A2433"/>
+                </a:solidFill>
+                <a:latin typeface="Calibri" pitchFamily="34" charset="0"/>
+                <a:ea typeface="Calibri" pitchFamily="34" charset="-122"/>
+                <a:cs typeface="Calibri" pitchFamily="34" charset="-120"/>
+              </a:rPr>
+              <a:t>15</a:t>
             </a:r>
             <a:endParaRPr lang="en-US" sz="1300" dirty="0"/>
           </a:p>
@@ -20117,7 +20117,7 @@
                 <a:ea typeface="Calibri" pitchFamily="34" charset="-122"/>
                 <a:cs typeface="Calibri" pitchFamily="34" charset="-120"/>
               </a:rPr>
-              <a:t>89,1%</a:t>
+              <a:t>93,8%</a:t>
             </a:r>
             <a:endParaRPr lang="en-US" sz="1300" dirty="0"/>
           </a:p>
@@ -20195,7 +20195,7 @@
                 <a:ea typeface="Calibri" pitchFamily="34" charset="-122"/>
                 <a:cs typeface="Calibri" pitchFamily="34" charset="-120"/>
               </a:rPr>
-              <a:t>186</a:t>
+              <a:t>188</a:t>
             </a:r>
             <a:endParaRPr lang="en-US" sz="1300" dirty="0"/>
           </a:p>
@@ -20257,7 +20257,7 @@
             </a:avLst>
           </a:prstGeom>
           <a:solidFill>
-            <a:srgbClr val="C0392B"/>
+            <a:srgbClr val="E0A32E"/>
           </a:solidFill>
           <a:ln/>
         </p:spPr>
@@ -20295,7 +20295,7 @@
                 <a:ea typeface="Calibri" pitchFamily="34" charset="-122"/>
                 <a:cs typeface="Calibri" pitchFamily="34" charset="-120"/>
               </a:rPr>
-              <a:t>Crítico</a:t>
+              <a:t>Atención</a:t>
             </a:r>
             <a:endParaRPr lang="en-US" sz="1050" dirty="0"/>
           </a:p>
@@ -21325,7 +21325,7 @@
                 <a:ea typeface="Calibri" pitchFamily="34" charset="-122"/>
                 <a:cs typeface="Calibri" pitchFamily="34" charset="-120"/>
               </a:rPr>
-              <a:t>428</a:t>
+              <a:t>430</a:t>
             </a:r>
             <a:endParaRPr lang="en-US" sz="1300" dirty="0"/>
           </a:p>
@@ -21364,7 +21364,7 @@
                 <a:ea typeface="Calibri" pitchFamily="34" charset="-122"/>
                 <a:cs typeface="Calibri" pitchFamily="34" charset="-120"/>
               </a:rPr>
-              <a:t>398</a:t>
+              <a:t>411</a:t>
             </a:r>
             <a:endParaRPr lang="en-US" sz="1300" dirty="0"/>
           </a:p>
@@ -21403,7 +21403,7 @@
                 <a:ea typeface="Calibri" pitchFamily="34" charset="-122"/>
                 <a:cs typeface="Calibri" pitchFamily="34" charset="-120"/>
               </a:rPr>
-              <a:t>30</a:t>
+              <a:t>19</a:t>
             </a:r>
             <a:endParaRPr lang="en-US" sz="1300" dirty="0"/>
           </a:p>
@@ -21442,7 +21442,7 @@
                 <a:ea typeface="Calibri" pitchFamily="34" charset="-122"/>
                 <a:cs typeface="Calibri" pitchFamily="34" charset="-120"/>
               </a:rPr>
-              <a:t>93%</a:t>
+              <a:t>95,6%</a:t>
             </a:r>
             <a:endParaRPr lang="en-US" sz="1300" dirty="0"/>
           </a:p>
@@ -21520,7 +21520,7 @@
                 <a:ea typeface="Calibri" pitchFamily="34" charset="-122"/>
                 <a:cs typeface="Calibri" pitchFamily="34" charset="-120"/>
               </a:rPr>
-              <a:t>265</a:t>
+              <a:t>267</a:t>
             </a:r>
             <a:endParaRPr lang="en-US" sz="1300" dirty="0"/>
           </a:p>
@@ -21598,7 +21598,7 @@
                 <a:ea typeface="Calibri" pitchFamily="34" charset="-122"/>
                 <a:cs typeface="Calibri" pitchFamily="34" charset="-120"/>
               </a:rPr>
-              <a:t>Mediana de cierre global 28 días · el hallazgo más lento tomó 313 días · 8 hallazgos sin especialidad declarada.</a:t>
+              <a:t>Mediana de cierre global 28 días · el hallazgo más lento tomó 389 días · 8 hallazgos sin especialidad declarada.</a:t>
             </a:r>
             <a:endParaRPr lang="en-US" sz="950" dirty="0"/>
           </a:p>
@@ -21637,7 +21637,7 @@
                 <a:ea typeface="Calibri" pitchFamily="34" charset="-122"/>
                 <a:cs typeface="Calibri" pitchFamily="34" charset="-120"/>
               </a:rPr>
-              <a:t>Fuente: 5640140e-Data_NCR_1.xlsx — hoja «Observaciones» · Corte 27-07-2026 · 436 registros desde 10-02-2023</a:t>
+              <a:t>Fuente: 1e73482e-Data_NCR03082026.xlsx — hoja «Observaciones» · Corte 03-08-2026 · 438 registros desde 10-02-2023</a:t>
             </a:r>
             <a:endParaRPr lang="en-US" sz="850" dirty="0"/>
           </a:p>
@@ -21888,7 +21888,7 @@
                 <a:ea typeface="Calibri" pitchFamily="34" charset="-122"/>
                 <a:cs typeface="Calibri" pitchFamily="34" charset="-120"/>
               </a:rPr>
-              <a:t>Entre el 21-07-2026 y el 27-07-2026 se levantaron 4 hallazgos: 0 internos y 4 externos. Todos siguen abiertos.</a:t>
+              <a:t>Entre el 28-07-2026 y el 03-08-2026 se levantó 1 hallazgo: 0 internos y 1 externo. Sigue abierto.</a:t>
             </a:r>
             <a:endParaRPr lang="en-US" sz="1350" dirty="0"/>
           </a:p>
@@ -22043,7 +22043,7 @@
                 <a:ea typeface="Calibri" pitchFamily="34" charset="-122"/>
                 <a:cs typeface="Calibri" pitchFamily="34" charset="-120"/>
               </a:rPr>
-              <a:t>OO.CC 3  ·  MECÁNICA 1</a:t>
+              <a:t>CALIDAD 1</a:t>
             </a:r>
             <a:endParaRPr lang="en-US" sz="1100" dirty="0"/>
           </a:p>
@@ -22121,7 +22121,7 @@
                 <a:ea typeface="Calibri" pitchFamily="34" charset="-122"/>
                 <a:cs typeface="Calibri" pitchFamily="34" charset="-120"/>
               </a:rPr>
-              <a:t>Talabre 3  ·  Desaladora 1</a:t>
+              <a:t>Talabre 1</a:t>
             </a:r>
             <a:endParaRPr lang="en-US" sz="1100" dirty="0"/>
           </a:p>
@@ -22199,7 +22199,7 @@
                 <a:ea typeface="Calibri" pitchFamily="34" charset="-122"/>
                 <a:cs typeface="Calibri" pitchFamily="34" charset="-120"/>
               </a:rPr>
-              <a:t>Externa · Cliente 4</a:t>
+              <a:t>Externa · Cliente 1</a:t>
             </a:r>
             <a:endParaRPr lang="en-US" sz="1100" dirty="0"/>
           </a:p>
@@ -22277,7 +22277,7 @@
                 <a:ea typeface="Calibri" pitchFamily="34" charset="-122"/>
                 <a:cs typeface="Calibri" pitchFamily="34" charset="-120"/>
               </a:rPr>
-              <a:t>No Conformidad 3  ·  Producto No Conforme 1</a:t>
+              <a:t>No Conformidad 1</a:t>
             </a:r>
             <a:endParaRPr lang="en-US" sz="1100" dirty="0"/>
           </a:p>
@@ -22729,7 +22729,7 @@
                 <a:ea typeface="Calibri" pitchFamily="34" charset="-122"/>
                 <a:cs typeface="Calibri" pitchFamily="34" charset="-120"/>
               </a:rPr>
-              <a:t>21-07-2026</a:t>
+              <a:t>28-07-2026</a:t>
             </a:r>
             <a:endParaRPr lang="en-US" sz="1050" dirty="0"/>
           </a:p>
@@ -22807,7 +22807,7 @@
                 <a:ea typeface="Calibri" pitchFamily="34" charset="-122"/>
                 <a:cs typeface="Calibri" pitchFamily="34" charset="-120"/>
               </a:rPr>
-              <a:t>237 · RNC N°445</a:t>
+              <a:t>241 · RNC N°449</a:t>
             </a:r>
             <a:endParaRPr lang="en-US" sz="1050" dirty="0"/>
           </a:p>
@@ -22924,7 +22924,7 @@
                 <a:ea typeface="Calibri" pitchFamily="34" charset="-122"/>
                 <a:cs typeface="Calibri" pitchFamily="34" charset="-120"/>
               </a:rPr>
-              <a:t>OO.CC</a:t>
+              <a:t>CALIDAD</a:t>
             </a:r>
             <a:endParaRPr lang="en-US" sz="1050" dirty="0"/>
           </a:p>
@@ -22963,7 +22963,7 @@
                 <a:ea typeface="Calibri" pitchFamily="34" charset="-122"/>
                 <a:cs typeface="Calibri" pitchFamily="34" charset="-120"/>
               </a:rPr>
-              <a:t>Mauricio Rocha A.</a:t>
+              <a:t>Daniel Ramirez B.</a:t>
             </a:r>
             <a:endParaRPr lang="en-US" sz="1050" dirty="0"/>
           </a:p>
@@ -23041,7 +23041,7 @@
                 <a:ea typeface="Calibri" pitchFamily="34" charset="-122"/>
                 <a:cs typeface="Calibri" pitchFamily="34" charset="-120"/>
               </a:rPr>
-              <a:t>Arrugas y trampolines en lá…</a:t>
+              <a:t>Registros de construcción n…</a:t>
             </a:r>
             <a:endParaRPr lang="en-US" sz="1000" dirty="0"/>
           </a:p>
@@ -23072,1169 +23072,7 @@
       </p:sp>
       <p:sp>
         <p:nvSpPr>
-          <p:cNvPr id="38" name="Shape 34"/>
-          <p:cNvSpPr/>
-          <p:nvPr/>
-        </p:nvSpPr>
-        <p:spPr>
-          <a:xfrm>
-            <a:off x="457200" y="4709160"/>
-            <a:ext cx="11292840" cy="329184"/>
-          </a:xfrm>
-          <a:prstGeom prst="rect">
-            <a:avLst/>
-          </a:prstGeom>
-          <a:solidFill>
-            <a:srgbClr val="FFFFFF"/>
-          </a:solidFill>
-          <a:ln/>
-        </p:spPr>
-      </p:sp>
-      <p:sp>
-        <p:nvSpPr>
-          <p:cNvPr id="39" name="Text 35"/>
-          <p:cNvSpPr/>
-          <p:nvPr/>
-        </p:nvSpPr>
-        <p:spPr>
-          <a:xfrm>
-            <a:off x="502920" y="4754880"/>
-            <a:ext cx="822960" cy="237744"/>
-          </a:xfrm>
-          <a:prstGeom prst="rect">
-            <a:avLst/>
-          </a:prstGeom>
-          <a:noFill/>
-          <a:ln/>
-        </p:spPr>
-        <p:txBody>
-          <a:bodyPr wrap="square" lIns="0" tIns="0" rIns="0" bIns="0" rtlCol="0" anchor="ctr"/>
-          <a:lstStyle/>
-          <a:p>
-            <a:pPr algn="l" indent="0" marL="0">
-              <a:buNone/>
-            </a:pPr>
-            <a:r>
-              <a:rPr lang="en-US" sz="1050" dirty="0">
-                <a:solidFill>
-                  <a:srgbClr val="1A2433"/>
-                </a:solidFill>
-                <a:latin typeface="Calibri" pitchFamily="34" charset="0"/>
-                <a:ea typeface="Calibri" pitchFamily="34" charset="-122"/>
-                <a:cs typeface="Calibri" pitchFamily="34" charset="-120"/>
-              </a:rPr>
-              <a:t>21-07-2026</a:t>
-            </a:r>
-            <a:endParaRPr lang="en-US" sz="1050" dirty="0"/>
-          </a:p>
-        </p:txBody>
-      </p:sp>
-      <p:sp>
-        <p:nvSpPr>
-          <p:cNvPr id="40" name="Text 36"/>
-          <p:cNvSpPr/>
-          <p:nvPr/>
-        </p:nvSpPr>
-        <p:spPr>
-          <a:xfrm>
-            <a:off x="1371600" y="4754880"/>
-            <a:ext cx="1051560" cy="237744"/>
-          </a:xfrm>
-          <a:prstGeom prst="rect">
-            <a:avLst/>
-          </a:prstGeom>
-          <a:noFill/>
-          <a:ln/>
-        </p:spPr>
-        <p:txBody>
-          <a:bodyPr wrap="square" lIns="0" tIns="0" rIns="0" bIns="0" rtlCol="0" anchor="ctr"/>
-          <a:lstStyle/>
-          <a:p>
-            <a:pPr algn="l" indent="0" marL="0">
-              <a:buNone/>
-            </a:pPr>
-            <a:r>
-              <a:rPr lang="en-US" sz="1050" dirty="0">
-                <a:solidFill>
-                  <a:srgbClr val="1A2433"/>
-                </a:solidFill>
-                <a:latin typeface="Calibri" pitchFamily="34" charset="0"/>
-                <a:ea typeface="Calibri" pitchFamily="34" charset="-122"/>
-                <a:cs typeface="Calibri" pitchFamily="34" charset="-120"/>
-              </a:rPr>
-              <a:t>Talabre</a:t>
-            </a:r>
-            <a:endParaRPr lang="en-US" sz="1050" dirty="0"/>
-          </a:p>
-        </p:txBody>
-      </p:sp>
-      <p:sp>
-        <p:nvSpPr>
-          <p:cNvPr id="41" name="Text 37"/>
-          <p:cNvSpPr/>
-          <p:nvPr/>
-        </p:nvSpPr>
-        <p:spPr>
-          <a:xfrm>
-            <a:off x="2468880" y="4754880"/>
-            <a:ext cx="1051560" cy="237744"/>
-          </a:xfrm>
-          <a:prstGeom prst="rect">
-            <a:avLst/>
-          </a:prstGeom>
-          <a:noFill/>
-          <a:ln/>
-        </p:spPr>
-        <p:txBody>
-          <a:bodyPr wrap="square" lIns="0" tIns="0" rIns="0" bIns="0" rtlCol="0" anchor="ctr"/>
-          <a:lstStyle/>
-          <a:p>
-            <a:pPr algn="l" indent="0" marL="0">
-              <a:buNone/>
-            </a:pPr>
-            <a:r>
-              <a:rPr lang="en-US" sz="1050" dirty="0">
-                <a:solidFill>
-                  <a:srgbClr val="1A2433"/>
-                </a:solidFill>
-                <a:latin typeface="Calibri" pitchFamily="34" charset="0"/>
-                <a:ea typeface="Calibri" pitchFamily="34" charset="-122"/>
-                <a:cs typeface="Calibri" pitchFamily="34" charset="-120"/>
-              </a:rPr>
-              <a:t>238 · PNC N°177</a:t>
-            </a:r>
-            <a:endParaRPr lang="en-US" sz="1050" dirty="0"/>
-          </a:p>
-        </p:txBody>
-      </p:sp>
-      <p:sp>
-        <p:nvSpPr>
-          <p:cNvPr id="42" name="Text 38"/>
-          <p:cNvSpPr/>
-          <p:nvPr/>
-        </p:nvSpPr>
-        <p:spPr>
-          <a:xfrm>
-            <a:off x="3566160" y="4754880"/>
-            <a:ext cx="1371600" cy="237744"/>
-          </a:xfrm>
-          <a:prstGeom prst="rect">
-            <a:avLst/>
-          </a:prstGeom>
-          <a:noFill/>
-          <a:ln/>
-        </p:spPr>
-        <p:txBody>
-          <a:bodyPr wrap="square" lIns="0" tIns="0" rIns="0" bIns="0" rtlCol="0" anchor="ctr"/>
-          <a:lstStyle/>
-          <a:p>
-            <a:pPr algn="l" indent="0" marL="0">
-              <a:buNone/>
-            </a:pPr>
-            <a:r>
-              <a:rPr lang="en-US" sz="1050" dirty="0">
-                <a:solidFill>
-                  <a:srgbClr val="1A2433"/>
-                </a:solidFill>
-                <a:latin typeface="Calibri" pitchFamily="34" charset="0"/>
-                <a:ea typeface="Calibri" pitchFamily="34" charset="-122"/>
-                <a:cs typeface="Calibri" pitchFamily="34" charset="-120"/>
-              </a:rPr>
-              <a:t>Producto No Confor…</a:t>
-            </a:r>
-            <a:endParaRPr lang="en-US" sz="1050" dirty="0"/>
-          </a:p>
-        </p:txBody>
-      </p:sp>
-      <p:sp>
-        <p:nvSpPr>
-          <p:cNvPr id="43" name="Text 39"/>
-          <p:cNvSpPr/>
-          <p:nvPr/>
-        </p:nvSpPr>
-        <p:spPr>
-          <a:xfrm>
-            <a:off x="4983480" y="4754880"/>
-            <a:ext cx="1417320" cy="237744"/>
-          </a:xfrm>
-          <a:prstGeom prst="rect">
-            <a:avLst/>
-          </a:prstGeom>
-          <a:noFill/>
-          <a:ln/>
-        </p:spPr>
-        <p:txBody>
-          <a:bodyPr wrap="square" lIns="0" tIns="0" rIns="0" bIns="0" rtlCol="0" anchor="ctr"/>
-          <a:lstStyle/>
-          <a:p>
-            <a:pPr algn="l" indent="0" marL="0">
-              <a:buNone/>
-            </a:pPr>
-            <a:r>
-              <a:rPr lang="en-US" sz="1050" b="1" dirty="0">
-                <a:solidFill>
-                  <a:srgbClr val="C87A32"/>
-                </a:solidFill>
-                <a:latin typeface="Calibri" pitchFamily="34" charset="0"/>
-                <a:ea typeface="Calibri" pitchFamily="34" charset="-122"/>
-                <a:cs typeface="Calibri" pitchFamily="34" charset="-120"/>
-              </a:rPr>
-              <a:t>Externa · Cliente</a:t>
-            </a:r>
-            <a:endParaRPr lang="en-US" sz="1050" dirty="0"/>
-          </a:p>
-        </p:txBody>
-      </p:sp>
-      <p:sp>
-        <p:nvSpPr>
-          <p:cNvPr id="44" name="Text 40"/>
-          <p:cNvSpPr/>
-          <p:nvPr/>
-        </p:nvSpPr>
-        <p:spPr>
-          <a:xfrm>
-            <a:off x="6446520" y="4754880"/>
-            <a:ext cx="1097280" cy="237744"/>
-          </a:xfrm>
-          <a:prstGeom prst="rect">
-            <a:avLst/>
-          </a:prstGeom>
-          <a:noFill/>
-          <a:ln/>
-        </p:spPr>
-        <p:txBody>
-          <a:bodyPr wrap="square" lIns="0" tIns="0" rIns="0" bIns="0" rtlCol="0" anchor="ctr"/>
-          <a:lstStyle/>
-          <a:p>
-            <a:pPr algn="l" indent="0" marL="0">
-              <a:buNone/>
-            </a:pPr>
-            <a:r>
-              <a:rPr lang="en-US" sz="1050" dirty="0">
-                <a:solidFill>
-                  <a:srgbClr val="1A2433"/>
-                </a:solidFill>
-                <a:latin typeface="Calibri" pitchFamily="34" charset="0"/>
-                <a:ea typeface="Calibri" pitchFamily="34" charset="-122"/>
-                <a:cs typeface="Calibri" pitchFamily="34" charset="-120"/>
-              </a:rPr>
-              <a:t>OO.CC</a:t>
-            </a:r>
-            <a:endParaRPr lang="en-US" sz="1050" dirty="0"/>
-          </a:p>
-        </p:txBody>
-      </p:sp>
-      <p:sp>
-        <p:nvSpPr>
-          <p:cNvPr id="45" name="Text 41"/>
-          <p:cNvSpPr/>
-          <p:nvPr/>
-        </p:nvSpPr>
-        <p:spPr>
-          <a:xfrm>
-            <a:off x="7589520" y="4754880"/>
-            <a:ext cx="1371600" cy="237744"/>
-          </a:xfrm>
-          <a:prstGeom prst="rect">
-            <a:avLst/>
-          </a:prstGeom>
-          <a:noFill/>
-          <a:ln/>
-        </p:spPr>
-        <p:txBody>
-          <a:bodyPr wrap="square" lIns="0" tIns="0" rIns="0" bIns="0" rtlCol="0" anchor="ctr"/>
-          <a:lstStyle/>
-          <a:p>
-            <a:pPr algn="l" indent="0" marL="0">
-              <a:buNone/>
-            </a:pPr>
-            <a:r>
-              <a:rPr lang="en-US" sz="1050" dirty="0">
-                <a:solidFill>
-                  <a:srgbClr val="1A2433"/>
-                </a:solidFill>
-                <a:latin typeface="Calibri" pitchFamily="34" charset="0"/>
-                <a:ea typeface="Calibri" pitchFamily="34" charset="-122"/>
-                <a:cs typeface="Calibri" pitchFamily="34" charset="-120"/>
-              </a:rPr>
-              <a:t>Sebastián Ramos</a:t>
-            </a:r>
-            <a:endParaRPr lang="en-US" sz="1050" dirty="0"/>
-          </a:p>
-        </p:txBody>
-      </p:sp>
-      <p:sp>
-        <p:nvSpPr>
-          <p:cNvPr id="46" name="Text 42"/>
-          <p:cNvSpPr/>
-          <p:nvPr/>
-        </p:nvSpPr>
-        <p:spPr>
-          <a:xfrm>
-            <a:off x="9006840" y="4754880"/>
-            <a:ext cx="868680" cy="237744"/>
-          </a:xfrm>
-          <a:prstGeom prst="rect">
-            <a:avLst/>
-          </a:prstGeom>
-          <a:noFill/>
-          <a:ln/>
-        </p:spPr>
-        <p:txBody>
-          <a:bodyPr wrap="square" lIns="0" tIns="0" rIns="0" bIns="0" rtlCol="0" anchor="ctr"/>
-          <a:lstStyle/>
-          <a:p>
-            <a:pPr algn="l" indent="0" marL="0">
-              <a:buNone/>
-            </a:pPr>
-            <a:r>
-              <a:rPr lang="en-US" sz="1050" dirty="0">
-                <a:solidFill>
-                  <a:srgbClr val="C0392B"/>
-                </a:solidFill>
-                <a:latin typeface="Calibri" pitchFamily="34" charset="0"/>
-                <a:ea typeface="Calibri" pitchFamily="34" charset="-122"/>
-                <a:cs typeface="Calibri" pitchFamily="34" charset="-120"/>
-              </a:rPr>
-              <a:t>Iniciado</a:t>
-            </a:r>
-            <a:endParaRPr lang="en-US" sz="1050" dirty="0"/>
-          </a:p>
-        </p:txBody>
-      </p:sp>
-      <p:sp>
-        <p:nvSpPr>
-          <p:cNvPr id="47" name="Text 43"/>
-          <p:cNvSpPr/>
-          <p:nvPr/>
-        </p:nvSpPr>
-        <p:spPr>
-          <a:xfrm>
-            <a:off x="9921240" y="4754880"/>
-            <a:ext cx="1828800" cy="237744"/>
-          </a:xfrm>
-          <a:prstGeom prst="rect">
-            <a:avLst/>
-          </a:prstGeom>
-          <a:noFill/>
-          <a:ln/>
-        </p:spPr>
-        <p:txBody>
-          <a:bodyPr wrap="square" lIns="0" tIns="0" rIns="0" bIns="0" rtlCol="0" anchor="ctr"/>
-          <a:lstStyle/>
-          <a:p>
-            <a:pPr algn="l" indent="0" marL="0">
-              <a:buNone/>
-            </a:pPr>
-            <a:r>
-              <a:rPr lang="en-US" sz="1000" dirty="0">
-                <a:solidFill>
-                  <a:srgbClr val="1A2433"/>
-                </a:solidFill>
-                <a:latin typeface="Calibri" pitchFamily="34" charset="0"/>
-                <a:ea typeface="Calibri" pitchFamily="34" charset="-122"/>
-                <a:cs typeface="Calibri" pitchFamily="34" charset="-120"/>
-              </a:rPr>
-              <a:t>Relleno en fundaciones FS-0…</a:t>
-            </a:r>
-            <a:endParaRPr lang="en-US" sz="1000" dirty="0"/>
-          </a:p>
-        </p:txBody>
-      </p:sp>
-      <p:sp>
-        <p:nvSpPr>
-          <p:cNvPr id="48" name="Shape 44"/>
-          <p:cNvSpPr/>
-          <p:nvPr/>
-        </p:nvSpPr>
-        <p:spPr>
-          <a:xfrm>
-            <a:off x="502920" y="5029200"/>
-            <a:ext cx="11247120" cy="0"/>
-          </a:xfrm>
-          <a:prstGeom prst="line">
-            <a:avLst/>
-          </a:prstGeom>
-          <a:noFill/>
-          <a:ln w="9525">
-            <a:solidFill>
-              <a:srgbClr val="D9DFE6"/>
-            </a:solidFill>
-            <a:prstDash val="solid"/>
-          </a:ln>
-        </p:spPr>
-      </p:sp>
-      <p:sp>
-        <p:nvSpPr>
-          <p:cNvPr id="49" name="Text 45"/>
-          <p:cNvSpPr/>
-          <p:nvPr/>
-        </p:nvSpPr>
-        <p:spPr>
-          <a:xfrm>
-            <a:off x="502920" y="5084064"/>
-            <a:ext cx="822960" cy="237744"/>
-          </a:xfrm>
-          <a:prstGeom prst="rect">
-            <a:avLst/>
-          </a:prstGeom>
-          <a:noFill/>
-          <a:ln/>
-        </p:spPr>
-        <p:txBody>
-          <a:bodyPr wrap="square" lIns="0" tIns="0" rIns="0" bIns="0" rtlCol="0" anchor="ctr"/>
-          <a:lstStyle/>
-          <a:p>
-            <a:pPr algn="l" indent="0" marL="0">
-              <a:buNone/>
-            </a:pPr>
-            <a:r>
-              <a:rPr lang="en-US" sz="1050" dirty="0">
-                <a:solidFill>
-                  <a:srgbClr val="1A2433"/>
-                </a:solidFill>
-                <a:latin typeface="Calibri" pitchFamily="34" charset="0"/>
-                <a:ea typeface="Calibri" pitchFamily="34" charset="-122"/>
-                <a:cs typeface="Calibri" pitchFamily="34" charset="-120"/>
-              </a:rPr>
-              <a:t>23-07-2026</a:t>
-            </a:r>
-            <a:endParaRPr lang="en-US" sz="1050" dirty="0"/>
-          </a:p>
-        </p:txBody>
-      </p:sp>
-      <p:sp>
-        <p:nvSpPr>
-          <p:cNvPr id="50" name="Text 46"/>
-          <p:cNvSpPr/>
-          <p:nvPr/>
-        </p:nvSpPr>
-        <p:spPr>
-          <a:xfrm>
-            <a:off x="1371600" y="5084064"/>
-            <a:ext cx="1051560" cy="237744"/>
-          </a:xfrm>
-          <a:prstGeom prst="rect">
-            <a:avLst/>
-          </a:prstGeom>
-          <a:noFill/>
-          <a:ln/>
-        </p:spPr>
-        <p:txBody>
-          <a:bodyPr wrap="square" lIns="0" tIns="0" rIns="0" bIns="0" rtlCol="0" anchor="ctr"/>
-          <a:lstStyle/>
-          <a:p>
-            <a:pPr algn="l" indent="0" marL="0">
-              <a:buNone/>
-            </a:pPr>
-            <a:r>
-              <a:rPr lang="en-US" sz="1050" dirty="0">
-                <a:solidFill>
-                  <a:srgbClr val="1A2433"/>
-                </a:solidFill>
-                <a:latin typeface="Calibri" pitchFamily="34" charset="0"/>
-                <a:ea typeface="Calibri" pitchFamily="34" charset="-122"/>
-                <a:cs typeface="Calibri" pitchFamily="34" charset="-120"/>
-              </a:rPr>
-              <a:t>Talabre</a:t>
-            </a:r>
-            <a:endParaRPr lang="en-US" sz="1050" dirty="0"/>
-          </a:p>
-        </p:txBody>
-      </p:sp>
-      <p:sp>
-        <p:nvSpPr>
-          <p:cNvPr id="51" name="Text 47"/>
-          <p:cNvSpPr/>
-          <p:nvPr/>
-        </p:nvSpPr>
-        <p:spPr>
-          <a:xfrm>
-            <a:off x="2468880" y="5084064"/>
-            <a:ext cx="1051560" cy="237744"/>
-          </a:xfrm>
-          <a:prstGeom prst="rect">
-            <a:avLst/>
-          </a:prstGeom>
-          <a:noFill/>
-          <a:ln/>
-        </p:spPr>
-        <p:txBody>
-          <a:bodyPr wrap="square" lIns="0" tIns="0" rIns="0" bIns="0" rtlCol="0" anchor="ctr"/>
-          <a:lstStyle/>
-          <a:p>
-            <a:pPr algn="l" indent="0" marL="0">
-              <a:buNone/>
-            </a:pPr>
-            <a:r>
-              <a:rPr lang="en-US" sz="1050" dirty="0">
-                <a:solidFill>
-                  <a:srgbClr val="1A2433"/>
-                </a:solidFill>
-                <a:latin typeface="Calibri" pitchFamily="34" charset="0"/>
-                <a:ea typeface="Calibri" pitchFamily="34" charset="-122"/>
-                <a:cs typeface="Calibri" pitchFamily="34" charset="-120"/>
-              </a:rPr>
-              <a:t>239 · RNC N°447</a:t>
-            </a:r>
-            <a:endParaRPr lang="en-US" sz="1050" dirty="0"/>
-          </a:p>
-        </p:txBody>
-      </p:sp>
-      <p:sp>
-        <p:nvSpPr>
-          <p:cNvPr id="52" name="Text 48"/>
-          <p:cNvSpPr/>
-          <p:nvPr/>
-        </p:nvSpPr>
-        <p:spPr>
-          <a:xfrm>
-            <a:off x="3566160" y="5084064"/>
-            <a:ext cx="1371600" cy="237744"/>
-          </a:xfrm>
-          <a:prstGeom prst="rect">
-            <a:avLst/>
-          </a:prstGeom>
-          <a:noFill/>
-          <a:ln/>
-        </p:spPr>
-        <p:txBody>
-          <a:bodyPr wrap="square" lIns="0" tIns="0" rIns="0" bIns="0" rtlCol="0" anchor="ctr"/>
-          <a:lstStyle/>
-          <a:p>
-            <a:pPr algn="l" indent="0" marL="0">
-              <a:buNone/>
-            </a:pPr>
-            <a:r>
-              <a:rPr lang="en-US" sz="1050" dirty="0">
-                <a:solidFill>
-                  <a:srgbClr val="1A2433"/>
-                </a:solidFill>
-                <a:latin typeface="Calibri" pitchFamily="34" charset="0"/>
-                <a:ea typeface="Calibri" pitchFamily="34" charset="-122"/>
-                <a:cs typeface="Calibri" pitchFamily="34" charset="-120"/>
-              </a:rPr>
-              <a:t>No Conformidad</a:t>
-            </a:r>
-            <a:endParaRPr lang="en-US" sz="1050" dirty="0"/>
-          </a:p>
-        </p:txBody>
-      </p:sp>
-      <p:sp>
-        <p:nvSpPr>
-          <p:cNvPr id="53" name="Text 49"/>
-          <p:cNvSpPr/>
-          <p:nvPr/>
-        </p:nvSpPr>
-        <p:spPr>
-          <a:xfrm>
-            <a:off x="4983480" y="5084064"/>
-            <a:ext cx="1417320" cy="237744"/>
-          </a:xfrm>
-          <a:prstGeom prst="rect">
-            <a:avLst/>
-          </a:prstGeom>
-          <a:noFill/>
-          <a:ln/>
-        </p:spPr>
-        <p:txBody>
-          <a:bodyPr wrap="square" lIns="0" tIns="0" rIns="0" bIns="0" rtlCol="0" anchor="ctr"/>
-          <a:lstStyle/>
-          <a:p>
-            <a:pPr algn="l" indent="0" marL="0">
-              <a:buNone/>
-            </a:pPr>
-            <a:r>
-              <a:rPr lang="en-US" sz="1050" b="1" dirty="0">
-                <a:solidFill>
-                  <a:srgbClr val="C87A32"/>
-                </a:solidFill>
-                <a:latin typeface="Calibri" pitchFamily="34" charset="0"/>
-                <a:ea typeface="Calibri" pitchFamily="34" charset="-122"/>
-                <a:cs typeface="Calibri" pitchFamily="34" charset="-120"/>
-              </a:rPr>
-              <a:t>Externa · Cliente</a:t>
-            </a:r>
-            <a:endParaRPr lang="en-US" sz="1050" dirty="0"/>
-          </a:p>
-        </p:txBody>
-      </p:sp>
-      <p:sp>
-        <p:nvSpPr>
-          <p:cNvPr id="54" name="Text 50"/>
-          <p:cNvSpPr/>
-          <p:nvPr/>
-        </p:nvSpPr>
-        <p:spPr>
-          <a:xfrm>
-            <a:off x="6446520" y="5084064"/>
-            <a:ext cx="1097280" cy="237744"/>
-          </a:xfrm>
-          <a:prstGeom prst="rect">
-            <a:avLst/>
-          </a:prstGeom>
-          <a:noFill/>
-          <a:ln/>
-        </p:spPr>
-        <p:txBody>
-          <a:bodyPr wrap="square" lIns="0" tIns="0" rIns="0" bIns="0" rtlCol="0" anchor="ctr"/>
-          <a:lstStyle/>
-          <a:p>
-            <a:pPr algn="l" indent="0" marL="0">
-              <a:buNone/>
-            </a:pPr>
-            <a:r>
-              <a:rPr lang="en-US" sz="1050" dirty="0">
-                <a:solidFill>
-                  <a:srgbClr val="1A2433"/>
-                </a:solidFill>
-                <a:latin typeface="Calibri" pitchFamily="34" charset="0"/>
-                <a:ea typeface="Calibri" pitchFamily="34" charset="-122"/>
-                <a:cs typeface="Calibri" pitchFamily="34" charset="-120"/>
-              </a:rPr>
-              <a:t>OO.CC</a:t>
-            </a:r>
-            <a:endParaRPr lang="en-US" sz="1050" dirty="0"/>
-          </a:p>
-        </p:txBody>
-      </p:sp>
-      <p:sp>
-        <p:nvSpPr>
-          <p:cNvPr id="55" name="Text 51"/>
-          <p:cNvSpPr/>
-          <p:nvPr/>
-        </p:nvSpPr>
-        <p:spPr>
-          <a:xfrm>
-            <a:off x="7589520" y="5084064"/>
-            <a:ext cx="1371600" cy="237744"/>
-          </a:xfrm>
-          <a:prstGeom prst="rect">
-            <a:avLst/>
-          </a:prstGeom>
-          <a:noFill/>
-          <a:ln/>
-        </p:spPr>
-        <p:txBody>
-          <a:bodyPr wrap="square" lIns="0" tIns="0" rIns="0" bIns="0" rtlCol="0" anchor="ctr"/>
-          <a:lstStyle/>
-          <a:p>
-            <a:pPr algn="l" indent="0" marL="0">
-              <a:buNone/>
-            </a:pPr>
-            <a:r>
-              <a:rPr lang="en-US" sz="1050" dirty="0">
-                <a:solidFill>
-                  <a:srgbClr val="1A2433"/>
-                </a:solidFill>
-                <a:latin typeface="Calibri" pitchFamily="34" charset="0"/>
-                <a:ea typeface="Calibri" pitchFamily="34" charset="-122"/>
-                <a:cs typeface="Calibri" pitchFamily="34" charset="-120"/>
-              </a:rPr>
-              <a:t>Mauricio Rocha A.</a:t>
-            </a:r>
-            <a:endParaRPr lang="en-US" sz="1050" dirty="0"/>
-          </a:p>
-        </p:txBody>
-      </p:sp>
-      <p:sp>
-        <p:nvSpPr>
-          <p:cNvPr id="56" name="Text 52"/>
-          <p:cNvSpPr/>
-          <p:nvPr/>
-        </p:nvSpPr>
-        <p:spPr>
-          <a:xfrm>
-            <a:off x="9006840" y="5084064"/>
-            <a:ext cx="868680" cy="237744"/>
-          </a:xfrm>
-          <a:prstGeom prst="rect">
-            <a:avLst/>
-          </a:prstGeom>
-          <a:noFill/>
-          <a:ln/>
-        </p:spPr>
-        <p:txBody>
-          <a:bodyPr wrap="square" lIns="0" tIns="0" rIns="0" bIns="0" rtlCol="0" anchor="ctr"/>
-          <a:lstStyle/>
-          <a:p>
-            <a:pPr algn="l" indent="0" marL="0">
-              <a:buNone/>
-            </a:pPr>
-            <a:r>
-              <a:rPr lang="en-US" sz="1050" dirty="0">
-                <a:solidFill>
-                  <a:srgbClr val="C0392B"/>
-                </a:solidFill>
-                <a:latin typeface="Calibri" pitchFamily="34" charset="0"/>
-                <a:ea typeface="Calibri" pitchFamily="34" charset="-122"/>
-                <a:cs typeface="Calibri" pitchFamily="34" charset="-120"/>
-              </a:rPr>
-              <a:t>Iniciado</a:t>
-            </a:r>
-            <a:endParaRPr lang="en-US" sz="1050" dirty="0"/>
-          </a:p>
-        </p:txBody>
-      </p:sp>
-      <p:sp>
-        <p:nvSpPr>
-          <p:cNvPr id="57" name="Text 53"/>
-          <p:cNvSpPr/>
-          <p:nvPr/>
-        </p:nvSpPr>
-        <p:spPr>
-          <a:xfrm>
-            <a:off x="9921240" y="5084064"/>
-            <a:ext cx="1828800" cy="237744"/>
-          </a:xfrm>
-          <a:prstGeom prst="rect">
-            <a:avLst/>
-          </a:prstGeom>
-          <a:noFill/>
-          <a:ln/>
-        </p:spPr>
-        <p:txBody>
-          <a:bodyPr wrap="square" lIns="0" tIns="0" rIns="0" bIns="0" rtlCol="0" anchor="ctr"/>
-          <a:lstStyle/>
-          <a:p>
-            <a:pPr algn="l" indent="0" marL="0">
-              <a:buNone/>
-            </a:pPr>
-            <a:r>
-              <a:rPr lang="en-US" sz="1000" dirty="0">
-                <a:solidFill>
-                  <a:srgbClr val="1A2433"/>
-                </a:solidFill>
-                <a:latin typeface="Calibri" pitchFamily="34" charset="0"/>
-                <a:ea typeface="Calibri" pitchFamily="34" charset="-122"/>
-                <a:cs typeface="Calibri" pitchFamily="34" charset="-120"/>
-              </a:rPr>
-              <a:t>Presencia de daños visibles…</a:t>
-            </a:r>
-            <a:endParaRPr lang="en-US" sz="1000" dirty="0"/>
-          </a:p>
-        </p:txBody>
-      </p:sp>
-      <p:sp>
-        <p:nvSpPr>
-          <p:cNvPr id="58" name="Shape 54"/>
-          <p:cNvSpPr/>
-          <p:nvPr/>
-        </p:nvSpPr>
-        <p:spPr>
-          <a:xfrm>
-            <a:off x="502920" y="5358384"/>
-            <a:ext cx="11247120" cy="0"/>
-          </a:xfrm>
-          <a:prstGeom prst="line">
-            <a:avLst/>
-          </a:prstGeom>
-          <a:noFill/>
-          <a:ln w="9525">
-            <a:solidFill>
-              <a:srgbClr val="D9DFE6"/>
-            </a:solidFill>
-            <a:prstDash val="solid"/>
-          </a:ln>
-        </p:spPr>
-      </p:sp>
-      <p:sp>
-        <p:nvSpPr>
-          <p:cNvPr id="59" name="Shape 55"/>
-          <p:cNvSpPr/>
-          <p:nvPr/>
-        </p:nvSpPr>
-        <p:spPr>
-          <a:xfrm>
-            <a:off x="457200" y="5367528"/>
-            <a:ext cx="11292840" cy="329184"/>
-          </a:xfrm>
-          <a:prstGeom prst="rect">
-            <a:avLst/>
-          </a:prstGeom>
-          <a:solidFill>
-            <a:srgbClr val="FFFFFF"/>
-          </a:solidFill>
-          <a:ln/>
-        </p:spPr>
-      </p:sp>
-      <p:sp>
-        <p:nvSpPr>
-          <p:cNvPr id="60" name="Text 56"/>
-          <p:cNvSpPr/>
-          <p:nvPr/>
-        </p:nvSpPr>
-        <p:spPr>
-          <a:xfrm>
-            <a:off x="502920" y="5413248"/>
-            <a:ext cx="822960" cy="237744"/>
-          </a:xfrm>
-          <a:prstGeom prst="rect">
-            <a:avLst/>
-          </a:prstGeom>
-          <a:noFill/>
-          <a:ln/>
-        </p:spPr>
-        <p:txBody>
-          <a:bodyPr wrap="square" lIns="0" tIns="0" rIns="0" bIns="0" rtlCol="0" anchor="ctr"/>
-          <a:lstStyle/>
-          <a:p>
-            <a:pPr algn="l" indent="0" marL="0">
-              <a:buNone/>
-            </a:pPr>
-            <a:r>
-              <a:rPr lang="en-US" sz="1050" dirty="0">
-                <a:solidFill>
-                  <a:srgbClr val="1A2433"/>
-                </a:solidFill>
-                <a:latin typeface="Calibri" pitchFamily="34" charset="0"/>
-                <a:ea typeface="Calibri" pitchFamily="34" charset="-122"/>
-                <a:cs typeface="Calibri" pitchFamily="34" charset="-120"/>
-              </a:rPr>
-              <a:t>27-07-2026</a:t>
-            </a:r>
-            <a:endParaRPr lang="en-US" sz="1050" dirty="0"/>
-          </a:p>
-        </p:txBody>
-      </p:sp>
-      <p:sp>
-        <p:nvSpPr>
-          <p:cNvPr id="61" name="Text 57"/>
-          <p:cNvSpPr/>
-          <p:nvPr/>
-        </p:nvSpPr>
-        <p:spPr>
-          <a:xfrm>
-            <a:off x="1371600" y="5413248"/>
-            <a:ext cx="1051560" cy="237744"/>
-          </a:xfrm>
-          <a:prstGeom prst="rect">
-            <a:avLst/>
-          </a:prstGeom>
-          <a:noFill/>
-          <a:ln/>
-        </p:spPr>
-        <p:txBody>
-          <a:bodyPr wrap="square" lIns="0" tIns="0" rIns="0" bIns="0" rtlCol="0" anchor="ctr"/>
-          <a:lstStyle/>
-          <a:p>
-            <a:pPr algn="l" indent="0" marL="0">
-              <a:buNone/>
-            </a:pPr>
-            <a:r>
-              <a:rPr lang="en-US" sz="1050" dirty="0">
-                <a:solidFill>
-                  <a:srgbClr val="1A2433"/>
-                </a:solidFill>
-                <a:latin typeface="Calibri" pitchFamily="34" charset="0"/>
-                <a:ea typeface="Calibri" pitchFamily="34" charset="-122"/>
-                <a:cs typeface="Calibri" pitchFamily="34" charset="-120"/>
-              </a:rPr>
-              <a:t>Desaladora</a:t>
-            </a:r>
-            <a:endParaRPr lang="en-US" sz="1050" dirty="0"/>
-          </a:p>
-        </p:txBody>
-      </p:sp>
-      <p:sp>
-        <p:nvSpPr>
-          <p:cNvPr id="62" name="Text 58"/>
-          <p:cNvSpPr/>
-          <p:nvPr/>
-        </p:nvSpPr>
-        <p:spPr>
-          <a:xfrm>
-            <a:off x="2468880" y="5413248"/>
-            <a:ext cx="1051560" cy="237744"/>
-          </a:xfrm>
-          <a:prstGeom prst="rect">
-            <a:avLst/>
-          </a:prstGeom>
-          <a:noFill/>
-          <a:ln/>
-        </p:spPr>
-        <p:txBody>
-          <a:bodyPr wrap="square" lIns="0" tIns="0" rIns="0" bIns="0" rtlCol="0" anchor="ctr"/>
-          <a:lstStyle/>
-          <a:p>
-            <a:pPr algn="l" indent="0" marL="0">
-              <a:buNone/>
-            </a:pPr>
-            <a:r>
-              <a:rPr lang="en-US" sz="1050" dirty="0">
-                <a:solidFill>
-                  <a:srgbClr val="1A2433"/>
-                </a:solidFill>
-                <a:latin typeface="Calibri" pitchFamily="34" charset="0"/>
-                <a:ea typeface="Calibri" pitchFamily="34" charset="-122"/>
-                <a:cs typeface="Calibri" pitchFamily="34" charset="-120"/>
-              </a:rPr>
-              <a:t>95 · NCR-0535</a:t>
-            </a:r>
-            <a:endParaRPr lang="en-US" sz="1050" dirty="0"/>
-          </a:p>
-        </p:txBody>
-      </p:sp>
-      <p:sp>
-        <p:nvSpPr>
-          <p:cNvPr id="63" name="Text 59"/>
-          <p:cNvSpPr/>
-          <p:nvPr/>
-        </p:nvSpPr>
-        <p:spPr>
-          <a:xfrm>
-            <a:off x="3566160" y="5413248"/>
-            <a:ext cx="1371600" cy="237744"/>
-          </a:xfrm>
-          <a:prstGeom prst="rect">
-            <a:avLst/>
-          </a:prstGeom>
-          <a:noFill/>
-          <a:ln/>
-        </p:spPr>
-        <p:txBody>
-          <a:bodyPr wrap="square" lIns="0" tIns="0" rIns="0" bIns="0" rtlCol="0" anchor="ctr"/>
-          <a:lstStyle/>
-          <a:p>
-            <a:pPr algn="l" indent="0" marL="0">
-              <a:buNone/>
-            </a:pPr>
-            <a:r>
-              <a:rPr lang="en-US" sz="1050" dirty="0">
-                <a:solidFill>
-                  <a:srgbClr val="1A2433"/>
-                </a:solidFill>
-                <a:latin typeface="Calibri" pitchFamily="34" charset="0"/>
-                <a:ea typeface="Calibri" pitchFamily="34" charset="-122"/>
-                <a:cs typeface="Calibri" pitchFamily="34" charset="-120"/>
-              </a:rPr>
-              <a:t>No Conformidad</a:t>
-            </a:r>
-            <a:endParaRPr lang="en-US" sz="1050" dirty="0"/>
-          </a:p>
-        </p:txBody>
-      </p:sp>
-      <p:sp>
-        <p:nvSpPr>
-          <p:cNvPr id="64" name="Text 60"/>
-          <p:cNvSpPr/>
-          <p:nvPr/>
-        </p:nvSpPr>
-        <p:spPr>
-          <a:xfrm>
-            <a:off x="4983480" y="5413248"/>
-            <a:ext cx="1417320" cy="237744"/>
-          </a:xfrm>
-          <a:prstGeom prst="rect">
-            <a:avLst/>
-          </a:prstGeom>
-          <a:noFill/>
-          <a:ln/>
-        </p:spPr>
-        <p:txBody>
-          <a:bodyPr wrap="square" lIns="0" tIns="0" rIns="0" bIns="0" rtlCol="0" anchor="ctr"/>
-          <a:lstStyle/>
-          <a:p>
-            <a:pPr algn="l" indent="0" marL="0">
-              <a:buNone/>
-            </a:pPr>
-            <a:r>
-              <a:rPr lang="en-US" sz="1050" b="1" dirty="0">
-                <a:solidFill>
-                  <a:srgbClr val="C87A32"/>
-                </a:solidFill>
-                <a:latin typeface="Calibri" pitchFamily="34" charset="0"/>
-                <a:ea typeface="Calibri" pitchFamily="34" charset="-122"/>
-                <a:cs typeface="Calibri" pitchFamily="34" charset="-120"/>
-              </a:rPr>
-              <a:t>Externa · Cliente</a:t>
-            </a:r>
-            <a:endParaRPr lang="en-US" sz="1050" dirty="0"/>
-          </a:p>
-        </p:txBody>
-      </p:sp>
-      <p:sp>
-        <p:nvSpPr>
-          <p:cNvPr id="65" name="Text 61"/>
-          <p:cNvSpPr/>
-          <p:nvPr/>
-        </p:nvSpPr>
-        <p:spPr>
-          <a:xfrm>
-            <a:off x="6446520" y="5413248"/>
-            <a:ext cx="1097280" cy="237744"/>
-          </a:xfrm>
-          <a:prstGeom prst="rect">
-            <a:avLst/>
-          </a:prstGeom>
-          <a:noFill/>
-          <a:ln/>
-        </p:spPr>
-        <p:txBody>
-          <a:bodyPr wrap="square" lIns="0" tIns="0" rIns="0" bIns="0" rtlCol="0" anchor="ctr"/>
-          <a:lstStyle/>
-          <a:p>
-            <a:pPr algn="l" indent="0" marL="0">
-              <a:buNone/>
-            </a:pPr>
-            <a:r>
-              <a:rPr lang="en-US" sz="1050" dirty="0">
-                <a:solidFill>
-                  <a:srgbClr val="1A2433"/>
-                </a:solidFill>
-                <a:latin typeface="Calibri" pitchFamily="34" charset="0"/>
-                <a:ea typeface="Calibri" pitchFamily="34" charset="-122"/>
-                <a:cs typeface="Calibri" pitchFamily="34" charset="-120"/>
-              </a:rPr>
-              <a:t>MECÁNICA</a:t>
-            </a:r>
-            <a:endParaRPr lang="en-US" sz="1050" dirty="0"/>
-          </a:p>
-        </p:txBody>
-      </p:sp>
-      <p:sp>
-        <p:nvSpPr>
-          <p:cNvPr id="66" name="Text 62"/>
-          <p:cNvSpPr/>
-          <p:nvPr/>
-        </p:nvSpPr>
-        <p:spPr>
-          <a:xfrm>
-            <a:off x="7589520" y="5413248"/>
-            <a:ext cx="1371600" cy="237744"/>
-          </a:xfrm>
-          <a:prstGeom prst="rect">
-            <a:avLst/>
-          </a:prstGeom>
-          <a:noFill/>
-          <a:ln/>
-        </p:spPr>
-        <p:txBody>
-          <a:bodyPr wrap="square" lIns="0" tIns="0" rIns="0" bIns="0" rtlCol="0" anchor="ctr"/>
-          <a:lstStyle/>
-          <a:p>
-            <a:pPr algn="l" indent="0" marL="0">
-              <a:buNone/>
-            </a:pPr>
-            <a:r>
-              <a:rPr lang="en-US" sz="1050" dirty="0">
-                <a:solidFill>
-                  <a:srgbClr val="1A2433"/>
-                </a:solidFill>
-                <a:latin typeface="Calibri" pitchFamily="34" charset="0"/>
-                <a:ea typeface="Calibri" pitchFamily="34" charset="-122"/>
-                <a:cs typeface="Calibri" pitchFamily="34" charset="-120"/>
-              </a:rPr>
-              <a:t>Wilson Jara</a:t>
-            </a:r>
-            <a:endParaRPr lang="en-US" sz="1050" dirty="0"/>
-          </a:p>
-        </p:txBody>
-      </p:sp>
-      <p:sp>
-        <p:nvSpPr>
-          <p:cNvPr id="67" name="Text 63"/>
-          <p:cNvSpPr/>
-          <p:nvPr/>
-        </p:nvSpPr>
-        <p:spPr>
-          <a:xfrm>
-            <a:off x="9006840" y="5413248"/>
-            <a:ext cx="868680" cy="237744"/>
-          </a:xfrm>
-          <a:prstGeom prst="rect">
-            <a:avLst/>
-          </a:prstGeom>
-          <a:noFill/>
-          <a:ln/>
-        </p:spPr>
-        <p:txBody>
-          <a:bodyPr wrap="square" lIns="0" tIns="0" rIns="0" bIns="0" rtlCol="0" anchor="ctr"/>
-          <a:lstStyle/>
-          <a:p>
-            <a:pPr algn="l" indent="0" marL="0">
-              <a:buNone/>
-            </a:pPr>
-            <a:r>
-              <a:rPr lang="en-US" sz="1050" dirty="0">
-                <a:solidFill>
-                  <a:srgbClr val="C0392B"/>
-                </a:solidFill>
-                <a:latin typeface="Calibri" pitchFamily="34" charset="0"/>
-                <a:ea typeface="Calibri" pitchFamily="34" charset="-122"/>
-                <a:cs typeface="Calibri" pitchFamily="34" charset="-120"/>
-              </a:rPr>
-              <a:t>Iniciado</a:t>
-            </a:r>
-            <a:endParaRPr lang="en-US" sz="1050" dirty="0"/>
-          </a:p>
-        </p:txBody>
-      </p:sp>
-      <p:sp>
-        <p:nvSpPr>
-          <p:cNvPr id="68" name="Text 64"/>
-          <p:cNvSpPr/>
-          <p:nvPr/>
-        </p:nvSpPr>
-        <p:spPr>
-          <a:xfrm>
-            <a:off x="9921240" y="5413248"/>
-            <a:ext cx="1828800" cy="237744"/>
-          </a:xfrm>
-          <a:prstGeom prst="rect">
-            <a:avLst/>
-          </a:prstGeom>
-          <a:noFill/>
-          <a:ln/>
-        </p:spPr>
-        <p:txBody>
-          <a:bodyPr wrap="square" lIns="0" tIns="0" rIns="0" bIns="0" rtlCol="0" anchor="ctr"/>
-          <a:lstStyle/>
-          <a:p>
-            <a:pPr algn="l" indent="0" marL="0">
-              <a:buNone/>
-            </a:pPr>
-            <a:r>
-              <a:rPr lang="en-US" sz="1000" dirty="0">
-                <a:solidFill>
-                  <a:srgbClr val="1A2433"/>
-                </a:solidFill>
-                <a:latin typeface="Calibri" pitchFamily="34" charset="0"/>
-                <a:ea typeface="Calibri" pitchFamily="34" charset="-122"/>
-                <a:cs typeface="Calibri" pitchFamily="34" charset="-120"/>
-              </a:rPr>
-              <a:t>Verificación de Preservación</a:t>
-            </a:r>
-            <a:endParaRPr lang="en-US" sz="1000" dirty="0"/>
-          </a:p>
-        </p:txBody>
-      </p:sp>
-      <p:sp>
-        <p:nvSpPr>
-          <p:cNvPr id="69" name="Shape 65"/>
-          <p:cNvSpPr/>
-          <p:nvPr/>
-        </p:nvSpPr>
-        <p:spPr>
-          <a:xfrm>
-            <a:off x="502920" y="5687568"/>
-            <a:ext cx="11247120" cy="0"/>
-          </a:xfrm>
-          <a:prstGeom prst="line">
-            <a:avLst/>
-          </a:prstGeom>
-          <a:noFill/>
-          <a:ln w="9525">
-            <a:solidFill>
-              <a:srgbClr val="D9DFE6"/>
-            </a:solidFill>
-            <a:prstDash val="solid"/>
-          </a:ln>
-        </p:spPr>
-      </p:sp>
-      <p:sp>
-        <p:nvSpPr>
-          <p:cNvPr id="70" name="Text 66"/>
+          <p:cNvPr id="38" name="Text 34"/>
           <p:cNvSpPr/>
           <p:nvPr/>
         </p:nvSpPr>
@@ -24265,7 +23103,7 @@
                 <a:ea typeface="Calibri" pitchFamily="34" charset="-122"/>
                 <a:cs typeface="Calibri" pitchFamily="34" charset="-120"/>
               </a:rPr>
-              <a:t>Fuente: 5640140e-Data_NCR_1.xlsx — hoja «Observaciones» · Corte 27-07-2026 · 436 registros desde 10-02-2023</a:t>
+              <a:t>Fuente: 1e73482e-Data_NCR03082026.xlsx — hoja «Observaciones» · Corte 03-08-2026 · 438 registros desde 10-02-2023</a:t>
             </a:r>
             <a:endParaRPr lang="en-US" sz="850" dirty="0"/>
           </a:p>
@@ -24273,7 +23111,7 @@
       </p:sp>
       <p:sp>
         <p:nvSpPr>
-          <p:cNvPr id="71" name="Text 67"/>
+          <p:cNvPr id="39" name="Text 35"/>
           <p:cNvSpPr/>
           <p:nvPr/>
         </p:nvSpPr>
@@ -24312,7 +23150,7 @@
       </p:sp>
       <p:sp>
         <p:nvSpPr>
-          <p:cNvPr id="72" name="Text 68"/>
+          <p:cNvPr id="40" name="Text 36"/>
           <p:cNvSpPr/>
           <p:nvPr/>
         </p:nvSpPr>
@@ -24516,7 +23354,7 @@
                 <a:ea typeface="Calibri" pitchFamily="34" charset="-122"/>
                 <a:cs typeface="Calibri" pitchFamily="34" charset="-120"/>
               </a:rPr>
-              <a:t>Interna es autodetección: la levanta Besalco antes que nadie. Externa la levanta el cliente —compromete el contrato— o un subcontrato. Autodetección global: 37,9%.</a:t>
+              <a:t>Interna es autodetección: la levanta Besalco antes que nadie. Externa la levanta el cliente —compromete el contrato— o un subcontrato. Autodetección global: 37,8%.</a:t>
             </a:r>
             <a:endParaRPr lang="en-US" sz="1350" dirty="0"/>
           </a:p>
@@ -24726,7 +23564,7 @@
                 <a:ea typeface="Cambria" pitchFamily="34" charset="-122"/>
                 <a:cs typeface="Cambria" pitchFamily="34" charset="-120"/>
               </a:rPr>
-              <a:t>22,2%</a:t>
+              <a:t>22%</a:t>
             </a:r>
             <a:endParaRPr lang="en-US" sz="2400" dirty="0"/>
           </a:p>
@@ -24882,7 +23720,7 @@
                 <a:ea typeface="Calibri" pitchFamily="34" charset="-122"/>
                 <a:cs typeface="Calibri" pitchFamily="34" charset="-120"/>
               </a:rPr>
-              <a:t>Fuente: 5640140e-Data_NCR_1.xlsx — hoja «Observaciones» · Corte 27-07-2026 · 436 registros desde 10-02-2023</a:t>
+              <a:t>Fuente: 1e73482e-Data_NCR03082026.xlsx — hoja «Observaciones» · Corte 03-08-2026 · 438 registros desde 10-02-2023</a:t>
             </a:r>
             <a:endParaRPr lang="en-US" sz="850" dirty="0"/>
           </a:p>
@@ -25133,7 +23971,7 @@
                 <a:ea typeface="Calibri" pitchFamily="34" charset="-122"/>
                 <a:cs typeface="Calibri" pitchFamily="34" charset="-120"/>
               </a:rPr>
-              <a:t>De los 30 hallazgos abiertos, 7 llevan más de 180 días desde que se levantaron y 2 más de un año. La mediana de cierre global es de 28 días.</a:t>
+              <a:t>De los 19 hallazgos abiertos, 3 llevan más de 180 días desde que se levantaron y 1 más de un año. La mediana de cierre global es de 28 días.</a:t>
             </a:r>
             <a:endParaRPr lang="en-US" sz="1350" dirty="0"/>
           </a:p>
@@ -25270,7 +24108,7 @@
                 <a:ea typeface="Calibri" pitchFamily="34" charset="-122"/>
                 <a:cs typeface="Calibri" pitchFamily="34" charset="-120"/>
               </a:rPr>
-              <a:t>Ninguno de los 30 abiertos trae esa fecha: la columna «Fecha De Cierre» del Excel solo se llena al cerrar. El indicador no se puede calcular y el panel lo declara en vez de informar 0 atrasados. En su lugar se usa la antigüedad.</a:t>
+              <a:t>Ninguno de los 19 abiertos trae esa fecha: la columna «Fecha De Cierre» del Excel solo se llena al cerrar. El indicador no se puede calcular y el panel lo declara en vez de informar 0 atrasados. En su lugar se usa la antigüedad.</a:t>
             </a:r>
             <a:endParaRPr lang="en-US" sz="1150" dirty="0"/>
           </a:p>
@@ -25949,7 +24787,7 @@
                 <a:ea typeface="Calibri" pitchFamily="34" charset="-122"/>
                 <a:cs typeface="Calibri" pitchFamily="34" charset="-120"/>
               </a:rPr>
-              <a:t>213</a:t>
+              <a:t>226</a:t>
             </a:r>
             <a:endParaRPr lang="en-US" sz="1150" dirty="0"/>
           </a:p>
@@ -25988,7 +24826,7 @@
                 <a:ea typeface="Calibri" pitchFamily="34" charset="-122"/>
                 <a:cs typeface="Calibri" pitchFamily="34" charset="-120"/>
               </a:rPr>
-              <a:t>22 d</a:t>
+              <a:t>23 d</a:t>
             </a:r>
             <a:endParaRPr lang="en-US" sz="1150" dirty="0"/>
           </a:p>
@@ -26027,7 +24865,7 @@
                 <a:ea typeface="Calibri" pitchFamily="34" charset="-122"/>
                 <a:cs typeface="Calibri" pitchFamily="34" charset="-120"/>
               </a:rPr>
-              <a:t>269 d</a:t>
+              <a:t>389 d</a:t>
             </a:r>
             <a:endParaRPr lang="en-US" sz="1150" dirty="0"/>
           </a:p>
@@ -26060,13 +24898,13 @@
             <a:r>
               <a:rPr lang="en-US" sz="1150" dirty="0">
                 <a:solidFill>
-                  <a:srgbClr val="C0392B"/>
-                </a:solidFill>
-                <a:latin typeface="Calibri" pitchFamily="34" charset="0"/>
-                <a:ea typeface="Calibri" pitchFamily="34" charset="-122"/>
-                <a:cs typeface="Calibri" pitchFamily="34" charset="-120"/>
-              </a:rPr>
-              <a:t>26</a:t>
+                  <a:srgbClr val="1A2433"/>
+                </a:solidFill>
+                <a:latin typeface="Calibri" pitchFamily="34" charset="0"/>
+                <a:ea typeface="Calibri" pitchFamily="34" charset="-122"/>
+                <a:cs typeface="Calibri" pitchFamily="34" charset="-120"/>
+              </a:rPr>
+              <a:t>15</a:t>
             </a:r>
             <a:endParaRPr lang="en-US" sz="1150" dirty="0"/>
           </a:p>
@@ -26690,7 +25528,7 @@
                 <a:ea typeface="Calibri" pitchFamily="34" charset="-122"/>
                 <a:cs typeface="Calibri" pitchFamily="34" charset="-120"/>
               </a:rPr>
-              <a:t>Fuente: 5640140e-Data_NCR_1.xlsx — hoja «Observaciones» · Corte 27-07-2026 · 436 registros desde 10-02-2023</a:t>
+              <a:t>Fuente: 1e73482e-Data_NCR03082026.xlsx — hoja «Observaciones» · Corte 03-08-2026 · 438 registros desde 10-02-2023</a:t>
             </a:r>
             <a:endParaRPr lang="en-US" sz="850" dirty="0"/>
           </a:p>
@@ -27064,7 +25902,7 @@
                 <a:ea typeface="Calibri" pitchFamily="34" charset="-122"/>
                 <a:cs typeface="Calibri" pitchFamily="34" charset="-120"/>
               </a:rPr>
-              <a:t>26 de los 30 hallazgos abiertos (86,7%) y 89,1% de cierre, contra 93,1% global. Es la ruta crítica del módulo.</a:t>
+              <a:t>15 de los 19 hallazgos abiertos (78,9%) y 93,8% de cierre, contra 95,7% global. Es la ruta crítica del módulo.</a:t>
             </a:r>
             <a:endParaRPr lang="en-US" sz="1100" dirty="0"/>
           </a:p>
@@ -27206,7 +26044,7 @@
                 <a:ea typeface="Calibri" pitchFamily="34" charset="-122"/>
                 <a:cs typeface="Calibri" pitchFamily="34" charset="-120"/>
               </a:rPr>
-              <a:t>Solo 22,2% de sus hallazgos los detecta Besalco; el mejor frente va en 59,6%. Lo que no se detecta adentro llega como observación del cliente.</a:t>
+              <a:t>Solo 22% de sus hallazgos los detecta Besalco; el mejor frente va en 59,6%. Lo que no se detecta adentro llega como observación del cliente.</a:t>
             </a:r>
             <a:endParaRPr lang="en-US" sz="1100" dirty="0"/>
           </a:p>
@@ -27306,7 +26144,7 @@
                 <a:ea typeface="Calibri" pitchFamily="34" charset="-122"/>
                 <a:cs typeface="Calibri" pitchFamily="34" charset="-120"/>
               </a:rPr>
-              <a:t>Sacar los 7 hallazgos sobre 180 días</a:t>
+              <a:t>Sacar los 3 hallazgos sobre 180 días</a:t>
             </a:r>
             <a:endParaRPr lang="en-US" sz="1400" dirty="0"/>
           </a:p>
@@ -27348,7 +26186,7 @@
                 <a:ea typeface="Calibri" pitchFamily="34" charset="-122"/>
                 <a:cs typeface="Calibri" pitchFamily="34" charset="-120"/>
               </a:rPr>
-              <a:t>2 de ellos superan el año abiertos. Los tienen a cargo Alejandro Rivera G. (4), Alvaro Cortés V. (3). Es deuda antigua que no se cierra sola.</a:t>
+              <a:t>1 de ellos superan el año abiertos. Los tienen a cargo Alvaro Cortés V. (3). Es deuda antigua que no se cierra sola.</a:t>
             </a:r>
             <a:endParaRPr lang="en-US" sz="1100" dirty="0"/>
           </a:p>
@@ -27529,7 +26367,7 @@
                 <a:ea typeface="Calibri" pitchFamily="34" charset="-122"/>
                 <a:cs typeface="Calibri" pitchFamily="34" charset="-120"/>
               </a:rPr>
-              <a:t>Fuente: 5640140e-Data_NCR_1.xlsx — hoja «Observaciones» · Corte 27-07-2026 · 436 registros desde 10-02-2023</a:t>
+              <a:t>Fuente: 1e73482e-Data_NCR03082026.xlsx — hoja «Observaciones» · Corte 03-08-2026 · 438 registros desde 10-02-2023</a:t>
             </a:r>
             <a:endParaRPr lang="en-US" sz="850" dirty="0"/>
           </a:p>
@@ -28253,7 +27091,7 @@
                 <a:ea typeface="Calibri" pitchFamily="34" charset="-122"/>
                 <a:cs typeface="Calibri" pitchFamily="34" charset="-120"/>
               </a:rPr>
-              <a:t>Corte: 27-07-2026</a:t>
+              <a:t>Corte: 03-08-2026</a:t>
             </a:r>
             <a:endParaRPr lang="en-US" sz="1100" dirty="0"/>
           </a:p>
@@ -28292,7 +27130,7 @@
                 <a:ea typeface="Calibri" pitchFamily="34" charset="-122"/>
                 <a:cs typeface="Calibri" pitchFamily="34" charset="-120"/>
               </a:rPr>
-              <a:t>Fuente: 5640140e-Data_NCR_1.xlsx — hoja «Observaciones» · Corte 27-07-2026 · 436 registros desde 10-02-2023</a:t>
+              <a:t>Fuente: 1e73482e-Data_NCR03082026.xlsx — hoja «Observaciones» · Corte 03-08-2026 · 438 registros desde 10-02-2023</a:t>
             </a:r>
             <a:endParaRPr lang="en-US" sz="850" dirty="0"/>
           </a:p>
@@ -28885,7 +27723,7 @@
                 <a:ea typeface="Calibri" pitchFamily="34" charset="-122"/>
                 <a:cs typeface="Calibri" pitchFamily="34" charset="-120"/>
               </a:rPr>
-              <a:t>Global del módulo: 93,1%</a:t>
+              <a:t>Global del módulo: 95,7%</a:t>
             </a:r>
             <a:endParaRPr lang="en-US" sz="950" dirty="0"/>
           </a:p>
@@ -29483,7 +28321,7 @@
                 <a:ea typeface="Calibri" pitchFamily="34" charset="-122"/>
                 <a:cs typeface="Calibri" pitchFamily="34" charset="-120"/>
               </a:rPr>
-              <a:t>global del módulo 37,9%</a:t>
+              <a:t>global del módulo 37,8%</a:t>
             </a:r>
             <a:endParaRPr lang="en-US" sz="1000" dirty="0"/>
           </a:p>
@@ -30093,7 +28931,7 @@
                 <a:ea typeface="Calibri" pitchFamily="34" charset="-122"/>
                 <a:cs typeface="Calibri" pitchFamily="34" charset="-120"/>
               </a:rPr>
-              <a:t>Fuente: 5640140e-Data_NCR_1.xlsx — hoja «Observaciones» · Corte 27-07-2026 · 436 registros desde 10-02-2023</a:t>
+              <a:t>Fuente: 1e73482e-Data_NCR03082026.xlsx — hoja «Observaciones» · Corte 03-08-2026 · 438 registros desde 10-02-2023</a:t>
             </a:r>
             <a:endParaRPr lang="en-US" sz="850" dirty="0"/>
           </a:p>

</xml_diff>

<commit_message>
NC: el ritmo abre 5 semanas y acumula las anteriores
Ocho filas ocupaban media pantalla sin aportar lectura. La ventana sigue
siendo de 8 semanas, pero solo las 5 más recientes van una a una: las 3
anteriores se suman en «5 semanas o más». Dos filas menos.

Esa fila no es una semana y no puede leerse como tal: va en cursiva, con
línea punteada al costado, con «· 3 semanas» en su rótulo y el aviso en
el título de la sección. En la PPT la barra se rotula «3 sem.» y el
título del gráfico lo declara.

Las constantes son SEM_VENTANA y SEM_DETALLE en no_conformidades.py;
panel y PPT se adaptan solos al cambiarlas.

Co-Authored-By: Claude Opus 5 <noreply@anthropic.com>
Claude-Session: https://claude.ai/code/session_011SHyPcub1TtjA2kTAsaPFu
</commit_message>
<xml_diff>
--- a/modulo_nc/Panel_No_Conformidades.pptx
+++ b/modulo_nc/Panel_No_Conformidades.pptx
@@ -148,7 +148,7 @@
                 </a:solidFill>
                 <a:latin typeface="Calibri"/>
               </a:rPr>
-              <a:t>Hallazgos levantados en cada una de las últimas 8 semanas</a:t>
+              <a:t>Ritmo semanal — la barra «3 sem.» acumula las semanas más viejas</a:t>
             </a:r>
           </a:p>
         </c:rich>
@@ -211,32 +211,26 @@
           </c:dLbls>
           <c:cat>
             <c:multiLvlStrRef>
-              <c:f>Sheet1!$A$2:$A$9</c:f>
+              <c:f>Sheet1!$A$2:$A$7</c:f>
               <c:multiLvlStrCache>
-                <c:ptCount val="8"/>
+                <c:ptCount val="6"/>
                 <c:lvl>
                   <c:pt idx="0">
-                    <c:v>09-06</c:v>
+                    <c:v>3 sem.</c:v>
                   </c:pt>
                   <c:pt idx="1">
-                    <c:v>16-06</c:v>
+                    <c:v>30-06</c:v>
                   </c:pt>
                   <c:pt idx="2">
-                    <c:v>23-06</c:v>
+                    <c:v>07-07</c:v>
                   </c:pt>
                   <c:pt idx="3">
-                    <c:v>30-06</c:v>
+                    <c:v>14-07</c:v>
                   </c:pt>
                   <c:pt idx="4">
-                    <c:v>07-07</c:v>
+                    <c:v>21-07</c:v>
                   </c:pt>
                   <c:pt idx="5">
-                    <c:v>14-07</c:v>
-                  </c:pt>
-                  <c:pt idx="6">
-                    <c:v>21-07</c:v>
-                  </c:pt>
-                  <c:pt idx="7">
                     <c:v>28-07</c:v>
                   </c:pt>
                 </c:lvl>
@@ -245,32 +239,26 @@
           </c:cat>
           <c:val>
             <c:numRef>
-              <c:f>Sheet1!$B$2:$B$9</c:f>
+              <c:f>Sheet1!$B$2:$B$7</c:f>
               <c:numCache>
                 <c:formatCode>General</c:formatCode>
-                <c:ptCount val="8"/>
+                <c:ptCount val="6"/>
                 <c:pt idx="0">
                   <c:v>3</c:v>
                 </c:pt>
                 <c:pt idx="1">
+                  <c:v>2</c:v>
+                </c:pt>
+                <c:pt idx="2">
+                  <c:v>1</c:v>
+                </c:pt>
+                <c:pt idx="3">
                   <c:v/>
                 </c:pt>
-                <c:pt idx="2">
-                  <c:v/>
-                </c:pt>
-                <c:pt idx="3">
-                  <c:v>2</c:v>
-                </c:pt>
                 <c:pt idx="4">
-                  <c:v>1</c:v>
+                  <c:v>4</c:v>
                 </c:pt>
                 <c:pt idx="5">
-                  <c:v/>
-                </c:pt>
-                <c:pt idx="6">
-                  <c:v>4</c:v>
-                </c:pt>
-                <c:pt idx="7">
                   <c:v>1</c:v>
                 </c:pt>
               </c:numCache>
@@ -325,32 +313,26 @@
           </c:dLbls>
           <c:cat>
             <c:multiLvlStrRef>
-              <c:f>Sheet1!$A$2:$A$9</c:f>
+              <c:f>Sheet1!$A$2:$A$7</c:f>
               <c:multiLvlStrCache>
-                <c:ptCount val="8"/>
+                <c:ptCount val="6"/>
                 <c:lvl>
                   <c:pt idx="0">
-                    <c:v>09-06</c:v>
+                    <c:v>3 sem.</c:v>
                   </c:pt>
                   <c:pt idx="1">
-                    <c:v>16-06</c:v>
+                    <c:v>30-06</c:v>
                   </c:pt>
                   <c:pt idx="2">
-                    <c:v>23-06</c:v>
+                    <c:v>07-07</c:v>
                   </c:pt>
                   <c:pt idx="3">
-                    <c:v>30-06</c:v>
+                    <c:v>14-07</c:v>
                   </c:pt>
                   <c:pt idx="4">
-                    <c:v>07-07</c:v>
+                    <c:v>21-07</c:v>
                   </c:pt>
                   <c:pt idx="5">
-                    <c:v>14-07</c:v>
-                  </c:pt>
-                  <c:pt idx="6">
-                    <c:v>21-07</c:v>
-                  </c:pt>
-                  <c:pt idx="7">
                     <c:v>28-07</c:v>
                   </c:pt>
                 </c:lvl>
@@ -359,32 +341,26 @@
           </c:cat>
           <c:val>
             <c:numRef>
-              <c:f>Sheet1!$C$2:$C$9</c:f>
+              <c:f>Sheet1!$C$2:$C$7</c:f>
               <c:numCache>
                 <c:formatCode>General</c:formatCode>
-                <c:ptCount val="8"/>
+                <c:ptCount val="6"/>
                 <c:pt idx="0">
+                  <c:v>4</c:v>
+                </c:pt>
+                <c:pt idx="1">
                   <c:v>2</c:v>
                 </c:pt>
-                <c:pt idx="1">
+                <c:pt idx="2">
                   <c:v/>
                 </c:pt>
-                <c:pt idx="2">
-                  <c:v>2</c:v>
-                </c:pt>
                 <c:pt idx="3">
-                  <c:v>2</c:v>
+                  <c:v/>
                 </c:pt>
                 <c:pt idx="4">
-                  <c:v/>
+                  <c:v>1</c:v>
                 </c:pt>
                 <c:pt idx="5">
-                  <c:v/>
-                </c:pt>
-                <c:pt idx="6">
-                  <c:v>1</c:v>
-                </c:pt>
-                <c:pt idx="7">
                   <c:v/>
                 </c:pt>
               </c:numCache>

</xml_diff>

<commit_message>
NC: agregar «Estado de cada vía» bajo el gráfico de origen
El gráfico decía por dónde entra el hallazgo, pero no qué pasó después.
La tabla abre cada vía en levantadas · cerradas · % cierre · abiertas ·
atrasadas · más de 180 días · antigüedad mediana, con su chip de color.

La columna «Atrasadas» dice n/c, no 0: con este archivo el atraso no es
calculable —ninguna abierta trae fecha comprometida— y un 0 se leería
como que no hay atraso. La severidad de lo abierto la dan las dos
columnas siguientes. Si el Excel algún día trae la fecha, la columna
muestra el número real sin tocar nada (depende de atrasoCalculable).

La PPT lleva la misma tabla en su lámina de origen; el helper tabla()
acepta ahora un ancho para no rayar sobre el gráfico vecino.

Co-Authored-By: Claude Opus 5 <noreply@anthropic.com>
Claude-Session: https://claude.ai/code/session_011SHyPcub1TtjA2kTAsaPFu
</commit_message>
<xml_diff>
--- a/modulo_nc/Panel_No_Conformidades.pptx
+++ b/modulo_nc/Panel_No_Conformidades.pptx
@@ -26377,7 +26377,7 @@
         </p:nvGraphicFramePr>
         <p:xfrm>
           <a:off x="457200" y="1828800"/>
-          <a:ext cx="6035040" cy="4023360"/>
+          <a:ext cx="6035040" cy="2240280"/>
         </p:xfrm>
         <a:graphic xmlns:a="http://schemas.openxmlformats.org/drawingml/2006/main">
           <a:graphicData uri="http://schemas.openxmlformats.org/drawingml/2006/chart">
@@ -26385,9 +26385,1396 @@
           </a:graphicData>
         </a:graphic>
       </p:graphicFrame>
+      <p:sp>
+        <p:nvSpPr>
+          <p:cNvPr id="7" name="Text 3"/>
+          <p:cNvSpPr/>
+          <p:nvPr/>
+        </p:nvSpPr>
+        <p:spPr>
+          <a:xfrm>
+            <a:off x="502920" y="4160520"/>
+            <a:ext cx="5486400" cy="274320"/>
+          </a:xfrm>
+          <a:prstGeom prst="rect">
+            <a:avLst/>
+          </a:prstGeom>
+          <a:noFill/>
+          <a:ln/>
+        </p:spPr>
+        <p:txBody>
+          <a:bodyPr wrap="square" lIns="0" tIns="0" rIns="0" bIns="0" rtlCol="0" anchor="ctr"/>
+          <a:lstStyle/>
+          <a:p>
+            <a:pPr indent="0" marL="0">
+              <a:buNone/>
+            </a:pPr>
+            <a:r>
+              <a:rPr lang="en-US" sz="1100" b="1" spc="150" kern="0" dirty="0">
+                <a:solidFill>
+                  <a:srgbClr val="C87A32"/>
+                </a:solidFill>
+                <a:latin typeface="Calibri" pitchFamily="34" charset="0"/>
+                <a:ea typeface="Calibri" pitchFamily="34" charset="-122"/>
+                <a:cs typeface="Calibri" pitchFamily="34" charset="-120"/>
+              </a:rPr>
+              <a:t>ESTADO DE CADA VÍA</a:t>
+            </a:r>
+            <a:endParaRPr lang="en-US" sz="1100" dirty="0"/>
+          </a:p>
+        </p:txBody>
+      </p:sp>
+      <p:sp>
+        <p:nvSpPr>
+          <p:cNvPr id="8" name="Text 4"/>
+          <p:cNvSpPr/>
+          <p:nvPr/>
+        </p:nvSpPr>
+        <p:spPr>
+          <a:xfrm>
+            <a:off x="502920" y="4462272"/>
+            <a:ext cx="1783080" cy="274320"/>
+          </a:xfrm>
+          <a:prstGeom prst="rect">
+            <a:avLst/>
+          </a:prstGeom>
+          <a:noFill/>
+          <a:ln/>
+        </p:spPr>
+        <p:txBody>
+          <a:bodyPr wrap="square" lIns="0" tIns="0" rIns="0" bIns="0" rtlCol="0" anchor="ctr"/>
+          <a:lstStyle/>
+          <a:p>
+            <a:pPr algn="l" indent="0" marL="0">
+              <a:buNone/>
+            </a:pPr>
+            <a:r>
+              <a:rPr lang="en-US" sz="950" b="1" spc="50" kern="0" dirty="0">
+                <a:solidFill>
+                  <a:srgbClr val="56606E"/>
+                </a:solidFill>
+                <a:latin typeface="Calibri" pitchFamily="34" charset="0"/>
+                <a:ea typeface="Calibri" pitchFamily="34" charset="-122"/>
+                <a:cs typeface="Calibri" pitchFamily="34" charset="-120"/>
+              </a:rPr>
+              <a:t>VÍA DE EMISIÓN</a:t>
+            </a:r>
+            <a:endParaRPr lang="en-US" sz="950" dirty="0"/>
+          </a:p>
+        </p:txBody>
+      </p:sp>
+      <p:sp>
+        <p:nvSpPr>
+          <p:cNvPr id="9" name="Text 5"/>
+          <p:cNvSpPr/>
+          <p:nvPr/>
+        </p:nvSpPr>
+        <p:spPr>
+          <a:xfrm>
+            <a:off x="2377440" y="4462272"/>
+            <a:ext cx="960120" cy="274320"/>
+          </a:xfrm>
+          <a:prstGeom prst="rect">
+            <a:avLst/>
+          </a:prstGeom>
+          <a:noFill/>
+          <a:ln/>
+        </p:spPr>
+        <p:txBody>
+          <a:bodyPr wrap="square" lIns="0" tIns="0" rIns="0" bIns="0" rtlCol="0" anchor="ctr"/>
+          <a:lstStyle/>
+          <a:p>
+            <a:pPr algn="r" indent="0" marL="0">
+              <a:buNone/>
+            </a:pPr>
+            <a:r>
+              <a:rPr lang="en-US" sz="950" b="1" spc="50" kern="0" dirty="0">
+                <a:solidFill>
+                  <a:srgbClr val="56606E"/>
+                </a:solidFill>
+                <a:latin typeface="Calibri" pitchFamily="34" charset="0"/>
+                <a:ea typeface="Calibri" pitchFamily="34" charset="-122"/>
+                <a:cs typeface="Calibri" pitchFamily="34" charset="-120"/>
+              </a:rPr>
+              <a:t>LEVANTADAS</a:t>
+            </a:r>
+            <a:endParaRPr lang="en-US" sz="950" dirty="0"/>
+          </a:p>
+        </p:txBody>
+      </p:sp>
+      <p:sp>
+        <p:nvSpPr>
+          <p:cNvPr id="10" name="Text 6"/>
+          <p:cNvSpPr/>
+          <p:nvPr/>
+        </p:nvSpPr>
+        <p:spPr>
+          <a:xfrm>
+            <a:off x="3429000" y="4462272"/>
+            <a:ext cx="914400" cy="274320"/>
+          </a:xfrm>
+          <a:prstGeom prst="rect">
+            <a:avLst/>
+          </a:prstGeom>
+          <a:noFill/>
+          <a:ln/>
+        </p:spPr>
+        <p:txBody>
+          <a:bodyPr wrap="square" lIns="0" tIns="0" rIns="0" bIns="0" rtlCol="0" anchor="ctr"/>
+          <a:lstStyle/>
+          <a:p>
+            <a:pPr algn="r" indent="0" marL="0">
+              <a:buNone/>
+            </a:pPr>
+            <a:r>
+              <a:rPr lang="en-US" sz="950" b="1" spc="50" kern="0" dirty="0">
+                <a:solidFill>
+                  <a:srgbClr val="56606E"/>
+                </a:solidFill>
+                <a:latin typeface="Calibri" pitchFamily="34" charset="0"/>
+                <a:ea typeface="Calibri" pitchFamily="34" charset="-122"/>
+                <a:cs typeface="Calibri" pitchFamily="34" charset="-120"/>
+              </a:rPr>
+              <a:t>CERRADAS</a:t>
+            </a:r>
+            <a:endParaRPr lang="en-US" sz="950" dirty="0"/>
+          </a:p>
+        </p:txBody>
+      </p:sp>
+      <p:sp>
+        <p:nvSpPr>
+          <p:cNvPr id="11" name="Text 7"/>
+          <p:cNvSpPr/>
+          <p:nvPr/>
+        </p:nvSpPr>
+        <p:spPr>
+          <a:xfrm>
+            <a:off x="4434840" y="4462272"/>
+            <a:ext cx="868680" cy="274320"/>
+          </a:xfrm>
+          <a:prstGeom prst="rect">
+            <a:avLst/>
+          </a:prstGeom>
+          <a:noFill/>
+          <a:ln/>
+        </p:spPr>
+        <p:txBody>
+          <a:bodyPr wrap="square" lIns="0" tIns="0" rIns="0" bIns="0" rtlCol="0" anchor="ctr"/>
+          <a:lstStyle/>
+          <a:p>
+            <a:pPr algn="r" indent="0" marL="0">
+              <a:buNone/>
+            </a:pPr>
+            <a:r>
+              <a:rPr lang="en-US" sz="950" b="1" spc="50" kern="0" dirty="0">
+                <a:solidFill>
+                  <a:srgbClr val="56606E"/>
+                </a:solidFill>
+                <a:latin typeface="Calibri" pitchFamily="34" charset="0"/>
+                <a:ea typeface="Calibri" pitchFamily="34" charset="-122"/>
+                <a:cs typeface="Calibri" pitchFamily="34" charset="-120"/>
+              </a:rPr>
+              <a:t>ABIERTAS</a:t>
+            </a:r>
+            <a:endParaRPr lang="en-US" sz="950" dirty="0"/>
+          </a:p>
+        </p:txBody>
+      </p:sp>
+      <p:sp>
+        <p:nvSpPr>
+          <p:cNvPr id="12" name="Text 8"/>
+          <p:cNvSpPr/>
+          <p:nvPr/>
+        </p:nvSpPr>
+        <p:spPr>
+          <a:xfrm>
+            <a:off x="5394960" y="4462272"/>
+            <a:ext cx="1051560" cy="274320"/>
+          </a:xfrm>
+          <a:prstGeom prst="rect">
+            <a:avLst/>
+          </a:prstGeom>
+          <a:noFill/>
+          <a:ln/>
+        </p:spPr>
+        <p:txBody>
+          <a:bodyPr wrap="square" lIns="0" tIns="0" rIns="0" bIns="0" rtlCol="0" anchor="ctr"/>
+          <a:lstStyle/>
+          <a:p>
+            <a:pPr algn="r" indent="0" marL="0">
+              <a:buNone/>
+            </a:pPr>
+            <a:r>
+              <a:rPr lang="en-US" sz="950" b="1" spc="50" kern="0" dirty="0">
+                <a:solidFill>
+                  <a:srgbClr val="56606E"/>
+                </a:solidFill>
+                <a:latin typeface="Calibri" pitchFamily="34" charset="0"/>
+                <a:ea typeface="Calibri" pitchFamily="34" charset="-122"/>
+                <a:cs typeface="Calibri" pitchFamily="34" charset="-120"/>
+              </a:rPr>
+              <a:t>ANTIG. MEDIANA</a:t>
+            </a:r>
+            <a:endParaRPr lang="en-US" sz="950" dirty="0"/>
+          </a:p>
+        </p:txBody>
+      </p:sp>
+      <p:sp>
+        <p:nvSpPr>
+          <p:cNvPr id="13" name="Shape 9"/>
+          <p:cNvSpPr/>
+          <p:nvPr/>
+        </p:nvSpPr>
+        <p:spPr>
+          <a:xfrm>
+            <a:off x="502920" y="4773168"/>
+            <a:ext cx="5943600" cy="0"/>
+          </a:xfrm>
+          <a:prstGeom prst="line">
+            <a:avLst/>
+          </a:prstGeom>
+          <a:noFill/>
+          <a:ln w="12700">
+            <a:solidFill>
+              <a:srgbClr val="6E8CA8"/>
+            </a:solidFill>
+            <a:prstDash val="solid"/>
+          </a:ln>
+        </p:spPr>
+      </p:sp>
+      <p:sp>
+        <p:nvSpPr>
+          <p:cNvPr id="14" name="Text 10"/>
+          <p:cNvSpPr/>
+          <p:nvPr/>
+        </p:nvSpPr>
+        <p:spPr>
+          <a:xfrm>
+            <a:off x="502920" y="4901184"/>
+            <a:ext cx="1783080" cy="192024"/>
+          </a:xfrm>
+          <a:prstGeom prst="rect">
+            <a:avLst/>
+          </a:prstGeom>
+          <a:noFill/>
+          <a:ln/>
+        </p:spPr>
+        <p:txBody>
+          <a:bodyPr wrap="square" lIns="0" tIns="0" rIns="0" bIns="0" rtlCol="0" anchor="ctr"/>
+          <a:lstStyle/>
+          <a:p>
+            <a:pPr algn="l" indent="0" marL="0">
+              <a:buNone/>
+            </a:pPr>
+            <a:r>
+              <a:rPr lang="en-US" sz="1100" dirty="0">
+                <a:solidFill>
+                  <a:srgbClr val="2E6FB5"/>
+                </a:solidFill>
+                <a:latin typeface="Calibri" pitchFamily="34" charset="0"/>
+                <a:ea typeface="Calibri" pitchFamily="34" charset="-122"/>
+                <a:cs typeface="Calibri" pitchFamily="34" charset="-120"/>
+              </a:rPr>
+              <a:t>Interna (Besalco)</a:t>
+            </a:r>
+            <a:endParaRPr lang="en-US" sz="1100" dirty="0"/>
+          </a:p>
+        </p:txBody>
+      </p:sp>
+      <p:sp>
+        <p:nvSpPr>
+          <p:cNvPr id="15" name="Text 11"/>
+          <p:cNvSpPr/>
+          <p:nvPr/>
+        </p:nvSpPr>
+        <p:spPr>
+          <a:xfrm>
+            <a:off x="2377440" y="4901184"/>
+            <a:ext cx="960120" cy="192024"/>
+          </a:xfrm>
+          <a:prstGeom prst="rect">
+            <a:avLst/>
+          </a:prstGeom>
+          <a:noFill/>
+          <a:ln/>
+        </p:spPr>
+        <p:txBody>
+          <a:bodyPr wrap="square" lIns="0" tIns="0" rIns="0" bIns="0" rtlCol="0" anchor="ctr"/>
+          <a:lstStyle/>
+          <a:p>
+            <a:pPr algn="r" indent="0" marL="0">
+              <a:buNone/>
+            </a:pPr>
+            <a:r>
+              <a:rPr lang="en-US" sz="1100" dirty="0">
+                <a:solidFill>
+                  <a:srgbClr val="1A2433"/>
+                </a:solidFill>
+                <a:latin typeface="Calibri" pitchFamily="34" charset="0"/>
+                <a:ea typeface="Calibri" pitchFamily="34" charset="-122"/>
+                <a:cs typeface="Calibri" pitchFamily="34" charset="-120"/>
+              </a:rPr>
+              <a:t>162</a:t>
+            </a:r>
+            <a:endParaRPr lang="en-US" sz="1100" dirty="0"/>
+          </a:p>
+        </p:txBody>
+      </p:sp>
+      <p:sp>
+        <p:nvSpPr>
+          <p:cNvPr id="16" name="Text 12"/>
+          <p:cNvSpPr/>
+          <p:nvPr/>
+        </p:nvSpPr>
+        <p:spPr>
+          <a:xfrm>
+            <a:off x="3429000" y="4901184"/>
+            <a:ext cx="914400" cy="192024"/>
+          </a:xfrm>
+          <a:prstGeom prst="rect">
+            <a:avLst/>
+          </a:prstGeom>
+          <a:noFill/>
+          <a:ln/>
+        </p:spPr>
+        <p:txBody>
+          <a:bodyPr wrap="square" lIns="0" tIns="0" rIns="0" bIns="0" rtlCol="0" anchor="ctr"/>
+          <a:lstStyle/>
+          <a:p>
+            <a:pPr algn="r" indent="0" marL="0">
+              <a:buNone/>
+            </a:pPr>
+            <a:r>
+              <a:rPr lang="en-US" sz="1100" dirty="0">
+                <a:solidFill>
+                  <a:srgbClr val="1A2433"/>
+                </a:solidFill>
+                <a:latin typeface="Calibri" pitchFamily="34" charset="0"/>
+                <a:ea typeface="Calibri" pitchFamily="34" charset="-122"/>
+                <a:cs typeface="Calibri" pitchFamily="34" charset="-120"/>
+              </a:rPr>
+              <a:t>157</a:t>
+            </a:r>
+            <a:endParaRPr lang="en-US" sz="1100" dirty="0"/>
+          </a:p>
+        </p:txBody>
+      </p:sp>
+      <p:sp>
+        <p:nvSpPr>
+          <p:cNvPr id="17" name="Text 13"/>
+          <p:cNvSpPr/>
+          <p:nvPr/>
+        </p:nvSpPr>
+        <p:spPr>
+          <a:xfrm>
+            <a:off x="4434840" y="4901184"/>
+            <a:ext cx="868680" cy="192024"/>
+          </a:xfrm>
+          <a:prstGeom prst="rect">
+            <a:avLst/>
+          </a:prstGeom>
+          <a:noFill/>
+          <a:ln/>
+        </p:spPr>
+        <p:txBody>
+          <a:bodyPr wrap="square" lIns="0" tIns="0" rIns="0" bIns="0" rtlCol="0" anchor="ctr"/>
+          <a:lstStyle/>
+          <a:p>
+            <a:pPr algn="r" indent="0" marL="0">
+              <a:buNone/>
+            </a:pPr>
+            <a:r>
+              <a:rPr lang="en-US" sz="1100" dirty="0">
+                <a:solidFill>
+                  <a:srgbClr val="C0392B"/>
+                </a:solidFill>
+                <a:latin typeface="Calibri" pitchFamily="34" charset="0"/>
+                <a:ea typeface="Calibri" pitchFamily="34" charset="-122"/>
+                <a:cs typeface="Calibri" pitchFamily="34" charset="-120"/>
+              </a:rPr>
+              <a:t>5</a:t>
+            </a:r>
+            <a:endParaRPr lang="en-US" sz="1100" dirty="0"/>
+          </a:p>
+        </p:txBody>
+      </p:sp>
+      <p:sp>
+        <p:nvSpPr>
+          <p:cNvPr id="18" name="Text 14"/>
+          <p:cNvSpPr/>
+          <p:nvPr/>
+        </p:nvSpPr>
+        <p:spPr>
+          <a:xfrm>
+            <a:off x="5394960" y="4901184"/>
+            <a:ext cx="1051560" cy="192024"/>
+          </a:xfrm>
+          <a:prstGeom prst="rect">
+            <a:avLst/>
+          </a:prstGeom>
+          <a:noFill/>
+          <a:ln/>
+        </p:spPr>
+        <p:txBody>
+          <a:bodyPr wrap="square" lIns="0" tIns="0" rIns="0" bIns="0" rtlCol="0" anchor="ctr"/>
+          <a:lstStyle/>
+          <a:p>
+            <a:pPr algn="r" indent="0" marL="0">
+              <a:buNone/>
+            </a:pPr>
+            <a:r>
+              <a:rPr lang="en-US" sz="1100" dirty="0">
+                <a:solidFill>
+                  <a:srgbClr val="1A2433"/>
+                </a:solidFill>
+                <a:latin typeface="Calibri" pitchFamily="34" charset="0"/>
+                <a:ea typeface="Calibri" pitchFamily="34" charset="-122"/>
+                <a:cs typeface="Calibri" pitchFamily="34" charset="-120"/>
+              </a:rPr>
+              <a:t>224 d</a:t>
+            </a:r>
+            <a:endParaRPr lang="en-US" sz="1100" dirty="0"/>
+          </a:p>
+        </p:txBody>
+      </p:sp>
+      <p:sp>
+        <p:nvSpPr>
+          <p:cNvPr id="19" name="Shape 15"/>
+          <p:cNvSpPr/>
+          <p:nvPr/>
+        </p:nvSpPr>
+        <p:spPr>
+          <a:xfrm>
+            <a:off x="502920" y="5129784"/>
+            <a:ext cx="5943600" cy="0"/>
+          </a:xfrm>
+          <a:prstGeom prst="line">
+            <a:avLst/>
+          </a:prstGeom>
+          <a:noFill/>
+          <a:ln w="9525">
+            <a:solidFill>
+              <a:srgbClr val="D9DFE6"/>
+            </a:solidFill>
+            <a:prstDash val="solid"/>
+          </a:ln>
+        </p:spPr>
+      </p:sp>
+      <p:sp>
+        <p:nvSpPr>
+          <p:cNvPr id="20" name="Shape 16"/>
+          <p:cNvSpPr/>
+          <p:nvPr/>
+        </p:nvSpPr>
+        <p:spPr>
+          <a:xfrm>
+            <a:off x="457200" y="5138928"/>
+            <a:ext cx="5989320" cy="283464"/>
+          </a:xfrm>
+          <a:prstGeom prst="rect">
+            <a:avLst/>
+          </a:prstGeom>
+          <a:solidFill>
+            <a:srgbClr val="FFFFFF"/>
+          </a:solidFill>
+          <a:ln/>
+        </p:spPr>
+      </p:sp>
+      <p:sp>
+        <p:nvSpPr>
+          <p:cNvPr id="21" name="Text 17"/>
+          <p:cNvSpPr/>
+          <p:nvPr/>
+        </p:nvSpPr>
+        <p:spPr>
+          <a:xfrm>
+            <a:off x="502920" y="5184648"/>
+            <a:ext cx="1783080" cy="192024"/>
+          </a:xfrm>
+          <a:prstGeom prst="rect">
+            <a:avLst/>
+          </a:prstGeom>
+          <a:noFill/>
+          <a:ln/>
+        </p:spPr>
+        <p:txBody>
+          <a:bodyPr wrap="square" lIns="0" tIns="0" rIns="0" bIns="0" rtlCol="0" anchor="ctr"/>
+          <a:lstStyle/>
+          <a:p>
+            <a:pPr algn="l" indent="0" marL="0">
+              <a:buNone/>
+            </a:pPr>
+            <a:r>
+              <a:rPr lang="en-US" sz="1100" dirty="0">
+                <a:solidFill>
+                  <a:srgbClr val="9A6B0F"/>
+                </a:solidFill>
+                <a:latin typeface="Calibri" pitchFamily="34" charset="0"/>
+                <a:ea typeface="Calibri" pitchFamily="34" charset="-122"/>
+                <a:cs typeface="Calibri" pitchFamily="34" charset="-120"/>
+              </a:rPr>
+              <a:t>Externa · Cliente</a:t>
+            </a:r>
+            <a:endParaRPr lang="en-US" sz="1100" dirty="0"/>
+          </a:p>
+        </p:txBody>
+      </p:sp>
+      <p:sp>
+        <p:nvSpPr>
+          <p:cNvPr id="22" name="Text 18"/>
+          <p:cNvSpPr/>
+          <p:nvPr/>
+        </p:nvSpPr>
+        <p:spPr>
+          <a:xfrm>
+            <a:off x="2377440" y="5184648"/>
+            <a:ext cx="960120" cy="192024"/>
+          </a:xfrm>
+          <a:prstGeom prst="rect">
+            <a:avLst/>
+          </a:prstGeom>
+          <a:noFill/>
+          <a:ln/>
+        </p:spPr>
+        <p:txBody>
+          <a:bodyPr wrap="square" lIns="0" tIns="0" rIns="0" bIns="0" rtlCol="0" anchor="ctr"/>
+          <a:lstStyle/>
+          <a:p>
+            <a:pPr algn="r" indent="0" marL="0">
+              <a:buNone/>
+            </a:pPr>
+            <a:r>
+              <a:rPr lang="en-US" sz="1100" dirty="0">
+                <a:solidFill>
+                  <a:srgbClr val="1A2433"/>
+                </a:solidFill>
+                <a:latin typeface="Calibri" pitchFamily="34" charset="0"/>
+                <a:ea typeface="Calibri" pitchFamily="34" charset="-122"/>
+                <a:cs typeface="Calibri" pitchFamily="34" charset="-120"/>
+              </a:rPr>
+              <a:t>289</a:t>
+            </a:r>
+            <a:endParaRPr lang="en-US" sz="1100" dirty="0"/>
+          </a:p>
+        </p:txBody>
+      </p:sp>
+      <p:sp>
+        <p:nvSpPr>
+          <p:cNvPr id="23" name="Text 19"/>
+          <p:cNvSpPr/>
+          <p:nvPr/>
+        </p:nvSpPr>
+        <p:spPr>
+          <a:xfrm>
+            <a:off x="3429000" y="5184648"/>
+            <a:ext cx="914400" cy="192024"/>
+          </a:xfrm>
+          <a:prstGeom prst="rect">
+            <a:avLst/>
+          </a:prstGeom>
+          <a:noFill/>
+          <a:ln/>
+        </p:spPr>
+        <p:txBody>
+          <a:bodyPr wrap="square" lIns="0" tIns="0" rIns="0" bIns="0" rtlCol="0" anchor="ctr"/>
+          <a:lstStyle/>
+          <a:p>
+            <a:pPr algn="r" indent="0" marL="0">
+              <a:buNone/>
+            </a:pPr>
+            <a:r>
+              <a:rPr lang="en-US" sz="1100" dirty="0">
+                <a:solidFill>
+                  <a:srgbClr val="1A2433"/>
+                </a:solidFill>
+                <a:latin typeface="Calibri" pitchFamily="34" charset="0"/>
+                <a:ea typeface="Calibri" pitchFamily="34" charset="-122"/>
+                <a:cs typeface="Calibri" pitchFamily="34" charset="-120"/>
+              </a:rPr>
+              <a:t>240</a:t>
+            </a:r>
+            <a:endParaRPr lang="en-US" sz="1100" dirty="0"/>
+          </a:p>
+        </p:txBody>
+      </p:sp>
+      <p:sp>
+        <p:nvSpPr>
+          <p:cNvPr id="24" name="Text 20"/>
+          <p:cNvSpPr/>
+          <p:nvPr/>
+        </p:nvSpPr>
+        <p:spPr>
+          <a:xfrm>
+            <a:off x="4434840" y="5184648"/>
+            <a:ext cx="868680" cy="192024"/>
+          </a:xfrm>
+          <a:prstGeom prst="rect">
+            <a:avLst/>
+          </a:prstGeom>
+          <a:noFill/>
+          <a:ln/>
+        </p:spPr>
+        <p:txBody>
+          <a:bodyPr wrap="square" lIns="0" tIns="0" rIns="0" bIns="0" rtlCol="0" anchor="ctr"/>
+          <a:lstStyle/>
+          <a:p>
+            <a:pPr algn="r" indent="0" marL="0">
+              <a:buNone/>
+            </a:pPr>
+            <a:r>
+              <a:rPr lang="en-US" sz="1100" dirty="0">
+                <a:solidFill>
+                  <a:srgbClr val="C0392B"/>
+                </a:solidFill>
+                <a:latin typeface="Calibri" pitchFamily="34" charset="0"/>
+                <a:ea typeface="Calibri" pitchFamily="34" charset="-122"/>
+                <a:cs typeface="Calibri" pitchFamily="34" charset="-120"/>
+              </a:rPr>
+              <a:t>49</a:t>
+            </a:r>
+            <a:endParaRPr lang="en-US" sz="1100" dirty="0"/>
+          </a:p>
+        </p:txBody>
+      </p:sp>
+      <p:sp>
+        <p:nvSpPr>
+          <p:cNvPr id="25" name="Text 21"/>
+          <p:cNvSpPr/>
+          <p:nvPr/>
+        </p:nvSpPr>
+        <p:spPr>
+          <a:xfrm>
+            <a:off x="5394960" y="5184648"/>
+            <a:ext cx="1051560" cy="192024"/>
+          </a:xfrm>
+          <a:prstGeom prst="rect">
+            <a:avLst/>
+          </a:prstGeom>
+          <a:noFill/>
+          <a:ln/>
+        </p:spPr>
+        <p:txBody>
+          <a:bodyPr wrap="square" lIns="0" tIns="0" rIns="0" bIns="0" rtlCol="0" anchor="ctr"/>
+          <a:lstStyle/>
+          <a:p>
+            <a:pPr algn="r" indent="0" marL="0">
+              <a:buNone/>
+            </a:pPr>
+            <a:r>
+              <a:rPr lang="en-US" sz="1100" dirty="0">
+                <a:solidFill>
+                  <a:srgbClr val="1A2433"/>
+                </a:solidFill>
+                <a:latin typeface="Calibri" pitchFamily="34" charset="0"/>
+                <a:ea typeface="Calibri" pitchFamily="34" charset="-122"/>
+                <a:cs typeface="Calibri" pitchFamily="34" charset="-120"/>
+              </a:rPr>
+              <a:t>133 d</a:t>
+            </a:r>
+            <a:endParaRPr lang="en-US" sz="1100" dirty="0"/>
+          </a:p>
+        </p:txBody>
+      </p:sp>
+      <p:sp>
+        <p:nvSpPr>
+          <p:cNvPr id="26" name="Shape 22"/>
+          <p:cNvSpPr/>
+          <p:nvPr/>
+        </p:nvSpPr>
+        <p:spPr>
+          <a:xfrm>
+            <a:off x="502920" y="5413248"/>
+            <a:ext cx="5943600" cy="0"/>
+          </a:xfrm>
+          <a:prstGeom prst="line">
+            <a:avLst/>
+          </a:prstGeom>
+          <a:noFill/>
+          <a:ln w="9525">
+            <a:solidFill>
+              <a:srgbClr val="D9DFE6"/>
+            </a:solidFill>
+            <a:prstDash val="solid"/>
+          </a:ln>
+        </p:spPr>
+      </p:sp>
+      <p:sp>
+        <p:nvSpPr>
+          <p:cNvPr id="27" name="Text 23"/>
+          <p:cNvSpPr/>
+          <p:nvPr/>
+        </p:nvSpPr>
+        <p:spPr>
+          <a:xfrm>
+            <a:off x="502920" y="5468112"/>
+            <a:ext cx="1783080" cy="192024"/>
+          </a:xfrm>
+          <a:prstGeom prst="rect">
+            <a:avLst/>
+          </a:prstGeom>
+          <a:noFill/>
+          <a:ln/>
+        </p:spPr>
+        <p:txBody>
+          <a:bodyPr wrap="square" lIns="0" tIns="0" rIns="0" bIns="0" rtlCol="0" anchor="ctr"/>
+          <a:lstStyle/>
+          <a:p>
+            <a:pPr algn="l" indent="0" marL="0">
+              <a:buNone/>
+            </a:pPr>
+            <a:r>
+              <a:rPr lang="en-US" sz="1100" dirty="0">
+                <a:solidFill>
+                  <a:srgbClr val="8A5520"/>
+                </a:solidFill>
+                <a:latin typeface="Calibri" pitchFamily="34" charset="0"/>
+                <a:ea typeface="Calibri" pitchFamily="34" charset="-122"/>
+                <a:cs typeface="Calibri" pitchFamily="34" charset="-120"/>
+              </a:rPr>
+              <a:t>Externa · Subcontrato</a:t>
+            </a:r>
+            <a:endParaRPr lang="en-US" sz="1100" dirty="0"/>
+          </a:p>
+        </p:txBody>
+      </p:sp>
+      <p:sp>
+        <p:nvSpPr>
+          <p:cNvPr id="28" name="Text 24"/>
+          <p:cNvSpPr/>
+          <p:nvPr/>
+        </p:nvSpPr>
+        <p:spPr>
+          <a:xfrm>
+            <a:off x="2377440" y="5468112"/>
+            <a:ext cx="960120" cy="192024"/>
+          </a:xfrm>
+          <a:prstGeom prst="rect">
+            <a:avLst/>
+          </a:prstGeom>
+          <a:noFill/>
+          <a:ln/>
+        </p:spPr>
+        <p:txBody>
+          <a:bodyPr wrap="square" lIns="0" tIns="0" rIns="0" bIns="0" rtlCol="0" anchor="ctr"/>
+          <a:lstStyle/>
+          <a:p>
+            <a:pPr algn="r" indent="0" marL="0">
+              <a:buNone/>
+            </a:pPr>
+            <a:r>
+              <a:rPr lang="en-US" sz="1100" dirty="0">
+                <a:solidFill>
+                  <a:srgbClr val="1A2433"/>
+                </a:solidFill>
+                <a:latin typeface="Calibri" pitchFamily="34" charset="0"/>
+                <a:ea typeface="Calibri" pitchFamily="34" charset="-122"/>
+                <a:cs typeface="Calibri" pitchFamily="34" charset="-120"/>
+              </a:rPr>
+              <a:t>48</a:t>
+            </a:r>
+            <a:endParaRPr lang="en-US" sz="1100" dirty="0"/>
+          </a:p>
+        </p:txBody>
+      </p:sp>
+      <p:sp>
+        <p:nvSpPr>
+          <p:cNvPr id="29" name="Text 25"/>
+          <p:cNvSpPr/>
+          <p:nvPr/>
+        </p:nvSpPr>
+        <p:spPr>
+          <a:xfrm>
+            <a:off x="3429000" y="5468112"/>
+            <a:ext cx="914400" cy="192024"/>
+          </a:xfrm>
+          <a:prstGeom prst="rect">
+            <a:avLst/>
+          </a:prstGeom>
+          <a:noFill/>
+          <a:ln/>
+        </p:spPr>
+        <p:txBody>
+          <a:bodyPr wrap="square" lIns="0" tIns="0" rIns="0" bIns="0" rtlCol="0" anchor="ctr"/>
+          <a:lstStyle/>
+          <a:p>
+            <a:pPr algn="r" indent="0" marL="0">
+              <a:buNone/>
+            </a:pPr>
+            <a:r>
+              <a:rPr lang="en-US" sz="1100" dirty="0">
+                <a:solidFill>
+                  <a:srgbClr val="1A2433"/>
+                </a:solidFill>
+                <a:latin typeface="Calibri" pitchFamily="34" charset="0"/>
+                <a:ea typeface="Calibri" pitchFamily="34" charset="-122"/>
+                <a:cs typeface="Calibri" pitchFamily="34" charset="-120"/>
+              </a:rPr>
+              <a:t>48</a:t>
+            </a:r>
+            <a:endParaRPr lang="en-US" sz="1100" dirty="0"/>
+          </a:p>
+        </p:txBody>
+      </p:sp>
+      <p:sp>
+        <p:nvSpPr>
+          <p:cNvPr id="30" name="Text 26"/>
+          <p:cNvSpPr/>
+          <p:nvPr/>
+        </p:nvSpPr>
+        <p:spPr>
+          <a:xfrm>
+            <a:off x="4434840" y="5468112"/>
+            <a:ext cx="868680" cy="192024"/>
+          </a:xfrm>
+          <a:prstGeom prst="rect">
+            <a:avLst/>
+          </a:prstGeom>
+          <a:noFill/>
+          <a:ln/>
+        </p:spPr>
+        <p:txBody>
+          <a:bodyPr wrap="square" lIns="0" tIns="0" rIns="0" bIns="0" rtlCol="0" anchor="ctr"/>
+          <a:lstStyle/>
+          <a:p>
+            <a:pPr algn="r" indent="0" marL="0">
+              <a:buNone/>
+            </a:pPr>
+            <a:r>
+              <a:rPr lang="en-US" sz="1100" dirty="0">
+                <a:solidFill>
+                  <a:srgbClr val="56606E"/>
+                </a:solidFill>
+                <a:latin typeface="Calibri" pitchFamily="34" charset="0"/>
+                <a:ea typeface="Calibri" pitchFamily="34" charset="-122"/>
+                <a:cs typeface="Calibri" pitchFamily="34" charset="-120"/>
+              </a:rPr>
+              <a:t>—</a:t>
+            </a:r>
+            <a:endParaRPr lang="en-US" sz="1100" dirty="0"/>
+          </a:p>
+        </p:txBody>
+      </p:sp>
+      <p:sp>
+        <p:nvSpPr>
+          <p:cNvPr id="31" name="Text 27"/>
+          <p:cNvSpPr/>
+          <p:nvPr/>
+        </p:nvSpPr>
+        <p:spPr>
+          <a:xfrm>
+            <a:off x="5394960" y="5468112"/>
+            <a:ext cx="1051560" cy="192024"/>
+          </a:xfrm>
+          <a:prstGeom prst="rect">
+            <a:avLst/>
+          </a:prstGeom>
+          <a:noFill/>
+          <a:ln/>
+        </p:spPr>
+        <p:txBody>
+          <a:bodyPr wrap="square" lIns="0" tIns="0" rIns="0" bIns="0" rtlCol="0" anchor="ctr"/>
+          <a:lstStyle/>
+          <a:p>
+            <a:pPr algn="r" indent="0" marL="0">
+              <a:buNone/>
+            </a:pPr>
+            <a:r>
+              <a:rPr lang="en-US" sz="1100" dirty="0">
+                <a:solidFill>
+                  <a:srgbClr val="56606E"/>
+                </a:solidFill>
+                <a:latin typeface="Calibri" pitchFamily="34" charset="0"/>
+                <a:ea typeface="Calibri" pitchFamily="34" charset="-122"/>
+                <a:cs typeface="Calibri" pitchFamily="34" charset="-120"/>
+              </a:rPr>
+              <a:t>—</a:t>
+            </a:r>
+            <a:endParaRPr lang="en-US" sz="1100" dirty="0"/>
+          </a:p>
+        </p:txBody>
+      </p:sp>
+      <p:sp>
+        <p:nvSpPr>
+          <p:cNvPr id="32" name="Shape 28"/>
+          <p:cNvSpPr/>
+          <p:nvPr/>
+        </p:nvSpPr>
+        <p:spPr>
+          <a:xfrm>
+            <a:off x="502920" y="5696712"/>
+            <a:ext cx="5943600" cy="0"/>
+          </a:xfrm>
+          <a:prstGeom prst="line">
+            <a:avLst/>
+          </a:prstGeom>
+          <a:noFill/>
+          <a:ln w="9525">
+            <a:solidFill>
+              <a:srgbClr val="D9DFE6"/>
+            </a:solidFill>
+            <a:prstDash val="solid"/>
+          </a:ln>
+        </p:spPr>
+      </p:sp>
+      <p:sp>
+        <p:nvSpPr>
+          <p:cNvPr id="33" name="Shape 29"/>
+          <p:cNvSpPr/>
+          <p:nvPr/>
+        </p:nvSpPr>
+        <p:spPr>
+          <a:xfrm>
+            <a:off x="457200" y="5705856"/>
+            <a:ext cx="5989320" cy="283464"/>
+          </a:xfrm>
+          <a:prstGeom prst="rect">
+            <a:avLst/>
+          </a:prstGeom>
+          <a:solidFill>
+            <a:srgbClr val="FFFFFF"/>
+          </a:solidFill>
+          <a:ln/>
+        </p:spPr>
+      </p:sp>
+      <p:sp>
+        <p:nvSpPr>
+          <p:cNvPr id="34" name="Text 30"/>
+          <p:cNvSpPr/>
+          <p:nvPr/>
+        </p:nvSpPr>
+        <p:spPr>
+          <a:xfrm>
+            <a:off x="502920" y="5751576"/>
+            <a:ext cx="1783080" cy="192024"/>
+          </a:xfrm>
+          <a:prstGeom prst="rect">
+            <a:avLst/>
+          </a:prstGeom>
+          <a:noFill/>
+          <a:ln/>
+        </p:spPr>
+        <p:txBody>
+          <a:bodyPr wrap="square" lIns="0" tIns="0" rIns="0" bIns="0" rtlCol="0" anchor="ctr"/>
+          <a:lstStyle/>
+          <a:p>
+            <a:pPr algn="l" indent="0" marL="0">
+              <a:buNone/>
+            </a:pPr>
+            <a:r>
+              <a:rPr lang="en-US" sz="1100" dirty="0">
+                <a:solidFill>
+                  <a:srgbClr val="5B6B7C"/>
+                </a:solidFill>
+                <a:latin typeface="Calibri" pitchFamily="34" charset="0"/>
+                <a:ea typeface="Calibri" pitchFamily="34" charset="-122"/>
+                <a:cs typeface="Calibri" pitchFamily="34" charset="-120"/>
+              </a:rPr>
+              <a:t>Sin clasificar</a:t>
+            </a:r>
+            <a:endParaRPr lang="en-US" sz="1100" dirty="0"/>
+          </a:p>
+        </p:txBody>
+      </p:sp>
+      <p:sp>
+        <p:nvSpPr>
+          <p:cNvPr id="35" name="Text 31"/>
+          <p:cNvSpPr/>
+          <p:nvPr/>
+        </p:nvSpPr>
+        <p:spPr>
+          <a:xfrm>
+            <a:off x="2377440" y="5751576"/>
+            <a:ext cx="960120" cy="192024"/>
+          </a:xfrm>
+          <a:prstGeom prst="rect">
+            <a:avLst/>
+          </a:prstGeom>
+          <a:noFill/>
+          <a:ln/>
+        </p:spPr>
+        <p:txBody>
+          <a:bodyPr wrap="square" lIns="0" tIns="0" rIns="0" bIns="0" rtlCol="0" anchor="ctr"/>
+          <a:lstStyle/>
+          <a:p>
+            <a:pPr algn="r" indent="0" marL="0">
+              <a:buNone/>
+            </a:pPr>
+            <a:r>
+              <a:rPr lang="en-US" sz="1100" dirty="0">
+                <a:solidFill>
+                  <a:srgbClr val="1A2433"/>
+                </a:solidFill>
+                <a:latin typeface="Calibri" pitchFamily="34" charset="0"/>
+                <a:ea typeface="Calibri" pitchFamily="34" charset="-122"/>
+                <a:cs typeface="Calibri" pitchFamily="34" charset="-120"/>
+              </a:rPr>
+              <a:t>9</a:t>
+            </a:r>
+            <a:endParaRPr lang="en-US" sz="1100" dirty="0"/>
+          </a:p>
+        </p:txBody>
+      </p:sp>
+      <p:sp>
+        <p:nvSpPr>
+          <p:cNvPr id="36" name="Text 32"/>
+          <p:cNvSpPr/>
+          <p:nvPr/>
+        </p:nvSpPr>
+        <p:spPr>
+          <a:xfrm>
+            <a:off x="3429000" y="5751576"/>
+            <a:ext cx="914400" cy="192024"/>
+          </a:xfrm>
+          <a:prstGeom prst="rect">
+            <a:avLst/>
+          </a:prstGeom>
+          <a:noFill/>
+          <a:ln/>
+        </p:spPr>
+        <p:txBody>
+          <a:bodyPr wrap="square" lIns="0" tIns="0" rIns="0" bIns="0" rtlCol="0" anchor="ctr"/>
+          <a:lstStyle/>
+          <a:p>
+            <a:pPr algn="r" indent="0" marL="0">
+              <a:buNone/>
+            </a:pPr>
+            <a:r>
+              <a:rPr lang="en-US" sz="1100" dirty="0">
+                <a:solidFill>
+                  <a:srgbClr val="1A2433"/>
+                </a:solidFill>
+                <a:latin typeface="Calibri" pitchFamily="34" charset="0"/>
+                <a:ea typeface="Calibri" pitchFamily="34" charset="-122"/>
+                <a:cs typeface="Calibri" pitchFamily="34" charset="-120"/>
+              </a:rPr>
+              <a:t>9</a:t>
+            </a:r>
+            <a:endParaRPr lang="en-US" sz="1100" dirty="0"/>
+          </a:p>
+        </p:txBody>
+      </p:sp>
+      <p:sp>
+        <p:nvSpPr>
+          <p:cNvPr id="37" name="Text 33"/>
+          <p:cNvSpPr/>
+          <p:nvPr/>
+        </p:nvSpPr>
+        <p:spPr>
+          <a:xfrm>
+            <a:off x="4434840" y="5751576"/>
+            <a:ext cx="868680" cy="192024"/>
+          </a:xfrm>
+          <a:prstGeom prst="rect">
+            <a:avLst/>
+          </a:prstGeom>
+          <a:noFill/>
+          <a:ln/>
+        </p:spPr>
+        <p:txBody>
+          <a:bodyPr wrap="square" lIns="0" tIns="0" rIns="0" bIns="0" rtlCol="0" anchor="ctr"/>
+          <a:lstStyle/>
+          <a:p>
+            <a:pPr algn="r" indent="0" marL="0">
+              <a:buNone/>
+            </a:pPr>
+            <a:r>
+              <a:rPr lang="en-US" sz="1100" dirty="0">
+                <a:solidFill>
+                  <a:srgbClr val="56606E"/>
+                </a:solidFill>
+                <a:latin typeface="Calibri" pitchFamily="34" charset="0"/>
+                <a:ea typeface="Calibri" pitchFamily="34" charset="-122"/>
+                <a:cs typeface="Calibri" pitchFamily="34" charset="-120"/>
+              </a:rPr>
+              <a:t>—</a:t>
+            </a:r>
+            <a:endParaRPr lang="en-US" sz="1100" dirty="0"/>
+          </a:p>
+        </p:txBody>
+      </p:sp>
+      <p:sp>
+        <p:nvSpPr>
+          <p:cNvPr id="38" name="Text 34"/>
+          <p:cNvSpPr/>
+          <p:nvPr/>
+        </p:nvSpPr>
+        <p:spPr>
+          <a:xfrm>
+            <a:off x="5394960" y="5751576"/>
+            <a:ext cx="1051560" cy="192024"/>
+          </a:xfrm>
+          <a:prstGeom prst="rect">
+            <a:avLst/>
+          </a:prstGeom>
+          <a:noFill/>
+          <a:ln/>
+        </p:spPr>
+        <p:txBody>
+          <a:bodyPr wrap="square" lIns="0" tIns="0" rIns="0" bIns="0" rtlCol="0" anchor="ctr"/>
+          <a:lstStyle/>
+          <a:p>
+            <a:pPr algn="r" indent="0" marL="0">
+              <a:buNone/>
+            </a:pPr>
+            <a:r>
+              <a:rPr lang="en-US" sz="1100" dirty="0">
+                <a:solidFill>
+                  <a:srgbClr val="56606E"/>
+                </a:solidFill>
+                <a:latin typeface="Calibri" pitchFamily="34" charset="0"/>
+                <a:ea typeface="Calibri" pitchFamily="34" charset="-122"/>
+                <a:cs typeface="Calibri" pitchFamily="34" charset="-120"/>
+              </a:rPr>
+              <a:t>—</a:t>
+            </a:r>
+            <a:endParaRPr lang="en-US" sz="1100" dirty="0"/>
+          </a:p>
+        </p:txBody>
+      </p:sp>
+      <p:sp>
+        <p:nvSpPr>
+          <p:cNvPr id="39" name="Shape 35"/>
+          <p:cNvSpPr/>
+          <p:nvPr/>
+        </p:nvSpPr>
+        <p:spPr>
+          <a:xfrm>
+            <a:off x="502920" y="5980176"/>
+            <a:ext cx="5943600" cy="0"/>
+          </a:xfrm>
+          <a:prstGeom prst="line">
+            <a:avLst/>
+          </a:prstGeom>
+          <a:noFill/>
+          <a:ln w="9525">
+            <a:solidFill>
+              <a:srgbClr val="D9DFE6"/>
+            </a:solidFill>
+            <a:prstDash val="solid"/>
+          </a:ln>
+        </p:spPr>
+      </p:sp>
+      <p:sp>
+        <p:nvSpPr>
+          <p:cNvPr id="40" name="Text 36"/>
+          <p:cNvSpPr/>
+          <p:nvPr/>
+        </p:nvSpPr>
+        <p:spPr>
+          <a:xfrm>
+            <a:off x="502920" y="6035040"/>
+            <a:ext cx="1783080" cy="192024"/>
+          </a:xfrm>
+          <a:prstGeom prst="rect">
+            <a:avLst/>
+          </a:prstGeom>
+          <a:noFill/>
+          <a:ln/>
+        </p:spPr>
+        <p:txBody>
+          <a:bodyPr wrap="square" lIns="0" tIns="0" rIns="0" bIns="0" rtlCol="0" anchor="ctr"/>
+          <a:lstStyle/>
+          <a:p>
+            <a:pPr algn="l" indent="0" marL="0">
+              <a:buNone/>
+            </a:pPr>
+            <a:r>
+              <a:rPr lang="en-US" sz="1100" b="1" dirty="0">
+                <a:solidFill>
+                  <a:srgbClr val="1A2433"/>
+                </a:solidFill>
+                <a:latin typeface="Calibri" pitchFamily="34" charset="0"/>
+                <a:ea typeface="Calibri" pitchFamily="34" charset="-122"/>
+                <a:cs typeface="Calibri" pitchFamily="34" charset="-120"/>
+              </a:rPr>
+              <a:t>Todas las vías</a:t>
+            </a:r>
+            <a:endParaRPr lang="en-US" sz="1100" dirty="0"/>
+          </a:p>
+        </p:txBody>
+      </p:sp>
+      <p:sp>
+        <p:nvSpPr>
+          <p:cNvPr id="41" name="Text 37"/>
+          <p:cNvSpPr/>
+          <p:nvPr/>
+        </p:nvSpPr>
+        <p:spPr>
+          <a:xfrm>
+            <a:off x="2377440" y="6035040"/>
+            <a:ext cx="960120" cy="192024"/>
+          </a:xfrm>
+          <a:prstGeom prst="rect">
+            <a:avLst/>
+          </a:prstGeom>
+          <a:noFill/>
+          <a:ln/>
+        </p:spPr>
+        <p:txBody>
+          <a:bodyPr wrap="square" lIns="0" tIns="0" rIns="0" bIns="0" rtlCol="0" anchor="ctr"/>
+          <a:lstStyle/>
+          <a:p>
+            <a:pPr algn="r" indent="0" marL="0">
+              <a:buNone/>
+            </a:pPr>
+            <a:r>
+              <a:rPr lang="en-US" sz="1100" b="1" dirty="0">
+                <a:solidFill>
+                  <a:srgbClr val="1A2433"/>
+                </a:solidFill>
+                <a:latin typeface="Calibri" pitchFamily="34" charset="0"/>
+                <a:ea typeface="Calibri" pitchFamily="34" charset="-122"/>
+                <a:cs typeface="Calibri" pitchFamily="34" charset="-120"/>
+              </a:rPr>
+              <a:t>508</a:t>
+            </a:r>
+            <a:endParaRPr lang="en-US" sz="1100" dirty="0"/>
+          </a:p>
+        </p:txBody>
+      </p:sp>
+      <p:sp>
+        <p:nvSpPr>
+          <p:cNvPr id="42" name="Text 38"/>
+          <p:cNvSpPr/>
+          <p:nvPr/>
+        </p:nvSpPr>
+        <p:spPr>
+          <a:xfrm>
+            <a:off x="3429000" y="6035040"/>
+            <a:ext cx="914400" cy="192024"/>
+          </a:xfrm>
+          <a:prstGeom prst="rect">
+            <a:avLst/>
+          </a:prstGeom>
+          <a:noFill/>
+          <a:ln/>
+        </p:spPr>
+        <p:txBody>
+          <a:bodyPr wrap="square" lIns="0" tIns="0" rIns="0" bIns="0" rtlCol="0" anchor="ctr"/>
+          <a:lstStyle/>
+          <a:p>
+            <a:pPr algn="r" indent="0" marL="0">
+              <a:buNone/>
+            </a:pPr>
+            <a:r>
+              <a:rPr lang="en-US" sz="1100" b="1" dirty="0">
+                <a:solidFill>
+                  <a:srgbClr val="1A2433"/>
+                </a:solidFill>
+                <a:latin typeface="Calibri" pitchFamily="34" charset="0"/>
+                <a:ea typeface="Calibri" pitchFamily="34" charset="-122"/>
+                <a:cs typeface="Calibri" pitchFamily="34" charset="-120"/>
+              </a:rPr>
+              <a:t>454</a:t>
+            </a:r>
+            <a:endParaRPr lang="en-US" sz="1100" dirty="0"/>
+          </a:p>
+        </p:txBody>
+      </p:sp>
+      <p:sp>
+        <p:nvSpPr>
+          <p:cNvPr id="43" name="Text 39"/>
+          <p:cNvSpPr/>
+          <p:nvPr/>
+        </p:nvSpPr>
+        <p:spPr>
+          <a:xfrm>
+            <a:off x="4434840" y="6035040"/>
+            <a:ext cx="868680" cy="192024"/>
+          </a:xfrm>
+          <a:prstGeom prst="rect">
+            <a:avLst/>
+          </a:prstGeom>
+          <a:noFill/>
+          <a:ln/>
+        </p:spPr>
+        <p:txBody>
+          <a:bodyPr wrap="square" lIns="0" tIns="0" rIns="0" bIns="0" rtlCol="0" anchor="ctr"/>
+          <a:lstStyle/>
+          <a:p>
+            <a:pPr algn="r" indent="0" marL="0">
+              <a:buNone/>
+            </a:pPr>
+            <a:r>
+              <a:rPr lang="en-US" sz="1100" b="1" dirty="0">
+                <a:solidFill>
+                  <a:srgbClr val="C0392B"/>
+                </a:solidFill>
+                <a:latin typeface="Calibri" pitchFamily="34" charset="0"/>
+                <a:ea typeface="Calibri" pitchFamily="34" charset="-122"/>
+                <a:cs typeface="Calibri" pitchFamily="34" charset="-120"/>
+              </a:rPr>
+              <a:t>54</a:t>
+            </a:r>
+            <a:endParaRPr lang="en-US" sz="1100" dirty="0"/>
+          </a:p>
+        </p:txBody>
+      </p:sp>
+      <p:sp>
+        <p:nvSpPr>
+          <p:cNvPr id="44" name="Text 40"/>
+          <p:cNvSpPr/>
+          <p:nvPr/>
+        </p:nvSpPr>
+        <p:spPr>
+          <a:xfrm>
+            <a:off x="5394960" y="6035040"/>
+            <a:ext cx="1051560" cy="192024"/>
+          </a:xfrm>
+          <a:prstGeom prst="rect">
+            <a:avLst/>
+          </a:prstGeom>
+          <a:noFill/>
+          <a:ln/>
+        </p:spPr>
+        <p:txBody>
+          <a:bodyPr wrap="square" lIns="0" tIns="0" rIns="0" bIns="0" rtlCol="0" anchor="ctr"/>
+          <a:lstStyle/>
+          <a:p>
+            <a:pPr algn="r" indent="0" marL="0">
+              <a:buNone/>
+            </a:pPr>
+            <a:r>
+              <a:rPr lang="en-US" sz="1100" b="1" dirty="0">
+                <a:solidFill>
+                  <a:srgbClr val="1A2433"/>
+                </a:solidFill>
+                <a:latin typeface="Calibri" pitchFamily="34" charset="0"/>
+                <a:ea typeface="Calibri" pitchFamily="34" charset="-122"/>
+                <a:cs typeface="Calibri" pitchFamily="34" charset="-120"/>
+              </a:rPr>
+              <a:t>139 d</a:t>
+            </a:r>
+            <a:endParaRPr lang="en-US" sz="1100" dirty="0"/>
+          </a:p>
+        </p:txBody>
+      </p:sp>
+      <p:sp>
+        <p:nvSpPr>
+          <p:cNvPr id="45" name="Shape 41"/>
+          <p:cNvSpPr/>
+          <p:nvPr/>
+        </p:nvSpPr>
+        <p:spPr>
+          <a:xfrm>
+            <a:off x="502920" y="6263640"/>
+            <a:ext cx="5943600" cy="0"/>
+          </a:xfrm>
+          <a:prstGeom prst="line">
+            <a:avLst/>
+          </a:prstGeom>
+          <a:noFill/>
+          <a:ln w="9525">
+            <a:solidFill>
+              <a:srgbClr val="D9DFE6"/>
+            </a:solidFill>
+            <a:prstDash val="solid"/>
+          </a:ln>
+        </p:spPr>
+      </p:sp>
       <p:graphicFrame>
         <p:nvGraphicFramePr>
-          <p:cNvPr id="7" name="Chart 1" descr=""/>
+          <p:cNvPr id="46" name="Chart 1" descr=""/>
           <p:cNvGraphicFramePr/>
           <p:nvPr/>
         </p:nvGraphicFramePr>
@@ -26403,7 +27790,7 @@
       </p:graphicFrame>
       <p:sp>
         <p:nvSpPr>
-          <p:cNvPr id="8" name="Shape 3"/>
+          <p:cNvPr id="47" name="Shape 42"/>
           <p:cNvSpPr/>
           <p:nvPr/>
         </p:nvSpPr>
@@ -26425,7 +27812,7 @@
       </p:sp>
       <p:sp>
         <p:nvSpPr>
-          <p:cNvPr id="9" name="Text 4"/>
+          <p:cNvPr id="48" name="Text 43"/>
           <p:cNvSpPr/>
           <p:nvPr/>
         </p:nvSpPr>
@@ -26464,7 +27851,7 @@
       </p:sp>
       <p:sp>
         <p:nvSpPr>
-          <p:cNvPr id="10" name="Text 5"/>
+          <p:cNvPr id="49" name="Text 44"/>
           <p:cNvSpPr/>
           <p:nvPr/>
         </p:nvSpPr>
@@ -26503,7 +27890,7 @@
       </p:sp>
       <p:sp>
         <p:nvSpPr>
-          <p:cNvPr id="11" name="Text 6"/>
+          <p:cNvPr id="50" name="Text 45"/>
           <p:cNvSpPr/>
           <p:nvPr/>
         </p:nvSpPr>
@@ -26542,7 +27929,7 @@
       </p:sp>
       <p:sp>
         <p:nvSpPr>
-          <p:cNvPr id="12" name="Text 7"/>
+          <p:cNvPr id="51" name="Text 46"/>
           <p:cNvSpPr/>
           <p:nvPr/>
         </p:nvSpPr>
@@ -26581,7 +27968,7 @@
       </p:sp>
       <p:sp>
         <p:nvSpPr>
-          <p:cNvPr id="13" name="Text 8"/>
+          <p:cNvPr id="52" name="Text 47"/>
           <p:cNvSpPr/>
           <p:nvPr/>
         </p:nvSpPr>
@@ -26620,7 +28007,7 @@
       </p:sp>
       <p:sp>
         <p:nvSpPr>
-          <p:cNvPr id="14" name="Text 9"/>
+          <p:cNvPr id="53" name="Text 48"/>
           <p:cNvSpPr/>
           <p:nvPr/>
         </p:nvSpPr>
@@ -26659,7 +28046,7 @@
       </p:sp>
       <p:sp>
         <p:nvSpPr>
-          <p:cNvPr id="15" name="Text 10"/>
+          <p:cNvPr id="54" name="Text 49"/>
           <p:cNvSpPr/>
           <p:nvPr/>
         </p:nvSpPr>
@@ -26698,7 +28085,7 @@
       </p:sp>
       <p:sp>
         <p:nvSpPr>
-          <p:cNvPr id="16" name="Text 11"/>
+          <p:cNvPr id="55" name="Text 50"/>
           <p:cNvSpPr/>
           <p:nvPr/>
         </p:nvSpPr>
@@ -26737,7 +28124,7 @@
       </p:sp>
       <p:sp>
         <p:nvSpPr>
-          <p:cNvPr id="17" name="Text 12"/>
+          <p:cNvPr id="56" name="Text 51"/>
           <p:cNvSpPr/>
           <p:nvPr/>
         </p:nvSpPr>
@@ -26776,7 +28163,7 @@
       </p:sp>
       <p:sp>
         <p:nvSpPr>
-          <p:cNvPr id="18" name="Text 13"/>
+          <p:cNvPr id="57" name="Text 52"/>
           <p:cNvSpPr/>
           <p:nvPr/>
         </p:nvSpPr>

</xml_diff>

<commit_message>
NC: acotar «Estado de cada vía» a 7 columnas y agregar el tiempo de respuesta
Vía · levantadas · cerradas · % cierre · abiertas · atrasadas · tiempo
promedio de respuesta. Salen las cuatro columnas de antigüedad (+90,
+180, mediana y la más antigua): esa lectura ya vive en su propio bloque.

resumir() expone promedioCierre además de medianaCierre — no dicen lo
mismo, un hallazgo de 400 días mueve el promedio y no la mediana. El
promedio va solo sobre las cerradas y la nota lo declara: las abiertas no
entran, así que la cifra es optimista.

Al corte el promedio va en 69 días contra los 10 de plazo (49 las del
cliente, 65 las internas, 179 las de subcontrato). La PPT lleva la misma
tabla con las mismas 7 columnas.

Co-Authored-By: Claude Opus 5 <noreply@anthropic.com>
Claude-Session: https://claude.ai/code/session_011SHyPcub1TtjA2kTAsaPFu
</commit_message>
<xml_diff>
--- a/modulo_nc/Panel_No_Conformidades.pptx
+++ b/modulo_nc/Panel_No_Conformidades.pptx
@@ -26394,7 +26394,7 @@
         <p:spPr>
           <a:xfrm>
             <a:off x="502920" y="4160520"/>
-            <a:ext cx="5486400" cy="274320"/>
+            <a:ext cx="6400800" cy="274320"/>
           </a:xfrm>
           <a:prstGeom prst="rect">
             <a:avLst/>
@@ -26410,7 +26410,7 @@
               <a:buNone/>
             </a:pPr>
             <a:r>
-              <a:rPr lang="en-US" sz="1100" b="1" spc="150" kern="0" dirty="0">
+              <a:rPr lang="en-US" sz="900" b="1" spc="60" kern="0" dirty="0">
                 <a:solidFill>
                   <a:srgbClr val="C87A32"/>
                 </a:solidFill>
@@ -26418,9 +26418,9 @@
                 <a:ea typeface="Calibri" pitchFamily="34" charset="-122"/>
                 <a:cs typeface="Calibri" pitchFamily="34" charset="-120"/>
               </a:rPr>
-              <a:t>ESTADO DE CADA VÍA</a:t>
-            </a:r>
-            <a:endParaRPr lang="en-US" sz="1100" dirty="0"/>
+              <a:t>ESTADO DE CADA VÍA  ·  atrasada = abierta que pasó los 10 días de plazo  ·  T. respuesta = días de emisión a cierre, solo sobre las cerradas</a:t>
+            </a:r>
+            <a:endParaRPr lang="en-US" sz="900" dirty="0"/>
           </a:p>
         </p:txBody>
       </p:sp>
@@ -26433,7 +26433,7 @@
         <p:spPr>
           <a:xfrm>
             <a:off x="502920" y="4462272"/>
-            <a:ext cx="1783080" cy="274320"/>
+            <a:ext cx="1463040" cy="274320"/>
           </a:xfrm>
           <a:prstGeom prst="rect">
             <a:avLst/>
@@ -26471,8 +26471,8 @@
         </p:nvSpPr>
         <p:spPr>
           <a:xfrm>
-            <a:off x="2377440" y="4462272"/>
-            <a:ext cx="960120" cy="274320"/>
+            <a:off x="2011680" y="4462272"/>
+            <a:ext cx="731520" cy="274320"/>
           </a:xfrm>
           <a:prstGeom prst="rect">
             <a:avLst/>
@@ -26496,7 +26496,7 @@
                 <a:ea typeface="Calibri" pitchFamily="34" charset="-122"/>
                 <a:cs typeface="Calibri" pitchFamily="34" charset="-120"/>
               </a:rPr>
-              <a:t>LEVANTADAS</a:t>
+              <a:t>LEVANT.</a:t>
             </a:r>
             <a:endParaRPr lang="en-US" sz="950" dirty="0"/>
           </a:p>
@@ -26510,7 +26510,163 @@
         </p:nvSpPr>
         <p:spPr>
           <a:xfrm>
-            <a:off x="3429000" y="4462272"/>
+            <a:off x="2788920" y="4462272"/>
+            <a:ext cx="731520" cy="274320"/>
+          </a:xfrm>
+          <a:prstGeom prst="rect">
+            <a:avLst/>
+          </a:prstGeom>
+          <a:noFill/>
+          <a:ln/>
+        </p:spPr>
+        <p:txBody>
+          <a:bodyPr wrap="square" lIns="0" tIns="0" rIns="0" bIns="0" rtlCol="0" anchor="ctr"/>
+          <a:lstStyle/>
+          <a:p>
+            <a:pPr algn="r" indent="0" marL="0">
+              <a:buNone/>
+            </a:pPr>
+            <a:r>
+              <a:rPr lang="en-US" sz="950" b="1" spc="50" kern="0" dirty="0">
+                <a:solidFill>
+                  <a:srgbClr val="56606E"/>
+                </a:solidFill>
+                <a:latin typeface="Calibri" pitchFamily="34" charset="0"/>
+                <a:ea typeface="Calibri" pitchFamily="34" charset="-122"/>
+                <a:cs typeface="Calibri" pitchFamily="34" charset="-120"/>
+              </a:rPr>
+              <a:t>CERRADAS</a:t>
+            </a:r>
+            <a:endParaRPr lang="en-US" sz="950" dirty="0"/>
+          </a:p>
+        </p:txBody>
+      </p:sp>
+      <p:sp>
+        <p:nvSpPr>
+          <p:cNvPr id="11" name="Text 7"/>
+          <p:cNvSpPr/>
+          <p:nvPr/>
+        </p:nvSpPr>
+        <p:spPr>
+          <a:xfrm>
+            <a:off x="3566160" y="4462272"/>
+            <a:ext cx="731520" cy="274320"/>
+          </a:xfrm>
+          <a:prstGeom prst="rect">
+            <a:avLst/>
+          </a:prstGeom>
+          <a:noFill/>
+          <a:ln/>
+        </p:spPr>
+        <p:txBody>
+          <a:bodyPr wrap="square" lIns="0" tIns="0" rIns="0" bIns="0" rtlCol="0" anchor="ctr"/>
+          <a:lstStyle/>
+          <a:p>
+            <a:pPr algn="r" indent="0" marL="0">
+              <a:buNone/>
+            </a:pPr>
+            <a:r>
+              <a:rPr lang="en-US" sz="950" b="1" spc="50" kern="0" dirty="0">
+                <a:solidFill>
+                  <a:srgbClr val="56606E"/>
+                </a:solidFill>
+                <a:latin typeface="Calibri" pitchFamily="34" charset="0"/>
+                <a:ea typeface="Calibri" pitchFamily="34" charset="-122"/>
+                <a:cs typeface="Calibri" pitchFamily="34" charset="-120"/>
+              </a:rPr>
+              <a:t>% CIERRE</a:t>
+            </a:r>
+            <a:endParaRPr lang="en-US" sz="950" dirty="0"/>
+          </a:p>
+        </p:txBody>
+      </p:sp>
+      <p:sp>
+        <p:nvSpPr>
+          <p:cNvPr id="12" name="Text 8"/>
+          <p:cNvSpPr/>
+          <p:nvPr/>
+        </p:nvSpPr>
+        <p:spPr>
+          <a:xfrm>
+            <a:off x="4343400" y="4462272"/>
+            <a:ext cx="731520" cy="274320"/>
+          </a:xfrm>
+          <a:prstGeom prst="rect">
+            <a:avLst/>
+          </a:prstGeom>
+          <a:noFill/>
+          <a:ln/>
+        </p:spPr>
+        <p:txBody>
+          <a:bodyPr wrap="square" lIns="0" tIns="0" rIns="0" bIns="0" rtlCol="0" anchor="ctr"/>
+          <a:lstStyle/>
+          <a:p>
+            <a:pPr algn="r" indent="0" marL="0">
+              <a:buNone/>
+            </a:pPr>
+            <a:r>
+              <a:rPr lang="en-US" sz="950" b="1" spc="50" kern="0" dirty="0">
+                <a:solidFill>
+                  <a:srgbClr val="56606E"/>
+                </a:solidFill>
+                <a:latin typeface="Calibri" pitchFamily="34" charset="0"/>
+                <a:ea typeface="Calibri" pitchFamily="34" charset="-122"/>
+                <a:cs typeface="Calibri" pitchFamily="34" charset="-120"/>
+              </a:rPr>
+              <a:t>ABIERTAS</a:t>
+            </a:r>
+            <a:endParaRPr lang="en-US" sz="950" dirty="0"/>
+          </a:p>
+        </p:txBody>
+      </p:sp>
+      <p:sp>
+        <p:nvSpPr>
+          <p:cNvPr id="13" name="Text 9"/>
+          <p:cNvSpPr/>
+          <p:nvPr/>
+        </p:nvSpPr>
+        <p:spPr>
+          <a:xfrm>
+            <a:off x="5120640" y="4462272"/>
+            <a:ext cx="777240" cy="274320"/>
+          </a:xfrm>
+          <a:prstGeom prst="rect">
+            <a:avLst/>
+          </a:prstGeom>
+          <a:noFill/>
+          <a:ln/>
+        </p:spPr>
+        <p:txBody>
+          <a:bodyPr wrap="square" lIns="0" tIns="0" rIns="0" bIns="0" rtlCol="0" anchor="ctr"/>
+          <a:lstStyle/>
+          <a:p>
+            <a:pPr algn="r" indent="0" marL="0">
+              <a:buNone/>
+            </a:pPr>
+            <a:r>
+              <a:rPr lang="en-US" sz="950" b="1" spc="50" kern="0" dirty="0">
+                <a:solidFill>
+                  <a:srgbClr val="56606E"/>
+                </a:solidFill>
+                <a:latin typeface="Calibri" pitchFamily="34" charset="0"/>
+                <a:ea typeface="Calibri" pitchFamily="34" charset="-122"/>
+                <a:cs typeface="Calibri" pitchFamily="34" charset="-120"/>
+              </a:rPr>
+              <a:t>ATRASADAS</a:t>
+            </a:r>
+            <a:endParaRPr lang="en-US" sz="950" dirty="0"/>
+          </a:p>
+        </p:txBody>
+      </p:sp>
+      <p:sp>
+        <p:nvSpPr>
+          <p:cNvPr id="14" name="Text 10"/>
+          <p:cNvSpPr/>
+          <p:nvPr/>
+        </p:nvSpPr>
+        <p:spPr>
+          <a:xfrm>
+            <a:off x="5943600" y="4462272"/>
             <a:ext cx="914400" cy="274320"/>
           </a:xfrm>
           <a:prstGeom prst="rect">
@@ -26535,7 +26691,7 @@
                 <a:ea typeface="Calibri" pitchFamily="34" charset="-122"/>
                 <a:cs typeface="Calibri" pitchFamily="34" charset="-120"/>
               </a:rPr>
-              <a:t>CERRADAS</a:t>
+              <a:t>T. RESPUESTA</a:t>
             </a:r>
             <a:endParaRPr lang="en-US" sz="950" dirty="0"/>
           </a:p>
@@ -26543,92 +26699,14 @@
       </p:sp>
       <p:sp>
         <p:nvSpPr>
-          <p:cNvPr id="11" name="Text 7"/>
-          <p:cNvSpPr/>
-          <p:nvPr/>
-        </p:nvSpPr>
-        <p:spPr>
-          <a:xfrm>
-            <a:off x="4434840" y="4462272"/>
-            <a:ext cx="868680" cy="274320"/>
-          </a:xfrm>
-          <a:prstGeom prst="rect">
-            <a:avLst/>
-          </a:prstGeom>
-          <a:noFill/>
-          <a:ln/>
-        </p:spPr>
-        <p:txBody>
-          <a:bodyPr wrap="square" lIns="0" tIns="0" rIns="0" bIns="0" rtlCol="0" anchor="ctr"/>
-          <a:lstStyle/>
-          <a:p>
-            <a:pPr algn="r" indent="0" marL="0">
-              <a:buNone/>
-            </a:pPr>
-            <a:r>
-              <a:rPr lang="en-US" sz="950" b="1" spc="50" kern="0" dirty="0">
-                <a:solidFill>
-                  <a:srgbClr val="56606E"/>
-                </a:solidFill>
-                <a:latin typeface="Calibri" pitchFamily="34" charset="0"/>
-                <a:ea typeface="Calibri" pitchFamily="34" charset="-122"/>
-                <a:cs typeface="Calibri" pitchFamily="34" charset="-120"/>
-              </a:rPr>
-              <a:t>ABIERTAS</a:t>
-            </a:r>
-            <a:endParaRPr lang="en-US" sz="950" dirty="0"/>
-          </a:p>
-        </p:txBody>
-      </p:sp>
-      <p:sp>
-        <p:nvSpPr>
-          <p:cNvPr id="12" name="Text 8"/>
-          <p:cNvSpPr/>
-          <p:nvPr/>
-        </p:nvSpPr>
-        <p:spPr>
-          <a:xfrm>
-            <a:off x="5394960" y="4462272"/>
-            <a:ext cx="1051560" cy="274320"/>
-          </a:xfrm>
-          <a:prstGeom prst="rect">
-            <a:avLst/>
-          </a:prstGeom>
-          <a:noFill/>
-          <a:ln/>
-        </p:spPr>
-        <p:txBody>
-          <a:bodyPr wrap="square" lIns="0" tIns="0" rIns="0" bIns="0" rtlCol="0" anchor="ctr"/>
-          <a:lstStyle/>
-          <a:p>
-            <a:pPr algn="r" indent="0" marL="0">
-              <a:buNone/>
-            </a:pPr>
-            <a:r>
-              <a:rPr lang="en-US" sz="950" b="1" spc="50" kern="0" dirty="0">
-                <a:solidFill>
-                  <a:srgbClr val="56606E"/>
-                </a:solidFill>
-                <a:latin typeface="Calibri" pitchFamily="34" charset="0"/>
-                <a:ea typeface="Calibri" pitchFamily="34" charset="-122"/>
-                <a:cs typeface="Calibri" pitchFamily="34" charset="-120"/>
-              </a:rPr>
-              <a:t>ANTIG. MEDIANA</a:t>
-            </a:r>
-            <a:endParaRPr lang="en-US" sz="950" dirty="0"/>
-          </a:p>
-        </p:txBody>
-      </p:sp>
-      <p:sp>
-        <p:nvSpPr>
-          <p:cNvPr id="13" name="Shape 9"/>
+          <p:cNvPr id="15" name="Shape 11"/>
           <p:cNvSpPr/>
           <p:nvPr/>
         </p:nvSpPr>
         <p:spPr>
           <a:xfrm>
             <a:off x="502920" y="4773168"/>
-            <a:ext cx="5943600" cy="0"/>
+            <a:ext cx="6355080" cy="0"/>
           </a:xfrm>
           <a:prstGeom prst="line">
             <a:avLst/>
@@ -26644,14 +26722,14 @@
       </p:sp>
       <p:sp>
         <p:nvSpPr>
-          <p:cNvPr id="14" name="Text 10"/>
+          <p:cNvPr id="16" name="Text 12"/>
           <p:cNvSpPr/>
           <p:nvPr/>
         </p:nvSpPr>
         <p:spPr>
           <a:xfrm>
             <a:off x="502920" y="4901184"/>
-            <a:ext cx="1783080" cy="192024"/>
+            <a:ext cx="1463040" cy="192024"/>
           </a:xfrm>
           <a:prstGeom prst="rect">
             <a:avLst/>
@@ -26667,7 +26745,7 @@
               <a:buNone/>
             </a:pPr>
             <a:r>
-              <a:rPr lang="en-US" sz="1100" dirty="0">
+              <a:rPr lang="en-US" sz="1050" dirty="0">
                 <a:solidFill>
                   <a:srgbClr val="2E6FB5"/>
                 </a:solidFill>
@@ -26677,20 +26755,20 @@
               </a:rPr>
               <a:t>Interna (Besalco)</a:t>
             </a:r>
-            <a:endParaRPr lang="en-US" sz="1100" dirty="0"/>
-          </a:p>
-        </p:txBody>
-      </p:sp>
-      <p:sp>
-        <p:nvSpPr>
-          <p:cNvPr id="15" name="Text 11"/>
-          <p:cNvSpPr/>
-          <p:nvPr/>
-        </p:nvSpPr>
-        <p:spPr>
-          <a:xfrm>
-            <a:off x="2377440" y="4901184"/>
-            <a:ext cx="960120" cy="192024"/>
+            <a:endParaRPr lang="en-US" sz="1050" dirty="0"/>
+          </a:p>
+        </p:txBody>
+      </p:sp>
+      <p:sp>
+        <p:nvSpPr>
+          <p:cNvPr id="17" name="Text 13"/>
+          <p:cNvSpPr/>
+          <p:nvPr/>
+        </p:nvSpPr>
+        <p:spPr>
+          <a:xfrm>
+            <a:off x="2011680" y="4901184"/>
+            <a:ext cx="731520" cy="192024"/>
           </a:xfrm>
           <a:prstGeom prst="rect">
             <a:avLst/>
@@ -26706,7 +26784,7 @@
               <a:buNone/>
             </a:pPr>
             <a:r>
-              <a:rPr lang="en-US" sz="1100" dirty="0">
+              <a:rPr lang="en-US" sz="1050" dirty="0">
                 <a:solidFill>
                   <a:srgbClr val="1A2433"/>
                 </a:solidFill>
@@ -26716,19 +26794,175 @@
               </a:rPr>
               <a:t>162</a:t>
             </a:r>
-            <a:endParaRPr lang="en-US" sz="1100" dirty="0"/>
-          </a:p>
-        </p:txBody>
-      </p:sp>
-      <p:sp>
-        <p:nvSpPr>
-          <p:cNvPr id="16" name="Text 12"/>
-          <p:cNvSpPr/>
-          <p:nvPr/>
-        </p:nvSpPr>
-        <p:spPr>
-          <a:xfrm>
-            <a:off x="3429000" y="4901184"/>
+            <a:endParaRPr lang="en-US" sz="1050" dirty="0"/>
+          </a:p>
+        </p:txBody>
+      </p:sp>
+      <p:sp>
+        <p:nvSpPr>
+          <p:cNvPr id="18" name="Text 14"/>
+          <p:cNvSpPr/>
+          <p:nvPr/>
+        </p:nvSpPr>
+        <p:spPr>
+          <a:xfrm>
+            <a:off x="2788920" y="4901184"/>
+            <a:ext cx="731520" cy="192024"/>
+          </a:xfrm>
+          <a:prstGeom prst="rect">
+            <a:avLst/>
+          </a:prstGeom>
+          <a:noFill/>
+          <a:ln/>
+        </p:spPr>
+        <p:txBody>
+          <a:bodyPr wrap="square" lIns="0" tIns="0" rIns="0" bIns="0" rtlCol="0" anchor="ctr"/>
+          <a:lstStyle/>
+          <a:p>
+            <a:pPr algn="r" indent="0" marL="0">
+              <a:buNone/>
+            </a:pPr>
+            <a:r>
+              <a:rPr lang="en-US" sz="1050" dirty="0">
+                <a:solidFill>
+                  <a:srgbClr val="1A2433"/>
+                </a:solidFill>
+                <a:latin typeface="Calibri" pitchFamily="34" charset="0"/>
+                <a:ea typeface="Calibri" pitchFamily="34" charset="-122"/>
+                <a:cs typeface="Calibri" pitchFamily="34" charset="-120"/>
+              </a:rPr>
+              <a:t>157</a:t>
+            </a:r>
+            <a:endParaRPr lang="en-US" sz="1050" dirty="0"/>
+          </a:p>
+        </p:txBody>
+      </p:sp>
+      <p:sp>
+        <p:nvSpPr>
+          <p:cNvPr id="19" name="Text 15"/>
+          <p:cNvSpPr/>
+          <p:nvPr/>
+        </p:nvSpPr>
+        <p:spPr>
+          <a:xfrm>
+            <a:off x="3566160" y="4901184"/>
+            <a:ext cx="731520" cy="192024"/>
+          </a:xfrm>
+          <a:prstGeom prst="rect">
+            <a:avLst/>
+          </a:prstGeom>
+          <a:noFill/>
+          <a:ln/>
+        </p:spPr>
+        <p:txBody>
+          <a:bodyPr wrap="square" lIns="0" tIns="0" rIns="0" bIns="0" rtlCol="0" anchor="ctr"/>
+          <a:lstStyle/>
+          <a:p>
+            <a:pPr algn="r" indent="0" marL="0">
+              <a:buNone/>
+            </a:pPr>
+            <a:r>
+              <a:rPr lang="en-US" sz="1050" dirty="0">
+                <a:solidFill>
+                  <a:srgbClr val="1A2433"/>
+                </a:solidFill>
+                <a:latin typeface="Calibri" pitchFamily="34" charset="0"/>
+                <a:ea typeface="Calibri" pitchFamily="34" charset="-122"/>
+                <a:cs typeface="Calibri" pitchFamily="34" charset="-120"/>
+              </a:rPr>
+              <a:t>96,9%</a:t>
+            </a:r>
+            <a:endParaRPr lang="en-US" sz="1050" dirty="0"/>
+          </a:p>
+        </p:txBody>
+      </p:sp>
+      <p:sp>
+        <p:nvSpPr>
+          <p:cNvPr id="20" name="Text 16"/>
+          <p:cNvSpPr/>
+          <p:nvPr/>
+        </p:nvSpPr>
+        <p:spPr>
+          <a:xfrm>
+            <a:off x="4343400" y="4901184"/>
+            <a:ext cx="731520" cy="192024"/>
+          </a:xfrm>
+          <a:prstGeom prst="rect">
+            <a:avLst/>
+          </a:prstGeom>
+          <a:noFill/>
+          <a:ln/>
+        </p:spPr>
+        <p:txBody>
+          <a:bodyPr wrap="square" lIns="0" tIns="0" rIns="0" bIns="0" rtlCol="0" anchor="ctr"/>
+          <a:lstStyle/>
+          <a:p>
+            <a:pPr algn="r" indent="0" marL="0">
+              <a:buNone/>
+            </a:pPr>
+            <a:r>
+              <a:rPr lang="en-US" sz="1050" dirty="0">
+                <a:solidFill>
+                  <a:srgbClr val="C0392B"/>
+                </a:solidFill>
+                <a:latin typeface="Calibri" pitchFamily="34" charset="0"/>
+                <a:ea typeface="Calibri" pitchFamily="34" charset="-122"/>
+                <a:cs typeface="Calibri" pitchFamily="34" charset="-120"/>
+              </a:rPr>
+              <a:t>5</a:t>
+            </a:r>
+            <a:endParaRPr lang="en-US" sz="1050" dirty="0"/>
+          </a:p>
+        </p:txBody>
+      </p:sp>
+      <p:sp>
+        <p:nvSpPr>
+          <p:cNvPr id="21" name="Text 17"/>
+          <p:cNvSpPr/>
+          <p:nvPr/>
+        </p:nvSpPr>
+        <p:spPr>
+          <a:xfrm>
+            <a:off x="5120640" y="4901184"/>
+            <a:ext cx="777240" cy="192024"/>
+          </a:xfrm>
+          <a:prstGeom prst="rect">
+            <a:avLst/>
+          </a:prstGeom>
+          <a:noFill/>
+          <a:ln/>
+        </p:spPr>
+        <p:txBody>
+          <a:bodyPr wrap="square" lIns="0" tIns="0" rIns="0" bIns="0" rtlCol="0" anchor="ctr"/>
+          <a:lstStyle/>
+          <a:p>
+            <a:pPr algn="r" indent="0" marL="0">
+              <a:buNone/>
+            </a:pPr>
+            <a:r>
+              <a:rPr lang="en-US" sz="1050" dirty="0">
+                <a:solidFill>
+                  <a:srgbClr val="C0392B"/>
+                </a:solidFill>
+                <a:latin typeface="Calibri" pitchFamily="34" charset="0"/>
+                <a:ea typeface="Calibri" pitchFamily="34" charset="-122"/>
+                <a:cs typeface="Calibri" pitchFamily="34" charset="-120"/>
+              </a:rPr>
+              <a:t>5</a:t>
+            </a:r>
+            <a:endParaRPr lang="en-US" sz="1050" dirty="0"/>
+          </a:p>
+        </p:txBody>
+      </p:sp>
+      <p:sp>
+        <p:nvSpPr>
+          <p:cNvPr id="22" name="Text 18"/>
+          <p:cNvSpPr/>
+          <p:nvPr/>
+        </p:nvSpPr>
+        <p:spPr>
+          <a:xfrm>
+            <a:off x="5943600" y="4901184"/>
             <a:ext cx="914400" cy="192024"/>
           </a:xfrm>
           <a:prstGeom prst="rect">
@@ -26745,7 +26979,7 @@
               <a:buNone/>
             </a:pPr>
             <a:r>
-              <a:rPr lang="en-US" sz="1100" dirty="0">
+              <a:rPr lang="en-US" sz="1050" dirty="0">
                 <a:solidFill>
                   <a:srgbClr val="1A2433"/>
                 </a:solidFill>
@@ -26753,100 +26987,22 @@
                 <a:ea typeface="Calibri" pitchFamily="34" charset="-122"/>
                 <a:cs typeface="Calibri" pitchFamily="34" charset="-120"/>
               </a:rPr>
-              <a:t>157</a:t>
-            </a:r>
-            <a:endParaRPr lang="en-US" sz="1100" dirty="0"/>
-          </a:p>
-        </p:txBody>
-      </p:sp>
-      <p:sp>
-        <p:nvSpPr>
-          <p:cNvPr id="17" name="Text 13"/>
-          <p:cNvSpPr/>
-          <p:nvPr/>
-        </p:nvSpPr>
-        <p:spPr>
-          <a:xfrm>
-            <a:off x="4434840" y="4901184"/>
-            <a:ext cx="868680" cy="192024"/>
-          </a:xfrm>
-          <a:prstGeom prst="rect">
-            <a:avLst/>
-          </a:prstGeom>
-          <a:noFill/>
-          <a:ln/>
-        </p:spPr>
-        <p:txBody>
-          <a:bodyPr wrap="square" lIns="0" tIns="0" rIns="0" bIns="0" rtlCol="0" anchor="ctr"/>
-          <a:lstStyle/>
-          <a:p>
-            <a:pPr algn="r" indent="0" marL="0">
-              <a:buNone/>
-            </a:pPr>
-            <a:r>
-              <a:rPr lang="en-US" sz="1100" dirty="0">
-                <a:solidFill>
-                  <a:srgbClr val="C0392B"/>
-                </a:solidFill>
-                <a:latin typeface="Calibri" pitchFamily="34" charset="0"/>
-                <a:ea typeface="Calibri" pitchFamily="34" charset="-122"/>
-                <a:cs typeface="Calibri" pitchFamily="34" charset="-120"/>
-              </a:rPr>
-              <a:t>5</a:t>
-            </a:r>
-            <a:endParaRPr lang="en-US" sz="1100" dirty="0"/>
-          </a:p>
-        </p:txBody>
-      </p:sp>
-      <p:sp>
-        <p:nvSpPr>
-          <p:cNvPr id="18" name="Text 14"/>
-          <p:cNvSpPr/>
-          <p:nvPr/>
-        </p:nvSpPr>
-        <p:spPr>
-          <a:xfrm>
-            <a:off x="5394960" y="4901184"/>
-            <a:ext cx="1051560" cy="192024"/>
-          </a:xfrm>
-          <a:prstGeom prst="rect">
-            <a:avLst/>
-          </a:prstGeom>
-          <a:noFill/>
-          <a:ln/>
-        </p:spPr>
-        <p:txBody>
-          <a:bodyPr wrap="square" lIns="0" tIns="0" rIns="0" bIns="0" rtlCol="0" anchor="ctr"/>
-          <a:lstStyle/>
-          <a:p>
-            <a:pPr algn="r" indent="0" marL="0">
-              <a:buNone/>
-            </a:pPr>
-            <a:r>
-              <a:rPr lang="en-US" sz="1100" dirty="0">
-                <a:solidFill>
-                  <a:srgbClr val="1A2433"/>
-                </a:solidFill>
-                <a:latin typeface="Calibri" pitchFamily="34" charset="0"/>
-                <a:ea typeface="Calibri" pitchFamily="34" charset="-122"/>
-                <a:cs typeface="Calibri" pitchFamily="34" charset="-120"/>
-              </a:rPr>
-              <a:t>224 d</a:t>
-            </a:r>
-            <a:endParaRPr lang="en-US" sz="1100" dirty="0"/>
-          </a:p>
-        </p:txBody>
-      </p:sp>
-      <p:sp>
-        <p:nvSpPr>
-          <p:cNvPr id="19" name="Shape 15"/>
+              <a:t>65 d</a:t>
+            </a:r>
+            <a:endParaRPr lang="en-US" sz="1050" dirty="0"/>
+          </a:p>
+        </p:txBody>
+      </p:sp>
+      <p:sp>
+        <p:nvSpPr>
+          <p:cNvPr id="23" name="Shape 19"/>
           <p:cNvSpPr/>
           <p:nvPr/>
         </p:nvSpPr>
         <p:spPr>
           <a:xfrm>
             <a:off x="502920" y="5129784"/>
-            <a:ext cx="5943600" cy="0"/>
+            <a:ext cx="6355080" cy="0"/>
           </a:xfrm>
           <a:prstGeom prst="line">
             <a:avLst/>
@@ -26862,14 +27018,14 @@
       </p:sp>
       <p:sp>
         <p:nvSpPr>
-          <p:cNvPr id="20" name="Shape 16"/>
+          <p:cNvPr id="24" name="Shape 20"/>
           <p:cNvSpPr/>
           <p:nvPr/>
         </p:nvSpPr>
         <p:spPr>
           <a:xfrm>
             <a:off x="457200" y="5138928"/>
-            <a:ext cx="5989320" cy="283464"/>
+            <a:ext cx="6400800" cy="283464"/>
           </a:xfrm>
           <a:prstGeom prst="rect">
             <a:avLst/>
@@ -26882,14 +27038,14 @@
       </p:sp>
       <p:sp>
         <p:nvSpPr>
-          <p:cNvPr id="21" name="Text 17"/>
+          <p:cNvPr id="25" name="Text 21"/>
           <p:cNvSpPr/>
           <p:nvPr/>
         </p:nvSpPr>
         <p:spPr>
           <a:xfrm>
             <a:off x="502920" y="5184648"/>
-            <a:ext cx="1783080" cy="192024"/>
+            <a:ext cx="1463040" cy="192024"/>
           </a:xfrm>
           <a:prstGeom prst="rect">
             <a:avLst/>
@@ -26905,7 +27061,7 @@
               <a:buNone/>
             </a:pPr>
             <a:r>
-              <a:rPr lang="en-US" sz="1100" dirty="0">
+              <a:rPr lang="en-US" sz="1050" dirty="0">
                 <a:solidFill>
                   <a:srgbClr val="9A6B0F"/>
                 </a:solidFill>
@@ -26915,20 +27071,20 @@
               </a:rPr>
               <a:t>Externa · Cliente</a:t>
             </a:r>
-            <a:endParaRPr lang="en-US" sz="1100" dirty="0"/>
-          </a:p>
-        </p:txBody>
-      </p:sp>
-      <p:sp>
-        <p:nvSpPr>
-          <p:cNvPr id="22" name="Text 18"/>
-          <p:cNvSpPr/>
-          <p:nvPr/>
-        </p:nvSpPr>
-        <p:spPr>
-          <a:xfrm>
-            <a:off x="2377440" y="5184648"/>
-            <a:ext cx="960120" cy="192024"/>
+            <a:endParaRPr lang="en-US" sz="1050" dirty="0"/>
+          </a:p>
+        </p:txBody>
+      </p:sp>
+      <p:sp>
+        <p:nvSpPr>
+          <p:cNvPr id="26" name="Text 22"/>
+          <p:cNvSpPr/>
+          <p:nvPr/>
+        </p:nvSpPr>
+        <p:spPr>
+          <a:xfrm>
+            <a:off x="2011680" y="5184648"/>
+            <a:ext cx="731520" cy="192024"/>
           </a:xfrm>
           <a:prstGeom prst="rect">
             <a:avLst/>
@@ -26944,7 +27100,7 @@
               <a:buNone/>
             </a:pPr>
             <a:r>
-              <a:rPr lang="en-US" sz="1100" dirty="0">
+              <a:rPr lang="en-US" sz="1050" dirty="0">
                 <a:solidFill>
                   <a:srgbClr val="1A2433"/>
                 </a:solidFill>
@@ -26954,19 +27110,175 @@
               </a:rPr>
               <a:t>289</a:t>
             </a:r>
-            <a:endParaRPr lang="en-US" sz="1100" dirty="0"/>
-          </a:p>
-        </p:txBody>
-      </p:sp>
-      <p:sp>
-        <p:nvSpPr>
-          <p:cNvPr id="23" name="Text 19"/>
-          <p:cNvSpPr/>
-          <p:nvPr/>
-        </p:nvSpPr>
-        <p:spPr>
-          <a:xfrm>
-            <a:off x="3429000" y="5184648"/>
+            <a:endParaRPr lang="en-US" sz="1050" dirty="0"/>
+          </a:p>
+        </p:txBody>
+      </p:sp>
+      <p:sp>
+        <p:nvSpPr>
+          <p:cNvPr id="27" name="Text 23"/>
+          <p:cNvSpPr/>
+          <p:nvPr/>
+        </p:nvSpPr>
+        <p:spPr>
+          <a:xfrm>
+            <a:off x="2788920" y="5184648"/>
+            <a:ext cx="731520" cy="192024"/>
+          </a:xfrm>
+          <a:prstGeom prst="rect">
+            <a:avLst/>
+          </a:prstGeom>
+          <a:noFill/>
+          <a:ln/>
+        </p:spPr>
+        <p:txBody>
+          <a:bodyPr wrap="square" lIns="0" tIns="0" rIns="0" bIns="0" rtlCol="0" anchor="ctr"/>
+          <a:lstStyle/>
+          <a:p>
+            <a:pPr algn="r" indent="0" marL="0">
+              <a:buNone/>
+            </a:pPr>
+            <a:r>
+              <a:rPr lang="en-US" sz="1050" dirty="0">
+                <a:solidFill>
+                  <a:srgbClr val="1A2433"/>
+                </a:solidFill>
+                <a:latin typeface="Calibri" pitchFamily="34" charset="0"/>
+                <a:ea typeface="Calibri" pitchFamily="34" charset="-122"/>
+                <a:cs typeface="Calibri" pitchFamily="34" charset="-120"/>
+              </a:rPr>
+              <a:t>240</a:t>
+            </a:r>
+            <a:endParaRPr lang="en-US" sz="1050" dirty="0"/>
+          </a:p>
+        </p:txBody>
+      </p:sp>
+      <p:sp>
+        <p:nvSpPr>
+          <p:cNvPr id="28" name="Text 24"/>
+          <p:cNvSpPr/>
+          <p:nvPr/>
+        </p:nvSpPr>
+        <p:spPr>
+          <a:xfrm>
+            <a:off x="3566160" y="5184648"/>
+            <a:ext cx="731520" cy="192024"/>
+          </a:xfrm>
+          <a:prstGeom prst="rect">
+            <a:avLst/>
+          </a:prstGeom>
+          <a:noFill/>
+          <a:ln/>
+        </p:spPr>
+        <p:txBody>
+          <a:bodyPr wrap="square" lIns="0" tIns="0" rIns="0" bIns="0" rtlCol="0" anchor="ctr"/>
+          <a:lstStyle/>
+          <a:p>
+            <a:pPr algn="r" indent="0" marL="0">
+              <a:buNone/>
+            </a:pPr>
+            <a:r>
+              <a:rPr lang="en-US" sz="1050" dirty="0">
+                <a:solidFill>
+                  <a:srgbClr val="1A2433"/>
+                </a:solidFill>
+                <a:latin typeface="Calibri" pitchFamily="34" charset="0"/>
+                <a:ea typeface="Calibri" pitchFamily="34" charset="-122"/>
+                <a:cs typeface="Calibri" pitchFamily="34" charset="-120"/>
+              </a:rPr>
+              <a:t>83%</a:t>
+            </a:r>
+            <a:endParaRPr lang="en-US" sz="1050" dirty="0"/>
+          </a:p>
+        </p:txBody>
+      </p:sp>
+      <p:sp>
+        <p:nvSpPr>
+          <p:cNvPr id="29" name="Text 25"/>
+          <p:cNvSpPr/>
+          <p:nvPr/>
+        </p:nvSpPr>
+        <p:spPr>
+          <a:xfrm>
+            <a:off x="4343400" y="5184648"/>
+            <a:ext cx="731520" cy="192024"/>
+          </a:xfrm>
+          <a:prstGeom prst="rect">
+            <a:avLst/>
+          </a:prstGeom>
+          <a:noFill/>
+          <a:ln/>
+        </p:spPr>
+        <p:txBody>
+          <a:bodyPr wrap="square" lIns="0" tIns="0" rIns="0" bIns="0" rtlCol="0" anchor="ctr"/>
+          <a:lstStyle/>
+          <a:p>
+            <a:pPr algn="r" indent="0" marL="0">
+              <a:buNone/>
+            </a:pPr>
+            <a:r>
+              <a:rPr lang="en-US" sz="1050" dirty="0">
+                <a:solidFill>
+                  <a:srgbClr val="C0392B"/>
+                </a:solidFill>
+                <a:latin typeface="Calibri" pitchFamily="34" charset="0"/>
+                <a:ea typeface="Calibri" pitchFamily="34" charset="-122"/>
+                <a:cs typeface="Calibri" pitchFamily="34" charset="-120"/>
+              </a:rPr>
+              <a:t>49</a:t>
+            </a:r>
+            <a:endParaRPr lang="en-US" sz="1050" dirty="0"/>
+          </a:p>
+        </p:txBody>
+      </p:sp>
+      <p:sp>
+        <p:nvSpPr>
+          <p:cNvPr id="30" name="Text 26"/>
+          <p:cNvSpPr/>
+          <p:nvPr/>
+        </p:nvSpPr>
+        <p:spPr>
+          <a:xfrm>
+            <a:off x="5120640" y="5184648"/>
+            <a:ext cx="777240" cy="192024"/>
+          </a:xfrm>
+          <a:prstGeom prst="rect">
+            <a:avLst/>
+          </a:prstGeom>
+          <a:noFill/>
+          <a:ln/>
+        </p:spPr>
+        <p:txBody>
+          <a:bodyPr wrap="square" lIns="0" tIns="0" rIns="0" bIns="0" rtlCol="0" anchor="ctr"/>
+          <a:lstStyle/>
+          <a:p>
+            <a:pPr algn="r" indent="0" marL="0">
+              <a:buNone/>
+            </a:pPr>
+            <a:r>
+              <a:rPr lang="en-US" sz="1050" dirty="0">
+                <a:solidFill>
+                  <a:srgbClr val="C0392B"/>
+                </a:solidFill>
+                <a:latin typeface="Calibri" pitchFamily="34" charset="0"/>
+                <a:ea typeface="Calibri" pitchFamily="34" charset="-122"/>
+                <a:cs typeface="Calibri" pitchFamily="34" charset="-120"/>
+              </a:rPr>
+              <a:t>46</a:t>
+            </a:r>
+            <a:endParaRPr lang="en-US" sz="1050" dirty="0"/>
+          </a:p>
+        </p:txBody>
+      </p:sp>
+      <p:sp>
+        <p:nvSpPr>
+          <p:cNvPr id="31" name="Text 27"/>
+          <p:cNvSpPr/>
+          <p:nvPr/>
+        </p:nvSpPr>
+        <p:spPr>
+          <a:xfrm>
+            <a:off x="5943600" y="5184648"/>
             <a:ext cx="914400" cy="192024"/>
           </a:xfrm>
           <a:prstGeom prst="rect">
@@ -26983,7 +27295,7 @@
               <a:buNone/>
             </a:pPr>
             <a:r>
-              <a:rPr lang="en-US" sz="1100" dirty="0">
+              <a:rPr lang="en-US" sz="1050" dirty="0">
                 <a:solidFill>
                   <a:srgbClr val="1A2433"/>
                 </a:solidFill>
@@ -26991,100 +27303,22 @@
                 <a:ea typeface="Calibri" pitchFamily="34" charset="-122"/>
                 <a:cs typeface="Calibri" pitchFamily="34" charset="-120"/>
               </a:rPr>
-              <a:t>240</a:t>
-            </a:r>
-            <a:endParaRPr lang="en-US" sz="1100" dirty="0"/>
-          </a:p>
-        </p:txBody>
-      </p:sp>
-      <p:sp>
-        <p:nvSpPr>
-          <p:cNvPr id="24" name="Text 20"/>
-          <p:cNvSpPr/>
-          <p:nvPr/>
-        </p:nvSpPr>
-        <p:spPr>
-          <a:xfrm>
-            <a:off x="4434840" y="5184648"/>
-            <a:ext cx="868680" cy="192024"/>
-          </a:xfrm>
-          <a:prstGeom prst="rect">
-            <a:avLst/>
-          </a:prstGeom>
-          <a:noFill/>
-          <a:ln/>
-        </p:spPr>
-        <p:txBody>
-          <a:bodyPr wrap="square" lIns="0" tIns="0" rIns="0" bIns="0" rtlCol="0" anchor="ctr"/>
-          <a:lstStyle/>
-          <a:p>
-            <a:pPr algn="r" indent="0" marL="0">
-              <a:buNone/>
-            </a:pPr>
-            <a:r>
-              <a:rPr lang="en-US" sz="1100" dirty="0">
-                <a:solidFill>
-                  <a:srgbClr val="C0392B"/>
-                </a:solidFill>
-                <a:latin typeface="Calibri" pitchFamily="34" charset="0"/>
-                <a:ea typeface="Calibri" pitchFamily="34" charset="-122"/>
-                <a:cs typeface="Calibri" pitchFamily="34" charset="-120"/>
-              </a:rPr>
-              <a:t>49</a:t>
-            </a:r>
-            <a:endParaRPr lang="en-US" sz="1100" dirty="0"/>
-          </a:p>
-        </p:txBody>
-      </p:sp>
-      <p:sp>
-        <p:nvSpPr>
-          <p:cNvPr id="25" name="Text 21"/>
-          <p:cNvSpPr/>
-          <p:nvPr/>
-        </p:nvSpPr>
-        <p:spPr>
-          <a:xfrm>
-            <a:off x="5394960" y="5184648"/>
-            <a:ext cx="1051560" cy="192024"/>
-          </a:xfrm>
-          <a:prstGeom prst="rect">
-            <a:avLst/>
-          </a:prstGeom>
-          <a:noFill/>
-          <a:ln/>
-        </p:spPr>
-        <p:txBody>
-          <a:bodyPr wrap="square" lIns="0" tIns="0" rIns="0" bIns="0" rtlCol="0" anchor="ctr"/>
-          <a:lstStyle/>
-          <a:p>
-            <a:pPr algn="r" indent="0" marL="0">
-              <a:buNone/>
-            </a:pPr>
-            <a:r>
-              <a:rPr lang="en-US" sz="1100" dirty="0">
-                <a:solidFill>
-                  <a:srgbClr val="1A2433"/>
-                </a:solidFill>
-                <a:latin typeface="Calibri" pitchFamily="34" charset="0"/>
-                <a:ea typeface="Calibri" pitchFamily="34" charset="-122"/>
-                <a:cs typeface="Calibri" pitchFamily="34" charset="-120"/>
-              </a:rPr>
-              <a:t>133 d</a:t>
-            </a:r>
-            <a:endParaRPr lang="en-US" sz="1100" dirty="0"/>
-          </a:p>
-        </p:txBody>
-      </p:sp>
-      <p:sp>
-        <p:nvSpPr>
-          <p:cNvPr id="26" name="Shape 22"/>
+              <a:t>49 d</a:t>
+            </a:r>
+            <a:endParaRPr lang="en-US" sz="1050" dirty="0"/>
+          </a:p>
+        </p:txBody>
+      </p:sp>
+      <p:sp>
+        <p:nvSpPr>
+          <p:cNvPr id="32" name="Shape 28"/>
           <p:cNvSpPr/>
           <p:nvPr/>
         </p:nvSpPr>
         <p:spPr>
           <a:xfrm>
             <a:off x="502920" y="5413248"/>
-            <a:ext cx="5943600" cy="0"/>
+            <a:ext cx="6355080" cy="0"/>
           </a:xfrm>
           <a:prstGeom prst="line">
             <a:avLst/>
@@ -27100,14 +27334,14 @@
       </p:sp>
       <p:sp>
         <p:nvSpPr>
-          <p:cNvPr id="27" name="Text 23"/>
+          <p:cNvPr id="33" name="Text 29"/>
           <p:cNvSpPr/>
           <p:nvPr/>
         </p:nvSpPr>
         <p:spPr>
           <a:xfrm>
             <a:off x="502920" y="5468112"/>
-            <a:ext cx="1783080" cy="192024"/>
+            <a:ext cx="1463040" cy="192024"/>
           </a:xfrm>
           <a:prstGeom prst="rect">
             <a:avLst/>
@@ -27123,7 +27357,7 @@
               <a:buNone/>
             </a:pPr>
             <a:r>
-              <a:rPr lang="en-US" sz="1100" dirty="0">
+              <a:rPr lang="en-US" sz="1050" dirty="0">
                 <a:solidFill>
                   <a:srgbClr val="8A5520"/>
                 </a:solidFill>
@@ -27133,20 +27367,20 @@
               </a:rPr>
               <a:t>Externa · Subcontrato</a:t>
             </a:r>
-            <a:endParaRPr lang="en-US" sz="1100" dirty="0"/>
-          </a:p>
-        </p:txBody>
-      </p:sp>
-      <p:sp>
-        <p:nvSpPr>
-          <p:cNvPr id="28" name="Text 24"/>
-          <p:cNvSpPr/>
-          <p:nvPr/>
-        </p:nvSpPr>
-        <p:spPr>
-          <a:xfrm>
-            <a:off x="2377440" y="5468112"/>
-            <a:ext cx="960120" cy="192024"/>
+            <a:endParaRPr lang="en-US" sz="1050" dirty="0"/>
+          </a:p>
+        </p:txBody>
+      </p:sp>
+      <p:sp>
+        <p:nvSpPr>
+          <p:cNvPr id="34" name="Text 30"/>
+          <p:cNvSpPr/>
+          <p:nvPr/>
+        </p:nvSpPr>
+        <p:spPr>
+          <a:xfrm>
+            <a:off x="2011680" y="5468112"/>
+            <a:ext cx="731520" cy="192024"/>
           </a:xfrm>
           <a:prstGeom prst="rect">
             <a:avLst/>
@@ -27162,7 +27396,7 @@
               <a:buNone/>
             </a:pPr>
             <a:r>
-              <a:rPr lang="en-US" sz="1100" dirty="0">
+              <a:rPr lang="en-US" sz="1050" dirty="0">
                 <a:solidFill>
                   <a:srgbClr val="1A2433"/>
                 </a:solidFill>
@@ -27172,19 +27406,175 @@
               </a:rPr>
               <a:t>48</a:t>
             </a:r>
-            <a:endParaRPr lang="en-US" sz="1100" dirty="0"/>
-          </a:p>
-        </p:txBody>
-      </p:sp>
-      <p:sp>
-        <p:nvSpPr>
-          <p:cNvPr id="29" name="Text 25"/>
-          <p:cNvSpPr/>
-          <p:nvPr/>
-        </p:nvSpPr>
-        <p:spPr>
-          <a:xfrm>
-            <a:off x="3429000" y="5468112"/>
+            <a:endParaRPr lang="en-US" sz="1050" dirty="0"/>
+          </a:p>
+        </p:txBody>
+      </p:sp>
+      <p:sp>
+        <p:nvSpPr>
+          <p:cNvPr id="35" name="Text 31"/>
+          <p:cNvSpPr/>
+          <p:nvPr/>
+        </p:nvSpPr>
+        <p:spPr>
+          <a:xfrm>
+            <a:off x="2788920" y="5468112"/>
+            <a:ext cx="731520" cy="192024"/>
+          </a:xfrm>
+          <a:prstGeom prst="rect">
+            <a:avLst/>
+          </a:prstGeom>
+          <a:noFill/>
+          <a:ln/>
+        </p:spPr>
+        <p:txBody>
+          <a:bodyPr wrap="square" lIns="0" tIns="0" rIns="0" bIns="0" rtlCol="0" anchor="ctr"/>
+          <a:lstStyle/>
+          <a:p>
+            <a:pPr algn="r" indent="0" marL="0">
+              <a:buNone/>
+            </a:pPr>
+            <a:r>
+              <a:rPr lang="en-US" sz="1050" dirty="0">
+                <a:solidFill>
+                  <a:srgbClr val="1A2433"/>
+                </a:solidFill>
+                <a:latin typeface="Calibri" pitchFamily="34" charset="0"/>
+                <a:ea typeface="Calibri" pitchFamily="34" charset="-122"/>
+                <a:cs typeface="Calibri" pitchFamily="34" charset="-120"/>
+              </a:rPr>
+              <a:t>48</a:t>
+            </a:r>
+            <a:endParaRPr lang="en-US" sz="1050" dirty="0"/>
+          </a:p>
+        </p:txBody>
+      </p:sp>
+      <p:sp>
+        <p:nvSpPr>
+          <p:cNvPr id="36" name="Text 32"/>
+          <p:cNvSpPr/>
+          <p:nvPr/>
+        </p:nvSpPr>
+        <p:spPr>
+          <a:xfrm>
+            <a:off x="3566160" y="5468112"/>
+            <a:ext cx="731520" cy="192024"/>
+          </a:xfrm>
+          <a:prstGeom prst="rect">
+            <a:avLst/>
+          </a:prstGeom>
+          <a:noFill/>
+          <a:ln/>
+        </p:spPr>
+        <p:txBody>
+          <a:bodyPr wrap="square" lIns="0" tIns="0" rIns="0" bIns="0" rtlCol="0" anchor="ctr"/>
+          <a:lstStyle/>
+          <a:p>
+            <a:pPr algn="r" indent="0" marL="0">
+              <a:buNone/>
+            </a:pPr>
+            <a:r>
+              <a:rPr lang="en-US" sz="1050" dirty="0">
+                <a:solidFill>
+                  <a:srgbClr val="1A2433"/>
+                </a:solidFill>
+                <a:latin typeface="Calibri" pitchFamily="34" charset="0"/>
+                <a:ea typeface="Calibri" pitchFamily="34" charset="-122"/>
+                <a:cs typeface="Calibri" pitchFamily="34" charset="-120"/>
+              </a:rPr>
+              <a:t>100%</a:t>
+            </a:r>
+            <a:endParaRPr lang="en-US" sz="1050" dirty="0"/>
+          </a:p>
+        </p:txBody>
+      </p:sp>
+      <p:sp>
+        <p:nvSpPr>
+          <p:cNvPr id="37" name="Text 33"/>
+          <p:cNvSpPr/>
+          <p:nvPr/>
+        </p:nvSpPr>
+        <p:spPr>
+          <a:xfrm>
+            <a:off x="4343400" y="5468112"/>
+            <a:ext cx="731520" cy="192024"/>
+          </a:xfrm>
+          <a:prstGeom prst="rect">
+            <a:avLst/>
+          </a:prstGeom>
+          <a:noFill/>
+          <a:ln/>
+        </p:spPr>
+        <p:txBody>
+          <a:bodyPr wrap="square" lIns="0" tIns="0" rIns="0" bIns="0" rtlCol="0" anchor="ctr"/>
+          <a:lstStyle/>
+          <a:p>
+            <a:pPr algn="r" indent="0" marL="0">
+              <a:buNone/>
+            </a:pPr>
+            <a:r>
+              <a:rPr lang="en-US" sz="1050" dirty="0">
+                <a:solidFill>
+                  <a:srgbClr val="56606E"/>
+                </a:solidFill>
+                <a:latin typeface="Calibri" pitchFamily="34" charset="0"/>
+                <a:ea typeface="Calibri" pitchFamily="34" charset="-122"/>
+                <a:cs typeface="Calibri" pitchFamily="34" charset="-120"/>
+              </a:rPr>
+              <a:t>—</a:t>
+            </a:r>
+            <a:endParaRPr lang="en-US" sz="1050" dirty="0"/>
+          </a:p>
+        </p:txBody>
+      </p:sp>
+      <p:sp>
+        <p:nvSpPr>
+          <p:cNvPr id="38" name="Text 34"/>
+          <p:cNvSpPr/>
+          <p:nvPr/>
+        </p:nvSpPr>
+        <p:spPr>
+          <a:xfrm>
+            <a:off x="5120640" y="5468112"/>
+            <a:ext cx="777240" cy="192024"/>
+          </a:xfrm>
+          <a:prstGeom prst="rect">
+            <a:avLst/>
+          </a:prstGeom>
+          <a:noFill/>
+          <a:ln/>
+        </p:spPr>
+        <p:txBody>
+          <a:bodyPr wrap="square" lIns="0" tIns="0" rIns="0" bIns="0" rtlCol="0" anchor="ctr"/>
+          <a:lstStyle/>
+          <a:p>
+            <a:pPr algn="r" indent="0" marL="0">
+              <a:buNone/>
+            </a:pPr>
+            <a:r>
+              <a:rPr lang="en-US" sz="1050" dirty="0">
+                <a:solidFill>
+                  <a:srgbClr val="56606E"/>
+                </a:solidFill>
+                <a:latin typeface="Calibri" pitchFamily="34" charset="0"/>
+                <a:ea typeface="Calibri" pitchFamily="34" charset="-122"/>
+                <a:cs typeface="Calibri" pitchFamily="34" charset="-120"/>
+              </a:rPr>
+              <a:t>—</a:t>
+            </a:r>
+            <a:endParaRPr lang="en-US" sz="1050" dirty="0"/>
+          </a:p>
+        </p:txBody>
+      </p:sp>
+      <p:sp>
+        <p:nvSpPr>
+          <p:cNvPr id="39" name="Text 35"/>
+          <p:cNvSpPr/>
+          <p:nvPr/>
+        </p:nvSpPr>
+        <p:spPr>
+          <a:xfrm>
+            <a:off x="5943600" y="5468112"/>
             <a:ext cx="914400" cy="192024"/>
           </a:xfrm>
           <a:prstGeom prst="rect">
@@ -27201,7 +27591,7 @@
               <a:buNone/>
             </a:pPr>
             <a:r>
-              <a:rPr lang="en-US" sz="1100" dirty="0">
+              <a:rPr lang="en-US" sz="1050" dirty="0">
                 <a:solidFill>
                   <a:srgbClr val="1A2433"/>
                 </a:solidFill>
@@ -27209,100 +27599,22 @@
                 <a:ea typeface="Calibri" pitchFamily="34" charset="-122"/>
                 <a:cs typeface="Calibri" pitchFamily="34" charset="-120"/>
               </a:rPr>
-              <a:t>48</a:t>
-            </a:r>
-            <a:endParaRPr lang="en-US" sz="1100" dirty="0"/>
-          </a:p>
-        </p:txBody>
-      </p:sp>
-      <p:sp>
-        <p:nvSpPr>
-          <p:cNvPr id="30" name="Text 26"/>
-          <p:cNvSpPr/>
-          <p:nvPr/>
-        </p:nvSpPr>
-        <p:spPr>
-          <a:xfrm>
-            <a:off x="4434840" y="5468112"/>
-            <a:ext cx="868680" cy="192024"/>
-          </a:xfrm>
-          <a:prstGeom prst="rect">
-            <a:avLst/>
-          </a:prstGeom>
-          <a:noFill/>
-          <a:ln/>
-        </p:spPr>
-        <p:txBody>
-          <a:bodyPr wrap="square" lIns="0" tIns="0" rIns="0" bIns="0" rtlCol="0" anchor="ctr"/>
-          <a:lstStyle/>
-          <a:p>
-            <a:pPr algn="r" indent="0" marL="0">
-              <a:buNone/>
-            </a:pPr>
-            <a:r>
-              <a:rPr lang="en-US" sz="1100" dirty="0">
-                <a:solidFill>
-                  <a:srgbClr val="56606E"/>
-                </a:solidFill>
-                <a:latin typeface="Calibri" pitchFamily="34" charset="0"/>
-                <a:ea typeface="Calibri" pitchFamily="34" charset="-122"/>
-                <a:cs typeface="Calibri" pitchFamily="34" charset="-120"/>
-              </a:rPr>
-              <a:t>—</a:t>
-            </a:r>
-            <a:endParaRPr lang="en-US" sz="1100" dirty="0"/>
-          </a:p>
-        </p:txBody>
-      </p:sp>
-      <p:sp>
-        <p:nvSpPr>
-          <p:cNvPr id="31" name="Text 27"/>
-          <p:cNvSpPr/>
-          <p:nvPr/>
-        </p:nvSpPr>
-        <p:spPr>
-          <a:xfrm>
-            <a:off x="5394960" y="5468112"/>
-            <a:ext cx="1051560" cy="192024"/>
-          </a:xfrm>
-          <a:prstGeom prst="rect">
-            <a:avLst/>
-          </a:prstGeom>
-          <a:noFill/>
-          <a:ln/>
-        </p:spPr>
-        <p:txBody>
-          <a:bodyPr wrap="square" lIns="0" tIns="0" rIns="0" bIns="0" rtlCol="0" anchor="ctr"/>
-          <a:lstStyle/>
-          <a:p>
-            <a:pPr algn="r" indent="0" marL="0">
-              <a:buNone/>
-            </a:pPr>
-            <a:r>
-              <a:rPr lang="en-US" sz="1100" dirty="0">
-                <a:solidFill>
-                  <a:srgbClr val="56606E"/>
-                </a:solidFill>
-                <a:latin typeface="Calibri" pitchFamily="34" charset="0"/>
-                <a:ea typeface="Calibri" pitchFamily="34" charset="-122"/>
-                <a:cs typeface="Calibri" pitchFamily="34" charset="-120"/>
-              </a:rPr>
-              <a:t>—</a:t>
-            </a:r>
-            <a:endParaRPr lang="en-US" sz="1100" dirty="0"/>
-          </a:p>
-        </p:txBody>
-      </p:sp>
-      <p:sp>
-        <p:nvSpPr>
-          <p:cNvPr id="32" name="Shape 28"/>
+              <a:t>179 d</a:t>
+            </a:r>
+            <a:endParaRPr lang="en-US" sz="1050" dirty="0"/>
+          </a:p>
+        </p:txBody>
+      </p:sp>
+      <p:sp>
+        <p:nvSpPr>
+          <p:cNvPr id="40" name="Shape 36"/>
           <p:cNvSpPr/>
           <p:nvPr/>
         </p:nvSpPr>
         <p:spPr>
           <a:xfrm>
             <a:off x="502920" y="5696712"/>
-            <a:ext cx="5943600" cy="0"/>
+            <a:ext cx="6355080" cy="0"/>
           </a:xfrm>
           <a:prstGeom prst="line">
             <a:avLst/>
@@ -27318,14 +27630,14 @@
       </p:sp>
       <p:sp>
         <p:nvSpPr>
-          <p:cNvPr id="33" name="Shape 29"/>
+          <p:cNvPr id="41" name="Shape 37"/>
           <p:cNvSpPr/>
           <p:nvPr/>
         </p:nvSpPr>
         <p:spPr>
           <a:xfrm>
             <a:off x="457200" y="5705856"/>
-            <a:ext cx="5989320" cy="283464"/>
+            <a:ext cx="6400800" cy="283464"/>
           </a:xfrm>
           <a:prstGeom prst="rect">
             <a:avLst/>
@@ -27338,14 +27650,14 @@
       </p:sp>
       <p:sp>
         <p:nvSpPr>
-          <p:cNvPr id="34" name="Text 30"/>
+          <p:cNvPr id="42" name="Text 38"/>
           <p:cNvSpPr/>
           <p:nvPr/>
         </p:nvSpPr>
         <p:spPr>
           <a:xfrm>
             <a:off x="502920" y="5751576"/>
-            <a:ext cx="1783080" cy="192024"/>
+            <a:ext cx="1463040" cy="192024"/>
           </a:xfrm>
           <a:prstGeom prst="rect">
             <a:avLst/>
@@ -27361,7 +27673,7 @@
               <a:buNone/>
             </a:pPr>
             <a:r>
-              <a:rPr lang="en-US" sz="1100" dirty="0">
+              <a:rPr lang="en-US" sz="1050" dirty="0">
                 <a:solidFill>
                   <a:srgbClr val="5B6B7C"/>
                 </a:solidFill>
@@ -27371,20 +27683,20 @@
               </a:rPr>
               <a:t>Sin clasificar</a:t>
             </a:r>
-            <a:endParaRPr lang="en-US" sz="1100" dirty="0"/>
-          </a:p>
-        </p:txBody>
-      </p:sp>
-      <p:sp>
-        <p:nvSpPr>
-          <p:cNvPr id="35" name="Text 31"/>
-          <p:cNvSpPr/>
-          <p:nvPr/>
-        </p:nvSpPr>
-        <p:spPr>
-          <a:xfrm>
-            <a:off x="2377440" y="5751576"/>
-            <a:ext cx="960120" cy="192024"/>
+            <a:endParaRPr lang="en-US" sz="1050" dirty="0"/>
+          </a:p>
+        </p:txBody>
+      </p:sp>
+      <p:sp>
+        <p:nvSpPr>
+          <p:cNvPr id="43" name="Text 39"/>
+          <p:cNvSpPr/>
+          <p:nvPr/>
+        </p:nvSpPr>
+        <p:spPr>
+          <a:xfrm>
+            <a:off x="2011680" y="5751576"/>
+            <a:ext cx="731520" cy="192024"/>
           </a:xfrm>
           <a:prstGeom prst="rect">
             <a:avLst/>
@@ -27400,7 +27712,7 @@
               <a:buNone/>
             </a:pPr>
             <a:r>
-              <a:rPr lang="en-US" sz="1100" dirty="0">
+              <a:rPr lang="en-US" sz="1050" dirty="0">
                 <a:solidFill>
                   <a:srgbClr val="1A2433"/>
                 </a:solidFill>
@@ -27410,19 +27722,175 @@
               </a:rPr>
               <a:t>9</a:t>
             </a:r>
-            <a:endParaRPr lang="en-US" sz="1100" dirty="0"/>
-          </a:p>
-        </p:txBody>
-      </p:sp>
-      <p:sp>
-        <p:nvSpPr>
-          <p:cNvPr id="36" name="Text 32"/>
-          <p:cNvSpPr/>
-          <p:nvPr/>
-        </p:nvSpPr>
-        <p:spPr>
-          <a:xfrm>
-            <a:off x="3429000" y="5751576"/>
+            <a:endParaRPr lang="en-US" sz="1050" dirty="0"/>
+          </a:p>
+        </p:txBody>
+      </p:sp>
+      <p:sp>
+        <p:nvSpPr>
+          <p:cNvPr id="44" name="Text 40"/>
+          <p:cNvSpPr/>
+          <p:nvPr/>
+        </p:nvSpPr>
+        <p:spPr>
+          <a:xfrm>
+            <a:off x="2788920" y="5751576"/>
+            <a:ext cx="731520" cy="192024"/>
+          </a:xfrm>
+          <a:prstGeom prst="rect">
+            <a:avLst/>
+          </a:prstGeom>
+          <a:noFill/>
+          <a:ln/>
+        </p:spPr>
+        <p:txBody>
+          <a:bodyPr wrap="square" lIns="0" tIns="0" rIns="0" bIns="0" rtlCol="0" anchor="ctr"/>
+          <a:lstStyle/>
+          <a:p>
+            <a:pPr algn="r" indent="0" marL="0">
+              <a:buNone/>
+            </a:pPr>
+            <a:r>
+              <a:rPr lang="en-US" sz="1050" dirty="0">
+                <a:solidFill>
+                  <a:srgbClr val="1A2433"/>
+                </a:solidFill>
+                <a:latin typeface="Calibri" pitchFamily="34" charset="0"/>
+                <a:ea typeface="Calibri" pitchFamily="34" charset="-122"/>
+                <a:cs typeface="Calibri" pitchFamily="34" charset="-120"/>
+              </a:rPr>
+              <a:t>9</a:t>
+            </a:r>
+            <a:endParaRPr lang="en-US" sz="1050" dirty="0"/>
+          </a:p>
+        </p:txBody>
+      </p:sp>
+      <p:sp>
+        <p:nvSpPr>
+          <p:cNvPr id="45" name="Text 41"/>
+          <p:cNvSpPr/>
+          <p:nvPr/>
+        </p:nvSpPr>
+        <p:spPr>
+          <a:xfrm>
+            <a:off x="3566160" y="5751576"/>
+            <a:ext cx="731520" cy="192024"/>
+          </a:xfrm>
+          <a:prstGeom prst="rect">
+            <a:avLst/>
+          </a:prstGeom>
+          <a:noFill/>
+          <a:ln/>
+        </p:spPr>
+        <p:txBody>
+          <a:bodyPr wrap="square" lIns="0" tIns="0" rIns="0" bIns="0" rtlCol="0" anchor="ctr"/>
+          <a:lstStyle/>
+          <a:p>
+            <a:pPr algn="r" indent="0" marL="0">
+              <a:buNone/>
+            </a:pPr>
+            <a:r>
+              <a:rPr lang="en-US" sz="1050" dirty="0">
+                <a:solidFill>
+                  <a:srgbClr val="1A2433"/>
+                </a:solidFill>
+                <a:latin typeface="Calibri" pitchFamily="34" charset="0"/>
+                <a:ea typeface="Calibri" pitchFamily="34" charset="-122"/>
+                <a:cs typeface="Calibri" pitchFamily="34" charset="-120"/>
+              </a:rPr>
+              <a:t>100%</a:t>
+            </a:r>
+            <a:endParaRPr lang="en-US" sz="1050" dirty="0"/>
+          </a:p>
+        </p:txBody>
+      </p:sp>
+      <p:sp>
+        <p:nvSpPr>
+          <p:cNvPr id="46" name="Text 42"/>
+          <p:cNvSpPr/>
+          <p:nvPr/>
+        </p:nvSpPr>
+        <p:spPr>
+          <a:xfrm>
+            <a:off x="4343400" y="5751576"/>
+            <a:ext cx="731520" cy="192024"/>
+          </a:xfrm>
+          <a:prstGeom prst="rect">
+            <a:avLst/>
+          </a:prstGeom>
+          <a:noFill/>
+          <a:ln/>
+        </p:spPr>
+        <p:txBody>
+          <a:bodyPr wrap="square" lIns="0" tIns="0" rIns="0" bIns="0" rtlCol="0" anchor="ctr"/>
+          <a:lstStyle/>
+          <a:p>
+            <a:pPr algn="r" indent="0" marL="0">
+              <a:buNone/>
+            </a:pPr>
+            <a:r>
+              <a:rPr lang="en-US" sz="1050" dirty="0">
+                <a:solidFill>
+                  <a:srgbClr val="56606E"/>
+                </a:solidFill>
+                <a:latin typeface="Calibri" pitchFamily="34" charset="0"/>
+                <a:ea typeface="Calibri" pitchFamily="34" charset="-122"/>
+                <a:cs typeface="Calibri" pitchFamily="34" charset="-120"/>
+              </a:rPr>
+              <a:t>—</a:t>
+            </a:r>
+            <a:endParaRPr lang="en-US" sz="1050" dirty="0"/>
+          </a:p>
+        </p:txBody>
+      </p:sp>
+      <p:sp>
+        <p:nvSpPr>
+          <p:cNvPr id="47" name="Text 43"/>
+          <p:cNvSpPr/>
+          <p:nvPr/>
+        </p:nvSpPr>
+        <p:spPr>
+          <a:xfrm>
+            <a:off x="5120640" y="5751576"/>
+            <a:ext cx="777240" cy="192024"/>
+          </a:xfrm>
+          <a:prstGeom prst="rect">
+            <a:avLst/>
+          </a:prstGeom>
+          <a:noFill/>
+          <a:ln/>
+        </p:spPr>
+        <p:txBody>
+          <a:bodyPr wrap="square" lIns="0" tIns="0" rIns="0" bIns="0" rtlCol="0" anchor="ctr"/>
+          <a:lstStyle/>
+          <a:p>
+            <a:pPr algn="r" indent="0" marL="0">
+              <a:buNone/>
+            </a:pPr>
+            <a:r>
+              <a:rPr lang="en-US" sz="1050" dirty="0">
+                <a:solidFill>
+                  <a:srgbClr val="56606E"/>
+                </a:solidFill>
+                <a:latin typeface="Calibri" pitchFamily="34" charset="0"/>
+                <a:ea typeface="Calibri" pitchFamily="34" charset="-122"/>
+                <a:cs typeface="Calibri" pitchFamily="34" charset="-120"/>
+              </a:rPr>
+              <a:t>—</a:t>
+            </a:r>
+            <a:endParaRPr lang="en-US" sz="1050" dirty="0"/>
+          </a:p>
+        </p:txBody>
+      </p:sp>
+      <p:sp>
+        <p:nvSpPr>
+          <p:cNvPr id="48" name="Text 44"/>
+          <p:cNvSpPr/>
+          <p:nvPr/>
+        </p:nvSpPr>
+        <p:spPr>
+          <a:xfrm>
+            <a:off x="5943600" y="5751576"/>
             <a:ext cx="914400" cy="192024"/>
           </a:xfrm>
           <a:prstGeom prst="rect">
@@ -27439,7 +27907,7 @@
               <a:buNone/>
             </a:pPr>
             <a:r>
-              <a:rPr lang="en-US" sz="1100" dirty="0">
+              <a:rPr lang="en-US" sz="1050" dirty="0">
                 <a:solidFill>
                   <a:srgbClr val="1A2433"/>
                 </a:solidFill>
@@ -27447,100 +27915,22 @@
                 <a:ea typeface="Calibri" pitchFamily="34" charset="-122"/>
                 <a:cs typeface="Calibri" pitchFamily="34" charset="-120"/>
               </a:rPr>
-              <a:t>9</a:t>
-            </a:r>
-            <a:endParaRPr lang="en-US" sz="1100" dirty="0"/>
-          </a:p>
-        </p:txBody>
-      </p:sp>
-      <p:sp>
-        <p:nvSpPr>
-          <p:cNvPr id="37" name="Text 33"/>
-          <p:cNvSpPr/>
-          <p:nvPr/>
-        </p:nvSpPr>
-        <p:spPr>
-          <a:xfrm>
-            <a:off x="4434840" y="5751576"/>
-            <a:ext cx="868680" cy="192024"/>
-          </a:xfrm>
-          <a:prstGeom prst="rect">
-            <a:avLst/>
-          </a:prstGeom>
-          <a:noFill/>
-          <a:ln/>
-        </p:spPr>
-        <p:txBody>
-          <a:bodyPr wrap="square" lIns="0" tIns="0" rIns="0" bIns="0" rtlCol="0" anchor="ctr"/>
-          <a:lstStyle/>
-          <a:p>
-            <a:pPr algn="r" indent="0" marL="0">
-              <a:buNone/>
-            </a:pPr>
-            <a:r>
-              <a:rPr lang="en-US" sz="1100" dirty="0">
-                <a:solidFill>
-                  <a:srgbClr val="56606E"/>
-                </a:solidFill>
-                <a:latin typeface="Calibri" pitchFamily="34" charset="0"/>
-                <a:ea typeface="Calibri" pitchFamily="34" charset="-122"/>
-                <a:cs typeface="Calibri" pitchFamily="34" charset="-120"/>
-              </a:rPr>
-              <a:t>—</a:t>
-            </a:r>
-            <a:endParaRPr lang="en-US" sz="1100" dirty="0"/>
-          </a:p>
-        </p:txBody>
-      </p:sp>
-      <p:sp>
-        <p:nvSpPr>
-          <p:cNvPr id="38" name="Text 34"/>
-          <p:cNvSpPr/>
-          <p:nvPr/>
-        </p:nvSpPr>
-        <p:spPr>
-          <a:xfrm>
-            <a:off x="5394960" y="5751576"/>
-            <a:ext cx="1051560" cy="192024"/>
-          </a:xfrm>
-          <a:prstGeom prst="rect">
-            <a:avLst/>
-          </a:prstGeom>
-          <a:noFill/>
-          <a:ln/>
-        </p:spPr>
-        <p:txBody>
-          <a:bodyPr wrap="square" lIns="0" tIns="0" rIns="0" bIns="0" rtlCol="0" anchor="ctr"/>
-          <a:lstStyle/>
-          <a:p>
-            <a:pPr algn="r" indent="0" marL="0">
-              <a:buNone/>
-            </a:pPr>
-            <a:r>
-              <a:rPr lang="en-US" sz="1100" dirty="0">
-                <a:solidFill>
-                  <a:srgbClr val="56606E"/>
-                </a:solidFill>
-                <a:latin typeface="Calibri" pitchFamily="34" charset="0"/>
-                <a:ea typeface="Calibri" pitchFamily="34" charset="-122"/>
-                <a:cs typeface="Calibri" pitchFamily="34" charset="-120"/>
-              </a:rPr>
-              <a:t>—</a:t>
-            </a:r>
-            <a:endParaRPr lang="en-US" sz="1100" dirty="0"/>
-          </a:p>
-        </p:txBody>
-      </p:sp>
-      <p:sp>
-        <p:nvSpPr>
-          <p:cNvPr id="39" name="Shape 35"/>
+              <a:t>64 d</a:t>
+            </a:r>
+            <a:endParaRPr lang="en-US" sz="1050" dirty="0"/>
+          </a:p>
+        </p:txBody>
+      </p:sp>
+      <p:sp>
+        <p:nvSpPr>
+          <p:cNvPr id="49" name="Shape 45"/>
           <p:cNvSpPr/>
           <p:nvPr/>
         </p:nvSpPr>
         <p:spPr>
           <a:xfrm>
             <a:off x="502920" y="5980176"/>
-            <a:ext cx="5943600" cy="0"/>
+            <a:ext cx="6355080" cy="0"/>
           </a:xfrm>
           <a:prstGeom prst="line">
             <a:avLst/>
@@ -27556,14 +27946,14 @@
       </p:sp>
       <p:sp>
         <p:nvSpPr>
-          <p:cNvPr id="40" name="Text 36"/>
+          <p:cNvPr id="50" name="Text 46"/>
           <p:cNvSpPr/>
           <p:nvPr/>
         </p:nvSpPr>
         <p:spPr>
           <a:xfrm>
             <a:off x="502920" y="6035040"/>
-            <a:ext cx="1783080" cy="192024"/>
+            <a:ext cx="1463040" cy="192024"/>
           </a:xfrm>
           <a:prstGeom prst="rect">
             <a:avLst/>
@@ -27579,7 +27969,7 @@
               <a:buNone/>
             </a:pPr>
             <a:r>
-              <a:rPr lang="en-US" sz="1100" b="1" dirty="0">
+              <a:rPr lang="en-US" sz="1050" b="1" dirty="0">
                 <a:solidFill>
                   <a:srgbClr val="1A2433"/>
                 </a:solidFill>
@@ -27589,20 +27979,20 @@
               </a:rPr>
               <a:t>Todas las vías</a:t>
             </a:r>
-            <a:endParaRPr lang="en-US" sz="1100" dirty="0"/>
-          </a:p>
-        </p:txBody>
-      </p:sp>
-      <p:sp>
-        <p:nvSpPr>
-          <p:cNvPr id="41" name="Text 37"/>
-          <p:cNvSpPr/>
-          <p:nvPr/>
-        </p:nvSpPr>
-        <p:spPr>
-          <a:xfrm>
-            <a:off x="2377440" y="6035040"/>
-            <a:ext cx="960120" cy="192024"/>
+            <a:endParaRPr lang="en-US" sz="1050" dirty="0"/>
+          </a:p>
+        </p:txBody>
+      </p:sp>
+      <p:sp>
+        <p:nvSpPr>
+          <p:cNvPr id="51" name="Text 47"/>
+          <p:cNvSpPr/>
+          <p:nvPr/>
+        </p:nvSpPr>
+        <p:spPr>
+          <a:xfrm>
+            <a:off x="2011680" y="6035040"/>
+            <a:ext cx="731520" cy="192024"/>
           </a:xfrm>
           <a:prstGeom prst="rect">
             <a:avLst/>
@@ -27618,7 +28008,7 @@
               <a:buNone/>
             </a:pPr>
             <a:r>
-              <a:rPr lang="en-US" sz="1100" b="1" dirty="0">
+              <a:rPr lang="en-US" sz="1050" b="1" dirty="0">
                 <a:solidFill>
                   <a:srgbClr val="1A2433"/>
                 </a:solidFill>
@@ -27628,19 +28018,175 @@
               </a:rPr>
               <a:t>508</a:t>
             </a:r>
-            <a:endParaRPr lang="en-US" sz="1100" dirty="0"/>
-          </a:p>
-        </p:txBody>
-      </p:sp>
-      <p:sp>
-        <p:nvSpPr>
-          <p:cNvPr id="42" name="Text 38"/>
-          <p:cNvSpPr/>
-          <p:nvPr/>
-        </p:nvSpPr>
-        <p:spPr>
-          <a:xfrm>
-            <a:off x="3429000" y="6035040"/>
+            <a:endParaRPr lang="en-US" sz="1050" dirty="0"/>
+          </a:p>
+        </p:txBody>
+      </p:sp>
+      <p:sp>
+        <p:nvSpPr>
+          <p:cNvPr id="52" name="Text 48"/>
+          <p:cNvSpPr/>
+          <p:nvPr/>
+        </p:nvSpPr>
+        <p:spPr>
+          <a:xfrm>
+            <a:off x="2788920" y="6035040"/>
+            <a:ext cx="731520" cy="192024"/>
+          </a:xfrm>
+          <a:prstGeom prst="rect">
+            <a:avLst/>
+          </a:prstGeom>
+          <a:noFill/>
+          <a:ln/>
+        </p:spPr>
+        <p:txBody>
+          <a:bodyPr wrap="square" lIns="0" tIns="0" rIns="0" bIns="0" rtlCol="0" anchor="ctr"/>
+          <a:lstStyle/>
+          <a:p>
+            <a:pPr algn="r" indent="0" marL="0">
+              <a:buNone/>
+            </a:pPr>
+            <a:r>
+              <a:rPr lang="en-US" sz="1050" b="1" dirty="0">
+                <a:solidFill>
+                  <a:srgbClr val="1A2433"/>
+                </a:solidFill>
+                <a:latin typeface="Calibri" pitchFamily="34" charset="0"/>
+                <a:ea typeface="Calibri" pitchFamily="34" charset="-122"/>
+                <a:cs typeface="Calibri" pitchFamily="34" charset="-120"/>
+              </a:rPr>
+              <a:t>454</a:t>
+            </a:r>
+            <a:endParaRPr lang="en-US" sz="1050" dirty="0"/>
+          </a:p>
+        </p:txBody>
+      </p:sp>
+      <p:sp>
+        <p:nvSpPr>
+          <p:cNvPr id="53" name="Text 49"/>
+          <p:cNvSpPr/>
+          <p:nvPr/>
+        </p:nvSpPr>
+        <p:spPr>
+          <a:xfrm>
+            <a:off x="3566160" y="6035040"/>
+            <a:ext cx="731520" cy="192024"/>
+          </a:xfrm>
+          <a:prstGeom prst="rect">
+            <a:avLst/>
+          </a:prstGeom>
+          <a:noFill/>
+          <a:ln/>
+        </p:spPr>
+        <p:txBody>
+          <a:bodyPr wrap="square" lIns="0" tIns="0" rIns="0" bIns="0" rtlCol="0" anchor="ctr"/>
+          <a:lstStyle/>
+          <a:p>
+            <a:pPr algn="r" indent="0" marL="0">
+              <a:buNone/>
+            </a:pPr>
+            <a:r>
+              <a:rPr lang="en-US" sz="1050" b="1" dirty="0">
+                <a:solidFill>
+                  <a:srgbClr val="1A2433"/>
+                </a:solidFill>
+                <a:latin typeface="Calibri" pitchFamily="34" charset="0"/>
+                <a:ea typeface="Calibri" pitchFamily="34" charset="-122"/>
+                <a:cs typeface="Calibri" pitchFamily="34" charset="-120"/>
+              </a:rPr>
+              <a:t>89,4%</a:t>
+            </a:r>
+            <a:endParaRPr lang="en-US" sz="1050" dirty="0"/>
+          </a:p>
+        </p:txBody>
+      </p:sp>
+      <p:sp>
+        <p:nvSpPr>
+          <p:cNvPr id="54" name="Text 50"/>
+          <p:cNvSpPr/>
+          <p:nvPr/>
+        </p:nvSpPr>
+        <p:spPr>
+          <a:xfrm>
+            <a:off x="4343400" y="6035040"/>
+            <a:ext cx="731520" cy="192024"/>
+          </a:xfrm>
+          <a:prstGeom prst="rect">
+            <a:avLst/>
+          </a:prstGeom>
+          <a:noFill/>
+          <a:ln/>
+        </p:spPr>
+        <p:txBody>
+          <a:bodyPr wrap="square" lIns="0" tIns="0" rIns="0" bIns="0" rtlCol="0" anchor="ctr"/>
+          <a:lstStyle/>
+          <a:p>
+            <a:pPr algn="r" indent="0" marL="0">
+              <a:buNone/>
+            </a:pPr>
+            <a:r>
+              <a:rPr lang="en-US" sz="1050" b="1" dirty="0">
+                <a:solidFill>
+                  <a:srgbClr val="C0392B"/>
+                </a:solidFill>
+                <a:latin typeface="Calibri" pitchFamily="34" charset="0"/>
+                <a:ea typeface="Calibri" pitchFamily="34" charset="-122"/>
+                <a:cs typeface="Calibri" pitchFamily="34" charset="-120"/>
+              </a:rPr>
+              <a:t>54</a:t>
+            </a:r>
+            <a:endParaRPr lang="en-US" sz="1050" dirty="0"/>
+          </a:p>
+        </p:txBody>
+      </p:sp>
+      <p:sp>
+        <p:nvSpPr>
+          <p:cNvPr id="55" name="Text 51"/>
+          <p:cNvSpPr/>
+          <p:nvPr/>
+        </p:nvSpPr>
+        <p:spPr>
+          <a:xfrm>
+            <a:off x="5120640" y="6035040"/>
+            <a:ext cx="777240" cy="192024"/>
+          </a:xfrm>
+          <a:prstGeom prst="rect">
+            <a:avLst/>
+          </a:prstGeom>
+          <a:noFill/>
+          <a:ln/>
+        </p:spPr>
+        <p:txBody>
+          <a:bodyPr wrap="square" lIns="0" tIns="0" rIns="0" bIns="0" rtlCol="0" anchor="ctr"/>
+          <a:lstStyle/>
+          <a:p>
+            <a:pPr algn="r" indent="0" marL="0">
+              <a:buNone/>
+            </a:pPr>
+            <a:r>
+              <a:rPr lang="en-US" sz="1050" b="1" dirty="0">
+                <a:solidFill>
+                  <a:srgbClr val="C0392B"/>
+                </a:solidFill>
+                <a:latin typeface="Calibri" pitchFamily="34" charset="0"/>
+                <a:ea typeface="Calibri" pitchFamily="34" charset="-122"/>
+                <a:cs typeface="Calibri" pitchFamily="34" charset="-120"/>
+              </a:rPr>
+              <a:t>51</a:t>
+            </a:r>
+            <a:endParaRPr lang="en-US" sz="1050" dirty="0"/>
+          </a:p>
+        </p:txBody>
+      </p:sp>
+      <p:sp>
+        <p:nvSpPr>
+          <p:cNvPr id="56" name="Text 52"/>
+          <p:cNvSpPr/>
+          <p:nvPr/>
+        </p:nvSpPr>
+        <p:spPr>
+          <a:xfrm>
+            <a:off x="5943600" y="6035040"/>
             <a:ext cx="914400" cy="192024"/>
           </a:xfrm>
           <a:prstGeom prst="rect">
@@ -27657,7 +28203,7 @@
               <a:buNone/>
             </a:pPr>
             <a:r>
-              <a:rPr lang="en-US" sz="1100" b="1" dirty="0">
+              <a:rPr lang="en-US" sz="1050" b="1" dirty="0">
                 <a:solidFill>
                   <a:srgbClr val="1A2433"/>
                 </a:solidFill>
@@ -27665,100 +28211,22 @@
                 <a:ea typeface="Calibri" pitchFamily="34" charset="-122"/>
                 <a:cs typeface="Calibri" pitchFamily="34" charset="-120"/>
               </a:rPr>
-              <a:t>454</a:t>
-            </a:r>
-            <a:endParaRPr lang="en-US" sz="1100" dirty="0"/>
-          </a:p>
-        </p:txBody>
-      </p:sp>
-      <p:sp>
-        <p:nvSpPr>
-          <p:cNvPr id="43" name="Text 39"/>
-          <p:cNvSpPr/>
-          <p:nvPr/>
-        </p:nvSpPr>
-        <p:spPr>
-          <a:xfrm>
-            <a:off x="4434840" y="6035040"/>
-            <a:ext cx="868680" cy="192024"/>
-          </a:xfrm>
-          <a:prstGeom prst="rect">
-            <a:avLst/>
-          </a:prstGeom>
-          <a:noFill/>
-          <a:ln/>
-        </p:spPr>
-        <p:txBody>
-          <a:bodyPr wrap="square" lIns="0" tIns="0" rIns="0" bIns="0" rtlCol="0" anchor="ctr"/>
-          <a:lstStyle/>
-          <a:p>
-            <a:pPr algn="r" indent="0" marL="0">
-              <a:buNone/>
-            </a:pPr>
-            <a:r>
-              <a:rPr lang="en-US" sz="1100" b="1" dirty="0">
-                <a:solidFill>
-                  <a:srgbClr val="C0392B"/>
-                </a:solidFill>
-                <a:latin typeface="Calibri" pitchFamily="34" charset="0"/>
-                <a:ea typeface="Calibri" pitchFamily="34" charset="-122"/>
-                <a:cs typeface="Calibri" pitchFamily="34" charset="-120"/>
-              </a:rPr>
-              <a:t>54</a:t>
-            </a:r>
-            <a:endParaRPr lang="en-US" sz="1100" dirty="0"/>
-          </a:p>
-        </p:txBody>
-      </p:sp>
-      <p:sp>
-        <p:nvSpPr>
-          <p:cNvPr id="44" name="Text 40"/>
-          <p:cNvSpPr/>
-          <p:nvPr/>
-        </p:nvSpPr>
-        <p:spPr>
-          <a:xfrm>
-            <a:off x="5394960" y="6035040"/>
-            <a:ext cx="1051560" cy="192024"/>
-          </a:xfrm>
-          <a:prstGeom prst="rect">
-            <a:avLst/>
-          </a:prstGeom>
-          <a:noFill/>
-          <a:ln/>
-        </p:spPr>
-        <p:txBody>
-          <a:bodyPr wrap="square" lIns="0" tIns="0" rIns="0" bIns="0" rtlCol="0" anchor="ctr"/>
-          <a:lstStyle/>
-          <a:p>
-            <a:pPr algn="r" indent="0" marL="0">
-              <a:buNone/>
-            </a:pPr>
-            <a:r>
-              <a:rPr lang="en-US" sz="1100" b="1" dirty="0">
-                <a:solidFill>
-                  <a:srgbClr val="1A2433"/>
-                </a:solidFill>
-                <a:latin typeface="Calibri" pitchFamily="34" charset="0"/>
-                <a:ea typeface="Calibri" pitchFamily="34" charset="-122"/>
-                <a:cs typeface="Calibri" pitchFamily="34" charset="-120"/>
-              </a:rPr>
-              <a:t>139 d</a:t>
-            </a:r>
-            <a:endParaRPr lang="en-US" sz="1100" dirty="0"/>
-          </a:p>
-        </p:txBody>
-      </p:sp>
-      <p:sp>
-        <p:nvSpPr>
-          <p:cNvPr id="45" name="Shape 41"/>
+              <a:t>69 d</a:t>
+            </a:r>
+            <a:endParaRPr lang="en-US" sz="1050" dirty="0"/>
+          </a:p>
+        </p:txBody>
+      </p:sp>
+      <p:sp>
+        <p:nvSpPr>
+          <p:cNvPr id="57" name="Shape 53"/>
           <p:cNvSpPr/>
           <p:nvPr/>
         </p:nvSpPr>
         <p:spPr>
           <a:xfrm>
             <a:off x="502920" y="6263640"/>
-            <a:ext cx="5943600" cy="0"/>
+            <a:ext cx="6355080" cy="0"/>
           </a:xfrm>
           <a:prstGeom prst="line">
             <a:avLst/>
@@ -27774,7 +28242,7 @@
       </p:sp>
       <p:graphicFrame>
         <p:nvGraphicFramePr>
-          <p:cNvPr id="46" name="Chart 1" descr=""/>
+          <p:cNvPr id="58" name="Chart 1" descr=""/>
           <p:cNvGraphicFramePr/>
           <p:nvPr/>
         </p:nvGraphicFramePr>
@@ -27790,7 +28258,7 @@
       </p:graphicFrame>
       <p:sp>
         <p:nvSpPr>
-          <p:cNvPr id="47" name="Shape 42"/>
+          <p:cNvPr id="59" name="Shape 54"/>
           <p:cNvSpPr/>
           <p:nvPr/>
         </p:nvSpPr>
@@ -27812,7 +28280,7 @@
       </p:sp>
       <p:sp>
         <p:nvSpPr>
-          <p:cNvPr id="48" name="Text 43"/>
+          <p:cNvPr id="60" name="Text 55"/>
           <p:cNvSpPr/>
           <p:nvPr/>
         </p:nvSpPr>
@@ -27851,7 +28319,7 @@
       </p:sp>
       <p:sp>
         <p:nvSpPr>
-          <p:cNvPr id="49" name="Text 44"/>
+          <p:cNvPr id="61" name="Text 56"/>
           <p:cNvSpPr/>
           <p:nvPr/>
         </p:nvSpPr>
@@ -27890,7 +28358,7 @@
       </p:sp>
       <p:sp>
         <p:nvSpPr>
-          <p:cNvPr id="50" name="Text 45"/>
+          <p:cNvPr id="62" name="Text 57"/>
           <p:cNvSpPr/>
           <p:nvPr/>
         </p:nvSpPr>
@@ -27929,7 +28397,7 @@
       </p:sp>
       <p:sp>
         <p:nvSpPr>
-          <p:cNvPr id="51" name="Text 46"/>
+          <p:cNvPr id="63" name="Text 58"/>
           <p:cNvSpPr/>
           <p:nvPr/>
         </p:nvSpPr>
@@ -27968,7 +28436,7 @@
       </p:sp>
       <p:sp>
         <p:nvSpPr>
-          <p:cNvPr id="52" name="Text 47"/>
+          <p:cNvPr id="64" name="Text 59"/>
           <p:cNvSpPr/>
           <p:nvPr/>
         </p:nvSpPr>
@@ -28007,7 +28475,7 @@
       </p:sp>
       <p:sp>
         <p:nvSpPr>
-          <p:cNvPr id="53" name="Text 48"/>
+          <p:cNvPr id="65" name="Text 60"/>
           <p:cNvSpPr/>
           <p:nvPr/>
         </p:nvSpPr>
@@ -28046,7 +28514,7 @@
       </p:sp>
       <p:sp>
         <p:nvSpPr>
-          <p:cNvPr id="54" name="Text 49"/>
+          <p:cNvPr id="66" name="Text 61"/>
           <p:cNvSpPr/>
           <p:nvPr/>
         </p:nvSpPr>
@@ -28085,7 +28553,7 @@
       </p:sp>
       <p:sp>
         <p:nvSpPr>
-          <p:cNvPr id="55" name="Text 50"/>
+          <p:cNvPr id="67" name="Text 62"/>
           <p:cNvSpPr/>
           <p:nvPr/>
         </p:nvSpPr>
@@ -28124,7 +28592,7 @@
       </p:sp>
       <p:sp>
         <p:nvSpPr>
-          <p:cNvPr id="56" name="Text 51"/>
+          <p:cNvPr id="68" name="Text 63"/>
           <p:cNvSpPr/>
           <p:nvPr/>
         </p:nvSpPr>
@@ -28163,7 +28631,7 @@
       </p:sp>
       <p:sp>
         <p:nvSpPr>
-          <p:cNvPr id="57" name="Text 52"/>
+          <p:cNvPr id="69" name="Text 64"/>
           <p:cNvSpPr/>
           <p:nvPr/>
         </p:nvSpPr>

</xml_diff>

<commit_message>
NC: compactar la columna de promedio de respuesta
«Tiempo promedio de respuesta» pasa a «Promedio en respuesta» en dos
líneas, y el valor lleva la unidad completa (128 días, no 128 d). La
tabla usa .tbl.compacta —6 px de aire por celda en vez de 10— porque
comparte fila con «Estado de cierre»: entre el rótulo corto y el padding
la tabla bajó de 771 a 705 px y entra completa desde ~1.900 px de ancho.

Co-Authored-By: Claude Opus 5 <noreply@anthropic.com>
Claude-Session: https://claude.ai/code/session_011SHyPcub1TtjA2kTAsaPFu
</commit_message>
<xml_diff>
--- a/modulo_nc/Panel_No_Conformidades.pptx
+++ b/modulo_nc/Panel_No_Conformidades.pptx
@@ -26418,7 +26418,7 @@
                 <a:ea typeface="Calibri" pitchFamily="34" charset="-122"/>
                 <a:cs typeface="Calibri" pitchFamily="34" charset="-120"/>
               </a:rPr>
-              <a:t>ESTADO DE CADA VÍA  ·  atrasada = abierta que pasó los 10 días de plazo  ·  T. respuesta = días de emisión a cierre, solo sobre las cerradas</a:t>
+              <a:t>ESTADO DE CADA VÍA  ·  atrasada = abierta que pasó los 10 días de plazo  ·  promedio en respuesta = días de emisión a cierre, solo sobre las cerradas</a:t>
             </a:r>
             <a:endParaRPr lang="en-US" sz="900" dirty="0"/>
           </a:p>
@@ -26666,8 +26666,8 @@
         </p:nvSpPr>
         <p:spPr>
           <a:xfrm>
-            <a:off x="5943600" y="4462272"/>
-            <a:ext cx="914400" cy="274320"/>
+            <a:off x="5806440" y="4462272"/>
+            <a:ext cx="1051560" cy="274320"/>
           </a:xfrm>
           <a:prstGeom prst="rect">
             <a:avLst/>
@@ -26691,7 +26691,7 @@
                 <a:ea typeface="Calibri" pitchFamily="34" charset="-122"/>
                 <a:cs typeface="Calibri" pitchFamily="34" charset="-120"/>
               </a:rPr>
-              <a:t>T. RESPUESTA</a:t>
+              <a:t>PROM. RESPUESTA</a:t>
             </a:r>
             <a:endParaRPr lang="en-US" sz="950" dirty="0"/>
           </a:p>
@@ -26962,8 +26962,8 @@
         </p:nvSpPr>
         <p:spPr>
           <a:xfrm>
-            <a:off x="5943600" y="4901184"/>
-            <a:ext cx="914400" cy="192024"/>
+            <a:off x="5806440" y="4901184"/>
+            <a:ext cx="1051560" cy="192024"/>
           </a:xfrm>
           <a:prstGeom prst="rect">
             <a:avLst/>
@@ -26987,7 +26987,7 @@
                 <a:ea typeface="Calibri" pitchFamily="34" charset="-122"/>
                 <a:cs typeface="Calibri" pitchFamily="34" charset="-120"/>
               </a:rPr>
-              <a:t>65 d</a:t>
+              <a:t>65 días</a:t>
             </a:r>
             <a:endParaRPr lang="en-US" sz="1050" dirty="0"/>
           </a:p>
@@ -27278,8 +27278,8 @@
         </p:nvSpPr>
         <p:spPr>
           <a:xfrm>
-            <a:off x="5943600" y="5184648"/>
-            <a:ext cx="914400" cy="192024"/>
+            <a:off x="5806440" y="5184648"/>
+            <a:ext cx="1051560" cy="192024"/>
           </a:xfrm>
           <a:prstGeom prst="rect">
             <a:avLst/>
@@ -27303,7 +27303,7 @@
                 <a:ea typeface="Calibri" pitchFamily="34" charset="-122"/>
                 <a:cs typeface="Calibri" pitchFamily="34" charset="-120"/>
               </a:rPr>
-              <a:t>49 d</a:t>
+              <a:t>49 días</a:t>
             </a:r>
             <a:endParaRPr lang="en-US" sz="1050" dirty="0"/>
           </a:p>
@@ -27574,8 +27574,8 @@
         </p:nvSpPr>
         <p:spPr>
           <a:xfrm>
-            <a:off x="5943600" y="5468112"/>
-            <a:ext cx="914400" cy="192024"/>
+            <a:off x="5806440" y="5468112"/>
+            <a:ext cx="1051560" cy="192024"/>
           </a:xfrm>
           <a:prstGeom prst="rect">
             <a:avLst/>
@@ -27599,7 +27599,7 @@
                 <a:ea typeface="Calibri" pitchFamily="34" charset="-122"/>
                 <a:cs typeface="Calibri" pitchFamily="34" charset="-120"/>
               </a:rPr>
-              <a:t>179 d</a:t>
+              <a:t>179 días</a:t>
             </a:r>
             <a:endParaRPr lang="en-US" sz="1050" dirty="0"/>
           </a:p>
@@ -27890,8 +27890,8 @@
         </p:nvSpPr>
         <p:spPr>
           <a:xfrm>
-            <a:off x="5943600" y="5751576"/>
-            <a:ext cx="914400" cy="192024"/>
+            <a:off x="5806440" y="5751576"/>
+            <a:ext cx="1051560" cy="192024"/>
           </a:xfrm>
           <a:prstGeom prst="rect">
             <a:avLst/>
@@ -27915,7 +27915,7 @@
                 <a:ea typeface="Calibri" pitchFamily="34" charset="-122"/>
                 <a:cs typeface="Calibri" pitchFamily="34" charset="-120"/>
               </a:rPr>
-              <a:t>64 d</a:t>
+              <a:t>64 días</a:t>
             </a:r>
             <a:endParaRPr lang="en-US" sz="1050" dirty="0"/>
           </a:p>
@@ -28186,8 +28186,8 @@
         </p:nvSpPr>
         <p:spPr>
           <a:xfrm>
-            <a:off x="5943600" y="6035040"/>
-            <a:ext cx="914400" cy="192024"/>
+            <a:off x="5806440" y="6035040"/>
+            <a:ext cx="1051560" cy="192024"/>
           </a:xfrm>
           <a:prstGeom prst="rect">
             <a:avLst/>
@@ -28211,7 +28211,7 @@
                 <a:ea typeface="Calibri" pitchFamily="34" charset="-122"/>
                 <a:cs typeface="Calibri" pitchFamily="34" charset="-120"/>
               </a:rPr>
-              <a:t>69 d</a:t>
+              <a:t>69 días</a:t>
             </a:r>
             <a:endParaRPr lang="en-US" sz="1050" dirty="0"/>
           </a:p>

</xml_diff>

<commit_message>
NC: dejar fuera las opciones de mejora
No son hallazgos que haya que corregir, son propuestas: sumarlas infla
el universo y ensucia el % de cierre con algo que nadie está obligado a
cerrar. Se filtran en el origen —en las dos fuentes—, así que ninguna
vista, ni la PPT, ni la suite las cuentan.

508 registros en el Excel → 494 en el módulo. Quedan fuera 14: 13 de
Desaladora y 1 de Talabre, de las que solo 1 seguía abierta. Desaladora
pasa de 95 a 82 levantadas y de 96,8% a 97,6% de cierre; el consolidado,
de 89,4% a 89,3% y de 54 a 53 abiertas.

No se descartan en silencio: «Control de calidad del dato» declara el
contraste 508 → 494 con el motivo, las notas al pie lo repiten y el
script lo informa en sus avisos. La constante es TIPOS_EXCLUIDOS; para
volver a incluirlas basta vaciarla.

Co-Authored-By: Claude Opus 5 <noreply@anthropic.com>
Claude-Session: https://claude.ai/code/session_011SHyPcub1TtjA2kTAsaPFu
</commit_message>
<xml_diff>
--- a/modulo_nc/Panel_No_Conformidades.pptx
+++ b/modulo_nc/Panel_No_Conformidades.pptx
@@ -247,7 +247,7 @@
                   <c:v>3</c:v>
                 </c:pt>
                 <c:pt idx="1">
-                  <c:v>2</c:v>
+                  <c:v>1</c:v>
                 </c:pt>
                 <c:pt idx="2">
                   <c:v>1</c:v>
@@ -640,10 +640,10 @@
                 <c:formatCode>General</c:formatCode>
                 <c:ptCount val="4"/>
                 <c:pt idx="0">
-                  <c:v>56</c:v>
+                  <c:v>54</c:v>
                 </c:pt>
                 <c:pt idx="1">
-                  <c:v>53</c:v>
+                  <c:v>52</c:v>
                 </c:pt>
                 <c:pt idx="2">
                   <c:v>53</c:v>
@@ -730,7 +730,7 @@
                 <c:formatCode>General</c:formatCode>
                 <c:ptCount val="4"/>
                 <c:pt idx="0">
-                  <c:v>30</c:v>
+                  <c:v>19</c:v>
                 </c:pt>
                 <c:pt idx="1">
                   <c:v>188</c:v>
@@ -1171,9 +1171,9 @@
           </c:dLbls>
           <c:cat>
             <c:multiLvlStrRef>
-              <c:f>Sheet1!$A$2:$A$6</c:f>
+              <c:f>Sheet1!$A$2:$A$5</c:f>
               <c:multiLvlStrCache>
-                <c:ptCount val="5"/>
+                <c:ptCount val="4"/>
                 <c:lvl>
                   <c:pt idx="0">
                     <c:v>No Conformidad</c:v>
@@ -1185,9 +1185,6 @@
                     <c:v>Observación</c:v>
                   </c:pt>
                   <c:pt idx="3">
-                    <c:v>Opción de Mejora</c:v>
-                  </c:pt>
-                  <c:pt idx="4">
                     <c:v>Reporte HSE Nivel Alto</c:v>
                   </c:pt>
                 </c:lvl>
@@ -1196,10 +1193,10 @@
           </c:cat>
           <c:val>
             <c:numRef>
-              <c:f>Sheet1!$B$2:$B$6</c:f>
+              <c:f>Sheet1!$B$2:$B$5</c:f>
               <c:numCache>
                 <c:formatCode>General</c:formatCode>
-                <c:ptCount val="5"/>
+                <c:ptCount val="4"/>
                 <c:pt idx="0">
                   <c:v>279</c:v>
                 </c:pt>
@@ -1210,9 +1207,6 @@
                   <c:v>45</c:v>
                 </c:pt>
                 <c:pt idx="3">
-                  <c:v>13</c:v>
-                </c:pt>
-                <c:pt idx="4">
                   <c:v>1</c:v>
                 </c:pt>
               </c:numCache>
@@ -1267,9 +1261,9 @@
           </c:dLbls>
           <c:cat>
             <c:multiLvlStrRef>
-              <c:f>Sheet1!$A$2:$A$6</c:f>
+              <c:f>Sheet1!$A$2:$A$5</c:f>
               <c:multiLvlStrCache>
-                <c:ptCount val="5"/>
+                <c:ptCount val="4"/>
                 <c:lvl>
                   <c:pt idx="0">
                     <c:v>No Conformidad</c:v>
@@ -1281,9 +1275,6 @@
                     <c:v>Observación</c:v>
                   </c:pt>
                   <c:pt idx="3">
-                    <c:v>Opción de Mejora</c:v>
-                  </c:pt>
-                  <c:pt idx="4">
                     <c:v>Reporte HSE Nivel Alto</c:v>
                   </c:pt>
                 </c:lvl>
@@ -1292,10 +1283,10 @@
           </c:cat>
           <c:val>
             <c:numRef>
-              <c:f>Sheet1!$C$2:$C$6</c:f>
+              <c:f>Sheet1!$C$2:$C$5</c:f>
               <c:numCache>
                 <c:formatCode>General</c:formatCode>
-                <c:ptCount val="5"/>
+                <c:ptCount val="4"/>
                 <c:pt idx="0">
                   <c:v>34</c:v>
                 </c:pt>
@@ -1306,9 +1297,6 @@
                   <c:v>15</c:v>
                 </c:pt>
                 <c:pt idx="3">
-                  <c:v>1</c:v>
-                </c:pt>
-                <c:pt idx="4">
                   <c:v/>
                 </c:pt>
               </c:numCache>
@@ -1498,7 +1486,7 @@
                 </a:solidFill>
                 <a:latin typeface="Calibri"/>
               </a:rPr>
-              <a:t>Antigüedad de los 54 hallazgos abiertos</a:t>
+              <a:t>Antigüedad de los 53 hallazgos abiertos</a:t>
             </a:r>
           </a:p>
         </c:rich>
@@ -1579,7 +1567,7 @@
                 <c:formatCode>General</c:formatCode>
                 <c:ptCount val="1"/>
                 <c:pt idx="0">
-                  <c:v>7</c:v>
+                  <c:v>6</c:v>
                 </c:pt>
               </c:numCache>
             </c:numRef>
@@ -2127,10 +2115,10 @@
                     <c:v>ELÉCTRICA</c:v>
                   </c:pt>
                   <c:pt idx="1">
-                    <c:v>OO.CC</c:v>
+                    <c:v>ADMINISTRACIÓN</c:v>
                   </c:pt>
                   <c:pt idx="2">
-                    <c:v>ADMINISTRACIÓN</c:v>
+                    <c:v>OO.CC</c:v>
                   </c:pt>
                   <c:pt idx="3">
                     <c:v>RRLL</c:v>
@@ -2145,7 +2133,7 @@
                     <c:v>LOGÍSTICA</c:v>
                   </c:pt>
                   <c:pt idx="7">
-                    <c:v>ESTRUCTURA</c:v>
+                    <c:v>ADQUISICIONES</c:v>
                   </c:pt>
                 </c:lvl>
               </c:multiLvlStrCache>
@@ -2158,28 +2146,28 @@
                 <c:formatCode>General</c:formatCode>
                 <c:ptCount val="8"/>
                 <c:pt idx="0">
-                  <c:v>20</c:v>
+                  <c:v>15</c:v>
                 </c:pt>
                 <c:pt idx="1">
                   <c:v>12</c:v>
                 </c:pt>
                 <c:pt idx="2">
-                  <c:v>12</c:v>
+                  <c:v>10</c:v>
                 </c:pt>
                 <c:pt idx="3">
                   <c:v>10</c:v>
                 </c:pt>
                 <c:pt idx="4">
-                  <c:v>9</c:v>
+                  <c:v>7</c:v>
                 </c:pt>
                 <c:pt idx="5">
-                  <c:v>5</c:v>
+                  <c:v>4</c:v>
                 </c:pt>
                 <c:pt idx="6">
                   <c:v>4</c:v>
                 </c:pt>
                 <c:pt idx="7">
-                  <c:v>2</c:v>
+                  <c:v>3</c:v>
                 </c:pt>
               </c:numCache>
             </c:numRef>
@@ -2241,10 +2229,10 @@
                     <c:v>ELÉCTRICA</c:v>
                   </c:pt>
                   <c:pt idx="1">
-                    <c:v>OO.CC</c:v>
+                    <c:v>ADMINISTRACIÓN</c:v>
                   </c:pt>
                   <c:pt idx="2">
-                    <c:v>ADMINISTRACIÓN</c:v>
+                    <c:v>OO.CC</c:v>
                   </c:pt>
                   <c:pt idx="3">
                     <c:v>RRLL</c:v>
@@ -2259,7 +2247,7 @@
                     <c:v>LOGÍSTICA</c:v>
                   </c:pt>
                   <c:pt idx="7">
-                    <c:v>ESTRUCTURA</c:v>
+                    <c:v>ADQUISICIONES</c:v>
                   </c:pt>
                 </c:lvl>
               </c:multiLvlStrCache>
@@ -2293,7 +2281,7 @@
                   <c:v/>
                 </c:pt>
                 <c:pt idx="7">
-                  <c:v>1</c:v>
+                  <c:v/>
                 </c:pt>
               </c:numCache>
             </c:numRef>
@@ -2590,7 +2578,7 @@
                   <c:v>23</c:v>
                 </c:pt>
                 <c:pt idx="2">
-                  <c:v>16</c:v>
+                  <c:v>15</c:v>
                 </c:pt>
                 <c:pt idx="3">
                   <c:v>11</c:v>
@@ -2991,10 +2979,10 @@
                     <c:v>SUBCONTRATO</c:v>
                   </c:pt>
                   <c:pt idx="5">
-                    <c:v>ESTRUCTURA</c:v>
+                    <c:v>TOPOGRAFÍA</c:v>
                   </c:pt>
                   <c:pt idx="6">
-                    <c:v>TOPOGRAFÍA</c:v>
+                    <c:v>ESTRUCTURA</c:v>
                   </c:pt>
                   <c:pt idx="7">
                     <c:v>MECÁNICA</c:v>
@@ -3105,10 +3093,10 @@
                     <c:v>SUBCONTRATO</c:v>
                   </c:pt>
                   <c:pt idx="5">
-                    <c:v>ESTRUCTURA</c:v>
+                    <c:v>TOPOGRAFÍA</c:v>
                   </c:pt>
                   <c:pt idx="6">
-                    <c:v>TOPOGRAFÍA</c:v>
+                    <c:v>ESTRUCTURA</c:v>
                   </c:pt>
                   <c:pt idx="7">
                     <c:v>MECÁNICA</c:v>
@@ -5633,7 +5621,7 @@
                 <a:ea typeface="Calibri" pitchFamily="34" charset="-122"/>
                 <a:cs typeface="Calibri" pitchFamily="34" charset="-120"/>
               </a:rPr>
-              <a:t>508 hallazgos levantados entre 10-02-2023 y 28-07-2026 (Desaladora 95 · Talabre 241 · Arqueros 164 · Oficina Central 8).</a:t>
+              <a:t>494 hallazgos levantados entre 10-02-2023 y 28-07-2026 (Desaladora 82 · Talabre 240 · Arqueros 164 · Oficina Central 8).</a:t>
             </a:r>
             <a:endParaRPr lang="en-US" sz="1350" dirty="0"/>
           </a:p>
@@ -5692,7 +5680,7 @@
                 <a:ea typeface="Cambria" pitchFamily="34" charset="-122"/>
                 <a:cs typeface="Cambria" pitchFamily="34" charset="-120"/>
               </a:rPr>
-              <a:t>89,4%</a:t>
+              <a:t>89,3%</a:t>
             </a:r>
             <a:endParaRPr lang="en-US" sz="3400" dirty="0"/>
           </a:p>
@@ -5770,7 +5758,7 @@
                 <a:ea typeface="Cambria" pitchFamily="34" charset="-122"/>
                 <a:cs typeface="Cambria" pitchFamily="34" charset="-120"/>
               </a:rPr>
-              <a:t>54</a:t>
+              <a:t>53</a:t>
             </a:r>
             <a:endParaRPr lang="en-US" sz="3400" dirty="0"/>
           </a:p>
@@ -5926,7 +5914,7 @@
                 <a:ea typeface="Cambria" pitchFamily="34" charset="-122"/>
                 <a:cs typeface="Cambria" pitchFamily="34" charset="-120"/>
               </a:rPr>
-              <a:t>10.783</a:t>
+              <a:t>10.613</a:t>
             </a:r>
             <a:endParaRPr lang="en-US" sz="3400" dirty="0"/>
           </a:p>
@@ -6043,7 +6031,7 @@
                 <a:ea typeface="Calibri" pitchFamily="34" charset="-122"/>
                 <a:cs typeface="Calibri" pitchFamily="34" charset="-120"/>
               </a:rPr>
-              <a:t>Fuente: Data_NCR_10082026.xlsx — hoja «Observaciones» · Corte 03-08-2026 · 508 registros desde 10-02-2023</a:t>
+              <a:t>Fuente: 1e73482e-Data_NCR03082026.xlsx — hoja «Observaciones» · Corte 03-08-2026 · 494 registros desde 10-02-2023</a:t>
             </a:r>
             <a:endParaRPr lang="en-US" sz="850" dirty="0"/>
           </a:p>
@@ -6255,7 +6243,7 @@
                 <a:ea typeface="Calibri" pitchFamily="34" charset="-122"/>
                 <a:cs typeface="Calibri" pitchFamily="34" charset="-120"/>
               </a:rPr>
-              <a:t>3 hallazgos siguen abiertos; 0 con más de 180 días. Se listan del más antiguo al más reciente.</a:t>
+              <a:t>2 hallazgos siguen abiertos; 0 con más de 180 días. Se listan del más antiguo al más reciente.</a:t>
             </a:r>
             <a:endParaRPr lang="en-US" sz="1350" dirty="0"/>
           </a:p>
@@ -6984,7 +6972,7 @@
                 <a:ea typeface="Calibri" pitchFamily="34" charset="-122"/>
                 <a:cs typeface="Calibri" pitchFamily="34" charset="-120"/>
               </a:rPr>
-              <a:t>94</a:t>
+              <a:t>95</a:t>
             </a:r>
             <a:endParaRPr lang="en-US" sz="1050" dirty="0"/>
           </a:p>
@@ -7023,7 +7011,7 @@
                 <a:ea typeface="Calibri" pitchFamily="34" charset="-122"/>
                 <a:cs typeface="Calibri" pitchFamily="34" charset="-120"/>
               </a:rPr>
-              <a:t>Opción de Mejora</a:t>
+              <a:t>No Conformidad</a:t>
             </a:r>
             <a:endParaRPr lang="en-US" sz="1050" dirty="0"/>
           </a:p>
@@ -7101,7 +7089,7 @@
                 <a:ea typeface="Calibri" pitchFamily="34" charset="-122"/>
                 <a:cs typeface="Calibri" pitchFamily="34" charset="-120"/>
               </a:rPr>
-              <a:t>ESTRUCTURA</a:t>
+              <a:t>MECÁNICA</a:t>
             </a:r>
             <a:endParaRPr lang="en-US" sz="1050" dirty="0"/>
           </a:p>
@@ -7140,7 +7128,7 @@
                 <a:ea typeface="Calibri" pitchFamily="34" charset="-122"/>
                 <a:cs typeface="Calibri" pitchFamily="34" charset="-120"/>
               </a:rPr>
-              <a:t>Cristián Ellmen M.</a:t>
+              <a:t>Wilson Jara</a:t>
             </a:r>
             <a:endParaRPr lang="en-US" sz="1050" dirty="0"/>
           </a:p>
@@ -7218,7 +7206,7 @@
                 <a:ea typeface="Calibri" pitchFamily="34" charset="-122"/>
                 <a:cs typeface="Calibri" pitchFamily="34" charset="-120"/>
               </a:rPr>
-              <a:t>28</a:t>
+              <a:t>7</a:t>
             </a:r>
             <a:endParaRPr lang="en-US" sz="1050" dirty="0"/>
           </a:p>
@@ -7257,7 +7245,7 @@
                 <a:ea typeface="Calibri" pitchFamily="34" charset="-122"/>
                 <a:cs typeface="Calibri" pitchFamily="34" charset="-120"/>
               </a:rPr>
-              <a:t>Construcción Bodega de  Almacenamie…</a:t>
+              <a:t>Verificación de Preservación</a:t>
             </a:r>
             <a:endParaRPr lang="en-US" sz="1000" dirty="0"/>
           </a:p>
@@ -7288,342 +7276,7 @@
       </p:sp>
       <p:sp>
         <p:nvSpPr>
-          <p:cNvPr id="34" name="Text 31"/>
-          <p:cNvSpPr/>
-          <p:nvPr/>
-        </p:nvSpPr>
-        <p:spPr>
-          <a:xfrm>
-            <a:off x="502920" y="3008376"/>
-            <a:ext cx="822960" cy="256032"/>
-          </a:xfrm>
-          <a:prstGeom prst="rect">
-            <a:avLst/>
-          </a:prstGeom>
-          <a:noFill/>
-          <a:ln/>
-        </p:spPr>
-        <p:txBody>
-          <a:bodyPr wrap="square" lIns="0" tIns="0" rIns="0" bIns="0" rtlCol="0" anchor="ctr"/>
-          <a:lstStyle/>
-          <a:p>
-            <a:pPr algn="l" indent="0" marL="0">
-              <a:buNone/>
-            </a:pPr>
-            <a:r>
-              <a:rPr lang="en-US" sz="1050" dirty="0">
-                <a:solidFill>
-                  <a:srgbClr val="1A2433"/>
-                </a:solidFill>
-                <a:latin typeface="Calibri" pitchFamily="34" charset="0"/>
-                <a:ea typeface="Calibri" pitchFamily="34" charset="-122"/>
-                <a:cs typeface="Calibri" pitchFamily="34" charset="-120"/>
-              </a:rPr>
-              <a:t>95</a:t>
-            </a:r>
-            <a:endParaRPr lang="en-US" sz="1050" dirty="0"/>
-          </a:p>
-        </p:txBody>
-      </p:sp>
-      <p:sp>
-        <p:nvSpPr>
-          <p:cNvPr id="35" name="Text 32"/>
-          <p:cNvSpPr/>
-          <p:nvPr/>
-        </p:nvSpPr>
-        <p:spPr>
-          <a:xfrm>
-            <a:off x="1371600" y="3008376"/>
-            <a:ext cx="1508760" cy="256032"/>
-          </a:xfrm>
-          <a:prstGeom prst="rect">
-            <a:avLst/>
-          </a:prstGeom>
-          <a:noFill/>
-          <a:ln/>
-        </p:spPr>
-        <p:txBody>
-          <a:bodyPr wrap="square" lIns="0" tIns="0" rIns="0" bIns="0" rtlCol="0" anchor="ctr"/>
-          <a:lstStyle/>
-          <a:p>
-            <a:pPr algn="l" indent="0" marL="0">
-              <a:buNone/>
-            </a:pPr>
-            <a:r>
-              <a:rPr lang="en-US" sz="1050" dirty="0">
-                <a:solidFill>
-                  <a:srgbClr val="1A2433"/>
-                </a:solidFill>
-                <a:latin typeface="Calibri" pitchFamily="34" charset="0"/>
-                <a:ea typeface="Calibri" pitchFamily="34" charset="-122"/>
-                <a:cs typeface="Calibri" pitchFamily="34" charset="-120"/>
-              </a:rPr>
-              <a:t>No Conformidad</a:t>
-            </a:r>
-            <a:endParaRPr lang="en-US" sz="1050" dirty="0"/>
-          </a:p>
-        </p:txBody>
-      </p:sp>
-      <p:sp>
-        <p:nvSpPr>
-          <p:cNvPr id="36" name="Text 33"/>
-          <p:cNvSpPr/>
-          <p:nvPr/>
-        </p:nvSpPr>
-        <p:spPr>
-          <a:xfrm>
-            <a:off x="2926080" y="3008376"/>
-            <a:ext cx="1463040" cy="256032"/>
-          </a:xfrm>
-          <a:prstGeom prst="rect">
-            <a:avLst/>
-          </a:prstGeom>
-          <a:noFill/>
-          <a:ln/>
-        </p:spPr>
-        <p:txBody>
-          <a:bodyPr wrap="square" lIns="0" tIns="0" rIns="0" bIns="0" rtlCol="0" anchor="ctr"/>
-          <a:lstStyle/>
-          <a:p>
-            <a:pPr algn="l" indent="0" marL="0">
-              <a:buNone/>
-            </a:pPr>
-            <a:r>
-              <a:rPr lang="en-US" sz="1050" b="1" dirty="0">
-                <a:solidFill>
-                  <a:srgbClr val="C87A32"/>
-                </a:solidFill>
-                <a:latin typeface="Calibri" pitchFamily="34" charset="0"/>
-                <a:ea typeface="Calibri" pitchFamily="34" charset="-122"/>
-                <a:cs typeface="Calibri" pitchFamily="34" charset="-120"/>
-              </a:rPr>
-              <a:t>Externa · Cliente</a:t>
-            </a:r>
-            <a:endParaRPr lang="en-US" sz="1050" dirty="0"/>
-          </a:p>
-        </p:txBody>
-      </p:sp>
-      <p:sp>
-        <p:nvSpPr>
-          <p:cNvPr id="37" name="Text 34"/>
-          <p:cNvSpPr/>
-          <p:nvPr/>
-        </p:nvSpPr>
-        <p:spPr>
-          <a:xfrm>
-            <a:off x="4434840" y="3008376"/>
-            <a:ext cx="1280160" cy="256032"/>
-          </a:xfrm>
-          <a:prstGeom prst="rect">
-            <a:avLst/>
-          </a:prstGeom>
-          <a:noFill/>
-          <a:ln/>
-        </p:spPr>
-        <p:txBody>
-          <a:bodyPr wrap="square" lIns="0" tIns="0" rIns="0" bIns="0" rtlCol="0" anchor="ctr"/>
-          <a:lstStyle/>
-          <a:p>
-            <a:pPr algn="l" indent="0" marL="0">
-              <a:buNone/>
-            </a:pPr>
-            <a:r>
-              <a:rPr lang="en-US" sz="1050" dirty="0">
-                <a:solidFill>
-                  <a:srgbClr val="1A2433"/>
-                </a:solidFill>
-                <a:latin typeface="Calibri" pitchFamily="34" charset="0"/>
-                <a:ea typeface="Calibri" pitchFamily="34" charset="-122"/>
-                <a:cs typeface="Calibri" pitchFamily="34" charset="-120"/>
-              </a:rPr>
-              <a:t>MECÁNICA</a:t>
-            </a:r>
-            <a:endParaRPr lang="en-US" sz="1050" dirty="0"/>
-          </a:p>
-        </p:txBody>
-      </p:sp>
-      <p:sp>
-        <p:nvSpPr>
-          <p:cNvPr id="38" name="Text 35"/>
-          <p:cNvSpPr/>
-          <p:nvPr/>
-        </p:nvSpPr>
-        <p:spPr>
-          <a:xfrm>
-            <a:off x="5760720" y="3008376"/>
-            <a:ext cx="1508760" cy="256032"/>
-          </a:xfrm>
-          <a:prstGeom prst="rect">
-            <a:avLst/>
-          </a:prstGeom>
-          <a:noFill/>
-          <a:ln/>
-        </p:spPr>
-        <p:txBody>
-          <a:bodyPr wrap="square" lIns="0" tIns="0" rIns="0" bIns="0" rtlCol="0" anchor="ctr"/>
-          <a:lstStyle/>
-          <a:p>
-            <a:pPr algn="l" indent="0" marL="0">
-              <a:buNone/>
-            </a:pPr>
-            <a:r>
-              <a:rPr lang="en-US" sz="1050" dirty="0">
-                <a:solidFill>
-                  <a:srgbClr val="1A2433"/>
-                </a:solidFill>
-                <a:latin typeface="Calibri" pitchFamily="34" charset="0"/>
-                <a:ea typeface="Calibri" pitchFamily="34" charset="-122"/>
-                <a:cs typeface="Calibri" pitchFamily="34" charset="-120"/>
-              </a:rPr>
-              <a:t>Wilson Jara</a:t>
-            </a:r>
-            <a:endParaRPr lang="en-US" sz="1050" dirty="0"/>
-          </a:p>
-        </p:txBody>
-      </p:sp>
-      <p:sp>
-        <p:nvSpPr>
-          <p:cNvPr id="39" name="Text 36"/>
-          <p:cNvSpPr/>
-          <p:nvPr/>
-        </p:nvSpPr>
-        <p:spPr>
-          <a:xfrm>
-            <a:off x="7315200" y="3008376"/>
-            <a:ext cx="1325880" cy="256032"/>
-          </a:xfrm>
-          <a:prstGeom prst="rect">
-            <a:avLst/>
-          </a:prstGeom>
-          <a:noFill/>
-          <a:ln/>
-        </p:spPr>
-        <p:txBody>
-          <a:bodyPr wrap="square" lIns="0" tIns="0" rIns="0" bIns="0" rtlCol="0" anchor="ctr"/>
-          <a:lstStyle/>
-          <a:p>
-            <a:pPr algn="l" indent="0" marL="0">
-              <a:buNone/>
-            </a:pPr>
-            <a:r>
-              <a:rPr lang="en-US" sz="1050" dirty="0">
-                <a:solidFill>
-                  <a:srgbClr val="1A2433"/>
-                </a:solidFill>
-                <a:latin typeface="Calibri" pitchFamily="34" charset="0"/>
-                <a:ea typeface="Calibri" pitchFamily="34" charset="-122"/>
-                <a:cs typeface="Calibri" pitchFamily="34" charset="-120"/>
-              </a:rPr>
-              <a:t>Iniciado</a:t>
-            </a:r>
-            <a:endParaRPr lang="en-US" sz="1050" dirty="0"/>
-          </a:p>
-        </p:txBody>
-      </p:sp>
-      <p:sp>
-        <p:nvSpPr>
-          <p:cNvPr id="40" name="Text 37"/>
-          <p:cNvSpPr/>
-          <p:nvPr/>
-        </p:nvSpPr>
-        <p:spPr>
-          <a:xfrm>
-            <a:off x="8686800" y="3008376"/>
-            <a:ext cx="640080" cy="256032"/>
-          </a:xfrm>
-          <a:prstGeom prst="rect">
-            <a:avLst/>
-          </a:prstGeom>
-          <a:noFill/>
-          <a:ln/>
-        </p:spPr>
-        <p:txBody>
-          <a:bodyPr wrap="square" lIns="0" tIns="0" rIns="0" bIns="0" rtlCol="0" anchor="ctr"/>
-          <a:lstStyle/>
-          <a:p>
-            <a:pPr algn="r" indent="0" marL="0">
-              <a:buNone/>
-            </a:pPr>
-            <a:r>
-              <a:rPr lang="en-US" sz="1050" dirty="0">
-                <a:solidFill>
-                  <a:srgbClr val="1A2433"/>
-                </a:solidFill>
-                <a:latin typeface="Calibri" pitchFamily="34" charset="0"/>
-                <a:ea typeface="Calibri" pitchFamily="34" charset="-122"/>
-                <a:cs typeface="Calibri" pitchFamily="34" charset="-120"/>
-              </a:rPr>
-              <a:t>7</a:t>
-            </a:r>
-            <a:endParaRPr lang="en-US" sz="1050" dirty="0"/>
-          </a:p>
-        </p:txBody>
-      </p:sp>
-      <p:sp>
-        <p:nvSpPr>
-          <p:cNvPr id="41" name="Text 38"/>
-          <p:cNvSpPr/>
-          <p:nvPr/>
-        </p:nvSpPr>
-        <p:spPr>
-          <a:xfrm>
-            <a:off x="9464040" y="3008376"/>
-            <a:ext cx="2286000" cy="256032"/>
-          </a:xfrm>
-          <a:prstGeom prst="rect">
-            <a:avLst/>
-          </a:prstGeom>
-          <a:noFill/>
-          <a:ln/>
-        </p:spPr>
-        <p:txBody>
-          <a:bodyPr wrap="square" lIns="0" tIns="0" rIns="0" bIns="0" rtlCol="0" anchor="ctr"/>
-          <a:lstStyle/>
-          <a:p>
-            <a:pPr algn="l" indent="0" marL="0">
-              <a:buNone/>
-            </a:pPr>
-            <a:r>
-              <a:rPr lang="en-US" sz="1000" dirty="0">
-                <a:solidFill>
-                  <a:srgbClr val="1A2433"/>
-                </a:solidFill>
-                <a:latin typeface="Calibri" pitchFamily="34" charset="0"/>
-                <a:ea typeface="Calibri" pitchFamily="34" charset="-122"/>
-                <a:cs typeface="Calibri" pitchFamily="34" charset="-120"/>
-              </a:rPr>
-              <a:t>Verificación de Preservación</a:t>
-            </a:r>
-            <a:endParaRPr lang="en-US" sz="1000" dirty="0"/>
-          </a:p>
-        </p:txBody>
-      </p:sp>
-      <p:sp>
-        <p:nvSpPr>
-          <p:cNvPr id="42" name="Shape 39"/>
-          <p:cNvSpPr/>
-          <p:nvPr/>
-        </p:nvSpPr>
-        <p:spPr>
-          <a:xfrm>
-            <a:off x="502920" y="3300984"/>
-            <a:ext cx="11247120" cy="0"/>
-          </a:xfrm>
-          <a:prstGeom prst="line">
-            <a:avLst/>
-          </a:prstGeom>
-          <a:noFill/>
-          <a:ln w="9525">
-            <a:solidFill>
-              <a:srgbClr val="D9DFE6"/>
-            </a:solidFill>
-            <a:prstDash val="solid"/>
-          </a:ln>
-        </p:spPr>
-      </p:sp>
-      <p:sp>
-        <p:nvSpPr>
-          <p:cNvPr id="43" name="Shape 40"/>
+          <p:cNvPr id="34" name="Shape 31"/>
           <p:cNvSpPr/>
           <p:nvPr/>
         </p:nvSpPr>
@@ -7645,7 +7298,7 @@
       </p:sp>
       <p:sp>
         <p:nvSpPr>
-          <p:cNvPr id="44" name="Text 41"/>
+          <p:cNvPr id="35" name="Text 32"/>
           <p:cNvSpPr/>
           <p:nvPr/>
         </p:nvSpPr>
@@ -7684,7 +7337,7 @@
       </p:sp>
       <p:sp>
         <p:nvSpPr>
-          <p:cNvPr id="45" name="Text 42"/>
+          <p:cNvPr id="36" name="Text 33"/>
           <p:cNvSpPr/>
           <p:nvPr/>
         </p:nvSpPr>
@@ -7723,7 +7376,7 @@
       </p:sp>
       <p:sp>
         <p:nvSpPr>
-          <p:cNvPr id="46" name="Text 43"/>
+          <p:cNvPr id="37" name="Text 34"/>
           <p:cNvSpPr/>
           <p:nvPr/>
         </p:nvSpPr>
@@ -7754,7 +7407,7 @@
                 <a:ea typeface="Calibri" pitchFamily="34" charset="-122"/>
                 <a:cs typeface="Calibri" pitchFamily="34" charset="-120"/>
               </a:rPr>
-              <a:t>Fuente: Data_NCR_10082026.xlsx — hoja «Observaciones» · Corte 03-08-2026 · 508 registros desde 10-02-2023</a:t>
+              <a:t>Fuente: 1e73482e-Data_NCR03082026.xlsx — hoja «Observaciones» · Corte 03-08-2026 · 494 registros desde 10-02-2023</a:t>
             </a:r>
             <a:endParaRPr lang="en-US" sz="850" dirty="0"/>
           </a:p>
@@ -7762,7 +7415,7 @@
       </p:sp>
       <p:sp>
         <p:nvSpPr>
-          <p:cNvPr id="47" name="Text 44"/>
+          <p:cNvPr id="38" name="Text 35"/>
           <p:cNvSpPr/>
           <p:nvPr/>
         </p:nvSpPr>
@@ -7801,7 +7454,7 @@
       </p:sp>
       <p:sp>
         <p:nvSpPr>
-          <p:cNvPr id="48" name="Text 45"/>
+          <p:cNvPr id="39" name="Text 36"/>
           <p:cNvSpPr/>
           <p:nvPr/>
         </p:nvSpPr>
@@ -8107,7 +7760,7 @@
                 <a:ea typeface="Calibri" pitchFamily="34" charset="-122"/>
                 <a:cs typeface="Calibri" pitchFamily="34" charset="-120"/>
               </a:rPr>
-              <a:t>241 hallazgos levantados · 53 internas · 188 del cliente · 12 especialidades involucradas.</a:t>
+              <a:t>240 hallazgos levantados · 52 internas · 188 del cliente · 12 especialidades involucradas.</a:t>
             </a:r>
             <a:endParaRPr lang="en-US" sz="1350" dirty="0"/>
           </a:p>
@@ -8400,7 +8053,7 @@
                 <a:ea typeface="Cambria" pitchFamily="34" charset="-122"/>
                 <a:cs typeface="Cambria" pitchFamily="34" charset="-120"/>
               </a:rPr>
-              <a:t>22%</a:t>
+              <a:t>21,7%</a:t>
             </a:r>
             <a:endParaRPr lang="en-US" sz="3400" dirty="0"/>
           </a:p>
@@ -8517,7 +8170,7 @@
                 <a:ea typeface="Calibri" pitchFamily="34" charset="-122"/>
                 <a:cs typeface="Calibri" pitchFamily="34" charset="-120"/>
               </a:rPr>
-              <a:t>Fuente: Data_NCR_10082026.xlsx — hoja «Observaciones» · Corte 03-08-2026 · 508 registros desde 10-02-2023</a:t>
+              <a:t>Fuente: 1e73482e-Data_NCR03082026.xlsx — hoja «Observaciones» · Corte 03-08-2026 · 494 registros desde 10-02-2023</a:t>
             </a:r>
             <a:endParaRPr lang="en-US" sz="850" dirty="0"/>
           </a:p>
@@ -8783,7 +8436,7 @@
                 <a:ea typeface="Cambria" pitchFamily="34" charset="-122"/>
                 <a:cs typeface="Cambria" pitchFamily="34" charset="-120"/>
               </a:rPr>
-              <a:t>241</a:t>
+              <a:t>240</a:t>
             </a:r>
             <a:endParaRPr lang="en-US" sz="4000" dirty="0"/>
           </a:p>
@@ -8822,7 +8475,7 @@
                 <a:ea typeface="Calibri" pitchFamily="34" charset="-122"/>
                 <a:cs typeface="Calibri" pitchFamily="34" charset="-120"/>
               </a:rPr>
-              <a:t>226 cerrados</a:t>
+              <a:t>225 cerrados</a:t>
             </a:r>
             <a:endParaRPr lang="en-US" sz="1400" dirty="0"/>
           </a:p>
@@ -8900,7 +8553,7 @@
                 <a:ea typeface="Calibri" pitchFamily="34" charset="-122"/>
                 <a:cs typeface="Calibri" pitchFamily="34" charset="-120"/>
               </a:rPr>
-              <a:t>53 internas · 188 del cliente</a:t>
+              <a:t>52 internas · 188 del cliente</a:t>
             </a:r>
             <a:endParaRPr lang="en-US" sz="950" dirty="0"/>
           </a:p>
@@ -9032,7 +8685,7 @@
                 <a:ea typeface="Calibri" pitchFamily="34" charset="-122"/>
                 <a:cs typeface="Calibri" pitchFamily="34" charset="-120"/>
               </a:rPr>
-              <a:t>226/241</a:t>
+              <a:t>225/240</a:t>
             </a:r>
             <a:endParaRPr lang="en-US" sz="1400" dirty="0"/>
           </a:p>
@@ -9110,7 +8763,7 @@
                 <a:ea typeface="Calibri" pitchFamily="34" charset="-122"/>
                 <a:cs typeface="Calibri" pitchFamily="34" charset="-120"/>
               </a:rPr>
-              <a:t>Global del módulo: 89,4%</a:t>
+              <a:t>Global del módulo: 89,3%</a:t>
             </a:r>
             <a:endParaRPr lang="en-US" sz="950" dirty="0"/>
           </a:p>
@@ -9646,7 +9299,7 @@
                 <a:ea typeface="Cambria" pitchFamily="34" charset="-122"/>
                 <a:cs typeface="Cambria" pitchFamily="34" charset="-120"/>
               </a:rPr>
-              <a:t>22%</a:t>
+              <a:t>21,7%</a:t>
             </a:r>
             <a:endParaRPr lang="en-US" sz="2600" dirty="0"/>
           </a:p>
@@ -9708,7 +9361,7 @@
                 <a:ea typeface="Calibri" pitchFamily="34" charset="-122"/>
                 <a:cs typeface="Calibri" pitchFamily="34" charset="-120"/>
               </a:rPr>
-              <a:t>global del módulo 32,5%</a:t>
+              <a:t>global del módulo 32,8%</a:t>
             </a:r>
             <a:endParaRPr lang="en-US" sz="1000" dirty="0"/>
           </a:p>
@@ -9868,7 +9521,7 @@
                 <a:ea typeface="Cambria" pitchFamily="34" charset="-122"/>
                 <a:cs typeface="Cambria" pitchFamily="34" charset="-120"/>
               </a:rPr>
-              <a:t>53</a:t>
+              <a:t>52</a:t>
             </a:r>
             <a:endParaRPr lang="en-US" sz="1600" dirty="0"/>
           </a:p>
@@ -10044,7 +9697,7 @@
                 <a:ea typeface="Calibri" pitchFamily="34" charset="-122"/>
                 <a:cs typeface="Calibri" pitchFamily="34" charset="-120"/>
               </a:rPr>
-              <a:t>Fuente: Data_NCR_10082026.xlsx — hoja «Observaciones» · Corte 03-08-2026 · 508 registros desde 10-02-2023</a:t>
+              <a:t>Fuente: 1e73482e-Data_NCR03082026.xlsx — hoja «Observaciones» · Corte 03-08-2026 · 494 registros desde 10-02-2023</a:t>
             </a:r>
             <a:endParaRPr lang="en-US" sz="850" dirty="0"/>
           </a:p>
@@ -13903,7 +13556,7 @@
                 <a:ea typeface="Calibri" pitchFamily="34" charset="-122"/>
                 <a:cs typeface="Calibri" pitchFamily="34" charset="-120"/>
               </a:rPr>
-              <a:t>Fuente: Data_NCR_10082026.xlsx — hoja «Observaciones» · Corte 03-08-2026 · 508 registros desde 10-02-2023</a:t>
+              <a:t>Fuente: 1e73482e-Data_NCR03082026.xlsx — hoja «Observaciones» · Corte 03-08-2026 · 494 registros desde 10-02-2023</a:t>
             </a:r>
             <a:endParaRPr lang="en-US" sz="850" dirty="0"/>
           </a:p>
@@ -14666,7 +14319,7 @@
                 <a:ea typeface="Calibri" pitchFamily="34" charset="-122"/>
                 <a:cs typeface="Calibri" pitchFamily="34" charset="-120"/>
               </a:rPr>
-              <a:t>Fuente: Data_NCR_10082026.xlsx — hoja «Observaciones» · Corte 03-08-2026 · 508 registros desde 10-02-2023</a:t>
+              <a:t>Fuente: 1e73482e-Data_NCR03082026.xlsx — hoja «Observaciones» · Corte 03-08-2026 · 494 registros desde 10-02-2023</a:t>
             </a:r>
             <a:endParaRPr lang="en-US" sz="850" dirty="0"/>
           </a:p>
@@ -15259,7 +14912,7 @@
                 <a:ea typeface="Calibri" pitchFamily="34" charset="-122"/>
                 <a:cs typeface="Calibri" pitchFamily="34" charset="-120"/>
               </a:rPr>
-              <a:t>Global del módulo: 89,4%</a:t>
+              <a:t>Global del módulo: 89,3%</a:t>
             </a:r>
             <a:endParaRPr lang="en-US" sz="950" dirty="0"/>
           </a:p>
@@ -15857,7 +15510,7 @@
                 <a:ea typeface="Calibri" pitchFamily="34" charset="-122"/>
                 <a:cs typeface="Calibri" pitchFamily="34" charset="-120"/>
               </a:rPr>
-              <a:t>global del módulo 32,5%</a:t>
+              <a:t>global del módulo 32,8%</a:t>
             </a:r>
             <a:endParaRPr lang="en-US" sz="1000" dirty="0"/>
           </a:p>
@@ -16330,7 +15983,7 @@
                 <a:ea typeface="Calibri" pitchFamily="34" charset="-122"/>
                 <a:cs typeface="Calibri" pitchFamily="34" charset="-120"/>
               </a:rPr>
-              <a:t>Fuente: Data_NCR_10082026.xlsx — hoja «Observaciones» · Corte 03-08-2026 · 508 registros desde 10-02-2023</a:t>
+              <a:t>Fuente: 1e73482e-Data_NCR03082026.xlsx — hoja «Observaciones» · Corte 03-08-2026 · 494 registros desde 10-02-2023</a:t>
             </a:r>
             <a:endParaRPr lang="en-US" sz="850" dirty="0"/>
           </a:p>
@@ -20189,7 +19842,7 @@
                 <a:ea typeface="Calibri" pitchFamily="34" charset="-122"/>
                 <a:cs typeface="Calibri" pitchFamily="34" charset="-120"/>
               </a:rPr>
-              <a:t>Fuente: Data_NCR_10082026.xlsx — hoja «Observaciones» · Corte 03-08-2026 · 508 registros desde 10-02-2023</a:t>
+              <a:t>Fuente: 1e73482e-Data_NCR03082026.xlsx — hoja «Observaciones» · Corte 03-08-2026 · 494 registros desde 10-02-2023</a:t>
             </a:r>
             <a:endParaRPr lang="en-US" sz="850" dirty="0"/>
           </a:p>
@@ -20494,7 +20147,7 @@
                 <a:ea typeface="Cambria" pitchFamily="34" charset="-122"/>
                 <a:cs typeface="Cambria" pitchFamily="34" charset="-120"/>
               </a:rPr>
-              <a:t>89,4%</a:t>
+              <a:t>89,3%</a:t>
             </a:r>
             <a:endParaRPr lang="en-US" sz="4000" dirty="0"/>
           </a:p>
@@ -20533,7 +20186,7 @@
                 <a:ea typeface="Calibri" pitchFamily="34" charset="-122"/>
                 <a:cs typeface="Calibri" pitchFamily="34" charset="-120"/>
               </a:rPr>
-              <a:t>454/508</a:t>
+              <a:t>441/494</a:t>
             </a:r>
             <a:endParaRPr lang="en-US" sz="1400" dirty="0"/>
           </a:p>
@@ -20611,7 +20264,7 @@
                 <a:ea typeface="Calibri" pitchFamily="34" charset="-122"/>
                 <a:cs typeface="Calibri" pitchFamily="34" charset="-120"/>
               </a:rPr>
-              <a:t>54 abiertos · 17 con más de 180 días</a:t>
+              <a:t>53 abiertos · 17 con más de 180 días</a:t>
             </a:r>
             <a:endParaRPr lang="en-US" sz="950" dirty="0"/>
           </a:p>
@@ -20704,7 +20357,7 @@
                 <a:ea typeface="Cambria" pitchFamily="34" charset="-122"/>
                 <a:cs typeface="Cambria" pitchFamily="34" charset="-120"/>
               </a:rPr>
-              <a:t>54</a:t>
+              <a:t>53</a:t>
             </a:r>
             <a:endParaRPr lang="en-US" sz="4000" dirty="0"/>
           </a:p>
@@ -20743,7 +20396,7 @@
                 <a:ea typeface="Calibri" pitchFamily="34" charset="-122"/>
                 <a:cs typeface="Calibri" pitchFamily="34" charset="-120"/>
               </a:rPr>
-              <a:t>de 508 levantados</a:t>
+              <a:t>de 494 levantados</a:t>
             </a:r>
             <a:endParaRPr lang="en-US" sz="1400" dirty="0"/>
           </a:p>
@@ -20821,7 +20474,7 @@
                 <a:ea typeface="Calibri" pitchFamily="34" charset="-122"/>
                 <a:cs typeface="Calibri" pitchFamily="34" charset="-120"/>
               </a:rPr>
-              <a:t>15 iniciado · 1 no aceptado · 23 listo para revisión · 12 observada · 3 pendiente</a:t>
+              <a:t>14 iniciado · 1 no aceptado · 23 listo para revisión · 12 observada · 3 pendiente</a:t>
             </a:r>
             <a:endParaRPr lang="en-US" sz="950" dirty="0"/>
           </a:p>
@@ -20914,7 +20567,7 @@
                 <a:ea typeface="Cambria" pitchFamily="34" charset="-122"/>
                 <a:cs typeface="Cambria" pitchFamily="34" charset="-120"/>
               </a:rPr>
-              <a:t>32,5%</a:t>
+              <a:t>32,8%</a:t>
             </a:r>
             <a:endParaRPr lang="en-US" sz="4000" dirty="0"/>
           </a:p>
@@ -20953,7 +20606,7 @@
                 <a:ea typeface="Calibri" pitchFamily="34" charset="-122"/>
                 <a:cs typeface="Calibri" pitchFamily="34" charset="-120"/>
               </a:rPr>
-              <a:t>162/499 clasificados</a:t>
+              <a:t>159/485 clasificados</a:t>
             </a:r>
             <a:endParaRPr lang="en-US" sz="1400" dirty="0"/>
           </a:p>
@@ -21124,7 +20777,7 @@
                 <a:ea typeface="Cambria" pitchFamily="34" charset="-122"/>
                 <a:cs typeface="Cambria" pitchFamily="34" charset="-120"/>
               </a:rPr>
-              <a:t>10.783</a:t>
+              <a:t>10.613</a:t>
             </a:r>
             <a:endParaRPr lang="en-US" sz="4000" dirty="0"/>
           </a:p>
@@ -21163,7 +20816,7 @@
                 <a:ea typeface="Calibri" pitchFamily="34" charset="-122"/>
                 <a:cs typeface="Calibri" pitchFamily="34" charset="-120"/>
               </a:rPr>
-              <a:t>256 de 508 con costo</a:t>
+              <a:t>249 de 494 con costo</a:t>
             </a:r>
             <a:endParaRPr lang="en-US" sz="1400" dirty="0"/>
           </a:p>
@@ -21241,7 +20894,7 @@
                 <a:ea typeface="Calibri" pitchFamily="34" charset="-122"/>
                 <a:cs typeface="Calibri" pitchFamily="34" charset="-120"/>
               </a:rPr>
-              <a:t>252 hallazgos no declaran costo: la cifra es un piso</a:t>
+              <a:t>245 hallazgos no declaran costo: la cifra es un piso</a:t>
             </a:r>
             <a:endParaRPr lang="en-US" sz="950" dirty="0"/>
           </a:p>
@@ -21381,7 +21034,7 @@
                 <a:ea typeface="Calibri" pitchFamily="34" charset="-122"/>
                 <a:cs typeface="Calibri" pitchFamily="34" charset="-120"/>
               </a:rPr>
-              <a:t>36 de los 54 hallazgos abiertos (66,7%), y es uno de los frentes donde el cliente levanta más de lo que detecta Besalco (71 del cliente contra 53 internas).</a:t>
+              <a:t>36 de los 53 hallazgos abiertos (67,9%), y es uno de los frentes donde el cliente levanta más de lo que detecta Besalco (71 del cliente contra 53 internas).</a:t>
             </a:r>
             <a:endParaRPr lang="en-US" sz="1250" dirty="0"/>
           </a:p>
@@ -21522,7 +21175,7 @@
                 <a:ea typeface="Calibri" pitchFamily="34" charset="-122"/>
                 <a:cs typeface="Calibri" pitchFamily="34" charset="-120"/>
               </a:rPr>
-              <a:t>51 de los 54 abiertos están fuera del plazo de respuesta.  </a:t>
+              <a:t>50 de los 53 abiertos están fuera del plazo de respuesta.  </a:t>
             </a:r>
             <a:pPr indent="0" marL="0">
               <a:lnSpc>
@@ -21578,7 +21231,7 @@
                 <a:ea typeface="Calibri" pitchFamily="34" charset="-122"/>
                 <a:cs typeface="Calibri" pitchFamily="34" charset="-120"/>
               </a:rPr>
-              <a:t>Fuente: Data_NCR_10082026.xlsx — hoja «Observaciones» · Corte 03-08-2026 · 508 registros desde 10-02-2023</a:t>
+              <a:t>Fuente: 1e73482e-Data_NCR03082026.xlsx — hoja «Observaciones» · Corte 03-08-2026 · 494 registros desde 10-02-2023</a:t>
             </a:r>
             <a:endParaRPr lang="en-US" sz="850" dirty="0"/>
           </a:p>
@@ -22359,7 +22012,7 @@
                 <a:ea typeface="Calibri" pitchFamily="34" charset="-122"/>
                 <a:cs typeface="Calibri" pitchFamily="34" charset="-120"/>
               </a:rPr>
-              <a:t>95</a:t>
+              <a:t>82</a:t>
             </a:r>
             <a:endParaRPr lang="en-US" sz="1300" dirty="0"/>
           </a:p>
@@ -22398,7 +22051,7 @@
                 <a:ea typeface="Calibri" pitchFamily="34" charset="-122"/>
                 <a:cs typeface="Calibri" pitchFamily="34" charset="-120"/>
               </a:rPr>
-              <a:t>92</a:t>
+              <a:t>80</a:t>
             </a:r>
             <a:endParaRPr lang="en-US" sz="1300" dirty="0"/>
           </a:p>
@@ -22437,7 +22090,7 @@
                 <a:ea typeface="Calibri" pitchFamily="34" charset="-122"/>
                 <a:cs typeface="Calibri" pitchFamily="34" charset="-120"/>
               </a:rPr>
-              <a:t>3</a:t>
+              <a:t>2</a:t>
             </a:r>
             <a:endParaRPr lang="en-US" sz="1300" dirty="0"/>
           </a:p>
@@ -22476,7 +22129,7 @@
                 <a:ea typeface="Calibri" pitchFamily="34" charset="-122"/>
                 <a:cs typeface="Calibri" pitchFamily="34" charset="-120"/>
               </a:rPr>
-              <a:t>96,8%</a:t>
+              <a:t>97,6%</a:t>
             </a:r>
             <a:endParaRPr lang="en-US" sz="1300" dirty="0"/>
           </a:p>
@@ -22515,7 +22168,7 @@
                 <a:ea typeface="Calibri" pitchFamily="34" charset="-122"/>
                 <a:cs typeface="Calibri" pitchFamily="34" charset="-120"/>
               </a:rPr>
-              <a:t>56</a:t>
+              <a:t>54</a:t>
             </a:r>
             <a:endParaRPr lang="en-US" sz="1300" dirty="0"/>
           </a:p>
@@ -22554,7 +22207,7 @@
                 <a:ea typeface="Calibri" pitchFamily="34" charset="-122"/>
                 <a:cs typeface="Calibri" pitchFamily="34" charset="-120"/>
               </a:rPr>
-              <a:t>30</a:t>
+              <a:t>19</a:t>
             </a:r>
             <a:endParaRPr lang="en-US" sz="1300" dirty="0"/>
           </a:p>
@@ -22632,7 +22285,7 @@
                 <a:ea typeface="Calibri" pitchFamily="34" charset="-122"/>
                 <a:cs typeface="Calibri" pitchFamily="34" charset="-120"/>
               </a:rPr>
-              <a:t>1.573</a:t>
+              <a:t>1.403</a:t>
             </a:r>
             <a:endParaRPr lang="en-US" sz="1300" dirty="0"/>
           </a:p>
@@ -22853,7 +22506,7 @@
                 <a:ea typeface="Calibri" pitchFamily="34" charset="-122"/>
                 <a:cs typeface="Calibri" pitchFamily="34" charset="-120"/>
               </a:rPr>
-              <a:t>241</a:t>
+              <a:t>240</a:t>
             </a:r>
             <a:endParaRPr lang="en-US" sz="1300" dirty="0"/>
           </a:p>
@@ -22892,7 +22545,7 @@
                 <a:ea typeface="Calibri" pitchFamily="34" charset="-122"/>
                 <a:cs typeface="Calibri" pitchFamily="34" charset="-120"/>
               </a:rPr>
-              <a:t>226</a:t>
+              <a:t>225</a:t>
             </a:r>
             <a:endParaRPr lang="en-US" sz="1300" dirty="0"/>
           </a:p>
@@ -23009,7 +22662,7 @@
                 <a:ea typeface="Calibri" pitchFamily="34" charset="-122"/>
                 <a:cs typeface="Calibri" pitchFamily="34" charset="-120"/>
               </a:rPr>
-              <a:t>53</a:t>
+              <a:t>52</a:t>
             </a:r>
             <a:endParaRPr lang="en-US" sz="1300" dirty="0"/>
           </a:p>
@@ -24295,7 +23948,7 @@
                 <a:ea typeface="Calibri" pitchFamily="34" charset="-122"/>
                 <a:cs typeface="Calibri" pitchFamily="34" charset="-120"/>
               </a:rPr>
-              <a:t>500</a:t>
+              <a:t>486</a:t>
             </a:r>
             <a:endParaRPr lang="en-US" sz="1300" dirty="0"/>
           </a:p>
@@ -24334,7 +23987,7 @@
                 <a:ea typeface="Calibri" pitchFamily="34" charset="-122"/>
                 <a:cs typeface="Calibri" pitchFamily="34" charset="-120"/>
               </a:rPr>
-              <a:t>446</a:t>
+              <a:t>433</a:t>
             </a:r>
             <a:endParaRPr lang="en-US" sz="1300" dirty="0"/>
           </a:p>
@@ -24373,7 +24026,7 @@
                 <a:ea typeface="Calibri" pitchFamily="34" charset="-122"/>
                 <a:cs typeface="Calibri" pitchFamily="34" charset="-120"/>
               </a:rPr>
-              <a:t>54</a:t>
+              <a:t>53</a:t>
             </a:r>
             <a:endParaRPr lang="en-US" sz="1300" dirty="0"/>
           </a:p>
@@ -24412,7 +24065,7 @@
                 <a:ea typeface="Calibri" pitchFamily="34" charset="-122"/>
                 <a:cs typeface="Calibri" pitchFamily="34" charset="-120"/>
               </a:rPr>
-              <a:t>89,2%</a:t>
+              <a:t>89,1%</a:t>
             </a:r>
             <a:endParaRPr lang="en-US" sz="1300" dirty="0"/>
           </a:p>
@@ -24451,7 +24104,7 @@
                 <a:ea typeface="Calibri" pitchFamily="34" charset="-122"/>
                 <a:cs typeface="Calibri" pitchFamily="34" charset="-120"/>
               </a:rPr>
-              <a:t>162</a:t>
+              <a:t>159</a:t>
             </a:r>
             <a:endParaRPr lang="en-US" sz="1300" dirty="0"/>
           </a:p>
@@ -24490,7 +24143,7 @@
                 <a:ea typeface="Calibri" pitchFamily="34" charset="-122"/>
                 <a:cs typeface="Calibri" pitchFamily="34" charset="-120"/>
               </a:rPr>
-              <a:t>289</a:t>
+              <a:t>278</a:t>
             </a:r>
             <a:endParaRPr lang="en-US" sz="1300" dirty="0"/>
           </a:p>
@@ -24568,7 +24221,7 @@
                 <a:ea typeface="Calibri" pitchFamily="34" charset="-122"/>
                 <a:cs typeface="Calibri" pitchFamily="34" charset="-120"/>
               </a:rPr>
-              <a:t>10.783</a:t>
+              <a:t>10.613</a:t>
             </a:r>
             <a:endParaRPr lang="en-US" sz="1300" dirty="0"/>
           </a:p>
@@ -24646,7 +24299,7 @@
                 <a:ea typeface="Calibri" pitchFamily="34" charset="-122"/>
                 <a:cs typeface="Calibri" pitchFamily="34" charset="-120"/>
               </a:rPr>
-              <a:t>Fuente: Data_NCR_10082026.xlsx — hoja «Observaciones» · Corte 03-08-2026 · 508 registros desde 10-02-2023</a:t>
+              <a:t>Fuente: 1e73482e-Data_NCR03082026.xlsx — hoja «Observaciones» · Corte 03-08-2026 · 494 registros desde 10-02-2023</a:t>
             </a:r>
             <a:endParaRPr lang="en-US" sz="850" dirty="0"/>
           </a:p>
@@ -26112,7 +25765,7 @@
                 <a:ea typeface="Calibri" pitchFamily="34" charset="-122"/>
                 <a:cs typeface="Calibri" pitchFamily="34" charset="-120"/>
               </a:rPr>
-              <a:t>Fuente: Data_NCR_10082026.xlsx — hoja «Observaciones» · Corte 03-08-2026 · 508 registros desde 10-02-2023</a:t>
+              <a:t>Fuente: 1e73482e-Data_NCR03082026.xlsx — hoja «Observaciones» · Corte 03-08-2026 · 494 registros desde 10-02-2023</a:t>
             </a:r>
             <a:endParaRPr lang="en-US" sz="850" dirty="0"/>
           </a:p>
@@ -26363,7 +26016,7 @@
                 <a:ea typeface="Calibri" pitchFamily="34" charset="-122"/>
                 <a:cs typeface="Calibri" pitchFamily="34" charset="-120"/>
               </a:rPr>
-              <a:t>Interna es autodetección: la levanta Besalco antes que nadie. Externa la levanta el cliente —compromete el contrato— o un subcontrato. Autodetección global: 32,5%.</a:t>
+              <a:t>Interna es autodetección: la levanta Besalco antes que nadie. Externa la levanta el cliente —compromete el contrato— o un subcontrato. Autodetección global: 32,8%.</a:t>
             </a:r>
             <a:endParaRPr lang="en-US" sz="1350" dirty="0"/>
           </a:p>
@@ -26792,7 +26445,7 @@
                 <a:ea typeface="Calibri" pitchFamily="34" charset="-122"/>
                 <a:cs typeface="Calibri" pitchFamily="34" charset="-120"/>
               </a:rPr>
-              <a:t>162</a:t>
+              <a:t>159</a:t>
             </a:r>
             <a:endParaRPr lang="en-US" sz="1050" dirty="0"/>
           </a:p>
@@ -26831,7 +26484,7 @@
                 <a:ea typeface="Calibri" pitchFamily="34" charset="-122"/>
                 <a:cs typeface="Calibri" pitchFamily="34" charset="-120"/>
               </a:rPr>
-              <a:t>157</a:t>
+              <a:t>154</a:t>
             </a:r>
             <a:endParaRPr lang="en-US" sz="1050" dirty="0"/>
           </a:p>
@@ -26987,7 +26640,7 @@
                 <a:ea typeface="Calibri" pitchFamily="34" charset="-122"/>
                 <a:cs typeface="Calibri" pitchFamily="34" charset="-120"/>
               </a:rPr>
-              <a:t>65 días</a:t>
+              <a:t>64 días</a:t>
             </a:r>
             <a:endParaRPr lang="en-US" sz="1050" dirty="0"/>
           </a:p>
@@ -27108,7 +26761,7 @@
                 <a:ea typeface="Calibri" pitchFamily="34" charset="-122"/>
                 <a:cs typeface="Calibri" pitchFamily="34" charset="-120"/>
               </a:rPr>
-              <a:t>289</a:t>
+              <a:t>278</a:t>
             </a:r>
             <a:endParaRPr lang="en-US" sz="1050" dirty="0"/>
           </a:p>
@@ -27147,7 +26800,7 @@
                 <a:ea typeface="Calibri" pitchFamily="34" charset="-122"/>
                 <a:cs typeface="Calibri" pitchFamily="34" charset="-120"/>
               </a:rPr>
-              <a:t>240</a:t>
+              <a:t>230</a:t>
             </a:r>
             <a:endParaRPr lang="en-US" sz="1050" dirty="0"/>
           </a:p>
@@ -27186,7 +26839,7 @@
                 <a:ea typeface="Calibri" pitchFamily="34" charset="-122"/>
                 <a:cs typeface="Calibri" pitchFamily="34" charset="-120"/>
               </a:rPr>
-              <a:t>83%</a:t>
+              <a:t>82,7%</a:t>
             </a:r>
             <a:endParaRPr lang="en-US" sz="1050" dirty="0"/>
           </a:p>
@@ -27225,7 +26878,7 @@
                 <a:ea typeface="Calibri" pitchFamily="34" charset="-122"/>
                 <a:cs typeface="Calibri" pitchFamily="34" charset="-120"/>
               </a:rPr>
-              <a:t>49</a:t>
+              <a:t>48</a:t>
             </a:r>
             <a:endParaRPr lang="en-US" sz="1050" dirty="0"/>
           </a:p>
@@ -27264,7 +26917,7 @@
                 <a:ea typeface="Calibri" pitchFamily="34" charset="-122"/>
                 <a:cs typeface="Calibri" pitchFamily="34" charset="-120"/>
               </a:rPr>
-              <a:t>46</a:t>
+              <a:t>45</a:t>
             </a:r>
             <a:endParaRPr lang="en-US" sz="1050" dirty="0"/>
           </a:p>
@@ -27303,7 +26956,7 @@
                 <a:ea typeface="Calibri" pitchFamily="34" charset="-122"/>
                 <a:cs typeface="Calibri" pitchFamily="34" charset="-120"/>
               </a:rPr>
-              <a:t>49 días</a:t>
+              <a:t>50 días</a:t>
             </a:r>
             <a:endParaRPr lang="en-US" sz="1050" dirty="0"/>
           </a:p>
@@ -28016,7 +27669,7 @@
                 <a:ea typeface="Calibri" pitchFamily="34" charset="-122"/>
                 <a:cs typeface="Calibri" pitchFamily="34" charset="-120"/>
               </a:rPr>
-              <a:t>508</a:t>
+              <a:t>494</a:t>
             </a:r>
             <a:endParaRPr lang="en-US" sz="1050" dirty="0"/>
           </a:p>
@@ -28055,7 +27708,7 @@
                 <a:ea typeface="Calibri" pitchFamily="34" charset="-122"/>
                 <a:cs typeface="Calibri" pitchFamily="34" charset="-120"/>
               </a:rPr>
-              <a:t>454</a:t>
+              <a:t>441</a:t>
             </a:r>
             <a:endParaRPr lang="en-US" sz="1050" dirty="0"/>
           </a:p>
@@ -28094,7 +27747,7 @@
                 <a:ea typeface="Calibri" pitchFamily="34" charset="-122"/>
                 <a:cs typeface="Calibri" pitchFamily="34" charset="-120"/>
               </a:rPr>
-              <a:t>89,4%</a:t>
+              <a:t>89,3%</a:t>
             </a:r>
             <a:endParaRPr lang="en-US" sz="1050" dirty="0"/>
           </a:p>
@@ -28133,7 +27786,7 @@
                 <a:ea typeface="Calibri" pitchFamily="34" charset="-122"/>
                 <a:cs typeface="Calibri" pitchFamily="34" charset="-120"/>
               </a:rPr>
-              <a:t>54</a:t>
+              <a:t>53</a:t>
             </a:r>
             <a:endParaRPr lang="en-US" sz="1050" dirty="0"/>
           </a:p>
@@ -28172,7 +27825,7 @@
                 <a:ea typeface="Calibri" pitchFamily="34" charset="-122"/>
                 <a:cs typeface="Calibri" pitchFamily="34" charset="-120"/>
               </a:rPr>
-              <a:t>51</a:t>
+              <a:t>50</a:t>
             </a:r>
             <a:endParaRPr lang="en-US" sz="1050" dirty="0"/>
           </a:p>
@@ -28350,7 +28003,7 @@
                 <a:ea typeface="Cambria" pitchFamily="34" charset="-122"/>
                 <a:cs typeface="Cambria" pitchFamily="34" charset="-120"/>
               </a:rPr>
-              <a:t>59,6%</a:t>
+              <a:t>66,7%</a:t>
             </a:r>
             <a:endParaRPr lang="en-US" sz="2400" dirty="0"/>
           </a:p>
@@ -28428,7 +28081,7 @@
                 <a:ea typeface="Cambria" pitchFamily="34" charset="-122"/>
                 <a:cs typeface="Cambria" pitchFamily="34" charset="-120"/>
               </a:rPr>
-              <a:t>22%</a:t>
+              <a:t>21,7%</a:t>
             </a:r>
             <a:endParaRPr lang="en-US" sz="2400" dirty="0"/>
           </a:p>
@@ -28584,7 +28237,7 @@
                 <a:ea typeface="Calibri" pitchFamily="34" charset="-122"/>
                 <a:cs typeface="Calibri" pitchFamily="34" charset="-120"/>
               </a:rPr>
-              <a:t>Fuente: Data_NCR_10082026.xlsx — hoja «Observaciones» · Corte 03-08-2026 · 508 registros desde 10-02-2023</a:t>
+              <a:t>Fuente: 1e73482e-Data_NCR03082026.xlsx — hoja «Observaciones» · Corte 03-08-2026 · 494 registros desde 10-02-2023</a:t>
             </a:r>
             <a:endParaRPr lang="en-US" sz="850" dirty="0"/>
           </a:p>
@@ -28835,7 +28488,7 @@
                 <a:ea typeface="Calibri" pitchFamily="34" charset="-122"/>
                 <a:cs typeface="Calibri" pitchFamily="34" charset="-120"/>
               </a:rPr>
-              <a:t>De los 54 hallazgos abiertos, 17 llevan más de 180 días desde que se levantaron y 3 más de un año. La mediana de cierre global es de 30 días.</a:t>
+              <a:t>De los 53 hallazgos abiertos, 17 llevan más de 180 días desde que se levantaron y 3 más de un año. La mediana de cierre global es de 30 días.</a:t>
             </a:r>
             <a:endParaRPr lang="en-US" sz="1350" dirty="0"/>
           </a:p>
@@ -28972,7 +28625,7 @@
                 <a:ea typeface="Calibri" pitchFamily="34" charset="-122"/>
                 <a:cs typeface="Calibri" pitchFamily="34" charset="-120"/>
               </a:rPr>
-              <a:t>Al corte hay 51 hallazgos fuera de plazo de los 54 abiertos.</a:t>
+              <a:t>Al corte hay 50 hallazgos fuera de plazo de los 53 abiertos.</a:t>
             </a:r>
             <a:endParaRPr lang="en-US" sz="1150" dirty="0"/>
           </a:p>
@@ -29385,7 +29038,7 @@
                 <a:ea typeface="Calibri" pitchFamily="34" charset="-122"/>
                 <a:cs typeface="Calibri" pitchFamily="34" charset="-120"/>
               </a:rPr>
-              <a:t>92</a:t>
+              <a:t>80</a:t>
             </a:r>
             <a:endParaRPr lang="en-US" sz="1150" dirty="0"/>
           </a:p>
@@ -29502,7 +29155,7 @@
                 <a:ea typeface="Calibri" pitchFamily="34" charset="-122"/>
                 <a:cs typeface="Calibri" pitchFamily="34" charset="-120"/>
               </a:rPr>
-              <a:t>3</a:t>
+              <a:t>2</a:t>
             </a:r>
             <a:endParaRPr lang="en-US" sz="1150" dirty="0"/>
           </a:p>
@@ -29651,7 +29304,7 @@
                 <a:ea typeface="Calibri" pitchFamily="34" charset="-122"/>
                 <a:cs typeface="Calibri" pitchFamily="34" charset="-120"/>
               </a:rPr>
-              <a:t>226</a:t>
+              <a:t>225</a:t>
             </a:r>
             <a:endParaRPr lang="en-US" sz="1150" dirty="0"/>
           </a:p>
@@ -30392,7 +30045,7 @@
                 <a:ea typeface="Calibri" pitchFamily="34" charset="-122"/>
                 <a:cs typeface="Calibri" pitchFamily="34" charset="-120"/>
               </a:rPr>
-              <a:t>Fuente: Data_NCR_10082026.xlsx — hoja «Observaciones» · Corte 03-08-2026 · 508 registros desde 10-02-2023</a:t>
+              <a:t>Fuente: 1e73482e-Data_NCR03082026.xlsx — hoja «Observaciones» · Corte 03-08-2026 · 494 registros desde 10-02-2023</a:t>
             </a:r>
             <a:endParaRPr lang="en-US" sz="850" dirty="0"/>
           </a:p>
@@ -30766,7 +30419,7 @@
                 <a:ea typeface="Calibri" pitchFamily="34" charset="-122"/>
                 <a:cs typeface="Calibri" pitchFamily="34" charset="-120"/>
               </a:rPr>
-              <a:t>36 de los 54 hallazgos abiertos (66,7%) y 78% de cierre, contra 89,4% global. Es la ruta crítica del módulo.</a:t>
+              <a:t>36 de los 53 hallazgos abiertos (67,9%) y 78% de cierre, contra 89,3% global. Es la ruta crítica del módulo.</a:t>
             </a:r>
             <a:endParaRPr lang="en-US" sz="1100" dirty="0"/>
           </a:p>
@@ -30908,7 +30561,7 @@
                 <a:ea typeface="Calibri" pitchFamily="34" charset="-122"/>
                 <a:cs typeface="Calibri" pitchFamily="34" charset="-120"/>
               </a:rPr>
-              <a:t>Solo 22% de sus hallazgos los detecta Besalco; el mejor frente va en 59,6%. Lo que no se detecta adentro llega como observación del cliente.</a:t>
+              <a:t>Solo 21,7% de sus hallazgos los detecta Besalco; el mejor frente va en 66,7%. Lo que no se detecta adentro llega como observación del cliente.</a:t>
             </a:r>
             <a:endParaRPr lang="en-US" sz="1100" dirty="0"/>
           </a:p>
@@ -31150,7 +30803,7 @@
                 <a:ea typeface="Calibri" pitchFamily="34" charset="-122"/>
                 <a:cs typeface="Calibri" pitchFamily="34" charset="-120"/>
               </a:rPr>
-              <a:t>Responder las 51 que pasaron el plazo</a:t>
+              <a:t>Responder las 50 que pasaron el plazo</a:t>
             </a:r>
             <a:endParaRPr lang="en-US" sz="1400" dirty="0"/>
           </a:p>
@@ -31192,7 +30845,7 @@
                 <a:ea typeface="Calibri" pitchFamily="34" charset="-122"/>
                 <a:cs typeface="Calibri" pitchFamily="34" charset="-120"/>
               </a:rPr>
-              <a:t>El plazo es de 10 días desde la emisión y hoy lo incumplen 94,4% de los abiertos. Solo 3 siguen dentro de plazo.</a:t>
+              <a:t>El plazo es de 10 días desde la emisión y hoy lo incumplen 94,3% de los abiertos. Solo 3 siguen dentro de plazo.</a:t>
             </a:r>
             <a:endParaRPr lang="en-US" sz="1100" dirty="0"/>
           </a:p>
@@ -31231,7 +30884,7 @@
                 <a:ea typeface="Calibri" pitchFamily="34" charset="-122"/>
                 <a:cs typeface="Calibri" pitchFamily="34" charset="-120"/>
               </a:rPr>
-              <a:t>Fuente: Data_NCR_10082026.xlsx — hoja «Observaciones» · Corte 03-08-2026 · 508 registros desde 10-02-2023</a:t>
+              <a:t>Fuente: 1e73482e-Data_NCR03082026.xlsx — hoja «Observaciones» · Corte 03-08-2026 · 494 registros desde 10-02-2023</a:t>
             </a:r>
             <a:endParaRPr lang="en-US" sz="850" dirty="0"/>
           </a:p>
@@ -31584,7 +31237,7 @@
                 <a:ea typeface="Calibri" pitchFamily="34" charset="-122"/>
                 <a:cs typeface="Calibri" pitchFamily="34" charset="-120"/>
               </a:rPr>
-              <a:t>95 hallazgos levantados · 56 internas · 30 del cliente · 8 de subcontrato · 18 especialidades involucradas.</a:t>
+              <a:t>82 hallazgos levantados · 54 internas · 19 del cliente · 8 de subcontrato · 18 especialidades involucradas.</a:t>
             </a:r>
             <a:endParaRPr lang="en-US" sz="1350" dirty="0"/>
           </a:p>
@@ -31643,7 +31296,7 @@
                 <a:ea typeface="Cambria" pitchFamily="34" charset="-122"/>
                 <a:cs typeface="Cambria" pitchFamily="34" charset="-120"/>
               </a:rPr>
-              <a:t>96,8%</a:t>
+              <a:t>97,6%</a:t>
             </a:r>
             <a:endParaRPr lang="en-US" sz="3400" dirty="0"/>
           </a:p>
@@ -31721,7 +31374,7 @@
                 <a:ea typeface="Cambria" pitchFamily="34" charset="-122"/>
                 <a:cs typeface="Cambria" pitchFamily="34" charset="-120"/>
               </a:rPr>
-              <a:t>3</a:t>
+              <a:t>2</a:t>
             </a:r>
             <a:endParaRPr lang="en-US" sz="3400" dirty="0"/>
           </a:p>
@@ -31877,7 +31530,7 @@
                 <a:ea typeface="Cambria" pitchFamily="34" charset="-122"/>
                 <a:cs typeface="Cambria" pitchFamily="34" charset="-120"/>
               </a:rPr>
-              <a:t>59,6%</a:t>
+              <a:t>66,7%</a:t>
             </a:r>
             <a:endParaRPr lang="en-US" sz="3400" dirty="0"/>
           </a:p>
@@ -31994,7 +31647,7 @@
                 <a:ea typeface="Calibri" pitchFamily="34" charset="-122"/>
                 <a:cs typeface="Calibri" pitchFamily="34" charset="-120"/>
               </a:rPr>
-              <a:t>Fuente: Data_NCR_10082026.xlsx — hoja «Observaciones» · Corte 03-08-2026 · 508 registros desde 10-02-2023</a:t>
+              <a:t>Fuente: 1e73482e-Data_NCR03082026.xlsx — hoja «Observaciones» · Corte 03-08-2026 · 494 registros desde 10-02-2023</a:t>
             </a:r>
             <a:endParaRPr lang="en-US" sz="850" dirty="0"/>
           </a:p>
@@ -32260,7 +31913,7 @@
                 <a:ea typeface="Cambria" pitchFamily="34" charset="-122"/>
                 <a:cs typeface="Cambria" pitchFamily="34" charset="-120"/>
               </a:rPr>
-              <a:t>95</a:t>
+              <a:t>82</a:t>
             </a:r>
             <a:endParaRPr lang="en-US" sz="4000" dirty="0"/>
           </a:p>
@@ -32299,7 +31952,7 @@
                 <a:ea typeface="Calibri" pitchFamily="34" charset="-122"/>
                 <a:cs typeface="Calibri" pitchFamily="34" charset="-120"/>
               </a:rPr>
-              <a:t>92 cerrados</a:t>
+              <a:t>80 cerrados</a:t>
             </a:r>
             <a:endParaRPr lang="en-US" sz="1400" dirty="0"/>
           </a:p>
@@ -32377,7 +32030,7 @@
                 <a:ea typeface="Calibri" pitchFamily="34" charset="-122"/>
                 <a:cs typeface="Calibri" pitchFamily="34" charset="-120"/>
               </a:rPr>
-              <a:t>56 internas · 30 del cliente · 8 de subcontrato</a:t>
+              <a:t>54 internas · 19 del cliente · 8 de subcontrato</a:t>
             </a:r>
             <a:endParaRPr lang="en-US" sz="950" dirty="0"/>
           </a:p>
@@ -32470,7 +32123,7 @@
                 <a:ea typeface="Cambria" pitchFamily="34" charset="-122"/>
                 <a:cs typeface="Cambria" pitchFamily="34" charset="-120"/>
               </a:rPr>
-              <a:t>96,8%</a:t>
+              <a:t>97,6%</a:t>
             </a:r>
             <a:endParaRPr lang="en-US" sz="4000" dirty="0"/>
           </a:p>
@@ -32509,7 +32162,7 @@
                 <a:ea typeface="Calibri" pitchFamily="34" charset="-122"/>
                 <a:cs typeface="Calibri" pitchFamily="34" charset="-120"/>
               </a:rPr>
-              <a:t>92/95</a:t>
+              <a:t>80/82</a:t>
             </a:r>
             <a:endParaRPr lang="en-US" sz="1400" dirty="0"/>
           </a:p>
@@ -32587,7 +32240,7 @@
                 <a:ea typeface="Calibri" pitchFamily="34" charset="-122"/>
                 <a:cs typeface="Calibri" pitchFamily="34" charset="-120"/>
               </a:rPr>
-              <a:t>Global del módulo: 89,4%</a:t>
+              <a:t>Global del módulo: 89,3%</a:t>
             </a:r>
             <a:endParaRPr lang="en-US" sz="950" dirty="0"/>
           </a:p>
@@ -32680,7 +32333,7 @@
                 <a:ea typeface="Cambria" pitchFamily="34" charset="-122"/>
                 <a:cs typeface="Cambria" pitchFamily="34" charset="-120"/>
               </a:rPr>
-              <a:t>3</a:t>
+              <a:t>2</a:t>
             </a:r>
             <a:endParaRPr lang="en-US" sz="4000" dirty="0"/>
           </a:p>
@@ -32797,7 +32450,7 @@
                 <a:ea typeface="Calibri" pitchFamily="34" charset="-122"/>
                 <a:cs typeface="Calibri" pitchFamily="34" charset="-120"/>
               </a:rPr>
-              <a:t>1 listo para revisión · 2 iniciado</a:t>
+              <a:t>1 listo para revisión · 1 iniciado</a:t>
             </a:r>
             <a:endParaRPr lang="en-US" sz="950" dirty="0"/>
           </a:p>
@@ -33123,7 +32776,7 @@
                 <a:ea typeface="Cambria" pitchFamily="34" charset="-122"/>
                 <a:cs typeface="Cambria" pitchFamily="34" charset="-120"/>
               </a:rPr>
-              <a:t>59,6%</a:t>
+              <a:t>66,7%</a:t>
             </a:r>
             <a:endParaRPr lang="en-US" sz="2600" dirty="0"/>
           </a:p>
@@ -33185,7 +32838,7 @@
                 <a:ea typeface="Calibri" pitchFamily="34" charset="-122"/>
                 <a:cs typeface="Calibri" pitchFamily="34" charset="-120"/>
               </a:rPr>
-              <a:t>global del módulo 32,5%</a:t>
+              <a:t>global del módulo 32,8%</a:t>
             </a:r>
             <a:endParaRPr lang="en-US" sz="1000" dirty="0"/>
           </a:p>
@@ -33345,7 +32998,7 @@
                 <a:ea typeface="Cambria" pitchFamily="34" charset="-122"/>
                 <a:cs typeface="Cambria" pitchFamily="34" charset="-120"/>
               </a:rPr>
-              <a:t>56</a:t>
+              <a:t>54</a:t>
             </a:r>
             <a:endParaRPr lang="en-US" sz="1600" dirty="0"/>
           </a:p>
@@ -33443,7 +33096,7 @@
                 <a:ea typeface="Calibri" pitchFamily="34" charset="-122"/>
                 <a:cs typeface="Calibri" pitchFamily="34" charset="-120"/>
               </a:rPr>
-              <a:t>2 ab.</a:t>
+              <a:t>1 ab.</a:t>
             </a:r>
             <a:endParaRPr lang="en-US" sz="950" dirty="0"/>
           </a:p>
@@ -33482,7 +33135,7 @@
                 <a:ea typeface="Cambria" pitchFamily="34" charset="-122"/>
                 <a:cs typeface="Cambria" pitchFamily="34" charset="-120"/>
               </a:rPr>
-              <a:t>30</a:t>
+              <a:t>19</a:t>
             </a:r>
             <a:endParaRPr lang="en-US" sz="1600" dirty="0"/>
           </a:p>
@@ -33795,7 +33448,7 @@
                 <a:ea typeface="Calibri" pitchFamily="34" charset="-122"/>
                 <a:cs typeface="Calibri" pitchFamily="34" charset="-120"/>
               </a:rPr>
-              <a:t>Fuente: Data_NCR_10082026.xlsx — hoja «Observaciones» · Corte 03-08-2026 · 508 registros desde 10-02-2023</a:t>
+              <a:t>Fuente: 1e73482e-Data_NCR03082026.xlsx — hoja «Observaciones» · Corte 03-08-2026 · 494 registros desde 10-02-2023</a:t>
             </a:r>
             <a:endParaRPr lang="en-US" sz="850" dirty="0"/>
           </a:p>

</xml_diff>

<commit_message>
No Conformidades al corte 24-08-2026
501 registros (+3), 46 abiertas (-6), cierre 90,8%. Talabre cierra cinco y
sube de 94,3% a 96,4%; Arqueros baja una y queda en 78,0%.

Los tres hallazgos nuevos son del cliente en Talabre y ninguno declara
costo, así que el total sigue en 10.613 UF con 108 registros que declaran
monto y ya 250 con la casilla vacía. La matriz de costo mensual suma 24
meses y sigue cuadrando contra el costo del frente.

98 comprobaciones OK · suite verificada en 1366/1920/2560.

Co-Authored-By: Claude Opus 5 <noreply@anthropic.com>
Claude-Session: https://claude.ai/code/session_011SHyPcub1TtjA2kTAsaPFu
</commit_message>
<xml_diff>
--- a/modulo_nc/Panel_No_Conformidades.pptx
+++ b/modulo_nc/Panel_No_Conformidades.pptx
@@ -220,19 +220,19 @@
                     <c:v>3 sem.</c:v>
                   </c:pt>
                   <c:pt idx="1">
-                    <c:v>13-07</c:v>
+                    <c:v>20-07</c:v>
                   </c:pt>
                   <c:pt idx="2">
-                    <c:v>20-07</c:v>
+                    <c:v>27-07</c:v>
                   </c:pt>
                   <c:pt idx="3">
-                    <c:v>27-07</c:v>
+                    <c:v>03-08</c:v>
                   </c:pt>
                   <c:pt idx="4">
-                    <c:v>03-08</c:v>
+                    <c:v>10-08</c:v>
                   </c:pt>
                   <c:pt idx="5">
-                    <c:v>10-08</c:v>
+                    <c:v>17-08</c:v>
                   </c:pt>
                 </c:lvl>
               </c:multiLvlStrCache>
@@ -251,13 +251,13 @@
                   <c:v/>
                 </c:pt>
                 <c:pt idx="2">
-                  <c:v>1</c:v>
+                  <c:v>2</c:v>
                 </c:pt>
                 <c:pt idx="3">
-                  <c:v>3</c:v>
+                  <c:v/>
                 </c:pt>
                 <c:pt idx="4">
-                  <c:v/>
+                  <c:v>2</c:v>
                 </c:pt>
                 <c:pt idx="5">
                   <c:v>2</c:v>
@@ -322,19 +322,19 @@
                     <c:v>3 sem.</c:v>
                   </c:pt>
                   <c:pt idx="1">
-                    <c:v>13-07</c:v>
+                    <c:v>20-07</c:v>
                   </c:pt>
                   <c:pt idx="2">
-                    <c:v>20-07</c:v>
+                    <c:v>27-07</c:v>
                   </c:pt>
                   <c:pt idx="3">
-                    <c:v>27-07</c:v>
+                    <c:v>03-08</c:v>
                   </c:pt>
                   <c:pt idx="4">
-                    <c:v>03-08</c:v>
+                    <c:v>10-08</c:v>
                   </c:pt>
                   <c:pt idx="5">
-                    <c:v>10-08</c:v>
+                    <c:v>17-08</c:v>
                   </c:pt>
                 </c:lvl>
               </c:multiLvlStrCache>
@@ -347,10 +347,10 @@
                 <c:formatCode>General</c:formatCode>
                 <c:ptCount val="6"/>
                 <c:pt idx="0">
-                  <c:v>5</c:v>
+                  <c:v>3</c:v>
                 </c:pt>
                 <c:pt idx="1">
-                  <c:v/>
+                  <c:v>3</c:v>
                 </c:pt>
                 <c:pt idx="2">
                   <c:v>2</c:v>
@@ -734,7 +734,7 @@
                   <c:v>19</c:v>
                 </c:pt>
                 <c:pt idx="1">
-                  <c:v>192</c:v>
+                  <c:v>195</c:v>
                 </c:pt>
                 <c:pt idx="2">
                   <c:v>71</c:v>
@@ -1199,10 +1199,10 @@
                 <c:formatCode>General</c:formatCode>
                 <c:ptCount val="4"/>
                 <c:pt idx="0">
-                  <c:v>283</c:v>
+                  <c:v>289</c:v>
                 </c:pt>
                 <c:pt idx="1">
-                  <c:v>117</c:v>
+                  <c:v>120</c:v>
                 </c:pt>
                 <c:pt idx="2">
                   <c:v>45</c:v>
@@ -1289,10 +1289,10 @@
                 <c:formatCode>General</c:formatCode>
                 <c:ptCount val="4"/>
                 <c:pt idx="0">
-                  <c:v>33</c:v>
+                  <c:v>29</c:v>
                 </c:pt>
                 <c:pt idx="1">
-                  <c:v>4</c:v>
+                  <c:v>2</c:v>
                 </c:pt>
                 <c:pt idx="2">
                   <c:v>15</c:v>
@@ -1487,7 +1487,7 @@
                 </a:solidFill>
                 <a:latin typeface="Calibri"/>
               </a:rPr>
-              <a:t>Antigüedad de los 52 hallazgos abiertos</a:t>
+              <a:t>Antigüedad de los 46 hallazgos abiertos</a:t>
             </a:r>
           </a:p>
         </c:rich>
@@ -1640,7 +1640,7 @@
                 <c:formatCode>General</c:formatCode>
                 <c:ptCount val="1"/>
                 <c:pt idx="0">
-                  <c:v>10</c:v>
+                  <c:v>6</c:v>
                 </c:pt>
               </c:numCache>
             </c:numRef>
@@ -1784,7 +1784,7 @@
                 <c:formatCode>General</c:formatCode>
                 <c:ptCount val="1"/>
                 <c:pt idx="0">
-                  <c:v>15</c:v>
+                  <c:v>14</c:v>
                 </c:pt>
               </c:numCache>
             </c:numRef>
@@ -1856,7 +1856,7 @@
                 <c:formatCode>General</c:formatCode>
                 <c:ptCount val="1"/>
                 <c:pt idx="0">
-                  <c:v>4</c:v>
+                  <c:v>3</c:v>
                 </c:pt>
               </c:numCache>
             </c:numRef>
@@ -2573,7 +2573,7 @@
                 <c:formatCode>General</c:formatCode>
                 <c:ptCount val="8"/>
                 <c:pt idx="0">
-                  <c:v>134</c:v>
+                  <c:v>139</c:v>
                 </c:pt>
                 <c:pt idx="1">
                   <c:v>24</c:v>
@@ -2687,13 +2687,13 @@
                 <c:formatCode>General</c:formatCode>
                 <c:ptCount val="8"/>
                 <c:pt idx="0">
-                  <c:v>9</c:v>
+                  <c:v>6</c:v>
                 </c:pt>
                 <c:pt idx="1">
                   <c:v>2</c:v>
                 </c:pt>
                 <c:pt idx="2">
-                  <c:v/>
+                  <c:v>1</c:v>
                 </c:pt>
                 <c:pt idx="3">
                   <c:v/>
@@ -2999,7 +2999,7 @@
                 <c:formatCode>General</c:formatCode>
                 <c:ptCount val="8"/>
                 <c:pt idx="0">
-                  <c:v>35</c:v>
+                  <c:v>36</c:v>
                 </c:pt>
                 <c:pt idx="1">
                   <c:v>37</c:v>
@@ -3113,7 +3113,7 @@
                 <c:formatCode>General</c:formatCode>
                 <c:ptCount val="8"/>
                 <c:pt idx="0">
-                  <c:v>36</c:v>
+                  <c:v>35</c:v>
                 </c:pt>
                 <c:pt idx="1">
                   <c:v/>
@@ -5710,7 +5710,7 @@
                 <a:ea typeface="Calibri" pitchFamily="34" charset="-122"/>
                 <a:cs typeface="Calibri" pitchFamily="34" charset="-120"/>
               </a:rPr>
-              <a:t>498 hallazgos levantados entre 10-02-2023 y 11-08-2026 (Desaladora 82 · Talabre 244 · Arqueros 164 · Oficina Central 8).</a:t>
+              <a:t>501 hallazgos levantados entre 10-02-2023 y 19-08-2026 (Desaladora 82 · Talabre 247 · Arqueros 164 · Oficina Central 8).</a:t>
             </a:r>
             <a:endParaRPr lang="en-US" sz="1350" dirty="0"/>
           </a:p>
@@ -5769,7 +5769,7 @@
                 <a:ea typeface="Cambria" pitchFamily="34" charset="-122"/>
                 <a:cs typeface="Cambria" pitchFamily="34" charset="-120"/>
               </a:rPr>
-              <a:t>89,6%</a:t>
+              <a:t>90,8%</a:t>
             </a:r>
             <a:endParaRPr lang="en-US" sz="3400" dirty="0"/>
           </a:p>
@@ -5847,7 +5847,7 @@
                 <a:ea typeface="Cambria" pitchFamily="34" charset="-122"/>
                 <a:cs typeface="Cambria" pitchFamily="34" charset="-120"/>
               </a:rPr>
-              <a:t>52</a:t>
+              <a:t>46</a:t>
             </a:r>
             <a:endParaRPr lang="en-US" sz="3400" dirty="0"/>
           </a:p>
@@ -6081,7 +6081,7 @@
                 <a:ea typeface="Calibri" pitchFamily="34" charset="-122"/>
                 <a:cs typeface="Calibri" pitchFamily="34" charset="-120"/>
               </a:rPr>
-              <a:t>Corte: 17-08-2026</a:t>
+              <a:t>Corte: 24-08-2026</a:t>
             </a:r>
             <a:endParaRPr lang="en-US" sz="1100" dirty="0"/>
           </a:p>
@@ -6120,7 +6120,7 @@
                 <a:ea typeface="Calibri" pitchFamily="34" charset="-122"/>
                 <a:cs typeface="Calibri" pitchFamily="34" charset="-120"/>
               </a:rPr>
-              <a:t>Fuente: Data_NCR17082026.xlsx — hoja «Observaciones» · Corte 17-08-2026 · 498 registros desde 10-02-2023</a:t>
+              <a:t>Fuente: Data_NCR24082026.xlsx — hoja «Observaciones» · Corte 24-08-2026 · 501 registros desde 10-02-2023</a:t>
             </a:r>
             <a:endParaRPr lang="en-US" sz="850" dirty="0"/>
           </a:p>
@@ -6713,7 +6713,7 @@
                 <a:ea typeface="Calibri" pitchFamily="34" charset="-122"/>
                 <a:cs typeface="Calibri" pitchFamily="34" charset="-120"/>
               </a:rPr>
-              <a:t>Global del módulo: 89,6%</a:t>
+              <a:t>Global del módulo: 90,8%</a:t>
             </a:r>
             <a:endParaRPr lang="en-US" sz="950" dirty="0"/>
           </a:p>
@@ -7311,7 +7311,7 @@
                 <a:ea typeface="Calibri" pitchFamily="34" charset="-122"/>
                 <a:cs typeface="Calibri" pitchFamily="34" charset="-120"/>
               </a:rPr>
-              <a:t>global del módulo 32,5%</a:t>
+              <a:t>global del módulo 32,3%</a:t>
             </a:r>
             <a:endParaRPr lang="en-US" sz="1000" dirty="0"/>
           </a:p>
@@ -7921,7 +7921,7 @@
                 <a:ea typeface="Calibri" pitchFamily="34" charset="-122"/>
                 <a:cs typeface="Calibri" pitchFamily="34" charset="-120"/>
               </a:rPr>
-              <a:t>Fuente: Data_NCR17082026.xlsx — hoja «Observaciones» · Corte 17-08-2026 · 498 registros desde 10-02-2023</a:t>
+              <a:t>Fuente: Data_NCR24082026.xlsx — hoja «Observaciones» · Corte 24-08-2026 · 501 registros desde 10-02-2023</a:t>
             </a:r>
             <a:endParaRPr lang="en-US" sz="850" dirty="0"/>
           </a:p>
@@ -8780,7 +8780,7 @@
                 <a:ea typeface="Calibri" pitchFamily="34" charset="-122"/>
                 <a:cs typeface="Calibri" pitchFamily="34" charset="-120"/>
               </a:rPr>
-              <a:t>97</a:t>
+              <a:t>104</a:t>
             </a:r>
             <a:endParaRPr lang="en-US" sz="1050" dirty="0"/>
           </a:p>
@@ -8903,7 +8903,7 @@
                 <a:ea typeface="Calibri" pitchFamily="34" charset="-122"/>
                 <a:cs typeface="Calibri" pitchFamily="34" charset="-120"/>
               </a:rPr>
-              <a:t>SEMANA 10-08-2026 — 16-08-2026</a:t>
+              <a:t>SEMANA 17-08-2026 — 23-08-2026</a:t>
             </a:r>
             <a:endParaRPr lang="en-US" sz="1000" dirty="0"/>
           </a:p>
@@ -8981,7 +8981,7 @@
                 <a:ea typeface="Calibri" pitchFamily="34" charset="-122"/>
                 <a:cs typeface="Calibri" pitchFamily="34" charset="-120"/>
               </a:rPr>
-              <a:t>Fuente: Data_NCR17082026.xlsx — hoja «Observaciones» · Corte 17-08-2026 · 498 registros desde 10-02-2023</a:t>
+              <a:t>Fuente: Data_NCR24082026.xlsx — hoja «Observaciones» · Corte 24-08-2026 · 501 registros desde 10-02-2023</a:t>
             </a:r>
             <a:endParaRPr lang="en-US" sz="850" dirty="0"/>
           </a:p>
@@ -9334,7 +9334,7 @@
                 <a:ea typeface="Calibri" pitchFamily="34" charset="-122"/>
                 <a:cs typeface="Calibri" pitchFamily="34" charset="-120"/>
               </a:rPr>
-              <a:t>244 hallazgos levantados · 52 internas · 192 del cliente · 12 especialidades involucradas.</a:t>
+              <a:t>247 hallazgos levantados · 52 internas · 195 del cliente · 12 especialidades involucradas.</a:t>
             </a:r>
             <a:endParaRPr lang="en-US" sz="1350" dirty="0"/>
           </a:p>
@@ -9393,7 +9393,7 @@
                 <a:ea typeface="Cambria" pitchFamily="34" charset="-122"/>
                 <a:cs typeface="Cambria" pitchFamily="34" charset="-120"/>
               </a:rPr>
-              <a:t>94,3%</a:t>
+              <a:t>96,4%</a:t>
             </a:r>
             <a:endParaRPr lang="en-US" sz="3400" dirty="0"/>
           </a:p>
@@ -9471,7 +9471,7 @@
                 <a:ea typeface="Cambria" pitchFamily="34" charset="-122"/>
                 <a:cs typeface="Cambria" pitchFamily="34" charset="-120"/>
               </a:rPr>
-              <a:t>14</a:t>
+              <a:t>9</a:t>
             </a:r>
             <a:endParaRPr lang="en-US" sz="3400" dirty="0"/>
           </a:p>
@@ -9627,7 +9627,7 @@
                 <a:ea typeface="Cambria" pitchFamily="34" charset="-122"/>
                 <a:cs typeface="Cambria" pitchFamily="34" charset="-120"/>
               </a:rPr>
-              <a:t>21,3%</a:t>
+              <a:t>21,1%</a:t>
             </a:r>
             <a:endParaRPr lang="en-US" sz="3400" dirty="0"/>
           </a:p>
@@ -9705,7 +9705,7 @@
                 <a:ea typeface="Calibri" pitchFamily="34" charset="-122"/>
                 <a:cs typeface="Calibri" pitchFamily="34" charset="-120"/>
               </a:rPr>
-              <a:t>Corte: 17-08-2026</a:t>
+              <a:t>Corte: 24-08-2026</a:t>
             </a:r>
             <a:endParaRPr lang="en-US" sz="1100" dirty="0"/>
           </a:p>
@@ -9744,7 +9744,7 @@
                 <a:ea typeface="Calibri" pitchFamily="34" charset="-122"/>
                 <a:cs typeface="Calibri" pitchFamily="34" charset="-120"/>
               </a:rPr>
-              <a:t>Fuente: Data_NCR17082026.xlsx — hoja «Observaciones» · Corte 17-08-2026 · 498 registros desde 10-02-2023</a:t>
+              <a:t>Fuente: Data_NCR24082026.xlsx — hoja «Observaciones» · Corte 24-08-2026 · 501 registros desde 10-02-2023</a:t>
             </a:r>
             <a:endParaRPr lang="en-US" sz="850" dirty="0"/>
           </a:p>
@@ -10010,7 +10010,7 @@
                 <a:ea typeface="Cambria" pitchFamily="34" charset="-122"/>
                 <a:cs typeface="Cambria" pitchFamily="34" charset="-120"/>
               </a:rPr>
-              <a:t>244</a:t>
+              <a:t>247</a:t>
             </a:r>
             <a:endParaRPr lang="en-US" sz="4000" dirty="0"/>
           </a:p>
@@ -10049,7 +10049,7 @@
                 <a:ea typeface="Calibri" pitchFamily="34" charset="-122"/>
                 <a:cs typeface="Calibri" pitchFamily="34" charset="-120"/>
               </a:rPr>
-              <a:t>230 cerrados</a:t>
+              <a:t>238 cerrados</a:t>
             </a:r>
             <a:endParaRPr lang="en-US" sz="1400" dirty="0"/>
           </a:p>
@@ -10127,7 +10127,7 @@
                 <a:ea typeface="Calibri" pitchFamily="34" charset="-122"/>
                 <a:cs typeface="Calibri" pitchFamily="34" charset="-120"/>
               </a:rPr>
-              <a:t>52 internas · 192 del cliente</a:t>
+              <a:t>52 internas · 195 del cliente</a:t>
             </a:r>
             <a:endParaRPr lang="en-US" sz="950" dirty="0"/>
           </a:p>
@@ -10220,7 +10220,7 @@
                 <a:ea typeface="Cambria" pitchFamily="34" charset="-122"/>
                 <a:cs typeface="Cambria" pitchFamily="34" charset="-120"/>
               </a:rPr>
-              <a:t>94,3%</a:t>
+              <a:t>96,4%</a:t>
             </a:r>
             <a:endParaRPr lang="en-US" sz="4000" dirty="0"/>
           </a:p>
@@ -10259,7 +10259,7 @@
                 <a:ea typeface="Calibri" pitchFamily="34" charset="-122"/>
                 <a:cs typeface="Calibri" pitchFamily="34" charset="-120"/>
               </a:rPr>
-              <a:t>230/244</a:t>
+              <a:t>238/247</a:t>
             </a:r>
             <a:endParaRPr lang="en-US" sz="1400" dirty="0"/>
           </a:p>
@@ -10337,7 +10337,7 @@
                 <a:ea typeface="Calibri" pitchFamily="34" charset="-122"/>
                 <a:cs typeface="Calibri" pitchFamily="34" charset="-120"/>
               </a:rPr>
-              <a:t>Global del módulo: 89,6%</a:t>
+              <a:t>Global del módulo: 90,8%</a:t>
             </a:r>
             <a:endParaRPr lang="en-US" sz="950" dirty="0"/>
           </a:p>
@@ -10430,7 +10430,7 @@
                 <a:ea typeface="Cambria" pitchFamily="34" charset="-122"/>
                 <a:cs typeface="Cambria" pitchFamily="34" charset="-120"/>
               </a:rPr>
-              <a:t>14</a:t>
+              <a:t>9</a:t>
             </a:r>
             <a:endParaRPr lang="en-US" sz="4000" dirty="0"/>
           </a:p>
@@ -10547,7 +10547,7 @@
                 <a:ea typeface="Calibri" pitchFamily="34" charset="-122"/>
                 <a:cs typeface="Calibri" pitchFamily="34" charset="-120"/>
               </a:rPr>
-              <a:t>13 iniciado · 1 no aceptado</a:t>
+              <a:t>5 iniciado · 1 no aceptado · 3 listo para revisión</a:t>
             </a:r>
             <a:endParaRPr lang="en-US" sz="950" dirty="0"/>
           </a:p>
@@ -10757,7 +10757,7 @@
                 <a:ea typeface="Calibri" pitchFamily="34" charset="-122"/>
                 <a:cs typeface="Calibri" pitchFamily="34" charset="-120"/>
               </a:rPr>
-              <a:t>el más lento tomó 389 días</a:t>
+              <a:t>el más lento tomó 407 días</a:t>
             </a:r>
             <a:endParaRPr lang="en-US" sz="950" dirty="0"/>
           </a:p>
@@ -10873,7 +10873,7 @@
                 <a:ea typeface="Cambria" pitchFamily="34" charset="-122"/>
                 <a:cs typeface="Cambria" pitchFamily="34" charset="-120"/>
               </a:rPr>
-              <a:t>21,3%</a:t>
+              <a:t>21,1%</a:t>
             </a:r>
             <a:endParaRPr lang="en-US" sz="2600" dirty="0"/>
           </a:p>
@@ -10935,7 +10935,7 @@
                 <a:ea typeface="Calibri" pitchFamily="34" charset="-122"/>
                 <a:cs typeface="Calibri" pitchFamily="34" charset="-120"/>
               </a:rPr>
-              <a:t>global del módulo 32,5%</a:t>
+              <a:t>global del módulo 32,3%</a:t>
             </a:r>
             <a:endParaRPr lang="en-US" sz="1000" dirty="0"/>
           </a:p>
@@ -11050,13 +11050,13 @@
             <a:r>
               <a:rPr lang="en-US" sz="950" dirty="0">
                 <a:solidFill>
-                  <a:srgbClr val="E3A55B"/>
-                </a:solidFill>
-                <a:latin typeface="Calibri" pitchFamily="34" charset="0"/>
-                <a:ea typeface="Calibri" pitchFamily="34" charset="-122"/>
-                <a:cs typeface="Calibri" pitchFamily="34" charset="-120"/>
-              </a:rPr>
-              <a:t>3 ab.</a:t>
+                  <a:srgbClr val="6E8CA8"/>
+                </a:solidFill>
+                <a:latin typeface="Calibri" pitchFamily="34" charset="0"/>
+                <a:ea typeface="Calibri" pitchFamily="34" charset="-122"/>
+                <a:cs typeface="Calibri" pitchFamily="34" charset="-120"/>
+              </a:rPr>
+              <a:t>0 ab.</a:t>
             </a:r>
             <a:endParaRPr lang="en-US" sz="950" dirty="0"/>
           </a:p>
@@ -11193,7 +11193,7 @@
                 <a:ea typeface="Calibri" pitchFamily="34" charset="-122"/>
                 <a:cs typeface="Calibri" pitchFamily="34" charset="-120"/>
               </a:rPr>
-              <a:t>11 ab.</a:t>
+              <a:t>9 ab.</a:t>
             </a:r>
             <a:endParaRPr lang="en-US" sz="950" dirty="0"/>
           </a:p>
@@ -11232,7 +11232,7 @@
                 <a:ea typeface="Cambria" pitchFamily="34" charset="-122"/>
                 <a:cs typeface="Cambria" pitchFamily="34" charset="-120"/>
               </a:rPr>
-              <a:t>192</a:t>
+              <a:t>195</a:t>
             </a:r>
             <a:endParaRPr lang="en-US" sz="1600" dirty="0"/>
           </a:p>
@@ -11271,7 +11271,7 @@
                 <a:ea typeface="Calibri" pitchFamily="34" charset="-122"/>
                 <a:cs typeface="Calibri" pitchFamily="34" charset="-120"/>
               </a:rPr>
-              <a:t>Fuente: Data_NCR17082026.xlsx — hoja «Observaciones» · Corte 17-08-2026 · 498 registros desde 10-02-2023</a:t>
+              <a:t>Fuente: Data_NCR24082026.xlsx — hoja «Observaciones» · Corte 24-08-2026 · 501 registros desde 10-02-2023</a:t>
             </a:r>
             <a:endParaRPr lang="en-US" sz="850" dirty="0"/>
           </a:p>
@@ -11522,7 +11522,7 @@
                 <a:ea typeface="Calibri" pitchFamily="34" charset="-122"/>
                 <a:cs typeface="Calibri" pitchFamily="34" charset="-120"/>
               </a:rPr>
-              <a:t>14 hallazgos siguen abiertos; 3 con más de 180 días. Se listan del más antiguo al más reciente.</a:t>
+              <a:t>9 hallazgos siguen abiertos; 0 con más de 180 días. Se listan del más antiguo al más reciente.</a:t>
             </a:r>
             <a:endParaRPr lang="en-US" sz="1350" dirty="0"/>
           </a:p>
@@ -11896,7 +11896,7 @@
                 <a:ea typeface="Calibri" pitchFamily="34" charset="-122"/>
                 <a:cs typeface="Calibri" pitchFamily="34" charset="-120"/>
               </a:rPr>
-              <a:t>21</a:t>
+              <a:t>198</a:t>
             </a:r>
             <a:endParaRPr lang="en-US" sz="1050" dirty="0"/>
           </a:p>
@@ -11935,7 +11935,7 @@
                 <a:ea typeface="Calibri" pitchFamily="34" charset="-122"/>
                 <a:cs typeface="Calibri" pitchFamily="34" charset="-120"/>
               </a:rPr>
-              <a:t>No Conformidad</a:t>
+              <a:t>Producto No Conforme</a:t>
             </a:r>
             <a:endParaRPr lang="en-US" sz="1050" dirty="0"/>
           </a:p>
@@ -11968,13 +11968,13 @@
             <a:r>
               <a:rPr lang="en-US" sz="1050" b="1" dirty="0">
                 <a:solidFill>
-                  <a:srgbClr val="2E6FB5"/>
-                </a:solidFill>
-                <a:latin typeface="Calibri" pitchFamily="34" charset="0"/>
-                <a:ea typeface="Calibri" pitchFamily="34" charset="-122"/>
-                <a:cs typeface="Calibri" pitchFamily="34" charset="-120"/>
-              </a:rPr>
-              <a:t>Interna (Besalco)</a:t>
+                  <a:srgbClr val="C87A32"/>
+                </a:solidFill>
+                <a:latin typeface="Calibri" pitchFamily="34" charset="0"/>
+                <a:ea typeface="Calibri" pitchFamily="34" charset="-122"/>
+                <a:cs typeface="Calibri" pitchFamily="34" charset="-120"/>
+              </a:rPr>
+              <a:t>Externa · Cliente</a:t>
             </a:r>
             <a:endParaRPr lang="en-US" sz="1050" dirty="0"/>
           </a:p>
@@ -12013,7 +12013,7 @@
                 <a:ea typeface="Calibri" pitchFamily="34" charset="-122"/>
                 <a:cs typeface="Calibri" pitchFamily="34" charset="-120"/>
               </a:rPr>
-              <a:t>EXPEDITORÍA</a:t>
+              <a:t>OO.CC</a:t>
             </a:r>
             <a:endParaRPr lang="en-US" sz="1050" dirty="0"/>
           </a:p>
@@ -12052,7 +12052,7 @@
                 <a:ea typeface="Calibri" pitchFamily="34" charset="-122"/>
                 <a:cs typeface="Calibri" pitchFamily="34" charset="-120"/>
               </a:rPr>
-              <a:t>Alvaro Cortés V.</a:t>
+              <a:t>Wladimir Carvajal …</a:t>
             </a:r>
             <a:endParaRPr lang="en-US" sz="1050" dirty="0"/>
           </a:p>
@@ -12122,15 +12122,15 @@
               <a:buNone/>
             </a:pPr>
             <a:r>
-              <a:rPr lang="en-US" sz="1050" b="1" dirty="0">
-                <a:solidFill>
-                  <a:srgbClr val="C0392B"/>
-                </a:solidFill>
-                <a:latin typeface="Calibri" pitchFamily="34" charset="0"/>
-                <a:ea typeface="Calibri" pitchFamily="34" charset="-122"/>
-                <a:cs typeface="Calibri" pitchFamily="34" charset="-120"/>
-              </a:rPr>
-              <a:t>406</a:t>
+              <a:rPr lang="en-US" sz="1050" dirty="0">
+                <a:solidFill>
+                  <a:srgbClr val="1A2433"/>
+                </a:solidFill>
+                <a:latin typeface="Calibri" pitchFamily="34" charset="0"/>
+                <a:ea typeface="Calibri" pitchFamily="34" charset="-122"/>
+                <a:cs typeface="Calibri" pitchFamily="34" charset="-120"/>
+              </a:rPr>
+              <a:t>154</a:t>
             </a:r>
             <a:endParaRPr lang="en-US" sz="1050" dirty="0"/>
           </a:p>
@@ -12169,7 +12169,7 @@
                 <a:ea typeface="Calibri" pitchFamily="34" charset="-122"/>
                 <a:cs typeface="Calibri" pitchFamily="34" charset="-120"/>
               </a:rPr>
-              <a:t>Incumplimiento a Plan de Calidad de…</a:t>
+              <a:t>Corte en geomembrana HDPE instalada…</a:t>
             </a:r>
             <a:endParaRPr lang="en-US" sz="1000" dirty="0"/>
           </a:p>
@@ -12251,7 +12251,7 @@
                 <a:ea typeface="Calibri" pitchFamily="34" charset="-122"/>
                 <a:cs typeface="Calibri" pitchFamily="34" charset="-120"/>
               </a:rPr>
-              <a:t>72</a:t>
+              <a:t>205</a:t>
             </a:r>
             <a:endParaRPr lang="en-US" sz="1050" dirty="0"/>
           </a:p>
@@ -12290,7 +12290,7 @@
                 <a:ea typeface="Calibri" pitchFamily="34" charset="-122"/>
                 <a:cs typeface="Calibri" pitchFamily="34" charset="-120"/>
               </a:rPr>
-              <a:t>No Conformidad</a:t>
+              <a:t>Producto No Conforme</a:t>
             </a:r>
             <a:endParaRPr lang="en-US" sz="1050" dirty="0"/>
           </a:p>
@@ -12323,13 +12323,13 @@
             <a:r>
               <a:rPr lang="en-US" sz="1050" b="1" dirty="0">
                 <a:solidFill>
-                  <a:srgbClr val="2E6FB5"/>
-                </a:solidFill>
-                <a:latin typeface="Calibri" pitchFamily="34" charset="0"/>
-                <a:ea typeface="Calibri" pitchFamily="34" charset="-122"/>
-                <a:cs typeface="Calibri" pitchFamily="34" charset="-120"/>
-              </a:rPr>
-              <a:t>Interna (Besalco)</a:t>
+                  <a:srgbClr val="C87A32"/>
+                </a:solidFill>
+                <a:latin typeface="Calibri" pitchFamily="34" charset="0"/>
+                <a:ea typeface="Calibri" pitchFamily="34" charset="-122"/>
+                <a:cs typeface="Calibri" pitchFamily="34" charset="-120"/>
+              </a:rPr>
+              <a:t>Externa · Cliente</a:t>
             </a:r>
             <a:endParaRPr lang="en-US" sz="1050" dirty="0"/>
           </a:p>
@@ -12368,7 +12368,7 @@
                 <a:ea typeface="Calibri" pitchFamily="34" charset="-122"/>
                 <a:cs typeface="Calibri" pitchFamily="34" charset="-120"/>
               </a:rPr>
-              <a:t>EXPEDITORÍA</a:t>
+              <a:t>OO.CC</a:t>
             </a:r>
             <a:endParaRPr lang="en-US" sz="1050" dirty="0"/>
           </a:p>
@@ -12407,7 +12407,7 @@
                 <a:ea typeface="Calibri" pitchFamily="34" charset="-122"/>
                 <a:cs typeface="Calibri" pitchFamily="34" charset="-120"/>
               </a:rPr>
-              <a:t>Alvaro Cortés V.</a:t>
+              <a:t>Sebastián Ramos</a:t>
             </a:r>
             <a:endParaRPr lang="en-US" sz="1050" dirty="0"/>
           </a:p>
@@ -12446,7 +12446,7 @@
                 <a:ea typeface="Calibri" pitchFamily="34" charset="-122"/>
                 <a:cs typeface="Calibri" pitchFamily="34" charset="-120"/>
               </a:rPr>
-              <a:t>Iniciado</a:t>
+              <a:t>No aceptado</a:t>
             </a:r>
             <a:endParaRPr lang="en-US" sz="1050" dirty="0"/>
           </a:p>
@@ -12477,15 +12477,15 @@
               <a:buNone/>
             </a:pPr>
             <a:r>
-              <a:rPr lang="en-US" sz="1050" b="1" dirty="0">
-                <a:solidFill>
-                  <a:srgbClr val="C0392B"/>
-                </a:solidFill>
-                <a:latin typeface="Calibri" pitchFamily="34" charset="0"/>
-                <a:ea typeface="Calibri" pitchFamily="34" charset="-122"/>
-                <a:cs typeface="Calibri" pitchFamily="34" charset="-120"/>
-              </a:rPr>
-              <a:t>342</a:t>
+              <a:rPr lang="en-US" sz="1050" dirty="0">
+                <a:solidFill>
+                  <a:srgbClr val="1A2433"/>
+                </a:solidFill>
+                <a:latin typeface="Calibri" pitchFamily="34" charset="0"/>
+                <a:ea typeface="Calibri" pitchFamily="34" charset="-122"/>
+                <a:cs typeface="Calibri" pitchFamily="34" charset="-120"/>
+              </a:rPr>
+              <a:t>140</a:t>
             </a:r>
             <a:endParaRPr lang="en-US" sz="1050" dirty="0"/>
           </a:p>
@@ -12524,7 +12524,7 @@
                 <a:ea typeface="Calibri" pitchFamily="34" charset="-122"/>
                 <a:cs typeface="Calibri" pitchFamily="34" charset="-120"/>
               </a:rPr>
-              <a:t>Incumplimiento a la recepción de ma…</a:t>
+              <a:t>Solución proyectada asociada al ele…</a:t>
             </a:r>
             <a:endParaRPr lang="en-US" sz="1000" dirty="0"/>
           </a:p>
@@ -12586,7 +12586,7 @@
                 <a:ea typeface="Calibri" pitchFamily="34" charset="-122"/>
                 <a:cs typeface="Calibri" pitchFamily="34" charset="-120"/>
               </a:rPr>
-              <a:t>142</a:t>
+              <a:t>230</a:t>
             </a:r>
             <a:endParaRPr lang="en-US" sz="1050" dirty="0"/>
           </a:p>
@@ -12658,13 +12658,13 @@
             <a:r>
               <a:rPr lang="en-US" sz="1050" b="1" dirty="0">
                 <a:solidFill>
-                  <a:srgbClr val="2E6FB5"/>
-                </a:solidFill>
-                <a:latin typeface="Calibri" pitchFamily="34" charset="0"/>
-                <a:ea typeface="Calibri" pitchFamily="34" charset="-122"/>
-                <a:cs typeface="Calibri" pitchFamily="34" charset="-120"/>
-              </a:rPr>
-              <a:t>Interna (Besalco)</a:t>
+                  <a:srgbClr val="C87A32"/>
+                </a:solidFill>
+                <a:latin typeface="Calibri" pitchFamily="34" charset="0"/>
+                <a:ea typeface="Calibri" pitchFamily="34" charset="-122"/>
+                <a:cs typeface="Calibri" pitchFamily="34" charset="-120"/>
+              </a:rPr>
+              <a:t>Externa · Cliente</a:t>
             </a:r>
             <a:endParaRPr lang="en-US" sz="1050" dirty="0"/>
           </a:p>
@@ -12703,7 +12703,7 @@
                 <a:ea typeface="Calibri" pitchFamily="34" charset="-122"/>
                 <a:cs typeface="Calibri" pitchFamily="34" charset="-120"/>
               </a:rPr>
-              <a:t>EXPEDITORÍA</a:t>
+              <a:t>CALIDAD</a:t>
             </a:r>
             <a:endParaRPr lang="en-US" sz="1050" dirty="0"/>
           </a:p>
@@ -12742,7 +12742,7 @@
                 <a:ea typeface="Calibri" pitchFamily="34" charset="-122"/>
                 <a:cs typeface="Calibri" pitchFamily="34" charset="-120"/>
               </a:rPr>
-              <a:t>Alvaro Cortés V.</a:t>
+              <a:t>Mauricio Soto B.</a:t>
             </a:r>
             <a:endParaRPr lang="en-US" sz="1050" dirty="0"/>
           </a:p>
@@ -12812,15 +12812,15 @@
               <a:buNone/>
             </a:pPr>
             <a:r>
-              <a:rPr lang="en-US" sz="1050" b="1" dirty="0">
-                <a:solidFill>
-                  <a:srgbClr val="C0392B"/>
-                </a:solidFill>
-                <a:latin typeface="Calibri" pitchFamily="34" charset="0"/>
-                <a:ea typeface="Calibri" pitchFamily="34" charset="-122"/>
-                <a:cs typeface="Calibri" pitchFamily="34" charset="-120"/>
-              </a:rPr>
-              <a:t>238</a:t>
+              <a:rPr lang="en-US" sz="1050" dirty="0">
+                <a:solidFill>
+                  <a:srgbClr val="1A2433"/>
+                </a:solidFill>
+                <a:latin typeface="Calibri" pitchFamily="34" charset="0"/>
+                <a:ea typeface="Calibri" pitchFamily="34" charset="-122"/>
+                <a:cs typeface="Calibri" pitchFamily="34" charset="-120"/>
+              </a:rPr>
+              <a:t>76</a:t>
             </a:r>
             <a:endParaRPr lang="en-US" sz="1050" dirty="0"/>
           </a:p>
@@ -12859,7 +12859,7 @@
                 <a:ea typeface="Calibri" pitchFamily="34" charset="-122"/>
                 <a:cs typeface="Calibri" pitchFamily="34" charset="-120"/>
               </a:rPr>
-              <a:t>Daños manguerotes en recepción/desc…</a:t>
+              <a:t>No se evidenció un Plan de Cierre d…</a:t>
             </a:r>
             <a:endParaRPr lang="en-US" sz="1000" dirty="0"/>
           </a:p>
@@ -12941,7 +12941,7 @@
                 <a:ea typeface="Calibri" pitchFamily="34" charset="-122"/>
                 <a:cs typeface="Calibri" pitchFamily="34" charset="-120"/>
               </a:rPr>
-              <a:t>192</a:t>
+              <a:t>235</a:t>
             </a:r>
             <a:endParaRPr lang="en-US" sz="1050" dirty="0"/>
           </a:p>
@@ -13097,7 +13097,7 @@
                 <a:ea typeface="Calibri" pitchFamily="34" charset="-122"/>
                 <a:cs typeface="Calibri" pitchFamily="34" charset="-120"/>
               </a:rPr>
-              <a:t>Sebastián Ramos</a:t>
+              <a:t>Mauricio Rocha A.</a:t>
             </a:r>
             <a:endParaRPr lang="en-US" sz="1050" dirty="0"/>
           </a:p>
@@ -13175,7 +13175,7 @@
                 <a:ea typeface="Calibri" pitchFamily="34" charset="-122"/>
                 <a:cs typeface="Calibri" pitchFamily="34" charset="-120"/>
               </a:rPr>
-              <a:t>153</a:t>
+              <a:t>55</a:t>
             </a:r>
             <a:endParaRPr lang="en-US" sz="1050" dirty="0"/>
           </a:p>
@@ -13214,7 +13214,7 @@
                 <a:ea typeface="Calibri" pitchFamily="34" charset="-122"/>
                 <a:cs typeface="Calibri" pitchFamily="34" charset="-120"/>
               </a:rPr>
-              <a:t>Fundaciones sin relleno estructural…</a:t>
+              <a:t>Geomembrana presenta sectores en lo…</a:t>
             </a:r>
             <a:endParaRPr lang="en-US" sz="1000" dirty="0"/>
           </a:p>
@@ -13276,7 +13276,7 @@
                 <a:ea typeface="Calibri" pitchFamily="34" charset="-122"/>
                 <a:cs typeface="Calibri" pitchFamily="34" charset="-120"/>
               </a:rPr>
-              <a:t>198</a:t>
+              <a:t>241</a:t>
             </a:r>
             <a:endParaRPr lang="en-US" sz="1050" dirty="0"/>
           </a:p>
@@ -13315,7 +13315,7 @@
                 <a:ea typeface="Calibri" pitchFamily="34" charset="-122"/>
                 <a:cs typeface="Calibri" pitchFamily="34" charset="-120"/>
               </a:rPr>
-              <a:t>Producto No Conforme</a:t>
+              <a:t>No Conformidad</a:t>
             </a:r>
             <a:endParaRPr lang="en-US" sz="1050" dirty="0"/>
           </a:p>
@@ -13393,7 +13393,7 @@
                 <a:ea typeface="Calibri" pitchFamily="34" charset="-122"/>
                 <a:cs typeface="Calibri" pitchFamily="34" charset="-120"/>
               </a:rPr>
-              <a:t>OO.CC</a:t>
+              <a:t>CALIDAD</a:t>
             </a:r>
             <a:endParaRPr lang="en-US" sz="1050" dirty="0"/>
           </a:p>
@@ -13432,7 +13432,7 @@
                 <a:ea typeface="Calibri" pitchFamily="34" charset="-122"/>
                 <a:cs typeface="Calibri" pitchFamily="34" charset="-120"/>
               </a:rPr>
-              <a:t>Wladimir Carvajal …</a:t>
+              <a:t>Daniel Ramirez B.</a:t>
             </a:r>
             <a:endParaRPr lang="en-US" sz="1050" dirty="0"/>
           </a:p>
@@ -13471,7 +13471,7 @@
                 <a:ea typeface="Calibri" pitchFamily="34" charset="-122"/>
                 <a:cs typeface="Calibri" pitchFamily="34" charset="-120"/>
               </a:rPr>
-              <a:t>Iniciado</a:t>
+              <a:t>Listo para revisi…</a:t>
             </a:r>
             <a:endParaRPr lang="en-US" sz="1050" dirty="0"/>
           </a:p>
@@ -13510,7 +13510,7 @@
                 <a:ea typeface="Calibri" pitchFamily="34" charset="-122"/>
                 <a:cs typeface="Calibri" pitchFamily="34" charset="-120"/>
               </a:rPr>
-              <a:t>147</a:t>
+              <a:t>27</a:t>
             </a:r>
             <a:endParaRPr lang="en-US" sz="1050" dirty="0"/>
           </a:p>
@@ -13549,7 +13549,7 @@
                 <a:ea typeface="Calibri" pitchFamily="34" charset="-122"/>
                 <a:cs typeface="Calibri" pitchFamily="34" charset="-120"/>
               </a:rPr>
-              <a:t>Corte en geomembrana HDPE instalada…</a:t>
+              <a:t>Registros de construcción no contie…</a:t>
             </a:r>
             <a:endParaRPr lang="en-US" sz="1000" dirty="0"/>
           </a:p>
@@ -13631,7 +13631,7 @@
                 <a:ea typeface="Calibri" pitchFamily="34" charset="-122"/>
                 <a:cs typeface="Calibri" pitchFamily="34" charset="-120"/>
               </a:rPr>
-              <a:t>205</a:t>
+              <a:t>243</a:t>
             </a:r>
             <a:endParaRPr lang="en-US" sz="1050" dirty="0"/>
           </a:p>
@@ -13670,7 +13670,7 @@
                 <a:ea typeface="Calibri" pitchFamily="34" charset="-122"/>
                 <a:cs typeface="Calibri" pitchFamily="34" charset="-120"/>
               </a:rPr>
-              <a:t>Producto No Conforme</a:t>
+              <a:t>No Conformidad</a:t>
             </a:r>
             <a:endParaRPr lang="en-US" sz="1050" dirty="0"/>
           </a:p>
@@ -13787,7 +13787,7 @@
                 <a:ea typeface="Calibri" pitchFamily="34" charset="-122"/>
                 <a:cs typeface="Calibri" pitchFamily="34" charset="-120"/>
               </a:rPr>
-              <a:t>Sebastián Ramos</a:t>
+              <a:t>Mauricio Rocha A.</a:t>
             </a:r>
             <a:endParaRPr lang="en-US" sz="1050" dirty="0"/>
           </a:p>
@@ -13826,7 +13826,7 @@
                 <a:ea typeface="Calibri" pitchFamily="34" charset="-122"/>
                 <a:cs typeface="Calibri" pitchFamily="34" charset="-120"/>
               </a:rPr>
-              <a:t>No aceptado</a:t>
+              <a:t>Listo para revisi…</a:t>
             </a:r>
             <a:endParaRPr lang="en-US" sz="1050" dirty="0"/>
           </a:p>
@@ -13865,7 +13865,7 @@
                 <a:ea typeface="Calibri" pitchFamily="34" charset="-122"/>
                 <a:cs typeface="Calibri" pitchFamily="34" charset="-120"/>
               </a:rPr>
-              <a:t>133</a:t>
+              <a:t>14</a:t>
             </a:r>
             <a:endParaRPr lang="en-US" sz="1050" dirty="0"/>
           </a:p>
@@ -13904,7 +13904,7 @@
                 <a:ea typeface="Calibri" pitchFamily="34" charset="-122"/>
                 <a:cs typeface="Calibri" pitchFamily="34" charset="-120"/>
               </a:rPr>
-              <a:t>Solución proyectada asociada al ele…</a:t>
+              <a:t>Rollos de geomembrana KRAH (2 mm es…</a:t>
             </a:r>
             <a:endParaRPr lang="en-US" sz="1000" dirty="0"/>
           </a:p>
@@ -13966,7 +13966,7 @@
                 <a:ea typeface="Calibri" pitchFamily="34" charset="-122"/>
                 <a:cs typeface="Calibri" pitchFamily="34" charset="-120"/>
               </a:rPr>
-              <a:t>209</a:t>
+              <a:t>244</a:t>
             </a:r>
             <a:endParaRPr lang="en-US" sz="1050" dirty="0"/>
           </a:p>
@@ -14122,7 +14122,7 @@
                 <a:ea typeface="Calibri" pitchFamily="34" charset="-122"/>
                 <a:cs typeface="Calibri" pitchFamily="34" charset="-120"/>
               </a:rPr>
-              <a:t>Sebastián Ramos</a:t>
+              <a:t>Mauricio Rocha A.</a:t>
             </a:r>
             <a:endParaRPr lang="en-US" sz="1050" dirty="0"/>
           </a:p>
@@ -14161,7 +14161,7 @@
                 <a:ea typeface="Calibri" pitchFamily="34" charset="-122"/>
                 <a:cs typeface="Calibri" pitchFamily="34" charset="-120"/>
               </a:rPr>
-              <a:t>Iniciado</a:t>
+              <a:t>Listo para revisi…</a:t>
             </a:r>
             <a:endParaRPr lang="en-US" sz="1050" dirty="0"/>
           </a:p>
@@ -14200,7 +14200,7 @@
                 <a:ea typeface="Calibri" pitchFamily="34" charset="-122"/>
                 <a:cs typeface="Calibri" pitchFamily="34" charset="-120"/>
               </a:rPr>
-              <a:t>125</a:t>
+              <a:t>14</a:t>
             </a:r>
             <a:endParaRPr lang="en-US" sz="1050" dirty="0"/>
           </a:p>
@@ -14239,7 +14239,7 @@
                 <a:ea typeface="Calibri" pitchFamily="34" charset="-122"/>
                 <a:cs typeface="Calibri" pitchFamily="34" charset="-120"/>
               </a:rPr>
-              <a:t>Sector Manifold EBMS, Fundaciones F…</a:t>
+              <a:t>En Piscina Quebrada Sur, se evidenc…</a:t>
             </a:r>
             <a:endParaRPr lang="en-US" sz="1000" dirty="0"/>
           </a:p>
@@ -14321,7 +14321,7 @@
                 <a:ea typeface="Calibri" pitchFamily="34" charset="-122"/>
                 <a:cs typeface="Calibri" pitchFamily="34" charset="-120"/>
               </a:rPr>
-              <a:t>230</a:t>
+              <a:t>247</a:t>
             </a:r>
             <a:endParaRPr lang="en-US" sz="1050" dirty="0"/>
           </a:p>
@@ -14438,7 +14438,7 @@
                 <a:ea typeface="Calibri" pitchFamily="34" charset="-122"/>
                 <a:cs typeface="Calibri" pitchFamily="34" charset="-120"/>
               </a:rPr>
-              <a:t>CALIDAD</a:t>
+              <a:t>OO.CC</a:t>
             </a:r>
             <a:endParaRPr lang="en-US" sz="1050" dirty="0"/>
           </a:p>
@@ -14477,7 +14477,7 @@
                 <a:ea typeface="Calibri" pitchFamily="34" charset="-122"/>
                 <a:cs typeface="Calibri" pitchFamily="34" charset="-120"/>
               </a:rPr>
-              <a:t>Mauricio Soto B.</a:t>
+              <a:t>Luis Ogalde H.</a:t>
             </a:r>
             <a:endParaRPr lang="en-US" sz="1050" dirty="0"/>
           </a:p>
@@ -14555,7 +14555,7 @@
                 <a:ea typeface="Calibri" pitchFamily="34" charset="-122"/>
                 <a:cs typeface="Calibri" pitchFamily="34" charset="-120"/>
               </a:rPr>
-              <a:t>69</a:t>
+              <a:t>5</a:t>
             </a:r>
             <a:endParaRPr lang="en-US" sz="1050" dirty="0"/>
           </a:p>
@@ -14594,7 +14594,7 @@
                 <a:ea typeface="Calibri" pitchFamily="34" charset="-122"/>
                 <a:cs typeface="Calibri" pitchFamily="34" charset="-120"/>
               </a:rPr>
-              <a:t>No se evidenció un Plan de Cierre d…</a:t>
+              <a:t>Fundaciones FS-01 (10 elementos) no…</a:t>
             </a:r>
             <a:endParaRPr lang="en-US" sz="1000" dirty="0"/>
           </a:p>
@@ -14656,7 +14656,7 @@
                 <a:ea typeface="Calibri" pitchFamily="34" charset="-122"/>
                 <a:cs typeface="Calibri" pitchFamily="34" charset="-120"/>
               </a:rPr>
-              <a:t>235</a:t>
+              <a:t>248</a:t>
             </a:r>
             <a:endParaRPr lang="en-US" sz="1050" dirty="0"/>
           </a:p>
@@ -14773,7 +14773,7 @@
                 <a:ea typeface="Calibri" pitchFamily="34" charset="-122"/>
                 <a:cs typeface="Calibri" pitchFamily="34" charset="-120"/>
               </a:rPr>
-              <a:t>OO.CC</a:t>
+              <a:t>PIPING</a:t>
             </a:r>
             <a:endParaRPr lang="en-US" sz="1050" dirty="0"/>
           </a:p>
@@ -14812,7 +14812,7 @@
                 <a:ea typeface="Calibri" pitchFamily="34" charset="-122"/>
                 <a:cs typeface="Calibri" pitchFamily="34" charset="-120"/>
               </a:rPr>
-              <a:t>Mauricio Rocha A.</a:t>
+              <a:t>Oscar Nahuel P.</a:t>
             </a:r>
             <a:endParaRPr lang="en-US" sz="1050" dirty="0"/>
           </a:p>
@@ -14890,7 +14890,7 @@
                 <a:ea typeface="Calibri" pitchFamily="34" charset="-122"/>
                 <a:cs typeface="Calibri" pitchFamily="34" charset="-120"/>
               </a:rPr>
-              <a:t>48</a:t>
+              <a:t>5</a:t>
             </a:r>
             <a:endParaRPr lang="en-US" sz="1050" dirty="0"/>
           </a:p>
@@ -14929,7 +14929,7 @@
                 <a:ea typeface="Calibri" pitchFamily="34" charset="-122"/>
                 <a:cs typeface="Calibri" pitchFamily="34" charset="-120"/>
               </a:rPr>
-              <a:t>Geomembrana presenta sectores en lo…</a:t>
+              <a:t>Línea TAG N° 3716D-RW-24-H1-0425-N …</a:t>
             </a:r>
             <a:endParaRPr lang="en-US" sz="1000" dirty="0"/>
           </a:p>
@@ -14960,46 +14960,7 @@
       </p:sp>
       <p:sp>
         <p:nvSpPr>
-          <p:cNvPr id="100" name="Text 97"/>
-          <p:cNvSpPr/>
-          <p:nvPr/>
-        </p:nvSpPr>
-        <p:spPr>
-          <a:xfrm>
-            <a:off x="502920" y="5440680"/>
-            <a:ext cx="8229600" cy="256032"/>
-          </a:xfrm>
-          <a:prstGeom prst="rect">
-            <a:avLst/>
-          </a:prstGeom>
-          <a:noFill/>
-          <a:ln/>
-        </p:spPr>
-        <p:txBody>
-          <a:bodyPr wrap="square" lIns="0" tIns="0" rIns="0" bIns="0" rtlCol="0" anchor="ctr"/>
-          <a:lstStyle/>
-          <a:p>
-            <a:pPr indent="0" marL="0">
-              <a:buNone/>
-            </a:pPr>
-            <a:r>
-              <a:rPr lang="en-US" sz="950" i="1" dirty="0">
-                <a:solidFill>
-                  <a:srgbClr val="56606E"/>
-                </a:solidFill>
-                <a:latin typeface="Calibri" pitchFamily="34" charset="0"/>
-                <a:ea typeface="Calibri" pitchFamily="34" charset="-122"/>
-                <a:cs typeface="Calibri" pitchFamily="34" charset="-120"/>
-              </a:rPr>
-              <a:t>Se listan los 9 más antiguos de 14 abiertos; el detalle completo está en el panel.</a:t>
-            </a:r>
-            <a:endParaRPr lang="en-US" sz="950" dirty="0"/>
-          </a:p>
-        </p:txBody>
-      </p:sp>
-      <p:sp>
-        <p:nvSpPr>
-          <p:cNvPr id="101" name="Shape 98"/>
+          <p:cNvPr id="100" name="Shape 97"/>
           <p:cNvSpPr/>
           <p:nvPr/>
         </p:nvSpPr>
@@ -15021,7 +14982,7 @@
       </p:sp>
       <p:sp>
         <p:nvSpPr>
-          <p:cNvPr id="102" name="Text 99"/>
+          <p:cNvPr id="101" name="Text 98"/>
           <p:cNvSpPr/>
           <p:nvPr/>
         </p:nvSpPr>
@@ -15052,7 +15013,7 @@
                 <a:ea typeface="Calibri" pitchFamily="34" charset="-122"/>
                 <a:cs typeface="Calibri" pitchFamily="34" charset="-120"/>
               </a:rPr>
-              <a:t>SEMANA 10-08-2026 — 16-08-2026</a:t>
+              <a:t>SEMANA 17-08-2026 — 23-08-2026</a:t>
             </a:r>
             <a:endParaRPr lang="en-US" sz="1000" dirty="0"/>
           </a:p>
@@ -15060,7 +15021,7 @@
       </p:sp>
       <p:sp>
         <p:nvSpPr>
-          <p:cNvPr id="103" name="Text 100"/>
+          <p:cNvPr id="102" name="Text 99"/>
           <p:cNvSpPr/>
           <p:nvPr/>
         </p:nvSpPr>
@@ -15091,7 +15052,7 @@
                 <a:ea typeface="Calibri" pitchFamily="34" charset="-122"/>
                 <a:cs typeface="Calibri" pitchFamily="34" charset="-120"/>
               </a:rPr>
-              <a:t>3 hallazgos nuevos · 0 internas · 3 del cliente · OO.CC 3 · 2 siguen abiertos</a:t>
+              <a:t>3 hallazgos nuevos · 0 internas · 3 del cliente · OO.CC 2 · PIPING 1 · 2 siguen abiertos</a:t>
             </a:r>
             <a:endParaRPr lang="en-US" sz="1150" dirty="0"/>
           </a:p>
@@ -15099,7 +15060,7 @@
       </p:sp>
       <p:sp>
         <p:nvSpPr>
-          <p:cNvPr id="104" name="Text 101"/>
+          <p:cNvPr id="103" name="Text 100"/>
           <p:cNvSpPr/>
           <p:nvPr/>
         </p:nvSpPr>
@@ -15130,7 +15091,7 @@
                 <a:ea typeface="Calibri" pitchFamily="34" charset="-122"/>
                 <a:cs typeface="Calibri" pitchFamily="34" charset="-120"/>
               </a:rPr>
-              <a:t>Fuente: Data_NCR17082026.xlsx — hoja «Observaciones» · Corte 17-08-2026 · 498 registros desde 10-02-2023</a:t>
+              <a:t>Fuente: Data_NCR24082026.xlsx — hoja «Observaciones» · Corte 24-08-2026 · 501 registros desde 10-02-2023</a:t>
             </a:r>
             <a:endParaRPr lang="en-US" sz="850" dirty="0"/>
           </a:p>
@@ -15138,7 +15099,7 @@
       </p:sp>
       <p:sp>
         <p:nvSpPr>
-          <p:cNvPr id="105" name="Text 102"/>
+          <p:cNvPr id="104" name="Text 101"/>
           <p:cNvSpPr/>
           <p:nvPr/>
         </p:nvSpPr>
@@ -15177,7 +15138,7 @@
       </p:sp>
       <p:sp>
         <p:nvSpPr>
-          <p:cNvPr id="106" name="Text 103"/>
+          <p:cNvPr id="105" name="Text 102"/>
           <p:cNvSpPr/>
           <p:nvPr/>
         </p:nvSpPr>
@@ -15542,7 +15503,7 @@
                 <a:ea typeface="Cambria" pitchFamily="34" charset="-122"/>
                 <a:cs typeface="Cambria" pitchFamily="34" charset="-120"/>
               </a:rPr>
-              <a:t>77,4%</a:t>
+              <a:t>78%</a:t>
             </a:r>
             <a:endParaRPr lang="en-US" sz="3400" dirty="0"/>
           </a:p>
@@ -15620,7 +15581,7 @@
                 <a:ea typeface="Cambria" pitchFamily="34" charset="-122"/>
                 <a:cs typeface="Cambria" pitchFamily="34" charset="-120"/>
               </a:rPr>
-              <a:t>37</a:t>
+              <a:t>36</a:t>
             </a:r>
             <a:endParaRPr lang="en-US" sz="3400" dirty="0"/>
           </a:p>
@@ -15698,7 +15659,7 @@
                 <a:ea typeface="Cambria" pitchFamily="34" charset="-122"/>
                 <a:cs typeface="Cambria" pitchFamily="34" charset="-120"/>
               </a:rPr>
-              <a:t>129 d</a:t>
+              <a:t>131 d</a:t>
             </a:r>
             <a:endParaRPr lang="en-US" sz="3400" dirty="0"/>
           </a:p>
@@ -15854,7 +15815,7 @@
                 <a:ea typeface="Calibri" pitchFamily="34" charset="-122"/>
                 <a:cs typeface="Calibri" pitchFamily="34" charset="-120"/>
               </a:rPr>
-              <a:t>Corte: 17-08-2026</a:t>
+              <a:t>Corte: 24-08-2026</a:t>
             </a:r>
             <a:endParaRPr lang="en-US" sz="1100" dirty="0"/>
           </a:p>
@@ -15893,7 +15854,7 @@
                 <a:ea typeface="Calibri" pitchFamily="34" charset="-122"/>
                 <a:cs typeface="Calibri" pitchFamily="34" charset="-120"/>
               </a:rPr>
-              <a:t>Fuente: Data_NCR17082026.xlsx — hoja «Observaciones» · Corte 17-08-2026 · 498 registros desde 10-02-2023</a:t>
+              <a:t>Fuente: Data_NCR24082026.xlsx — hoja «Observaciones» · Corte 24-08-2026 · 501 registros desde 10-02-2023</a:t>
             </a:r>
             <a:endParaRPr lang="en-US" sz="850" dirty="0"/>
           </a:p>
@@ -16198,7 +16159,7 @@
                 <a:ea typeface="Calibri" pitchFamily="34" charset="-122"/>
                 <a:cs typeface="Calibri" pitchFamily="34" charset="-120"/>
               </a:rPr>
-              <a:t>127 cerrados</a:t>
+              <a:t>128 cerrados</a:t>
             </a:r>
             <a:endParaRPr lang="en-US" sz="1400" dirty="0"/>
           </a:p>
@@ -16369,7 +16330,7 @@
                 <a:ea typeface="Cambria" pitchFamily="34" charset="-122"/>
                 <a:cs typeface="Cambria" pitchFamily="34" charset="-120"/>
               </a:rPr>
-              <a:t>77,4%</a:t>
+              <a:t>78%</a:t>
             </a:r>
             <a:endParaRPr lang="en-US" sz="4000" dirty="0"/>
           </a:p>
@@ -16408,7 +16369,7 @@
                 <a:ea typeface="Calibri" pitchFamily="34" charset="-122"/>
                 <a:cs typeface="Calibri" pitchFamily="34" charset="-120"/>
               </a:rPr>
-              <a:t>127/164</a:t>
+              <a:t>128/164</a:t>
             </a:r>
             <a:endParaRPr lang="en-US" sz="1400" dirty="0"/>
           </a:p>
@@ -16486,7 +16447,7 @@
                 <a:ea typeface="Calibri" pitchFamily="34" charset="-122"/>
                 <a:cs typeface="Calibri" pitchFamily="34" charset="-120"/>
               </a:rPr>
-              <a:t>Global del módulo: 89,6%</a:t>
+              <a:t>Global del módulo: 90,8%</a:t>
             </a:r>
             <a:endParaRPr lang="en-US" sz="950" dirty="0"/>
           </a:p>
@@ -16579,7 +16540,7 @@
                 <a:ea typeface="Cambria" pitchFamily="34" charset="-122"/>
                 <a:cs typeface="Cambria" pitchFamily="34" charset="-120"/>
               </a:rPr>
-              <a:t>37</a:t>
+              <a:t>36</a:t>
             </a:r>
             <a:endParaRPr lang="en-US" sz="4000" dirty="0"/>
           </a:p>
@@ -16696,7 +16657,7 @@
                 <a:ea typeface="Calibri" pitchFamily="34" charset="-122"/>
                 <a:cs typeface="Calibri" pitchFamily="34" charset="-120"/>
               </a:rPr>
-              <a:t>1 iniciado · 25 listo para revisión · 10 stand by · 1 observada</a:t>
+              <a:t>1 iniciado · 25 listo para revisión · 10 stand by</a:t>
             </a:r>
             <a:endParaRPr lang="en-US" sz="950" dirty="0"/>
           </a:p>
@@ -16789,7 +16750,7 @@
                 <a:ea typeface="Cambria" pitchFamily="34" charset="-122"/>
                 <a:cs typeface="Cambria" pitchFamily="34" charset="-120"/>
               </a:rPr>
-              <a:t>129</a:t>
+              <a:t>131</a:t>
             </a:r>
             <a:endParaRPr lang="en-US" sz="4000" dirty="0"/>
           </a:p>
@@ -16906,7 +16867,7 @@
                 <a:ea typeface="Calibri" pitchFamily="34" charset="-122"/>
                 <a:cs typeface="Calibri" pitchFamily="34" charset="-120"/>
               </a:rPr>
-              <a:t>el más lento tomó 313 días</a:t>
+              <a:t>el más lento tomó 409 días</a:t>
             </a:r>
             <a:endParaRPr lang="en-US" sz="950" dirty="0"/>
           </a:p>
@@ -17084,7 +17045,7 @@
                 <a:ea typeface="Calibri" pitchFamily="34" charset="-122"/>
                 <a:cs typeface="Calibri" pitchFamily="34" charset="-120"/>
               </a:rPr>
-              <a:t>global del módulo 32,5%</a:t>
+              <a:t>global del módulo 32,3%</a:t>
             </a:r>
             <a:endParaRPr lang="en-US" sz="1000" dirty="0"/>
           </a:p>
@@ -17342,7 +17303,7 @@
                 <a:ea typeface="Calibri" pitchFamily="34" charset="-122"/>
                 <a:cs typeface="Calibri" pitchFamily="34" charset="-120"/>
               </a:rPr>
-              <a:t>36 ab.</a:t>
+              <a:t>35 ab.</a:t>
             </a:r>
             <a:endParaRPr lang="en-US" sz="950" dirty="0"/>
           </a:p>
@@ -17557,7 +17518,7 @@
                 <a:ea typeface="Calibri" pitchFamily="34" charset="-122"/>
                 <a:cs typeface="Calibri" pitchFamily="34" charset="-120"/>
               </a:rPr>
-              <a:t>Fuente: Data_NCR17082026.xlsx — hoja «Observaciones» · Corte 17-08-2026 · 498 registros desde 10-02-2023</a:t>
+              <a:t>Fuente: Data_NCR24082026.xlsx — hoja «Observaciones» · Corte 24-08-2026 · 501 registros desde 10-02-2023</a:t>
             </a:r>
             <a:endParaRPr lang="en-US" sz="850" dirty="0"/>
           </a:p>
@@ -17808,7 +17769,7 @@
                 <a:ea typeface="Calibri" pitchFamily="34" charset="-122"/>
                 <a:cs typeface="Calibri" pitchFamily="34" charset="-120"/>
               </a:rPr>
-              <a:t>37 hallazgos siguen abiertos; 16 con más de 180 días. Se listan del más antiguo al más reciente.</a:t>
+              <a:t>36 hallazgos siguen abiertos; 17 con más de 180 días. Se listan del más antiguo al más reciente.</a:t>
             </a:r>
             <a:endParaRPr lang="en-US" sz="1350" dirty="0"/>
           </a:p>
@@ -18416,7 +18377,7 @@
                 <a:ea typeface="Calibri" pitchFamily="34" charset="-122"/>
                 <a:cs typeface="Calibri" pitchFamily="34" charset="-120"/>
               </a:rPr>
-              <a:t>409</a:t>
+              <a:t>416</a:t>
             </a:r>
             <a:endParaRPr lang="en-US" sz="1050" dirty="0"/>
           </a:p>
@@ -18537,7 +18498,7 @@
                 <a:ea typeface="Calibri" pitchFamily="34" charset="-122"/>
                 <a:cs typeface="Calibri" pitchFamily="34" charset="-120"/>
               </a:rPr>
-              <a:t>MASA-2</a:t>
+              <a:t>MASA-6</a:t>
             </a:r>
             <a:endParaRPr lang="en-US" sz="1050" dirty="0"/>
           </a:p>
@@ -18576,7 +18537,7 @@
                 <a:ea typeface="Calibri" pitchFamily="34" charset="-122"/>
                 <a:cs typeface="Calibri" pitchFamily="34" charset="-120"/>
               </a:rPr>
-              <a:t>No Conformidad</a:t>
+              <a:t>Observación</a:t>
             </a:r>
             <a:endParaRPr lang="en-US" sz="1050" dirty="0"/>
           </a:p>
@@ -18771,7 +18732,7 @@
                 <a:ea typeface="Calibri" pitchFamily="34" charset="-122"/>
                 <a:cs typeface="Calibri" pitchFamily="34" charset="-120"/>
               </a:rPr>
-              <a:t>406</a:t>
+              <a:t>382</a:t>
             </a:r>
             <a:endParaRPr lang="en-US" sz="1050" dirty="0"/>
           </a:p>
@@ -18810,7 +18771,7 @@
                 <a:ea typeface="Calibri" pitchFamily="34" charset="-122"/>
                 <a:cs typeface="Calibri" pitchFamily="34" charset="-120"/>
               </a:rPr>
-              <a:t>Uniones soldadas y touch-up en tolv…</a:t>
+              <a:t>Condición del grout de nivelación e…</a:t>
             </a:r>
             <a:endParaRPr lang="en-US" sz="1000" dirty="0"/>
           </a:p>
@@ -18872,7 +18833,7 @@
                 <a:ea typeface="Calibri" pitchFamily="34" charset="-122"/>
                 <a:cs typeface="Calibri" pitchFamily="34" charset="-120"/>
               </a:rPr>
-              <a:t>MASA-6</a:t>
+              <a:t>MASA-8</a:t>
             </a:r>
             <a:endParaRPr lang="en-US" sz="1050" dirty="0"/>
           </a:p>
@@ -19106,7 +19067,7 @@
                 <a:ea typeface="Calibri" pitchFamily="34" charset="-122"/>
                 <a:cs typeface="Calibri" pitchFamily="34" charset="-120"/>
               </a:rPr>
-              <a:t>375</a:t>
+              <a:t>370</a:t>
             </a:r>
             <a:endParaRPr lang="en-US" sz="1050" dirty="0"/>
           </a:p>
@@ -19145,7 +19106,7 @@
                 <a:ea typeface="Calibri" pitchFamily="34" charset="-122"/>
                 <a:cs typeface="Calibri" pitchFamily="34" charset="-120"/>
               </a:rPr>
-              <a:t>Condición del grout de nivelación e…</a:t>
+              <a:t>Montaje de estructura metálica sin …</a:t>
             </a:r>
             <a:endParaRPr lang="en-US" sz="1000" dirty="0"/>
           </a:p>
@@ -19227,7 +19188,7 @@
                 <a:ea typeface="Calibri" pitchFamily="34" charset="-122"/>
                 <a:cs typeface="Calibri" pitchFamily="34" charset="-120"/>
               </a:rPr>
-              <a:t>MASA-8</a:t>
+              <a:t>MASA-10</a:t>
             </a:r>
             <a:endParaRPr lang="en-US" sz="1050" dirty="0"/>
           </a:p>
@@ -19461,7 +19422,7 @@
                 <a:ea typeface="Calibri" pitchFamily="34" charset="-122"/>
                 <a:cs typeface="Calibri" pitchFamily="34" charset="-120"/>
               </a:rPr>
-              <a:t>363</a:t>
+              <a:t>342</a:t>
             </a:r>
             <a:endParaRPr lang="en-US" sz="1050" dirty="0"/>
           </a:p>
@@ -19500,7 +19461,7 @@
                 <a:ea typeface="Calibri" pitchFamily="34" charset="-122"/>
                 <a:cs typeface="Calibri" pitchFamily="34" charset="-120"/>
               </a:rPr>
-              <a:t>Montaje de estructura metálica sin …</a:t>
+              <a:t>Vigas (puntales) Montadas Fuera de …</a:t>
             </a:r>
             <a:endParaRPr lang="en-US" sz="1000" dirty="0"/>
           </a:p>
@@ -19562,7 +19523,7 @@
                 <a:ea typeface="Calibri" pitchFamily="34" charset="-122"/>
                 <a:cs typeface="Calibri" pitchFamily="34" charset="-120"/>
               </a:rPr>
-              <a:t>MASA-10</a:t>
+              <a:t>MASA-21</a:t>
             </a:r>
             <a:endParaRPr lang="en-US" sz="1050" dirty="0"/>
           </a:p>
@@ -19601,7 +19562,7 @@
                 <a:ea typeface="Calibri" pitchFamily="34" charset="-122"/>
                 <a:cs typeface="Calibri" pitchFamily="34" charset="-120"/>
               </a:rPr>
-              <a:t>Observación</a:t>
+              <a:t>No Conformidad</a:t>
             </a:r>
             <a:endParaRPr lang="en-US" sz="1050" dirty="0"/>
           </a:p>
@@ -19796,7 +19757,7 @@
                 <a:ea typeface="Calibri" pitchFamily="34" charset="-122"/>
                 <a:cs typeface="Calibri" pitchFamily="34" charset="-120"/>
               </a:rPr>
-              <a:t>335</a:t>
+              <a:t>312</a:t>
             </a:r>
             <a:endParaRPr lang="en-US" sz="1050" dirty="0"/>
           </a:p>
@@ -19835,7 +19796,7 @@
                 <a:ea typeface="Calibri" pitchFamily="34" charset="-122"/>
                 <a:cs typeface="Calibri" pitchFamily="34" charset="-120"/>
               </a:rPr>
-              <a:t>Vigas (puntales) Montadas Fuera de …</a:t>
+              <a:t>Informe Técnico de Inspección – Fis…</a:t>
             </a:r>
             <a:endParaRPr lang="en-US" sz="1000" dirty="0"/>
           </a:p>
@@ -19917,7 +19878,7 @@
                 <a:ea typeface="Calibri" pitchFamily="34" charset="-122"/>
                 <a:cs typeface="Calibri" pitchFamily="34" charset="-120"/>
               </a:rPr>
-              <a:t>MASA-21</a:t>
+              <a:t>MASA-24</a:t>
             </a:r>
             <a:endParaRPr lang="en-US" sz="1050" dirty="0"/>
           </a:p>
@@ -20112,7 +20073,7 @@
                 <a:ea typeface="Calibri" pitchFamily="34" charset="-122"/>
                 <a:cs typeface="Calibri" pitchFamily="34" charset="-120"/>
               </a:rPr>
-              <a:t>Listo para revisi…</a:t>
+              <a:t>Stand By</a:t>
             </a:r>
             <a:endParaRPr lang="en-US" sz="1050" dirty="0"/>
           </a:p>
@@ -20151,7 +20112,7 @@
                 <a:ea typeface="Calibri" pitchFamily="34" charset="-122"/>
                 <a:cs typeface="Calibri" pitchFamily="34" charset="-120"/>
               </a:rPr>
-              <a:t>305</a:t>
+              <a:t>312</a:t>
             </a:r>
             <a:endParaRPr lang="en-US" sz="1050" dirty="0"/>
           </a:p>
@@ -20190,7 +20151,7 @@
                 <a:ea typeface="Calibri" pitchFamily="34" charset="-122"/>
                 <a:cs typeface="Calibri" pitchFamily="34" charset="-120"/>
               </a:rPr>
-              <a:t>Informe Técnico de Inspección – Fis…</a:t>
+              <a:t>Inspección grout de los recesos de …</a:t>
             </a:r>
             <a:endParaRPr lang="en-US" sz="1000" dirty="0"/>
           </a:p>
@@ -20252,7 +20213,7 @@
                 <a:ea typeface="Calibri" pitchFamily="34" charset="-122"/>
                 <a:cs typeface="Calibri" pitchFamily="34" charset="-120"/>
               </a:rPr>
-              <a:t>MASA-24</a:t>
+              <a:t>MASA-28</a:t>
             </a:r>
             <a:endParaRPr lang="en-US" sz="1050" dirty="0"/>
           </a:p>
@@ -20291,7 +20252,7 @@
                 <a:ea typeface="Calibri" pitchFamily="34" charset="-122"/>
                 <a:cs typeface="Calibri" pitchFamily="34" charset="-120"/>
               </a:rPr>
-              <a:t>No Conformidad</a:t>
+              <a:t>Observación</a:t>
             </a:r>
             <a:endParaRPr lang="en-US" sz="1050" dirty="0"/>
           </a:p>
@@ -20447,7 +20408,7 @@
                 <a:ea typeface="Calibri" pitchFamily="34" charset="-122"/>
                 <a:cs typeface="Calibri" pitchFamily="34" charset="-120"/>
               </a:rPr>
-              <a:t>Stand By</a:t>
+              <a:t>Listo para revisi…</a:t>
             </a:r>
             <a:endParaRPr lang="en-US" sz="1050" dirty="0"/>
           </a:p>
@@ -20486,7 +20447,7 @@
                 <a:ea typeface="Calibri" pitchFamily="34" charset="-122"/>
                 <a:cs typeface="Calibri" pitchFamily="34" charset="-120"/>
               </a:rPr>
-              <a:t>305</a:t>
+              <a:t>291</a:t>
             </a:r>
             <a:endParaRPr lang="en-US" sz="1050" dirty="0"/>
           </a:p>
@@ -20525,7 +20486,7 @@
                 <a:ea typeface="Calibri" pitchFamily="34" charset="-122"/>
                 <a:cs typeface="Calibri" pitchFamily="34" charset="-120"/>
               </a:rPr>
-              <a:t>Inspección grout de los recesos de …</a:t>
+              <a:t>Cámara 3700-MH-002, salida sala elé…</a:t>
             </a:r>
             <a:endParaRPr lang="en-US" sz="1000" dirty="0"/>
           </a:p>
@@ -20607,7 +20568,7 @@
                 <a:ea typeface="Calibri" pitchFamily="34" charset="-122"/>
                 <a:cs typeface="Calibri" pitchFamily="34" charset="-120"/>
               </a:rPr>
-              <a:t>MASA-28</a:t>
+              <a:t>MASA-30</a:t>
             </a:r>
             <a:endParaRPr lang="en-US" sz="1050" dirty="0"/>
           </a:p>
@@ -20841,7 +20802,7 @@
                 <a:ea typeface="Calibri" pitchFamily="34" charset="-122"/>
                 <a:cs typeface="Calibri" pitchFamily="34" charset="-120"/>
               </a:rPr>
-              <a:t>284</a:t>
+              <a:t>287</a:t>
             </a:r>
             <a:endParaRPr lang="en-US" sz="1050" dirty="0"/>
           </a:p>
@@ -20880,7 +20841,7 @@
                 <a:ea typeface="Calibri" pitchFamily="34" charset="-122"/>
                 <a:cs typeface="Calibri" pitchFamily="34" charset="-120"/>
               </a:rPr>
-              <a:t>Cámara 3700-MH-002, salida sala elé…</a:t>
+              <a:t>Fundaciones faltantes para apoyo de…</a:t>
             </a:r>
             <a:endParaRPr lang="en-US" sz="1000" dirty="0"/>
           </a:p>
@@ -20942,7 +20903,7 @@
                 <a:ea typeface="Calibri" pitchFamily="34" charset="-122"/>
                 <a:cs typeface="Calibri" pitchFamily="34" charset="-120"/>
               </a:rPr>
-              <a:t>MASA-30</a:t>
+              <a:t>MASA-37</a:t>
             </a:r>
             <a:endParaRPr lang="en-US" sz="1050" dirty="0"/>
           </a:p>
@@ -20981,7 +20942,7 @@
                 <a:ea typeface="Calibri" pitchFamily="34" charset="-122"/>
                 <a:cs typeface="Calibri" pitchFamily="34" charset="-120"/>
               </a:rPr>
-              <a:t>Observación</a:t>
+              <a:t>No Conformidad</a:t>
             </a:r>
             <a:endParaRPr lang="en-US" sz="1050" dirty="0"/>
           </a:p>
@@ -21176,7 +21137,7 @@
                 <a:ea typeface="Calibri" pitchFamily="34" charset="-122"/>
                 <a:cs typeface="Calibri" pitchFamily="34" charset="-120"/>
               </a:rPr>
-              <a:t>280</a:t>
+              <a:t>250</a:t>
             </a:r>
             <a:endParaRPr lang="en-US" sz="1050" dirty="0"/>
           </a:p>
@@ -21215,7 +21176,7 @@
                 <a:ea typeface="Calibri" pitchFamily="34" charset="-122"/>
                 <a:cs typeface="Calibri" pitchFamily="34" charset="-120"/>
               </a:rPr>
-              <a:t>Fundaciones faltantes para apoyo de…</a:t>
+              <a:t>Tolerancia transversal en chutes de…</a:t>
             </a:r>
             <a:endParaRPr lang="en-US" sz="1000" dirty="0"/>
           </a:p>
@@ -21277,7 +21238,7 @@
                 <a:ea typeface="Calibri" pitchFamily="34" charset="-122"/>
                 <a:cs typeface="Calibri" pitchFamily="34" charset="-120"/>
               </a:rPr>
-              <a:t>Se listan los 9 más antiguos de 37 abiertos; el detalle completo está en el panel.</a:t>
+              <a:t>Se listan los 9 más antiguos de 36 abiertos; el detalle completo está en el panel.</a:t>
             </a:r>
             <a:endParaRPr lang="en-US" sz="950" dirty="0"/>
           </a:p>
@@ -21338,7 +21299,7 @@
                 <a:ea typeface="Calibri" pitchFamily="34" charset="-122"/>
                 <a:cs typeface="Calibri" pitchFamily="34" charset="-120"/>
               </a:rPr>
-              <a:t>SEMANA 10-08-2026 — 16-08-2026</a:t>
+              <a:t>SEMANA 17-08-2026 — 23-08-2026</a:t>
             </a:r>
             <a:endParaRPr lang="en-US" sz="1000" dirty="0"/>
           </a:p>
@@ -21416,7 +21377,7 @@
                 <a:ea typeface="Calibri" pitchFamily="34" charset="-122"/>
                 <a:cs typeface="Calibri" pitchFamily="34" charset="-120"/>
               </a:rPr>
-              <a:t>Fuente: Data_NCR17082026.xlsx — hoja «Observaciones» · Corte 17-08-2026 · 498 registros desde 10-02-2023</a:t>
+              <a:t>Fuente: Data_NCR24082026.xlsx — hoja «Observaciones» · Corte 24-08-2026 · 501 registros desde 10-02-2023</a:t>
             </a:r>
             <a:endParaRPr lang="en-US" sz="850" dirty="0"/>
           </a:p>
@@ -21721,7 +21682,7 @@
                 <a:ea typeface="Cambria" pitchFamily="34" charset="-122"/>
                 <a:cs typeface="Cambria" pitchFamily="34" charset="-120"/>
               </a:rPr>
-              <a:t>89,6%</a:t>
+              <a:t>90,8%</a:t>
             </a:r>
             <a:endParaRPr lang="en-US" sz="4000" dirty="0"/>
           </a:p>
@@ -21760,7 +21721,7 @@
                 <a:ea typeface="Calibri" pitchFamily="34" charset="-122"/>
                 <a:cs typeface="Calibri" pitchFamily="34" charset="-120"/>
               </a:rPr>
-              <a:t>446/498</a:t>
+              <a:t>455/501</a:t>
             </a:r>
             <a:endParaRPr lang="en-US" sz="1400" dirty="0"/>
           </a:p>
@@ -21838,7 +21799,7 @@
                 <a:ea typeface="Calibri" pitchFamily="34" charset="-122"/>
                 <a:cs typeface="Calibri" pitchFamily="34" charset="-120"/>
               </a:rPr>
-              <a:t>52 abiertos · 19 con más de 180 días</a:t>
+              <a:t>46 abiertos · 17 con más de 180 días</a:t>
             </a:r>
             <a:endParaRPr lang="en-US" sz="950" dirty="0"/>
           </a:p>
@@ -21931,7 +21892,7 @@
                 <a:ea typeface="Cambria" pitchFamily="34" charset="-122"/>
                 <a:cs typeface="Cambria" pitchFamily="34" charset="-120"/>
               </a:rPr>
-              <a:t>52</a:t>
+              <a:t>46</a:t>
             </a:r>
             <a:endParaRPr lang="en-US" sz="4000" dirty="0"/>
           </a:p>
@@ -21970,7 +21931,7 @@
                 <a:ea typeface="Calibri" pitchFamily="34" charset="-122"/>
                 <a:cs typeface="Calibri" pitchFamily="34" charset="-120"/>
               </a:rPr>
-              <a:t>de 498 levantados</a:t>
+              <a:t>de 501 levantados</a:t>
             </a:r>
             <a:endParaRPr lang="en-US" sz="1400" dirty="0"/>
           </a:p>
@@ -22048,7 +22009,7 @@
                 <a:ea typeface="Calibri" pitchFamily="34" charset="-122"/>
                 <a:cs typeface="Calibri" pitchFamily="34" charset="-120"/>
               </a:rPr>
-              <a:t>14 iniciado · 1 no aceptado · 26 listo para revisión · 10 stand by · 1 observada</a:t>
+              <a:t>6 iniciado · 1 no aceptado · 29 listo para revisión · 10 stand by</a:t>
             </a:r>
             <a:endParaRPr lang="en-US" sz="950" dirty="0"/>
           </a:p>
@@ -22141,7 +22102,7 @@
                 <a:ea typeface="Cambria" pitchFamily="34" charset="-122"/>
                 <a:cs typeface="Cambria" pitchFamily="34" charset="-120"/>
               </a:rPr>
-              <a:t>32,5%</a:t>
+              <a:t>32,3%</a:t>
             </a:r>
             <a:endParaRPr lang="en-US" sz="4000" dirty="0"/>
           </a:p>
@@ -22180,7 +22141,7 @@
                 <a:ea typeface="Calibri" pitchFamily="34" charset="-122"/>
                 <a:cs typeface="Calibri" pitchFamily="34" charset="-120"/>
               </a:rPr>
-              <a:t>159/489 clasificados</a:t>
+              <a:t>159/492 clasificados</a:t>
             </a:r>
             <a:endParaRPr lang="en-US" sz="1400" dirty="0"/>
           </a:p>
@@ -22390,7 +22351,7 @@
                 <a:ea typeface="Calibri" pitchFamily="34" charset="-122"/>
                 <a:cs typeface="Calibri" pitchFamily="34" charset="-120"/>
               </a:rPr>
-              <a:t>251 de 498 con costo</a:t>
+              <a:t>251 de 501 con costo</a:t>
             </a:r>
             <a:endParaRPr lang="en-US" sz="1400" dirty="0"/>
           </a:p>
@@ -22468,7 +22429,7 @@
                 <a:ea typeface="Calibri" pitchFamily="34" charset="-122"/>
                 <a:cs typeface="Calibri" pitchFamily="34" charset="-120"/>
               </a:rPr>
-              <a:t>247 hallazgos no declaran costo: la cifra es un piso</a:t>
+              <a:t>250 hallazgos no declaran costo: la cifra es un piso</a:t>
             </a:r>
             <a:endParaRPr lang="en-US" sz="950" dirty="0"/>
           </a:p>
@@ -22608,7 +22569,7 @@
                 <a:ea typeface="Calibri" pitchFamily="34" charset="-122"/>
                 <a:cs typeface="Calibri" pitchFamily="34" charset="-120"/>
               </a:rPr>
-              <a:t>37 de los 52 hallazgos abiertos (71,2%), y es uno de los frentes donde el cliente levanta más de lo que detecta Besalco (71 del cliente contra 53 internas).</a:t>
+              <a:t>36 de los 46 hallazgos abiertos (78,3%), y es uno de los frentes donde el cliente levanta más de lo que detecta Besalco (71 del cliente contra 53 internas).</a:t>
             </a:r>
             <a:endParaRPr lang="en-US" sz="1250" dirty="0"/>
           </a:p>
@@ -22687,7 +22648,7 @@
                 <a:ea typeface="Calibri" pitchFamily="34" charset="-122"/>
                 <a:cs typeface="Calibri" pitchFamily="34" charset="-120"/>
               </a:rPr>
-              <a:t>10-08-2026 al 16-08-2026: 3 del cliente en OO.CC (3). 2 siguen abiertos; la semana anterior entraron 1.</a:t>
+              <a:t>17-08-2026 al 23-08-2026: 3 del cliente en OO.CC (2) y PIPING (1). 2 siguen abiertos; la semana anterior entraron 3.</a:t>
             </a:r>
             <a:endParaRPr lang="en-US" sz="1250" dirty="0"/>
           </a:p>
@@ -22749,7 +22710,7 @@
                 <a:ea typeface="Calibri" pitchFamily="34" charset="-122"/>
                 <a:cs typeface="Calibri" pitchFamily="34" charset="-120"/>
               </a:rPr>
-              <a:t>50 de los 52 abiertos están fuera del plazo de respuesta.  </a:t>
+              <a:t>44 de los 46 abiertos están fuera del plazo de respuesta.  </a:t>
             </a:r>
             <a:pPr indent="0" marL="0">
               <a:lnSpc>
@@ -22766,7 +22727,7 @@
                 <a:ea typeface="Calibri" pitchFamily="34" charset="-122"/>
                 <a:cs typeface="Calibri" pitchFamily="34" charset="-120"/>
               </a:rPr>
-              <a:t>El plazo es de 10 días desde que se emite la NC. De los atrasados, 19 llevan más de 180 días abiertos y 4 más de un año: no es atraso de días, es deuda vieja.</a:t>
+              <a:t>El plazo es de 10 días desde que se emite la NC. De los atrasados, 17 llevan más de 180 días abiertos y 3 más de un año: no es atraso de días, es deuda vieja.</a:t>
             </a:r>
             <a:endParaRPr lang="en-US" sz="1250" dirty="0"/>
           </a:p>
@@ -22805,7 +22766,7 @@
                 <a:ea typeface="Calibri" pitchFamily="34" charset="-122"/>
                 <a:cs typeface="Calibri" pitchFamily="34" charset="-120"/>
               </a:rPr>
-              <a:t>Fuente: Data_NCR17082026.xlsx — hoja «Observaciones» · Corte 17-08-2026 · 498 registros desde 10-02-2023</a:t>
+              <a:t>Fuente: Data_NCR24082026.xlsx — hoja «Observaciones» · Corte 24-08-2026 · 501 registros desde 10-02-2023</a:t>
             </a:r>
             <a:endParaRPr lang="en-US" sz="850" dirty="0"/>
           </a:p>
@@ -24080,7 +24041,7 @@
                 <a:ea typeface="Calibri" pitchFamily="34" charset="-122"/>
                 <a:cs typeface="Calibri" pitchFamily="34" charset="-120"/>
               </a:rPr>
-              <a:t>244</a:t>
+              <a:t>247</a:t>
             </a:r>
             <a:endParaRPr lang="en-US" sz="1300" dirty="0"/>
           </a:p>
@@ -24119,7 +24080,7 @@
                 <a:ea typeface="Calibri" pitchFamily="34" charset="-122"/>
                 <a:cs typeface="Calibri" pitchFamily="34" charset="-120"/>
               </a:rPr>
-              <a:t>230</a:t>
+              <a:t>238</a:t>
             </a:r>
             <a:endParaRPr lang="en-US" sz="1300" dirty="0"/>
           </a:p>
@@ -24158,7 +24119,7 @@
                 <a:ea typeface="Calibri" pitchFamily="34" charset="-122"/>
                 <a:cs typeface="Calibri" pitchFamily="34" charset="-120"/>
               </a:rPr>
-              <a:t>14</a:t>
+              <a:t>9</a:t>
             </a:r>
             <a:endParaRPr lang="en-US" sz="1300" dirty="0"/>
           </a:p>
@@ -24197,7 +24158,7 @@
                 <a:ea typeface="Calibri" pitchFamily="34" charset="-122"/>
                 <a:cs typeface="Calibri" pitchFamily="34" charset="-120"/>
               </a:rPr>
-              <a:t>94,3%</a:t>
+              <a:t>96,4%</a:t>
             </a:r>
             <a:endParaRPr lang="en-US" sz="1300" dirty="0"/>
           </a:p>
@@ -24275,7 +24236,7 @@
                 <a:ea typeface="Calibri" pitchFamily="34" charset="-122"/>
                 <a:cs typeface="Calibri" pitchFamily="34" charset="-120"/>
               </a:rPr>
-              <a:t>192</a:t>
+              <a:t>195</a:t>
             </a:r>
             <a:endParaRPr lang="en-US" sz="1300" dirty="0"/>
           </a:p>
@@ -24593,7 +24554,7 @@
                 <a:ea typeface="Calibri" pitchFamily="34" charset="-122"/>
                 <a:cs typeface="Calibri" pitchFamily="34" charset="-120"/>
               </a:rPr>
-              <a:t>127</a:t>
+              <a:t>128</a:t>
             </a:r>
             <a:endParaRPr lang="en-US" sz="1300" dirty="0"/>
           </a:p>
@@ -24632,7 +24593,7 @@
                 <a:ea typeface="Calibri" pitchFamily="34" charset="-122"/>
                 <a:cs typeface="Calibri" pitchFamily="34" charset="-120"/>
               </a:rPr>
-              <a:t>37</a:t>
+              <a:t>36</a:t>
             </a:r>
             <a:endParaRPr lang="en-US" sz="1300" dirty="0"/>
           </a:p>
@@ -24671,7 +24632,7 @@
                 <a:ea typeface="Calibri" pitchFamily="34" charset="-122"/>
                 <a:cs typeface="Calibri" pitchFamily="34" charset="-120"/>
               </a:rPr>
-              <a:t>77,4%</a:t>
+              <a:t>78%</a:t>
             </a:r>
             <a:endParaRPr lang="en-US" sz="1300" dirty="0"/>
           </a:p>
@@ -25522,7 +25483,7 @@
                 <a:ea typeface="Calibri" pitchFamily="34" charset="-122"/>
                 <a:cs typeface="Calibri" pitchFamily="34" charset="-120"/>
               </a:rPr>
-              <a:t>490</a:t>
+              <a:t>493</a:t>
             </a:r>
             <a:endParaRPr lang="en-US" sz="1300" dirty="0"/>
           </a:p>
@@ -25561,7 +25522,7 @@
                 <a:ea typeface="Calibri" pitchFamily="34" charset="-122"/>
                 <a:cs typeface="Calibri" pitchFamily="34" charset="-120"/>
               </a:rPr>
-              <a:t>438</a:t>
+              <a:t>447</a:t>
             </a:r>
             <a:endParaRPr lang="en-US" sz="1300" dirty="0"/>
           </a:p>
@@ -25600,7 +25561,7 @@
                 <a:ea typeface="Calibri" pitchFamily="34" charset="-122"/>
                 <a:cs typeface="Calibri" pitchFamily="34" charset="-120"/>
               </a:rPr>
-              <a:t>52</a:t>
+              <a:t>46</a:t>
             </a:r>
             <a:endParaRPr lang="en-US" sz="1300" dirty="0"/>
           </a:p>
@@ -25639,7 +25600,7 @@
                 <a:ea typeface="Calibri" pitchFamily="34" charset="-122"/>
                 <a:cs typeface="Calibri" pitchFamily="34" charset="-120"/>
               </a:rPr>
-              <a:t>89,4%</a:t>
+              <a:t>90,7%</a:t>
             </a:r>
             <a:endParaRPr lang="en-US" sz="1300" dirty="0"/>
           </a:p>
@@ -25717,7 +25678,7 @@
                 <a:ea typeface="Calibri" pitchFamily="34" charset="-122"/>
                 <a:cs typeface="Calibri" pitchFamily="34" charset="-120"/>
               </a:rPr>
-              <a:t>282</a:t>
+              <a:t>285</a:t>
             </a:r>
             <a:endParaRPr lang="en-US" sz="1300" dirty="0"/>
           </a:p>
@@ -25834,7 +25795,7 @@
                 <a:ea typeface="Calibri" pitchFamily="34" charset="-122"/>
                 <a:cs typeface="Calibri" pitchFamily="34" charset="-120"/>
               </a:rPr>
-              <a:t>Mediana de cierre global 30 días · el hallazgo más lento tomó 389 días · 79 hallazgos sin especialidad declarada.</a:t>
+              <a:t>Mediana de cierre global 30 días · el hallazgo más lento tomó 409 días · 79 hallazgos sin especialidad declarada.</a:t>
             </a:r>
             <a:endParaRPr lang="en-US" sz="950" dirty="0"/>
           </a:p>
@@ -25873,7 +25834,7 @@
                 <a:ea typeface="Calibri" pitchFamily="34" charset="-122"/>
                 <a:cs typeface="Calibri" pitchFamily="34" charset="-120"/>
               </a:rPr>
-              <a:t>Fuente: Data_NCR17082026.xlsx — hoja «Observaciones» · Corte 17-08-2026 · 498 registros desde 10-02-2023</a:t>
+              <a:t>Fuente: Data_NCR24082026.xlsx — hoja «Observaciones» · Corte 24-08-2026 · 501 registros desde 10-02-2023</a:t>
             </a:r>
             <a:endParaRPr lang="en-US" sz="850" dirty="0"/>
           </a:p>
@@ -26124,7 +26085,7 @@
                 <a:ea typeface="Calibri" pitchFamily="34" charset="-122"/>
                 <a:cs typeface="Calibri" pitchFamily="34" charset="-120"/>
               </a:rPr>
-              <a:t>Entre el 10-08-2026 y el 16-08-2026 se levantaron 3 hallazgos: 0 internas · 3 del cliente. 2 siguen abiertos.</a:t>
+              <a:t>Entre el 17-08-2026 y el 23-08-2026 se levantaron 3 hallazgos: 0 internas · 3 del cliente. 2 siguen abiertos.</a:t>
             </a:r>
             <a:endParaRPr lang="en-US" sz="1350" dirty="0"/>
           </a:p>
@@ -26279,7 +26240,7 @@
                 <a:ea typeface="Calibri" pitchFamily="34" charset="-122"/>
                 <a:cs typeface="Calibri" pitchFamily="34" charset="-120"/>
               </a:rPr>
-              <a:t>OO.CC 3</a:t>
+              <a:t>OO.CC 2  ·  PIPING 1</a:t>
             </a:r>
             <a:endParaRPr lang="en-US" sz="1100" dirty="0"/>
           </a:p>
@@ -26513,7 +26474,7 @@
                 <a:ea typeface="Calibri" pitchFamily="34" charset="-122"/>
                 <a:cs typeface="Calibri" pitchFamily="34" charset="-120"/>
               </a:rPr>
-              <a:t>No Conformidad 3</a:t>
+              <a:t>No Conformidad 2  ·  Producto No Conforme 1</a:t>
             </a:r>
             <a:endParaRPr lang="en-US" sz="1100" dirty="0"/>
           </a:p>
@@ -26965,7 +26926,7 @@
                 <a:ea typeface="Calibri" pitchFamily="34" charset="-122"/>
                 <a:cs typeface="Calibri" pitchFamily="34" charset="-120"/>
               </a:rPr>
-              <a:t>10-08-2026</a:t>
+              <a:t>18-08-2026</a:t>
             </a:r>
             <a:endParaRPr lang="en-US" sz="1050" dirty="0"/>
           </a:p>
@@ -27043,7 +27004,7 @@
                 <a:ea typeface="Calibri" pitchFamily="34" charset="-122"/>
                 <a:cs typeface="Calibri" pitchFamily="34" charset="-120"/>
               </a:rPr>
-              <a:t>243 · RNC N°453</a:t>
+              <a:t>246 · PNC N°189</a:t>
             </a:r>
             <a:endParaRPr lang="en-US" sz="1050" dirty="0"/>
           </a:p>
@@ -27082,7 +27043,7 @@
                 <a:ea typeface="Calibri" pitchFamily="34" charset="-122"/>
                 <a:cs typeface="Calibri" pitchFamily="34" charset="-120"/>
               </a:rPr>
-              <a:t>No Conformidad</a:t>
+              <a:t>Producto No Confor…</a:t>
             </a:r>
             <a:endParaRPr lang="en-US" sz="1050" dirty="0"/>
           </a:p>
@@ -27199,7 +27160,7 @@
                 <a:ea typeface="Calibri" pitchFamily="34" charset="-122"/>
                 <a:cs typeface="Calibri" pitchFamily="34" charset="-120"/>
               </a:rPr>
-              <a:t>Mauricio Rocha A.</a:t>
+              <a:t>Luis Ogalde H.</a:t>
             </a:r>
             <a:endParaRPr lang="en-US" sz="1050" dirty="0"/>
           </a:p>
@@ -27232,13 +27193,13 @@
             <a:r>
               <a:rPr lang="en-US" sz="1050" dirty="0">
                 <a:solidFill>
-                  <a:srgbClr val="C0392B"/>
-                </a:solidFill>
-                <a:latin typeface="Calibri" pitchFamily="34" charset="0"/>
-                <a:ea typeface="Calibri" pitchFamily="34" charset="-122"/>
-                <a:cs typeface="Calibri" pitchFamily="34" charset="-120"/>
-              </a:rPr>
-              <a:t>Iniciado</a:t>
+                  <a:srgbClr val="1F7A44"/>
+                </a:solidFill>
+                <a:latin typeface="Calibri" pitchFamily="34" charset="0"/>
+                <a:ea typeface="Calibri" pitchFamily="34" charset="-122"/>
+                <a:cs typeface="Calibri" pitchFamily="34" charset="-120"/>
+              </a:rPr>
+              <a:t>Cerrado</a:t>
             </a:r>
             <a:endParaRPr lang="en-US" sz="1050" dirty="0"/>
           </a:p>
@@ -27277,7 +27238,7 @@
                 <a:ea typeface="Calibri" pitchFamily="34" charset="-122"/>
                 <a:cs typeface="Calibri" pitchFamily="34" charset="-120"/>
               </a:rPr>
-              <a:t>Rollos de geomembrana KRAH …</a:t>
+              <a:t>Daño estructural en la pare…</a:t>
             </a:r>
             <a:endParaRPr lang="en-US" sz="1000" dirty="0"/>
           </a:p>
@@ -27359,7 +27320,7 @@
                 <a:ea typeface="Calibri" pitchFamily="34" charset="-122"/>
                 <a:cs typeface="Calibri" pitchFamily="34" charset="-120"/>
               </a:rPr>
-              <a:t>10-08-2026</a:t>
+              <a:t>19-08-2026</a:t>
             </a:r>
             <a:endParaRPr lang="en-US" sz="1050" dirty="0"/>
           </a:p>
@@ -27437,7 +27398,7 @@
                 <a:ea typeface="Calibri" pitchFamily="34" charset="-122"/>
                 <a:cs typeface="Calibri" pitchFamily="34" charset="-120"/>
               </a:rPr>
-              <a:t>244 · RNC N°454</a:t>
+              <a:t>247 · RNC N°458</a:t>
             </a:r>
             <a:endParaRPr lang="en-US" sz="1050" dirty="0"/>
           </a:p>
@@ -27593,7 +27554,7 @@
                 <a:ea typeface="Calibri" pitchFamily="34" charset="-122"/>
                 <a:cs typeface="Calibri" pitchFamily="34" charset="-120"/>
               </a:rPr>
-              <a:t>Mauricio Rocha A.</a:t>
+              <a:t>Luis Ogalde H.</a:t>
             </a:r>
             <a:endParaRPr lang="en-US" sz="1050" dirty="0"/>
           </a:p>
@@ -27671,7 +27632,7 @@
                 <a:ea typeface="Calibri" pitchFamily="34" charset="-122"/>
                 <a:cs typeface="Calibri" pitchFamily="34" charset="-120"/>
               </a:rPr>
-              <a:t>En Piscina Quebrada Sur, se…</a:t>
+              <a:t>Fundaciones FS-01 (10 eleme…</a:t>
             </a:r>
             <a:endParaRPr lang="en-US" sz="1000" dirty="0"/>
           </a:p>
@@ -27733,7 +27694,7 @@
                 <a:ea typeface="Calibri" pitchFamily="34" charset="-122"/>
                 <a:cs typeface="Calibri" pitchFamily="34" charset="-120"/>
               </a:rPr>
-              <a:t>11-08-2026</a:t>
+              <a:t>19-08-2026</a:t>
             </a:r>
             <a:endParaRPr lang="en-US" sz="1050" dirty="0"/>
           </a:p>
@@ -27811,7 +27772,7 @@
                 <a:ea typeface="Calibri" pitchFamily="34" charset="-122"/>
                 <a:cs typeface="Calibri" pitchFamily="34" charset="-120"/>
               </a:rPr>
-              <a:t>245 · RNC N°455</a:t>
+              <a:t>248 · RNC N°463</a:t>
             </a:r>
             <a:endParaRPr lang="en-US" sz="1050" dirty="0"/>
           </a:p>
@@ -27928,7 +27889,7 @@
                 <a:ea typeface="Calibri" pitchFamily="34" charset="-122"/>
                 <a:cs typeface="Calibri" pitchFamily="34" charset="-120"/>
               </a:rPr>
-              <a:t>OO.CC</a:t>
+              <a:t>PIPING</a:t>
             </a:r>
             <a:endParaRPr lang="en-US" sz="1050" dirty="0"/>
           </a:p>
@@ -27967,7 +27928,7 @@
                 <a:ea typeface="Calibri" pitchFamily="34" charset="-122"/>
                 <a:cs typeface="Calibri" pitchFamily="34" charset="-120"/>
               </a:rPr>
-              <a:t>Sebastián Ramos</a:t>
+              <a:t>Oscar Nahuel P.</a:t>
             </a:r>
             <a:endParaRPr lang="en-US" sz="1050" dirty="0"/>
           </a:p>
@@ -28000,13 +27961,13 @@
             <a:r>
               <a:rPr lang="en-US" sz="1050" dirty="0">
                 <a:solidFill>
-                  <a:srgbClr val="1F7A44"/>
-                </a:solidFill>
-                <a:latin typeface="Calibri" pitchFamily="34" charset="0"/>
-                <a:ea typeface="Calibri" pitchFamily="34" charset="-122"/>
-                <a:cs typeface="Calibri" pitchFamily="34" charset="-120"/>
-              </a:rPr>
-              <a:t>Cerrado</a:t>
+                  <a:srgbClr val="C0392B"/>
+                </a:solidFill>
+                <a:latin typeface="Calibri" pitchFamily="34" charset="0"/>
+                <a:ea typeface="Calibri" pitchFamily="34" charset="-122"/>
+                <a:cs typeface="Calibri" pitchFamily="34" charset="-120"/>
+              </a:rPr>
+              <a:t>Iniciado</a:t>
             </a:r>
             <a:endParaRPr lang="en-US" sz="1050" dirty="0"/>
           </a:p>
@@ -28045,7 +28006,7 @@
                 <a:ea typeface="Calibri" pitchFamily="34" charset="-122"/>
                 <a:cs typeface="Calibri" pitchFamily="34" charset="-120"/>
               </a:rPr>
-              <a:t>Se utilizó la Solicitud de …</a:t>
+              <a:t>Línea TAG N° 3716D-RW-24-H1…</a:t>
             </a:r>
             <a:endParaRPr lang="en-US" sz="1000" dirty="0"/>
           </a:p>
@@ -28107,7 +28068,7 @@
                 <a:ea typeface="Calibri" pitchFamily="34" charset="-122"/>
                 <a:cs typeface="Calibri" pitchFamily="34" charset="-120"/>
               </a:rPr>
-              <a:t>Fuente: Data_NCR17082026.xlsx — hoja «Observaciones» · Corte 17-08-2026 · 498 registros desde 10-02-2023</a:t>
+              <a:t>Fuente: Data_NCR24082026.xlsx — hoja «Observaciones» · Corte 24-08-2026 · 501 registros desde 10-02-2023</a:t>
             </a:r>
             <a:endParaRPr lang="en-US" sz="850" dirty="0"/>
           </a:p>
@@ -28358,7 +28319,7 @@
                 <a:ea typeface="Calibri" pitchFamily="34" charset="-122"/>
                 <a:cs typeface="Calibri" pitchFamily="34" charset="-120"/>
               </a:rPr>
-              <a:t>Interna es autodetección: la levanta Besalco antes que nadie. Externa la levanta el cliente —compromete el contrato— o un subcontrato. Autodetección global: 32,5%.</a:t>
+              <a:t>Interna es autodetección: la levanta Besalco antes que nadie. Externa la levanta el cliente —compromete el contrato— o un subcontrato. Autodetección global: 32,3%.</a:t>
             </a:r>
             <a:endParaRPr lang="en-US" sz="1350" dirty="0"/>
           </a:p>
@@ -28826,7 +28787,7 @@
                 <a:ea typeface="Calibri" pitchFamily="34" charset="-122"/>
                 <a:cs typeface="Calibri" pitchFamily="34" charset="-120"/>
               </a:rPr>
-              <a:t>154</a:t>
+              <a:t>157</a:t>
             </a:r>
             <a:endParaRPr lang="en-US" sz="1050" dirty="0"/>
           </a:p>
@@ -28865,7 +28826,7 @@
                 <a:ea typeface="Calibri" pitchFamily="34" charset="-122"/>
                 <a:cs typeface="Calibri" pitchFamily="34" charset="-120"/>
               </a:rPr>
-              <a:t>96,9%</a:t>
+              <a:t>98,7%</a:t>
             </a:r>
             <a:endParaRPr lang="en-US" sz="1050" dirty="0"/>
           </a:p>
@@ -28904,7 +28865,7 @@
                 <a:ea typeface="Calibri" pitchFamily="34" charset="-122"/>
                 <a:cs typeface="Calibri" pitchFamily="34" charset="-120"/>
               </a:rPr>
-              <a:t>5</a:t>
+              <a:t>2</a:t>
             </a:r>
             <a:endParaRPr lang="en-US" sz="1050" dirty="0"/>
           </a:p>
@@ -28943,7 +28904,7 @@
                 <a:ea typeface="Calibri" pitchFamily="34" charset="-122"/>
                 <a:cs typeface="Calibri" pitchFamily="34" charset="-120"/>
               </a:rPr>
-              <a:t>5</a:t>
+              <a:t>2</a:t>
             </a:r>
             <a:endParaRPr lang="en-US" sz="1050" dirty="0"/>
           </a:p>
@@ -28982,7 +28943,7 @@
                 <a:ea typeface="Calibri" pitchFamily="34" charset="-122"/>
                 <a:cs typeface="Calibri" pitchFamily="34" charset="-120"/>
               </a:rPr>
-              <a:t>64 días</a:t>
+              <a:t>69 días</a:t>
             </a:r>
             <a:endParaRPr lang="en-US" sz="1050" dirty="0"/>
           </a:p>
@@ -29103,7 +29064,7 @@
                 <a:ea typeface="Calibri" pitchFamily="34" charset="-122"/>
                 <a:cs typeface="Calibri" pitchFamily="34" charset="-120"/>
               </a:rPr>
-              <a:t>282</a:t>
+              <a:t>285</a:t>
             </a:r>
             <a:endParaRPr lang="en-US" sz="1050" dirty="0"/>
           </a:p>
@@ -29142,7 +29103,7 @@
                 <a:ea typeface="Calibri" pitchFamily="34" charset="-122"/>
                 <a:cs typeface="Calibri" pitchFamily="34" charset="-120"/>
               </a:rPr>
-              <a:t>235</a:t>
+              <a:t>241</a:t>
             </a:r>
             <a:endParaRPr lang="en-US" sz="1050" dirty="0"/>
           </a:p>
@@ -29181,7 +29142,7 @@
                 <a:ea typeface="Calibri" pitchFamily="34" charset="-122"/>
                 <a:cs typeface="Calibri" pitchFamily="34" charset="-120"/>
               </a:rPr>
-              <a:t>83,3%</a:t>
+              <a:t>84,6%</a:t>
             </a:r>
             <a:endParaRPr lang="en-US" sz="1050" dirty="0"/>
           </a:p>
@@ -29220,7 +29181,7 @@
                 <a:ea typeface="Calibri" pitchFamily="34" charset="-122"/>
                 <a:cs typeface="Calibri" pitchFamily="34" charset="-120"/>
               </a:rPr>
-              <a:t>47</a:t>
+              <a:t>44</a:t>
             </a:r>
             <a:endParaRPr lang="en-US" sz="1050" dirty="0"/>
           </a:p>
@@ -29259,7 +29220,7 @@
                 <a:ea typeface="Calibri" pitchFamily="34" charset="-122"/>
                 <a:cs typeface="Calibri" pitchFamily="34" charset="-120"/>
               </a:rPr>
-              <a:t>45</a:t>
+              <a:t>42</a:t>
             </a:r>
             <a:endParaRPr lang="en-US" sz="1050" dirty="0"/>
           </a:p>
@@ -29298,7 +29259,7 @@
                 <a:ea typeface="Calibri" pitchFamily="34" charset="-122"/>
                 <a:cs typeface="Calibri" pitchFamily="34" charset="-120"/>
               </a:rPr>
-              <a:t>49 días</a:t>
+              <a:t>51 días</a:t>
             </a:r>
             <a:endParaRPr lang="en-US" sz="1050" dirty="0"/>
           </a:p>
@@ -30011,7 +29972,7 @@
                 <a:ea typeface="Calibri" pitchFamily="34" charset="-122"/>
                 <a:cs typeface="Calibri" pitchFamily="34" charset="-120"/>
               </a:rPr>
-              <a:t>498</a:t>
+              <a:t>501</a:t>
             </a:r>
             <a:endParaRPr lang="en-US" sz="1050" dirty="0"/>
           </a:p>
@@ -30050,7 +30011,7 @@
                 <a:ea typeface="Calibri" pitchFamily="34" charset="-122"/>
                 <a:cs typeface="Calibri" pitchFamily="34" charset="-120"/>
               </a:rPr>
-              <a:t>446</a:t>
+              <a:t>455</a:t>
             </a:r>
             <a:endParaRPr lang="en-US" sz="1050" dirty="0"/>
           </a:p>
@@ -30089,7 +30050,7 @@
                 <a:ea typeface="Calibri" pitchFamily="34" charset="-122"/>
                 <a:cs typeface="Calibri" pitchFamily="34" charset="-120"/>
               </a:rPr>
-              <a:t>89,6%</a:t>
+              <a:t>90,8%</a:t>
             </a:r>
             <a:endParaRPr lang="en-US" sz="1050" dirty="0"/>
           </a:p>
@@ -30128,7 +30089,7 @@
                 <a:ea typeface="Calibri" pitchFamily="34" charset="-122"/>
                 <a:cs typeface="Calibri" pitchFamily="34" charset="-120"/>
               </a:rPr>
-              <a:t>52</a:t>
+              <a:t>46</a:t>
             </a:r>
             <a:endParaRPr lang="en-US" sz="1050" dirty="0"/>
           </a:p>
@@ -30167,7 +30128,7 @@
                 <a:ea typeface="Calibri" pitchFamily="34" charset="-122"/>
                 <a:cs typeface="Calibri" pitchFamily="34" charset="-120"/>
               </a:rPr>
-              <a:t>50</a:t>
+              <a:t>44</a:t>
             </a:r>
             <a:endParaRPr lang="en-US" sz="1050" dirty="0"/>
           </a:p>
@@ -30206,7 +30167,7 @@
                 <a:ea typeface="Calibri" pitchFamily="34" charset="-122"/>
                 <a:cs typeface="Calibri" pitchFamily="34" charset="-120"/>
               </a:rPr>
-              <a:t>69 días</a:t>
+              <a:t>71 días</a:t>
             </a:r>
             <a:endParaRPr lang="en-US" sz="1050" dirty="0"/>
           </a:p>
@@ -30423,7 +30384,7 @@
                 <a:ea typeface="Cambria" pitchFamily="34" charset="-122"/>
                 <a:cs typeface="Cambria" pitchFamily="34" charset="-120"/>
               </a:rPr>
-              <a:t>21,3%</a:t>
+              <a:t>21,1%</a:t>
             </a:r>
             <a:endParaRPr lang="en-US" sz="2400" dirty="0"/>
           </a:p>
@@ -30579,7 +30540,7 @@
                 <a:ea typeface="Calibri" pitchFamily="34" charset="-122"/>
                 <a:cs typeface="Calibri" pitchFamily="34" charset="-120"/>
               </a:rPr>
-              <a:t>Fuente: Data_NCR17082026.xlsx — hoja «Observaciones» · Corte 17-08-2026 · 498 registros desde 10-02-2023</a:t>
+              <a:t>Fuente: Data_NCR24082026.xlsx — hoja «Observaciones» · Corte 24-08-2026 · 501 registros desde 10-02-2023</a:t>
             </a:r>
             <a:endParaRPr lang="en-US" sz="850" dirty="0"/>
           </a:p>
@@ -30830,7 +30791,7 @@
                 <a:ea typeface="Calibri" pitchFamily="34" charset="-122"/>
                 <a:cs typeface="Calibri" pitchFamily="34" charset="-120"/>
               </a:rPr>
-              <a:t>De los 52 hallazgos abiertos, 19 llevan más de 180 días desde que se levantaron y 4 más de un año. La mediana de cierre global es de 30 días.</a:t>
+              <a:t>De los 46 hallazgos abiertos, 17 llevan más de 180 días desde que se levantaron y 3 más de un año. La mediana de cierre global es de 30 días.</a:t>
             </a:r>
             <a:endParaRPr lang="en-US" sz="1350" dirty="0"/>
           </a:p>
@@ -30967,7 +30928,7 @@
                 <a:ea typeface="Calibri" pitchFamily="34" charset="-122"/>
                 <a:cs typeface="Calibri" pitchFamily="34" charset="-120"/>
               </a:rPr>
-              <a:t>Al corte hay 50 hallazgos fuera de plazo de los 52 abiertos.</a:t>
+              <a:t>Al corte hay 44 hallazgos fuera de plazo de los 46 abiertos.</a:t>
             </a:r>
             <a:endParaRPr lang="en-US" sz="1150" dirty="0"/>
           </a:p>
@@ -31646,7 +31607,7 @@
                 <a:ea typeface="Calibri" pitchFamily="34" charset="-122"/>
                 <a:cs typeface="Calibri" pitchFamily="34" charset="-120"/>
               </a:rPr>
-              <a:t>230</a:t>
+              <a:t>238</a:t>
             </a:r>
             <a:endParaRPr lang="en-US" sz="1150" dirty="0"/>
           </a:p>
@@ -31724,7 +31685,7 @@
                 <a:ea typeface="Calibri" pitchFamily="34" charset="-122"/>
                 <a:cs typeface="Calibri" pitchFamily="34" charset="-120"/>
               </a:rPr>
-              <a:t>389 d</a:t>
+              <a:t>407 d</a:t>
             </a:r>
             <a:endParaRPr lang="en-US" sz="1150" dirty="0"/>
           </a:p>
@@ -31763,7 +31724,7 @@
                 <a:ea typeface="Calibri" pitchFamily="34" charset="-122"/>
                 <a:cs typeface="Calibri" pitchFamily="34" charset="-120"/>
               </a:rPr>
-              <a:t>14</a:t>
+              <a:t>9</a:t>
             </a:r>
             <a:endParaRPr lang="en-US" sz="1150" dirty="0"/>
           </a:p>
@@ -31892,7 +31853,7 @@
                 <a:ea typeface="Calibri" pitchFamily="34" charset="-122"/>
                 <a:cs typeface="Calibri" pitchFamily="34" charset="-120"/>
               </a:rPr>
-              <a:t>127</a:t>
+              <a:t>128</a:t>
             </a:r>
             <a:endParaRPr lang="en-US" sz="1150" dirty="0"/>
           </a:p>
@@ -31931,7 +31892,7 @@
                 <a:ea typeface="Calibri" pitchFamily="34" charset="-122"/>
                 <a:cs typeface="Calibri" pitchFamily="34" charset="-120"/>
               </a:rPr>
-              <a:t>129 d</a:t>
+              <a:t>131 d</a:t>
             </a:r>
             <a:endParaRPr lang="en-US" sz="1150" dirty="0"/>
           </a:p>
@@ -31970,7 +31931,7 @@
                 <a:ea typeface="Calibri" pitchFamily="34" charset="-122"/>
                 <a:cs typeface="Calibri" pitchFamily="34" charset="-120"/>
               </a:rPr>
-              <a:t>313 d</a:t>
+              <a:t>409 d</a:t>
             </a:r>
             <a:endParaRPr lang="en-US" sz="1150" dirty="0"/>
           </a:p>
@@ -32009,7 +31970,7 @@
                 <a:ea typeface="Calibri" pitchFamily="34" charset="-122"/>
                 <a:cs typeface="Calibri" pitchFamily="34" charset="-120"/>
               </a:rPr>
-              <a:t>37</a:t>
+              <a:t>36</a:t>
             </a:r>
             <a:endParaRPr lang="en-US" sz="1150" dirty="0"/>
           </a:p>
@@ -32387,7 +32348,7 @@
                 <a:ea typeface="Calibri" pitchFamily="34" charset="-122"/>
                 <a:cs typeface="Calibri" pitchFamily="34" charset="-120"/>
               </a:rPr>
-              <a:t>Fuente: Data_NCR17082026.xlsx — hoja «Observaciones» · Corte 17-08-2026 · 498 registros desde 10-02-2023</a:t>
+              <a:t>Fuente: Data_NCR24082026.xlsx — hoja «Observaciones» · Corte 24-08-2026 · 501 registros desde 10-02-2023</a:t>
             </a:r>
             <a:endParaRPr lang="en-US" sz="850" dirty="0"/>
           </a:p>
@@ -32638,7 +32599,7 @@
                 <a:ea typeface="Calibri" pitchFamily="34" charset="-122"/>
                 <a:cs typeface="Calibri" pitchFamily="34" charset="-120"/>
               </a:rPr>
-              <a:t>10.613 UF declaradas entre nov-24 y ago-26, imputadas al mes en que se levantó cada hallazgo. Las declaran 108 de 487 hallazgos del período.</a:t>
+              <a:t>10.613 UF declaradas entre nov-24 y ago-26, imputadas al mes en que se levantó cada hallazgo. Las declaran 108 de 490 hallazgos del período.</a:t>
             </a:r>
             <a:endParaRPr lang="en-US" sz="1350" dirty="0"/>
           </a:p>
@@ -49468,7 +49429,7 @@
                           <a:ea typeface="Calibri" pitchFamily="34" charset="-122"/>
                           <a:cs typeface="Calibri" pitchFamily="34" charset="-120"/>
                         </a:rPr>
-                        <a:t>0/4</a:t>
+                        <a:t>0/7</a:t>
                       </a:r>
                       <a:endParaRPr lang="en-US" sz="750" dirty="0">
                         <a:latin typeface="Calibri" charset="0"/>
@@ -49536,7 +49497,7 @@
                           <a:ea typeface="Calibri" pitchFamily="34" charset="-122"/>
                           <a:cs typeface="Calibri" pitchFamily="34" charset="-120"/>
                         </a:rPr>
-                        <a:t>108/487</a:t>
+                        <a:t>108/490</a:t>
                       </a:r>
                       <a:endParaRPr lang="en-US" sz="750" dirty="0">
                         <a:latin typeface="Calibri" charset="0"/>
@@ -50200,7 +50161,7 @@
                 <a:ea typeface="Cambria" pitchFamily="34" charset="-122"/>
                 <a:cs typeface="Cambria" pitchFamily="34" charset="-120"/>
               </a:rPr>
-              <a:t>247</a:t>
+              <a:t>250</a:t>
             </a:r>
             <a:endParaRPr lang="en-US" sz="2100" dirty="0"/>
           </a:p>
@@ -50317,7 +50278,7 @@
                 <a:ea typeface="Calibri" pitchFamily="34" charset="-122"/>
                 <a:cs typeface="Calibri" pitchFamily="34" charset="-120"/>
               </a:rPr>
-              <a:t>Fuente: Data_NCR17082026.xlsx — hoja «Observaciones» · Corte 17-08-2026 · 498 registros desde 10-02-2023</a:t>
+              <a:t>Fuente: Data_NCR24082026.xlsx — hoja «Observaciones» · Corte 24-08-2026 · 501 registros desde 10-02-2023</a:t>
             </a:r>
             <a:endParaRPr lang="en-US" sz="850" dirty="0"/>
           </a:p>
@@ -50691,7 +50652,7 @@
                 <a:ea typeface="Calibri" pitchFamily="34" charset="-122"/>
                 <a:cs typeface="Calibri" pitchFamily="34" charset="-120"/>
               </a:rPr>
-              <a:t>37 de los 52 hallazgos abiertos (71,2%) y 77,4% de cierre, contra 89,6% global. Es la ruta crítica del módulo.</a:t>
+              <a:t>36 de los 46 hallazgos abiertos (78,3%) y 78% de cierre, contra 90,8% global. Es la ruta crítica del módulo.</a:t>
             </a:r>
             <a:endParaRPr lang="en-US" sz="1100" dirty="0"/>
           </a:p>
@@ -50833,7 +50794,7 @@
                 <a:ea typeface="Calibri" pitchFamily="34" charset="-122"/>
                 <a:cs typeface="Calibri" pitchFamily="34" charset="-120"/>
               </a:rPr>
-              <a:t>Solo 21,3% de sus hallazgos los detecta Besalco; el mejor frente va en 66,7%. Lo que no se detecta adentro llega como observación del cliente.</a:t>
+              <a:t>Solo 21,1% de sus hallazgos los detecta Besalco; el mejor frente va en 66,7%. Lo que no se detecta adentro llega como observación del cliente.</a:t>
             </a:r>
             <a:endParaRPr lang="en-US" sz="1100" dirty="0"/>
           </a:p>
@@ -50933,7 +50894,7 @@
                 <a:ea typeface="Calibri" pitchFamily="34" charset="-122"/>
                 <a:cs typeface="Calibri" pitchFamily="34" charset="-120"/>
               </a:rPr>
-              <a:t>Sacar los 19 hallazgos sobre 180 días</a:t>
+              <a:t>Sacar los 17 hallazgos sobre 180 días</a:t>
             </a:r>
             <a:endParaRPr lang="en-US" sz="1400" dirty="0"/>
           </a:p>
@@ -50975,7 +50936,7 @@
                 <a:ea typeface="Calibri" pitchFamily="34" charset="-122"/>
                 <a:cs typeface="Calibri" pitchFamily="34" charset="-120"/>
               </a:rPr>
-              <a:t>4 de ellos superan el año abiertos. Los tienen a cargo Sin asignar (16), Alvaro Cortés V. (3). Es deuda antigua que no se cierra sola.</a:t>
+              <a:t>3 de ellos superan el año abiertos. Los tienen a cargo Sin asignar (17). Es deuda antigua que no se cierra sola.</a:t>
             </a:r>
             <a:endParaRPr lang="en-US" sz="1100" dirty="0"/>
           </a:p>
@@ -51075,7 +51036,7 @@
                 <a:ea typeface="Calibri" pitchFamily="34" charset="-122"/>
                 <a:cs typeface="Calibri" pitchFamily="34" charset="-120"/>
               </a:rPr>
-              <a:t>Responder las 50 que pasaron el plazo</a:t>
+              <a:t>Responder las 44 que pasaron el plazo</a:t>
             </a:r>
             <a:endParaRPr lang="en-US" sz="1400" dirty="0"/>
           </a:p>
@@ -51117,7 +51078,7 @@
                 <a:ea typeface="Calibri" pitchFamily="34" charset="-122"/>
                 <a:cs typeface="Calibri" pitchFamily="34" charset="-120"/>
               </a:rPr>
-              <a:t>El plazo es de 10 días desde la emisión y hoy lo incumplen 96,2% de los abiertos. Solo 2 siguen dentro de plazo.</a:t>
+              <a:t>El plazo es de 10 días desde la emisión y hoy lo incumplen 95,7% de los abiertos. Solo 2 siguen dentro de plazo.</a:t>
             </a:r>
             <a:endParaRPr lang="en-US" sz="1100" dirty="0"/>
           </a:p>
@@ -51156,7 +51117,7 @@
                 <a:ea typeface="Calibri" pitchFamily="34" charset="-122"/>
                 <a:cs typeface="Calibri" pitchFamily="34" charset="-120"/>
               </a:rPr>
-              <a:t>Fuente: Data_NCR17082026.xlsx — hoja «Observaciones» · Corte 17-08-2026 · 498 registros desde 10-02-2023</a:t>
+              <a:t>Fuente: Data_NCR24082026.xlsx — hoja «Observaciones» · Corte 24-08-2026 · 501 registros desde 10-02-2023</a:t>
             </a:r>
             <a:endParaRPr lang="en-US" sz="850" dirty="0"/>
           </a:p>
@@ -51880,7 +51841,7 @@
                 <a:ea typeface="Calibri" pitchFamily="34" charset="-122"/>
                 <a:cs typeface="Calibri" pitchFamily="34" charset="-120"/>
               </a:rPr>
-              <a:t>Corte: 17-08-2026</a:t>
+              <a:t>Corte: 24-08-2026</a:t>
             </a:r>
             <a:endParaRPr lang="en-US" sz="1100" dirty="0"/>
           </a:p>
@@ -51919,7 +51880,7 @@
                 <a:ea typeface="Calibri" pitchFamily="34" charset="-122"/>
                 <a:cs typeface="Calibri" pitchFamily="34" charset="-120"/>
               </a:rPr>
-              <a:t>Fuente: Data_NCR17082026.xlsx — hoja «Observaciones» · Corte 17-08-2026 · 498 registros desde 10-02-2023</a:t>
+              <a:t>Fuente: Data_NCR24082026.xlsx — hoja «Observaciones» · Corte 24-08-2026 · 501 registros desde 10-02-2023</a:t>
             </a:r>
             <a:endParaRPr lang="en-US" sz="850" dirty="0"/>
           </a:p>

</xml_diff>

<commit_message>
No Conformidades al corte 31-08-2026
Ocho cierres y un solo hallazgo nuevo: 39 abiertas (-7), cierre 92,2%.
Arqueros cierra cuatro y sube de 78,0% a 80,5% —la primera vez que se mueve
en cuatro cortes—; Talabre cierra tres y llega a 97,6%.

El costo sigue sin declararse: el hallazgo nuevo tampoco trae monto, así que
van 108 registros con cifra contra 251 con la casilla vacía, y agosto cierra
en 0/8. Son cuatro meses seguidos sin un solo monto.

95 comprobaciones OK · suite verificada en 1366/1920/2560.

Co-Authored-By: Claude Opus 5 <noreply@anthropic.com>
Claude-Session: https://claude.ai/code/session_011SHyPcub1TtjA2kTAsaPFu
</commit_message>
<xml_diff>
--- a/modulo_nc/Panel_No_Conformidades.pptx
+++ b/modulo_nc/Panel_No_Conformidades.pptx
@@ -220,19 +220,19 @@
                     <c:v>3 sem.</c:v>
                   </c:pt>
                   <c:pt idx="1">
-                    <c:v>20-07</c:v>
+                    <c:v>27-07</c:v>
                   </c:pt>
                   <c:pt idx="2">
-                    <c:v>27-07</c:v>
+                    <c:v>03-08</c:v>
                   </c:pt>
                   <c:pt idx="3">
-                    <c:v>03-08</c:v>
+                    <c:v>10-08</c:v>
                   </c:pt>
                   <c:pt idx="4">
-                    <c:v>10-08</c:v>
+                    <c:v>17-08</c:v>
                   </c:pt>
                   <c:pt idx="5">
-                    <c:v>17-08</c:v>
+                    <c:v>24-08</c:v>
                   </c:pt>
                 </c:lvl>
               </c:multiLvlStrCache>
@@ -245,13 +245,13 @@
                 <c:formatCode>General</c:formatCode>
                 <c:ptCount val="6"/>
                 <c:pt idx="0">
-                  <c:v>1</c:v>
+                  <c:v/>
                 </c:pt>
                 <c:pt idx="1">
-                  <c:v/>
+                  <c:v>2</c:v>
                 </c:pt>
                 <c:pt idx="2">
-                  <c:v>2</c:v>
+                  <c:v/>
                 </c:pt>
                 <c:pt idx="3">
                   <c:v/>
@@ -260,7 +260,7 @@
                   <c:v>2</c:v>
                 </c:pt>
                 <c:pt idx="5">
-                  <c:v>2</c:v>
+                  <c:v>1</c:v>
                 </c:pt>
               </c:numCache>
             </c:numRef>
@@ -322,19 +322,19 @@
                     <c:v>3 sem.</c:v>
                   </c:pt>
                   <c:pt idx="1">
-                    <c:v>20-07</c:v>
+                    <c:v>27-07</c:v>
                   </c:pt>
                   <c:pt idx="2">
-                    <c:v>27-07</c:v>
+                    <c:v>03-08</c:v>
                   </c:pt>
                   <c:pt idx="3">
-                    <c:v>03-08</c:v>
+                    <c:v>10-08</c:v>
                   </c:pt>
                   <c:pt idx="4">
-                    <c:v>10-08</c:v>
+                    <c:v>17-08</c:v>
                   </c:pt>
                   <c:pt idx="5">
-                    <c:v>17-08</c:v>
+                    <c:v>24-08</c:v>
                   </c:pt>
                 </c:lvl>
               </c:multiLvlStrCache>
@@ -347,22 +347,22 @@
                 <c:formatCode>General</c:formatCode>
                 <c:ptCount val="6"/>
                 <c:pt idx="0">
-                  <c:v>3</c:v>
+                  <c:v>4</c:v>
                 </c:pt>
                 <c:pt idx="1">
-                  <c:v>3</c:v>
+                  <c:v>2</c:v>
                 </c:pt>
                 <c:pt idx="2">
-                  <c:v>2</c:v>
+                  <c:v>1</c:v>
                 </c:pt>
                 <c:pt idx="3">
-                  <c:v>1</c:v>
+                  <c:v>3</c:v>
                 </c:pt>
                 <c:pt idx="4">
                   <c:v>1</c:v>
                 </c:pt>
                 <c:pt idx="5">
-                  <c:v>1</c:v>
+                  <c:v/>
                 </c:pt>
               </c:numCache>
             </c:numRef>
@@ -734,7 +734,7 @@
                   <c:v>19</c:v>
                 </c:pt>
                 <c:pt idx="1">
-                  <c:v>195</c:v>
+                  <c:v>196</c:v>
                 </c:pt>
                 <c:pt idx="2">
                   <c:v>71</c:v>
@@ -1199,13 +1199,13 @@
                 <c:formatCode>General</c:formatCode>
                 <c:ptCount val="4"/>
                 <c:pt idx="0">
-                  <c:v>289</c:v>
+                  <c:v>292</c:v>
                 </c:pt>
                 <c:pt idx="1">
-                  <c:v>120</c:v>
+                  <c:v>121</c:v>
                 </c:pt>
                 <c:pt idx="2">
-                  <c:v>45</c:v>
+                  <c:v>49</c:v>
                 </c:pt>
                 <c:pt idx="3">
                   <c:v>1</c:v>
@@ -1289,13 +1289,13 @@
                 <c:formatCode>General</c:formatCode>
                 <c:ptCount val="4"/>
                 <c:pt idx="0">
-                  <c:v>29</c:v>
+                  <c:v>26</c:v>
                 </c:pt>
                 <c:pt idx="1">
                   <c:v>2</c:v>
                 </c:pt>
                 <c:pt idx="2">
-                  <c:v>15</c:v>
+                  <c:v>11</c:v>
                 </c:pt>
                 <c:pt idx="3">
                   <c:v/>
@@ -1487,7 +1487,7 @@
                 </a:solidFill>
                 <a:latin typeface="Calibri"/>
               </a:rPr>
-              <a:t>Antigüedad de los 46 hallazgos abiertos</a:t>
+              <a:t>Antigüedad de los 39 hallazgos abiertos</a:t>
             </a:r>
           </a:p>
         </c:rich>
@@ -1568,7 +1568,7 @@
                 <c:formatCode>General</c:formatCode>
                 <c:ptCount val="1"/>
                 <c:pt idx="0">
-                  <c:v>6</c:v>
+                  <c:v>3</c:v>
                 </c:pt>
               </c:numCache>
             </c:numRef>
@@ -1784,79 +1784,7 @@
                 <c:formatCode>General</c:formatCode>
                 <c:ptCount val="1"/>
                 <c:pt idx="0">
-                  <c:v>14</c:v>
-                </c:pt>
-              </c:numCache>
-            </c:numRef>
-          </c:val>
-        </c:ser>
-        <c:ser>
-          <c:idx val="4"/>
-          <c:order val="4"/>
-          <c:tx>
-            <c:strRef>
-              <c:f>Sheet1!$F$1</c:f>
-              <c:strCache>
-                <c:ptCount val="1"/>
-                <c:pt idx="0">
-                  <c:v>Más de un año</c:v>
-                </c:pt>
-              </c:strCache>
-            </c:strRef>
-          </c:tx>
-          <c:spPr>
-            <a:solidFill>
-              <a:srgbClr val="C0392B"/>
-            </a:solidFill>
-            <a:effectLst/>
-          </c:spPr>
-          <c:invertIfNegative val="0"/>
-          <c:dLbls>
-            <c:numFmt formatCode="#,##0" sourceLinked="0"/>
-            <c:txPr>
-              <a:bodyPr/>
-              <a:lstStyle/>
-              <a:p>
-                <a:pPr>
-                  <a:defRPr b="1" i="0" strike="noStrike" sz="1100" u="none">
-                    <a:solidFill>
-                      <a:srgbClr val="FFFFFF"/>
-                    </a:solidFill>
-                    <a:latin typeface="Calibri"/>
-                  </a:defRPr>
-                </a:pPr>
-              </a:p>
-            </c:txPr>
-            <c:dLblPos val="ctr"/>
-            <c:showLegendKey val="0"/>
-            <c:showVal val="1"/>
-            <c:showCatName val="0"/>
-            <c:showSerName val="0"/>
-            <c:showPercent val="0"/>
-            <c:showBubbleSize val="0"/>
-            <c:showLeaderLines val="0"/>
-          </c:dLbls>
-          <c:cat>
-            <c:multiLvlStrRef>
-              <c:f>Sheet1!$A$2:$A$2</c:f>
-              <c:multiLvlStrCache>
-                <c:ptCount val="1"/>
-                <c:lvl>
-                  <c:pt idx="0">
-                    <c:v>Abiertos</c:v>
-                  </c:pt>
-                </c:lvl>
-              </c:multiLvlStrCache>
-            </c:multiLvlStrRef>
-          </c:cat>
-          <c:val>
-            <c:numRef>
-              <c:f>Sheet1!$F$2:$F$2</c:f>
-              <c:numCache>
-                <c:formatCode>General</c:formatCode>
-                <c:ptCount val="1"/>
-                <c:pt idx="0">
-                  <c:v>3</c:v>
+                  <c:v>13</c:v>
                 </c:pt>
               </c:numCache>
             </c:numRef>
@@ -2573,10 +2501,10 @@
                 <c:formatCode>General</c:formatCode>
                 <c:ptCount val="8"/>
                 <c:pt idx="0">
-                  <c:v>139</c:v>
+                  <c:v>142</c:v>
                 </c:pt>
                 <c:pt idx="1">
-                  <c:v>24</c:v>
+                  <c:v>25</c:v>
                 </c:pt>
                 <c:pt idx="2">
                   <c:v>16</c:v>
@@ -2687,10 +2615,10 @@
                 <c:formatCode>General</c:formatCode>
                 <c:ptCount val="8"/>
                 <c:pt idx="0">
-                  <c:v>6</c:v>
+                  <c:v>4</c:v>
                 </c:pt>
                 <c:pt idx="1">
-                  <c:v>2</c:v>
+                  <c:v>1</c:v>
                 </c:pt>
                 <c:pt idx="2">
                   <c:v>1</c:v>
@@ -2999,7 +2927,7 @@
                 <c:formatCode>General</c:formatCode>
                 <c:ptCount val="8"/>
                 <c:pt idx="0">
-                  <c:v>36</c:v>
+                  <c:v>40</c:v>
                 </c:pt>
                 <c:pt idx="1">
                   <c:v>37</c:v>
@@ -3113,7 +3041,7 @@
                 <c:formatCode>General</c:formatCode>
                 <c:ptCount val="8"/>
                 <c:pt idx="0">
-                  <c:v>35</c:v>
+                  <c:v>31</c:v>
                 </c:pt>
                 <c:pt idx="1">
                   <c:v/>
@@ -5710,7 +5638,7 @@
                 <a:ea typeface="Calibri" pitchFamily="34" charset="-122"/>
                 <a:cs typeface="Calibri" pitchFamily="34" charset="-120"/>
               </a:rPr>
-              <a:t>501 hallazgos levantados entre 10-02-2023 y 19-08-2026 (Desaladora 82 · Talabre 247 · Arqueros 164 · Oficina Central 8).</a:t>
+              <a:t>502 hallazgos levantados entre 10-02-2023 y 24-08-2026 (Desaladora 82 · Talabre 248 · Arqueros 164 · Oficina Central 8).</a:t>
             </a:r>
             <a:endParaRPr lang="en-US" sz="1350" dirty="0"/>
           </a:p>
@@ -5769,7 +5697,7 @@
                 <a:ea typeface="Cambria" pitchFamily="34" charset="-122"/>
                 <a:cs typeface="Cambria" pitchFamily="34" charset="-120"/>
               </a:rPr>
-              <a:t>90,8%</a:t>
+              <a:t>92,2%</a:t>
             </a:r>
             <a:endParaRPr lang="en-US" sz="3400" dirty="0"/>
           </a:p>
@@ -5847,7 +5775,7 @@
                 <a:ea typeface="Cambria" pitchFamily="34" charset="-122"/>
                 <a:cs typeface="Cambria" pitchFamily="34" charset="-120"/>
               </a:rPr>
-              <a:t>46</a:t>
+              <a:t>39</a:t>
             </a:r>
             <a:endParaRPr lang="en-US" sz="3400" dirty="0"/>
           </a:p>
@@ -6081,7 +6009,7 @@
                 <a:ea typeface="Calibri" pitchFamily="34" charset="-122"/>
                 <a:cs typeface="Calibri" pitchFamily="34" charset="-120"/>
               </a:rPr>
-              <a:t>Corte: 24-08-2026</a:t>
+              <a:t>Corte: 31-08-2026</a:t>
             </a:r>
             <a:endParaRPr lang="en-US" sz="1100" dirty="0"/>
           </a:p>
@@ -6120,7 +6048,7 @@
                 <a:ea typeface="Calibri" pitchFamily="34" charset="-122"/>
                 <a:cs typeface="Calibri" pitchFamily="34" charset="-120"/>
               </a:rPr>
-              <a:t>Fuente: Data_NCR24082026.xlsx — hoja «Observaciones» · Corte 24-08-2026 · 501 registros desde 10-02-2023</a:t>
+              <a:t>Fuente: Data_NCR31082026.xlsx — hoja «Observaciones» · Corte 31-08-2026 · 502 registros desde 10-02-2023</a:t>
             </a:r>
             <a:endParaRPr lang="en-US" sz="850" dirty="0"/>
           </a:p>
@@ -6713,7 +6641,7 @@
                 <a:ea typeface="Calibri" pitchFamily="34" charset="-122"/>
                 <a:cs typeface="Calibri" pitchFamily="34" charset="-120"/>
               </a:rPr>
-              <a:t>Global del módulo: 90,8%</a:t>
+              <a:t>Global del módulo: 92,2%</a:t>
             </a:r>
             <a:endParaRPr lang="en-US" sz="950" dirty="0"/>
           </a:p>
@@ -7921,7 +7849,7 @@
                 <a:ea typeface="Calibri" pitchFamily="34" charset="-122"/>
                 <a:cs typeface="Calibri" pitchFamily="34" charset="-120"/>
               </a:rPr>
-              <a:t>Fuente: Data_NCR24082026.xlsx — hoja «Observaciones» · Corte 24-08-2026 · 501 registros desde 10-02-2023</a:t>
+              <a:t>Fuente: Data_NCR31082026.xlsx — hoja «Observaciones» · Corte 31-08-2026 · 502 registros desde 10-02-2023</a:t>
             </a:r>
             <a:endParaRPr lang="en-US" sz="850" dirty="0"/>
           </a:p>
@@ -8780,7 +8708,7 @@
                 <a:ea typeface="Calibri" pitchFamily="34" charset="-122"/>
                 <a:cs typeface="Calibri" pitchFamily="34" charset="-120"/>
               </a:rPr>
-              <a:t>104</a:t>
+              <a:t>111</a:t>
             </a:r>
             <a:endParaRPr lang="en-US" sz="1050" dirty="0"/>
           </a:p>
@@ -8903,7 +8831,7 @@
                 <a:ea typeface="Calibri" pitchFamily="34" charset="-122"/>
                 <a:cs typeface="Calibri" pitchFamily="34" charset="-120"/>
               </a:rPr>
-              <a:t>SEMANA 17-08-2026 — 23-08-2026</a:t>
+              <a:t>SEMANA 24-08-2026 — 30-08-2026</a:t>
             </a:r>
             <a:endParaRPr lang="en-US" sz="1000" dirty="0"/>
           </a:p>
@@ -8981,7 +8909,7 @@
                 <a:ea typeface="Calibri" pitchFamily="34" charset="-122"/>
                 <a:cs typeface="Calibri" pitchFamily="34" charset="-120"/>
               </a:rPr>
-              <a:t>Fuente: Data_NCR24082026.xlsx — hoja «Observaciones» · Corte 24-08-2026 · 501 registros desde 10-02-2023</a:t>
+              <a:t>Fuente: Data_NCR31082026.xlsx — hoja «Observaciones» · Corte 31-08-2026 · 502 registros desde 10-02-2023</a:t>
             </a:r>
             <a:endParaRPr lang="en-US" sz="850" dirty="0"/>
           </a:p>
@@ -9334,7 +9262,7 @@
                 <a:ea typeface="Calibri" pitchFamily="34" charset="-122"/>
                 <a:cs typeface="Calibri" pitchFamily="34" charset="-120"/>
               </a:rPr>
-              <a:t>247 hallazgos levantados · 52 internas · 195 del cliente · 12 especialidades involucradas.</a:t>
+              <a:t>248 hallazgos levantados · 52 internas · 196 del cliente · 12 especialidades involucradas.</a:t>
             </a:r>
             <a:endParaRPr lang="en-US" sz="1350" dirty="0"/>
           </a:p>
@@ -9393,7 +9321,7 @@
                 <a:ea typeface="Cambria" pitchFamily="34" charset="-122"/>
                 <a:cs typeface="Cambria" pitchFamily="34" charset="-120"/>
               </a:rPr>
-              <a:t>96,4%</a:t>
+              <a:t>97,6%</a:t>
             </a:r>
             <a:endParaRPr lang="en-US" sz="3400" dirty="0"/>
           </a:p>
@@ -9471,7 +9399,7 @@
                 <a:ea typeface="Cambria" pitchFamily="34" charset="-122"/>
                 <a:cs typeface="Cambria" pitchFamily="34" charset="-120"/>
               </a:rPr>
-              <a:t>9</a:t>
+              <a:t>6</a:t>
             </a:r>
             <a:endParaRPr lang="en-US" sz="3400" dirty="0"/>
           </a:p>
@@ -9627,7 +9555,7 @@
                 <a:ea typeface="Cambria" pitchFamily="34" charset="-122"/>
                 <a:cs typeface="Cambria" pitchFamily="34" charset="-120"/>
               </a:rPr>
-              <a:t>21,1%</a:t>
+              <a:t>21%</a:t>
             </a:r>
             <a:endParaRPr lang="en-US" sz="3400" dirty="0"/>
           </a:p>
@@ -9705,7 +9633,7 @@
                 <a:ea typeface="Calibri" pitchFamily="34" charset="-122"/>
                 <a:cs typeface="Calibri" pitchFamily="34" charset="-120"/>
               </a:rPr>
-              <a:t>Corte: 24-08-2026</a:t>
+              <a:t>Corte: 31-08-2026</a:t>
             </a:r>
             <a:endParaRPr lang="en-US" sz="1100" dirty="0"/>
           </a:p>
@@ -9744,7 +9672,7 @@
                 <a:ea typeface="Calibri" pitchFamily="34" charset="-122"/>
                 <a:cs typeface="Calibri" pitchFamily="34" charset="-120"/>
               </a:rPr>
-              <a:t>Fuente: Data_NCR24082026.xlsx — hoja «Observaciones» · Corte 24-08-2026 · 501 registros desde 10-02-2023</a:t>
+              <a:t>Fuente: Data_NCR31082026.xlsx — hoja «Observaciones» · Corte 31-08-2026 · 502 registros desde 10-02-2023</a:t>
             </a:r>
             <a:endParaRPr lang="en-US" sz="850" dirty="0"/>
           </a:p>
@@ -10010,7 +9938,7 @@
                 <a:ea typeface="Cambria" pitchFamily="34" charset="-122"/>
                 <a:cs typeface="Cambria" pitchFamily="34" charset="-120"/>
               </a:rPr>
-              <a:t>247</a:t>
+              <a:t>248</a:t>
             </a:r>
             <a:endParaRPr lang="en-US" sz="4000" dirty="0"/>
           </a:p>
@@ -10049,7 +9977,7 @@
                 <a:ea typeface="Calibri" pitchFamily="34" charset="-122"/>
                 <a:cs typeface="Calibri" pitchFamily="34" charset="-120"/>
               </a:rPr>
-              <a:t>238 cerrados</a:t>
+              <a:t>242 cerrados</a:t>
             </a:r>
             <a:endParaRPr lang="en-US" sz="1400" dirty="0"/>
           </a:p>
@@ -10127,7 +10055,7 @@
                 <a:ea typeface="Calibri" pitchFamily="34" charset="-122"/>
                 <a:cs typeface="Calibri" pitchFamily="34" charset="-120"/>
               </a:rPr>
-              <a:t>52 internas · 195 del cliente</a:t>
+              <a:t>52 internas · 196 del cliente</a:t>
             </a:r>
             <a:endParaRPr lang="en-US" sz="950" dirty="0"/>
           </a:p>
@@ -10220,7 +10148,7 @@
                 <a:ea typeface="Cambria" pitchFamily="34" charset="-122"/>
                 <a:cs typeface="Cambria" pitchFamily="34" charset="-120"/>
               </a:rPr>
-              <a:t>96,4%</a:t>
+              <a:t>97,6%</a:t>
             </a:r>
             <a:endParaRPr lang="en-US" sz="4000" dirty="0"/>
           </a:p>
@@ -10259,7 +10187,7 @@
                 <a:ea typeface="Calibri" pitchFamily="34" charset="-122"/>
                 <a:cs typeface="Calibri" pitchFamily="34" charset="-120"/>
               </a:rPr>
-              <a:t>238/247</a:t>
+              <a:t>242/248</a:t>
             </a:r>
             <a:endParaRPr lang="en-US" sz="1400" dirty="0"/>
           </a:p>
@@ -10337,7 +10265,7 @@
                 <a:ea typeface="Calibri" pitchFamily="34" charset="-122"/>
                 <a:cs typeface="Calibri" pitchFamily="34" charset="-120"/>
               </a:rPr>
-              <a:t>Global del módulo: 90,8%</a:t>
+              <a:t>Global del módulo: 92,2%</a:t>
             </a:r>
             <a:endParaRPr lang="en-US" sz="950" dirty="0"/>
           </a:p>
@@ -10430,7 +10358,7 @@
                 <a:ea typeface="Cambria" pitchFamily="34" charset="-122"/>
                 <a:cs typeface="Cambria" pitchFamily="34" charset="-120"/>
               </a:rPr>
-              <a:t>9</a:t>
+              <a:t>6</a:t>
             </a:r>
             <a:endParaRPr lang="en-US" sz="4000" dirty="0"/>
           </a:p>
@@ -10547,7 +10475,7 @@
                 <a:ea typeface="Calibri" pitchFamily="34" charset="-122"/>
                 <a:cs typeface="Calibri" pitchFamily="34" charset="-120"/>
               </a:rPr>
-              <a:t>5 iniciado · 1 no aceptado · 3 listo para revisión</a:t>
+              <a:t>5 iniciado · 1 listo para revisión</a:t>
             </a:r>
             <a:endParaRPr lang="en-US" sz="950" dirty="0"/>
           </a:p>
@@ -10873,7 +10801,7 @@
                 <a:ea typeface="Cambria" pitchFamily="34" charset="-122"/>
                 <a:cs typeface="Cambria" pitchFamily="34" charset="-120"/>
               </a:rPr>
-              <a:t>21,1%</a:t>
+              <a:t>21%</a:t>
             </a:r>
             <a:endParaRPr lang="en-US" sz="2600" dirty="0"/>
           </a:p>
@@ -11193,7 +11121,7 @@
                 <a:ea typeface="Calibri" pitchFamily="34" charset="-122"/>
                 <a:cs typeface="Calibri" pitchFamily="34" charset="-120"/>
               </a:rPr>
-              <a:t>9 ab.</a:t>
+              <a:t>6 ab.</a:t>
             </a:r>
             <a:endParaRPr lang="en-US" sz="950" dirty="0"/>
           </a:p>
@@ -11232,7 +11160,7 @@
                 <a:ea typeface="Cambria" pitchFamily="34" charset="-122"/>
                 <a:cs typeface="Cambria" pitchFamily="34" charset="-120"/>
               </a:rPr>
-              <a:t>195</a:t>
+              <a:t>196</a:t>
             </a:r>
             <a:endParaRPr lang="en-US" sz="1600" dirty="0"/>
           </a:p>
@@ -11271,7 +11199,7 @@
                 <a:ea typeface="Calibri" pitchFamily="34" charset="-122"/>
                 <a:cs typeface="Calibri" pitchFamily="34" charset="-120"/>
               </a:rPr>
-              <a:t>Fuente: Data_NCR24082026.xlsx — hoja «Observaciones» · Corte 24-08-2026 · 501 registros desde 10-02-2023</a:t>
+              <a:t>Fuente: Data_NCR31082026.xlsx — hoja «Observaciones» · Corte 31-08-2026 · 502 registros desde 10-02-2023</a:t>
             </a:r>
             <a:endParaRPr lang="en-US" sz="850" dirty="0"/>
           </a:p>
@@ -11522,7 +11450,7 @@
                 <a:ea typeface="Calibri" pitchFamily="34" charset="-122"/>
                 <a:cs typeface="Calibri" pitchFamily="34" charset="-120"/>
               </a:rPr>
-              <a:t>9 hallazgos siguen abiertos; 0 con más de 180 días. Se listan del más antiguo al más reciente.</a:t>
+              <a:t>6 hallazgos siguen abiertos; 0 con más de 180 días. Se listan del más antiguo al más reciente.</a:t>
             </a:r>
             <a:endParaRPr lang="en-US" sz="1350" dirty="0"/>
           </a:p>
@@ -12130,7 +12058,7 @@
                 <a:ea typeface="Calibri" pitchFamily="34" charset="-122"/>
                 <a:cs typeface="Calibri" pitchFamily="34" charset="-120"/>
               </a:rPr>
-              <a:t>154</a:t>
+              <a:t>161</a:t>
             </a:r>
             <a:endParaRPr lang="en-US" sz="1050" dirty="0"/>
           </a:p>
@@ -12251,7 +12179,7 @@
                 <a:ea typeface="Calibri" pitchFamily="34" charset="-122"/>
                 <a:cs typeface="Calibri" pitchFamily="34" charset="-120"/>
               </a:rPr>
-              <a:t>205</a:t>
+              <a:t>235</a:t>
             </a:r>
             <a:endParaRPr lang="en-US" sz="1050" dirty="0"/>
           </a:p>
@@ -12290,7 +12218,7 @@
                 <a:ea typeface="Calibri" pitchFamily="34" charset="-122"/>
                 <a:cs typeface="Calibri" pitchFamily="34" charset="-120"/>
               </a:rPr>
-              <a:t>Producto No Conforme</a:t>
+              <a:t>No Conformidad</a:t>
             </a:r>
             <a:endParaRPr lang="en-US" sz="1050" dirty="0"/>
           </a:p>
@@ -12407,7 +12335,7 @@
                 <a:ea typeface="Calibri" pitchFamily="34" charset="-122"/>
                 <a:cs typeface="Calibri" pitchFamily="34" charset="-120"/>
               </a:rPr>
-              <a:t>Sebastián Ramos</a:t>
+              <a:t>Mauricio Rocha A.</a:t>
             </a:r>
             <a:endParaRPr lang="en-US" sz="1050" dirty="0"/>
           </a:p>
@@ -12446,7 +12374,7 @@
                 <a:ea typeface="Calibri" pitchFamily="34" charset="-122"/>
                 <a:cs typeface="Calibri" pitchFamily="34" charset="-120"/>
               </a:rPr>
-              <a:t>No aceptado</a:t>
+              <a:t>Iniciado</a:t>
             </a:r>
             <a:endParaRPr lang="en-US" sz="1050" dirty="0"/>
           </a:p>
@@ -12485,7 +12413,7 @@
                 <a:ea typeface="Calibri" pitchFamily="34" charset="-122"/>
                 <a:cs typeface="Calibri" pitchFamily="34" charset="-120"/>
               </a:rPr>
-              <a:t>140</a:t>
+              <a:t>62</a:t>
             </a:r>
             <a:endParaRPr lang="en-US" sz="1050" dirty="0"/>
           </a:p>
@@ -12524,7 +12452,7 @@
                 <a:ea typeface="Calibri" pitchFamily="34" charset="-122"/>
                 <a:cs typeface="Calibri" pitchFamily="34" charset="-120"/>
               </a:rPr>
-              <a:t>Solución proyectada asociada al ele…</a:t>
+              <a:t>Geomembrana presenta sectores en lo…</a:t>
             </a:r>
             <a:endParaRPr lang="en-US" sz="1000" dirty="0"/>
           </a:p>
@@ -12586,7 +12514,7 @@
                 <a:ea typeface="Calibri" pitchFamily="34" charset="-122"/>
                 <a:cs typeface="Calibri" pitchFamily="34" charset="-120"/>
               </a:rPr>
-              <a:t>230</a:t>
+              <a:t>241</a:t>
             </a:r>
             <a:endParaRPr lang="en-US" sz="1050" dirty="0"/>
           </a:p>
@@ -12742,7 +12670,7 @@
                 <a:ea typeface="Calibri" pitchFamily="34" charset="-122"/>
                 <a:cs typeface="Calibri" pitchFamily="34" charset="-120"/>
               </a:rPr>
-              <a:t>Mauricio Soto B.</a:t>
+              <a:t>Daniel Ramirez B.</a:t>
             </a:r>
             <a:endParaRPr lang="en-US" sz="1050" dirty="0"/>
           </a:p>
@@ -12781,7 +12709,7 @@
                 <a:ea typeface="Calibri" pitchFamily="34" charset="-122"/>
                 <a:cs typeface="Calibri" pitchFamily="34" charset="-120"/>
               </a:rPr>
-              <a:t>Iniciado</a:t>
+              <a:t>Listo para revisi…</a:t>
             </a:r>
             <a:endParaRPr lang="en-US" sz="1050" dirty="0"/>
           </a:p>
@@ -12820,7 +12748,7 @@
                 <a:ea typeface="Calibri" pitchFamily="34" charset="-122"/>
                 <a:cs typeface="Calibri" pitchFamily="34" charset="-120"/>
               </a:rPr>
-              <a:t>76</a:t>
+              <a:t>34</a:t>
             </a:r>
             <a:endParaRPr lang="en-US" sz="1050" dirty="0"/>
           </a:p>
@@ -12859,7 +12787,7 @@
                 <a:ea typeface="Calibri" pitchFamily="34" charset="-122"/>
                 <a:cs typeface="Calibri" pitchFamily="34" charset="-120"/>
               </a:rPr>
-              <a:t>No se evidenció un Plan de Cierre d…</a:t>
+              <a:t>Registros de construcción no contie…</a:t>
             </a:r>
             <a:endParaRPr lang="en-US" sz="1000" dirty="0"/>
           </a:p>
@@ -12941,7 +12869,7 @@
                 <a:ea typeface="Calibri" pitchFamily="34" charset="-122"/>
                 <a:cs typeface="Calibri" pitchFamily="34" charset="-120"/>
               </a:rPr>
-              <a:t>235</a:t>
+              <a:t>247</a:t>
             </a:r>
             <a:endParaRPr lang="en-US" sz="1050" dirty="0"/>
           </a:p>
@@ -13097,7 +13025,7 @@
                 <a:ea typeface="Calibri" pitchFamily="34" charset="-122"/>
                 <a:cs typeface="Calibri" pitchFamily="34" charset="-120"/>
               </a:rPr>
-              <a:t>Mauricio Rocha A.</a:t>
+              <a:t>Luis Ogalde H.</a:t>
             </a:r>
             <a:endParaRPr lang="en-US" sz="1050" dirty="0"/>
           </a:p>
@@ -13175,7 +13103,7 @@
                 <a:ea typeface="Calibri" pitchFamily="34" charset="-122"/>
                 <a:cs typeface="Calibri" pitchFamily="34" charset="-120"/>
               </a:rPr>
-              <a:t>55</a:t>
+              <a:t>12</a:t>
             </a:r>
             <a:endParaRPr lang="en-US" sz="1050" dirty="0"/>
           </a:p>
@@ -13214,7 +13142,7 @@
                 <a:ea typeface="Calibri" pitchFamily="34" charset="-122"/>
                 <a:cs typeface="Calibri" pitchFamily="34" charset="-120"/>
               </a:rPr>
-              <a:t>Geomembrana presenta sectores en lo…</a:t>
+              <a:t>Fundaciones FS-01 (10 elementos) no…</a:t>
             </a:r>
             <a:endParaRPr lang="en-US" sz="1000" dirty="0"/>
           </a:p>
@@ -13276,7 +13204,7 @@
                 <a:ea typeface="Calibri" pitchFamily="34" charset="-122"/>
                 <a:cs typeface="Calibri" pitchFamily="34" charset="-120"/>
               </a:rPr>
-              <a:t>241</a:t>
+              <a:t>248</a:t>
             </a:r>
             <a:endParaRPr lang="en-US" sz="1050" dirty="0"/>
           </a:p>
@@ -13393,7 +13321,7 @@
                 <a:ea typeface="Calibri" pitchFamily="34" charset="-122"/>
                 <a:cs typeface="Calibri" pitchFamily="34" charset="-120"/>
               </a:rPr>
-              <a:t>CALIDAD</a:t>
+              <a:t>PIPING</a:t>
             </a:r>
             <a:endParaRPr lang="en-US" sz="1050" dirty="0"/>
           </a:p>
@@ -13432,7 +13360,7 @@
                 <a:ea typeface="Calibri" pitchFamily="34" charset="-122"/>
                 <a:cs typeface="Calibri" pitchFamily="34" charset="-120"/>
               </a:rPr>
-              <a:t>Daniel Ramirez B.</a:t>
+              <a:t>Oscar Nahuel P.</a:t>
             </a:r>
             <a:endParaRPr lang="en-US" sz="1050" dirty="0"/>
           </a:p>
@@ -13471,7 +13399,7 @@
                 <a:ea typeface="Calibri" pitchFamily="34" charset="-122"/>
                 <a:cs typeface="Calibri" pitchFamily="34" charset="-120"/>
               </a:rPr>
-              <a:t>Listo para revisi…</a:t>
+              <a:t>Iniciado</a:t>
             </a:r>
             <a:endParaRPr lang="en-US" sz="1050" dirty="0"/>
           </a:p>
@@ -13510,7 +13438,7 @@
                 <a:ea typeface="Calibri" pitchFamily="34" charset="-122"/>
                 <a:cs typeface="Calibri" pitchFamily="34" charset="-120"/>
               </a:rPr>
-              <a:t>27</a:t>
+              <a:t>12</a:t>
             </a:r>
             <a:endParaRPr lang="en-US" sz="1050" dirty="0"/>
           </a:p>
@@ -13549,7 +13477,7 @@
                 <a:ea typeface="Calibri" pitchFamily="34" charset="-122"/>
                 <a:cs typeface="Calibri" pitchFamily="34" charset="-120"/>
               </a:rPr>
-              <a:t>Registros de construcción no contie…</a:t>
+              <a:t>Línea TAG N° 3716D-RW-24-H1-0425-N …</a:t>
             </a:r>
             <a:endParaRPr lang="en-US" sz="1000" dirty="0"/>
           </a:p>
@@ -13631,7 +13559,7 @@
                 <a:ea typeface="Calibri" pitchFamily="34" charset="-122"/>
                 <a:cs typeface="Calibri" pitchFamily="34" charset="-120"/>
               </a:rPr>
-              <a:t>243</a:t>
+              <a:t>249</a:t>
             </a:r>
             <a:endParaRPr lang="en-US" sz="1050" dirty="0"/>
           </a:p>
@@ -13670,7 +13598,7 @@
                 <a:ea typeface="Calibri" pitchFamily="34" charset="-122"/>
                 <a:cs typeface="Calibri" pitchFamily="34" charset="-120"/>
               </a:rPr>
-              <a:t>No Conformidad</a:t>
+              <a:t>Producto No Conforme</a:t>
             </a:r>
             <a:endParaRPr lang="en-US" sz="1050" dirty="0"/>
           </a:p>
@@ -13826,7 +13754,7 @@
                 <a:ea typeface="Calibri" pitchFamily="34" charset="-122"/>
                 <a:cs typeface="Calibri" pitchFamily="34" charset="-120"/>
               </a:rPr>
-              <a:t>Listo para revisi…</a:t>
+              <a:t>Iniciado</a:t>
             </a:r>
             <a:endParaRPr lang="en-US" sz="1050" dirty="0"/>
           </a:p>
@@ -13865,7 +13793,7 @@
                 <a:ea typeface="Calibri" pitchFamily="34" charset="-122"/>
                 <a:cs typeface="Calibri" pitchFamily="34" charset="-120"/>
               </a:rPr>
-              <a:t>14</a:t>
+              <a:t>7</a:t>
             </a:r>
             <a:endParaRPr lang="en-US" sz="1050" dirty="0"/>
           </a:p>
@@ -13904,7 +13832,7 @@
                 <a:ea typeface="Calibri" pitchFamily="34" charset="-122"/>
                 <a:cs typeface="Calibri" pitchFamily="34" charset="-120"/>
               </a:rPr>
-              <a:t>Rollos de geomembrana KRAH (2 mm es…</a:t>
+              <a:t>Se evidencia daño físico en la geom…</a:t>
             </a:r>
             <a:endParaRPr lang="en-US" sz="1000" dirty="0"/>
           </a:p>
@@ -13935,1032 +13863,7 @@
       </p:sp>
       <p:sp>
         <p:nvSpPr>
-          <p:cNvPr id="72" name="Text 69"/>
-          <p:cNvSpPr/>
-          <p:nvPr/>
-        </p:nvSpPr>
-        <p:spPr>
-          <a:xfrm>
-            <a:off x="502920" y="4398264"/>
-            <a:ext cx="822960" cy="256032"/>
-          </a:xfrm>
-          <a:prstGeom prst="rect">
-            <a:avLst/>
-          </a:prstGeom>
-          <a:noFill/>
-          <a:ln/>
-        </p:spPr>
-        <p:txBody>
-          <a:bodyPr wrap="square" lIns="0" tIns="0" rIns="0" bIns="0" rtlCol="0" anchor="ctr"/>
-          <a:lstStyle/>
-          <a:p>
-            <a:pPr algn="l" indent="0" marL="0">
-              <a:buNone/>
-            </a:pPr>
-            <a:r>
-              <a:rPr lang="en-US" sz="1050" dirty="0">
-                <a:solidFill>
-                  <a:srgbClr val="1A2433"/>
-                </a:solidFill>
-                <a:latin typeface="Calibri" pitchFamily="34" charset="0"/>
-                <a:ea typeface="Calibri" pitchFamily="34" charset="-122"/>
-                <a:cs typeface="Calibri" pitchFamily="34" charset="-120"/>
-              </a:rPr>
-              <a:t>244</a:t>
-            </a:r>
-            <a:endParaRPr lang="en-US" sz="1050" dirty="0"/>
-          </a:p>
-        </p:txBody>
-      </p:sp>
-      <p:sp>
-        <p:nvSpPr>
-          <p:cNvPr id="73" name="Text 70"/>
-          <p:cNvSpPr/>
-          <p:nvPr/>
-        </p:nvSpPr>
-        <p:spPr>
-          <a:xfrm>
-            <a:off x="1371600" y="4398264"/>
-            <a:ext cx="1508760" cy="256032"/>
-          </a:xfrm>
-          <a:prstGeom prst="rect">
-            <a:avLst/>
-          </a:prstGeom>
-          <a:noFill/>
-          <a:ln/>
-        </p:spPr>
-        <p:txBody>
-          <a:bodyPr wrap="square" lIns="0" tIns="0" rIns="0" bIns="0" rtlCol="0" anchor="ctr"/>
-          <a:lstStyle/>
-          <a:p>
-            <a:pPr algn="l" indent="0" marL="0">
-              <a:buNone/>
-            </a:pPr>
-            <a:r>
-              <a:rPr lang="en-US" sz="1050" dirty="0">
-                <a:solidFill>
-                  <a:srgbClr val="1A2433"/>
-                </a:solidFill>
-                <a:latin typeface="Calibri" pitchFamily="34" charset="0"/>
-                <a:ea typeface="Calibri" pitchFamily="34" charset="-122"/>
-                <a:cs typeface="Calibri" pitchFamily="34" charset="-120"/>
-              </a:rPr>
-              <a:t>No Conformidad</a:t>
-            </a:r>
-            <a:endParaRPr lang="en-US" sz="1050" dirty="0"/>
-          </a:p>
-        </p:txBody>
-      </p:sp>
-      <p:sp>
-        <p:nvSpPr>
-          <p:cNvPr id="74" name="Text 71"/>
-          <p:cNvSpPr/>
-          <p:nvPr/>
-        </p:nvSpPr>
-        <p:spPr>
-          <a:xfrm>
-            <a:off x="2926080" y="4398264"/>
-            <a:ext cx="1463040" cy="256032"/>
-          </a:xfrm>
-          <a:prstGeom prst="rect">
-            <a:avLst/>
-          </a:prstGeom>
-          <a:noFill/>
-          <a:ln/>
-        </p:spPr>
-        <p:txBody>
-          <a:bodyPr wrap="square" lIns="0" tIns="0" rIns="0" bIns="0" rtlCol="0" anchor="ctr"/>
-          <a:lstStyle/>
-          <a:p>
-            <a:pPr algn="l" indent="0" marL="0">
-              <a:buNone/>
-            </a:pPr>
-            <a:r>
-              <a:rPr lang="en-US" sz="1050" b="1" dirty="0">
-                <a:solidFill>
-                  <a:srgbClr val="C87A32"/>
-                </a:solidFill>
-                <a:latin typeface="Calibri" pitchFamily="34" charset="0"/>
-                <a:ea typeface="Calibri" pitchFamily="34" charset="-122"/>
-                <a:cs typeface="Calibri" pitchFamily="34" charset="-120"/>
-              </a:rPr>
-              <a:t>Externa · Cliente</a:t>
-            </a:r>
-            <a:endParaRPr lang="en-US" sz="1050" dirty="0"/>
-          </a:p>
-        </p:txBody>
-      </p:sp>
-      <p:sp>
-        <p:nvSpPr>
-          <p:cNvPr id="75" name="Text 72"/>
-          <p:cNvSpPr/>
-          <p:nvPr/>
-        </p:nvSpPr>
-        <p:spPr>
-          <a:xfrm>
-            <a:off x="4434840" y="4398264"/>
-            <a:ext cx="1280160" cy="256032"/>
-          </a:xfrm>
-          <a:prstGeom prst="rect">
-            <a:avLst/>
-          </a:prstGeom>
-          <a:noFill/>
-          <a:ln/>
-        </p:spPr>
-        <p:txBody>
-          <a:bodyPr wrap="square" lIns="0" tIns="0" rIns="0" bIns="0" rtlCol="0" anchor="ctr"/>
-          <a:lstStyle/>
-          <a:p>
-            <a:pPr algn="l" indent="0" marL="0">
-              <a:buNone/>
-            </a:pPr>
-            <a:r>
-              <a:rPr lang="en-US" sz="1050" dirty="0">
-                <a:solidFill>
-                  <a:srgbClr val="1A2433"/>
-                </a:solidFill>
-                <a:latin typeface="Calibri" pitchFamily="34" charset="0"/>
-                <a:ea typeface="Calibri" pitchFamily="34" charset="-122"/>
-                <a:cs typeface="Calibri" pitchFamily="34" charset="-120"/>
-              </a:rPr>
-              <a:t>OO.CC</a:t>
-            </a:r>
-            <a:endParaRPr lang="en-US" sz="1050" dirty="0"/>
-          </a:p>
-        </p:txBody>
-      </p:sp>
-      <p:sp>
-        <p:nvSpPr>
-          <p:cNvPr id="76" name="Text 73"/>
-          <p:cNvSpPr/>
-          <p:nvPr/>
-        </p:nvSpPr>
-        <p:spPr>
-          <a:xfrm>
-            <a:off x="5760720" y="4398264"/>
-            <a:ext cx="1508760" cy="256032"/>
-          </a:xfrm>
-          <a:prstGeom prst="rect">
-            <a:avLst/>
-          </a:prstGeom>
-          <a:noFill/>
-          <a:ln/>
-        </p:spPr>
-        <p:txBody>
-          <a:bodyPr wrap="square" lIns="0" tIns="0" rIns="0" bIns="0" rtlCol="0" anchor="ctr"/>
-          <a:lstStyle/>
-          <a:p>
-            <a:pPr algn="l" indent="0" marL="0">
-              <a:buNone/>
-            </a:pPr>
-            <a:r>
-              <a:rPr lang="en-US" sz="1050" dirty="0">
-                <a:solidFill>
-                  <a:srgbClr val="1A2433"/>
-                </a:solidFill>
-                <a:latin typeface="Calibri" pitchFamily="34" charset="0"/>
-                <a:ea typeface="Calibri" pitchFamily="34" charset="-122"/>
-                <a:cs typeface="Calibri" pitchFamily="34" charset="-120"/>
-              </a:rPr>
-              <a:t>Mauricio Rocha A.</a:t>
-            </a:r>
-            <a:endParaRPr lang="en-US" sz="1050" dirty="0"/>
-          </a:p>
-        </p:txBody>
-      </p:sp>
-      <p:sp>
-        <p:nvSpPr>
-          <p:cNvPr id="77" name="Text 74"/>
-          <p:cNvSpPr/>
-          <p:nvPr/>
-        </p:nvSpPr>
-        <p:spPr>
-          <a:xfrm>
-            <a:off x="7315200" y="4398264"/>
-            <a:ext cx="1325880" cy="256032"/>
-          </a:xfrm>
-          <a:prstGeom prst="rect">
-            <a:avLst/>
-          </a:prstGeom>
-          <a:noFill/>
-          <a:ln/>
-        </p:spPr>
-        <p:txBody>
-          <a:bodyPr wrap="square" lIns="0" tIns="0" rIns="0" bIns="0" rtlCol="0" anchor="ctr"/>
-          <a:lstStyle/>
-          <a:p>
-            <a:pPr algn="l" indent="0" marL="0">
-              <a:buNone/>
-            </a:pPr>
-            <a:r>
-              <a:rPr lang="en-US" sz="1050" dirty="0">
-                <a:solidFill>
-                  <a:srgbClr val="1A2433"/>
-                </a:solidFill>
-                <a:latin typeface="Calibri" pitchFamily="34" charset="0"/>
-                <a:ea typeface="Calibri" pitchFamily="34" charset="-122"/>
-                <a:cs typeface="Calibri" pitchFamily="34" charset="-120"/>
-              </a:rPr>
-              <a:t>Listo para revisi…</a:t>
-            </a:r>
-            <a:endParaRPr lang="en-US" sz="1050" dirty="0"/>
-          </a:p>
-        </p:txBody>
-      </p:sp>
-      <p:sp>
-        <p:nvSpPr>
-          <p:cNvPr id="78" name="Text 75"/>
-          <p:cNvSpPr/>
-          <p:nvPr/>
-        </p:nvSpPr>
-        <p:spPr>
-          <a:xfrm>
-            <a:off x="8686800" y="4398264"/>
-            <a:ext cx="640080" cy="256032"/>
-          </a:xfrm>
-          <a:prstGeom prst="rect">
-            <a:avLst/>
-          </a:prstGeom>
-          <a:noFill/>
-          <a:ln/>
-        </p:spPr>
-        <p:txBody>
-          <a:bodyPr wrap="square" lIns="0" tIns="0" rIns="0" bIns="0" rtlCol="0" anchor="ctr"/>
-          <a:lstStyle/>
-          <a:p>
-            <a:pPr algn="r" indent="0" marL="0">
-              <a:buNone/>
-            </a:pPr>
-            <a:r>
-              <a:rPr lang="en-US" sz="1050" dirty="0">
-                <a:solidFill>
-                  <a:srgbClr val="1A2433"/>
-                </a:solidFill>
-                <a:latin typeface="Calibri" pitchFamily="34" charset="0"/>
-                <a:ea typeface="Calibri" pitchFamily="34" charset="-122"/>
-                <a:cs typeface="Calibri" pitchFamily="34" charset="-120"/>
-              </a:rPr>
-              <a:t>14</a:t>
-            </a:r>
-            <a:endParaRPr lang="en-US" sz="1050" dirty="0"/>
-          </a:p>
-        </p:txBody>
-      </p:sp>
-      <p:sp>
-        <p:nvSpPr>
-          <p:cNvPr id="79" name="Text 76"/>
-          <p:cNvSpPr/>
-          <p:nvPr/>
-        </p:nvSpPr>
-        <p:spPr>
-          <a:xfrm>
-            <a:off x="9464040" y="4398264"/>
-            <a:ext cx="2286000" cy="256032"/>
-          </a:xfrm>
-          <a:prstGeom prst="rect">
-            <a:avLst/>
-          </a:prstGeom>
-          <a:noFill/>
-          <a:ln/>
-        </p:spPr>
-        <p:txBody>
-          <a:bodyPr wrap="square" lIns="0" tIns="0" rIns="0" bIns="0" rtlCol="0" anchor="ctr"/>
-          <a:lstStyle/>
-          <a:p>
-            <a:pPr algn="l" indent="0" marL="0">
-              <a:buNone/>
-            </a:pPr>
-            <a:r>
-              <a:rPr lang="en-US" sz="1000" dirty="0">
-                <a:solidFill>
-                  <a:srgbClr val="1A2433"/>
-                </a:solidFill>
-                <a:latin typeface="Calibri" pitchFamily="34" charset="0"/>
-                <a:ea typeface="Calibri" pitchFamily="34" charset="-122"/>
-                <a:cs typeface="Calibri" pitchFamily="34" charset="-120"/>
-              </a:rPr>
-              <a:t>En Piscina Quebrada Sur, se evidenc…</a:t>
-            </a:r>
-            <a:endParaRPr lang="en-US" sz="1000" dirty="0"/>
-          </a:p>
-        </p:txBody>
-      </p:sp>
-      <p:sp>
-        <p:nvSpPr>
-          <p:cNvPr id="80" name="Shape 77"/>
-          <p:cNvSpPr/>
-          <p:nvPr/>
-        </p:nvSpPr>
-        <p:spPr>
-          <a:xfrm>
-            <a:off x="502920" y="4690872"/>
-            <a:ext cx="11247120" cy="0"/>
-          </a:xfrm>
-          <a:prstGeom prst="line">
-            <a:avLst/>
-          </a:prstGeom>
-          <a:noFill/>
-          <a:ln w="9525">
-            <a:solidFill>
-              <a:srgbClr val="D9DFE6"/>
-            </a:solidFill>
-            <a:prstDash val="solid"/>
-          </a:ln>
-        </p:spPr>
-      </p:sp>
-      <p:sp>
-        <p:nvSpPr>
-          <p:cNvPr id="81" name="Shape 78"/>
-          <p:cNvSpPr/>
-          <p:nvPr/>
-        </p:nvSpPr>
-        <p:spPr>
-          <a:xfrm>
-            <a:off x="457200" y="4700016"/>
-            <a:ext cx="11292840" cy="347472"/>
-          </a:xfrm>
-          <a:prstGeom prst="rect">
-            <a:avLst/>
-          </a:prstGeom>
-          <a:solidFill>
-            <a:srgbClr val="FFFFFF"/>
-          </a:solidFill>
-          <a:ln/>
-        </p:spPr>
-      </p:sp>
-      <p:sp>
-        <p:nvSpPr>
-          <p:cNvPr id="82" name="Text 79"/>
-          <p:cNvSpPr/>
-          <p:nvPr/>
-        </p:nvSpPr>
-        <p:spPr>
-          <a:xfrm>
-            <a:off x="502920" y="4745736"/>
-            <a:ext cx="822960" cy="256032"/>
-          </a:xfrm>
-          <a:prstGeom prst="rect">
-            <a:avLst/>
-          </a:prstGeom>
-          <a:noFill/>
-          <a:ln/>
-        </p:spPr>
-        <p:txBody>
-          <a:bodyPr wrap="square" lIns="0" tIns="0" rIns="0" bIns="0" rtlCol="0" anchor="ctr"/>
-          <a:lstStyle/>
-          <a:p>
-            <a:pPr algn="l" indent="0" marL="0">
-              <a:buNone/>
-            </a:pPr>
-            <a:r>
-              <a:rPr lang="en-US" sz="1050" dirty="0">
-                <a:solidFill>
-                  <a:srgbClr val="1A2433"/>
-                </a:solidFill>
-                <a:latin typeface="Calibri" pitchFamily="34" charset="0"/>
-                <a:ea typeface="Calibri" pitchFamily="34" charset="-122"/>
-                <a:cs typeface="Calibri" pitchFamily="34" charset="-120"/>
-              </a:rPr>
-              <a:t>247</a:t>
-            </a:r>
-            <a:endParaRPr lang="en-US" sz="1050" dirty="0"/>
-          </a:p>
-        </p:txBody>
-      </p:sp>
-      <p:sp>
-        <p:nvSpPr>
-          <p:cNvPr id="83" name="Text 80"/>
-          <p:cNvSpPr/>
-          <p:nvPr/>
-        </p:nvSpPr>
-        <p:spPr>
-          <a:xfrm>
-            <a:off x="1371600" y="4745736"/>
-            <a:ext cx="1508760" cy="256032"/>
-          </a:xfrm>
-          <a:prstGeom prst="rect">
-            <a:avLst/>
-          </a:prstGeom>
-          <a:noFill/>
-          <a:ln/>
-        </p:spPr>
-        <p:txBody>
-          <a:bodyPr wrap="square" lIns="0" tIns="0" rIns="0" bIns="0" rtlCol="0" anchor="ctr"/>
-          <a:lstStyle/>
-          <a:p>
-            <a:pPr algn="l" indent="0" marL="0">
-              <a:buNone/>
-            </a:pPr>
-            <a:r>
-              <a:rPr lang="en-US" sz="1050" dirty="0">
-                <a:solidFill>
-                  <a:srgbClr val="1A2433"/>
-                </a:solidFill>
-                <a:latin typeface="Calibri" pitchFamily="34" charset="0"/>
-                <a:ea typeface="Calibri" pitchFamily="34" charset="-122"/>
-                <a:cs typeface="Calibri" pitchFamily="34" charset="-120"/>
-              </a:rPr>
-              <a:t>No Conformidad</a:t>
-            </a:r>
-            <a:endParaRPr lang="en-US" sz="1050" dirty="0"/>
-          </a:p>
-        </p:txBody>
-      </p:sp>
-      <p:sp>
-        <p:nvSpPr>
-          <p:cNvPr id="84" name="Text 81"/>
-          <p:cNvSpPr/>
-          <p:nvPr/>
-        </p:nvSpPr>
-        <p:spPr>
-          <a:xfrm>
-            <a:off x="2926080" y="4745736"/>
-            <a:ext cx="1463040" cy="256032"/>
-          </a:xfrm>
-          <a:prstGeom prst="rect">
-            <a:avLst/>
-          </a:prstGeom>
-          <a:noFill/>
-          <a:ln/>
-        </p:spPr>
-        <p:txBody>
-          <a:bodyPr wrap="square" lIns="0" tIns="0" rIns="0" bIns="0" rtlCol="0" anchor="ctr"/>
-          <a:lstStyle/>
-          <a:p>
-            <a:pPr algn="l" indent="0" marL="0">
-              <a:buNone/>
-            </a:pPr>
-            <a:r>
-              <a:rPr lang="en-US" sz="1050" b="1" dirty="0">
-                <a:solidFill>
-                  <a:srgbClr val="C87A32"/>
-                </a:solidFill>
-                <a:latin typeface="Calibri" pitchFamily="34" charset="0"/>
-                <a:ea typeface="Calibri" pitchFamily="34" charset="-122"/>
-                <a:cs typeface="Calibri" pitchFamily="34" charset="-120"/>
-              </a:rPr>
-              <a:t>Externa · Cliente</a:t>
-            </a:r>
-            <a:endParaRPr lang="en-US" sz="1050" dirty="0"/>
-          </a:p>
-        </p:txBody>
-      </p:sp>
-      <p:sp>
-        <p:nvSpPr>
-          <p:cNvPr id="85" name="Text 82"/>
-          <p:cNvSpPr/>
-          <p:nvPr/>
-        </p:nvSpPr>
-        <p:spPr>
-          <a:xfrm>
-            <a:off x="4434840" y="4745736"/>
-            <a:ext cx="1280160" cy="256032"/>
-          </a:xfrm>
-          <a:prstGeom prst="rect">
-            <a:avLst/>
-          </a:prstGeom>
-          <a:noFill/>
-          <a:ln/>
-        </p:spPr>
-        <p:txBody>
-          <a:bodyPr wrap="square" lIns="0" tIns="0" rIns="0" bIns="0" rtlCol="0" anchor="ctr"/>
-          <a:lstStyle/>
-          <a:p>
-            <a:pPr algn="l" indent="0" marL="0">
-              <a:buNone/>
-            </a:pPr>
-            <a:r>
-              <a:rPr lang="en-US" sz="1050" dirty="0">
-                <a:solidFill>
-                  <a:srgbClr val="1A2433"/>
-                </a:solidFill>
-                <a:latin typeface="Calibri" pitchFamily="34" charset="0"/>
-                <a:ea typeface="Calibri" pitchFamily="34" charset="-122"/>
-                <a:cs typeface="Calibri" pitchFamily="34" charset="-120"/>
-              </a:rPr>
-              <a:t>OO.CC</a:t>
-            </a:r>
-            <a:endParaRPr lang="en-US" sz="1050" dirty="0"/>
-          </a:p>
-        </p:txBody>
-      </p:sp>
-      <p:sp>
-        <p:nvSpPr>
-          <p:cNvPr id="86" name="Text 83"/>
-          <p:cNvSpPr/>
-          <p:nvPr/>
-        </p:nvSpPr>
-        <p:spPr>
-          <a:xfrm>
-            <a:off x="5760720" y="4745736"/>
-            <a:ext cx="1508760" cy="256032"/>
-          </a:xfrm>
-          <a:prstGeom prst="rect">
-            <a:avLst/>
-          </a:prstGeom>
-          <a:noFill/>
-          <a:ln/>
-        </p:spPr>
-        <p:txBody>
-          <a:bodyPr wrap="square" lIns="0" tIns="0" rIns="0" bIns="0" rtlCol="0" anchor="ctr"/>
-          <a:lstStyle/>
-          <a:p>
-            <a:pPr algn="l" indent="0" marL="0">
-              <a:buNone/>
-            </a:pPr>
-            <a:r>
-              <a:rPr lang="en-US" sz="1050" dirty="0">
-                <a:solidFill>
-                  <a:srgbClr val="1A2433"/>
-                </a:solidFill>
-                <a:latin typeface="Calibri" pitchFamily="34" charset="0"/>
-                <a:ea typeface="Calibri" pitchFamily="34" charset="-122"/>
-                <a:cs typeface="Calibri" pitchFamily="34" charset="-120"/>
-              </a:rPr>
-              <a:t>Luis Ogalde H.</a:t>
-            </a:r>
-            <a:endParaRPr lang="en-US" sz="1050" dirty="0"/>
-          </a:p>
-        </p:txBody>
-      </p:sp>
-      <p:sp>
-        <p:nvSpPr>
-          <p:cNvPr id="87" name="Text 84"/>
-          <p:cNvSpPr/>
-          <p:nvPr/>
-        </p:nvSpPr>
-        <p:spPr>
-          <a:xfrm>
-            <a:off x="7315200" y="4745736"/>
-            <a:ext cx="1325880" cy="256032"/>
-          </a:xfrm>
-          <a:prstGeom prst="rect">
-            <a:avLst/>
-          </a:prstGeom>
-          <a:noFill/>
-          <a:ln/>
-        </p:spPr>
-        <p:txBody>
-          <a:bodyPr wrap="square" lIns="0" tIns="0" rIns="0" bIns="0" rtlCol="0" anchor="ctr"/>
-          <a:lstStyle/>
-          <a:p>
-            <a:pPr algn="l" indent="0" marL="0">
-              <a:buNone/>
-            </a:pPr>
-            <a:r>
-              <a:rPr lang="en-US" sz="1050" dirty="0">
-                <a:solidFill>
-                  <a:srgbClr val="1A2433"/>
-                </a:solidFill>
-                <a:latin typeface="Calibri" pitchFamily="34" charset="0"/>
-                <a:ea typeface="Calibri" pitchFamily="34" charset="-122"/>
-                <a:cs typeface="Calibri" pitchFamily="34" charset="-120"/>
-              </a:rPr>
-              <a:t>Iniciado</a:t>
-            </a:r>
-            <a:endParaRPr lang="en-US" sz="1050" dirty="0"/>
-          </a:p>
-        </p:txBody>
-      </p:sp>
-      <p:sp>
-        <p:nvSpPr>
-          <p:cNvPr id="88" name="Text 85"/>
-          <p:cNvSpPr/>
-          <p:nvPr/>
-        </p:nvSpPr>
-        <p:spPr>
-          <a:xfrm>
-            <a:off x="8686800" y="4745736"/>
-            <a:ext cx="640080" cy="256032"/>
-          </a:xfrm>
-          <a:prstGeom prst="rect">
-            <a:avLst/>
-          </a:prstGeom>
-          <a:noFill/>
-          <a:ln/>
-        </p:spPr>
-        <p:txBody>
-          <a:bodyPr wrap="square" lIns="0" tIns="0" rIns="0" bIns="0" rtlCol="0" anchor="ctr"/>
-          <a:lstStyle/>
-          <a:p>
-            <a:pPr algn="r" indent="0" marL="0">
-              <a:buNone/>
-            </a:pPr>
-            <a:r>
-              <a:rPr lang="en-US" sz="1050" dirty="0">
-                <a:solidFill>
-                  <a:srgbClr val="1A2433"/>
-                </a:solidFill>
-                <a:latin typeface="Calibri" pitchFamily="34" charset="0"/>
-                <a:ea typeface="Calibri" pitchFamily="34" charset="-122"/>
-                <a:cs typeface="Calibri" pitchFamily="34" charset="-120"/>
-              </a:rPr>
-              <a:t>5</a:t>
-            </a:r>
-            <a:endParaRPr lang="en-US" sz="1050" dirty="0"/>
-          </a:p>
-        </p:txBody>
-      </p:sp>
-      <p:sp>
-        <p:nvSpPr>
-          <p:cNvPr id="89" name="Text 86"/>
-          <p:cNvSpPr/>
-          <p:nvPr/>
-        </p:nvSpPr>
-        <p:spPr>
-          <a:xfrm>
-            <a:off x="9464040" y="4745736"/>
-            <a:ext cx="2286000" cy="256032"/>
-          </a:xfrm>
-          <a:prstGeom prst="rect">
-            <a:avLst/>
-          </a:prstGeom>
-          <a:noFill/>
-          <a:ln/>
-        </p:spPr>
-        <p:txBody>
-          <a:bodyPr wrap="square" lIns="0" tIns="0" rIns="0" bIns="0" rtlCol="0" anchor="ctr"/>
-          <a:lstStyle/>
-          <a:p>
-            <a:pPr algn="l" indent="0" marL="0">
-              <a:buNone/>
-            </a:pPr>
-            <a:r>
-              <a:rPr lang="en-US" sz="1000" dirty="0">
-                <a:solidFill>
-                  <a:srgbClr val="1A2433"/>
-                </a:solidFill>
-                <a:latin typeface="Calibri" pitchFamily="34" charset="0"/>
-                <a:ea typeface="Calibri" pitchFamily="34" charset="-122"/>
-                <a:cs typeface="Calibri" pitchFamily="34" charset="-120"/>
-              </a:rPr>
-              <a:t>Fundaciones FS-01 (10 elementos) no…</a:t>
-            </a:r>
-            <a:endParaRPr lang="en-US" sz="1000" dirty="0"/>
-          </a:p>
-        </p:txBody>
-      </p:sp>
-      <p:sp>
-        <p:nvSpPr>
-          <p:cNvPr id="90" name="Shape 87"/>
-          <p:cNvSpPr/>
-          <p:nvPr/>
-        </p:nvSpPr>
-        <p:spPr>
-          <a:xfrm>
-            <a:off x="502920" y="5038344"/>
-            <a:ext cx="11247120" cy="0"/>
-          </a:xfrm>
-          <a:prstGeom prst="line">
-            <a:avLst/>
-          </a:prstGeom>
-          <a:noFill/>
-          <a:ln w="9525">
-            <a:solidFill>
-              <a:srgbClr val="D9DFE6"/>
-            </a:solidFill>
-            <a:prstDash val="solid"/>
-          </a:ln>
-        </p:spPr>
-      </p:sp>
-      <p:sp>
-        <p:nvSpPr>
-          <p:cNvPr id="91" name="Text 88"/>
-          <p:cNvSpPr/>
-          <p:nvPr/>
-        </p:nvSpPr>
-        <p:spPr>
-          <a:xfrm>
-            <a:off x="502920" y="5093208"/>
-            <a:ext cx="822960" cy="256032"/>
-          </a:xfrm>
-          <a:prstGeom prst="rect">
-            <a:avLst/>
-          </a:prstGeom>
-          <a:noFill/>
-          <a:ln/>
-        </p:spPr>
-        <p:txBody>
-          <a:bodyPr wrap="square" lIns="0" tIns="0" rIns="0" bIns="0" rtlCol="0" anchor="ctr"/>
-          <a:lstStyle/>
-          <a:p>
-            <a:pPr algn="l" indent="0" marL="0">
-              <a:buNone/>
-            </a:pPr>
-            <a:r>
-              <a:rPr lang="en-US" sz="1050" dirty="0">
-                <a:solidFill>
-                  <a:srgbClr val="1A2433"/>
-                </a:solidFill>
-                <a:latin typeface="Calibri" pitchFamily="34" charset="0"/>
-                <a:ea typeface="Calibri" pitchFamily="34" charset="-122"/>
-                <a:cs typeface="Calibri" pitchFamily="34" charset="-120"/>
-              </a:rPr>
-              <a:t>248</a:t>
-            </a:r>
-            <a:endParaRPr lang="en-US" sz="1050" dirty="0"/>
-          </a:p>
-        </p:txBody>
-      </p:sp>
-      <p:sp>
-        <p:nvSpPr>
-          <p:cNvPr id="92" name="Text 89"/>
-          <p:cNvSpPr/>
-          <p:nvPr/>
-        </p:nvSpPr>
-        <p:spPr>
-          <a:xfrm>
-            <a:off x="1371600" y="5093208"/>
-            <a:ext cx="1508760" cy="256032"/>
-          </a:xfrm>
-          <a:prstGeom prst="rect">
-            <a:avLst/>
-          </a:prstGeom>
-          <a:noFill/>
-          <a:ln/>
-        </p:spPr>
-        <p:txBody>
-          <a:bodyPr wrap="square" lIns="0" tIns="0" rIns="0" bIns="0" rtlCol="0" anchor="ctr"/>
-          <a:lstStyle/>
-          <a:p>
-            <a:pPr algn="l" indent="0" marL="0">
-              <a:buNone/>
-            </a:pPr>
-            <a:r>
-              <a:rPr lang="en-US" sz="1050" dirty="0">
-                <a:solidFill>
-                  <a:srgbClr val="1A2433"/>
-                </a:solidFill>
-                <a:latin typeface="Calibri" pitchFamily="34" charset="0"/>
-                <a:ea typeface="Calibri" pitchFamily="34" charset="-122"/>
-                <a:cs typeface="Calibri" pitchFamily="34" charset="-120"/>
-              </a:rPr>
-              <a:t>No Conformidad</a:t>
-            </a:r>
-            <a:endParaRPr lang="en-US" sz="1050" dirty="0"/>
-          </a:p>
-        </p:txBody>
-      </p:sp>
-      <p:sp>
-        <p:nvSpPr>
-          <p:cNvPr id="93" name="Text 90"/>
-          <p:cNvSpPr/>
-          <p:nvPr/>
-        </p:nvSpPr>
-        <p:spPr>
-          <a:xfrm>
-            <a:off x="2926080" y="5093208"/>
-            <a:ext cx="1463040" cy="256032"/>
-          </a:xfrm>
-          <a:prstGeom prst="rect">
-            <a:avLst/>
-          </a:prstGeom>
-          <a:noFill/>
-          <a:ln/>
-        </p:spPr>
-        <p:txBody>
-          <a:bodyPr wrap="square" lIns="0" tIns="0" rIns="0" bIns="0" rtlCol="0" anchor="ctr"/>
-          <a:lstStyle/>
-          <a:p>
-            <a:pPr algn="l" indent="0" marL="0">
-              <a:buNone/>
-            </a:pPr>
-            <a:r>
-              <a:rPr lang="en-US" sz="1050" b="1" dirty="0">
-                <a:solidFill>
-                  <a:srgbClr val="C87A32"/>
-                </a:solidFill>
-                <a:latin typeface="Calibri" pitchFamily="34" charset="0"/>
-                <a:ea typeface="Calibri" pitchFamily="34" charset="-122"/>
-                <a:cs typeface="Calibri" pitchFamily="34" charset="-120"/>
-              </a:rPr>
-              <a:t>Externa · Cliente</a:t>
-            </a:r>
-            <a:endParaRPr lang="en-US" sz="1050" dirty="0"/>
-          </a:p>
-        </p:txBody>
-      </p:sp>
-      <p:sp>
-        <p:nvSpPr>
-          <p:cNvPr id="94" name="Text 91"/>
-          <p:cNvSpPr/>
-          <p:nvPr/>
-        </p:nvSpPr>
-        <p:spPr>
-          <a:xfrm>
-            <a:off x="4434840" y="5093208"/>
-            <a:ext cx="1280160" cy="256032"/>
-          </a:xfrm>
-          <a:prstGeom prst="rect">
-            <a:avLst/>
-          </a:prstGeom>
-          <a:noFill/>
-          <a:ln/>
-        </p:spPr>
-        <p:txBody>
-          <a:bodyPr wrap="square" lIns="0" tIns="0" rIns="0" bIns="0" rtlCol="0" anchor="ctr"/>
-          <a:lstStyle/>
-          <a:p>
-            <a:pPr algn="l" indent="0" marL="0">
-              <a:buNone/>
-            </a:pPr>
-            <a:r>
-              <a:rPr lang="en-US" sz="1050" dirty="0">
-                <a:solidFill>
-                  <a:srgbClr val="1A2433"/>
-                </a:solidFill>
-                <a:latin typeface="Calibri" pitchFamily="34" charset="0"/>
-                <a:ea typeface="Calibri" pitchFamily="34" charset="-122"/>
-                <a:cs typeface="Calibri" pitchFamily="34" charset="-120"/>
-              </a:rPr>
-              <a:t>PIPING</a:t>
-            </a:r>
-            <a:endParaRPr lang="en-US" sz="1050" dirty="0"/>
-          </a:p>
-        </p:txBody>
-      </p:sp>
-      <p:sp>
-        <p:nvSpPr>
-          <p:cNvPr id="95" name="Text 92"/>
-          <p:cNvSpPr/>
-          <p:nvPr/>
-        </p:nvSpPr>
-        <p:spPr>
-          <a:xfrm>
-            <a:off x="5760720" y="5093208"/>
-            <a:ext cx="1508760" cy="256032"/>
-          </a:xfrm>
-          <a:prstGeom prst="rect">
-            <a:avLst/>
-          </a:prstGeom>
-          <a:noFill/>
-          <a:ln/>
-        </p:spPr>
-        <p:txBody>
-          <a:bodyPr wrap="square" lIns="0" tIns="0" rIns="0" bIns="0" rtlCol="0" anchor="ctr"/>
-          <a:lstStyle/>
-          <a:p>
-            <a:pPr algn="l" indent="0" marL="0">
-              <a:buNone/>
-            </a:pPr>
-            <a:r>
-              <a:rPr lang="en-US" sz="1050" dirty="0">
-                <a:solidFill>
-                  <a:srgbClr val="1A2433"/>
-                </a:solidFill>
-                <a:latin typeface="Calibri" pitchFamily="34" charset="0"/>
-                <a:ea typeface="Calibri" pitchFamily="34" charset="-122"/>
-                <a:cs typeface="Calibri" pitchFamily="34" charset="-120"/>
-              </a:rPr>
-              <a:t>Oscar Nahuel P.</a:t>
-            </a:r>
-            <a:endParaRPr lang="en-US" sz="1050" dirty="0"/>
-          </a:p>
-        </p:txBody>
-      </p:sp>
-      <p:sp>
-        <p:nvSpPr>
-          <p:cNvPr id="96" name="Text 93"/>
-          <p:cNvSpPr/>
-          <p:nvPr/>
-        </p:nvSpPr>
-        <p:spPr>
-          <a:xfrm>
-            <a:off x="7315200" y="5093208"/>
-            <a:ext cx="1325880" cy="256032"/>
-          </a:xfrm>
-          <a:prstGeom prst="rect">
-            <a:avLst/>
-          </a:prstGeom>
-          <a:noFill/>
-          <a:ln/>
-        </p:spPr>
-        <p:txBody>
-          <a:bodyPr wrap="square" lIns="0" tIns="0" rIns="0" bIns="0" rtlCol="0" anchor="ctr"/>
-          <a:lstStyle/>
-          <a:p>
-            <a:pPr algn="l" indent="0" marL="0">
-              <a:buNone/>
-            </a:pPr>
-            <a:r>
-              <a:rPr lang="en-US" sz="1050" dirty="0">
-                <a:solidFill>
-                  <a:srgbClr val="1A2433"/>
-                </a:solidFill>
-                <a:latin typeface="Calibri" pitchFamily="34" charset="0"/>
-                <a:ea typeface="Calibri" pitchFamily="34" charset="-122"/>
-                <a:cs typeface="Calibri" pitchFamily="34" charset="-120"/>
-              </a:rPr>
-              <a:t>Iniciado</a:t>
-            </a:r>
-            <a:endParaRPr lang="en-US" sz="1050" dirty="0"/>
-          </a:p>
-        </p:txBody>
-      </p:sp>
-      <p:sp>
-        <p:nvSpPr>
-          <p:cNvPr id="97" name="Text 94"/>
-          <p:cNvSpPr/>
-          <p:nvPr/>
-        </p:nvSpPr>
-        <p:spPr>
-          <a:xfrm>
-            <a:off x="8686800" y="5093208"/>
-            <a:ext cx="640080" cy="256032"/>
-          </a:xfrm>
-          <a:prstGeom prst="rect">
-            <a:avLst/>
-          </a:prstGeom>
-          <a:noFill/>
-          <a:ln/>
-        </p:spPr>
-        <p:txBody>
-          <a:bodyPr wrap="square" lIns="0" tIns="0" rIns="0" bIns="0" rtlCol="0" anchor="ctr"/>
-          <a:lstStyle/>
-          <a:p>
-            <a:pPr algn="r" indent="0" marL="0">
-              <a:buNone/>
-            </a:pPr>
-            <a:r>
-              <a:rPr lang="en-US" sz="1050" dirty="0">
-                <a:solidFill>
-                  <a:srgbClr val="1A2433"/>
-                </a:solidFill>
-                <a:latin typeface="Calibri" pitchFamily="34" charset="0"/>
-                <a:ea typeface="Calibri" pitchFamily="34" charset="-122"/>
-                <a:cs typeface="Calibri" pitchFamily="34" charset="-120"/>
-              </a:rPr>
-              <a:t>5</a:t>
-            </a:r>
-            <a:endParaRPr lang="en-US" sz="1050" dirty="0"/>
-          </a:p>
-        </p:txBody>
-      </p:sp>
-      <p:sp>
-        <p:nvSpPr>
-          <p:cNvPr id="98" name="Text 95"/>
-          <p:cNvSpPr/>
-          <p:nvPr/>
-        </p:nvSpPr>
-        <p:spPr>
-          <a:xfrm>
-            <a:off x="9464040" y="5093208"/>
-            <a:ext cx="2286000" cy="256032"/>
-          </a:xfrm>
-          <a:prstGeom prst="rect">
-            <a:avLst/>
-          </a:prstGeom>
-          <a:noFill/>
-          <a:ln/>
-        </p:spPr>
-        <p:txBody>
-          <a:bodyPr wrap="square" lIns="0" tIns="0" rIns="0" bIns="0" rtlCol="0" anchor="ctr"/>
-          <a:lstStyle/>
-          <a:p>
-            <a:pPr algn="l" indent="0" marL="0">
-              <a:buNone/>
-            </a:pPr>
-            <a:r>
-              <a:rPr lang="en-US" sz="1000" dirty="0">
-                <a:solidFill>
-                  <a:srgbClr val="1A2433"/>
-                </a:solidFill>
-                <a:latin typeface="Calibri" pitchFamily="34" charset="0"/>
-                <a:ea typeface="Calibri" pitchFamily="34" charset="-122"/>
-                <a:cs typeface="Calibri" pitchFamily="34" charset="-120"/>
-              </a:rPr>
-              <a:t>Línea TAG N° 3716D-RW-24-H1-0425-N …</a:t>
-            </a:r>
-            <a:endParaRPr lang="en-US" sz="1000" dirty="0"/>
-          </a:p>
-        </p:txBody>
-      </p:sp>
-      <p:sp>
-        <p:nvSpPr>
-          <p:cNvPr id="99" name="Shape 96"/>
-          <p:cNvSpPr/>
-          <p:nvPr/>
-        </p:nvSpPr>
-        <p:spPr>
-          <a:xfrm>
-            <a:off x="502920" y="5385816"/>
-            <a:ext cx="11247120" cy="0"/>
-          </a:xfrm>
-          <a:prstGeom prst="line">
-            <a:avLst/>
-          </a:prstGeom>
-          <a:noFill/>
-          <a:ln w="9525">
-            <a:solidFill>
-              <a:srgbClr val="D9DFE6"/>
-            </a:solidFill>
-            <a:prstDash val="solid"/>
-          </a:ln>
-        </p:spPr>
-      </p:sp>
-      <p:sp>
-        <p:nvSpPr>
-          <p:cNvPr id="100" name="Shape 97"/>
+          <p:cNvPr id="72" name="Shape 69"/>
           <p:cNvSpPr/>
           <p:nvPr/>
         </p:nvSpPr>
@@ -14982,7 +13885,7 @@
       </p:sp>
       <p:sp>
         <p:nvSpPr>
-          <p:cNvPr id="101" name="Text 98"/>
+          <p:cNvPr id="73" name="Text 70"/>
           <p:cNvSpPr/>
           <p:nvPr/>
         </p:nvSpPr>
@@ -15013,7 +13916,7 @@
                 <a:ea typeface="Calibri" pitchFamily="34" charset="-122"/>
                 <a:cs typeface="Calibri" pitchFamily="34" charset="-120"/>
               </a:rPr>
-              <a:t>SEMANA 17-08-2026 — 23-08-2026</a:t>
+              <a:t>SEMANA 24-08-2026 — 30-08-2026</a:t>
             </a:r>
             <a:endParaRPr lang="en-US" sz="1000" dirty="0"/>
           </a:p>
@@ -15021,7 +13924,7 @@
       </p:sp>
       <p:sp>
         <p:nvSpPr>
-          <p:cNvPr id="102" name="Text 99"/>
+          <p:cNvPr id="74" name="Text 71"/>
           <p:cNvSpPr/>
           <p:nvPr/>
         </p:nvSpPr>
@@ -15052,7 +13955,7 @@
                 <a:ea typeface="Calibri" pitchFamily="34" charset="-122"/>
                 <a:cs typeface="Calibri" pitchFamily="34" charset="-120"/>
               </a:rPr>
-              <a:t>3 hallazgos nuevos · 0 internas · 3 del cliente · OO.CC 2 · PIPING 1 · 2 siguen abiertos</a:t>
+              <a:t>1 hallazgo nuevo · 0 internas · 1 del cliente · OO.CC 1 · 1 sigue abierto</a:t>
             </a:r>
             <a:endParaRPr lang="en-US" sz="1150" dirty="0"/>
           </a:p>
@@ -15060,7 +13963,7 @@
       </p:sp>
       <p:sp>
         <p:nvSpPr>
-          <p:cNvPr id="103" name="Text 100"/>
+          <p:cNvPr id="75" name="Text 72"/>
           <p:cNvSpPr/>
           <p:nvPr/>
         </p:nvSpPr>
@@ -15091,7 +13994,7 @@
                 <a:ea typeface="Calibri" pitchFamily="34" charset="-122"/>
                 <a:cs typeface="Calibri" pitchFamily="34" charset="-120"/>
               </a:rPr>
-              <a:t>Fuente: Data_NCR24082026.xlsx — hoja «Observaciones» · Corte 24-08-2026 · 501 registros desde 10-02-2023</a:t>
+              <a:t>Fuente: Data_NCR31082026.xlsx — hoja «Observaciones» · Corte 31-08-2026 · 502 registros desde 10-02-2023</a:t>
             </a:r>
             <a:endParaRPr lang="en-US" sz="850" dirty="0"/>
           </a:p>
@@ -15099,7 +14002,7 @@
       </p:sp>
       <p:sp>
         <p:nvSpPr>
-          <p:cNvPr id="104" name="Text 101"/>
+          <p:cNvPr id="76" name="Text 73"/>
           <p:cNvSpPr/>
           <p:nvPr/>
         </p:nvSpPr>
@@ -15138,7 +14041,7 @@
       </p:sp>
       <p:sp>
         <p:nvSpPr>
-          <p:cNvPr id="105" name="Text 102"/>
+          <p:cNvPr id="77" name="Text 74"/>
           <p:cNvSpPr/>
           <p:nvPr/>
         </p:nvSpPr>
@@ -15503,7 +14406,7 @@
                 <a:ea typeface="Cambria" pitchFamily="34" charset="-122"/>
                 <a:cs typeface="Cambria" pitchFamily="34" charset="-120"/>
               </a:rPr>
-              <a:t>78%</a:t>
+              <a:t>80,5%</a:t>
             </a:r>
             <a:endParaRPr lang="en-US" sz="3400" dirty="0"/>
           </a:p>
@@ -15581,7 +14484,7 @@
                 <a:ea typeface="Cambria" pitchFamily="34" charset="-122"/>
                 <a:cs typeface="Cambria" pitchFamily="34" charset="-120"/>
               </a:rPr>
-              <a:t>36</a:t>
+              <a:t>32</a:t>
             </a:r>
             <a:endParaRPr lang="en-US" sz="3400" dirty="0"/>
           </a:p>
@@ -15659,7 +14562,7 @@
                 <a:ea typeface="Cambria" pitchFamily="34" charset="-122"/>
                 <a:cs typeface="Cambria" pitchFamily="34" charset="-120"/>
               </a:rPr>
-              <a:t>131 d</a:t>
+              <a:t>139 d</a:t>
             </a:r>
             <a:endParaRPr lang="en-US" sz="3400" dirty="0"/>
           </a:p>
@@ -15815,7 +14718,7 @@
                 <a:ea typeface="Calibri" pitchFamily="34" charset="-122"/>
                 <a:cs typeface="Calibri" pitchFamily="34" charset="-120"/>
               </a:rPr>
-              <a:t>Corte: 24-08-2026</a:t>
+              <a:t>Corte: 31-08-2026</a:t>
             </a:r>
             <a:endParaRPr lang="en-US" sz="1100" dirty="0"/>
           </a:p>
@@ -15854,7 +14757,7 @@
                 <a:ea typeface="Calibri" pitchFamily="34" charset="-122"/>
                 <a:cs typeface="Calibri" pitchFamily="34" charset="-120"/>
               </a:rPr>
-              <a:t>Fuente: Data_NCR24082026.xlsx — hoja «Observaciones» · Corte 24-08-2026 · 501 registros desde 10-02-2023</a:t>
+              <a:t>Fuente: Data_NCR31082026.xlsx — hoja «Observaciones» · Corte 31-08-2026 · 502 registros desde 10-02-2023</a:t>
             </a:r>
             <a:endParaRPr lang="en-US" sz="850" dirty="0"/>
           </a:p>
@@ -16159,7 +15062,7 @@
                 <a:ea typeface="Calibri" pitchFamily="34" charset="-122"/>
                 <a:cs typeface="Calibri" pitchFamily="34" charset="-120"/>
               </a:rPr>
-              <a:t>128 cerrados</a:t>
+              <a:t>132 cerrados</a:t>
             </a:r>
             <a:endParaRPr lang="en-US" sz="1400" dirty="0"/>
           </a:p>
@@ -16330,7 +15233,7 @@
                 <a:ea typeface="Cambria" pitchFamily="34" charset="-122"/>
                 <a:cs typeface="Cambria" pitchFamily="34" charset="-120"/>
               </a:rPr>
-              <a:t>78%</a:t>
+              <a:t>80,5%</a:t>
             </a:r>
             <a:endParaRPr lang="en-US" sz="4000" dirty="0"/>
           </a:p>
@@ -16369,7 +15272,7 @@
                 <a:ea typeface="Calibri" pitchFamily="34" charset="-122"/>
                 <a:cs typeface="Calibri" pitchFamily="34" charset="-120"/>
               </a:rPr>
-              <a:t>128/164</a:t>
+              <a:t>132/164</a:t>
             </a:r>
             <a:endParaRPr lang="en-US" sz="1400" dirty="0"/>
           </a:p>
@@ -16447,7 +15350,7 @@
                 <a:ea typeface="Calibri" pitchFamily="34" charset="-122"/>
                 <a:cs typeface="Calibri" pitchFamily="34" charset="-120"/>
               </a:rPr>
-              <a:t>Global del módulo: 90,8%</a:t>
+              <a:t>Global del módulo: 92,2%</a:t>
             </a:r>
             <a:endParaRPr lang="en-US" sz="950" dirty="0"/>
           </a:p>
@@ -16540,7 +15443,7 @@
                 <a:ea typeface="Cambria" pitchFamily="34" charset="-122"/>
                 <a:cs typeface="Cambria" pitchFamily="34" charset="-120"/>
               </a:rPr>
-              <a:t>36</a:t>
+              <a:t>32</a:t>
             </a:r>
             <a:endParaRPr lang="en-US" sz="4000" dirty="0"/>
           </a:p>
@@ -16657,7 +15560,7 @@
                 <a:ea typeface="Calibri" pitchFamily="34" charset="-122"/>
                 <a:cs typeface="Calibri" pitchFamily="34" charset="-120"/>
               </a:rPr>
-              <a:t>1 iniciado · 25 listo para revisión · 10 stand by</a:t>
+              <a:t>1 iniciado · 21 listo para revisión · 9 stand by · 1 observada</a:t>
             </a:r>
             <a:endParaRPr lang="en-US" sz="950" dirty="0"/>
           </a:p>
@@ -16750,7 +15653,7 @@
                 <a:ea typeface="Cambria" pitchFamily="34" charset="-122"/>
                 <a:cs typeface="Cambria" pitchFamily="34" charset="-120"/>
               </a:rPr>
-              <a:t>131</a:t>
+              <a:t>139</a:t>
             </a:r>
             <a:endParaRPr lang="en-US" sz="4000" dirty="0"/>
           </a:p>
@@ -16867,7 +15770,7 @@
                 <a:ea typeface="Calibri" pitchFamily="34" charset="-122"/>
                 <a:cs typeface="Calibri" pitchFamily="34" charset="-120"/>
               </a:rPr>
-              <a:t>el más lento tomó 409 días</a:t>
+              <a:t>el más lento tomó 419 días</a:t>
             </a:r>
             <a:endParaRPr lang="en-US" sz="950" dirty="0"/>
           </a:p>
@@ -17303,7 +16206,7 @@
                 <a:ea typeface="Calibri" pitchFamily="34" charset="-122"/>
                 <a:cs typeface="Calibri" pitchFamily="34" charset="-120"/>
               </a:rPr>
-              <a:t>35 ab.</a:t>
+              <a:t>31 ab.</a:t>
             </a:r>
             <a:endParaRPr lang="en-US" sz="950" dirty="0"/>
           </a:p>
@@ -17518,7 +16421,7 @@
                 <a:ea typeface="Calibri" pitchFamily="34" charset="-122"/>
                 <a:cs typeface="Calibri" pitchFamily="34" charset="-120"/>
               </a:rPr>
-              <a:t>Fuente: Data_NCR24082026.xlsx — hoja «Observaciones» · Corte 24-08-2026 · 501 registros desde 10-02-2023</a:t>
+              <a:t>Fuente: Data_NCR31082026.xlsx — hoja «Observaciones» · Corte 31-08-2026 · 502 registros desde 10-02-2023</a:t>
             </a:r>
             <a:endParaRPr lang="en-US" sz="850" dirty="0"/>
           </a:p>
@@ -17769,7 +16672,7 @@
                 <a:ea typeface="Calibri" pitchFamily="34" charset="-122"/>
                 <a:cs typeface="Calibri" pitchFamily="34" charset="-120"/>
               </a:rPr>
-              <a:t>36 hallazgos siguen abiertos; 17 con más de 180 días. Se listan del más antiguo al más reciente.</a:t>
+              <a:t>32 hallazgos siguen abiertos; 13 con más de 180 días. Se listan del más antiguo al más reciente.</a:t>
             </a:r>
             <a:endParaRPr lang="en-US" sz="1350" dirty="0"/>
           </a:p>
@@ -18143,7 +17046,7 @@
                 <a:ea typeface="Calibri" pitchFamily="34" charset="-122"/>
                 <a:cs typeface="Calibri" pitchFamily="34" charset="-120"/>
               </a:rPr>
-              <a:t>MASA-4</a:t>
+              <a:t>MASA-21</a:t>
             </a:r>
             <a:endParaRPr lang="en-US" sz="1050" dirty="0"/>
           </a:p>
@@ -18182,7 +17085,7 @@
                 <a:ea typeface="Calibri" pitchFamily="34" charset="-122"/>
                 <a:cs typeface="Calibri" pitchFamily="34" charset="-120"/>
               </a:rPr>
-              <a:t>Observación</a:t>
+              <a:t>No Conformidad</a:t>
             </a:r>
             <a:endParaRPr lang="en-US" sz="1050" dirty="0"/>
           </a:p>
@@ -18377,7 +17280,7 @@
                 <a:ea typeface="Calibri" pitchFamily="34" charset="-122"/>
                 <a:cs typeface="Calibri" pitchFamily="34" charset="-120"/>
               </a:rPr>
-              <a:t>416</a:t>
+              <a:t>319</a:t>
             </a:r>
             <a:endParaRPr lang="en-US" sz="1050" dirty="0"/>
           </a:p>
@@ -18416,7 +17319,7 @@
                 <a:ea typeface="Calibri" pitchFamily="34" charset="-122"/>
                 <a:cs typeface="Calibri" pitchFamily="34" charset="-120"/>
               </a:rPr>
-              <a:t>Sistema de conexión desde chute 220…</a:t>
+              <a:t>Informe Técnico de Inspección – Fis…</a:t>
             </a:r>
             <a:endParaRPr lang="en-US" sz="1000" dirty="0"/>
           </a:p>
@@ -18498,7 +17401,7 @@
                 <a:ea typeface="Calibri" pitchFamily="34" charset="-122"/>
                 <a:cs typeface="Calibri" pitchFamily="34" charset="-120"/>
               </a:rPr>
-              <a:t>MASA-6</a:t>
+              <a:t>MASA-24</a:t>
             </a:r>
             <a:endParaRPr lang="en-US" sz="1050" dirty="0"/>
           </a:p>
@@ -18537,7 +17440,7 @@
                 <a:ea typeface="Calibri" pitchFamily="34" charset="-122"/>
                 <a:cs typeface="Calibri" pitchFamily="34" charset="-120"/>
               </a:rPr>
-              <a:t>Observación</a:t>
+              <a:t>No Conformidad</a:t>
             </a:r>
             <a:endParaRPr lang="en-US" sz="1050" dirty="0"/>
           </a:p>
@@ -18693,7 +17596,7 @@
                 <a:ea typeface="Calibri" pitchFamily="34" charset="-122"/>
                 <a:cs typeface="Calibri" pitchFamily="34" charset="-120"/>
               </a:rPr>
-              <a:t>Listo para revisi…</a:t>
+              <a:t>Stand By</a:t>
             </a:r>
             <a:endParaRPr lang="en-US" sz="1050" dirty="0"/>
           </a:p>
@@ -18732,7 +17635,7 @@
                 <a:ea typeface="Calibri" pitchFamily="34" charset="-122"/>
                 <a:cs typeface="Calibri" pitchFamily="34" charset="-120"/>
               </a:rPr>
-              <a:t>382</a:t>
+              <a:t>319</a:t>
             </a:r>
             <a:endParaRPr lang="en-US" sz="1050" dirty="0"/>
           </a:p>
@@ -18771,7 +17674,7 @@
                 <a:ea typeface="Calibri" pitchFamily="34" charset="-122"/>
                 <a:cs typeface="Calibri" pitchFamily="34" charset="-120"/>
               </a:rPr>
-              <a:t>Condición del grout de nivelación e…</a:t>
+              <a:t>Inspección grout de los recesos de …</a:t>
             </a:r>
             <a:endParaRPr lang="en-US" sz="1000" dirty="0"/>
           </a:p>
@@ -18833,7 +17736,7 @@
                 <a:ea typeface="Calibri" pitchFamily="34" charset="-122"/>
                 <a:cs typeface="Calibri" pitchFamily="34" charset="-120"/>
               </a:rPr>
-              <a:t>MASA-8</a:t>
+              <a:t>MASA-28</a:t>
             </a:r>
             <a:endParaRPr lang="en-US" sz="1050" dirty="0"/>
           </a:p>
@@ -19067,7 +17970,7 @@
                 <a:ea typeface="Calibri" pitchFamily="34" charset="-122"/>
                 <a:cs typeface="Calibri" pitchFamily="34" charset="-120"/>
               </a:rPr>
-              <a:t>370</a:t>
+              <a:t>298</a:t>
             </a:r>
             <a:endParaRPr lang="en-US" sz="1050" dirty="0"/>
           </a:p>
@@ -19106,7 +18009,7 @@
                 <a:ea typeface="Calibri" pitchFamily="34" charset="-122"/>
                 <a:cs typeface="Calibri" pitchFamily="34" charset="-120"/>
               </a:rPr>
-              <a:t>Montaje de estructura metálica sin …</a:t>
+              <a:t>Cámara 3700-MH-002, salida sala elé…</a:t>
             </a:r>
             <a:endParaRPr lang="en-US" sz="1000" dirty="0"/>
           </a:p>
@@ -19188,7 +18091,7 @@
                 <a:ea typeface="Calibri" pitchFamily="34" charset="-122"/>
                 <a:cs typeface="Calibri" pitchFamily="34" charset="-120"/>
               </a:rPr>
-              <a:t>MASA-10</a:t>
+              <a:t>MASA-30</a:t>
             </a:r>
             <a:endParaRPr lang="en-US" sz="1050" dirty="0"/>
           </a:p>
@@ -19422,7 +18325,7 @@
                 <a:ea typeface="Calibri" pitchFamily="34" charset="-122"/>
                 <a:cs typeface="Calibri" pitchFamily="34" charset="-120"/>
               </a:rPr>
-              <a:t>342</a:t>
+              <a:t>294</a:t>
             </a:r>
             <a:endParaRPr lang="en-US" sz="1050" dirty="0"/>
           </a:p>
@@ -19461,7 +18364,7 @@
                 <a:ea typeface="Calibri" pitchFamily="34" charset="-122"/>
                 <a:cs typeface="Calibri" pitchFamily="34" charset="-120"/>
               </a:rPr>
-              <a:t>Vigas (puntales) Montadas Fuera de …</a:t>
+              <a:t>Fundaciones faltantes para apoyo de…</a:t>
             </a:r>
             <a:endParaRPr lang="en-US" sz="1000" dirty="0"/>
           </a:p>
@@ -19523,7 +18426,7 @@
                 <a:ea typeface="Calibri" pitchFamily="34" charset="-122"/>
                 <a:cs typeface="Calibri" pitchFamily="34" charset="-120"/>
               </a:rPr>
-              <a:t>MASA-21</a:t>
+              <a:t>MASA-37</a:t>
             </a:r>
             <a:endParaRPr lang="en-US" sz="1050" dirty="0"/>
           </a:p>
@@ -19718,7 +18621,7 @@
                 <a:ea typeface="Calibri" pitchFamily="34" charset="-122"/>
                 <a:cs typeface="Calibri" pitchFamily="34" charset="-120"/>
               </a:rPr>
-              <a:t>Listo para revisi…</a:t>
+              <a:t>Observada</a:t>
             </a:r>
             <a:endParaRPr lang="en-US" sz="1050" dirty="0"/>
           </a:p>
@@ -19757,7 +18660,7 @@
                 <a:ea typeface="Calibri" pitchFamily="34" charset="-122"/>
                 <a:cs typeface="Calibri" pitchFamily="34" charset="-120"/>
               </a:rPr>
-              <a:t>312</a:t>
+              <a:t>257</a:t>
             </a:r>
             <a:endParaRPr lang="en-US" sz="1050" dirty="0"/>
           </a:p>
@@ -19796,7 +18699,7 @@
                 <a:ea typeface="Calibri" pitchFamily="34" charset="-122"/>
                 <a:cs typeface="Calibri" pitchFamily="34" charset="-120"/>
               </a:rPr>
-              <a:t>Informe Técnico de Inspección – Fis…</a:t>
+              <a:t>Tolerancia transversal en chutes de…</a:t>
             </a:r>
             <a:endParaRPr lang="en-US" sz="1000" dirty="0"/>
           </a:p>
@@ -19878,7 +18781,7 @@
                 <a:ea typeface="Calibri" pitchFamily="34" charset="-122"/>
                 <a:cs typeface="Calibri" pitchFamily="34" charset="-120"/>
               </a:rPr>
-              <a:t>MASA-24</a:t>
+              <a:t>MASA-42</a:t>
             </a:r>
             <a:endParaRPr lang="en-US" sz="1050" dirty="0"/>
           </a:p>
@@ -19917,7 +18820,7 @@
                 <a:ea typeface="Calibri" pitchFamily="34" charset="-122"/>
                 <a:cs typeface="Calibri" pitchFamily="34" charset="-120"/>
               </a:rPr>
-              <a:t>No Conformidad</a:t>
+              <a:t>Observación</a:t>
             </a:r>
             <a:endParaRPr lang="en-US" sz="1050" dirty="0"/>
           </a:p>
@@ -20112,7 +19015,7 @@
                 <a:ea typeface="Calibri" pitchFamily="34" charset="-122"/>
                 <a:cs typeface="Calibri" pitchFamily="34" charset="-120"/>
               </a:rPr>
-              <a:t>312</a:t>
+              <a:t>228</a:t>
             </a:r>
             <a:endParaRPr lang="en-US" sz="1050" dirty="0"/>
           </a:p>
@@ -20151,7 +19054,7 @@
                 <a:ea typeface="Calibri" pitchFamily="34" charset="-122"/>
                 <a:cs typeface="Calibri" pitchFamily="34" charset="-120"/>
               </a:rPr>
-              <a:t>Inspección grout de los recesos de …</a:t>
+              <a:t>Estructura de correa 2100-CV-001 mo…</a:t>
             </a:r>
             <a:endParaRPr lang="en-US" sz="1000" dirty="0"/>
           </a:p>
@@ -20213,7 +19116,7 @@
                 <a:ea typeface="Calibri" pitchFamily="34" charset="-122"/>
                 <a:cs typeface="Calibri" pitchFamily="34" charset="-120"/>
               </a:rPr>
-              <a:t>MASA-28</a:t>
+              <a:t>MASA-43</a:t>
             </a:r>
             <a:endParaRPr lang="en-US" sz="1050" dirty="0"/>
           </a:p>
@@ -20252,7 +19155,7 @@
                 <a:ea typeface="Calibri" pitchFamily="34" charset="-122"/>
                 <a:cs typeface="Calibri" pitchFamily="34" charset="-120"/>
               </a:rPr>
-              <a:t>Observación</a:t>
+              <a:t>No Conformidad</a:t>
             </a:r>
             <a:endParaRPr lang="en-US" sz="1050" dirty="0"/>
           </a:p>
@@ -20447,7 +19350,7 @@
                 <a:ea typeface="Calibri" pitchFamily="34" charset="-122"/>
                 <a:cs typeface="Calibri" pitchFamily="34" charset="-120"/>
               </a:rPr>
-              <a:t>291</a:t>
+              <a:t>228</a:t>
             </a:r>
             <a:endParaRPr lang="en-US" sz="1050" dirty="0"/>
           </a:p>
@@ -20486,7 +19389,7 @@
                 <a:ea typeface="Calibri" pitchFamily="34" charset="-122"/>
                 <a:cs typeface="Calibri" pitchFamily="34" charset="-120"/>
               </a:rPr>
-              <a:t>Cámara 3700-MH-002, salida sala elé…</a:t>
+              <a:t>Perforaciones faltantes en estructu…</a:t>
             </a:r>
             <a:endParaRPr lang="en-US" sz="1000" dirty="0"/>
           </a:p>
@@ -20568,7 +19471,7 @@
                 <a:ea typeface="Calibri" pitchFamily="34" charset="-122"/>
                 <a:cs typeface="Calibri" pitchFamily="34" charset="-120"/>
               </a:rPr>
-              <a:t>MASA-30</a:t>
+              <a:t>MASA-45</a:t>
             </a:r>
             <a:endParaRPr lang="en-US" sz="1050" dirty="0"/>
           </a:p>
@@ -20802,7 +19705,7 @@
                 <a:ea typeface="Calibri" pitchFamily="34" charset="-122"/>
                 <a:cs typeface="Calibri" pitchFamily="34" charset="-120"/>
               </a:rPr>
-              <a:t>287</a:t>
+              <a:t>228</a:t>
             </a:r>
             <a:endParaRPr lang="en-US" sz="1050" dirty="0"/>
           </a:p>
@@ -20841,7 +19744,7 @@
                 <a:ea typeface="Calibri" pitchFamily="34" charset="-122"/>
                 <a:cs typeface="Calibri" pitchFamily="34" charset="-120"/>
               </a:rPr>
-              <a:t>Fundaciones faltantes para apoyo de…</a:t>
+              <a:t>(i) Cable de comunicación dañado - …</a:t>
             </a:r>
             <a:endParaRPr lang="en-US" sz="1000" dirty="0"/>
           </a:p>
@@ -20903,7 +19806,7 @@
                 <a:ea typeface="Calibri" pitchFamily="34" charset="-122"/>
                 <a:cs typeface="Calibri" pitchFamily="34" charset="-120"/>
               </a:rPr>
-              <a:t>MASA-37</a:t>
+              <a:t>MASA-48</a:t>
             </a:r>
             <a:endParaRPr lang="en-US" sz="1050" dirty="0"/>
           </a:p>
@@ -21098,7 +20001,7 @@
                 <a:ea typeface="Calibri" pitchFamily="34" charset="-122"/>
                 <a:cs typeface="Calibri" pitchFamily="34" charset="-120"/>
               </a:rPr>
-              <a:t>Listo para revisi…</a:t>
+              <a:t>Stand By</a:t>
             </a:r>
             <a:endParaRPr lang="en-US" sz="1050" dirty="0"/>
           </a:p>
@@ -21137,7 +20040,7 @@
                 <a:ea typeface="Calibri" pitchFamily="34" charset="-122"/>
                 <a:cs typeface="Calibri" pitchFamily="34" charset="-120"/>
               </a:rPr>
-              <a:t>250</a:t>
+              <a:t>228</a:t>
             </a:r>
             <a:endParaRPr lang="en-US" sz="1050" dirty="0"/>
           </a:p>
@@ -21176,7 +20079,7 @@
                 <a:ea typeface="Calibri" pitchFamily="34" charset="-122"/>
                 <a:cs typeface="Calibri" pitchFamily="34" charset="-120"/>
               </a:rPr>
-              <a:t>Tolerancia transversal en chutes de…</a:t>
+              <a:t>FISURACIÓN DE RADIER CELDAS COLUMNA…</a:t>
             </a:r>
             <a:endParaRPr lang="en-US" sz="1000" dirty="0"/>
           </a:p>
@@ -21238,7 +20141,7 @@
                 <a:ea typeface="Calibri" pitchFamily="34" charset="-122"/>
                 <a:cs typeface="Calibri" pitchFamily="34" charset="-120"/>
               </a:rPr>
-              <a:t>Se listan los 9 más antiguos de 36 abiertos; el detalle completo está en el panel.</a:t>
+              <a:t>Se listan los 9 más antiguos de 32 abiertos; el detalle completo está en el panel.</a:t>
             </a:r>
             <a:endParaRPr lang="en-US" sz="950" dirty="0"/>
           </a:p>
@@ -21299,7 +20202,7 @@
                 <a:ea typeface="Calibri" pitchFamily="34" charset="-122"/>
                 <a:cs typeface="Calibri" pitchFamily="34" charset="-120"/>
               </a:rPr>
-              <a:t>SEMANA 17-08-2026 — 23-08-2026</a:t>
+              <a:t>SEMANA 24-08-2026 — 30-08-2026</a:t>
             </a:r>
             <a:endParaRPr lang="en-US" sz="1000" dirty="0"/>
           </a:p>
@@ -21377,7 +20280,7 @@
                 <a:ea typeface="Calibri" pitchFamily="34" charset="-122"/>
                 <a:cs typeface="Calibri" pitchFamily="34" charset="-120"/>
               </a:rPr>
-              <a:t>Fuente: Data_NCR24082026.xlsx — hoja «Observaciones» · Corte 24-08-2026 · 501 registros desde 10-02-2023</a:t>
+              <a:t>Fuente: Data_NCR31082026.xlsx — hoja «Observaciones» · Corte 31-08-2026 · 502 registros desde 10-02-2023</a:t>
             </a:r>
             <a:endParaRPr lang="en-US" sz="850" dirty="0"/>
           </a:p>
@@ -21682,7 +20585,7 @@
                 <a:ea typeface="Cambria" pitchFamily="34" charset="-122"/>
                 <a:cs typeface="Cambria" pitchFamily="34" charset="-120"/>
               </a:rPr>
-              <a:t>90,8%</a:t>
+              <a:t>92,2%</a:t>
             </a:r>
             <a:endParaRPr lang="en-US" sz="4000" dirty="0"/>
           </a:p>
@@ -21721,7 +20624,7 @@
                 <a:ea typeface="Calibri" pitchFamily="34" charset="-122"/>
                 <a:cs typeface="Calibri" pitchFamily="34" charset="-120"/>
               </a:rPr>
-              <a:t>455/501</a:t>
+              <a:t>463/502</a:t>
             </a:r>
             <a:endParaRPr lang="en-US" sz="1400" dirty="0"/>
           </a:p>
@@ -21799,7 +20702,7 @@
                 <a:ea typeface="Calibri" pitchFamily="34" charset="-122"/>
                 <a:cs typeface="Calibri" pitchFamily="34" charset="-120"/>
               </a:rPr>
-              <a:t>46 abiertos · 17 con más de 180 días</a:t>
+              <a:t>39 abiertos · 13 con más de 180 días</a:t>
             </a:r>
             <a:endParaRPr lang="en-US" sz="950" dirty="0"/>
           </a:p>
@@ -21892,7 +20795,7 @@
                 <a:ea typeface="Cambria" pitchFamily="34" charset="-122"/>
                 <a:cs typeface="Cambria" pitchFamily="34" charset="-120"/>
               </a:rPr>
-              <a:t>46</a:t>
+              <a:t>39</a:t>
             </a:r>
             <a:endParaRPr lang="en-US" sz="4000" dirty="0"/>
           </a:p>
@@ -21931,7 +20834,7 @@
                 <a:ea typeface="Calibri" pitchFamily="34" charset="-122"/>
                 <a:cs typeface="Calibri" pitchFamily="34" charset="-120"/>
               </a:rPr>
-              <a:t>de 501 levantados</a:t>
+              <a:t>de 502 levantados</a:t>
             </a:r>
             <a:endParaRPr lang="en-US" sz="1400" dirty="0"/>
           </a:p>
@@ -22009,7 +20912,7 @@
                 <a:ea typeface="Calibri" pitchFamily="34" charset="-122"/>
                 <a:cs typeface="Calibri" pitchFamily="34" charset="-120"/>
               </a:rPr>
-              <a:t>6 iniciado · 1 no aceptado · 29 listo para revisión · 10 stand by</a:t>
+              <a:t>6 iniciado · 23 listo para revisión · 9 stand by · 1 observada</a:t>
             </a:r>
             <a:endParaRPr lang="en-US" sz="950" dirty="0"/>
           </a:p>
@@ -22141,7 +21044,7 @@
                 <a:ea typeface="Calibri" pitchFamily="34" charset="-122"/>
                 <a:cs typeface="Calibri" pitchFamily="34" charset="-120"/>
               </a:rPr>
-              <a:t>159/492 clasificados</a:t>
+              <a:t>159/493 clasificados</a:t>
             </a:r>
             <a:endParaRPr lang="en-US" sz="1400" dirty="0"/>
           </a:p>
@@ -22351,7 +21254,7 @@
                 <a:ea typeface="Calibri" pitchFamily="34" charset="-122"/>
                 <a:cs typeface="Calibri" pitchFamily="34" charset="-120"/>
               </a:rPr>
-              <a:t>251 de 501 con costo</a:t>
+              <a:t>251 de 502 con costo</a:t>
             </a:r>
             <a:endParaRPr lang="en-US" sz="1400" dirty="0"/>
           </a:p>
@@ -22429,7 +21332,7 @@
                 <a:ea typeface="Calibri" pitchFamily="34" charset="-122"/>
                 <a:cs typeface="Calibri" pitchFamily="34" charset="-120"/>
               </a:rPr>
-              <a:t>250 hallazgos no declaran costo: la cifra es un piso</a:t>
+              <a:t>251 hallazgos no declaran costo: la cifra es un piso</a:t>
             </a:r>
             <a:endParaRPr lang="en-US" sz="950" dirty="0"/>
           </a:p>
@@ -22569,7 +21472,7 @@
                 <a:ea typeface="Calibri" pitchFamily="34" charset="-122"/>
                 <a:cs typeface="Calibri" pitchFamily="34" charset="-120"/>
               </a:rPr>
-              <a:t>36 de los 46 hallazgos abiertos (78,3%), y es uno de los frentes donde el cliente levanta más de lo que detecta Besalco (71 del cliente contra 53 internas).</a:t>
+              <a:t>32 de los 39 hallazgos abiertos (82,1%), y es uno de los frentes donde el cliente levanta más de lo que detecta Besalco (71 del cliente contra 53 internas).</a:t>
             </a:r>
             <a:endParaRPr lang="en-US" sz="1250" dirty="0"/>
           </a:p>
@@ -22631,7 +21534,7 @@
                 <a:ea typeface="Calibri" pitchFamily="34" charset="-122"/>
                 <a:cs typeface="Calibri" pitchFamily="34" charset="-120"/>
               </a:rPr>
-              <a:t>La semana trajo 3 hallazgos nuevos, ninguno de autodetección.  </a:t>
+              <a:t>La semana trajo 1 hallazgo nuevo, ninguno de autodetección.  </a:t>
             </a:r>
             <a:pPr indent="0" marL="0">
               <a:lnSpc>
@@ -22648,7 +21551,7 @@
                 <a:ea typeface="Calibri" pitchFamily="34" charset="-122"/>
                 <a:cs typeface="Calibri" pitchFamily="34" charset="-120"/>
               </a:rPr>
-              <a:t>17-08-2026 al 23-08-2026: 3 del cliente en OO.CC (2) y PIPING (1). 2 siguen abiertos; la semana anterior entraron 3.</a:t>
+              <a:t>24-08-2026 al 30-08-2026: 1 del cliente en OO.CC (1). Todos siguen abiertos; la semana anterior entraron 3.</a:t>
             </a:r>
             <a:endParaRPr lang="en-US" sz="1250" dirty="0"/>
           </a:p>
@@ -22710,7 +21613,7 @@
                 <a:ea typeface="Calibri" pitchFamily="34" charset="-122"/>
                 <a:cs typeface="Calibri" pitchFamily="34" charset="-120"/>
               </a:rPr>
-              <a:t>44 de los 46 abiertos están fuera del plazo de respuesta.  </a:t>
+              <a:t>38 de los 39 abiertos están fuera del plazo de respuesta.  </a:t>
             </a:r>
             <a:pPr indent="0" marL="0">
               <a:lnSpc>
@@ -22727,7 +21630,7 @@
                 <a:ea typeface="Calibri" pitchFamily="34" charset="-122"/>
                 <a:cs typeface="Calibri" pitchFamily="34" charset="-120"/>
               </a:rPr>
-              <a:t>El plazo es de 10 días desde que se emite la NC. De los atrasados, 17 llevan más de 180 días abiertos y 3 más de un año: no es atraso de días, es deuda vieja.</a:t>
+              <a:t>El plazo es de 10 días desde que se emite la NC. De los atrasados, 13 llevan más de 180 días abiertos y 0 más de un año: no es atraso de días, es deuda vieja.</a:t>
             </a:r>
             <a:endParaRPr lang="en-US" sz="1250" dirty="0"/>
           </a:p>
@@ -22766,7 +21669,7 @@
                 <a:ea typeface="Calibri" pitchFamily="34" charset="-122"/>
                 <a:cs typeface="Calibri" pitchFamily="34" charset="-120"/>
               </a:rPr>
-              <a:t>Fuente: Data_NCR24082026.xlsx — hoja «Observaciones» · Corte 24-08-2026 · 501 registros desde 10-02-2023</a:t>
+              <a:t>Fuente: Data_NCR31082026.xlsx — hoja «Observaciones» · Corte 31-08-2026 · 502 registros desde 10-02-2023</a:t>
             </a:r>
             <a:endParaRPr lang="en-US" sz="850" dirty="0"/>
           </a:p>
@@ -24041,7 +22944,7 @@
                 <a:ea typeface="Calibri" pitchFamily="34" charset="-122"/>
                 <a:cs typeface="Calibri" pitchFamily="34" charset="-120"/>
               </a:rPr>
-              <a:t>247</a:t>
+              <a:t>248</a:t>
             </a:r>
             <a:endParaRPr lang="en-US" sz="1300" dirty="0"/>
           </a:p>
@@ -24080,7 +22983,7 @@
                 <a:ea typeface="Calibri" pitchFamily="34" charset="-122"/>
                 <a:cs typeface="Calibri" pitchFamily="34" charset="-120"/>
               </a:rPr>
-              <a:t>238</a:t>
+              <a:t>242</a:t>
             </a:r>
             <a:endParaRPr lang="en-US" sz="1300" dirty="0"/>
           </a:p>
@@ -24119,7 +23022,7 @@
                 <a:ea typeface="Calibri" pitchFamily="34" charset="-122"/>
                 <a:cs typeface="Calibri" pitchFamily="34" charset="-120"/>
               </a:rPr>
-              <a:t>9</a:t>
+              <a:t>6</a:t>
             </a:r>
             <a:endParaRPr lang="en-US" sz="1300" dirty="0"/>
           </a:p>
@@ -24158,7 +23061,7 @@
                 <a:ea typeface="Calibri" pitchFamily="34" charset="-122"/>
                 <a:cs typeface="Calibri" pitchFamily="34" charset="-120"/>
               </a:rPr>
-              <a:t>96,4%</a:t>
+              <a:t>97,6%</a:t>
             </a:r>
             <a:endParaRPr lang="en-US" sz="1300" dirty="0"/>
           </a:p>
@@ -24236,7 +23139,7 @@
                 <a:ea typeface="Calibri" pitchFamily="34" charset="-122"/>
                 <a:cs typeface="Calibri" pitchFamily="34" charset="-120"/>
               </a:rPr>
-              <a:t>195</a:t>
+              <a:t>196</a:t>
             </a:r>
             <a:endParaRPr lang="en-US" sz="1300" dirty="0"/>
           </a:p>
@@ -24554,7 +23457,7 @@
                 <a:ea typeface="Calibri" pitchFamily="34" charset="-122"/>
                 <a:cs typeface="Calibri" pitchFamily="34" charset="-120"/>
               </a:rPr>
-              <a:t>128</a:t>
+              <a:t>132</a:t>
             </a:r>
             <a:endParaRPr lang="en-US" sz="1300" dirty="0"/>
           </a:p>
@@ -24593,7 +23496,7 @@
                 <a:ea typeface="Calibri" pitchFamily="34" charset="-122"/>
                 <a:cs typeface="Calibri" pitchFamily="34" charset="-120"/>
               </a:rPr>
-              <a:t>36</a:t>
+              <a:t>32</a:t>
             </a:r>
             <a:endParaRPr lang="en-US" sz="1300" dirty="0"/>
           </a:p>
@@ -24632,7 +23535,7 @@
                 <a:ea typeface="Calibri" pitchFamily="34" charset="-122"/>
                 <a:cs typeface="Calibri" pitchFamily="34" charset="-120"/>
               </a:rPr>
-              <a:t>78%</a:t>
+              <a:t>80,5%</a:t>
             </a:r>
             <a:endParaRPr lang="en-US" sz="1300" dirty="0"/>
           </a:p>
@@ -25483,7 +24386,7 @@
                 <a:ea typeface="Calibri" pitchFamily="34" charset="-122"/>
                 <a:cs typeface="Calibri" pitchFamily="34" charset="-120"/>
               </a:rPr>
-              <a:t>493</a:t>
+              <a:t>494</a:t>
             </a:r>
             <a:endParaRPr lang="en-US" sz="1300" dirty="0"/>
           </a:p>
@@ -25522,7 +24425,7 @@
                 <a:ea typeface="Calibri" pitchFamily="34" charset="-122"/>
                 <a:cs typeface="Calibri" pitchFamily="34" charset="-120"/>
               </a:rPr>
-              <a:t>447</a:t>
+              <a:t>455</a:t>
             </a:r>
             <a:endParaRPr lang="en-US" sz="1300" dirty="0"/>
           </a:p>
@@ -25561,7 +24464,7 @@
                 <a:ea typeface="Calibri" pitchFamily="34" charset="-122"/>
                 <a:cs typeface="Calibri" pitchFamily="34" charset="-120"/>
               </a:rPr>
-              <a:t>46</a:t>
+              <a:t>39</a:t>
             </a:r>
             <a:endParaRPr lang="en-US" sz="1300" dirty="0"/>
           </a:p>
@@ -25600,7 +24503,7 @@
                 <a:ea typeface="Calibri" pitchFamily="34" charset="-122"/>
                 <a:cs typeface="Calibri" pitchFamily="34" charset="-120"/>
               </a:rPr>
-              <a:t>90,7%</a:t>
+              <a:t>92,1%</a:t>
             </a:r>
             <a:endParaRPr lang="en-US" sz="1300" dirty="0"/>
           </a:p>
@@ -25678,7 +24581,7 @@
                 <a:ea typeface="Calibri" pitchFamily="34" charset="-122"/>
                 <a:cs typeface="Calibri" pitchFamily="34" charset="-120"/>
               </a:rPr>
-              <a:t>285</a:t>
+              <a:t>286</a:t>
             </a:r>
             <a:endParaRPr lang="en-US" sz="1300" dirty="0"/>
           </a:p>
@@ -25795,7 +24698,7 @@
                 <a:ea typeface="Calibri" pitchFamily="34" charset="-122"/>
                 <a:cs typeface="Calibri" pitchFamily="34" charset="-120"/>
               </a:rPr>
-              <a:t>Mediana de cierre global 30 días · el hallazgo más lento tomó 409 días · 79 hallazgos sin especialidad declarada.</a:t>
+              <a:t>Mediana de cierre global 30 días · el hallazgo más lento tomó 419 días · 79 hallazgos sin especialidad declarada.</a:t>
             </a:r>
             <a:endParaRPr lang="en-US" sz="950" dirty="0"/>
           </a:p>
@@ -25834,7 +24737,7 @@
                 <a:ea typeface="Calibri" pitchFamily="34" charset="-122"/>
                 <a:cs typeface="Calibri" pitchFamily="34" charset="-120"/>
               </a:rPr>
-              <a:t>Fuente: Data_NCR24082026.xlsx — hoja «Observaciones» · Corte 24-08-2026 · 501 registros desde 10-02-2023</a:t>
+              <a:t>Fuente: Data_NCR31082026.xlsx — hoja «Observaciones» · Corte 31-08-2026 · 502 registros desde 10-02-2023</a:t>
             </a:r>
             <a:endParaRPr lang="en-US" sz="850" dirty="0"/>
           </a:p>
@@ -26085,7 +24988,7 @@
                 <a:ea typeface="Calibri" pitchFamily="34" charset="-122"/>
                 <a:cs typeface="Calibri" pitchFamily="34" charset="-120"/>
               </a:rPr>
-              <a:t>Entre el 17-08-2026 y el 23-08-2026 se levantaron 3 hallazgos: 0 internas · 3 del cliente. 2 siguen abiertos.</a:t>
+              <a:t>Entre el 24-08-2026 y el 30-08-2026 se levantó 1 hallazgo: 0 internas · 1 del cliente. Sigue abierto.</a:t>
             </a:r>
             <a:endParaRPr lang="en-US" sz="1350" dirty="0"/>
           </a:p>
@@ -26240,7 +25143,7 @@
                 <a:ea typeface="Calibri" pitchFamily="34" charset="-122"/>
                 <a:cs typeface="Calibri" pitchFamily="34" charset="-120"/>
               </a:rPr>
-              <a:t>OO.CC 2  ·  PIPING 1</a:t>
+              <a:t>OO.CC 1</a:t>
             </a:r>
             <a:endParaRPr lang="en-US" sz="1100" dirty="0"/>
           </a:p>
@@ -26318,7 +25221,7 @@
                 <a:ea typeface="Calibri" pitchFamily="34" charset="-122"/>
                 <a:cs typeface="Calibri" pitchFamily="34" charset="-120"/>
               </a:rPr>
-              <a:t>Talabre 3</a:t>
+              <a:t>Talabre 1</a:t>
             </a:r>
             <a:endParaRPr lang="en-US" sz="1100" dirty="0"/>
           </a:p>
@@ -26396,7 +25299,7 @@
                 <a:ea typeface="Calibri" pitchFamily="34" charset="-122"/>
                 <a:cs typeface="Calibri" pitchFamily="34" charset="-120"/>
               </a:rPr>
-              <a:t>Externa · Cliente 3</a:t>
+              <a:t>Externa · Cliente 1</a:t>
             </a:r>
             <a:endParaRPr lang="en-US" sz="1100" dirty="0"/>
           </a:p>
@@ -26474,7 +25377,7 @@
                 <a:ea typeface="Calibri" pitchFamily="34" charset="-122"/>
                 <a:cs typeface="Calibri" pitchFamily="34" charset="-120"/>
               </a:rPr>
-              <a:t>No Conformidad 2  ·  Producto No Conforme 1</a:t>
+              <a:t>Producto No Conforme 1</a:t>
             </a:r>
             <a:endParaRPr lang="en-US" sz="1100" dirty="0"/>
           </a:p>
@@ -26926,7 +25829,7 @@
                 <a:ea typeface="Calibri" pitchFamily="34" charset="-122"/>
                 <a:cs typeface="Calibri" pitchFamily="34" charset="-120"/>
               </a:rPr>
-              <a:t>18-08-2026</a:t>
+              <a:t>24-08-2026</a:t>
             </a:r>
             <a:endParaRPr lang="en-US" sz="1050" dirty="0"/>
           </a:p>
@@ -27004,7 +25907,7 @@
                 <a:ea typeface="Calibri" pitchFamily="34" charset="-122"/>
                 <a:cs typeface="Calibri" pitchFamily="34" charset="-120"/>
               </a:rPr>
-              <a:t>246 · PNC N°189</a:t>
+              <a:t>249 · PNC N°192</a:t>
             </a:r>
             <a:endParaRPr lang="en-US" sz="1050" dirty="0"/>
           </a:p>
@@ -27160,7 +26063,7 @@
                 <a:ea typeface="Calibri" pitchFamily="34" charset="-122"/>
                 <a:cs typeface="Calibri" pitchFamily="34" charset="-120"/>
               </a:rPr>
-              <a:t>Luis Ogalde H.</a:t>
+              <a:t>Mauricio Rocha A.</a:t>
             </a:r>
             <a:endParaRPr lang="en-US" sz="1050" dirty="0"/>
           </a:p>
@@ -27193,13 +26096,13 @@
             <a:r>
               <a:rPr lang="en-US" sz="1050" dirty="0">
                 <a:solidFill>
-                  <a:srgbClr val="1F7A44"/>
-                </a:solidFill>
-                <a:latin typeface="Calibri" pitchFamily="34" charset="0"/>
-                <a:ea typeface="Calibri" pitchFamily="34" charset="-122"/>
-                <a:cs typeface="Calibri" pitchFamily="34" charset="-120"/>
-              </a:rPr>
-              <a:t>Cerrado</a:t>
+                  <a:srgbClr val="C0392B"/>
+                </a:solidFill>
+                <a:latin typeface="Calibri" pitchFamily="34" charset="0"/>
+                <a:ea typeface="Calibri" pitchFamily="34" charset="-122"/>
+                <a:cs typeface="Calibri" pitchFamily="34" charset="-120"/>
+              </a:rPr>
+              <a:t>Iniciado</a:t>
             </a:r>
             <a:endParaRPr lang="en-US" sz="1050" dirty="0"/>
           </a:p>
@@ -27238,7 +26141,7 @@
                 <a:ea typeface="Calibri" pitchFamily="34" charset="-122"/>
                 <a:cs typeface="Calibri" pitchFamily="34" charset="-120"/>
               </a:rPr>
-              <a:t>Daño estructural en la pare…</a:t>
+              <a:t>Se evidencia daño físico en…</a:t>
             </a:r>
             <a:endParaRPr lang="en-US" sz="1000" dirty="0"/>
           </a:p>
@@ -27269,775 +26172,7 @@
       </p:sp>
       <p:sp>
         <p:nvSpPr>
-          <p:cNvPr id="38" name="Shape 34"/>
-          <p:cNvSpPr/>
-          <p:nvPr/>
-        </p:nvSpPr>
-        <p:spPr>
-          <a:xfrm>
-            <a:off x="457200" y="4709160"/>
-            <a:ext cx="11292840" cy="329184"/>
-          </a:xfrm>
-          <a:prstGeom prst="rect">
-            <a:avLst/>
-          </a:prstGeom>
-          <a:solidFill>
-            <a:srgbClr val="FFFFFF"/>
-          </a:solidFill>
-          <a:ln/>
-        </p:spPr>
-      </p:sp>
-      <p:sp>
-        <p:nvSpPr>
-          <p:cNvPr id="39" name="Text 35"/>
-          <p:cNvSpPr/>
-          <p:nvPr/>
-        </p:nvSpPr>
-        <p:spPr>
-          <a:xfrm>
-            <a:off x="502920" y="4754880"/>
-            <a:ext cx="822960" cy="237744"/>
-          </a:xfrm>
-          <a:prstGeom prst="rect">
-            <a:avLst/>
-          </a:prstGeom>
-          <a:noFill/>
-          <a:ln/>
-        </p:spPr>
-        <p:txBody>
-          <a:bodyPr wrap="square" lIns="0" tIns="0" rIns="0" bIns="0" rtlCol="0" anchor="ctr"/>
-          <a:lstStyle/>
-          <a:p>
-            <a:pPr algn="l" indent="0" marL="0">
-              <a:buNone/>
-            </a:pPr>
-            <a:r>
-              <a:rPr lang="en-US" sz="1050" dirty="0">
-                <a:solidFill>
-                  <a:srgbClr val="1A2433"/>
-                </a:solidFill>
-                <a:latin typeface="Calibri" pitchFamily="34" charset="0"/>
-                <a:ea typeface="Calibri" pitchFamily="34" charset="-122"/>
-                <a:cs typeface="Calibri" pitchFamily="34" charset="-120"/>
-              </a:rPr>
-              <a:t>19-08-2026</a:t>
-            </a:r>
-            <a:endParaRPr lang="en-US" sz="1050" dirty="0"/>
-          </a:p>
-        </p:txBody>
-      </p:sp>
-      <p:sp>
-        <p:nvSpPr>
-          <p:cNvPr id="40" name="Text 36"/>
-          <p:cNvSpPr/>
-          <p:nvPr/>
-        </p:nvSpPr>
-        <p:spPr>
-          <a:xfrm>
-            <a:off x="1371600" y="4754880"/>
-            <a:ext cx="1051560" cy="237744"/>
-          </a:xfrm>
-          <a:prstGeom prst="rect">
-            <a:avLst/>
-          </a:prstGeom>
-          <a:noFill/>
-          <a:ln/>
-        </p:spPr>
-        <p:txBody>
-          <a:bodyPr wrap="square" lIns="0" tIns="0" rIns="0" bIns="0" rtlCol="0" anchor="ctr"/>
-          <a:lstStyle/>
-          <a:p>
-            <a:pPr algn="l" indent="0" marL="0">
-              <a:buNone/>
-            </a:pPr>
-            <a:r>
-              <a:rPr lang="en-US" sz="1050" dirty="0">
-                <a:solidFill>
-                  <a:srgbClr val="1A2433"/>
-                </a:solidFill>
-                <a:latin typeface="Calibri" pitchFamily="34" charset="0"/>
-                <a:ea typeface="Calibri" pitchFamily="34" charset="-122"/>
-                <a:cs typeface="Calibri" pitchFamily="34" charset="-120"/>
-              </a:rPr>
-              <a:t>Talabre</a:t>
-            </a:r>
-            <a:endParaRPr lang="en-US" sz="1050" dirty="0"/>
-          </a:p>
-        </p:txBody>
-      </p:sp>
-      <p:sp>
-        <p:nvSpPr>
-          <p:cNvPr id="41" name="Text 37"/>
-          <p:cNvSpPr/>
-          <p:nvPr/>
-        </p:nvSpPr>
-        <p:spPr>
-          <a:xfrm>
-            <a:off x="2468880" y="4754880"/>
-            <a:ext cx="1051560" cy="237744"/>
-          </a:xfrm>
-          <a:prstGeom prst="rect">
-            <a:avLst/>
-          </a:prstGeom>
-          <a:noFill/>
-          <a:ln/>
-        </p:spPr>
-        <p:txBody>
-          <a:bodyPr wrap="square" lIns="0" tIns="0" rIns="0" bIns="0" rtlCol="0" anchor="ctr"/>
-          <a:lstStyle/>
-          <a:p>
-            <a:pPr algn="l" indent="0" marL="0">
-              <a:buNone/>
-            </a:pPr>
-            <a:r>
-              <a:rPr lang="en-US" sz="1050" dirty="0">
-                <a:solidFill>
-                  <a:srgbClr val="1A2433"/>
-                </a:solidFill>
-                <a:latin typeface="Calibri" pitchFamily="34" charset="0"/>
-                <a:ea typeface="Calibri" pitchFamily="34" charset="-122"/>
-                <a:cs typeface="Calibri" pitchFamily="34" charset="-120"/>
-              </a:rPr>
-              <a:t>247 · RNC N°458</a:t>
-            </a:r>
-            <a:endParaRPr lang="en-US" sz="1050" dirty="0"/>
-          </a:p>
-        </p:txBody>
-      </p:sp>
-      <p:sp>
-        <p:nvSpPr>
-          <p:cNvPr id="42" name="Text 38"/>
-          <p:cNvSpPr/>
-          <p:nvPr/>
-        </p:nvSpPr>
-        <p:spPr>
-          <a:xfrm>
-            <a:off x="3566160" y="4754880"/>
-            <a:ext cx="1371600" cy="237744"/>
-          </a:xfrm>
-          <a:prstGeom prst="rect">
-            <a:avLst/>
-          </a:prstGeom>
-          <a:noFill/>
-          <a:ln/>
-        </p:spPr>
-        <p:txBody>
-          <a:bodyPr wrap="square" lIns="0" tIns="0" rIns="0" bIns="0" rtlCol="0" anchor="ctr"/>
-          <a:lstStyle/>
-          <a:p>
-            <a:pPr algn="l" indent="0" marL="0">
-              <a:buNone/>
-            </a:pPr>
-            <a:r>
-              <a:rPr lang="en-US" sz="1050" dirty="0">
-                <a:solidFill>
-                  <a:srgbClr val="1A2433"/>
-                </a:solidFill>
-                <a:latin typeface="Calibri" pitchFamily="34" charset="0"/>
-                <a:ea typeface="Calibri" pitchFamily="34" charset="-122"/>
-                <a:cs typeface="Calibri" pitchFamily="34" charset="-120"/>
-              </a:rPr>
-              <a:t>No Conformidad</a:t>
-            </a:r>
-            <a:endParaRPr lang="en-US" sz="1050" dirty="0"/>
-          </a:p>
-        </p:txBody>
-      </p:sp>
-      <p:sp>
-        <p:nvSpPr>
-          <p:cNvPr id="43" name="Text 39"/>
-          <p:cNvSpPr/>
-          <p:nvPr/>
-        </p:nvSpPr>
-        <p:spPr>
-          <a:xfrm>
-            <a:off x="4983480" y="4754880"/>
-            <a:ext cx="1417320" cy="237744"/>
-          </a:xfrm>
-          <a:prstGeom prst="rect">
-            <a:avLst/>
-          </a:prstGeom>
-          <a:noFill/>
-          <a:ln/>
-        </p:spPr>
-        <p:txBody>
-          <a:bodyPr wrap="square" lIns="0" tIns="0" rIns="0" bIns="0" rtlCol="0" anchor="ctr"/>
-          <a:lstStyle/>
-          <a:p>
-            <a:pPr algn="l" indent="0" marL="0">
-              <a:buNone/>
-            </a:pPr>
-            <a:r>
-              <a:rPr lang="en-US" sz="1050" b="1" dirty="0">
-                <a:solidFill>
-                  <a:srgbClr val="C87A32"/>
-                </a:solidFill>
-                <a:latin typeface="Calibri" pitchFamily="34" charset="0"/>
-                <a:ea typeface="Calibri" pitchFamily="34" charset="-122"/>
-                <a:cs typeface="Calibri" pitchFamily="34" charset="-120"/>
-              </a:rPr>
-              <a:t>Externa · Cliente</a:t>
-            </a:r>
-            <a:endParaRPr lang="en-US" sz="1050" dirty="0"/>
-          </a:p>
-        </p:txBody>
-      </p:sp>
-      <p:sp>
-        <p:nvSpPr>
-          <p:cNvPr id="44" name="Text 40"/>
-          <p:cNvSpPr/>
-          <p:nvPr/>
-        </p:nvSpPr>
-        <p:spPr>
-          <a:xfrm>
-            <a:off x="6446520" y="4754880"/>
-            <a:ext cx="1097280" cy="237744"/>
-          </a:xfrm>
-          <a:prstGeom prst="rect">
-            <a:avLst/>
-          </a:prstGeom>
-          <a:noFill/>
-          <a:ln/>
-        </p:spPr>
-        <p:txBody>
-          <a:bodyPr wrap="square" lIns="0" tIns="0" rIns="0" bIns="0" rtlCol="0" anchor="ctr"/>
-          <a:lstStyle/>
-          <a:p>
-            <a:pPr algn="l" indent="0" marL="0">
-              <a:buNone/>
-            </a:pPr>
-            <a:r>
-              <a:rPr lang="en-US" sz="1050" dirty="0">
-                <a:solidFill>
-                  <a:srgbClr val="1A2433"/>
-                </a:solidFill>
-                <a:latin typeface="Calibri" pitchFamily="34" charset="0"/>
-                <a:ea typeface="Calibri" pitchFamily="34" charset="-122"/>
-                <a:cs typeface="Calibri" pitchFamily="34" charset="-120"/>
-              </a:rPr>
-              <a:t>OO.CC</a:t>
-            </a:r>
-            <a:endParaRPr lang="en-US" sz="1050" dirty="0"/>
-          </a:p>
-        </p:txBody>
-      </p:sp>
-      <p:sp>
-        <p:nvSpPr>
-          <p:cNvPr id="45" name="Text 41"/>
-          <p:cNvSpPr/>
-          <p:nvPr/>
-        </p:nvSpPr>
-        <p:spPr>
-          <a:xfrm>
-            <a:off x="7589520" y="4754880"/>
-            <a:ext cx="1371600" cy="237744"/>
-          </a:xfrm>
-          <a:prstGeom prst="rect">
-            <a:avLst/>
-          </a:prstGeom>
-          <a:noFill/>
-          <a:ln/>
-        </p:spPr>
-        <p:txBody>
-          <a:bodyPr wrap="square" lIns="0" tIns="0" rIns="0" bIns="0" rtlCol="0" anchor="ctr"/>
-          <a:lstStyle/>
-          <a:p>
-            <a:pPr algn="l" indent="0" marL="0">
-              <a:buNone/>
-            </a:pPr>
-            <a:r>
-              <a:rPr lang="en-US" sz="1050" dirty="0">
-                <a:solidFill>
-                  <a:srgbClr val="1A2433"/>
-                </a:solidFill>
-                <a:latin typeface="Calibri" pitchFamily="34" charset="0"/>
-                <a:ea typeface="Calibri" pitchFamily="34" charset="-122"/>
-                <a:cs typeface="Calibri" pitchFamily="34" charset="-120"/>
-              </a:rPr>
-              <a:t>Luis Ogalde H.</a:t>
-            </a:r>
-            <a:endParaRPr lang="en-US" sz="1050" dirty="0"/>
-          </a:p>
-        </p:txBody>
-      </p:sp>
-      <p:sp>
-        <p:nvSpPr>
-          <p:cNvPr id="46" name="Text 42"/>
-          <p:cNvSpPr/>
-          <p:nvPr/>
-        </p:nvSpPr>
-        <p:spPr>
-          <a:xfrm>
-            <a:off x="9006840" y="4754880"/>
-            <a:ext cx="868680" cy="237744"/>
-          </a:xfrm>
-          <a:prstGeom prst="rect">
-            <a:avLst/>
-          </a:prstGeom>
-          <a:noFill/>
-          <a:ln/>
-        </p:spPr>
-        <p:txBody>
-          <a:bodyPr wrap="square" lIns="0" tIns="0" rIns="0" bIns="0" rtlCol="0" anchor="ctr"/>
-          <a:lstStyle/>
-          <a:p>
-            <a:pPr algn="l" indent="0" marL="0">
-              <a:buNone/>
-            </a:pPr>
-            <a:r>
-              <a:rPr lang="en-US" sz="1050" dirty="0">
-                <a:solidFill>
-                  <a:srgbClr val="C0392B"/>
-                </a:solidFill>
-                <a:latin typeface="Calibri" pitchFamily="34" charset="0"/>
-                <a:ea typeface="Calibri" pitchFamily="34" charset="-122"/>
-                <a:cs typeface="Calibri" pitchFamily="34" charset="-120"/>
-              </a:rPr>
-              <a:t>Iniciado</a:t>
-            </a:r>
-            <a:endParaRPr lang="en-US" sz="1050" dirty="0"/>
-          </a:p>
-        </p:txBody>
-      </p:sp>
-      <p:sp>
-        <p:nvSpPr>
-          <p:cNvPr id="47" name="Text 43"/>
-          <p:cNvSpPr/>
-          <p:nvPr/>
-        </p:nvSpPr>
-        <p:spPr>
-          <a:xfrm>
-            <a:off x="9921240" y="4754880"/>
-            <a:ext cx="1828800" cy="237744"/>
-          </a:xfrm>
-          <a:prstGeom prst="rect">
-            <a:avLst/>
-          </a:prstGeom>
-          <a:noFill/>
-          <a:ln/>
-        </p:spPr>
-        <p:txBody>
-          <a:bodyPr wrap="square" lIns="0" tIns="0" rIns="0" bIns="0" rtlCol="0" anchor="ctr"/>
-          <a:lstStyle/>
-          <a:p>
-            <a:pPr algn="l" indent="0" marL="0">
-              <a:buNone/>
-            </a:pPr>
-            <a:r>
-              <a:rPr lang="en-US" sz="1000" dirty="0">
-                <a:solidFill>
-                  <a:srgbClr val="1A2433"/>
-                </a:solidFill>
-                <a:latin typeface="Calibri" pitchFamily="34" charset="0"/>
-                <a:ea typeface="Calibri" pitchFamily="34" charset="-122"/>
-                <a:cs typeface="Calibri" pitchFamily="34" charset="-120"/>
-              </a:rPr>
-              <a:t>Fundaciones FS-01 (10 eleme…</a:t>
-            </a:r>
-            <a:endParaRPr lang="en-US" sz="1000" dirty="0"/>
-          </a:p>
-        </p:txBody>
-      </p:sp>
-      <p:sp>
-        <p:nvSpPr>
-          <p:cNvPr id="48" name="Shape 44"/>
-          <p:cNvSpPr/>
-          <p:nvPr/>
-        </p:nvSpPr>
-        <p:spPr>
-          <a:xfrm>
-            <a:off x="502920" y="5029200"/>
-            <a:ext cx="11247120" cy="0"/>
-          </a:xfrm>
-          <a:prstGeom prst="line">
-            <a:avLst/>
-          </a:prstGeom>
-          <a:noFill/>
-          <a:ln w="9525">
-            <a:solidFill>
-              <a:srgbClr val="D9DFE6"/>
-            </a:solidFill>
-            <a:prstDash val="solid"/>
-          </a:ln>
-        </p:spPr>
-      </p:sp>
-      <p:sp>
-        <p:nvSpPr>
-          <p:cNvPr id="49" name="Text 45"/>
-          <p:cNvSpPr/>
-          <p:nvPr/>
-        </p:nvSpPr>
-        <p:spPr>
-          <a:xfrm>
-            <a:off x="502920" y="5084064"/>
-            <a:ext cx="822960" cy="237744"/>
-          </a:xfrm>
-          <a:prstGeom prst="rect">
-            <a:avLst/>
-          </a:prstGeom>
-          <a:noFill/>
-          <a:ln/>
-        </p:spPr>
-        <p:txBody>
-          <a:bodyPr wrap="square" lIns="0" tIns="0" rIns="0" bIns="0" rtlCol="0" anchor="ctr"/>
-          <a:lstStyle/>
-          <a:p>
-            <a:pPr algn="l" indent="0" marL="0">
-              <a:buNone/>
-            </a:pPr>
-            <a:r>
-              <a:rPr lang="en-US" sz="1050" dirty="0">
-                <a:solidFill>
-                  <a:srgbClr val="1A2433"/>
-                </a:solidFill>
-                <a:latin typeface="Calibri" pitchFamily="34" charset="0"/>
-                <a:ea typeface="Calibri" pitchFamily="34" charset="-122"/>
-                <a:cs typeface="Calibri" pitchFamily="34" charset="-120"/>
-              </a:rPr>
-              <a:t>19-08-2026</a:t>
-            </a:r>
-            <a:endParaRPr lang="en-US" sz="1050" dirty="0"/>
-          </a:p>
-        </p:txBody>
-      </p:sp>
-      <p:sp>
-        <p:nvSpPr>
-          <p:cNvPr id="50" name="Text 46"/>
-          <p:cNvSpPr/>
-          <p:nvPr/>
-        </p:nvSpPr>
-        <p:spPr>
-          <a:xfrm>
-            <a:off x="1371600" y="5084064"/>
-            <a:ext cx="1051560" cy="237744"/>
-          </a:xfrm>
-          <a:prstGeom prst="rect">
-            <a:avLst/>
-          </a:prstGeom>
-          <a:noFill/>
-          <a:ln/>
-        </p:spPr>
-        <p:txBody>
-          <a:bodyPr wrap="square" lIns="0" tIns="0" rIns="0" bIns="0" rtlCol="0" anchor="ctr"/>
-          <a:lstStyle/>
-          <a:p>
-            <a:pPr algn="l" indent="0" marL="0">
-              <a:buNone/>
-            </a:pPr>
-            <a:r>
-              <a:rPr lang="en-US" sz="1050" dirty="0">
-                <a:solidFill>
-                  <a:srgbClr val="1A2433"/>
-                </a:solidFill>
-                <a:latin typeface="Calibri" pitchFamily="34" charset="0"/>
-                <a:ea typeface="Calibri" pitchFamily="34" charset="-122"/>
-                <a:cs typeface="Calibri" pitchFamily="34" charset="-120"/>
-              </a:rPr>
-              <a:t>Talabre</a:t>
-            </a:r>
-            <a:endParaRPr lang="en-US" sz="1050" dirty="0"/>
-          </a:p>
-        </p:txBody>
-      </p:sp>
-      <p:sp>
-        <p:nvSpPr>
-          <p:cNvPr id="51" name="Text 47"/>
-          <p:cNvSpPr/>
-          <p:nvPr/>
-        </p:nvSpPr>
-        <p:spPr>
-          <a:xfrm>
-            <a:off x="2468880" y="5084064"/>
-            <a:ext cx="1051560" cy="237744"/>
-          </a:xfrm>
-          <a:prstGeom prst="rect">
-            <a:avLst/>
-          </a:prstGeom>
-          <a:noFill/>
-          <a:ln/>
-        </p:spPr>
-        <p:txBody>
-          <a:bodyPr wrap="square" lIns="0" tIns="0" rIns="0" bIns="0" rtlCol="0" anchor="ctr"/>
-          <a:lstStyle/>
-          <a:p>
-            <a:pPr algn="l" indent="0" marL="0">
-              <a:buNone/>
-            </a:pPr>
-            <a:r>
-              <a:rPr lang="en-US" sz="1050" dirty="0">
-                <a:solidFill>
-                  <a:srgbClr val="1A2433"/>
-                </a:solidFill>
-                <a:latin typeface="Calibri" pitchFamily="34" charset="0"/>
-                <a:ea typeface="Calibri" pitchFamily="34" charset="-122"/>
-                <a:cs typeface="Calibri" pitchFamily="34" charset="-120"/>
-              </a:rPr>
-              <a:t>248 · RNC N°463</a:t>
-            </a:r>
-            <a:endParaRPr lang="en-US" sz="1050" dirty="0"/>
-          </a:p>
-        </p:txBody>
-      </p:sp>
-      <p:sp>
-        <p:nvSpPr>
-          <p:cNvPr id="52" name="Text 48"/>
-          <p:cNvSpPr/>
-          <p:nvPr/>
-        </p:nvSpPr>
-        <p:spPr>
-          <a:xfrm>
-            <a:off x="3566160" y="5084064"/>
-            <a:ext cx="1371600" cy="237744"/>
-          </a:xfrm>
-          <a:prstGeom prst="rect">
-            <a:avLst/>
-          </a:prstGeom>
-          <a:noFill/>
-          <a:ln/>
-        </p:spPr>
-        <p:txBody>
-          <a:bodyPr wrap="square" lIns="0" tIns="0" rIns="0" bIns="0" rtlCol="0" anchor="ctr"/>
-          <a:lstStyle/>
-          <a:p>
-            <a:pPr algn="l" indent="0" marL="0">
-              <a:buNone/>
-            </a:pPr>
-            <a:r>
-              <a:rPr lang="en-US" sz="1050" dirty="0">
-                <a:solidFill>
-                  <a:srgbClr val="1A2433"/>
-                </a:solidFill>
-                <a:latin typeface="Calibri" pitchFamily="34" charset="0"/>
-                <a:ea typeface="Calibri" pitchFamily="34" charset="-122"/>
-                <a:cs typeface="Calibri" pitchFamily="34" charset="-120"/>
-              </a:rPr>
-              <a:t>No Conformidad</a:t>
-            </a:r>
-            <a:endParaRPr lang="en-US" sz="1050" dirty="0"/>
-          </a:p>
-        </p:txBody>
-      </p:sp>
-      <p:sp>
-        <p:nvSpPr>
-          <p:cNvPr id="53" name="Text 49"/>
-          <p:cNvSpPr/>
-          <p:nvPr/>
-        </p:nvSpPr>
-        <p:spPr>
-          <a:xfrm>
-            <a:off x="4983480" y="5084064"/>
-            <a:ext cx="1417320" cy="237744"/>
-          </a:xfrm>
-          <a:prstGeom prst="rect">
-            <a:avLst/>
-          </a:prstGeom>
-          <a:noFill/>
-          <a:ln/>
-        </p:spPr>
-        <p:txBody>
-          <a:bodyPr wrap="square" lIns="0" tIns="0" rIns="0" bIns="0" rtlCol="0" anchor="ctr"/>
-          <a:lstStyle/>
-          <a:p>
-            <a:pPr algn="l" indent="0" marL="0">
-              <a:buNone/>
-            </a:pPr>
-            <a:r>
-              <a:rPr lang="en-US" sz="1050" b="1" dirty="0">
-                <a:solidFill>
-                  <a:srgbClr val="C87A32"/>
-                </a:solidFill>
-                <a:latin typeface="Calibri" pitchFamily="34" charset="0"/>
-                <a:ea typeface="Calibri" pitchFamily="34" charset="-122"/>
-                <a:cs typeface="Calibri" pitchFamily="34" charset="-120"/>
-              </a:rPr>
-              <a:t>Externa · Cliente</a:t>
-            </a:r>
-            <a:endParaRPr lang="en-US" sz="1050" dirty="0"/>
-          </a:p>
-        </p:txBody>
-      </p:sp>
-      <p:sp>
-        <p:nvSpPr>
-          <p:cNvPr id="54" name="Text 50"/>
-          <p:cNvSpPr/>
-          <p:nvPr/>
-        </p:nvSpPr>
-        <p:spPr>
-          <a:xfrm>
-            <a:off x="6446520" y="5084064"/>
-            <a:ext cx="1097280" cy="237744"/>
-          </a:xfrm>
-          <a:prstGeom prst="rect">
-            <a:avLst/>
-          </a:prstGeom>
-          <a:noFill/>
-          <a:ln/>
-        </p:spPr>
-        <p:txBody>
-          <a:bodyPr wrap="square" lIns="0" tIns="0" rIns="0" bIns="0" rtlCol="0" anchor="ctr"/>
-          <a:lstStyle/>
-          <a:p>
-            <a:pPr algn="l" indent="0" marL="0">
-              <a:buNone/>
-            </a:pPr>
-            <a:r>
-              <a:rPr lang="en-US" sz="1050" dirty="0">
-                <a:solidFill>
-                  <a:srgbClr val="1A2433"/>
-                </a:solidFill>
-                <a:latin typeface="Calibri" pitchFamily="34" charset="0"/>
-                <a:ea typeface="Calibri" pitchFamily="34" charset="-122"/>
-                <a:cs typeface="Calibri" pitchFamily="34" charset="-120"/>
-              </a:rPr>
-              <a:t>PIPING</a:t>
-            </a:r>
-            <a:endParaRPr lang="en-US" sz="1050" dirty="0"/>
-          </a:p>
-        </p:txBody>
-      </p:sp>
-      <p:sp>
-        <p:nvSpPr>
-          <p:cNvPr id="55" name="Text 51"/>
-          <p:cNvSpPr/>
-          <p:nvPr/>
-        </p:nvSpPr>
-        <p:spPr>
-          <a:xfrm>
-            <a:off x="7589520" y="5084064"/>
-            <a:ext cx="1371600" cy="237744"/>
-          </a:xfrm>
-          <a:prstGeom prst="rect">
-            <a:avLst/>
-          </a:prstGeom>
-          <a:noFill/>
-          <a:ln/>
-        </p:spPr>
-        <p:txBody>
-          <a:bodyPr wrap="square" lIns="0" tIns="0" rIns="0" bIns="0" rtlCol="0" anchor="ctr"/>
-          <a:lstStyle/>
-          <a:p>
-            <a:pPr algn="l" indent="0" marL="0">
-              <a:buNone/>
-            </a:pPr>
-            <a:r>
-              <a:rPr lang="en-US" sz="1050" dirty="0">
-                <a:solidFill>
-                  <a:srgbClr val="1A2433"/>
-                </a:solidFill>
-                <a:latin typeface="Calibri" pitchFamily="34" charset="0"/>
-                <a:ea typeface="Calibri" pitchFamily="34" charset="-122"/>
-                <a:cs typeface="Calibri" pitchFamily="34" charset="-120"/>
-              </a:rPr>
-              <a:t>Oscar Nahuel P.</a:t>
-            </a:r>
-            <a:endParaRPr lang="en-US" sz="1050" dirty="0"/>
-          </a:p>
-        </p:txBody>
-      </p:sp>
-      <p:sp>
-        <p:nvSpPr>
-          <p:cNvPr id="56" name="Text 52"/>
-          <p:cNvSpPr/>
-          <p:nvPr/>
-        </p:nvSpPr>
-        <p:spPr>
-          <a:xfrm>
-            <a:off x="9006840" y="5084064"/>
-            <a:ext cx="868680" cy="237744"/>
-          </a:xfrm>
-          <a:prstGeom prst="rect">
-            <a:avLst/>
-          </a:prstGeom>
-          <a:noFill/>
-          <a:ln/>
-        </p:spPr>
-        <p:txBody>
-          <a:bodyPr wrap="square" lIns="0" tIns="0" rIns="0" bIns="0" rtlCol="0" anchor="ctr"/>
-          <a:lstStyle/>
-          <a:p>
-            <a:pPr algn="l" indent="0" marL="0">
-              <a:buNone/>
-            </a:pPr>
-            <a:r>
-              <a:rPr lang="en-US" sz="1050" dirty="0">
-                <a:solidFill>
-                  <a:srgbClr val="C0392B"/>
-                </a:solidFill>
-                <a:latin typeface="Calibri" pitchFamily="34" charset="0"/>
-                <a:ea typeface="Calibri" pitchFamily="34" charset="-122"/>
-                <a:cs typeface="Calibri" pitchFamily="34" charset="-120"/>
-              </a:rPr>
-              <a:t>Iniciado</a:t>
-            </a:r>
-            <a:endParaRPr lang="en-US" sz="1050" dirty="0"/>
-          </a:p>
-        </p:txBody>
-      </p:sp>
-      <p:sp>
-        <p:nvSpPr>
-          <p:cNvPr id="57" name="Text 53"/>
-          <p:cNvSpPr/>
-          <p:nvPr/>
-        </p:nvSpPr>
-        <p:spPr>
-          <a:xfrm>
-            <a:off x="9921240" y="5084064"/>
-            <a:ext cx="1828800" cy="237744"/>
-          </a:xfrm>
-          <a:prstGeom prst="rect">
-            <a:avLst/>
-          </a:prstGeom>
-          <a:noFill/>
-          <a:ln/>
-        </p:spPr>
-        <p:txBody>
-          <a:bodyPr wrap="square" lIns="0" tIns="0" rIns="0" bIns="0" rtlCol="0" anchor="ctr"/>
-          <a:lstStyle/>
-          <a:p>
-            <a:pPr algn="l" indent="0" marL="0">
-              <a:buNone/>
-            </a:pPr>
-            <a:r>
-              <a:rPr lang="en-US" sz="1000" dirty="0">
-                <a:solidFill>
-                  <a:srgbClr val="1A2433"/>
-                </a:solidFill>
-                <a:latin typeface="Calibri" pitchFamily="34" charset="0"/>
-                <a:ea typeface="Calibri" pitchFamily="34" charset="-122"/>
-                <a:cs typeface="Calibri" pitchFamily="34" charset="-120"/>
-              </a:rPr>
-              <a:t>Línea TAG N° 3716D-RW-24-H1…</a:t>
-            </a:r>
-            <a:endParaRPr lang="en-US" sz="1000" dirty="0"/>
-          </a:p>
-        </p:txBody>
-      </p:sp>
-      <p:sp>
-        <p:nvSpPr>
-          <p:cNvPr id="58" name="Shape 54"/>
-          <p:cNvSpPr/>
-          <p:nvPr/>
-        </p:nvSpPr>
-        <p:spPr>
-          <a:xfrm>
-            <a:off x="502920" y="5358384"/>
-            <a:ext cx="11247120" cy="0"/>
-          </a:xfrm>
-          <a:prstGeom prst="line">
-            <a:avLst/>
-          </a:prstGeom>
-          <a:noFill/>
-          <a:ln w="9525">
-            <a:solidFill>
-              <a:srgbClr val="D9DFE6"/>
-            </a:solidFill>
-            <a:prstDash val="solid"/>
-          </a:ln>
-        </p:spPr>
-      </p:sp>
-      <p:sp>
-        <p:nvSpPr>
-          <p:cNvPr id="59" name="Text 55"/>
+          <p:cNvPr id="38" name="Text 34"/>
           <p:cNvSpPr/>
           <p:nvPr/>
         </p:nvSpPr>
@@ -28068,7 +26203,7 @@
                 <a:ea typeface="Calibri" pitchFamily="34" charset="-122"/>
                 <a:cs typeface="Calibri" pitchFamily="34" charset="-120"/>
               </a:rPr>
-              <a:t>Fuente: Data_NCR24082026.xlsx — hoja «Observaciones» · Corte 24-08-2026 · 501 registros desde 10-02-2023</a:t>
+              <a:t>Fuente: Data_NCR31082026.xlsx — hoja «Observaciones» · Corte 31-08-2026 · 502 registros desde 10-02-2023</a:t>
             </a:r>
             <a:endParaRPr lang="en-US" sz="850" dirty="0"/>
           </a:p>
@@ -28076,7 +26211,7 @@
       </p:sp>
       <p:sp>
         <p:nvSpPr>
-          <p:cNvPr id="60" name="Text 56"/>
+          <p:cNvPr id="39" name="Text 35"/>
           <p:cNvSpPr/>
           <p:nvPr/>
         </p:nvSpPr>
@@ -28115,7 +26250,7 @@
       </p:sp>
       <p:sp>
         <p:nvSpPr>
-          <p:cNvPr id="61" name="Text 57"/>
+          <p:cNvPr id="40" name="Text 36"/>
           <p:cNvSpPr/>
           <p:nvPr/>
         </p:nvSpPr>
@@ -29064,7 +27199,7 @@
                 <a:ea typeface="Calibri" pitchFamily="34" charset="-122"/>
                 <a:cs typeface="Calibri" pitchFamily="34" charset="-120"/>
               </a:rPr>
-              <a:t>285</a:t>
+              <a:t>286</a:t>
             </a:r>
             <a:endParaRPr lang="en-US" sz="1050" dirty="0"/>
           </a:p>
@@ -29103,7 +27238,7 @@
                 <a:ea typeface="Calibri" pitchFamily="34" charset="-122"/>
                 <a:cs typeface="Calibri" pitchFamily="34" charset="-120"/>
               </a:rPr>
-              <a:t>241</a:t>
+              <a:t>249</a:t>
             </a:r>
             <a:endParaRPr lang="en-US" sz="1050" dirty="0"/>
           </a:p>
@@ -29142,7 +27277,7 @@
                 <a:ea typeface="Calibri" pitchFamily="34" charset="-122"/>
                 <a:cs typeface="Calibri" pitchFamily="34" charset="-120"/>
               </a:rPr>
-              <a:t>84,6%</a:t>
+              <a:t>87,1%</a:t>
             </a:r>
             <a:endParaRPr lang="en-US" sz="1050" dirty="0"/>
           </a:p>
@@ -29181,7 +27316,7 @@
                 <a:ea typeface="Calibri" pitchFamily="34" charset="-122"/>
                 <a:cs typeface="Calibri" pitchFamily="34" charset="-120"/>
               </a:rPr>
-              <a:t>44</a:t>
+              <a:t>37</a:t>
             </a:r>
             <a:endParaRPr lang="en-US" sz="1050" dirty="0"/>
           </a:p>
@@ -29220,7 +27355,7 @@
                 <a:ea typeface="Calibri" pitchFamily="34" charset="-122"/>
                 <a:cs typeface="Calibri" pitchFamily="34" charset="-120"/>
               </a:rPr>
-              <a:t>42</a:t>
+              <a:t>36</a:t>
             </a:r>
             <a:endParaRPr lang="en-US" sz="1050" dirty="0"/>
           </a:p>
@@ -29259,7 +27394,7 @@
                 <a:ea typeface="Calibri" pitchFamily="34" charset="-122"/>
                 <a:cs typeface="Calibri" pitchFamily="34" charset="-120"/>
               </a:rPr>
-              <a:t>51 días</a:t>
+              <a:t>57 días</a:t>
             </a:r>
             <a:endParaRPr lang="en-US" sz="1050" dirty="0"/>
           </a:p>
@@ -29972,7 +28107,7 @@
                 <a:ea typeface="Calibri" pitchFamily="34" charset="-122"/>
                 <a:cs typeface="Calibri" pitchFamily="34" charset="-120"/>
               </a:rPr>
-              <a:t>501</a:t>
+              <a:t>502</a:t>
             </a:r>
             <a:endParaRPr lang="en-US" sz="1050" dirty="0"/>
           </a:p>
@@ -30011,7 +28146,7 @@
                 <a:ea typeface="Calibri" pitchFamily="34" charset="-122"/>
                 <a:cs typeface="Calibri" pitchFamily="34" charset="-120"/>
               </a:rPr>
-              <a:t>455</a:t>
+              <a:t>463</a:t>
             </a:r>
             <a:endParaRPr lang="en-US" sz="1050" dirty="0"/>
           </a:p>
@@ -30050,7 +28185,7 @@
                 <a:ea typeface="Calibri" pitchFamily="34" charset="-122"/>
                 <a:cs typeface="Calibri" pitchFamily="34" charset="-120"/>
               </a:rPr>
-              <a:t>90,8%</a:t>
+              <a:t>92,2%</a:t>
             </a:r>
             <a:endParaRPr lang="en-US" sz="1050" dirty="0"/>
           </a:p>
@@ -30089,7 +28224,7 @@
                 <a:ea typeface="Calibri" pitchFamily="34" charset="-122"/>
                 <a:cs typeface="Calibri" pitchFamily="34" charset="-120"/>
               </a:rPr>
-              <a:t>46</a:t>
+              <a:t>39</a:t>
             </a:r>
             <a:endParaRPr lang="en-US" sz="1050" dirty="0"/>
           </a:p>
@@ -30128,7 +28263,7 @@
                 <a:ea typeface="Calibri" pitchFamily="34" charset="-122"/>
                 <a:cs typeface="Calibri" pitchFamily="34" charset="-120"/>
               </a:rPr>
-              <a:t>44</a:t>
+              <a:t>38</a:t>
             </a:r>
             <a:endParaRPr lang="en-US" sz="1050" dirty="0"/>
           </a:p>
@@ -30167,7 +28302,7 @@
                 <a:ea typeface="Calibri" pitchFamily="34" charset="-122"/>
                 <a:cs typeface="Calibri" pitchFamily="34" charset="-120"/>
               </a:rPr>
-              <a:t>71 días</a:t>
+              <a:t>74 días</a:t>
             </a:r>
             <a:endParaRPr lang="en-US" sz="1050" dirty="0"/>
           </a:p>
@@ -30384,7 +28519,7 @@
                 <a:ea typeface="Cambria" pitchFamily="34" charset="-122"/>
                 <a:cs typeface="Cambria" pitchFamily="34" charset="-120"/>
               </a:rPr>
-              <a:t>21,1%</a:t>
+              <a:t>21%</a:t>
             </a:r>
             <a:endParaRPr lang="en-US" sz="2400" dirty="0"/>
           </a:p>
@@ -30540,7 +28675,7 @@
                 <a:ea typeface="Calibri" pitchFamily="34" charset="-122"/>
                 <a:cs typeface="Calibri" pitchFamily="34" charset="-120"/>
               </a:rPr>
-              <a:t>Fuente: Data_NCR24082026.xlsx — hoja «Observaciones» · Corte 24-08-2026 · 501 registros desde 10-02-2023</a:t>
+              <a:t>Fuente: Data_NCR31082026.xlsx — hoja «Observaciones» · Corte 31-08-2026 · 502 registros desde 10-02-2023</a:t>
             </a:r>
             <a:endParaRPr lang="en-US" sz="850" dirty="0"/>
           </a:p>
@@ -30791,7 +28926,7 @@
                 <a:ea typeface="Calibri" pitchFamily="34" charset="-122"/>
                 <a:cs typeface="Calibri" pitchFamily="34" charset="-120"/>
               </a:rPr>
-              <a:t>De los 46 hallazgos abiertos, 17 llevan más de 180 días desde que se levantaron y 3 más de un año. La mediana de cierre global es de 30 días.</a:t>
+              <a:t>De los 39 hallazgos abiertos, 13 llevan más de 180 días desde que se levantaron y 0 más de un año. La mediana de cierre global es de 30 días.</a:t>
             </a:r>
             <a:endParaRPr lang="en-US" sz="1350" dirty="0"/>
           </a:p>
@@ -30928,7 +29063,7 @@
                 <a:ea typeface="Calibri" pitchFamily="34" charset="-122"/>
                 <a:cs typeface="Calibri" pitchFamily="34" charset="-120"/>
               </a:rPr>
-              <a:t>Al corte hay 44 hallazgos fuera de plazo de los 46 abiertos.</a:t>
+              <a:t>Al corte hay 38 hallazgos fuera de plazo de los 39 abiertos.</a:t>
             </a:r>
             <a:endParaRPr lang="en-US" sz="1150" dirty="0"/>
           </a:p>
@@ -31607,7 +29742,7 @@
                 <a:ea typeface="Calibri" pitchFamily="34" charset="-122"/>
                 <a:cs typeface="Calibri" pitchFamily="34" charset="-120"/>
               </a:rPr>
-              <a:t>238</a:t>
+              <a:t>242</a:t>
             </a:r>
             <a:endParaRPr lang="en-US" sz="1150" dirty="0"/>
           </a:p>
@@ -31724,7 +29859,7 @@
                 <a:ea typeface="Calibri" pitchFamily="34" charset="-122"/>
                 <a:cs typeface="Calibri" pitchFamily="34" charset="-120"/>
               </a:rPr>
-              <a:t>9</a:t>
+              <a:t>6</a:t>
             </a:r>
             <a:endParaRPr lang="en-US" sz="1150" dirty="0"/>
           </a:p>
@@ -31853,7 +29988,7 @@
                 <a:ea typeface="Calibri" pitchFamily="34" charset="-122"/>
                 <a:cs typeface="Calibri" pitchFamily="34" charset="-120"/>
               </a:rPr>
-              <a:t>128</a:t>
+              <a:t>132</a:t>
             </a:r>
             <a:endParaRPr lang="en-US" sz="1150" dirty="0"/>
           </a:p>
@@ -31892,7 +30027,7 @@
                 <a:ea typeface="Calibri" pitchFamily="34" charset="-122"/>
                 <a:cs typeface="Calibri" pitchFamily="34" charset="-120"/>
               </a:rPr>
-              <a:t>131 d</a:t>
+              <a:t>139 d</a:t>
             </a:r>
             <a:endParaRPr lang="en-US" sz="1150" dirty="0"/>
           </a:p>
@@ -31931,7 +30066,7 @@
                 <a:ea typeface="Calibri" pitchFamily="34" charset="-122"/>
                 <a:cs typeface="Calibri" pitchFamily="34" charset="-120"/>
               </a:rPr>
-              <a:t>409 d</a:t>
+              <a:t>419 d</a:t>
             </a:r>
             <a:endParaRPr lang="en-US" sz="1150" dirty="0"/>
           </a:p>
@@ -31970,7 +30105,7 @@
                 <a:ea typeface="Calibri" pitchFamily="34" charset="-122"/>
                 <a:cs typeface="Calibri" pitchFamily="34" charset="-120"/>
               </a:rPr>
-              <a:t>36</a:t>
+              <a:t>32</a:t>
             </a:r>
             <a:endParaRPr lang="en-US" sz="1150" dirty="0"/>
           </a:p>
@@ -32009,7 +30144,7 @@
                 <a:ea typeface="Calibri" pitchFamily="34" charset="-122"/>
                 <a:cs typeface="Calibri" pitchFamily="34" charset="-120"/>
               </a:rPr>
-              <a:t>7× más lento que el mejor frente</a:t>
+              <a:t>8× más lento que el mejor frente</a:t>
             </a:r>
             <a:endParaRPr lang="en-US" sz="1150" dirty="0"/>
           </a:p>
@@ -32348,7 +30483,7 @@
                 <a:ea typeface="Calibri" pitchFamily="34" charset="-122"/>
                 <a:cs typeface="Calibri" pitchFamily="34" charset="-120"/>
               </a:rPr>
-              <a:t>Fuente: Data_NCR24082026.xlsx — hoja «Observaciones» · Corte 24-08-2026 · 501 registros desde 10-02-2023</a:t>
+              <a:t>Fuente: Data_NCR31082026.xlsx — hoja «Observaciones» · Corte 31-08-2026 · 502 registros desde 10-02-2023</a:t>
             </a:r>
             <a:endParaRPr lang="en-US" sz="850" dirty="0"/>
           </a:p>
@@ -32599,7 +30734,7 @@
                 <a:ea typeface="Calibri" pitchFamily="34" charset="-122"/>
                 <a:cs typeface="Calibri" pitchFamily="34" charset="-120"/>
               </a:rPr>
-              <a:t>10.613 UF declaradas entre nov-24 y ago-26, imputadas al mes en que se levantó cada hallazgo. Las declaran 108 de 490 hallazgos del período.</a:t>
+              <a:t>10.613 UF declaradas entre nov-24 y ago-26, imputadas al mes en que se levantó cada hallazgo. Las declaran 108 de 491 hallazgos del período.</a:t>
             </a:r>
             <a:endParaRPr lang="en-US" sz="1350" dirty="0"/>
           </a:p>
@@ -49429,7 +47564,7 @@
                           <a:ea typeface="Calibri" pitchFamily="34" charset="-122"/>
                           <a:cs typeface="Calibri" pitchFamily="34" charset="-120"/>
                         </a:rPr>
-                        <a:t>0/7</a:t>
+                        <a:t>0/8</a:t>
                       </a:r>
                       <a:endParaRPr lang="en-US" sz="750" dirty="0">
                         <a:latin typeface="Calibri" charset="0"/>
@@ -49497,7 +47632,7 @@
                           <a:ea typeface="Calibri" pitchFamily="34" charset="-122"/>
                           <a:cs typeface="Calibri" pitchFamily="34" charset="-120"/>
                         </a:rPr>
-                        <a:t>108/490</a:t>
+                        <a:t>108/491</a:t>
                       </a:r>
                       <a:endParaRPr lang="en-US" sz="750" dirty="0">
                         <a:latin typeface="Calibri" charset="0"/>
@@ -50161,7 +48296,7 @@
                 <a:ea typeface="Cambria" pitchFamily="34" charset="-122"/>
                 <a:cs typeface="Cambria" pitchFamily="34" charset="-120"/>
               </a:rPr>
-              <a:t>250</a:t>
+              <a:t>251</a:t>
             </a:r>
             <a:endParaRPr lang="en-US" sz="2100" dirty="0"/>
           </a:p>
@@ -50278,7 +48413,7 @@
                 <a:ea typeface="Calibri" pitchFamily="34" charset="-122"/>
                 <a:cs typeface="Calibri" pitchFamily="34" charset="-120"/>
               </a:rPr>
-              <a:t>Fuente: Data_NCR24082026.xlsx — hoja «Observaciones» · Corte 24-08-2026 · 501 registros desde 10-02-2023</a:t>
+              <a:t>Fuente: Data_NCR31082026.xlsx — hoja «Observaciones» · Corte 31-08-2026 · 502 registros desde 10-02-2023</a:t>
             </a:r>
             <a:endParaRPr lang="en-US" sz="850" dirty="0"/>
           </a:p>
@@ -50652,7 +48787,7 @@
                 <a:ea typeface="Calibri" pitchFamily="34" charset="-122"/>
                 <a:cs typeface="Calibri" pitchFamily="34" charset="-120"/>
               </a:rPr>
-              <a:t>36 de los 46 hallazgos abiertos (78,3%) y 78% de cierre, contra 90,8% global. Es la ruta crítica del módulo.</a:t>
+              <a:t>32 de los 39 hallazgos abiertos (82,1%) y 80,5% de cierre, contra 92,2% global. Es la ruta crítica del módulo.</a:t>
             </a:r>
             <a:endParaRPr lang="en-US" sz="1100" dirty="0"/>
           </a:p>
@@ -50794,7 +48929,7 @@
                 <a:ea typeface="Calibri" pitchFamily="34" charset="-122"/>
                 <a:cs typeface="Calibri" pitchFamily="34" charset="-120"/>
               </a:rPr>
-              <a:t>Solo 21,1% de sus hallazgos los detecta Besalco; el mejor frente va en 66,7%. Lo que no se detecta adentro llega como observación del cliente.</a:t>
+              <a:t>Solo 21% de sus hallazgos los detecta Besalco; el mejor frente va en 66,7%. Lo que no se detecta adentro llega como observación del cliente.</a:t>
             </a:r>
             <a:endParaRPr lang="en-US" sz="1100" dirty="0"/>
           </a:p>
@@ -50894,7 +49029,7 @@
                 <a:ea typeface="Calibri" pitchFamily="34" charset="-122"/>
                 <a:cs typeface="Calibri" pitchFamily="34" charset="-120"/>
               </a:rPr>
-              <a:t>Sacar los 17 hallazgos sobre 180 días</a:t>
+              <a:t>Sacar los 13 hallazgos sobre 180 días</a:t>
             </a:r>
             <a:endParaRPr lang="en-US" sz="1400" dirty="0"/>
           </a:p>
@@ -50936,7 +49071,7 @@
                 <a:ea typeface="Calibri" pitchFamily="34" charset="-122"/>
                 <a:cs typeface="Calibri" pitchFamily="34" charset="-120"/>
               </a:rPr>
-              <a:t>3 de ellos superan el año abiertos. Los tienen a cargo Sin asignar (17). Es deuda antigua que no se cierra sola.</a:t>
+              <a:t>0 de ellos superan el año abiertos. Los tienen a cargo Sin asignar (13). Es deuda antigua que no se cierra sola.</a:t>
             </a:r>
             <a:endParaRPr lang="en-US" sz="1100" dirty="0"/>
           </a:p>
@@ -51036,7 +49171,7 @@
                 <a:ea typeface="Calibri" pitchFamily="34" charset="-122"/>
                 <a:cs typeface="Calibri" pitchFamily="34" charset="-120"/>
               </a:rPr>
-              <a:t>Responder las 44 que pasaron el plazo</a:t>
+              <a:t>Responder las 38 que pasaron el plazo</a:t>
             </a:r>
             <a:endParaRPr lang="en-US" sz="1400" dirty="0"/>
           </a:p>
@@ -51078,7 +49213,7 @@
                 <a:ea typeface="Calibri" pitchFamily="34" charset="-122"/>
                 <a:cs typeface="Calibri" pitchFamily="34" charset="-120"/>
               </a:rPr>
-              <a:t>El plazo es de 10 días desde la emisión y hoy lo incumplen 95,7% de los abiertos. Solo 2 siguen dentro de plazo.</a:t>
+              <a:t>El plazo es de 10 días desde la emisión y hoy lo incumplen 97,4% de los abiertos. Solo 1 siguen dentro de plazo.</a:t>
             </a:r>
             <a:endParaRPr lang="en-US" sz="1100" dirty="0"/>
           </a:p>
@@ -51117,7 +49252,7 @@
                 <a:ea typeface="Calibri" pitchFamily="34" charset="-122"/>
                 <a:cs typeface="Calibri" pitchFamily="34" charset="-120"/>
               </a:rPr>
-              <a:t>Fuente: Data_NCR24082026.xlsx — hoja «Observaciones» · Corte 24-08-2026 · 501 registros desde 10-02-2023</a:t>
+              <a:t>Fuente: Data_NCR31082026.xlsx — hoja «Observaciones» · Corte 31-08-2026 · 502 registros desde 10-02-2023</a:t>
             </a:r>
             <a:endParaRPr lang="en-US" sz="850" dirty="0"/>
           </a:p>
@@ -51841,7 +49976,7 @@
                 <a:ea typeface="Calibri" pitchFamily="34" charset="-122"/>
                 <a:cs typeface="Calibri" pitchFamily="34" charset="-120"/>
               </a:rPr>
-              <a:t>Corte: 24-08-2026</a:t>
+              <a:t>Corte: 31-08-2026</a:t>
             </a:r>
             <a:endParaRPr lang="en-US" sz="1100" dirty="0"/>
           </a:p>
@@ -51880,7 +50015,7 @@
                 <a:ea typeface="Calibri" pitchFamily="34" charset="-122"/>
                 <a:cs typeface="Calibri" pitchFamily="34" charset="-120"/>
               </a:rPr>
-              <a:t>Fuente: Data_NCR24082026.xlsx — hoja «Observaciones» · Corte 24-08-2026 · 501 registros desde 10-02-2023</a:t>
+              <a:t>Fuente: Data_NCR31082026.xlsx — hoja «Observaciones» · Corte 31-08-2026 · 502 registros desde 10-02-2023</a:t>
             </a:r>
             <a:endParaRPr lang="en-US" sz="850" dirty="0"/>
           </a:p>

</xml_diff>

<commit_message>
No Conformidades al corte 07-09-2026
Semana sin un solo cierre y con siete hallazgos nuevos: las abiertas suben
de 39 a 46 y el cierre cae de 92,2% a 90,8%. Seis de los siete los levanta
MASA en Arqueros el 01-09 —el log del cliente pasa de 71 a 77 registros— y
el séptimo es del cliente en Talabre.

Arqueros retrocede de 80,5% a 77,6% y vuelve a quedar donde estaba hace un
mes. Ninguno de los siete declara costo, así que van 108 registros con monto
contra 258 con la casilla vacía y septiembre arranca en 0/7.

95 comprobaciones OK · suite verificada en 1366/1920/2560.

Co-Authored-By: Claude Opus 5 <noreply@anthropic.com>
Claude-Session: https://claude.ai/code/session_011SHyPcub1TtjA2kTAsaPFu
</commit_message>
<xml_diff>
--- a/modulo_nc/Panel_No_Conformidades.pptx
+++ b/modulo_nc/Panel_No_Conformidades.pptx
@@ -220,19 +220,19 @@
                     <c:v>3 sem.</c:v>
                   </c:pt>
                   <c:pt idx="1">
-                    <c:v>27-07</c:v>
+                    <c:v>03-08</c:v>
                   </c:pt>
                   <c:pt idx="2">
-                    <c:v>03-08</c:v>
+                    <c:v>10-08</c:v>
                   </c:pt>
                   <c:pt idx="3">
-                    <c:v>10-08</c:v>
+                    <c:v>17-08</c:v>
                   </c:pt>
                   <c:pt idx="4">
-                    <c:v>17-08</c:v>
+                    <c:v>24-08</c:v>
                   </c:pt>
                   <c:pt idx="5">
-                    <c:v>24-08</c:v>
+                    <c:v>31-08</c:v>
                   </c:pt>
                 </c:lvl>
               </c:multiLvlStrCache>
@@ -245,22 +245,22 @@
                 <c:formatCode>General</c:formatCode>
                 <c:ptCount val="6"/>
                 <c:pt idx="0">
-                  <c:v/>
+                  <c:v>2</c:v>
                 </c:pt>
                 <c:pt idx="1">
-                  <c:v>2</c:v>
+                  <c:v/>
                 </c:pt>
                 <c:pt idx="2">
                   <c:v/>
                 </c:pt>
                 <c:pt idx="3">
-                  <c:v/>
+                  <c:v>2</c:v>
                 </c:pt>
                 <c:pt idx="4">
-                  <c:v>2</c:v>
+                  <c:v>1</c:v>
                 </c:pt>
                 <c:pt idx="5">
-                  <c:v>1</c:v>
+                  <c:v>7</c:v>
                 </c:pt>
               </c:numCache>
             </c:numRef>
@@ -322,19 +322,19 @@
                     <c:v>3 sem.</c:v>
                   </c:pt>
                   <c:pt idx="1">
-                    <c:v>27-07</c:v>
+                    <c:v>03-08</c:v>
                   </c:pt>
                   <c:pt idx="2">
-                    <c:v>03-08</c:v>
+                    <c:v>10-08</c:v>
                   </c:pt>
                   <c:pt idx="3">
-                    <c:v>10-08</c:v>
+                    <c:v>17-08</c:v>
                   </c:pt>
                   <c:pt idx="4">
-                    <c:v>17-08</c:v>
+                    <c:v>24-08</c:v>
                   </c:pt>
                   <c:pt idx="5">
-                    <c:v>24-08</c:v>
+                    <c:v>31-08</c:v>
                   </c:pt>
                 </c:lvl>
               </c:multiLvlStrCache>
@@ -347,19 +347,19 @@
                 <c:formatCode>General</c:formatCode>
                 <c:ptCount val="6"/>
                 <c:pt idx="0">
-                  <c:v>4</c:v>
+                  <c:v>5</c:v>
                 </c:pt>
                 <c:pt idx="1">
-                  <c:v>2</c:v>
+                  <c:v>1</c:v>
                 </c:pt>
                 <c:pt idx="2">
+                  <c:v>3</c:v>
+                </c:pt>
+                <c:pt idx="3">
                   <c:v>1</c:v>
                 </c:pt>
-                <c:pt idx="3">
-                  <c:v>3</c:v>
-                </c:pt>
                 <c:pt idx="4">
-                  <c:v>1</c:v>
+                  <c:v/>
                 </c:pt>
                 <c:pt idx="5">
                   <c:v/>
@@ -734,10 +734,10 @@
                   <c:v>19</c:v>
                 </c:pt>
                 <c:pt idx="1">
-                  <c:v>196</c:v>
+                  <c:v>197</c:v>
                 </c:pt>
                 <c:pt idx="2">
-                  <c:v>71</c:v>
+                  <c:v>77</c:v>
                 </c:pt>
                 <c:pt idx="3">
                   <c:v/>
@@ -1289,7 +1289,7 @@
                 <c:formatCode>General</c:formatCode>
                 <c:ptCount val="4"/>
                 <c:pt idx="0">
-                  <c:v>26</c:v>
+                  <c:v>33</c:v>
                 </c:pt>
                 <c:pt idx="1">
                   <c:v>2</c:v>
@@ -1487,7 +1487,7 @@
                 </a:solidFill>
                 <a:latin typeface="Calibri"/>
               </a:rPr>
-              <a:t>Antigüedad de los 39 hallazgos abiertos</a:t>
+              <a:t>Antigüedad de los 46 hallazgos abiertos</a:t>
             </a:r>
           </a:p>
         </c:rich>
@@ -1568,7 +1568,7 @@
                 <c:formatCode>General</c:formatCode>
                 <c:ptCount val="1"/>
                 <c:pt idx="0">
-                  <c:v>3</c:v>
+                  <c:v>10</c:v>
                 </c:pt>
               </c:numCache>
             </c:numRef>
@@ -1640,7 +1640,7 @@
                 <c:formatCode>General</c:formatCode>
                 <c:ptCount val="1"/>
                 <c:pt idx="0">
-                  <c:v>6</c:v>
+                  <c:v>4</c:v>
                 </c:pt>
               </c:numCache>
             </c:numRef>
@@ -1712,7 +1712,7 @@
                 <c:formatCode>General</c:formatCode>
                 <c:ptCount val="1"/>
                 <c:pt idx="0">
-                  <c:v>17</c:v>
+                  <c:v>15</c:v>
                 </c:pt>
               </c:numCache>
             </c:numRef>
@@ -1784,7 +1784,7 @@
                 <c:formatCode>General</c:formatCode>
                 <c:ptCount val="1"/>
                 <c:pt idx="0">
-                  <c:v>13</c:v>
+                  <c:v>17</c:v>
                 </c:pt>
               </c:numCache>
             </c:numRef>
@@ -2615,7 +2615,7 @@
                 <c:formatCode>General</c:formatCode>
                 <c:ptCount val="8"/>
                 <c:pt idx="0">
-                  <c:v>4</c:v>
+                  <c:v>5</c:v>
                 </c:pt>
                 <c:pt idx="1">
                   <c:v>1</c:v>
@@ -3041,7 +3041,7 @@
                 <c:formatCode>General</c:formatCode>
                 <c:ptCount val="8"/>
                 <c:pt idx="0">
-                  <c:v>31</c:v>
+                  <c:v>37</c:v>
                 </c:pt>
                 <c:pt idx="1">
                   <c:v/>
@@ -5638,7 +5638,7 @@
                 <a:ea typeface="Calibri" pitchFamily="34" charset="-122"/>
                 <a:cs typeface="Calibri" pitchFamily="34" charset="-120"/>
               </a:rPr>
-              <a:t>502 hallazgos levantados entre 10-02-2023 y 24-08-2026 (Desaladora 82 · Talabre 248 · Arqueros 164 · Oficina Central 8).</a:t>
+              <a:t>509 hallazgos levantados entre 10-02-2023 y 03-09-2026 (Desaladora 82 · Talabre 249 · Arqueros 170 · Oficina Central 8).</a:t>
             </a:r>
             <a:endParaRPr lang="en-US" sz="1350" dirty="0"/>
           </a:p>
@@ -5697,7 +5697,7 @@
                 <a:ea typeface="Cambria" pitchFamily="34" charset="-122"/>
                 <a:cs typeface="Cambria" pitchFamily="34" charset="-120"/>
               </a:rPr>
-              <a:t>92,2%</a:t>
+              <a:t>91%</a:t>
             </a:r>
             <a:endParaRPr lang="en-US" sz="3400" dirty="0"/>
           </a:p>
@@ -5775,7 +5775,7 @@
                 <a:ea typeface="Cambria" pitchFamily="34" charset="-122"/>
                 <a:cs typeface="Cambria" pitchFamily="34" charset="-120"/>
               </a:rPr>
-              <a:t>39</a:t>
+              <a:t>46</a:t>
             </a:r>
             <a:endParaRPr lang="en-US" sz="3400" dirty="0"/>
           </a:p>
@@ -6009,7 +6009,7 @@
                 <a:ea typeface="Calibri" pitchFamily="34" charset="-122"/>
                 <a:cs typeface="Calibri" pitchFamily="34" charset="-120"/>
               </a:rPr>
-              <a:t>Corte: 31-08-2026</a:t>
+              <a:t>Corte: 07-09-2026</a:t>
             </a:r>
             <a:endParaRPr lang="en-US" sz="1100" dirty="0"/>
           </a:p>
@@ -6048,7 +6048,7 @@
                 <a:ea typeface="Calibri" pitchFamily="34" charset="-122"/>
                 <a:cs typeface="Calibri" pitchFamily="34" charset="-120"/>
               </a:rPr>
-              <a:t>Fuente: Data_NCR31082026.xlsx — hoja «Observaciones» · Corte 31-08-2026 · 502 registros desde 10-02-2023</a:t>
+              <a:t>Fuente: Data_NCR07092026.xlsx — hoja «Observaciones» · Corte 07-09-2026 · 509 registros desde 10-02-2023</a:t>
             </a:r>
             <a:endParaRPr lang="en-US" sz="850" dirty="0"/>
           </a:p>
@@ -6641,7 +6641,7 @@
                 <a:ea typeface="Calibri" pitchFamily="34" charset="-122"/>
                 <a:cs typeface="Calibri" pitchFamily="34" charset="-120"/>
               </a:rPr>
-              <a:t>Global del módulo: 92,2%</a:t>
+              <a:t>Global del módulo: 91%</a:t>
             </a:r>
             <a:endParaRPr lang="en-US" sz="950" dirty="0"/>
           </a:p>
@@ -7239,7 +7239,7 @@
                 <a:ea typeface="Calibri" pitchFamily="34" charset="-122"/>
                 <a:cs typeface="Calibri" pitchFamily="34" charset="-120"/>
               </a:rPr>
-              <a:t>global del módulo 32,3%</a:t>
+              <a:t>global del módulo 31,8%</a:t>
             </a:r>
             <a:endParaRPr lang="en-US" sz="1000" dirty="0"/>
           </a:p>
@@ -7849,7 +7849,7 @@
                 <a:ea typeface="Calibri" pitchFamily="34" charset="-122"/>
                 <a:cs typeface="Calibri" pitchFamily="34" charset="-120"/>
               </a:rPr>
-              <a:t>Fuente: Data_NCR31082026.xlsx — hoja «Observaciones» · Corte 31-08-2026 · 502 registros desde 10-02-2023</a:t>
+              <a:t>Fuente: Data_NCR07092026.xlsx — hoja «Observaciones» · Corte 07-09-2026 · 509 registros desde 10-02-2023</a:t>
             </a:r>
             <a:endParaRPr lang="en-US" sz="850" dirty="0"/>
           </a:p>
@@ -8708,7 +8708,7 @@
                 <a:ea typeface="Calibri" pitchFamily="34" charset="-122"/>
                 <a:cs typeface="Calibri" pitchFamily="34" charset="-120"/>
               </a:rPr>
-              <a:t>111</a:t>
+              <a:t>118</a:t>
             </a:r>
             <a:endParaRPr lang="en-US" sz="1050" dirty="0"/>
           </a:p>
@@ -8831,7 +8831,7 @@
                 <a:ea typeface="Calibri" pitchFamily="34" charset="-122"/>
                 <a:cs typeface="Calibri" pitchFamily="34" charset="-120"/>
               </a:rPr>
-              <a:t>SEMANA 24-08-2026 — 30-08-2026</a:t>
+              <a:t>SEMANA 31-08-2026 — 06-09-2026</a:t>
             </a:r>
             <a:endParaRPr lang="en-US" sz="1000" dirty="0"/>
           </a:p>
@@ -8909,7 +8909,7 @@
                 <a:ea typeface="Calibri" pitchFamily="34" charset="-122"/>
                 <a:cs typeface="Calibri" pitchFamily="34" charset="-120"/>
               </a:rPr>
-              <a:t>Fuente: Data_NCR31082026.xlsx — hoja «Observaciones» · Corte 31-08-2026 · 502 registros desde 10-02-2023</a:t>
+              <a:t>Fuente: Data_NCR07092026.xlsx — hoja «Observaciones» · Corte 07-09-2026 · 509 registros desde 10-02-2023</a:t>
             </a:r>
             <a:endParaRPr lang="en-US" sz="850" dirty="0"/>
           </a:p>
@@ -9262,7 +9262,7 @@
                 <a:ea typeface="Calibri" pitchFamily="34" charset="-122"/>
                 <a:cs typeface="Calibri" pitchFamily="34" charset="-120"/>
               </a:rPr>
-              <a:t>248 hallazgos levantados · 52 internas · 196 del cliente · 12 especialidades involucradas.</a:t>
+              <a:t>249 hallazgos levantados · 52 internas · 197 del cliente · 12 especialidades involucradas.</a:t>
             </a:r>
             <a:endParaRPr lang="en-US" sz="1350" dirty="0"/>
           </a:p>
@@ -9321,7 +9321,7 @@
                 <a:ea typeface="Cambria" pitchFamily="34" charset="-122"/>
                 <a:cs typeface="Cambria" pitchFamily="34" charset="-120"/>
               </a:rPr>
-              <a:t>97,6%</a:t>
+              <a:t>97,2%</a:t>
             </a:r>
             <a:endParaRPr lang="en-US" sz="3400" dirty="0"/>
           </a:p>
@@ -9399,7 +9399,7 @@
                 <a:ea typeface="Cambria" pitchFamily="34" charset="-122"/>
                 <a:cs typeface="Cambria" pitchFamily="34" charset="-120"/>
               </a:rPr>
-              <a:t>6</a:t>
+              <a:t>7</a:t>
             </a:r>
             <a:endParaRPr lang="en-US" sz="3400" dirty="0"/>
           </a:p>
@@ -9555,7 +9555,7 @@
                 <a:ea typeface="Cambria" pitchFamily="34" charset="-122"/>
                 <a:cs typeface="Cambria" pitchFamily="34" charset="-120"/>
               </a:rPr>
-              <a:t>21%</a:t>
+              <a:t>20,9%</a:t>
             </a:r>
             <a:endParaRPr lang="en-US" sz="3400" dirty="0"/>
           </a:p>
@@ -9633,7 +9633,7 @@
                 <a:ea typeface="Calibri" pitchFamily="34" charset="-122"/>
                 <a:cs typeface="Calibri" pitchFamily="34" charset="-120"/>
               </a:rPr>
-              <a:t>Corte: 31-08-2026</a:t>
+              <a:t>Corte: 07-09-2026</a:t>
             </a:r>
             <a:endParaRPr lang="en-US" sz="1100" dirty="0"/>
           </a:p>
@@ -9672,7 +9672,7 @@
                 <a:ea typeface="Calibri" pitchFamily="34" charset="-122"/>
                 <a:cs typeface="Calibri" pitchFamily="34" charset="-120"/>
               </a:rPr>
-              <a:t>Fuente: Data_NCR31082026.xlsx — hoja «Observaciones» · Corte 31-08-2026 · 502 registros desde 10-02-2023</a:t>
+              <a:t>Fuente: Data_NCR07092026.xlsx — hoja «Observaciones» · Corte 07-09-2026 · 509 registros desde 10-02-2023</a:t>
             </a:r>
             <a:endParaRPr lang="en-US" sz="850" dirty="0"/>
           </a:p>
@@ -9938,7 +9938,7 @@
                 <a:ea typeface="Cambria" pitchFamily="34" charset="-122"/>
                 <a:cs typeface="Cambria" pitchFamily="34" charset="-120"/>
               </a:rPr>
-              <a:t>248</a:t>
+              <a:t>249</a:t>
             </a:r>
             <a:endParaRPr lang="en-US" sz="4000" dirty="0"/>
           </a:p>
@@ -10055,7 +10055,7 @@
                 <a:ea typeface="Calibri" pitchFamily="34" charset="-122"/>
                 <a:cs typeface="Calibri" pitchFamily="34" charset="-120"/>
               </a:rPr>
-              <a:t>52 internas · 196 del cliente</a:t>
+              <a:t>52 internas · 197 del cliente</a:t>
             </a:r>
             <a:endParaRPr lang="en-US" sz="950" dirty="0"/>
           </a:p>
@@ -10148,7 +10148,7 @@
                 <a:ea typeface="Cambria" pitchFamily="34" charset="-122"/>
                 <a:cs typeface="Cambria" pitchFamily="34" charset="-120"/>
               </a:rPr>
-              <a:t>97,6%</a:t>
+              <a:t>97,2%</a:t>
             </a:r>
             <a:endParaRPr lang="en-US" sz="4000" dirty="0"/>
           </a:p>
@@ -10187,7 +10187,7 @@
                 <a:ea typeface="Calibri" pitchFamily="34" charset="-122"/>
                 <a:cs typeface="Calibri" pitchFamily="34" charset="-120"/>
               </a:rPr>
-              <a:t>242/248</a:t>
+              <a:t>242/249</a:t>
             </a:r>
             <a:endParaRPr lang="en-US" sz="1400" dirty="0"/>
           </a:p>
@@ -10265,7 +10265,7 @@
                 <a:ea typeface="Calibri" pitchFamily="34" charset="-122"/>
                 <a:cs typeface="Calibri" pitchFamily="34" charset="-120"/>
               </a:rPr>
-              <a:t>Global del módulo: 92,2%</a:t>
+              <a:t>Global del módulo: 91%</a:t>
             </a:r>
             <a:endParaRPr lang="en-US" sz="950" dirty="0"/>
           </a:p>
@@ -10358,7 +10358,7 @@
                 <a:ea typeface="Cambria" pitchFamily="34" charset="-122"/>
                 <a:cs typeface="Cambria" pitchFamily="34" charset="-120"/>
               </a:rPr>
-              <a:t>6</a:t>
+              <a:t>7</a:t>
             </a:r>
             <a:endParaRPr lang="en-US" sz="4000" dirty="0"/>
           </a:p>
@@ -10475,7 +10475,7 @@
                 <a:ea typeface="Calibri" pitchFamily="34" charset="-122"/>
                 <a:cs typeface="Calibri" pitchFamily="34" charset="-120"/>
               </a:rPr>
-              <a:t>5 iniciado · 1 listo para revisión</a:t>
+              <a:t>6 iniciado · 1 listo para revisión</a:t>
             </a:r>
             <a:endParaRPr lang="en-US" sz="950" dirty="0"/>
           </a:p>
@@ -10801,7 +10801,7 @@
                 <a:ea typeface="Cambria" pitchFamily="34" charset="-122"/>
                 <a:cs typeface="Cambria" pitchFamily="34" charset="-120"/>
               </a:rPr>
-              <a:t>21%</a:t>
+              <a:t>20,9%</a:t>
             </a:r>
             <a:endParaRPr lang="en-US" sz="2600" dirty="0"/>
           </a:p>
@@ -10863,7 +10863,7 @@
                 <a:ea typeface="Calibri" pitchFamily="34" charset="-122"/>
                 <a:cs typeface="Calibri" pitchFamily="34" charset="-120"/>
               </a:rPr>
-              <a:t>global del módulo 32,3%</a:t>
+              <a:t>global del módulo 31,8%</a:t>
             </a:r>
             <a:endParaRPr lang="en-US" sz="1000" dirty="0"/>
           </a:p>
@@ -11121,7 +11121,7 @@
                 <a:ea typeface="Calibri" pitchFamily="34" charset="-122"/>
                 <a:cs typeface="Calibri" pitchFamily="34" charset="-120"/>
               </a:rPr>
-              <a:t>6 ab.</a:t>
+              <a:t>7 ab.</a:t>
             </a:r>
             <a:endParaRPr lang="en-US" sz="950" dirty="0"/>
           </a:p>
@@ -11160,7 +11160,7 @@
                 <a:ea typeface="Cambria" pitchFamily="34" charset="-122"/>
                 <a:cs typeface="Cambria" pitchFamily="34" charset="-120"/>
               </a:rPr>
-              <a:t>196</a:t>
+              <a:t>197</a:t>
             </a:r>
             <a:endParaRPr lang="en-US" sz="1600" dirty="0"/>
           </a:p>
@@ -11199,7 +11199,7 @@
                 <a:ea typeface="Calibri" pitchFamily="34" charset="-122"/>
                 <a:cs typeface="Calibri" pitchFamily="34" charset="-120"/>
               </a:rPr>
-              <a:t>Fuente: Data_NCR31082026.xlsx — hoja «Observaciones» · Corte 31-08-2026 · 502 registros desde 10-02-2023</a:t>
+              <a:t>Fuente: Data_NCR07092026.xlsx — hoja «Observaciones» · Corte 07-09-2026 · 509 registros desde 10-02-2023</a:t>
             </a:r>
             <a:endParaRPr lang="en-US" sz="850" dirty="0"/>
           </a:p>
@@ -11450,7 +11450,7 @@
                 <a:ea typeface="Calibri" pitchFamily="34" charset="-122"/>
                 <a:cs typeface="Calibri" pitchFamily="34" charset="-120"/>
               </a:rPr>
-              <a:t>6 hallazgos siguen abiertos; 0 con más de 180 días. Se listan del más antiguo al más reciente.</a:t>
+              <a:t>7 hallazgos siguen abiertos; 0 con más de 180 días. Se listan del más antiguo al más reciente.</a:t>
             </a:r>
             <a:endParaRPr lang="en-US" sz="1350" dirty="0"/>
           </a:p>
@@ -12058,7 +12058,7 @@
                 <a:ea typeface="Calibri" pitchFamily="34" charset="-122"/>
                 <a:cs typeface="Calibri" pitchFamily="34" charset="-120"/>
               </a:rPr>
-              <a:t>161</a:t>
+              <a:t>168</a:t>
             </a:r>
             <a:endParaRPr lang="en-US" sz="1050" dirty="0"/>
           </a:p>
@@ -12413,7 +12413,7 @@
                 <a:ea typeface="Calibri" pitchFamily="34" charset="-122"/>
                 <a:cs typeface="Calibri" pitchFamily="34" charset="-120"/>
               </a:rPr>
-              <a:t>62</a:t>
+              <a:t>69</a:t>
             </a:r>
             <a:endParaRPr lang="en-US" sz="1050" dirty="0"/>
           </a:p>
@@ -12748,7 +12748,7 @@
                 <a:ea typeface="Calibri" pitchFamily="34" charset="-122"/>
                 <a:cs typeface="Calibri" pitchFamily="34" charset="-120"/>
               </a:rPr>
-              <a:t>34</a:t>
+              <a:t>41</a:t>
             </a:r>
             <a:endParaRPr lang="en-US" sz="1050" dirty="0"/>
           </a:p>
@@ -13103,7 +13103,7 @@
                 <a:ea typeface="Calibri" pitchFamily="34" charset="-122"/>
                 <a:cs typeface="Calibri" pitchFamily="34" charset="-120"/>
               </a:rPr>
-              <a:t>12</a:t>
+              <a:t>19</a:t>
             </a:r>
             <a:endParaRPr lang="en-US" sz="1050" dirty="0"/>
           </a:p>
@@ -13438,7 +13438,7 @@
                 <a:ea typeface="Calibri" pitchFamily="34" charset="-122"/>
                 <a:cs typeface="Calibri" pitchFamily="34" charset="-120"/>
               </a:rPr>
-              <a:t>12</a:t>
+              <a:t>19</a:t>
             </a:r>
             <a:endParaRPr lang="en-US" sz="1050" dirty="0"/>
           </a:p>
@@ -13793,7 +13793,7 @@
                 <a:ea typeface="Calibri" pitchFamily="34" charset="-122"/>
                 <a:cs typeface="Calibri" pitchFamily="34" charset="-120"/>
               </a:rPr>
-              <a:t>7</a:t>
+              <a:t>14</a:t>
             </a:r>
             <a:endParaRPr lang="en-US" sz="1050" dirty="0"/>
           </a:p>
@@ -13863,7 +13863,342 @@
       </p:sp>
       <p:sp>
         <p:nvSpPr>
-          <p:cNvPr id="72" name="Shape 69"/>
+          <p:cNvPr id="72" name="Text 69"/>
+          <p:cNvSpPr/>
+          <p:nvPr/>
+        </p:nvSpPr>
+        <p:spPr>
+          <a:xfrm>
+            <a:off x="502920" y="4398264"/>
+            <a:ext cx="822960" cy="256032"/>
+          </a:xfrm>
+          <a:prstGeom prst="rect">
+            <a:avLst/>
+          </a:prstGeom>
+          <a:noFill/>
+          <a:ln/>
+        </p:spPr>
+        <p:txBody>
+          <a:bodyPr wrap="square" lIns="0" tIns="0" rIns="0" bIns="0" rtlCol="0" anchor="ctr"/>
+          <a:lstStyle/>
+          <a:p>
+            <a:pPr algn="l" indent="0" marL="0">
+              <a:buNone/>
+            </a:pPr>
+            <a:r>
+              <a:rPr lang="en-US" sz="1050" dirty="0">
+                <a:solidFill>
+                  <a:srgbClr val="1A2433"/>
+                </a:solidFill>
+                <a:latin typeface="Calibri" pitchFamily="34" charset="0"/>
+                <a:ea typeface="Calibri" pitchFamily="34" charset="-122"/>
+                <a:cs typeface="Calibri" pitchFamily="34" charset="-120"/>
+              </a:rPr>
+              <a:t>250</a:t>
+            </a:r>
+            <a:endParaRPr lang="en-US" sz="1050" dirty="0"/>
+          </a:p>
+        </p:txBody>
+      </p:sp>
+      <p:sp>
+        <p:nvSpPr>
+          <p:cNvPr id="73" name="Text 70"/>
+          <p:cNvSpPr/>
+          <p:nvPr/>
+        </p:nvSpPr>
+        <p:spPr>
+          <a:xfrm>
+            <a:off x="1371600" y="4398264"/>
+            <a:ext cx="1508760" cy="256032"/>
+          </a:xfrm>
+          <a:prstGeom prst="rect">
+            <a:avLst/>
+          </a:prstGeom>
+          <a:noFill/>
+          <a:ln/>
+        </p:spPr>
+        <p:txBody>
+          <a:bodyPr wrap="square" lIns="0" tIns="0" rIns="0" bIns="0" rtlCol="0" anchor="ctr"/>
+          <a:lstStyle/>
+          <a:p>
+            <a:pPr algn="l" indent="0" marL="0">
+              <a:buNone/>
+            </a:pPr>
+            <a:r>
+              <a:rPr lang="en-US" sz="1050" dirty="0">
+                <a:solidFill>
+                  <a:srgbClr val="1A2433"/>
+                </a:solidFill>
+                <a:latin typeface="Calibri" pitchFamily="34" charset="0"/>
+                <a:ea typeface="Calibri" pitchFamily="34" charset="-122"/>
+                <a:cs typeface="Calibri" pitchFamily="34" charset="-120"/>
+              </a:rPr>
+              <a:t>No Conformidad</a:t>
+            </a:r>
+            <a:endParaRPr lang="en-US" sz="1050" dirty="0"/>
+          </a:p>
+        </p:txBody>
+      </p:sp>
+      <p:sp>
+        <p:nvSpPr>
+          <p:cNvPr id="74" name="Text 71"/>
+          <p:cNvSpPr/>
+          <p:nvPr/>
+        </p:nvSpPr>
+        <p:spPr>
+          <a:xfrm>
+            <a:off x="2926080" y="4398264"/>
+            <a:ext cx="1463040" cy="256032"/>
+          </a:xfrm>
+          <a:prstGeom prst="rect">
+            <a:avLst/>
+          </a:prstGeom>
+          <a:noFill/>
+          <a:ln/>
+        </p:spPr>
+        <p:txBody>
+          <a:bodyPr wrap="square" lIns="0" tIns="0" rIns="0" bIns="0" rtlCol="0" anchor="ctr"/>
+          <a:lstStyle/>
+          <a:p>
+            <a:pPr algn="l" indent="0" marL="0">
+              <a:buNone/>
+            </a:pPr>
+            <a:r>
+              <a:rPr lang="en-US" sz="1050" b="1" dirty="0">
+                <a:solidFill>
+                  <a:srgbClr val="C87A32"/>
+                </a:solidFill>
+                <a:latin typeface="Calibri" pitchFamily="34" charset="0"/>
+                <a:ea typeface="Calibri" pitchFamily="34" charset="-122"/>
+                <a:cs typeface="Calibri" pitchFamily="34" charset="-120"/>
+              </a:rPr>
+              <a:t>Externa · Cliente</a:t>
+            </a:r>
+            <a:endParaRPr lang="en-US" sz="1050" dirty="0"/>
+          </a:p>
+        </p:txBody>
+      </p:sp>
+      <p:sp>
+        <p:nvSpPr>
+          <p:cNvPr id="75" name="Text 72"/>
+          <p:cNvSpPr/>
+          <p:nvPr/>
+        </p:nvSpPr>
+        <p:spPr>
+          <a:xfrm>
+            <a:off x="4434840" y="4398264"/>
+            <a:ext cx="1280160" cy="256032"/>
+          </a:xfrm>
+          <a:prstGeom prst="rect">
+            <a:avLst/>
+          </a:prstGeom>
+          <a:noFill/>
+          <a:ln/>
+        </p:spPr>
+        <p:txBody>
+          <a:bodyPr wrap="square" lIns="0" tIns="0" rIns="0" bIns="0" rtlCol="0" anchor="ctr"/>
+          <a:lstStyle/>
+          <a:p>
+            <a:pPr algn="l" indent="0" marL="0">
+              <a:buNone/>
+            </a:pPr>
+            <a:r>
+              <a:rPr lang="en-US" sz="1050" dirty="0">
+                <a:solidFill>
+                  <a:srgbClr val="1A2433"/>
+                </a:solidFill>
+                <a:latin typeface="Calibri" pitchFamily="34" charset="0"/>
+                <a:ea typeface="Calibri" pitchFamily="34" charset="-122"/>
+                <a:cs typeface="Calibri" pitchFamily="34" charset="-120"/>
+              </a:rPr>
+              <a:t>OO.CC</a:t>
+            </a:r>
+            <a:endParaRPr lang="en-US" sz="1050" dirty="0"/>
+          </a:p>
+        </p:txBody>
+      </p:sp>
+      <p:sp>
+        <p:nvSpPr>
+          <p:cNvPr id="76" name="Text 73"/>
+          <p:cNvSpPr/>
+          <p:nvPr/>
+        </p:nvSpPr>
+        <p:spPr>
+          <a:xfrm>
+            <a:off x="5760720" y="4398264"/>
+            <a:ext cx="1508760" cy="256032"/>
+          </a:xfrm>
+          <a:prstGeom prst="rect">
+            <a:avLst/>
+          </a:prstGeom>
+          <a:noFill/>
+          <a:ln/>
+        </p:spPr>
+        <p:txBody>
+          <a:bodyPr wrap="square" lIns="0" tIns="0" rIns="0" bIns="0" rtlCol="0" anchor="ctr"/>
+          <a:lstStyle/>
+          <a:p>
+            <a:pPr algn="l" indent="0" marL="0">
+              <a:buNone/>
+            </a:pPr>
+            <a:r>
+              <a:rPr lang="en-US" sz="1050" dirty="0">
+                <a:solidFill>
+                  <a:srgbClr val="1A2433"/>
+                </a:solidFill>
+                <a:latin typeface="Calibri" pitchFamily="34" charset="0"/>
+                <a:ea typeface="Calibri" pitchFamily="34" charset="-122"/>
+                <a:cs typeface="Calibri" pitchFamily="34" charset="-120"/>
+              </a:rPr>
+              <a:t>Daniel Ramirez B.</a:t>
+            </a:r>
+            <a:endParaRPr lang="en-US" sz="1050" dirty="0"/>
+          </a:p>
+        </p:txBody>
+      </p:sp>
+      <p:sp>
+        <p:nvSpPr>
+          <p:cNvPr id="77" name="Text 74"/>
+          <p:cNvSpPr/>
+          <p:nvPr/>
+        </p:nvSpPr>
+        <p:spPr>
+          <a:xfrm>
+            <a:off x="7315200" y="4398264"/>
+            <a:ext cx="1325880" cy="256032"/>
+          </a:xfrm>
+          <a:prstGeom prst="rect">
+            <a:avLst/>
+          </a:prstGeom>
+          <a:noFill/>
+          <a:ln/>
+        </p:spPr>
+        <p:txBody>
+          <a:bodyPr wrap="square" lIns="0" tIns="0" rIns="0" bIns="0" rtlCol="0" anchor="ctr"/>
+          <a:lstStyle/>
+          <a:p>
+            <a:pPr algn="l" indent="0" marL="0">
+              <a:buNone/>
+            </a:pPr>
+            <a:r>
+              <a:rPr lang="en-US" sz="1050" dirty="0">
+                <a:solidFill>
+                  <a:srgbClr val="1A2433"/>
+                </a:solidFill>
+                <a:latin typeface="Calibri" pitchFamily="34" charset="0"/>
+                <a:ea typeface="Calibri" pitchFamily="34" charset="-122"/>
+                <a:cs typeface="Calibri" pitchFamily="34" charset="-120"/>
+              </a:rPr>
+              <a:t>Iniciado</a:t>
+            </a:r>
+            <a:endParaRPr lang="en-US" sz="1050" dirty="0"/>
+          </a:p>
+        </p:txBody>
+      </p:sp>
+      <p:sp>
+        <p:nvSpPr>
+          <p:cNvPr id="78" name="Text 75"/>
+          <p:cNvSpPr/>
+          <p:nvPr/>
+        </p:nvSpPr>
+        <p:spPr>
+          <a:xfrm>
+            <a:off x="8686800" y="4398264"/>
+            <a:ext cx="640080" cy="256032"/>
+          </a:xfrm>
+          <a:prstGeom prst="rect">
+            <a:avLst/>
+          </a:prstGeom>
+          <a:noFill/>
+          <a:ln/>
+        </p:spPr>
+        <p:txBody>
+          <a:bodyPr wrap="square" lIns="0" tIns="0" rIns="0" bIns="0" rtlCol="0" anchor="ctr"/>
+          <a:lstStyle/>
+          <a:p>
+            <a:pPr algn="r" indent="0" marL="0">
+              <a:buNone/>
+            </a:pPr>
+            <a:r>
+              <a:rPr lang="en-US" sz="1050" dirty="0">
+                <a:solidFill>
+                  <a:srgbClr val="1A2433"/>
+                </a:solidFill>
+                <a:latin typeface="Calibri" pitchFamily="34" charset="0"/>
+                <a:ea typeface="Calibri" pitchFamily="34" charset="-122"/>
+                <a:cs typeface="Calibri" pitchFamily="34" charset="-120"/>
+              </a:rPr>
+              <a:t>4</a:t>
+            </a:r>
+            <a:endParaRPr lang="en-US" sz="1050" dirty="0"/>
+          </a:p>
+        </p:txBody>
+      </p:sp>
+      <p:sp>
+        <p:nvSpPr>
+          <p:cNvPr id="79" name="Text 76"/>
+          <p:cNvSpPr/>
+          <p:nvPr/>
+        </p:nvSpPr>
+        <p:spPr>
+          <a:xfrm>
+            <a:off x="9464040" y="4398264"/>
+            <a:ext cx="2286000" cy="256032"/>
+          </a:xfrm>
+          <a:prstGeom prst="rect">
+            <a:avLst/>
+          </a:prstGeom>
+          <a:noFill/>
+          <a:ln/>
+        </p:spPr>
+        <p:txBody>
+          <a:bodyPr wrap="square" lIns="0" tIns="0" rIns="0" bIns="0" rtlCol="0" anchor="ctr"/>
+          <a:lstStyle/>
+          <a:p>
+            <a:pPr algn="l" indent="0" marL="0">
+              <a:buNone/>
+            </a:pPr>
+            <a:r>
+              <a:rPr lang="en-US" sz="1000" dirty="0">
+                <a:solidFill>
+                  <a:srgbClr val="1A2433"/>
+                </a:solidFill>
+                <a:latin typeface="Calibri" pitchFamily="34" charset="0"/>
+                <a:ea typeface="Calibri" pitchFamily="34" charset="-122"/>
+                <a:cs typeface="Calibri" pitchFamily="34" charset="-120"/>
+              </a:rPr>
+              <a:t>Determinadas actas de liberación y …</a:t>
+            </a:r>
+            <a:endParaRPr lang="en-US" sz="1000" dirty="0"/>
+          </a:p>
+        </p:txBody>
+      </p:sp>
+      <p:sp>
+        <p:nvSpPr>
+          <p:cNvPr id="80" name="Shape 77"/>
+          <p:cNvSpPr/>
+          <p:nvPr/>
+        </p:nvSpPr>
+        <p:spPr>
+          <a:xfrm>
+            <a:off x="502920" y="4690872"/>
+            <a:ext cx="11247120" cy="0"/>
+          </a:xfrm>
+          <a:prstGeom prst="line">
+            <a:avLst/>
+          </a:prstGeom>
+          <a:noFill/>
+          <a:ln w="9525">
+            <a:solidFill>
+              <a:srgbClr val="D9DFE6"/>
+            </a:solidFill>
+            <a:prstDash val="solid"/>
+          </a:ln>
+        </p:spPr>
+      </p:sp>
+      <p:sp>
+        <p:nvSpPr>
+          <p:cNvPr id="81" name="Shape 78"/>
           <p:cNvSpPr/>
           <p:nvPr/>
         </p:nvSpPr>
@@ -13885,7 +14220,7 @@
       </p:sp>
       <p:sp>
         <p:nvSpPr>
-          <p:cNvPr id="73" name="Text 70"/>
+          <p:cNvPr id="82" name="Text 79"/>
           <p:cNvSpPr/>
           <p:nvPr/>
         </p:nvSpPr>
@@ -13916,7 +14251,7 @@
                 <a:ea typeface="Calibri" pitchFamily="34" charset="-122"/>
                 <a:cs typeface="Calibri" pitchFamily="34" charset="-120"/>
               </a:rPr>
-              <a:t>SEMANA 24-08-2026 — 30-08-2026</a:t>
+              <a:t>SEMANA 31-08-2026 — 06-09-2026</a:t>
             </a:r>
             <a:endParaRPr lang="en-US" sz="1000" dirty="0"/>
           </a:p>
@@ -13924,7 +14259,7 @@
       </p:sp>
       <p:sp>
         <p:nvSpPr>
-          <p:cNvPr id="74" name="Text 71"/>
+          <p:cNvPr id="83" name="Text 80"/>
           <p:cNvSpPr/>
           <p:nvPr/>
         </p:nvSpPr>
@@ -13963,7 +14298,7 @@
       </p:sp>
       <p:sp>
         <p:nvSpPr>
-          <p:cNvPr id="75" name="Text 72"/>
+          <p:cNvPr id="84" name="Text 81"/>
           <p:cNvSpPr/>
           <p:nvPr/>
         </p:nvSpPr>
@@ -13994,7 +14329,7 @@
                 <a:ea typeface="Calibri" pitchFamily="34" charset="-122"/>
                 <a:cs typeface="Calibri" pitchFamily="34" charset="-120"/>
               </a:rPr>
-              <a:t>Fuente: Data_NCR31082026.xlsx — hoja «Observaciones» · Corte 31-08-2026 · 502 registros desde 10-02-2023</a:t>
+              <a:t>Fuente: Data_NCR07092026.xlsx — hoja «Observaciones» · Corte 07-09-2026 · 509 registros desde 10-02-2023</a:t>
             </a:r>
             <a:endParaRPr lang="en-US" sz="850" dirty="0"/>
           </a:p>
@@ -14002,7 +14337,7 @@
       </p:sp>
       <p:sp>
         <p:nvSpPr>
-          <p:cNvPr id="76" name="Text 73"/>
+          <p:cNvPr id="85" name="Text 82"/>
           <p:cNvSpPr/>
           <p:nvPr/>
         </p:nvSpPr>
@@ -14041,7 +14376,7 @@
       </p:sp>
       <p:sp>
         <p:nvSpPr>
-          <p:cNvPr id="77" name="Text 74"/>
+          <p:cNvPr id="86" name="Text 83"/>
           <p:cNvSpPr/>
           <p:nvPr/>
         </p:nvSpPr>
@@ -14347,7 +14682,7 @@
                 <a:ea typeface="Calibri" pitchFamily="34" charset="-122"/>
                 <a:cs typeface="Calibri" pitchFamily="34" charset="-120"/>
               </a:rPr>
-              <a:t>164 hallazgos levantados · 53 internas · 71 del cliente · 40 de subcontrato · 18 especialidades involucradas.</a:t>
+              <a:t>170 hallazgos levantados · 53 internas · 77 del cliente · 40 de subcontrato · 18 especialidades involucradas.</a:t>
             </a:r>
             <a:endParaRPr lang="en-US" sz="1350" dirty="0"/>
           </a:p>
@@ -14406,7 +14741,7 @@
                 <a:ea typeface="Cambria" pitchFamily="34" charset="-122"/>
                 <a:cs typeface="Cambria" pitchFamily="34" charset="-120"/>
               </a:rPr>
-              <a:t>80,5%</a:t>
+              <a:t>77,6%</a:t>
             </a:r>
             <a:endParaRPr lang="en-US" sz="3400" dirty="0"/>
           </a:p>
@@ -14484,7 +14819,7 @@
                 <a:ea typeface="Cambria" pitchFamily="34" charset="-122"/>
                 <a:cs typeface="Cambria" pitchFamily="34" charset="-120"/>
               </a:rPr>
-              <a:t>32</a:t>
+              <a:t>38</a:t>
             </a:r>
             <a:endParaRPr lang="en-US" sz="3400" dirty="0"/>
           </a:p>
@@ -14640,7 +14975,7 @@
                 <a:ea typeface="Cambria" pitchFamily="34" charset="-122"/>
                 <a:cs typeface="Cambria" pitchFamily="34" charset="-120"/>
               </a:rPr>
-              <a:t>32,3%</a:t>
+              <a:t>31,2%</a:t>
             </a:r>
             <a:endParaRPr lang="en-US" sz="3400" dirty="0"/>
           </a:p>
@@ -14718,7 +15053,7 @@
                 <a:ea typeface="Calibri" pitchFamily="34" charset="-122"/>
                 <a:cs typeface="Calibri" pitchFamily="34" charset="-120"/>
               </a:rPr>
-              <a:t>Corte: 31-08-2026</a:t>
+              <a:t>Corte: 07-09-2026</a:t>
             </a:r>
             <a:endParaRPr lang="en-US" sz="1100" dirty="0"/>
           </a:p>
@@ -14757,7 +15092,7 @@
                 <a:ea typeface="Calibri" pitchFamily="34" charset="-122"/>
                 <a:cs typeface="Calibri" pitchFamily="34" charset="-120"/>
               </a:rPr>
-              <a:t>Fuente: Data_NCR31082026.xlsx — hoja «Observaciones» · Corte 31-08-2026 · 502 registros desde 10-02-2023</a:t>
+              <a:t>Fuente: Data_NCR07092026.xlsx — hoja «Observaciones» · Corte 07-09-2026 · 509 registros desde 10-02-2023</a:t>
             </a:r>
             <a:endParaRPr lang="en-US" sz="850" dirty="0"/>
           </a:p>
@@ -15023,7 +15358,7 @@
                 <a:ea typeface="Cambria" pitchFamily="34" charset="-122"/>
                 <a:cs typeface="Cambria" pitchFamily="34" charset="-120"/>
               </a:rPr>
-              <a:t>164</a:t>
+              <a:t>170</a:t>
             </a:r>
             <a:endParaRPr lang="en-US" sz="4000" dirty="0"/>
           </a:p>
@@ -15140,7 +15475,7 @@
                 <a:ea typeface="Calibri" pitchFamily="34" charset="-122"/>
                 <a:cs typeface="Calibri" pitchFamily="34" charset="-120"/>
               </a:rPr>
-              <a:t>53 internas · 71 del cliente · 40 de subcontrato</a:t>
+              <a:t>53 internas · 77 del cliente · 40 de subcontrato</a:t>
             </a:r>
             <a:endParaRPr lang="en-US" sz="950" dirty="0"/>
           </a:p>
@@ -15233,7 +15568,7 @@
                 <a:ea typeface="Cambria" pitchFamily="34" charset="-122"/>
                 <a:cs typeface="Cambria" pitchFamily="34" charset="-120"/>
               </a:rPr>
-              <a:t>80,5%</a:t>
+              <a:t>77,6%</a:t>
             </a:r>
             <a:endParaRPr lang="en-US" sz="4000" dirty="0"/>
           </a:p>
@@ -15272,7 +15607,7 @@
                 <a:ea typeface="Calibri" pitchFamily="34" charset="-122"/>
                 <a:cs typeface="Calibri" pitchFamily="34" charset="-120"/>
               </a:rPr>
-              <a:t>132/164</a:t>
+              <a:t>132/170</a:t>
             </a:r>
             <a:endParaRPr lang="en-US" sz="1400" dirty="0"/>
           </a:p>
@@ -15350,7 +15685,7 @@
                 <a:ea typeface="Calibri" pitchFamily="34" charset="-122"/>
                 <a:cs typeface="Calibri" pitchFamily="34" charset="-120"/>
               </a:rPr>
-              <a:t>Global del módulo: 92,2%</a:t>
+              <a:t>Global del módulo: 91%</a:t>
             </a:r>
             <a:endParaRPr lang="en-US" sz="950" dirty="0"/>
           </a:p>
@@ -15443,7 +15778,7 @@
                 <a:ea typeface="Cambria" pitchFamily="34" charset="-122"/>
                 <a:cs typeface="Cambria" pitchFamily="34" charset="-120"/>
               </a:rPr>
-              <a:t>32</a:t>
+              <a:t>38</a:t>
             </a:r>
             <a:endParaRPr lang="en-US" sz="4000" dirty="0"/>
           </a:p>
@@ -15560,7 +15895,7 @@
                 <a:ea typeface="Calibri" pitchFamily="34" charset="-122"/>
                 <a:cs typeface="Calibri" pitchFamily="34" charset="-120"/>
               </a:rPr>
-              <a:t>1 iniciado · 21 listo para revisión · 9 stand by · 1 observada</a:t>
+              <a:t>1 iniciado · 21 listo para revisión · 9 stand by · 1 observada · 6 pendiente</a:t>
             </a:r>
             <a:endParaRPr lang="en-US" sz="950" dirty="0"/>
           </a:p>
@@ -15886,7 +16221,7 @@
                 <a:ea typeface="Cambria" pitchFamily="34" charset="-122"/>
                 <a:cs typeface="Cambria" pitchFamily="34" charset="-120"/>
               </a:rPr>
-              <a:t>32,3%</a:t>
+              <a:t>31,2%</a:t>
             </a:r>
             <a:endParaRPr lang="en-US" sz="2600" dirty="0"/>
           </a:p>
@@ -15948,7 +16283,7 @@
                 <a:ea typeface="Calibri" pitchFamily="34" charset="-122"/>
                 <a:cs typeface="Calibri" pitchFamily="34" charset="-120"/>
               </a:rPr>
-              <a:t>global del módulo 32,3%</a:t>
+              <a:t>global del módulo 31,8%</a:t>
             </a:r>
             <a:endParaRPr lang="en-US" sz="1000" dirty="0"/>
           </a:p>
@@ -16206,7 +16541,7 @@
                 <a:ea typeface="Calibri" pitchFamily="34" charset="-122"/>
                 <a:cs typeface="Calibri" pitchFamily="34" charset="-120"/>
               </a:rPr>
-              <a:t>31 ab.</a:t>
+              <a:t>37 ab.</a:t>
             </a:r>
             <a:endParaRPr lang="en-US" sz="950" dirty="0"/>
           </a:p>
@@ -16245,7 +16580,7 @@
                 <a:ea typeface="Cambria" pitchFamily="34" charset="-122"/>
                 <a:cs typeface="Cambria" pitchFamily="34" charset="-120"/>
               </a:rPr>
-              <a:t>71</a:t>
+              <a:t>77</a:t>
             </a:r>
             <a:endParaRPr lang="en-US" sz="1600" dirty="0"/>
           </a:p>
@@ -16421,7 +16756,7 @@
                 <a:ea typeface="Calibri" pitchFamily="34" charset="-122"/>
                 <a:cs typeface="Calibri" pitchFamily="34" charset="-120"/>
               </a:rPr>
-              <a:t>Fuente: Data_NCR31082026.xlsx — hoja «Observaciones» · Corte 31-08-2026 · 502 registros desde 10-02-2023</a:t>
+              <a:t>Fuente: Data_NCR07092026.xlsx — hoja «Observaciones» · Corte 07-09-2026 · 509 registros desde 10-02-2023</a:t>
             </a:r>
             <a:endParaRPr lang="en-US" sz="850" dirty="0"/>
           </a:p>
@@ -16672,7 +17007,7 @@
                 <a:ea typeface="Calibri" pitchFamily="34" charset="-122"/>
                 <a:cs typeface="Calibri" pitchFamily="34" charset="-120"/>
               </a:rPr>
-              <a:t>32 hallazgos siguen abiertos; 13 con más de 180 días. Se listan del más antiguo al más reciente.</a:t>
+              <a:t>38 hallazgos siguen abiertos; 17 con más de 180 días. Se listan del más antiguo al más reciente.</a:t>
             </a:r>
             <a:endParaRPr lang="en-US" sz="1350" dirty="0"/>
           </a:p>
@@ -17280,7 +17615,7 @@
                 <a:ea typeface="Calibri" pitchFamily="34" charset="-122"/>
                 <a:cs typeface="Calibri" pitchFamily="34" charset="-120"/>
               </a:rPr>
-              <a:t>319</a:t>
+              <a:t>326</a:t>
             </a:r>
             <a:endParaRPr lang="en-US" sz="1050" dirty="0"/>
           </a:p>
@@ -17635,7 +17970,7 @@
                 <a:ea typeface="Calibri" pitchFamily="34" charset="-122"/>
                 <a:cs typeface="Calibri" pitchFamily="34" charset="-120"/>
               </a:rPr>
-              <a:t>319</a:t>
+              <a:t>326</a:t>
             </a:r>
             <a:endParaRPr lang="en-US" sz="1050" dirty="0"/>
           </a:p>
@@ -17970,7 +18305,7 @@
                 <a:ea typeface="Calibri" pitchFamily="34" charset="-122"/>
                 <a:cs typeface="Calibri" pitchFamily="34" charset="-120"/>
               </a:rPr>
-              <a:t>298</a:t>
+              <a:t>305</a:t>
             </a:r>
             <a:endParaRPr lang="en-US" sz="1050" dirty="0"/>
           </a:p>
@@ -18325,7 +18660,7 @@
                 <a:ea typeface="Calibri" pitchFamily="34" charset="-122"/>
                 <a:cs typeface="Calibri" pitchFamily="34" charset="-120"/>
               </a:rPr>
-              <a:t>294</a:t>
+              <a:t>301</a:t>
             </a:r>
             <a:endParaRPr lang="en-US" sz="1050" dirty="0"/>
           </a:p>
@@ -18660,7 +18995,7 @@
                 <a:ea typeface="Calibri" pitchFamily="34" charset="-122"/>
                 <a:cs typeface="Calibri" pitchFamily="34" charset="-120"/>
               </a:rPr>
-              <a:t>257</a:t>
+              <a:t>264</a:t>
             </a:r>
             <a:endParaRPr lang="en-US" sz="1050" dirty="0"/>
           </a:p>
@@ -19015,7 +19350,7 @@
                 <a:ea typeface="Calibri" pitchFamily="34" charset="-122"/>
                 <a:cs typeface="Calibri" pitchFamily="34" charset="-120"/>
               </a:rPr>
-              <a:t>228</a:t>
+              <a:t>235</a:t>
             </a:r>
             <a:endParaRPr lang="en-US" sz="1050" dirty="0"/>
           </a:p>
@@ -19350,7 +19685,7 @@
                 <a:ea typeface="Calibri" pitchFamily="34" charset="-122"/>
                 <a:cs typeface="Calibri" pitchFamily="34" charset="-120"/>
               </a:rPr>
-              <a:t>228</a:t>
+              <a:t>235</a:t>
             </a:r>
             <a:endParaRPr lang="en-US" sz="1050" dirty="0"/>
           </a:p>
@@ -19705,7 +20040,7 @@
                 <a:ea typeface="Calibri" pitchFamily="34" charset="-122"/>
                 <a:cs typeface="Calibri" pitchFamily="34" charset="-120"/>
               </a:rPr>
-              <a:t>228</a:t>
+              <a:t>235</a:t>
             </a:r>
             <a:endParaRPr lang="en-US" sz="1050" dirty="0"/>
           </a:p>
@@ -20040,7 +20375,7 @@
                 <a:ea typeface="Calibri" pitchFamily="34" charset="-122"/>
                 <a:cs typeface="Calibri" pitchFamily="34" charset="-120"/>
               </a:rPr>
-              <a:t>228</a:t>
+              <a:t>235</a:t>
             </a:r>
             <a:endParaRPr lang="en-US" sz="1050" dirty="0"/>
           </a:p>
@@ -20141,7 +20476,7 @@
                 <a:ea typeface="Calibri" pitchFamily="34" charset="-122"/>
                 <a:cs typeface="Calibri" pitchFamily="34" charset="-120"/>
               </a:rPr>
-              <a:t>Se listan los 9 más antiguos de 32 abiertos; el detalle completo está en el panel.</a:t>
+              <a:t>Se listan los 9 más antiguos de 38 abiertos; el detalle completo está en el panel.</a:t>
             </a:r>
             <a:endParaRPr lang="en-US" sz="950" dirty="0"/>
           </a:p>
@@ -20164,7 +20499,7 @@
             </a:avLst>
           </a:prstGeom>
           <a:solidFill>
-            <a:srgbClr val="E9EDF2"/>
+            <a:srgbClr val="12233B"/>
           </a:solidFill>
           <a:ln/>
         </p:spPr>
@@ -20196,13 +20531,13 @@
             <a:r>
               <a:rPr lang="en-US" sz="1000" b="1" spc="100" kern="0" dirty="0">
                 <a:solidFill>
-                  <a:srgbClr val="56606E"/>
-                </a:solidFill>
-                <a:latin typeface="Calibri" pitchFamily="34" charset="0"/>
-                <a:ea typeface="Calibri" pitchFamily="34" charset="-122"/>
-                <a:cs typeface="Calibri" pitchFamily="34" charset="-120"/>
-              </a:rPr>
-              <a:t>SEMANA 24-08-2026 — 30-08-2026</a:t>
+                  <a:srgbClr val="E3A55B"/>
+                </a:solidFill>
+                <a:latin typeface="Calibri" pitchFamily="34" charset="0"/>
+                <a:ea typeface="Calibri" pitchFamily="34" charset="-122"/>
+                <a:cs typeface="Calibri" pitchFamily="34" charset="-120"/>
+              </a:rPr>
+              <a:t>SEMANA 31-08-2026 — 06-09-2026</a:t>
             </a:r>
             <a:endParaRPr lang="en-US" sz="1000" dirty="0"/>
           </a:p>
@@ -20235,13 +20570,13 @@
             <a:r>
               <a:rPr lang="en-US" sz="1150" dirty="0">
                 <a:solidFill>
-                  <a:srgbClr val="56606E"/>
-                </a:solidFill>
-                <a:latin typeface="Calibri" pitchFamily="34" charset="0"/>
-                <a:ea typeface="Calibri" pitchFamily="34" charset="-122"/>
-                <a:cs typeface="Calibri" pitchFamily="34" charset="-120"/>
-              </a:rPr>
-              <a:t>Sin hallazgos nuevos en el período.</a:t>
+                  <a:srgbClr val="FFFFFF"/>
+                </a:solidFill>
+                <a:latin typeface="Calibri" pitchFamily="34" charset="0"/>
+                <a:ea typeface="Calibri" pitchFamily="34" charset="-122"/>
+                <a:cs typeface="Calibri" pitchFamily="34" charset="-120"/>
+              </a:rPr>
+              <a:t>6 hallazgos nuevos · 0 internas · 6 del cliente · Sin especialidad 6 · 6 siguen abiertos</a:t>
             </a:r>
             <a:endParaRPr lang="en-US" sz="1150" dirty="0"/>
           </a:p>
@@ -20280,7 +20615,7 @@
                 <a:ea typeface="Calibri" pitchFamily="34" charset="-122"/>
                 <a:cs typeface="Calibri" pitchFamily="34" charset="-120"/>
               </a:rPr>
-              <a:t>Fuente: Data_NCR31082026.xlsx — hoja «Observaciones» · Corte 31-08-2026 · 502 registros desde 10-02-2023</a:t>
+              <a:t>Fuente: Data_NCR07092026.xlsx — hoja «Observaciones» · Corte 07-09-2026 · 509 registros desde 10-02-2023</a:t>
             </a:r>
             <a:endParaRPr lang="en-US" sz="850" dirty="0"/>
           </a:p>
@@ -20585,7 +20920,7 @@
                 <a:ea typeface="Cambria" pitchFamily="34" charset="-122"/>
                 <a:cs typeface="Cambria" pitchFamily="34" charset="-120"/>
               </a:rPr>
-              <a:t>92,2%</a:t>
+              <a:t>91%</a:t>
             </a:r>
             <a:endParaRPr lang="en-US" sz="4000" dirty="0"/>
           </a:p>
@@ -20624,7 +20959,7 @@
                 <a:ea typeface="Calibri" pitchFamily="34" charset="-122"/>
                 <a:cs typeface="Calibri" pitchFamily="34" charset="-120"/>
               </a:rPr>
-              <a:t>463/502</a:t>
+              <a:t>463/509</a:t>
             </a:r>
             <a:endParaRPr lang="en-US" sz="1400" dirty="0"/>
           </a:p>
@@ -20702,7 +21037,7 @@
                 <a:ea typeface="Calibri" pitchFamily="34" charset="-122"/>
                 <a:cs typeface="Calibri" pitchFamily="34" charset="-120"/>
               </a:rPr>
-              <a:t>39 abiertos · 13 con más de 180 días</a:t>
+              <a:t>46 abiertos · 17 con más de 180 días</a:t>
             </a:r>
             <a:endParaRPr lang="en-US" sz="950" dirty="0"/>
           </a:p>
@@ -20795,7 +21130,7 @@
                 <a:ea typeface="Cambria" pitchFamily="34" charset="-122"/>
                 <a:cs typeface="Cambria" pitchFamily="34" charset="-120"/>
               </a:rPr>
-              <a:t>39</a:t>
+              <a:t>46</a:t>
             </a:r>
             <a:endParaRPr lang="en-US" sz="4000" dirty="0"/>
           </a:p>
@@ -20834,7 +21169,7 @@
                 <a:ea typeface="Calibri" pitchFamily="34" charset="-122"/>
                 <a:cs typeface="Calibri" pitchFamily="34" charset="-120"/>
               </a:rPr>
-              <a:t>de 502 levantados</a:t>
+              <a:t>de 509 levantados</a:t>
             </a:r>
             <a:endParaRPr lang="en-US" sz="1400" dirty="0"/>
           </a:p>
@@ -20912,7 +21247,7 @@
                 <a:ea typeface="Calibri" pitchFamily="34" charset="-122"/>
                 <a:cs typeface="Calibri" pitchFamily="34" charset="-120"/>
               </a:rPr>
-              <a:t>6 iniciado · 23 listo para revisión · 9 stand by · 1 observada</a:t>
+              <a:t>7 iniciado · 23 listo para revisión · 9 stand by · 1 observada · 6 pendiente</a:t>
             </a:r>
             <a:endParaRPr lang="en-US" sz="950" dirty="0"/>
           </a:p>
@@ -21005,7 +21340,7 @@
                 <a:ea typeface="Cambria" pitchFamily="34" charset="-122"/>
                 <a:cs typeface="Cambria" pitchFamily="34" charset="-120"/>
               </a:rPr>
-              <a:t>32,3%</a:t>
+              <a:t>31,8%</a:t>
             </a:r>
             <a:endParaRPr lang="en-US" sz="4000" dirty="0"/>
           </a:p>
@@ -21044,7 +21379,7 @@
                 <a:ea typeface="Calibri" pitchFamily="34" charset="-122"/>
                 <a:cs typeface="Calibri" pitchFamily="34" charset="-120"/>
               </a:rPr>
-              <a:t>159/493 clasificados</a:t>
+              <a:t>159/500 clasificados</a:t>
             </a:r>
             <a:endParaRPr lang="en-US" sz="1400" dirty="0"/>
           </a:p>
@@ -21254,7 +21589,7 @@
                 <a:ea typeface="Calibri" pitchFamily="34" charset="-122"/>
                 <a:cs typeface="Calibri" pitchFamily="34" charset="-120"/>
               </a:rPr>
-              <a:t>251 de 502 con costo</a:t>
+              <a:t>251 de 509 con costo</a:t>
             </a:r>
             <a:endParaRPr lang="en-US" sz="1400" dirty="0"/>
           </a:p>
@@ -21332,7 +21667,7 @@
                 <a:ea typeface="Calibri" pitchFamily="34" charset="-122"/>
                 <a:cs typeface="Calibri" pitchFamily="34" charset="-120"/>
               </a:rPr>
-              <a:t>251 hallazgos no declaran costo: la cifra es un piso</a:t>
+              <a:t>258 hallazgos no declaran costo: la cifra es un piso</a:t>
             </a:r>
             <a:endParaRPr lang="en-US" sz="950" dirty="0"/>
           </a:p>
@@ -21472,7 +21807,7 @@
                 <a:ea typeface="Calibri" pitchFamily="34" charset="-122"/>
                 <a:cs typeface="Calibri" pitchFamily="34" charset="-120"/>
               </a:rPr>
-              <a:t>32 de los 39 hallazgos abiertos (82,1%), y es uno de los frentes donde el cliente levanta más de lo que detecta Besalco (71 del cliente contra 53 internas).</a:t>
+              <a:t>38 de los 46 hallazgos abiertos (82,6%), y es uno de los frentes donde el cliente levanta más de lo que detecta Besalco (77 del cliente contra 53 internas).</a:t>
             </a:r>
             <a:endParaRPr lang="en-US" sz="1250" dirty="0"/>
           </a:p>
@@ -21534,7 +21869,7 @@
                 <a:ea typeface="Calibri" pitchFamily="34" charset="-122"/>
                 <a:cs typeface="Calibri" pitchFamily="34" charset="-120"/>
               </a:rPr>
-              <a:t>La semana trajo 1 hallazgo nuevo, ninguno de autodetección.  </a:t>
+              <a:t>La semana trajo 7 hallazgos nuevos, ninguno de autodetección.  </a:t>
             </a:r>
             <a:pPr indent="0" marL="0">
               <a:lnSpc>
@@ -21551,7 +21886,7 @@
                 <a:ea typeface="Calibri" pitchFamily="34" charset="-122"/>
                 <a:cs typeface="Calibri" pitchFamily="34" charset="-120"/>
               </a:rPr>
-              <a:t>24-08-2026 al 30-08-2026: 1 del cliente en OO.CC (1). Todos siguen abiertos; la semana anterior entraron 3.</a:t>
+              <a:t>31-08-2026 al 06-09-2026: 7 del cliente en Sin especialidad (6) y OO.CC (1). Todos siguen abiertos; la semana anterior entraron 1.</a:t>
             </a:r>
             <a:endParaRPr lang="en-US" sz="1250" dirty="0"/>
           </a:p>
@@ -21613,7 +21948,7 @@
                 <a:ea typeface="Calibri" pitchFamily="34" charset="-122"/>
                 <a:cs typeface="Calibri" pitchFamily="34" charset="-120"/>
               </a:rPr>
-              <a:t>38 de los 39 abiertos están fuera del plazo de respuesta.  </a:t>
+              <a:t>39 de los 46 abiertos están fuera del plazo de respuesta.  </a:t>
             </a:r>
             <a:pPr indent="0" marL="0">
               <a:lnSpc>
@@ -21630,7 +21965,7 @@
                 <a:ea typeface="Calibri" pitchFamily="34" charset="-122"/>
                 <a:cs typeface="Calibri" pitchFamily="34" charset="-120"/>
               </a:rPr>
-              <a:t>El plazo es de 10 días desde que se emite la NC. De los atrasados, 13 llevan más de 180 días abiertos y 0 más de un año: no es atraso de días, es deuda vieja.</a:t>
+              <a:t>El plazo es de 10 días desde que se emite la NC. De los atrasados, 17 llevan más de 180 días abiertos y 0 más de un año: no es atraso de días, es deuda vieja.</a:t>
             </a:r>
             <a:endParaRPr lang="en-US" sz="1250" dirty="0"/>
           </a:p>
@@ -21669,7 +22004,7 @@
                 <a:ea typeface="Calibri" pitchFamily="34" charset="-122"/>
                 <a:cs typeface="Calibri" pitchFamily="34" charset="-120"/>
               </a:rPr>
-              <a:t>Fuente: Data_NCR31082026.xlsx — hoja «Observaciones» · Corte 31-08-2026 · 502 registros desde 10-02-2023</a:t>
+              <a:t>Fuente: Data_NCR07092026.xlsx — hoja «Observaciones» · Corte 07-09-2026 · 509 registros desde 10-02-2023</a:t>
             </a:r>
             <a:endParaRPr lang="en-US" sz="850" dirty="0"/>
           </a:p>
@@ -22944,7 +23279,7 @@
                 <a:ea typeface="Calibri" pitchFamily="34" charset="-122"/>
                 <a:cs typeface="Calibri" pitchFamily="34" charset="-120"/>
               </a:rPr>
-              <a:t>248</a:t>
+              <a:t>249</a:t>
             </a:r>
             <a:endParaRPr lang="en-US" sz="1300" dirty="0"/>
           </a:p>
@@ -23022,7 +23357,7 @@
                 <a:ea typeface="Calibri" pitchFamily="34" charset="-122"/>
                 <a:cs typeface="Calibri" pitchFamily="34" charset="-120"/>
               </a:rPr>
-              <a:t>6</a:t>
+              <a:t>7</a:t>
             </a:r>
             <a:endParaRPr lang="en-US" sz="1300" dirty="0"/>
           </a:p>
@@ -23061,7 +23396,7 @@
                 <a:ea typeface="Calibri" pitchFamily="34" charset="-122"/>
                 <a:cs typeface="Calibri" pitchFamily="34" charset="-120"/>
               </a:rPr>
-              <a:t>97,6%</a:t>
+              <a:t>97,2%</a:t>
             </a:r>
             <a:endParaRPr lang="en-US" sz="1300" dirty="0"/>
           </a:p>
@@ -23139,7 +23474,7 @@
                 <a:ea typeface="Calibri" pitchFamily="34" charset="-122"/>
                 <a:cs typeface="Calibri" pitchFamily="34" charset="-120"/>
               </a:rPr>
-              <a:t>196</a:t>
+              <a:t>197</a:t>
             </a:r>
             <a:endParaRPr lang="en-US" sz="1300" dirty="0"/>
           </a:p>
@@ -23418,7 +23753,7 @@
                 <a:ea typeface="Calibri" pitchFamily="34" charset="-122"/>
                 <a:cs typeface="Calibri" pitchFamily="34" charset="-120"/>
               </a:rPr>
-              <a:t>164</a:t>
+              <a:t>170</a:t>
             </a:r>
             <a:endParaRPr lang="en-US" sz="1300" dirty="0"/>
           </a:p>
@@ -23496,7 +23831,7 @@
                 <a:ea typeface="Calibri" pitchFamily="34" charset="-122"/>
                 <a:cs typeface="Calibri" pitchFamily="34" charset="-120"/>
               </a:rPr>
-              <a:t>32</a:t>
+              <a:t>38</a:t>
             </a:r>
             <a:endParaRPr lang="en-US" sz="1300" dirty="0"/>
           </a:p>
@@ -23535,7 +23870,7 @@
                 <a:ea typeface="Calibri" pitchFamily="34" charset="-122"/>
                 <a:cs typeface="Calibri" pitchFamily="34" charset="-120"/>
               </a:rPr>
-              <a:t>80,5%</a:t>
+              <a:t>77,6%</a:t>
             </a:r>
             <a:endParaRPr lang="en-US" sz="1300" dirty="0"/>
           </a:p>
@@ -23613,7 +23948,7 @@
                 <a:ea typeface="Calibri" pitchFamily="34" charset="-122"/>
                 <a:cs typeface="Calibri" pitchFamily="34" charset="-120"/>
               </a:rPr>
-              <a:t>71</a:t>
+              <a:t>77</a:t>
             </a:r>
             <a:endParaRPr lang="en-US" sz="1300" dirty="0"/>
           </a:p>
@@ -24386,7 +24721,7 @@
                 <a:ea typeface="Calibri" pitchFamily="34" charset="-122"/>
                 <a:cs typeface="Calibri" pitchFamily="34" charset="-120"/>
               </a:rPr>
-              <a:t>494</a:t>
+              <a:t>501</a:t>
             </a:r>
             <a:endParaRPr lang="en-US" sz="1300" dirty="0"/>
           </a:p>
@@ -24464,7 +24799,7 @@
                 <a:ea typeface="Calibri" pitchFamily="34" charset="-122"/>
                 <a:cs typeface="Calibri" pitchFamily="34" charset="-120"/>
               </a:rPr>
-              <a:t>39</a:t>
+              <a:t>46</a:t>
             </a:r>
             <a:endParaRPr lang="en-US" sz="1300" dirty="0"/>
           </a:p>
@@ -24503,7 +24838,7 @@
                 <a:ea typeface="Calibri" pitchFamily="34" charset="-122"/>
                 <a:cs typeface="Calibri" pitchFamily="34" charset="-120"/>
               </a:rPr>
-              <a:t>92,1%</a:t>
+              <a:t>90,8%</a:t>
             </a:r>
             <a:endParaRPr lang="en-US" sz="1300" dirty="0"/>
           </a:p>
@@ -24581,7 +24916,7 @@
                 <a:ea typeface="Calibri" pitchFamily="34" charset="-122"/>
                 <a:cs typeface="Calibri" pitchFamily="34" charset="-120"/>
               </a:rPr>
-              <a:t>286</a:t>
+              <a:t>293</a:t>
             </a:r>
             <a:endParaRPr lang="en-US" sz="1300" dirty="0"/>
           </a:p>
@@ -24698,7 +25033,7 @@
                 <a:ea typeface="Calibri" pitchFamily="34" charset="-122"/>
                 <a:cs typeface="Calibri" pitchFamily="34" charset="-120"/>
               </a:rPr>
-              <a:t>Mediana de cierre global 30 días · el hallazgo más lento tomó 419 días · 79 hallazgos sin especialidad declarada.</a:t>
+              <a:t>Mediana de cierre global 30 días · el hallazgo más lento tomó 419 días · 85 hallazgos sin especialidad declarada.</a:t>
             </a:r>
             <a:endParaRPr lang="en-US" sz="950" dirty="0"/>
           </a:p>
@@ -24737,7 +25072,7 @@
                 <a:ea typeface="Calibri" pitchFamily="34" charset="-122"/>
                 <a:cs typeface="Calibri" pitchFamily="34" charset="-120"/>
               </a:rPr>
-              <a:t>Fuente: Data_NCR31082026.xlsx — hoja «Observaciones» · Corte 31-08-2026 · 502 registros desde 10-02-2023</a:t>
+              <a:t>Fuente: Data_NCR07092026.xlsx — hoja «Observaciones» · Corte 07-09-2026 · 509 registros desde 10-02-2023</a:t>
             </a:r>
             <a:endParaRPr lang="en-US" sz="850" dirty="0"/>
           </a:p>
@@ -24988,7 +25323,7 @@
                 <a:ea typeface="Calibri" pitchFamily="34" charset="-122"/>
                 <a:cs typeface="Calibri" pitchFamily="34" charset="-120"/>
               </a:rPr>
-              <a:t>Entre el 24-08-2026 y el 30-08-2026 se levantó 1 hallazgo: 0 internas · 1 del cliente. Sigue abierto.</a:t>
+              <a:t>Entre el 31-08-2026 y el 06-09-2026 se levantaron 7 hallazgos: 0 internas · 7 del cliente. Todos siguen abiertos.</a:t>
             </a:r>
             <a:endParaRPr lang="en-US" sz="1350" dirty="0"/>
           </a:p>
@@ -25143,7 +25478,7 @@
                 <a:ea typeface="Calibri" pitchFamily="34" charset="-122"/>
                 <a:cs typeface="Calibri" pitchFamily="34" charset="-120"/>
               </a:rPr>
-              <a:t>OO.CC 1</a:t>
+              <a:t>Sin especialidad 6  ·  OO.CC 1</a:t>
             </a:r>
             <a:endParaRPr lang="en-US" sz="1100" dirty="0"/>
           </a:p>
@@ -25221,7 +25556,7 @@
                 <a:ea typeface="Calibri" pitchFamily="34" charset="-122"/>
                 <a:cs typeface="Calibri" pitchFamily="34" charset="-120"/>
               </a:rPr>
-              <a:t>Talabre 1</a:t>
+              <a:t>Arqueros 6  ·  Talabre 1</a:t>
             </a:r>
             <a:endParaRPr lang="en-US" sz="1100" dirty="0"/>
           </a:p>
@@ -25299,7 +25634,7 @@
                 <a:ea typeface="Calibri" pitchFamily="34" charset="-122"/>
                 <a:cs typeface="Calibri" pitchFamily="34" charset="-120"/>
               </a:rPr>
-              <a:t>Externa · Cliente 1</a:t>
+              <a:t>Externa · Cliente 7</a:t>
             </a:r>
             <a:endParaRPr lang="en-US" sz="1100" dirty="0"/>
           </a:p>
@@ -25377,7 +25712,7 @@
                 <a:ea typeface="Calibri" pitchFamily="34" charset="-122"/>
                 <a:cs typeface="Calibri" pitchFamily="34" charset="-120"/>
               </a:rPr>
-              <a:t>Producto No Conforme 1</a:t>
+              <a:t>No Conformidad 7</a:t>
             </a:r>
             <a:endParaRPr lang="en-US" sz="1100" dirty="0"/>
           </a:p>
@@ -25416,7 +25751,7 @@
                 <a:ea typeface="Calibri" pitchFamily="34" charset="-122"/>
                 <a:cs typeface="Calibri" pitchFamily="34" charset="-120"/>
               </a:rPr>
-              <a:t>DETALLE DE LOS HALLAZGOS NUEVOS</a:t>
+              <a:t>DETALLE DE LOS HALLAZGOS NUEVOS — SE LISTAN 6 DE 7; EL RESTO ESTÁ EN EL PANEL</a:t>
             </a:r>
             <a:endParaRPr lang="en-US" sz="1050" dirty="0"/>
           </a:p>
@@ -25829,7 +26164,7 @@
                 <a:ea typeface="Calibri" pitchFamily="34" charset="-122"/>
                 <a:cs typeface="Calibri" pitchFamily="34" charset="-120"/>
               </a:rPr>
-              <a:t>24-08-2026</a:t>
+              <a:t>01-09-2026</a:t>
             </a:r>
             <a:endParaRPr lang="en-US" sz="1050" dirty="0"/>
           </a:p>
@@ -25868,7 +26203,7 @@
                 <a:ea typeface="Calibri" pitchFamily="34" charset="-122"/>
                 <a:cs typeface="Calibri" pitchFamily="34" charset="-120"/>
               </a:rPr>
-              <a:t>Talabre</a:t>
+              <a:t>Arqueros</a:t>
             </a:r>
             <a:endParaRPr lang="en-US" sz="1050" dirty="0"/>
           </a:p>
@@ -25907,7 +26242,7 @@
                 <a:ea typeface="Calibri" pitchFamily="34" charset="-122"/>
                 <a:cs typeface="Calibri" pitchFamily="34" charset="-120"/>
               </a:rPr>
-              <a:t>249 · PNC N°192</a:t>
+              <a:t>MASA-86 · EB-NE-1412</a:t>
             </a:r>
             <a:endParaRPr lang="en-US" sz="1050" dirty="0"/>
           </a:p>
@@ -25946,7 +26281,7 @@
                 <a:ea typeface="Calibri" pitchFamily="34" charset="-122"/>
                 <a:cs typeface="Calibri" pitchFamily="34" charset="-120"/>
               </a:rPr>
-              <a:t>Producto No Confor…</a:t>
+              <a:t>No Conformidad</a:t>
             </a:r>
             <a:endParaRPr lang="en-US" sz="1050" dirty="0"/>
           </a:p>
@@ -26024,7 +26359,7 @@
                 <a:ea typeface="Calibri" pitchFamily="34" charset="-122"/>
                 <a:cs typeface="Calibri" pitchFamily="34" charset="-120"/>
               </a:rPr>
-              <a:t>OO.CC</a:t>
+              <a:t>Sin especial…</a:t>
             </a:r>
             <a:endParaRPr lang="en-US" sz="1050" dirty="0"/>
           </a:p>
@@ -26063,7 +26398,7 @@
                 <a:ea typeface="Calibri" pitchFamily="34" charset="-122"/>
                 <a:cs typeface="Calibri" pitchFamily="34" charset="-120"/>
               </a:rPr>
-              <a:t>Mauricio Rocha A.</a:t>
+              <a:t>Sin asignar</a:t>
             </a:r>
             <a:endParaRPr lang="en-US" sz="1050" dirty="0"/>
           </a:p>
@@ -26102,7 +26437,7 @@
                 <a:ea typeface="Calibri" pitchFamily="34" charset="-122"/>
                 <a:cs typeface="Calibri" pitchFamily="34" charset="-120"/>
               </a:rPr>
-              <a:t>Iniciado</a:t>
+              <a:t>Pendiente</a:t>
             </a:r>
             <a:endParaRPr lang="en-US" sz="1050" dirty="0"/>
           </a:p>
@@ -26141,7 +26476,7 @@
                 <a:ea typeface="Calibri" pitchFamily="34" charset="-122"/>
                 <a:cs typeface="Calibri" pitchFamily="34" charset="-120"/>
               </a:rPr>
-              <a:t>Se evidencia daño físico en…</a:t>
+              <a:t>Perdida de torque en pernos</a:t>
             </a:r>
             <a:endParaRPr lang="en-US" sz="1000" dirty="0"/>
           </a:p>
@@ -26172,7 +26507,1937 @@
       </p:sp>
       <p:sp>
         <p:nvSpPr>
-          <p:cNvPr id="38" name="Text 34"/>
+          <p:cNvPr id="38" name="Shape 34"/>
+          <p:cNvSpPr/>
+          <p:nvPr/>
+        </p:nvSpPr>
+        <p:spPr>
+          <a:xfrm>
+            <a:off x="457200" y="4709160"/>
+            <a:ext cx="11292840" cy="329184"/>
+          </a:xfrm>
+          <a:prstGeom prst="rect">
+            <a:avLst/>
+          </a:prstGeom>
+          <a:solidFill>
+            <a:srgbClr val="FFFFFF"/>
+          </a:solidFill>
+          <a:ln/>
+        </p:spPr>
+      </p:sp>
+      <p:sp>
+        <p:nvSpPr>
+          <p:cNvPr id="39" name="Text 35"/>
+          <p:cNvSpPr/>
+          <p:nvPr/>
+        </p:nvSpPr>
+        <p:spPr>
+          <a:xfrm>
+            <a:off x="502920" y="4754880"/>
+            <a:ext cx="822960" cy="237744"/>
+          </a:xfrm>
+          <a:prstGeom prst="rect">
+            <a:avLst/>
+          </a:prstGeom>
+          <a:noFill/>
+          <a:ln/>
+        </p:spPr>
+        <p:txBody>
+          <a:bodyPr wrap="square" lIns="0" tIns="0" rIns="0" bIns="0" rtlCol="0" anchor="ctr"/>
+          <a:lstStyle/>
+          <a:p>
+            <a:pPr algn="l" indent="0" marL="0">
+              <a:buNone/>
+            </a:pPr>
+            <a:r>
+              <a:rPr lang="en-US" sz="1050" dirty="0">
+                <a:solidFill>
+                  <a:srgbClr val="1A2433"/>
+                </a:solidFill>
+                <a:latin typeface="Calibri" pitchFamily="34" charset="0"/>
+                <a:ea typeface="Calibri" pitchFamily="34" charset="-122"/>
+                <a:cs typeface="Calibri" pitchFamily="34" charset="-120"/>
+              </a:rPr>
+              <a:t>01-09-2026</a:t>
+            </a:r>
+            <a:endParaRPr lang="en-US" sz="1050" dirty="0"/>
+          </a:p>
+        </p:txBody>
+      </p:sp>
+      <p:sp>
+        <p:nvSpPr>
+          <p:cNvPr id="40" name="Text 36"/>
+          <p:cNvSpPr/>
+          <p:nvPr/>
+        </p:nvSpPr>
+        <p:spPr>
+          <a:xfrm>
+            <a:off x="1371600" y="4754880"/>
+            <a:ext cx="1051560" cy="237744"/>
+          </a:xfrm>
+          <a:prstGeom prst="rect">
+            <a:avLst/>
+          </a:prstGeom>
+          <a:noFill/>
+          <a:ln/>
+        </p:spPr>
+        <p:txBody>
+          <a:bodyPr wrap="square" lIns="0" tIns="0" rIns="0" bIns="0" rtlCol="0" anchor="ctr"/>
+          <a:lstStyle/>
+          <a:p>
+            <a:pPr algn="l" indent="0" marL="0">
+              <a:buNone/>
+            </a:pPr>
+            <a:r>
+              <a:rPr lang="en-US" sz="1050" dirty="0">
+                <a:solidFill>
+                  <a:srgbClr val="1A2433"/>
+                </a:solidFill>
+                <a:latin typeface="Calibri" pitchFamily="34" charset="0"/>
+                <a:ea typeface="Calibri" pitchFamily="34" charset="-122"/>
+                <a:cs typeface="Calibri" pitchFamily="34" charset="-120"/>
+              </a:rPr>
+              <a:t>Arqueros</a:t>
+            </a:r>
+            <a:endParaRPr lang="en-US" sz="1050" dirty="0"/>
+          </a:p>
+        </p:txBody>
+      </p:sp>
+      <p:sp>
+        <p:nvSpPr>
+          <p:cNvPr id="41" name="Text 37"/>
+          <p:cNvSpPr/>
+          <p:nvPr/>
+        </p:nvSpPr>
+        <p:spPr>
+          <a:xfrm>
+            <a:off x="2468880" y="4754880"/>
+            <a:ext cx="1051560" cy="237744"/>
+          </a:xfrm>
+          <a:prstGeom prst="rect">
+            <a:avLst/>
+          </a:prstGeom>
+          <a:noFill/>
+          <a:ln/>
+        </p:spPr>
+        <p:txBody>
+          <a:bodyPr wrap="square" lIns="0" tIns="0" rIns="0" bIns="0" rtlCol="0" anchor="ctr"/>
+          <a:lstStyle/>
+          <a:p>
+            <a:pPr algn="l" indent="0" marL="0">
+              <a:buNone/>
+            </a:pPr>
+            <a:r>
+              <a:rPr lang="en-US" sz="1050" dirty="0">
+                <a:solidFill>
+                  <a:srgbClr val="1A2433"/>
+                </a:solidFill>
+                <a:latin typeface="Calibri" pitchFamily="34" charset="0"/>
+                <a:ea typeface="Calibri" pitchFamily="34" charset="-122"/>
+                <a:cs typeface="Calibri" pitchFamily="34" charset="-120"/>
+              </a:rPr>
+              <a:t>MASA-87 · EB-NE-1412</a:t>
+            </a:r>
+            <a:endParaRPr lang="en-US" sz="1050" dirty="0"/>
+          </a:p>
+        </p:txBody>
+      </p:sp>
+      <p:sp>
+        <p:nvSpPr>
+          <p:cNvPr id="42" name="Text 38"/>
+          <p:cNvSpPr/>
+          <p:nvPr/>
+        </p:nvSpPr>
+        <p:spPr>
+          <a:xfrm>
+            <a:off x="3566160" y="4754880"/>
+            <a:ext cx="1371600" cy="237744"/>
+          </a:xfrm>
+          <a:prstGeom prst="rect">
+            <a:avLst/>
+          </a:prstGeom>
+          <a:noFill/>
+          <a:ln/>
+        </p:spPr>
+        <p:txBody>
+          <a:bodyPr wrap="square" lIns="0" tIns="0" rIns="0" bIns="0" rtlCol="0" anchor="ctr"/>
+          <a:lstStyle/>
+          <a:p>
+            <a:pPr algn="l" indent="0" marL="0">
+              <a:buNone/>
+            </a:pPr>
+            <a:r>
+              <a:rPr lang="en-US" sz="1050" dirty="0">
+                <a:solidFill>
+                  <a:srgbClr val="1A2433"/>
+                </a:solidFill>
+                <a:latin typeface="Calibri" pitchFamily="34" charset="0"/>
+                <a:ea typeface="Calibri" pitchFamily="34" charset="-122"/>
+                <a:cs typeface="Calibri" pitchFamily="34" charset="-120"/>
+              </a:rPr>
+              <a:t>No Conformidad</a:t>
+            </a:r>
+            <a:endParaRPr lang="en-US" sz="1050" dirty="0"/>
+          </a:p>
+        </p:txBody>
+      </p:sp>
+      <p:sp>
+        <p:nvSpPr>
+          <p:cNvPr id="43" name="Text 39"/>
+          <p:cNvSpPr/>
+          <p:nvPr/>
+        </p:nvSpPr>
+        <p:spPr>
+          <a:xfrm>
+            <a:off x="4983480" y="4754880"/>
+            <a:ext cx="1417320" cy="237744"/>
+          </a:xfrm>
+          <a:prstGeom prst="rect">
+            <a:avLst/>
+          </a:prstGeom>
+          <a:noFill/>
+          <a:ln/>
+        </p:spPr>
+        <p:txBody>
+          <a:bodyPr wrap="square" lIns="0" tIns="0" rIns="0" bIns="0" rtlCol="0" anchor="ctr"/>
+          <a:lstStyle/>
+          <a:p>
+            <a:pPr algn="l" indent="0" marL="0">
+              <a:buNone/>
+            </a:pPr>
+            <a:r>
+              <a:rPr lang="en-US" sz="1050" b="1" dirty="0">
+                <a:solidFill>
+                  <a:srgbClr val="C87A32"/>
+                </a:solidFill>
+                <a:latin typeface="Calibri" pitchFamily="34" charset="0"/>
+                <a:ea typeface="Calibri" pitchFamily="34" charset="-122"/>
+                <a:cs typeface="Calibri" pitchFamily="34" charset="-120"/>
+              </a:rPr>
+              <a:t>Externa · Cliente</a:t>
+            </a:r>
+            <a:endParaRPr lang="en-US" sz="1050" dirty="0"/>
+          </a:p>
+        </p:txBody>
+      </p:sp>
+      <p:sp>
+        <p:nvSpPr>
+          <p:cNvPr id="44" name="Text 40"/>
+          <p:cNvSpPr/>
+          <p:nvPr/>
+        </p:nvSpPr>
+        <p:spPr>
+          <a:xfrm>
+            <a:off x="6446520" y="4754880"/>
+            <a:ext cx="1097280" cy="237744"/>
+          </a:xfrm>
+          <a:prstGeom prst="rect">
+            <a:avLst/>
+          </a:prstGeom>
+          <a:noFill/>
+          <a:ln/>
+        </p:spPr>
+        <p:txBody>
+          <a:bodyPr wrap="square" lIns="0" tIns="0" rIns="0" bIns="0" rtlCol="0" anchor="ctr"/>
+          <a:lstStyle/>
+          <a:p>
+            <a:pPr algn="l" indent="0" marL="0">
+              <a:buNone/>
+            </a:pPr>
+            <a:r>
+              <a:rPr lang="en-US" sz="1050" dirty="0">
+                <a:solidFill>
+                  <a:srgbClr val="1A2433"/>
+                </a:solidFill>
+                <a:latin typeface="Calibri" pitchFamily="34" charset="0"/>
+                <a:ea typeface="Calibri" pitchFamily="34" charset="-122"/>
+                <a:cs typeface="Calibri" pitchFamily="34" charset="-120"/>
+              </a:rPr>
+              <a:t>Sin especial…</a:t>
+            </a:r>
+            <a:endParaRPr lang="en-US" sz="1050" dirty="0"/>
+          </a:p>
+        </p:txBody>
+      </p:sp>
+      <p:sp>
+        <p:nvSpPr>
+          <p:cNvPr id="45" name="Text 41"/>
+          <p:cNvSpPr/>
+          <p:nvPr/>
+        </p:nvSpPr>
+        <p:spPr>
+          <a:xfrm>
+            <a:off x="7589520" y="4754880"/>
+            <a:ext cx="1371600" cy="237744"/>
+          </a:xfrm>
+          <a:prstGeom prst="rect">
+            <a:avLst/>
+          </a:prstGeom>
+          <a:noFill/>
+          <a:ln/>
+        </p:spPr>
+        <p:txBody>
+          <a:bodyPr wrap="square" lIns="0" tIns="0" rIns="0" bIns="0" rtlCol="0" anchor="ctr"/>
+          <a:lstStyle/>
+          <a:p>
+            <a:pPr algn="l" indent="0" marL="0">
+              <a:buNone/>
+            </a:pPr>
+            <a:r>
+              <a:rPr lang="en-US" sz="1050" dirty="0">
+                <a:solidFill>
+                  <a:srgbClr val="1A2433"/>
+                </a:solidFill>
+                <a:latin typeface="Calibri" pitchFamily="34" charset="0"/>
+                <a:ea typeface="Calibri" pitchFamily="34" charset="-122"/>
+                <a:cs typeface="Calibri" pitchFamily="34" charset="-120"/>
+              </a:rPr>
+              <a:t>Sin asignar</a:t>
+            </a:r>
+            <a:endParaRPr lang="en-US" sz="1050" dirty="0"/>
+          </a:p>
+        </p:txBody>
+      </p:sp>
+      <p:sp>
+        <p:nvSpPr>
+          <p:cNvPr id="46" name="Text 42"/>
+          <p:cNvSpPr/>
+          <p:nvPr/>
+        </p:nvSpPr>
+        <p:spPr>
+          <a:xfrm>
+            <a:off x="9006840" y="4754880"/>
+            <a:ext cx="868680" cy="237744"/>
+          </a:xfrm>
+          <a:prstGeom prst="rect">
+            <a:avLst/>
+          </a:prstGeom>
+          <a:noFill/>
+          <a:ln/>
+        </p:spPr>
+        <p:txBody>
+          <a:bodyPr wrap="square" lIns="0" tIns="0" rIns="0" bIns="0" rtlCol="0" anchor="ctr"/>
+          <a:lstStyle/>
+          <a:p>
+            <a:pPr algn="l" indent="0" marL="0">
+              <a:buNone/>
+            </a:pPr>
+            <a:r>
+              <a:rPr lang="en-US" sz="1050" dirty="0">
+                <a:solidFill>
+                  <a:srgbClr val="C0392B"/>
+                </a:solidFill>
+                <a:latin typeface="Calibri" pitchFamily="34" charset="0"/>
+                <a:ea typeface="Calibri" pitchFamily="34" charset="-122"/>
+                <a:cs typeface="Calibri" pitchFamily="34" charset="-120"/>
+              </a:rPr>
+              <a:t>Pendiente</a:t>
+            </a:r>
+            <a:endParaRPr lang="en-US" sz="1050" dirty="0"/>
+          </a:p>
+        </p:txBody>
+      </p:sp>
+      <p:sp>
+        <p:nvSpPr>
+          <p:cNvPr id="47" name="Text 43"/>
+          <p:cNvSpPr/>
+          <p:nvPr/>
+        </p:nvSpPr>
+        <p:spPr>
+          <a:xfrm>
+            <a:off x="9921240" y="4754880"/>
+            <a:ext cx="1828800" cy="237744"/>
+          </a:xfrm>
+          <a:prstGeom prst="rect">
+            <a:avLst/>
+          </a:prstGeom>
+          <a:noFill/>
+          <a:ln/>
+        </p:spPr>
+        <p:txBody>
+          <a:bodyPr wrap="square" lIns="0" tIns="0" rIns="0" bIns="0" rtlCol="0" anchor="ctr"/>
+          <a:lstStyle/>
+          <a:p>
+            <a:pPr algn="l" indent="0" marL="0">
+              <a:buNone/>
+            </a:pPr>
+            <a:r>
+              <a:rPr lang="en-US" sz="1000" dirty="0">
+                <a:solidFill>
+                  <a:srgbClr val="1A2433"/>
+                </a:solidFill>
+                <a:latin typeface="Calibri" pitchFamily="34" charset="0"/>
+                <a:ea typeface="Calibri" pitchFamily="34" charset="-122"/>
+                <a:cs typeface="Calibri" pitchFamily="34" charset="-120"/>
+              </a:rPr>
+              <a:t>Elevación bomba de cizalle.…</a:t>
+            </a:r>
+            <a:endParaRPr lang="en-US" sz="1000" dirty="0"/>
+          </a:p>
+        </p:txBody>
+      </p:sp>
+      <p:sp>
+        <p:nvSpPr>
+          <p:cNvPr id="48" name="Shape 44"/>
+          <p:cNvSpPr/>
+          <p:nvPr/>
+        </p:nvSpPr>
+        <p:spPr>
+          <a:xfrm>
+            <a:off x="502920" y="5029200"/>
+            <a:ext cx="11247120" cy="0"/>
+          </a:xfrm>
+          <a:prstGeom prst="line">
+            <a:avLst/>
+          </a:prstGeom>
+          <a:noFill/>
+          <a:ln w="9525">
+            <a:solidFill>
+              <a:srgbClr val="D9DFE6"/>
+            </a:solidFill>
+            <a:prstDash val="solid"/>
+          </a:ln>
+        </p:spPr>
+      </p:sp>
+      <p:sp>
+        <p:nvSpPr>
+          <p:cNvPr id="49" name="Text 45"/>
+          <p:cNvSpPr/>
+          <p:nvPr/>
+        </p:nvSpPr>
+        <p:spPr>
+          <a:xfrm>
+            <a:off x="502920" y="5084064"/>
+            <a:ext cx="822960" cy="237744"/>
+          </a:xfrm>
+          <a:prstGeom prst="rect">
+            <a:avLst/>
+          </a:prstGeom>
+          <a:noFill/>
+          <a:ln/>
+        </p:spPr>
+        <p:txBody>
+          <a:bodyPr wrap="square" lIns="0" tIns="0" rIns="0" bIns="0" rtlCol="0" anchor="ctr"/>
+          <a:lstStyle/>
+          <a:p>
+            <a:pPr algn="l" indent="0" marL="0">
+              <a:buNone/>
+            </a:pPr>
+            <a:r>
+              <a:rPr lang="en-US" sz="1050" dirty="0">
+                <a:solidFill>
+                  <a:srgbClr val="1A2433"/>
+                </a:solidFill>
+                <a:latin typeface="Calibri" pitchFamily="34" charset="0"/>
+                <a:ea typeface="Calibri" pitchFamily="34" charset="-122"/>
+                <a:cs typeface="Calibri" pitchFamily="34" charset="-120"/>
+              </a:rPr>
+              <a:t>01-09-2026</a:t>
+            </a:r>
+            <a:endParaRPr lang="en-US" sz="1050" dirty="0"/>
+          </a:p>
+        </p:txBody>
+      </p:sp>
+      <p:sp>
+        <p:nvSpPr>
+          <p:cNvPr id="50" name="Text 46"/>
+          <p:cNvSpPr/>
+          <p:nvPr/>
+        </p:nvSpPr>
+        <p:spPr>
+          <a:xfrm>
+            <a:off x="1371600" y="5084064"/>
+            <a:ext cx="1051560" cy="237744"/>
+          </a:xfrm>
+          <a:prstGeom prst="rect">
+            <a:avLst/>
+          </a:prstGeom>
+          <a:noFill/>
+          <a:ln/>
+        </p:spPr>
+        <p:txBody>
+          <a:bodyPr wrap="square" lIns="0" tIns="0" rIns="0" bIns="0" rtlCol="0" anchor="ctr"/>
+          <a:lstStyle/>
+          <a:p>
+            <a:pPr algn="l" indent="0" marL="0">
+              <a:buNone/>
+            </a:pPr>
+            <a:r>
+              <a:rPr lang="en-US" sz="1050" dirty="0">
+                <a:solidFill>
+                  <a:srgbClr val="1A2433"/>
+                </a:solidFill>
+                <a:latin typeface="Calibri" pitchFamily="34" charset="0"/>
+                <a:ea typeface="Calibri" pitchFamily="34" charset="-122"/>
+                <a:cs typeface="Calibri" pitchFamily="34" charset="-120"/>
+              </a:rPr>
+              <a:t>Arqueros</a:t>
+            </a:r>
+            <a:endParaRPr lang="en-US" sz="1050" dirty="0"/>
+          </a:p>
+        </p:txBody>
+      </p:sp>
+      <p:sp>
+        <p:nvSpPr>
+          <p:cNvPr id="51" name="Text 47"/>
+          <p:cNvSpPr/>
+          <p:nvPr/>
+        </p:nvSpPr>
+        <p:spPr>
+          <a:xfrm>
+            <a:off x="2468880" y="5084064"/>
+            <a:ext cx="1051560" cy="237744"/>
+          </a:xfrm>
+          <a:prstGeom prst="rect">
+            <a:avLst/>
+          </a:prstGeom>
+          <a:noFill/>
+          <a:ln/>
+        </p:spPr>
+        <p:txBody>
+          <a:bodyPr wrap="square" lIns="0" tIns="0" rIns="0" bIns="0" rtlCol="0" anchor="ctr"/>
+          <a:lstStyle/>
+          <a:p>
+            <a:pPr algn="l" indent="0" marL="0">
+              <a:buNone/>
+            </a:pPr>
+            <a:r>
+              <a:rPr lang="en-US" sz="1050" dirty="0">
+                <a:solidFill>
+                  <a:srgbClr val="1A2433"/>
+                </a:solidFill>
+                <a:latin typeface="Calibri" pitchFamily="34" charset="0"/>
+                <a:ea typeface="Calibri" pitchFamily="34" charset="-122"/>
+                <a:cs typeface="Calibri" pitchFamily="34" charset="-120"/>
+              </a:rPr>
+              <a:t>MASA-88 · EB-NE-1412</a:t>
+            </a:r>
+            <a:endParaRPr lang="en-US" sz="1050" dirty="0"/>
+          </a:p>
+        </p:txBody>
+      </p:sp>
+      <p:sp>
+        <p:nvSpPr>
+          <p:cNvPr id="52" name="Text 48"/>
+          <p:cNvSpPr/>
+          <p:nvPr/>
+        </p:nvSpPr>
+        <p:spPr>
+          <a:xfrm>
+            <a:off x="3566160" y="5084064"/>
+            <a:ext cx="1371600" cy="237744"/>
+          </a:xfrm>
+          <a:prstGeom prst="rect">
+            <a:avLst/>
+          </a:prstGeom>
+          <a:noFill/>
+          <a:ln/>
+        </p:spPr>
+        <p:txBody>
+          <a:bodyPr wrap="square" lIns="0" tIns="0" rIns="0" bIns="0" rtlCol="0" anchor="ctr"/>
+          <a:lstStyle/>
+          <a:p>
+            <a:pPr algn="l" indent="0" marL="0">
+              <a:buNone/>
+            </a:pPr>
+            <a:r>
+              <a:rPr lang="en-US" sz="1050" dirty="0">
+                <a:solidFill>
+                  <a:srgbClr val="1A2433"/>
+                </a:solidFill>
+                <a:latin typeface="Calibri" pitchFamily="34" charset="0"/>
+                <a:ea typeface="Calibri" pitchFamily="34" charset="-122"/>
+                <a:cs typeface="Calibri" pitchFamily="34" charset="-120"/>
+              </a:rPr>
+              <a:t>No Conformidad</a:t>
+            </a:r>
+            <a:endParaRPr lang="en-US" sz="1050" dirty="0"/>
+          </a:p>
+        </p:txBody>
+      </p:sp>
+      <p:sp>
+        <p:nvSpPr>
+          <p:cNvPr id="53" name="Text 49"/>
+          <p:cNvSpPr/>
+          <p:nvPr/>
+        </p:nvSpPr>
+        <p:spPr>
+          <a:xfrm>
+            <a:off x="4983480" y="5084064"/>
+            <a:ext cx="1417320" cy="237744"/>
+          </a:xfrm>
+          <a:prstGeom prst="rect">
+            <a:avLst/>
+          </a:prstGeom>
+          <a:noFill/>
+          <a:ln/>
+        </p:spPr>
+        <p:txBody>
+          <a:bodyPr wrap="square" lIns="0" tIns="0" rIns="0" bIns="0" rtlCol="0" anchor="ctr"/>
+          <a:lstStyle/>
+          <a:p>
+            <a:pPr algn="l" indent="0" marL="0">
+              <a:buNone/>
+            </a:pPr>
+            <a:r>
+              <a:rPr lang="en-US" sz="1050" b="1" dirty="0">
+                <a:solidFill>
+                  <a:srgbClr val="C87A32"/>
+                </a:solidFill>
+                <a:latin typeface="Calibri" pitchFamily="34" charset="0"/>
+                <a:ea typeface="Calibri" pitchFamily="34" charset="-122"/>
+                <a:cs typeface="Calibri" pitchFamily="34" charset="-120"/>
+              </a:rPr>
+              <a:t>Externa · Cliente</a:t>
+            </a:r>
+            <a:endParaRPr lang="en-US" sz="1050" dirty="0"/>
+          </a:p>
+        </p:txBody>
+      </p:sp>
+      <p:sp>
+        <p:nvSpPr>
+          <p:cNvPr id="54" name="Text 50"/>
+          <p:cNvSpPr/>
+          <p:nvPr/>
+        </p:nvSpPr>
+        <p:spPr>
+          <a:xfrm>
+            <a:off x="6446520" y="5084064"/>
+            <a:ext cx="1097280" cy="237744"/>
+          </a:xfrm>
+          <a:prstGeom prst="rect">
+            <a:avLst/>
+          </a:prstGeom>
+          <a:noFill/>
+          <a:ln/>
+        </p:spPr>
+        <p:txBody>
+          <a:bodyPr wrap="square" lIns="0" tIns="0" rIns="0" bIns="0" rtlCol="0" anchor="ctr"/>
+          <a:lstStyle/>
+          <a:p>
+            <a:pPr algn="l" indent="0" marL="0">
+              <a:buNone/>
+            </a:pPr>
+            <a:r>
+              <a:rPr lang="en-US" sz="1050" dirty="0">
+                <a:solidFill>
+                  <a:srgbClr val="1A2433"/>
+                </a:solidFill>
+                <a:latin typeface="Calibri" pitchFamily="34" charset="0"/>
+                <a:ea typeface="Calibri" pitchFamily="34" charset="-122"/>
+                <a:cs typeface="Calibri" pitchFamily="34" charset="-120"/>
+              </a:rPr>
+              <a:t>Sin especial…</a:t>
+            </a:r>
+            <a:endParaRPr lang="en-US" sz="1050" dirty="0"/>
+          </a:p>
+        </p:txBody>
+      </p:sp>
+      <p:sp>
+        <p:nvSpPr>
+          <p:cNvPr id="55" name="Text 51"/>
+          <p:cNvSpPr/>
+          <p:nvPr/>
+        </p:nvSpPr>
+        <p:spPr>
+          <a:xfrm>
+            <a:off x="7589520" y="5084064"/>
+            <a:ext cx="1371600" cy="237744"/>
+          </a:xfrm>
+          <a:prstGeom prst="rect">
+            <a:avLst/>
+          </a:prstGeom>
+          <a:noFill/>
+          <a:ln/>
+        </p:spPr>
+        <p:txBody>
+          <a:bodyPr wrap="square" lIns="0" tIns="0" rIns="0" bIns="0" rtlCol="0" anchor="ctr"/>
+          <a:lstStyle/>
+          <a:p>
+            <a:pPr algn="l" indent="0" marL="0">
+              <a:buNone/>
+            </a:pPr>
+            <a:r>
+              <a:rPr lang="en-US" sz="1050" dirty="0">
+                <a:solidFill>
+                  <a:srgbClr val="1A2433"/>
+                </a:solidFill>
+                <a:latin typeface="Calibri" pitchFamily="34" charset="0"/>
+                <a:ea typeface="Calibri" pitchFamily="34" charset="-122"/>
+                <a:cs typeface="Calibri" pitchFamily="34" charset="-120"/>
+              </a:rPr>
+              <a:t>Sin asignar</a:t>
+            </a:r>
+            <a:endParaRPr lang="en-US" sz="1050" dirty="0"/>
+          </a:p>
+        </p:txBody>
+      </p:sp>
+      <p:sp>
+        <p:nvSpPr>
+          <p:cNvPr id="56" name="Text 52"/>
+          <p:cNvSpPr/>
+          <p:nvPr/>
+        </p:nvSpPr>
+        <p:spPr>
+          <a:xfrm>
+            <a:off x="9006840" y="5084064"/>
+            <a:ext cx="868680" cy="237744"/>
+          </a:xfrm>
+          <a:prstGeom prst="rect">
+            <a:avLst/>
+          </a:prstGeom>
+          <a:noFill/>
+          <a:ln/>
+        </p:spPr>
+        <p:txBody>
+          <a:bodyPr wrap="square" lIns="0" tIns="0" rIns="0" bIns="0" rtlCol="0" anchor="ctr"/>
+          <a:lstStyle/>
+          <a:p>
+            <a:pPr algn="l" indent="0" marL="0">
+              <a:buNone/>
+            </a:pPr>
+            <a:r>
+              <a:rPr lang="en-US" sz="1050" dirty="0">
+                <a:solidFill>
+                  <a:srgbClr val="C0392B"/>
+                </a:solidFill>
+                <a:latin typeface="Calibri" pitchFamily="34" charset="0"/>
+                <a:ea typeface="Calibri" pitchFamily="34" charset="-122"/>
+                <a:cs typeface="Calibri" pitchFamily="34" charset="-120"/>
+              </a:rPr>
+              <a:t>Pendiente</a:t>
+            </a:r>
+            <a:endParaRPr lang="en-US" sz="1050" dirty="0"/>
+          </a:p>
+        </p:txBody>
+      </p:sp>
+      <p:sp>
+        <p:nvSpPr>
+          <p:cNvPr id="57" name="Text 53"/>
+          <p:cNvSpPr/>
+          <p:nvPr/>
+        </p:nvSpPr>
+        <p:spPr>
+          <a:xfrm>
+            <a:off x="9921240" y="5084064"/>
+            <a:ext cx="1828800" cy="237744"/>
+          </a:xfrm>
+          <a:prstGeom prst="rect">
+            <a:avLst/>
+          </a:prstGeom>
+          <a:noFill/>
+          <a:ln/>
+        </p:spPr>
+        <p:txBody>
+          <a:bodyPr wrap="square" lIns="0" tIns="0" rIns="0" bIns="0" rtlCol="0" anchor="ctr"/>
+          <a:lstStyle/>
+          <a:p>
+            <a:pPr algn="l" indent="0" marL="0">
+              <a:buNone/>
+            </a:pPr>
+            <a:r>
+              <a:rPr lang="en-US" sz="1000" dirty="0">
+                <a:solidFill>
+                  <a:srgbClr val="1A2433"/>
+                </a:solidFill>
+                <a:latin typeface="Calibri" pitchFamily="34" charset="0"/>
+                <a:ea typeface="Calibri" pitchFamily="34" charset="-122"/>
+                <a:cs typeface="Calibri" pitchFamily="34" charset="-120"/>
+              </a:rPr>
+              <a:t>Desviación en línea de succ…</a:t>
+            </a:r>
+            <a:endParaRPr lang="en-US" sz="1000" dirty="0"/>
+          </a:p>
+        </p:txBody>
+      </p:sp>
+      <p:sp>
+        <p:nvSpPr>
+          <p:cNvPr id="58" name="Shape 54"/>
+          <p:cNvSpPr/>
+          <p:nvPr/>
+        </p:nvSpPr>
+        <p:spPr>
+          <a:xfrm>
+            <a:off x="502920" y="5358384"/>
+            <a:ext cx="11247120" cy="0"/>
+          </a:xfrm>
+          <a:prstGeom prst="line">
+            <a:avLst/>
+          </a:prstGeom>
+          <a:noFill/>
+          <a:ln w="9525">
+            <a:solidFill>
+              <a:srgbClr val="D9DFE6"/>
+            </a:solidFill>
+            <a:prstDash val="solid"/>
+          </a:ln>
+        </p:spPr>
+      </p:sp>
+      <p:sp>
+        <p:nvSpPr>
+          <p:cNvPr id="59" name="Shape 55"/>
+          <p:cNvSpPr/>
+          <p:nvPr/>
+        </p:nvSpPr>
+        <p:spPr>
+          <a:xfrm>
+            <a:off x="457200" y="5367528"/>
+            <a:ext cx="11292840" cy="329184"/>
+          </a:xfrm>
+          <a:prstGeom prst="rect">
+            <a:avLst/>
+          </a:prstGeom>
+          <a:solidFill>
+            <a:srgbClr val="FFFFFF"/>
+          </a:solidFill>
+          <a:ln/>
+        </p:spPr>
+      </p:sp>
+      <p:sp>
+        <p:nvSpPr>
+          <p:cNvPr id="60" name="Text 56"/>
+          <p:cNvSpPr/>
+          <p:nvPr/>
+        </p:nvSpPr>
+        <p:spPr>
+          <a:xfrm>
+            <a:off x="502920" y="5413248"/>
+            <a:ext cx="822960" cy="237744"/>
+          </a:xfrm>
+          <a:prstGeom prst="rect">
+            <a:avLst/>
+          </a:prstGeom>
+          <a:noFill/>
+          <a:ln/>
+        </p:spPr>
+        <p:txBody>
+          <a:bodyPr wrap="square" lIns="0" tIns="0" rIns="0" bIns="0" rtlCol="0" anchor="ctr"/>
+          <a:lstStyle/>
+          <a:p>
+            <a:pPr algn="l" indent="0" marL="0">
+              <a:buNone/>
+            </a:pPr>
+            <a:r>
+              <a:rPr lang="en-US" sz="1050" dirty="0">
+                <a:solidFill>
+                  <a:srgbClr val="1A2433"/>
+                </a:solidFill>
+                <a:latin typeface="Calibri" pitchFamily="34" charset="0"/>
+                <a:ea typeface="Calibri" pitchFamily="34" charset="-122"/>
+                <a:cs typeface="Calibri" pitchFamily="34" charset="-120"/>
+              </a:rPr>
+              <a:t>01-09-2026</a:t>
+            </a:r>
+            <a:endParaRPr lang="en-US" sz="1050" dirty="0"/>
+          </a:p>
+        </p:txBody>
+      </p:sp>
+      <p:sp>
+        <p:nvSpPr>
+          <p:cNvPr id="61" name="Text 57"/>
+          <p:cNvSpPr/>
+          <p:nvPr/>
+        </p:nvSpPr>
+        <p:spPr>
+          <a:xfrm>
+            <a:off x="1371600" y="5413248"/>
+            <a:ext cx="1051560" cy="237744"/>
+          </a:xfrm>
+          <a:prstGeom prst="rect">
+            <a:avLst/>
+          </a:prstGeom>
+          <a:noFill/>
+          <a:ln/>
+        </p:spPr>
+        <p:txBody>
+          <a:bodyPr wrap="square" lIns="0" tIns="0" rIns="0" bIns="0" rtlCol="0" anchor="ctr"/>
+          <a:lstStyle/>
+          <a:p>
+            <a:pPr algn="l" indent="0" marL="0">
+              <a:buNone/>
+            </a:pPr>
+            <a:r>
+              <a:rPr lang="en-US" sz="1050" dirty="0">
+                <a:solidFill>
+                  <a:srgbClr val="1A2433"/>
+                </a:solidFill>
+                <a:latin typeface="Calibri" pitchFamily="34" charset="0"/>
+                <a:ea typeface="Calibri" pitchFamily="34" charset="-122"/>
+                <a:cs typeface="Calibri" pitchFamily="34" charset="-120"/>
+              </a:rPr>
+              <a:t>Arqueros</a:t>
+            </a:r>
+            <a:endParaRPr lang="en-US" sz="1050" dirty="0"/>
+          </a:p>
+        </p:txBody>
+      </p:sp>
+      <p:sp>
+        <p:nvSpPr>
+          <p:cNvPr id="62" name="Text 58"/>
+          <p:cNvSpPr/>
+          <p:nvPr/>
+        </p:nvSpPr>
+        <p:spPr>
+          <a:xfrm>
+            <a:off x="2468880" y="5413248"/>
+            <a:ext cx="1051560" cy="237744"/>
+          </a:xfrm>
+          <a:prstGeom prst="rect">
+            <a:avLst/>
+          </a:prstGeom>
+          <a:noFill/>
+          <a:ln/>
+        </p:spPr>
+        <p:txBody>
+          <a:bodyPr wrap="square" lIns="0" tIns="0" rIns="0" bIns="0" rtlCol="0" anchor="ctr"/>
+          <a:lstStyle/>
+          <a:p>
+            <a:pPr algn="l" indent="0" marL="0">
+              <a:buNone/>
+            </a:pPr>
+            <a:r>
+              <a:rPr lang="en-US" sz="1050" dirty="0">
+                <a:solidFill>
+                  <a:srgbClr val="1A2433"/>
+                </a:solidFill>
+                <a:latin typeface="Calibri" pitchFamily="34" charset="0"/>
+                <a:ea typeface="Calibri" pitchFamily="34" charset="-122"/>
+                <a:cs typeface="Calibri" pitchFamily="34" charset="-120"/>
+              </a:rPr>
+              <a:t>MASA-89 · EB-NE-1412</a:t>
+            </a:r>
+            <a:endParaRPr lang="en-US" sz="1050" dirty="0"/>
+          </a:p>
+        </p:txBody>
+      </p:sp>
+      <p:sp>
+        <p:nvSpPr>
+          <p:cNvPr id="63" name="Text 59"/>
+          <p:cNvSpPr/>
+          <p:nvPr/>
+        </p:nvSpPr>
+        <p:spPr>
+          <a:xfrm>
+            <a:off x="3566160" y="5413248"/>
+            <a:ext cx="1371600" cy="237744"/>
+          </a:xfrm>
+          <a:prstGeom prst="rect">
+            <a:avLst/>
+          </a:prstGeom>
+          <a:noFill/>
+          <a:ln/>
+        </p:spPr>
+        <p:txBody>
+          <a:bodyPr wrap="square" lIns="0" tIns="0" rIns="0" bIns="0" rtlCol="0" anchor="ctr"/>
+          <a:lstStyle/>
+          <a:p>
+            <a:pPr algn="l" indent="0" marL="0">
+              <a:buNone/>
+            </a:pPr>
+            <a:r>
+              <a:rPr lang="en-US" sz="1050" dirty="0">
+                <a:solidFill>
+                  <a:srgbClr val="1A2433"/>
+                </a:solidFill>
+                <a:latin typeface="Calibri" pitchFamily="34" charset="0"/>
+                <a:ea typeface="Calibri" pitchFamily="34" charset="-122"/>
+                <a:cs typeface="Calibri" pitchFamily="34" charset="-120"/>
+              </a:rPr>
+              <a:t>No Conformidad</a:t>
+            </a:r>
+            <a:endParaRPr lang="en-US" sz="1050" dirty="0"/>
+          </a:p>
+        </p:txBody>
+      </p:sp>
+      <p:sp>
+        <p:nvSpPr>
+          <p:cNvPr id="64" name="Text 60"/>
+          <p:cNvSpPr/>
+          <p:nvPr/>
+        </p:nvSpPr>
+        <p:spPr>
+          <a:xfrm>
+            <a:off x="4983480" y="5413248"/>
+            <a:ext cx="1417320" cy="237744"/>
+          </a:xfrm>
+          <a:prstGeom prst="rect">
+            <a:avLst/>
+          </a:prstGeom>
+          <a:noFill/>
+          <a:ln/>
+        </p:spPr>
+        <p:txBody>
+          <a:bodyPr wrap="square" lIns="0" tIns="0" rIns="0" bIns="0" rtlCol="0" anchor="ctr"/>
+          <a:lstStyle/>
+          <a:p>
+            <a:pPr algn="l" indent="0" marL="0">
+              <a:buNone/>
+            </a:pPr>
+            <a:r>
+              <a:rPr lang="en-US" sz="1050" b="1" dirty="0">
+                <a:solidFill>
+                  <a:srgbClr val="C87A32"/>
+                </a:solidFill>
+                <a:latin typeface="Calibri" pitchFamily="34" charset="0"/>
+                <a:ea typeface="Calibri" pitchFamily="34" charset="-122"/>
+                <a:cs typeface="Calibri" pitchFamily="34" charset="-120"/>
+              </a:rPr>
+              <a:t>Externa · Cliente</a:t>
+            </a:r>
+            <a:endParaRPr lang="en-US" sz="1050" dirty="0"/>
+          </a:p>
+        </p:txBody>
+      </p:sp>
+      <p:sp>
+        <p:nvSpPr>
+          <p:cNvPr id="65" name="Text 61"/>
+          <p:cNvSpPr/>
+          <p:nvPr/>
+        </p:nvSpPr>
+        <p:spPr>
+          <a:xfrm>
+            <a:off x="6446520" y="5413248"/>
+            <a:ext cx="1097280" cy="237744"/>
+          </a:xfrm>
+          <a:prstGeom prst="rect">
+            <a:avLst/>
+          </a:prstGeom>
+          <a:noFill/>
+          <a:ln/>
+        </p:spPr>
+        <p:txBody>
+          <a:bodyPr wrap="square" lIns="0" tIns="0" rIns="0" bIns="0" rtlCol="0" anchor="ctr"/>
+          <a:lstStyle/>
+          <a:p>
+            <a:pPr algn="l" indent="0" marL="0">
+              <a:buNone/>
+            </a:pPr>
+            <a:r>
+              <a:rPr lang="en-US" sz="1050" dirty="0">
+                <a:solidFill>
+                  <a:srgbClr val="1A2433"/>
+                </a:solidFill>
+                <a:latin typeface="Calibri" pitchFamily="34" charset="0"/>
+                <a:ea typeface="Calibri" pitchFamily="34" charset="-122"/>
+                <a:cs typeface="Calibri" pitchFamily="34" charset="-120"/>
+              </a:rPr>
+              <a:t>Sin especial…</a:t>
+            </a:r>
+            <a:endParaRPr lang="en-US" sz="1050" dirty="0"/>
+          </a:p>
+        </p:txBody>
+      </p:sp>
+      <p:sp>
+        <p:nvSpPr>
+          <p:cNvPr id="66" name="Text 62"/>
+          <p:cNvSpPr/>
+          <p:nvPr/>
+        </p:nvSpPr>
+        <p:spPr>
+          <a:xfrm>
+            <a:off x="7589520" y="5413248"/>
+            <a:ext cx="1371600" cy="237744"/>
+          </a:xfrm>
+          <a:prstGeom prst="rect">
+            <a:avLst/>
+          </a:prstGeom>
+          <a:noFill/>
+          <a:ln/>
+        </p:spPr>
+        <p:txBody>
+          <a:bodyPr wrap="square" lIns="0" tIns="0" rIns="0" bIns="0" rtlCol="0" anchor="ctr"/>
+          <a:lstStyle/>
+          <a:p>
+            <a:pPr algn="l" indent="0" marL="0">
+              <a:buNone/>
+            </a:pPr>
+            <a:r>
+              <a:rPr lang="en-US" sz="1050" dirty="0">
+                <a:solidFill>
+                  <a:srgbClr val="1A2433"/>
+                </a:solidFill>
+                <a:latin typeface="Calibri" pitchFamily="34" charset="0"/>
+                <a:ea typeface="Calibri" pitchFamily="34" charset="-122"/>
+                <a:cs typeface="Calibri" pitchFamily="34" charset="-120"/>
+              </a:rPr>
+              <a:t>Sin asignar</a:t>
+            </a:r>
+            <a:endParaRPr lang="en-US" sz="1050" dirty="0"/>
+          </a:p>
+        </p:txBody>
+      </p:sp>
+      <p:sp>
+        <p:nvSpPr>
+          <p:cNvPr id="67" name="Text 63"/>
+          <p:cNvSpPr/>
+          <p:nvPr/>
+        </p:nvSpPr>
+        <p:spPr>
+          <a:xfrm>
+            <a:off x="9006840" y="5413248"/>
+            <a:ext cx="868680" cy="237744"/>
+          </a:xfrm>
+          <a:prstGeom prst="rect">
+            <a:avLst/>
+          </a:prstGeom>
+          <a:noFill/>
+          <a:ln/>
+        </p:spPr>
+        <p:txBody>
+          <a:bodyPr wrap="square" lIns="0" tIns="0" rIns="0" bIns="0" rtlCol="0" anchor="ctr"/>
+          <a:lstStyle/>
+          <a:p>
+            <a:pPr algn="l" indent="0" marL="0">
+              <a:buNone/>
+            </a:pPr>
+            <a:r>
+              <a:rPr lang="en-US" sz="1050" dirty="0">
+                <a:solidFill>
+                  <a:srgbClr val="C0392B"/>
+                </a:solidFill>
+                <a:latin typeface="Calibri" pitchFamily="34" charset="0"/>
+                <a:ea typeface="Calibri" pitchFamily="34" charset="-122"/>
+                <a:cs typeface="Calibri" pitchFamily="34" charset="-120"/>
+              </a:rPr>
+              <a:t>Pendiente</a:t>
+            </a:r>
+            <a:endParaRPr lang="en-US" sz="1050" dirty="0"/>
+          </a:p>
+        </p:txBody>
+      </p:sp>
+      <p:sp>
+        <p:nvSpPr>
+          <p:cNvPr id="68" name="Text 64"/>
+          <p:cNvSpPr/>
+          <p:nvPr/>
+        </p:nvSpPr>
+        <p:spPr>
+          <a:xfrm>
+            <a:off x="9921240" y="5413248"/>
+            <a:ext cx="1828800" cy="237744"/>
+          </a:xfrm>
+          <a:prstGeom prst="rect">
+            <a:avLst/>
+          </a:prstGeom>
+          <a:noFill/>
+          <a:ln/>
+        </p:spPr>
+        <p:txBody>
+          <a:bodyPr wrap="square" lIns="0" tIns="0" rIns="0" bIns="0" rtlCol="0" anchor="ctr"/>
+          <a:lstStyle/>
+          <a:p>
+            <a:pPr algn="l" indent="0" marL="0">
+              <a:buNone/>
+            </a:pPr>
+            <a:r>
+              <a:rPr lang="en-US" sz="1000" dirty="0">
+                <a:solidFill>
+                  <a:srgbClr val="1A2433"/>
+                </a:solidFill>
+                <a:latin typeface="Calibri" pitchFamily="34" charset="0"/>
+                <a:ea typeface="Calibri" pitchFamily="34" charset="-122"/>
+                <a:cs typeface="Calibri" pitchFamily="34" charset="-120"/>
+              </a:rPr>
+              <a:t>Desviación en alturagrado d…</a:t>
+            </a:r>
+            <a:endParaRPr lang="en-US" sz="1000" dirty="0"/>
+          </a:p>
+        </p:txBody>
+      </p:sp>
+      <p:sp>
+        <p:nvSpPr>
+          <p:cNvPr id="69" name="Shape 65"/>
+          <p:cNvSpPr/>
+          <p:nvPr/>
+        </p:nvSpPr>
+        <p:spPr>
+          <a:xfrm>
+            <a:off x="502920" y="5687568"/>
+            <a:ext cx="11247120" cy="0"/>
+          </a:xfrm>
+          <a:prstGeom prst="line">
+            <a:avLst/>
+          </a:prstGeom>
+          <a:noFill/>
+          <a:ln w="9525">
+            <a:solidFill>
+              <a:srgbClr val="D9DFE6"/>
+            </a:solidFill>
+            <a:prstDash val="solid"/>
+          </a:ln>
+        </p:spPr>
+      </p:sp>
+      <p:sp>
+        <p:nvSpPr>
+          <p:cNvPr id="70" name="Text 66"/>
+          <p:cNvSpPr/>
+          <p:nvPr/>
+        </p:nvSpPr>
+        <p:spPr>
+          <a:xfrm>
+            <a:off x="502920" y="5742432"/>
+            <a:ext cx="822960" cy="237744"/>
+          </a:xfrm>
+          <a:prstGeom prst="rect">
+            <a:avLst/>
+          </a:prstGeom>
+          <a:noFill/>
+          <a:ln/>
+        </p:spPr>
+        <p:txBody>
+          <a:bodyPr wrap="square" lIns="0" tIns="0" rIns="0" bIns="0" rtlCol="0" anchor="ctr"/>
+          <a:lstStyle/>
+          <a:p>
+            <a:pPr algn="l" indent="0" marL="0">
+              <a:buNone/>
+            </a:pPr>
+            <a:r>
+              <a:rPr lang="en-US" sz="1050" dirty="0">
+                <a:solidFill>
+                  <a:srgbClr val="1A2433"/>
+                </a:solidFill>
+                <a:latin typeface="Calibri" pitchFamily="34" charset="0"/>
+                <a:ea typeface="Calibri" pitchFamily="34" charset="-122"/>
+                <a:cs typeface="Calibri" pitchFamily="34" charset="-120"/>
+              </a:rPr>
+              <a:t>01-09-2026</a:t>
+            </a:r>
+            <a:endParaRPr lang="en-US" sz="1050" dirty="0"/>
+          </a:p>
+        </p:txBody>
+      </p:sp>
+      <p:sp>
+        <p:nvSpPr>
+          <p:cNvPr id="71" name="Text 67"/>
+          <p:cNvSpPr/>
+          <p:nvPr/>
+        </p:nvSpPr>
+        <p:spPr>
+          <a:xfrm>
+            <a:off x="1371600" y="5742432"/>
+            <a:ext cx="1051560" cy="237744"/>
+          </a:xfrm>
+          <a:prstGeom prst="rect">
+            <a:avLst/>
+          </a:prstGeom>
+          <a:noFill/>
+          <a:ln/>
+        </p:spPr>
+        <p:txBody>
+          <a:bodyPr wrap="square" lIns="0" tIns="0" rIns="0" bIns="0" rtlCol="0" anchor="ctr"/>
+          <a:lstStyle/>
+          <a:p>
+            <a:pPr algn="l" indent="0" marL="0">
+              <a:buNone/>
+            </a:pPr>
+            <a:r>
+              <a:rPr lang="en-US" sz="1050" dirty="0">
+                <a:solidFill>
+                  <a:srgbClr val="1A2433"/>
+                </a:solidFill>
+                <a:latin typeface="Calibri" pitchFamily="34" charset="0"/>
+                <a:ea typeface="Calibri" pitchFamily="34" charset="-122"/>
+                <a:cs typeface="Calibri" pitchFamily="34" charset="-120"/>
+              </a:rPr>
+              <a:t>Arqueros</a:t>
+            </a:r>
+            <a:endParaRPr lang="en-US" sz="1050" dirty="0"/>
+          </a:p>
+        </p:txBody>
+      </p:sp>
+      <p:sp>
+        <p:nvSpPr>
+          <p:cNvPr id="72" name="Text 68"/>
+          <p:cNvSpPr/>
+          <p:nvPr/>
+        </p:nvSpPr>
+        <p:spPr>
+          <a:xfrm>
+            <a:off x="2468880" y="5742432"/>
+            <a:ext cx="1051560" cy="237744"/>
+          </a:xfrm>
+          <a:prstGeom prst="rect">
+            <a:avLst/>
+          </a:prstGeom>
+          <a:noFill/>
+          <a:ln/>
+        </p:spPr>
+        <p:txBody>
+          <a:bodyPr wrap="square" lIns="0" tIns="0" rIns="0" bIns="0" rtlCol="0" anchor="ctr"/>
+          <a:lstStyle/>
+          <a:p>
+            <a:pPr algn="l" indent="0" marL="0">
+              <a:buNone/>
+            </a:pPr>
+            <a:r>
+              <a:rPr lang="en-US" sz="1050" dirty="0">
+                <a:solidFill>
+                  <a:srgbClr val="1A2433"/>
+                </a:solidFill>
+                <a:latin typeface="Calibri" pitchFamily="34" charset="0"/>
+                <a:ea typeface="Calibri" pitchFamily="34" charset="-122"/>
+                <a:cs typeface="Calibri" pitchFamily="34" charset="-120"/>
+              </a:rPr>
+              <a:t>MASA-90 · EB-NE-1412</a:t>
+            </a:r>
+            <a:endParaRPr lang="en-US" sz="1050" dirty="0"/>
+          </a:p>
+        </p:txBody>
+      </p:sp>
+      <p:sp>
+        <p:nvSpPr>
+          <p:cNvPr id="73" name="Text 69"/>
+          <p:cNvSpPr/>
+          <p:nvPr/>
+        </p:nvSpPr>
+        <p:spPr>
+          <a:xfrm>
+            <a:off x="3566160" y="5742432"/>
+            <a:ext cx="1371600" cy="237744"/>
+          </a:xfrm>
+          <a:prstGeom prst="rect">
+            <a:avLst/>
+          </a:prstGeom>
+          <a:noFill/>
+          <a:ln/>
+        </p:spPr>
+        <p:txBody>
+          <a:bodyPr wrap="square" lIns="0" tIns="0" rIns="0" bIns="0" rtlCol="0" anchor="ctr"/>
+          <a:lstStyle/>
+          <a:p>
+            <a:pPr algn="l" indent="0" marL="0">
+              <a:buNone/>
+            </a:pPr>
+            <a:r>
+              <a:rPr lang="en-US" sz="1050" dirty="0">
+                <a:solidFill>
+                  <a:srgbClr val="1A2433"/>
+                </a:solidFill>
+                <a:latin typeface="Calibri" pitchFamily="34" charset="0"/>
+                <a:ea typeface="Calibri" pitchFamily="34" charset="-122"/>
+                <a:cs typeface="Calibri" pitchFamily="34" charset="-120"/>
+              </a:rPr>
+              <a:t>No Conformidad</a:t>
+            </a:r>
+            <a:endParaRPr lang="en-US" sz="1050" dirty="0"/>
+          </a:p>
+        </p:txBody>
+      </p:sp>
+      <p:sp>
+        <p:nvSpPr>
+          <p:cNvPr id="74" name="Text 70"/>
+          <p:cNvSpPr/>
+          <p:nvPr/>
+        </p:nvSpPr>
+        <p:spPr>
+          <a:xfrm>
+            <a:off x="4983480" y="5742432"/>
+            <a:ext cx="1417320" cy="237744"/>
+          </a:xfrm>
+          <a:prstGeom prst="rect">
+            <a:avLst/>
+          </a:prstGeom>
+          <a:noFill/>
+          <a:ln/>
+        </p:spPr>
+        <p:txBody>
+          <a:bodyPr wrap="square" lIns="0" tIns="0" rIns="0" bIns="0" rtlCol="0" anchor="ctr"/>
+          <a:lstStyle/>
+          <a:p>
+            <a:pPr algn="l" indent="0" marL="0">
+              <a:buNone/>
+            </a:pPr>
+            <a:r>
+              <a:rPr lang="en-US" sz="1050" b="1" dirty="0">
+                <a:solidFill>
+                  <a:srgbClr val="C87A32"/>
+                </a:solidFill>
+                <a:latin typeface="Calibri" pitchFamily="34" charset="0"/>
+                <a:ea typeface="Calibri" pitchFamily="34" charset="-122"/>
+                <a:cs typeface="Calibri" pitchFamily="34" charset="-120"/>
+              </a:rPr>
+              <a:t>Externa · Cliente</a:t>
+            </a:r>
+            <a:endParaRPr lang="en-US" sz="1050" dirty="0"/>
+          </a:p>
+        </p:txBody>
+      </p:sp>
+      <p:sp>
+        <p:nvSpPr>
+          <p:cNvPr id="75" name="Text 71"/>
+          <p:cNvSpPr/>
+          <p:nvPr/>
+        </p:nvSpPr>
+        <p:spPr>
+          <a:xfrm>
+            <a:off x="6446520" y="5742432"/>
+            <a:ext cx="1097280" cy="237744"/>
+          </a:xfrm>
+          <a:prstGeom prst="rect">
+            <a:avLst/>
+          </a:prstGeom>
+          <a:noFill/>
+          <a:ln/>
+        </p:spPr>
+        <p:txBody>
+          <a:bodyPr wrap="square" lIns="0" tIns="0" rIns="0" bIns="0" rtlCol="0" anchor="ctr"/>
+          <a:lstStyle/>
+          <a:p>
+            <a:pPr algn="l" indent="0" marL="0">
+              <a:buNone/>
+            </a:pPr>
+            <a:r>
+              <a:rPr lang="en-US" sz="1050" dirty="0">
+                <a:solidFill>
+                  <a:srgbClr val="1A2433"/>
+                </a:solidFill>
+                <a:latin typeface="Calibri" pitchFamily="34" charset="0"/>
+                <a:ea typeface="Calibri" pitchFamily="34" charset="-122"/>
+                <a:cs typeface="Calibri" pitchFamily="34" charset="-120"/>
+              </a:rPr>
+              <a:t>Sin especial…</a:t>
+            </a:r>
+            <a:endParaRPr lang="en-US" sz="1050" dirty="0"/>
+          </a:p>
+        </p:txBody>
+      </p:sp>
+      <p:sp>
+        <p:nvSpPr>
+          <p:cNvPr id="76" name="Text 72"/>
+          <p:cNvSpPr/>
+          <p:nvPr/>
+        </p:nvSpPr>
+        <p:spPr>
+          <a:xfrm>
+            <a:off x="7589520" y="5742432"/>
+            <a:ext cx="1371600" cy="237744"/>
+          </a:xfrm>
+          <a:prstGeom prst="rect">
+            <a:avLst/>
+          </a:prstGeom>
+          <a:noFill/>
+          <a:ln/>
+        </p:spPr>
+        <p:txBody>
+          <a:bodyPr wrap="square" lIns="0" tIns="0" rIns="0" bIns="0" rtlCol="0" anchor="ctr"/>
+          <a:lstStyle/>
+          <a:p>
+            <a:pPr algn="l" indent="0" marL="0">
+              <a:buNone/>
+            </a:pPr>
+            <a:r>
+              <a:rPr lang="en-US" sz="1050" dirty="0">
+                <a:solidFill>
+                  <a:srgbClr val="1A2433"/>
+                </a:solidFill>
+                <a:latin typeface="Calibri" pitchFamily="34" charset="0"/>
+                <a:ea typeface="Calibri" pitchFamily="34" charset="-122"/>
+                <a:cs typeface="Calibri" pitchFamily="34" charset="-120"/>
+              </a:rPr>
+              <a:t>Sin asignar</a:t>
+            </a:r>
+            <a:endParaRPr lang="en-US" sz="1050" dirty="0"/>
+          </a:p>
+        </p:txBody>
+      </p:sp>
+      <p:sp>
+        <p:nvSpPr>
+          <p:cNvPr id="77" name="Text 73"/>
+          <p:cNvSpPr/>
+          <p:nvPr/>
+        </p:nvSpPr>
+        <p:spPr>
+          <a:xfrm>
+            <a:off x="9006840" y="5742432"/>
+            <a:ext cx="868680" cy="237744"/>
+          </a:xfrm>
+          <a:prstGeom prst="rect">
+            <a:avLst/>
+          </a:prstGeom>
+          <a:noFill/>
+          <a:ln/>
+        </p:spPr>
+        <p:txBody>
+          <a:bodyPr wrap="square" lIns="0" tIns="0" rIns="0" bIns="0" rtlCol="0" anchor="ctr"/>
+          <a:lstStyle/>
+          <a:p>
+            <a:pPr algn="l" indent="0" marL="0">
+              <a:buNone/>
+            </a:pPr>
+            <a:r>
+              <a:rPr lang="en-US" sz="1050" dirty="0">
+                <a:solidFill>
+                  <a:srgbClr val="C0392B"/>
+                </a:solidFill>
+                <a:latin typeface="Calibri" pitchFamily="34" charset="0"/>
+                <a:ea typeface="Calibri" pitchFamily="34" charset="-122"/>
+                <a:cs typeface="Calibri" pitchFamily="34" charset="-120"/>
+              </a:rPr>
+              <a:t>Pendiente</a:t>
+            </a:r>
+            <a:endParaRPr lang="en-US" sz="1050" dirty="0"/>
+          </a:p>
+        </p:txBody>
+      </p:sp>
+      <p:sp>
+        <p:nvSpPr>
+          <p:cNvPr id="78" name="Text 74"/>
+          <p:cNvSpPr/>
+          <p:nvPr/>
+        </p:nvSpPr>
+        <p:spPr>
+          <a:xfrm>
+            <a:off x="9921240" y="5742432"/>
+            <a:ext cx="1828800" cy="237744"/>
+          </a:xfrm>
+          <a:prstGeom prst="rect">
+            <a:avLst/>
+          </a:prstGeom>
+          <a:noFill/>
+          <a:ln/>
+        </p:spPr>
+        <p:txBody>
+          <a:bodyPr wrap="square" lIns="0" tIns="0" rIns="0" bIns="0" rtlCol="0" anchor="ctr"/>
+          <a:lstStyle/>
+          <a:p>
+            <a:pPr algn="l" indent="0" marL="0">
+              <a:buNone/>
+            </a:pPr>
+            <a:r>
+              <a:rPr lang="en-US" sz="1000" dirty="0">
+                <a:solidFill>
+                  <a:srgbClr val="1A2433"/>
+                </a:solidFill>
+                <a:latin typeface="Calibri" pitchFamily="34" charset="0"/>
+                <a:ea typeface="Calibri" pitchFamily="34" charset="-122"/>
+                <a:cs typeface="Calibri" pitchFamily="34" charset="-120"/>
+              </a:rPr>
+              <a:t>Desviación en soportación d…</a:t>
+            </a:r>
+            <a:endParaRPr lang="en-US" sz="1000" dirty="0"/>
+          </a:p>
+        </p:txBody>
+      </p:sp>
+      <p:sp>
+        <p:nvSpPr>
+          <p:cNvPr id="79" name="Shape 75"/>
+          <p:cNvSpPr/>
+          <p:nvPr/>
+        </p:nvSpPr>
+        <p:spPr>
+          <a:xfrm>
+            <a:off x="502920" y="6016752"/>
+            <a:ext cx="11247120" cy="0"/>
+          </a:xfrm>
+          <a:prstGeom prst="line">
+            <a:avLst/>
+          </a:prstGeom>
+          <a:noFill/>
+          <a:ln w="9525">
+            <a:solidFill>
+              <a:srgbClr val="D9DFE6"/>
+            </a:solidFill>
+            <a:prstDash val="solid"/>
+          </a:ln>
+        </p:spPr>
+      </p:sp>
+      <p:sp>
+        <p:nvSpPr>
+          <p:cNvPr id="80" name="Shape 76"/>
+          <p:cNvSpPr/>
+          <p:nvPr/>
+        </p:nvSpPr>
+        <p:spPr>
+          <a:xfrm>
+            <a:off x="457200" y="6025896"/>
+            <a:ext cx="11292840" cy="329184"/>
+          </a:xfrm>
+          <a:prstGeom prst="rect">
+            <a:avLst/>
+          </a:prstGeom>
+          <a:solidFill>
+            <a:srgbClr val="FFFFFF"/>
+          </a:solidFill>
+          <a:ln/>
+        </p:spPr>
+      </p:sp>
+      <p:sp>
+        <p:nvSpPr>
+          <p:cNvPr id="81" name="Text 77"/>
+          <p:cNvSpPr/>
+          <p:nvPr/>
+        </p:nvSpPr>
+        <p:spPr>
+          <a:xfrm>
+            <a:off x="502920" y="6071616"/>
+            <a:ext cx="822960" cy="237744"/>
+          </a:xfrm>
+          <a:prstGeom prst="rect">
+            <a:avLst/>
+          </a:prstGeom>
+          <a:noFill/>
+          <a:ln/>
+        </p:spPr>
+        <p:txBody>
+          <a:bodyPr wrap="square" lIns="0" tIns="0" rIns="0" bIns="0" rtlCol="0" anchor="ctr"/>
+          <a:lstStyle/>
+          <a:p>
+            <a:pPr algn="l" indent="0" marL="0">
+              <a:buNone/>
+            </a:pPr>
+            <a:r>
+              <a:rPr lang="en-US" sz="1050" dirty="0">
+                <a:solidFill>
+                  <a:srgbClr val="1A2433"/>
+                </a:solidFill>
+                <a:latin typeface="Calibri" pitchFamily="34" charset="0"/>
+                <a:ea typeface="Calibri" pitchFamily="34" charset="-122"/>
+                <a:cs typeface="Calibri" pitchFamily="34" charset="-120"/>
+              </a:rPr>
+              <a:t>01-09-2026</a:t>
+            </a:r>
+            <a:endParaRPr lang="en-US" sz="1050" dirty="0"/>
+          </a:p>
+        </p:txBody>
+      </p:sp>
+      <p:sp>
+        <p:nvSpPr>
+          <p:cNvPr id="82" name="Text 78"/>
+          <p:cNvSpPr/>
+          <p:nvPr/>
+        </p:nvSpPr>
+        <p:spPr>
+          <a:xfrm>
+            <a:off x="1371600" y="6071616"/>
+            <a:ext cx="1051560" cy="237744"/>
+          </a:xfrm>
+          <a:prstGeom prst="rect">
+            <a:avLst/>
+          </a:prstGeom>
+          <a:noFill/>
+          <a:ln/>
+        </p:spPr>
+        <p:txBody>
+          <a:bodyPr wrap="square" lIns="0" tIns="0" rIns="0" bIns="0" rtlCol="0" anchor="ctr"/>
+          <a:lstStyle/>
+          <a:p>
+            <a:pPr algn="l" indent="0" marL="0">
+              <a:buNone/>
+            </a:pPr>
+            <a:r>
+              <a:rPr lang="en-US" sz="1050" dirty="0">
+                <a:solidFill>
+                  <a:srgbClr val="1A2433"/>
+                </a:solidFill>
+                <a:latin typeface="Calibri" pitchFamily="34" charset="0"/>
+                <a:ea typeface="Calibri" pitchFamily="34" charset="-122"/>
+                <a:cs typeface="Calibri" pitchFamily="34" charset="-120"/>
+              </a:rPr>
+              <a:t>Arqueros</a:t>
+            </a:r>
+            <a:endParaRPr lang="en-US" sz="1050" dirty="0"/>
+          </a:p>
+        </p:txBody>
+      </p:sp>
+      <p:sp>
+        <p:nvSpPr>
+          <p:cNvPr id="83" name="Text 79"/>
+          <p:cNvSpPr/>
+          <p:nvPr/>
+        </p:nvSpPr>
+        <p:spPr>
+          <a:xfrm>
+            <a:off x="2468880" y="6071616"/>
+            <a:ext cx="1051560" cy="237744"/>
+          </a:xfrm>
+          <a:prstGeom prst="rect">
+            <a:avLst/>
+          </a:prstGeom>
+          <a:noFill/>
+          <a:ln/>
+        </p:spPr>
+        <p:txBody>
+          <a:bodyPr wrap="square" lIns="0" tIns="0" rIns="0" bIns="0" rtlCol="0" anchor="ctr"/>
+          <a:lstStyle/>
+          <a:p>
+            <a:pPr algn="l" indent="0" marL="0">
+              <a:buNone/>
+            </a:pPr>
+            <a:r>
+              <a:rPr lang="en-US" sz="1050" dirty="0">
+                <a:solidFill>
+                  <a:srgbClr val="1A2433"/>
+                </a:solidFill>
+                <a:latin typeface="Calibri" pitchFamily="34" charset="0"/>
+                <a:ea typeface="Calibri" pitchFamily="34" charset="-122"/>
+                <a:cs typeface="Calibri" pitchFamily="34" charset="-120"/>
+              </a:rPr>
+              <a:t>MASA-91 · EB-NE-1412</a:t>
+            </a:r>
+            <a:endParaRPr lang="en-US" sz="1050" dirty="0"/>
+          </a:p>
+        </p:txBody>
+      </p:sp>
+      <p:sp>
+        <p:nvSpPr>
+          <p:cNvPr id="84" name="Text 80"/>
+          <p:cNvSpPr/>
+          <p:nvPr/>
+        </p:nvSpPr>
+        <p:spPr>
+          <a:xfrm>
+            <a:off x="3566160" y="6071616"/>
+            <a:ext cx="1371600" cy="237744"/>
+          </a:xfrm>
+          <a:prstGeom prst="rect">
+            <a:avLst/>
+          </a:prstGeom>
+          <a:noFill/>
+          <a:ln/>
+        </p:spPr>
+        <p:txBody>
+          <a:bodyPr wrap="square" lIns="0" tIns="0" rIns="0" bIns="0" rtlCol="0" anchor="ctr"/>
+          <a:lstStyle/>
+          <a:p>
+            <a:pPr algn="l" indent="0" marL="0">
+              <a:buNone/>
+            </a:pPr>
+            <a:r>
+              <a:rPr lang="en-US" sz="1050" dirty="0">
+                <a:solidFill>
+                  <a:srgbClr val="1A2433"/>
+                </a:solidFill>
+                <a:latin typeface="Calibri" pitchFamily="34" charset="0"/>
+                <a:ea typeface="Calibri" pitchFamily="34" charset="-122"/>
+                <a:cs typeface="Calibri" pitchFamily="34" charset="-120"/>
+              </a:rPr>
+              <a:t>No Conformidad</a:t>
+            </a:r>
+            <a:endParaRPr lang="en-US" sz="1050" dirty="0"/>
+          </a:p>
+        </p:txBody>
+      </p:sp>
+      <p:sp>
+        <p:nvSpPr>
+          <p:cNvPr id="85" name="Text 81"/>
+          <p:cNvSpPr/>
+          <p:nvPr/>
+        </p:nvSpPr>
+        <p:spPr>
+          <a:xfrm>
+            <a:off x="4983480" y="6071616"/>
+            <a:ext cx="1417320" cy="237744"/>
+          </a:xfrm>
+          <a:prstGeom prst="rect">
+            <a:avLst/>
+          </a:prstGeom>
+          <a:noFill/>
+          <a:ln/>
+        </p:spPr>
+        <p:txBody>
+          <a:bodyPr wrap="square" lIns="0" tIns="0" rIns="0" bIns="0" rtlCol="0" anchor="ctr"/>
+          <a:lstStyle/>
+          <a:p>
+            <a:pPr algn="l" indent="0" marL="0">
+              <a:buNone/>
+            </a:pPr>
+            <a:r>
+              <a:rPr lang="en-US" sz="1050" b="1" dirty="0">
+                <a:solidFill>
+                  <a:srgbClr val="C87A32"/>
+                </a:solidFill>
+                <a:latin typeface="Calibri" pitchFamily="34" charset="0"/>
+                <a:ea typeface="Calibri" pitchFamily="34" charset="-122"/>
+                <a:cs typeface="Calibri" pitchFamily="34" charset="-120"/>
+              </a:rPr>
+              <a:t>Externa · Cliente</a:t>
+            </a:r>
+            <a:endParaRPr lang="en-US" sz="1050" dirty="0"/>
+          </a:p>
+        </p:txBody>
+      </p:sp>
+      <p:sp>
+        <p:nvSpPr>
+          <p:cNvPr id="86" name="Text 82"/>
+          <p:cNvSpPr/>
+          <p:nvPr/>
+        </p:nvSpPr>
+        <p:spPr>
+          <a:xfrm>
+            <a:off x="6446520" y="6071616"/>
+            <a:ext cx="1097280" cy="237744"/>
+          </a:xfrm>
+          <a:prstGeom prst="rect">
+            <a:avLst/>
+          </a:prstGeom>
+          <a:noFill/>
+          <a:ln/>
+        </p:spPr>
+        <p:txBody>
+          <a:bodyPr wrap="square" lIns="0" tIns="0" rIns="0" bIns="0" rtlCol="0" anchor="ctr"/>
+          <a:lstStyle/>
+          <a:p>
+            <a:pPr algn="l" indent="0" marL="0">
+              <a:buNone/>
+            </a:pPr>
+            <a:r>
+              <a:rPr lang="en-US" sz="1050" dirty="0">
+                <a:solidFill>
+                  <a:srgbClr val="1A2433"/>
+                </a:solidFill>
+                <a:latin typeface="Calibri" pitchFamily="34" charset="0"/>
+                <a:ea typeface="Calibri" pitchFamily="34" charset="-122"/>
+                <a:cs typeface="Calibri" pitchFamily="34" charset="-120"/>
+              </a:rPr>
+              <a:t>Sin especial…</a:t>
+            </a:r>
+            <a:endParaRPr lang="en-US" sz="1050" dirty="0"/>
+          </a:p>
+        </p:txBody>
+      </p:sp>
+      <p:sp>
+        <p:nvSpPr>
+          <p:cNvPr id="87" name="Text 83"/>
+          <p:cNvSpPr/>
+          <p:nvPr/>
+        </p:nvSpPr>
+        <p:spPr>
+          <a:xfrm>
+            <a:off x="7589520" y="6071616"/>
+            <a:ext cx="1371600" cy="237744"/>
+          </a:xfrm>
+          <a:prstGeom prst="rect">
+            <a:avLst/>
+          </a:prstGeom>
+          <a:noFill/>
+          <a:ln/>
+        </p:spPr>
+        <p:txBody>
+          <a:bodyPr wrap="square" lIns="0" tIns="0" rIns="0" bIns="0" rtlCol="0" anchor="ctr"/>
+          <a:lstStyle/>
+          <a:p>
+            <a:pPr algn="l" indent="0" marL="0">
+              <a:buNone/>
+            </a:pPr>
+            <a:r>
+              <a:rPr lang="en-US" sz="1050" dirty="0">
+                <a:solidFill>
+                  <a:srgbClr val="1A2433"/>
+                </a:solidFill>
+                <a:latin typeface="Calibri" pitchFamily="34" charset="0"/>
+                <a:ea typeface="Calibri" pitchFamily="34" charset="-122"/>
+                <a:cs typeface="Calibri" pitchFamily="34" charset="-120"/>
+              </a:rPr>
+              <a:t>Sin asignar</a:t>
+            </a:r>
+            <a:endParaRPr lang="en-US" sz="1050" dirty="0"/>
+          </a:p>
+        </p:txBody>
+      </p:sp>
+      <p:sp>
+        <p:nvSpPr>
+          <p:cNvPr id="88" name="Text 84"/>
+          <p:cNvSpPr/>
+          <p:nvPr/>
+        </p:nvSpPr>
+        <p:spPr>
+          <a:xfrm>
+            <a:off x="9006840" y="6071616"/>
+            <a:ext cx="868680" cy="237744"/>
+          </a:xfrm>
+          <a:prstGeom prst="rect">
+            <a:avLst/>
+          </a:prstGeom>
+          <a:noFill/>
+          <a:ln/>
+        </p:spPr>
+        <p:txBody>
+          <a:bodyPr wrap="square" lIns="0" tIns="0" rIns="0" bIns="0" rtlCol="0" anchor="ctr"/>
+          <a:lstStyle/>
+          <a:p>
+            <a:pPr algn="l" indent="0" marL="0">
+              <a:buNone/>
+            </a:pPr>
+            <a:r>
+              <a:rPr lang="en-US" sz="1050" dirty="0">
+                <a:solidFill>
+                  <a:srgbClr val="C0392B"/>
+                </a:solidFill>
+                <a:latin typeface="Calibri" pitchFamily="34" charset="0"/>
+                <a:ea typeface="Calibri" pitchFamily="34" charset="-122"/>
+                <a:cs typeface="Calibri" pitchFamily="34" charset="-120"/>
+              </a:rPr>
+              <a:t>Pendiente</a:t>
+            </a:r>
+            <a:endParaRPr lang="en-US" sz="1050" dirty="0"/>
+          </a:p>
+        </p:txBody>
+      </p:sp>
+      <p:sp>
+        <p:nvSpPr>
+          <p:cNvPr id="89" name="Text 85"/>
+          <p:cNvSpPr/>
+          <p:nvPr/>
+        </p:nvSpPr>
+        <p:spPr>
+          <a:xfrm>
+            <a:off x="9921240" y="6071616"/>
+            <a:ext cx="1828800" cy="237744"/>
+          </a:xfrm>
+          <a:prstGeom prst="rect">
+            <a:avLst/>
+          </a:prstGeom>
+          <a:noFill/>
+          <a:ln/>
+        </p:spPr>
+        <p:txBody>
+          <a:bodyPr wrap="square" lIns="0" tIns="0" rIns="0" bIns="0" rtlCol="0" anchor="ctr"/>
+          <a:lstStyle/>
+          <a:p>
+            <a:pPr algn="l" indent="0" marL="0">
+              <a:buNone/>
+            </a:pPr>
+            <a:r>
+              <a:rPr lang="en-US" sz="1000" dirty="0">
+                <a:solidFill>
+                  <a:srgbClr val="1A2433"/>
+                </a:solidFill>
+                <a:latin typeface="Calibri" pitchFamily="34" charset="0"/>
+                <a:ea typeface="Calibri" pitchFamily="34" charset="-122"/>
+                <a:cs typeface="Calibri" pitchFamily="34" charset="-120"/>
+              </a:rPr>
+              <a:t>gap en piping bombas celdas…</a:t>
+            </a:r>
+            <a:endParaRPr lang="en-US" sz="1000" dirty="0"/>
+          </a:p>
+        </p:txBody>
+      </p:sp>
+      <p:sp>
+        <p:nvSpPr>
+          <p:cNvPr id="90" name="Shape 86"/>
+          <p:cNvSpPr/>
+          <p:nvPr/>
+        </p:nvSpPr>
+        <p:spPr>
+          <a:xfrm>
+            <a:off x="502920" y="6345936"/>
+            <a:ext cx="11247120" cy="0"/>
+          </a:xfrm>
+          <a:prstGeom prst="line">
+            <a:avLst/>
+          </a:prstGeom>
+          <a:noFill/>
+          <a:ln w="9525">
+            <a:solidFill>
+              <a:srgbClr val="D9DFE6"/>
+            </a:solidFill>
+            <a:prstDash val="solid"/>
+          </a:ln>
+        </p:spPr>
+      </p:sp>
+      <p:sp>
+        <p:nvSpPr>
+          <p:cNvPr id="91" name="Text 87"/>
           <p:cNvSpPr/>
           <p:nvPr/>
         </p:nvSpPr>
@@ -26203,7 +28468,7 @@
                 <a:ea typeface="Calibri" pitchFamily="34" charset="-122"/>
                 <a:cs typeface="Calibri" pitchFamily="34" charset="-120"/>
               </a:rPr>
-              <a:t>Fuente: Data_NCR31082026.xlsx — hoja «Observaciones» · Corte 31-08-2026 · 502 registros desde 10-02-2023</a:t>
+              <a:t>Fuente: Data_NCR07092026.xlsx — hoja «Observaciones» · Corte 07-09-2026 · 509 registros desde 10-02-2023</a:t>
             </a:r>
             <a:endParaRPr lang="en-US" sz="850" dirty="0"/>
           </a:p>
@@ -26211,7 +28476,7 @@
       </p:sp>
       <p:sp>
         <p:nvSpPr>
-          <p:cNvPr id="39" name="Text 35"/>
+          <p:cNvPr id="92" name="Text 88"/>
           <p:cNvSpPr/>
           <p:nvPr/>
         </p:nvSpPr>
@@ -26250,7 +28515,7 @@
       </p:sp>
       <p:sp>
         <p:nvSpPr>
-          <p:cNvPr id="40" name="Text 36"/>
+          <p:cNvPr id="93" name="Text 89"/>
           <p:cNvSpPr/>
           <p:nvPr/>
         </p:nvSpPr>
@@ -26454,7 +28719,7 @@
                 <a:ea typeface="Calibri" pitchFamily="34" charset="-122"/>
                 <a:cs typeface="Calibri" pitchFamily="34" charset="-120"/>
               </a:rPr>
-              <a:t>Interna es autodetección: la levanta Besalco antes que nadie. Externa la levanta el cliente —compromete el contrato— o un subcontrato. Autodetección global: 32,3%.</a:t>
+              <a:t>Interna es autodetección: la levanta Besalco antes que nadie. Externa la levanta el cliente —compromete el contrato— o un subcontrato. Autodetección global: 31,8%.</a:t>
             </a:r>
             <a:endParaRPr lang="en-US" sz="1350" dirty="0"/>
           </a:p>
@@ -27199,7 +29464,7 @@
                 <a:ea typeface="Calibri" pitchFamily="34" charset="-122"/>
                 <a:cs typeface="Calibri" pitchFamily="34" charset="-120"/>
               </a:rPr>
-              <a:t>286</a:t>
+              <a:t>293</a:t>
             </a:r>
             <a:endParaRPr lang="en-US" sz="1050" dirty="0"/>
           </a:p>
@@ -27277,7 +29542,7 @@
                 <a:ea typeface="Calibri" pitchFamily="34" charset="-122"/>
                 <a:cs typeface="Calibri" pitchFamily="34" charset="-120"/>
               </a:rPr>
-              <a:t>87,1%</a:t>
+              <a:t>85%</a:t>
             </a:r>
             <a:endParaRPr lang="en-US" sz="1050" dirty="0"/>
           </a:p>
@@ -27316,7 +29581,7 @@
                 <a:ea typeface="Calibri" pitchFamily="34" charset="-122"/>
                 <a:cs typeface="Calibri" pitchFamily="34" charset="-120"/>
               </a:rPr>
-              <a:t>37</a:t>
+              <a:t>44</a:t>
             </a:r>
             <a:endParaRPr lang="en-US" sz="1050" dirty="0"/>
           </a:p>
@@ -27355,7 +29620,7 @@
                 <a:ea typeface="Calibri" pitchFamily="34" charset="-122"/>
                 <a:cs typeface="Calibri" pitchFamily="34" charset="-120"/>
               </a:rPr>
-              <a:t>36</a:t>
+              <a:t>37</a:t>
             </a:r>
             <a:endParaRPr lang="en-US" sz="1050" dirty="0"/>
           </a:p>
@@ -28107,7 +30372,7 @@
                 <a:ea typeface="Calibri" pitchFamily="34" charset="-122"/>
                 <a:cs typeface="Calibri" pitchFamily="34" charset="-120"/>
               </a:rPr>
-              <a:t>502</a:t>
+              <a:t>509</a:t>
             </a:r>
             <a:endParaRPr lang="en-US" sz="1050" dirty="0"/>
           </a:p>
@@ -28185,7 +30450,7 @@
                 <a:ea typeface="Calibri" pitchFamily="34" charset="-122"/>
                 <a:cs typeface="Calibri" pitchFamily="34" charset="-120"/>
               </a:rPr>
-              <a:t>92,2%</a:t>
+              <a:t>91%</a:t>
             </a:r>
             <a:endParaRPr lang="en-US" sz="1050" dirty="0"/>
           </a:p>
@@ -28224,7 +30489,7 @@
                 <a:ea typeface="Calibri" pitchFamily="34" charset="-122"/>
                 <a:cs typeface="Calibri" pitchFamily="34" charset="-120"/>
               </a:rPr>
-              <a:t>39</a:t>
+              <a:t>46</a:t>
             </a:r>
             <a:endParaRPr lang="en-US" sz="1050" dirty="0"/>
           </a:p>
@@ -28263,7 +30528,7 @@
                 <a:ea typeface="Calibri" pitchFamily="34" charset="-122"/>
                 <a:cs typeface="Calibri" pitchFamily="34" charset="-120"/>
               </a:rPr>
-              <a:t>38</a:t>
+              <a:t>39</a:t>
             </a:r>
             <a:endParaRPr lang="en-US" sz="1050" dirty="0"/>
           </a:p>
@@ -28519,7 +30784,7 @@
                 <a:ea typeface="Cambria" pitchFamily="34" charset="-122"/>
                 <a:cs typeface="Cambria" pitchFamily="34" charset="-120"/>
               </a:rPr>
-              <a:t>21%</a:t>
+              <a:t>20,9%</a:t>
             </a:r>
             <a:endParaRPr lang="en-US" sz="2400" dirty="0"/>
           </a:p>
@@ -28597,7 +30862,7 @@
                 <a:ea typeface="Cambria" pitchFamily="34" charset="-122"/>
                 <a:cs typeface="Cambria" pitchFamily="34" charset="-120"/>
               </a:rPr>
-              <a:t>32,3%</a:t>
+              <a:t>31,2%</a:t>
             </a:r>
             <a:endParaRPr lang="en-US" sz="2400" dirty="0"/>
           </a:p>
@@ -28675,7 +30940,7 @@
                 <a:ea typeface="Calibri" pitchFamily="34" charset="-122"/>
                 <a:cs typeface="Calibri" pitchFamily="34" charset="-120"/>
               </a:rPr>
-              <a:t>Fuente: Data_NCR31082026.xlsx — hoja «Observaciones» · Corte 31-08-2026 · 502 registros desde 10-02-2023</a:t>
+              <a:t>Fuente: Data_NCR07092026.xlsx — hoja «Observaciones» · Corte 07-09-2026 · 509 registros desde 10-02-2023</a:t>
             </a:r>
             <a:endParaRPr lang="en-US" sz="850" dirty="0"/>
           </a:p>
@@ -28926,7 +31191,7 @@
                 <a:ea typeface="Calibri" pitchFamily="34" charset="-122"/>
                 <a:cs typeface="Calibri" pitchFamily="34" charset="-120"/>
               </a:rPr>
-              <a:t>De los 39 hallazgos abiertos, 13 llevan más de 180 días desde que se levantaron y 0 más de un año. La mediana de cierre global es de 30 días.</a:t>
+              <a:t>De los 46 hallazgos abiertos, 17 llevan más de 180 días desde que se levantaron y 0 más de un año. La mediana de cierre global es de 30 días.</a:t>
             </a:r>
             <a:endParaRPr lang="en-US" sz="1350" dirty="0"/>
           </a:p>
@@ -29063,7 +31328,7 @@
                 <a:ea typeface="Calibri" pitchFamily="34" charset="-122"/>
                 <a:cs typeface="Calibri" pitchFamily="34" charset="-120"/>
               </a:rPr>
-              <a:t>Al corte hay 38 hallazgos fuera de plazo de los 39 abiertos.</a:t>
+              <a:t>Al corte hay 39 hallazgos fuera de plazo de los 46 abiertos.</a:t>
             </a:r>
             <a:endParaRPr lang="en-US" sz="1150" dirty="0"/>
           </a:p>
@@ -29859,7 +32124,7 @@
                 <a:ea typeface="Calibri" pitchFamily="34" charset="-122"/>
                 <a:cs typeface="Calibri" pitchFamily="34" charset="-120"/>
               </a:rPr>
-              <a:t>6</a:t>
+              <a:t>7</a:t>
             </a:r>
             <a:endParaRPr lang="en-US" sz="1150" dirty="0"/>
           </a:p>
@@ -30105,7 +32370,7 @@
                 <a:ea typeface="Calibri" pitchFamily="34" charset="-122"/>
                 <a:cs typeface="Calibri" pitchFamily="34" charset="-120"/>
               </a:rPr>
-              <a:t>32</a:t>
+              <a:t>38</a:t>
             </a:r>
             <a:endParaRPr lang="en-US" sz="1150" dirty="0"/>
           </a:p>
@@ -30483,7 +32748,7 @@
                 <a:ea typeface="Calibri" pitchFamily="34" charset="-122"/>
                 <a:cs typeface="Calibri" pitchFamily="34" charset="-120"/>
               </a:rPr>
-              <a:t>Fuente: Data_NCR31082026.xlsx — hoja «Observaciones» · Corte 31-08-2026 · 502 registros desde 10-02-2023</a:t>
+              <a:t>Fuente: Data_NCR07092026.xlsx — hoja «Observaciones» · Corte 07-09-2026 · 509 registros desde 10-02-2023</a:t>
             </a:r>
             <a:endParaRPr lang="en-US" sz="850" dirty="0"/>
           </a:p>
@@ -30734,7 +32999,7 @@
                 <a:ea typeface="Calibri" pitchFamily="34" charset="-122"/>
                 <a:cs typeface="Calibri" pitchFamily="34" charset="-120"/>
               </a:rPr>
-              <a:t>10.613 UF declaradas entre nov-24 y ago-26, imputadas al mes en que se levantó cada hallazgo. Las declaran 108 de 491 hallazgos del período.</a:t>
+              <a:t>10.613 UF declaradas entre nov-24 y sep-26, imputadas al mes en que se levantó cada hallazgo. Las declaran 108 de 498 hallazgos del período.</a:t>
             </a:r>
             <a:endParaRPr lang="en-US" sz="1350" dirty="0"/>
           </a:p>
@@ -30756,7 +33021,7 @@
         </p:nvGraphicFramePr>
         <p:xfrm>
           <a:off x="411480" y="1810512"/>
-          <a:ext cx="11594592" cy="914400"/>
+          <a:ext cx="11996928" cy="914400"/>
         </p:xfrm>
         <a:graphic>
           <a:graphicData uri="http://schemas.openxmlformats.org/drawingml/2006/table">
@@ -30764,6 +33029,7 @@
               <a:tblPr/>
               <a:tblGrid>
                 <a:gridCol w="1920240"/>
+                <a:gridCol w="402336"/>
                 <a:gridCol w="402336"/>
                 <a:gridCol w="402336"/>
                 <a:gridCol w="402336"/>
@@ -32832,6 +35098,95 @@
                           <a:ea typeface="Calibri" pitchFamily="34" charset="-122"/>
                           <a:cs typeface="Calibri" pitchFamily="34" charset="-120"/>
                         </a:rPr>
+                        <a:t>sep</a:t>
+                      </a:r>
+                      <a:endParaRPr lang="en-US" sz="750" dirty="0">
+                        <a:latin typeface="Calibri" charset="0"/>
+                        <a:ea typeface="Calibri" charset="0"/>
+                        <a:cs typeface="Calibri" charset="0"/>
+                      </a:endParaRPr>
+                    </a:p>
+                    <a:p>
+                      <a:pPr algn="r" indent="0" marL="0">
+                        <a:buNone/>
+                      </a:pPr>
+                      <a:r>
+                        <a:rPr lang="en-US" sz="750" b="1" dirty="0">
+                          <a:solidFill>
+                            <a:srgbClr val="56606E"/>
+                          </a:solidFill>
+                          <a:latin typeface="Calibri" pitchFamily="34" charset="0"/>
+                          <a:ea typeface="Calibri" pitchFamily="34" charset="-122"/>
+                          <a:cs typeface="Calibri" pitchFamily="34" charset="-120"/>
+                        </a:rPr>
+                        <a:t>26</a:t>
+                      </a:r>
+                      <a:endParaRPr lang="en-US" sz="750" dirty="0">
+                        <a:latin typeface="Calibri" charset="0"/>
+                        <a:ea typeface="Calibri" charset="0"/>
+                        <a:cs typeface="Calibri" charset="0"/>
+                      </a:endParaRPr>
+                    </a:p>
+                  </a:txBody>
+                  <a:tcPr marL="25400" marR="25400" marT="25400" marB="25400" anchor="b">
+                    <a:lnL w="12700" cap="flat" cmpd="sng" algn="ctr">
+                      <a:solidFill>
+                        <a:srgbClr val="F4F6F9"/>
+                      </a:solidFill>
+                      <a:prstDash val="solid"/>
+                      <a:round/>
+                      <a:headEnd type="none" w="med" len="med"/>
+                      <a:tailEnd type="none" w="med" len="med"/>
+                    </a:lnL>
+                    <a:lnR w="12700" cap="flat" cmpd="sng" algn="ctr">
+                      <a:solidFill>
+                        <a:srgbClr val="F4F6F9"/>
+                      </a:solidFill>
+                      <a:prstDash val="solid"/>
+                      <a:round/>
+                      <a:headEnd type="none" w="med" len="med"/>
+                      <a:tailEnd type="none" w="med" len="med"/>
+                    </a:lnR>
+                    <a:lnT w="12700" cap="flat" cmpd="sng" algn="ctr">
+                      <a:solidFill>
+                        <a:srgbClr val="F4F6F9"/>
+                      </a:solidFill>
+                      <a:prstDash val="solid"/>
+                      <a:round/>
+                      <a:headEnd type="none" w="med" len="med"/>
+                      <a:tailEnd type="none" w="med" len="med"/>
+                    </a:lnT>
+                    <a:lnB w="12700" cap="flat" cmpd="sng" algn="ctr">
+                      <a:solidFill>
+                        <a:srgbClr val="F4F6F9"/>
+                      </a:solidFill>
+                      <a:prstDash val="solid"/>
+                      <a:round/>
+                      <a:headEnd type="none" w="med" len="med"/>
+                      <a:tailEnd type="none" w="med" len="med"/>
+                    </a:lnB>
+                    <a:solidFill>
+                      <a:srgbClr val="F4F6F9"/>
+                    </a:solidFill>
+                  </a:tcPr>
+                </a:tc>
+                <a:tc>
+                  <a:txBody>
+                    <a:bodyPr/>
+                    <a:lstStyle/>
+                    <a:p>
+                      <a:pPr algn="r" indent="0" marL="0">
+                        <a:buNone/>
+                      </a:pPr>
+                      <a:r>
+                        <a:rPr lang="en-US" sz="750" b="1" dirty="0">
+                          <a:solidFill>
+                            <a:srgbClr val="56606E"/>
+                          </a:solidFill>
+                          <a:latin typeface="Calibri" pitchFamily="34" charset="0"/>
+                          <a:ea typeface="Calibri" pitchFamily="34" charset="-122"/>
+                          <a:cs typeface="Calibri" pitchFamily="34" charset="-120"/>
+                        </a:rPr>
                         <a:t>TOTAL UF</a:t>
                       </a:r>
                       <a:endParaRPr lang="en-US" sz="750" dirty="0">
@@ -34226,6 +36581,63 @@
                       <a:pPr algn="r" indent="0" marL="0">
                         <a:buNone/>
                       </a:pPr>
+                      <a:endParaRPr lang="en-US" sz="750" dirty="0">
+                        <a:latin typeface="Calibri" charset="0"/>
+                        <a:ea typeface="Calibri" charset="0"/>
+                        <a:cs typeface="Calibri" charset="0"/>
+                      </a:endParaRPr>
+                    </a:p>
+                  </a:txBody>
+                  <a:tcPr marL="25400" marR="25400" marT="25400" marB="25400" anchor="ctr">
+                    <a:lnL w="12700" cap="flat" cmpd="sng" algn="ctr">
+                      <a:solidFill>
+                        <a:srgbClr val="F4F6F9"/>
+                      </a:solidFill>
+                      <a:prstDash val="solid"/>
+                      <a:round/>
+                      <a:headEnd type="none" w="med" len="med"/>
+                      <a:tailEnd type="none" w="med" len="med"/>
+                    </a:lnL>
+                    <a:lnR w="12700" cap="flat" cmpd="sng" algn="ctr">
+                      <a:solidFill>
+                        <a:srgbClr val="F4F6F9"/>
+                      </a:solidFill>
+                      <a:prstDash val="solid"/>
+                      <a:round/>
+                      <a:headEnd type="none" w="med" len="med"/>
+                      <a:tailEnd type="none" w="med" len="med"/>
+                    </a:lnR>
+                    <a:lnT w="12700" cap="flat" cmpd="sng" algn="ctr">
+                      <a:solidFill>
+                        <a:srgbClr val="F4F6F9"/>
+                      </a:solidFill>
+                      <a:prstDash val="solid"/>
+                      <a:round/>
+                      <a:headEnd type="none" w="med" len="med"/>
+                      <a:tailEnd type="none" w="med" len="med"/>
+                    </a:lnT>
+                    <a:lnB w="12700" cap="flat" cmpd="sng" algn="ctr">
+                      <a:solidFill>
+                        <a:srgbClr val="F4F6F9"/>
+                      </a:solidFill>
+                      <a:prstDash val="solid"/>
+                      <a:round/>
+                      <a:headEnd type="none" w="med" len="med"/>
+                      <a:tailEnd type="none" w="med" len="med"/>
+                    </a:lnB>
+                    <a:solidFill>
+                      <a:srgbClr val="EFF2F6"/>
+                    </a:solidFill>
+                  </a:tcPr>
+                </a:tc>
+                <a:tc>
+                  <a:txBody>
+                    <a:bodyPr/>
+                    <a:lstStyle/>
+                    <a:p>
+                      <a:pPr algn="r" indent="0" marL="0">
+                        <a:buNone/>
+                      </a:pPr>
                       <a:r>
                         <a:rPr lang="en-US" sz="750" b="1" dirty="0">
                           <a:solidFill>
@@ -35772,6 +38184,63 @@
                       <a:pPr algn="r" indent="0" marL="0">
                         <a:buNone/>
                       </a:pPr>
+                      <a:endParaRPr lang="en-US" sz="750" dirty="0">
+                        <a:latin typeface="Calibri" charset="0"/>
+                        <a:ea typeface="Calibri" charset="0"/>
+                        <a:cs typeface="Calibri" charset="0"/>
+                      </a:endParaRPr>
+                    </a:p>
+                  </a:txBody>
+                  <a:tcPr marL="25400" marR="25400" marT="25400" marB="25400" anchor="ctr">
+                    <a:lnL w="12700" cap="flat" cmpd="sng" algn="ctr">
+                      <a:solidFill>
+                        <a:srgbClr val="F4F6F9"/>
+                      </a:solidFill>
+                      <a:prstDash val="solid"/>
+                      <a:round/>
+                      <a:headEnd type="none" w="med" len="med"/>
+                      <a:tailEnd type="none" w="med" len="med"/>
+                    </a:lnL>
+                    <a:lnR w="12700" cap="flat" cmpd="sng" algn="ctr">
+                      <a:solidFill>
+                        <a:srgbClr val="F4F6F9"/>
+                      </a:solidFill>
+                      <a:prstDash val="solid"/>
+                      <a:round/>
+                      <a:headEnd type="none" w="med" len="med"/>
+                      <a:tailEnd type="none" w="med" len="med"/>
+                    </a:lnR>
+                    <a:lnT w="12700" cap="flat" cmpd="sng" algn="ctr">
+                      <a:solidFill>
+                        <a:srgbClr val="F4F6F9"/>
+                      </a:solidFill>
+                      <a:prstDash val="solid"/>
+                      <a:round/>
+                      <a:headEnd type="none" w="med" len="med"/>
+                      <a:tailEnd type="none" w="med" len="med"/>
+                    </a:lnT>
+                    <a:lnB w="12700" cap="flat" cmpd="sng" algn="ctr">
+                      <a:solidFill>
+                        <a:srgbClr val="F4F6F9"/>
+                      </a:solidFill>
+                      <a:prstDash val="solid"/>
+                      <a:round/>
+                      <a:headEnd type="none" w="med" len="med"/>
+                      <a:tailEnd type="none" w="med" len="med"/>
+                    </a:lnB>
+                    <a:solidFill>
+                      <a:srgbClr val="EFF2F6"/>
+                    </a:solidFill>
+                  </a:tcPr>
+                </a:tc>
+                <a:tc>
+                  <a:txBody>
+                    <a:bodyPr/>
+                    <a:lstStyle/>
+                    <a:p>
+                      <a:pPr algn="r" indent="0" marL="0">
+                        <a:buNone/>
+                      </a:pPr>
                       <a:r>
                         <a:rPr lang="en-US" sz="750" b="1" dirty="0">
                           <a:solidFill>
@@ -37274,6 +39743,63 @@
                       <a:pPr algn="r" indent="0" marL="0">
                         <a:buNone/>
                       </a:pPr>
+                      <a:endParaRPr lang="en-US" sz="750" dirty="0">
+                        <a:latin typeface="Calibri" charset="0"/>
+                        <a:ea typeface="Calibri" charset="0"/>
+                        <a:cs typeface="Calibri" charset="0"/>
+                      </a:endParaRPr>
+                    </a:p>
+                  </a:txBody>
+                  <a:tcPr marL="25400" marR="25400" marT="25400" marB="25400" anchor="ctr">
+                    <a:lnL w="12700" cap="flat" cmpd="sng" algn="ctr">
+                      <a:solidFill>
+                        <a:srgbClr val="F4F6F9"/>
+                      </a:solidFill>
+                      <a:prstDash val="solid"/>
+                      <a:round/>
+                      <a:headEnd type="none" w="med" len="med"/>
+                      <a:tailEnd type="none" w="med" len="med"/>
+                    </a:lnL>
+                    <a:lnR w="12700" cap="flat" cmpd="sng" algn="ctr">
+                      <a:solidFill>
+                        <a:srgbClr val="F4F6F9"/>
+                      </a:solidFill>
+                      <a:prstDash val="solid"/>
+                      <a:round/>
+                      <a:headEnd type="none" w="med" len="med"/>
+                      <a:tailEnd type="none" w="med" len="med"/>
+                    </a:lnR>
+                    <a:lnT w="12700" cap="flat" cmpd="sng" algn="ctr">
+                      <a:solidFill>
+                        <a:srgbClr val="F4F6F9"/>
+                      </a:solidFill>
+                      <a:prstDash val="solid"/>
+                      <a:round/>
+                      <a:headEnd type="none" w="med" len="med"/>
+                      <a:tailEnd type="none" w="med" len="med"/>
+                    </a:lnT>
+                    <a:lnB w="12700" cap="flat" cmpd="sng" algn="ctr">
+                      <a:solidFill>
+                        <a:srgbClr val="F4F6F9"/>
+                      </a:solidFill>
+                      <a:prstDash val="solid"/>
+                      <a:round/>
+                      <a:headEnd type="none" w="med" len="med"/>
+                      <a:tailEnd type="none" w="med" len="med"/>
+                    </a:lnB>
+                    <a:solidFill>
+                      <a:srgbClr val="EFF2F6"/>
+                    </a:solidFill>
+                  </a:tcPr>
+                </a:tc>
+                <a:tc>
+                  <a:txBody>
+                    <a:bodyPr/>
+                    <a:lstStyle/>
+                    <a:p>
+                      <a:pPr algn="r" indent="0" marL="0">
+                        <a:buNone/>
+                      </a:pPr>
                       <a:r>
                         <a:rPr lang="en-US" sz="750" b="1" dirty="0">
                           <a:solidFill>
@@ -38721,6 +41247,63 @@
                       <a:pPr algn="r" indent="0" marL="0">
                         <a:buNone/>
                       </a:pPr>
+                      <a:endParaRPr lang="en-US" sz="750" dirty="0">
+                        <a:latin typeface="Calibri" charset="0"/>
+                        <a:ea typeface="Calibri" charset="0"/>
+                        <a:cs typeface="Calibri" charset="0"/>
+                      </a:endParaRPr>
+                    </a:p>
+                  </a:txBody>
+                  <a:tcPr marL="25400" marR="25400" marT="25400" marB="25400" anchor="ctr">
+                    <a:lnL w="12700" cap="flat" cmpd="sng" algn="ctr">
+                      <a:solidFill>
+                        <a:srgbClr val="F4F6F9"/>
+                      </a:solidFill>
+                      <a:prstDash val="solid"/>
+                      <a:round/>
+                      <a:headEnd type="none" w="med" len="med"/>
+                      <a:tailEnd type="none" w="med" len="med"/>
+                    </a:lnL>
+                    <a:lnR w="12700" cap="flat" cmpd="sng" algn="ctr">
+                      <a:solidFill>
+                        <a:srgbClr val="F4F6F9"/>
+                      </a:solidFill>
+                      <a:prstDash val="solid"/>
+                      <a:round/>
+                      <a:headEnd type="none" w="med" len="med"/>
+                      <a:tailEnd type="none" w="med" len="med"/>
+                    </a:lnR>
+                    <a:lnT w="12700" cap="flat" cmpd="sng" algn="ctr">
+                      <a:solidFill>
+                        <a:srgbClr val="F4F6F9"/>
+                      </a:solidFill>
+                      <a:prstDash val="solid"/>
+                      <a:round/>
+                      <a:headEnd type="none" w="med" len="med"/>
+                      <a:tailEnd type="none" w="med" len="med"/>
+                    </a:lnT>
+                    <a:lnB w="12700" cap="flat" cmpd="sng" algn="ctr">
+                      <a:solidFill>
+                        <a:srgbClr val="F4F6F9"/>
+                      </a:solidFill>
+                      <a:prstDash val="solid"/>
+                      <a:round/>
+                      <a:headEnd type="none" w="med" len="med"/>
+                      <a:tailEnd type="none" w="med" len="med"/>
+                    </a:lnB>
+                    <a:solidFill>
+                      <a:srgbClr val="EFF2F6"/>
+                    </a:solidFill>
+                  </a:tcPr>
+                </a:tc>
+                <a:tc>
+                  <a:txBody>
+                    <a:bodyPr/>
+                    <a:lstStyle/>
+                    <a:p>
+                      <a:pPr algn="r" indent="0" marL="0">
+                        <a:buNone/>
+                      </a:pPr>
                       <a:r>
                         <a:rPr lang="en-US" sz="750" b="1" dirty="0">
                           <a:solidFill>
@@ -40168,6 +42751,63 @@
                       <a:pPr algn="r" indent="0" marL="0">
                         <a:buNone/>
                       </a:pPr>
+                      <a:endParaRPr lang="en-US" sz="750" dirty="0">
+                        <a:latin typeface="Calibri" charset="0"/>
+                        <a:ea typeface="Calibri" charset="0"/>
+                        <a:cs typeface="Calibri" charset="0"/>
+                      </a:endParaRPr>
+                    </a:p>
+                  </a:txBody>
+                  <a:tcPr marL="25400" marR="25400" marT="25400" marB="25400" anchor="ctr">
+                    <a:lnL w="12700" cap="flat" cmpd="sng" algn="ctr">
+                      <a:solidFill>
+                        <a:srgbClr val="F4F6F9"/>
+                      </a:solidFill>
+                      <a:prstDash val="solid"/>
+                      <a:round/>
+                      <a:headEnd type="none" w="med" len="med"/>
+                      <a:tailEnd type="none" w="med" len="med"/>
+                    </a:lnL>
+                    <a:lnR w="12700" cap="flat" cmpd="sng" algn="ctr">
+                      <a:solidFill>
+                        <a:srgbClr val="F4F6F9"/>
+                      </a:solidFill>
+                      <a:prstDash val="solid"/>
+                      <a:round/>
+                      <a:headEnd type="none" w="med" len="med"/>
+                      <a:tailEnd type="none" w="med" len="med"/>
+                    </a:lnR>
+                    <a:lnT w="12700" cap="flat" cmpd="sng" algn="ctr">
+                      <a:solidFill>
+                        <a:srgbClr val="F4F6F9"/>
+                      </a:solidFill>
+                      <a:prstDash val="solid"/>
+                      <a:round/>
+                      <a:headEnd type="none" w="med" len="med"/>
+                      <a:tailEnd type="none" w="med" len="med"/>
+                    </a:lnT>
+                    <a:lnB w="12700" cap="flat" cmpd="sng" algn="ctr">
+                      <a:solidFill>
+                        <a:srgbClr val="F4F6F9"/>
+                      </a:solidFill>
+                      <a:prstDash val="solid"/>
+                      <a:round/>
+                      <a:headEnd type="none" w="med" len="med"/>
+                      <a:tailEnd type="none" w="med" len="med"/>
+                    </a:lnB>
+                    <a:solidFill>
+                      <a:srgbClr val="EFF2F6"/>
+                    </a:solidFill>
+                  </a:tcPr>
+                </a:tc>
+                <a:tc>
+                  <a:txBody>
+                    <a:bodyPr/>
+                    <a:lstStyle/>
+                    <a:p>
+                      <a:pPr algn="r" indent="0" marL="0">
+                        <a:buNone/>
+                      </a:pPr>
                       <a:r>
                         <a:rPr lang="en-US" sz="750" b="1" dirty="0">
                           <a:solidFill>
@@ -41582,6 +44222,63 @@
                       <a:pPr algn="r" indent="0" marL="0">
                         <a:buNone/>
                       </a:pPr>
+                      <a:endParaRPr lang="en-US" sz="750" dirty="0">
+                        <a:latin typeface="Calibri" charset="0"/>
+                        <a:ea typeface="Calibri" charset="0"/>
+                        <a:cs typeface="Calibri" charset="0"/>
+                      </a:endParaRPr>
+                    </a:p>
+                  </a:txBody>
+                  <a:tcPr marL="25400" marR="25400" marT="25400" marB="25400" anchor="ctr">
+                    <a:lnL w="12700" cap="flat" cmpd="sng" algn="ctr">
+                      <a:solidFill>
+                        <a:srgbClr val="F4F6F9"/>
+                      </a:solidFill>
+                      <a:prstDash val="solid"/>
+                      <a:round/>
+                      <a:headEnd type="none" w="med" len="med"/>
+                      <a:tailEnd type="none" w="med" len="med"/>
+                    </a:lnL>
+                    <a:lnR w="12700" cap="flat" cmpd="sng" algn="ctr">
+                      <a:solidFill>
+                        <a:srgbClr val="F4F6F9"/>
+                      </a:solidFill>
+                      <a:prstDash val="solid"/>
+                      <a:round/>
+                      <a:headEnd type="none" w="med" len="med"/>
+                      <a:tailEnd type="none" w="med" len="med"/>
+                    </a:lnR>
+                    <a:lnT w="12700" cap="flat" cmpd="sng" algn="ctr">
+                      <a:solidFill>
+                        <a:srgbClr val="F4F6F9"/>
+                      </a:solidFill>
+                      <a:prstDash val="solid"/>
+                      <a:round/>
+                      <a:headEnd type="none" w="med" len="med"/>
+                      <a:tailEnd type="none" w="med" len="med"/>
+                    </a:lnT>
+                    <a:lnB w="12700" cap="flat" cmpd="sng" algn="ctr">
+                      <a:solidFill>
+                        <a:srgbClr val="F4F6F9"/>
+                      </a:solidFill>
+                      <a:prstDash val="solid"/>
+                      <a:round/>
+                      <a:headEnd type="none" w="med" len="med"/>
+                      <a:tailEnd type="none" w="med" len="med"/>
+                    </a:lnB>
+                    <a:solidFill>
+                      <a:srgbClr val="EFF2F6"/>
+                    </a:solidFill>
+                  </a:tcPr>
+                </a:tc>
+                <a:tc>
+                  <a:txBody>
+                    <a:bodyPr/>
+                    <a:lstStyle/>
+                    <a:p>
+                      <a:pPr algn="r" indent="0" marL="0">
+                        <a:buNone/>
+                      </a:pPr>
                       <a:r>
                         <a:rPr lang="en-US" sz="750" b="1" dirty="0">
                           <a:solidFill>
@@ -42996,6 +45693,63 @@
                       <a:pPr algn="r" indent="0" marL="0">
                         <a:buNone/>
                       </a:pPr>
+                      <a:endParaRPr lang="en-US" sz="750" dirty="0">
+                        <a:latin typeface="Calibri" charset="0"/>
+                        <a:ea typeface="Calibri" charset="0"/>
+                        <a:cs typeface="Calibri" charset="0"/>
+                      </a:endParaRPr>
+                    </a:p>
+                  </a:txBody>
+                  <a:tcPr marL="25400" marR="25400" marT="25400" marB="25400" anchor="ctr">
+                    <a:lnL w="12700" cap="flat" cmpd="sng" algn="ctr">
+                      <a:solidFill>
+                        <a:srgbClr val="F4F6F9"/>
+                      </a:solidFill>
+                      <a:prstDash val="solid"/>
+                      <a:round/>
+                      <a:headEnd type="none" w="med" len="med"/>
+                      <a:tailEnd type="none" w="med" len="med"/>
+                    </a:lnL>
+                    <a:lnR w="12700" cap="flat" cmpd="sng" algn="ctr">
+                      <a:solidFill>
+                        <a:srgbClr val="F4F6F9"/>
+                      </a:solidFill>
+                      <a:prstDash val="solid"/>
+                      <a:round/>
+                      <a:headEnd type="none" w="med" len="med"/>
+                      <a:tailEnd type="none" w="med" len="med"/>
+                    </a:lnR>
+                    <a:lnT w="12700" cap="flat" cmpd="sng" algn="ctr">
+                      <a:solidFill>
+                        <a:srgbClr val="F4F6F9"/>
+                      </a:solidFill>
+                      <a:prstDash val="solid"/>
+                      <a:round/>
+                      <a:headEnd type="none" w="med" len="med"/>
+                      <a:tailEnd type="none" w="med" len="med"/>
+                    </a:lnT>
+                    <a:lnB w="12700" cap="flat" cmpd="sng" algn="ctr">
+                      <a:solidFill>
+                        <a:srgbClr val="F4F6F9"/>
+                      </a:solidFill>
+                      <a:prstDash val="solid"/>
+                      <a:round/>
+                      <a:headEnd type="none" w="med" len="med"/>
+                      <a:tailEnd type="none" w="med" len="med"/>
+                    </a:lnB>
+                    <a:solidFill>
+                      <a:srgbClr val="EFF2F6"/>
+                    </a:solidFill>
+                  </a:tcPr>
+                </a:tc>
+                <a:tc>
+                  <a:txBody>
+                    <a:bodyPr/>
+                    <a:lstStyle/>
+                    <a:p>
+                      <a:pPr algn="r" indent="0" marL="0">
+                        <a:buNone/>
+                      </a:pPr>
                       <a:r>
                         <a:rPr lang="en-US" sz="750" b="1" dirty="0">
                           <a:solidFill>
@@ -44421,6 +47175,63 @@
                       <a:pPr algn="r" indent="0" marL="0">
                         <a:buNone/>
                       </a:pPr>
+                      <a:endParaRPr lang="en-US" sz="750" dirty="0">
+                        <a:latin typeface="Calibri" charset="0"/>
+                        <a:ea typeface="Calibri" charset="0"/>
+                        <a:cs typeface="Calibri" charset="0"/>
+                      </a:endParaRPr>
+                    </a:p>
+                  </a:txBody>
+                  <a:tcPr marL="25400" marR="25400" marT="25400" marB="25400" anchor="ctr">
+                    <a:lnL w="12700" cap="flat" cmpd="sng" algn="ctr">
+                      <a:solidFill>
+                        <a:srgbClr val="F4F6F9"/>
+                      </a:solidFill>
+                      <a:prstDash val="solid"/>
+                      <a:round/>
+                      <a:headEnd type="none" w="med" len="med"/>
+                      <a:tailEnd type="none" w="med" len="med"/>
+                    </a:lnL>
+                    <a:lnR w="12700" cap="flat" cmpd="sng" algn="ctr">
+                      <a:solidFill>
+                        <a:srgbClr val="F4F6F9"/>
+                      </a:solidFill>
+                      <a:prstDash val="solid"/>
+                      <a:round/>
+                      <a:headEnd type="none" w="med" len="med"/>
+                      <a:tailEnd type="none" w="med" len="med"/>
+                    </a:lnR>
+                    <a:lnT w="12700" cap="flat" cmpd="sng" algn="ctr">
+                      <a:solidFill>
+                        <a:srgbClr val="F4F6F9"/>
+                      </a:solidFill>
+                      <a:prstDash val="solid"/>
+                      <a:round/>
+                      <a:headEnd type="none" w="med" len="med"/>
+                      <a:tailEnd type="none" w="med" len="med"/>
+                    </a:lnT>
+                    <a:lnB w="12700" cap="flat" cmpd="sng" algn="ctr">
+                      <a:solidFill>
+                        <a:srgbClr val="F4F6F9"/>
+                      </a:solidFill>
+                      <a:prstDash val="solid"/>
+                      <a:round/>
+                      <a:headEnd type="none" w="med" len="med"/>
+                      <a:tailEnd type="none" w="med" len="med"/>
+                    </a:lnB>
+                    <a:solidFill>
+                      <a:srgbClr val="EFF2F6"/>
+                    </a:solidFill>
+                  </a:tcPr>
+                </a:tc>
+                <a:tc>
+                  <a:txBody>
+                    <a:bodyPr/>
+                    <a:lstStyle/>
+                    <a:p>
+                      <a:pPr algn="r" indent="0" marL="0">
+                        <a:buNone/>
+                      </a:pPr>
                       <a:r>
                         <a:rPr lang="en-US" sz="750" b="1" dirty="0">
                           <a:solidFill>
@@ -45989,6 +48800,63 @@
                       <a:pPr algn="r" indent="0" marL="0">
                         <a:buNone/>
                       </a:pPr>
+                      <a:endParaRPr lang="en-US" sz="750" dirty="0">
+                        <a:latin typeface="Calibri" charset="0"/>
+                        <a:ea typeface="Calibri" charset="0"/>
+                        <a:cs typeface="Calibri" charset="0"/>
+                      </a:endParaRPr>
+                    </a:p>
+                  </a:txBody>
+                  <a:tcPr marL="25400" marR="25400" marT="25400" marB="25400" anchor="ctr">
+                    <a:lnL w="12700" cap="flat" cmpd="sng" algn="ctr">
+                      <a:solidFill>
+                        <a:srgbClr val="F4F6F9"/>
+                      </a:solidFill>
+                      <a:prstDash val="solid"/>
+                      <a:round/>
+                      <a:headEnd type="none" w="med" len="med"/>
+                      <a:tailEnd type="none" w="med" len="med"/>
+                    </a:lnL>
+                    <a:lnR w="12700" cap="flat" cmpd="sng" algn="ctr">
+                      <a:solidFill>
+                        <a:srgbClr val="F4F6F9"/>
+                      </a:solidFill>
+                      <a:prstDash val="solid"/>
+                      <a:round/>
+                      <a:headEnd type="none" w="med" len="med"/>
+                      <a:tailEnd type="none" w="med" len="med"/>
+                    </a:lnR>
+                    <a:lnT w="12700" cap="flat" cmpd="sng" algn="ctr">
+                      <a:solidFill>
+                        <a:srgbClr val="F4F6F9"/>
+                      </a:solidFill>
+                      <a:prstDash val="solid"/>
+                      <a:round/>
+                      <a:headEnd type="none" w="med" len="med"/>
+                      <a:tailEnd type="none" w="med" len="med"/>
+                    </a:lnT>
+                    <a:lnB w="12700" cap="flat" cmpd="sng" algn="ctr">
+                      <a:solidFill>
+                        <a:srgbClr val="F4F6F9"/>
+                      </a:solidFill>
+                      <a:prstDash val="solid"/>
+                      <a:round/>
+                      <a:headEnd type="none" w="med" len="med"/>
+                      <a:tailEnd type="none" w="med" len="med"/>
+                    </a:lnB>
+                    <a:solidFill>
+                      <a:srgbClr val="EFF2F6"/>
+                    </a:solidFill>
+                  </a:tcPr>
+                </a:tc>
+                <a:tc>
+                  <a:txBody>
+                    <a:bodyPr/>
+                    <a:lstStyle/>
+                    <a:p>
+                      <a:pPr algn="r" indent="0" marL="0">
+                        <a:buNone/>
+                      </a:pPr>
                       <a:r>
                         <a:rPr lang="en-US" sz="750" b="1" dirty="0">
                           <a:solidFill>
@@ -47626,13 +50494,81 @@
                       <a:r>
                         <a:rPr lang="en-US" sz="750" b="1" dirty="0">
                           <a:solidFill>
+                            <a:srgbClr val="C0392B"/>
+                          </a:solidFill>
+                          <a:latin typeface="Calibri" pitchFamily="34" charset="0"/>
+                          <a:ea typeface="Calibri" pitchFamily="34" charset="-122"/>
+                          <a:cs typeface="Calibri" pitchFamily="34" charset="-120"/>
+                        </a:rPr>
+                        <a:t>0/7</a:t>
+                      </a:r>
+                      <a:endParaRPr lang="en-US" sz="750" dirty="0">
+                        <a:latin typeface="Calibri" charset="0"/>
+                        <a:ea typeface="Calibri" charset="0"/>
+                        <a:cs typeface="Calibri" charset="0"/>
+                      </a:endParaRPr>
+                    </a:p>
+                  </a:txBody>
+                  <a:tcPr marL="25400" marR="25400" marT="25400" marB="25400" anchor="ctr">
+                    <a:lnL w="12700" cap="flat" cmpd="sng" algn="ctr">
+                      <a:solidFill>
+                        <a:srgbClr val="F4F6F9"/>
+                      </a:solidFill>
+                      <a:prstDash val="solid"/>
+                      <a:round/>
+                      <a:headEnd type="none" w="med" len="med"/>
+                      <a:tailEnd type="none" w="med" len="med"/>
+                    </a:lnL>
+                    <a:lnR w="12700" cap="flat" cmpd="sng" algn="ctr">
+                      <a:solidFill>
+                        <a:srgbClr val="F4F6F9"/>
+                      </a:solidFill>
+                      <a:prstDash val="solid"/>
+                      <a:round/>
+                      <a:headEnd type="none" w="med" len="med"/>
+                      <a:tailEnd type="none" w="med" len="med"/>
+                    </a:lnR>
+                    <a:lnT w="12700" cap="flat" cmpd="sng" algn="ctr">
+                      <a:solidFill>
+                        <a:srgbClr val="F4F6F9"/>
+                      </a:solidFill>
+                      <a:prstDash val="solid"/>
+                      <a:round/>
+                      <a:headEnd type="none" w="med" len="med"/>
+                      <a:tailEnd type="none" w="med" len="med"/>
+                    </a:lnT>
+                    <a:lnB w="12700" cap="flat" cmpd="sng" algn="ctr">
+                      <a:solidFill>
+                        <a:srgbClr val="F4F6F9"/>
+                      </a:solidFill>
+                      <a:prstDash val="solid"/>
+                      <a:round/>
+                      <a:headEnd type="none" w="med" len="med"/>
+                      <a:tailEnd type="none" w="med" len="med"/>
+                    </a:lnB>
+                    <a:solidFill>
+                      <a:srgbClr val="F4F6F9"/>
+                    </a:solidFill>
+                  </a:tcPr>
+                </a:tc>
+                <a:tc>
+                  <a:txBody>
+                    <a:bodyPr/>
+                    <a:lstStyle/>
+                    <a:p>
+                      <a:pPr algn="r" indent="0" marL="0">
+                        <a:buNone/>
+                      </a:pPr>
+                      <a:r>
+                        <a:rPr lang="en-US" sz="750" b="1" dirty="0">
+                          <a:solidFill>
                             <a:srgbClr val="56606E"/>
                           </a:solidFill>
                           <a:latin typeface="Calibri" pitchFamily="34" charset="0"/>
                           <a:ea typeface="Calibri" pitchFamily="34" charset="-122"/>
                           <a:cs typeface="Calibri" pitchFamily="34" charset="-120"/>
                         </a:rPr>
-                        <a:t>108/491</a:t>
+                        <a:t>108/498</a:t>
                       </a:r>
                       <a:endParaRPr lang="en-US" sz="750" dirty="0">
                         <a:latin typeface="Calibri" charset="0"/>
@@ -48296,7 +51232,7 @@
                 <a:ea typeface="Cambria" pitchFamily="34" charset="-122"/>
                 <a:cs typeface="Cambria" pitchFamily="34" charset="-120"/>
               </a:rPr>
-              <a:t>251</a:t>
+              <a:t>258</a:t>
             </a:r>
             <a:endParaRPr lang="en-US" sz="2100" dirty="0"/>
           </a:p>
@@ -48374,7 +51310,7 @@
                 <a:ea typeface="Calibri" pitchFamily="34" charset="-122"/>
                 <a:cs typeface="Calibri" pitchFamily="34" charset="-120"/>
               </a:rPr>
-              <a:t>El costo se imputa al mes de emisión: la columna «Costo De La No Conformidad» no trae fecha propia. El mes más caro es jul-25 con 4.382 UF. Los últimos 4 meses no traen ningún monto declarado —un mes en blanco es «sin declarar», no «sin costo»—. La cifra es un piso del costo real.</a:t>
+              <a:t>El costo se imputa al mes de emisión: la columna «Costo De La No Conformidad» no trae fecha propia. El mes más caro es jul-25 con 4.382 UF. Los últimos 5 meses no traen ningún monto declarado —un mes en blanco es «sin declarar», no «sin costo»—. La cifra es un piso del costo real.</a:t>
             </a:r>
             <a:endParaRPr lang="en-US" sz="950" dirty="0"/>
           </a:p>
@@ -48413,7 +51349,7 @@
                 <a:ea typeface="Calibri" pitchFamily="34" charset="-122"/>
                 <a:cs typeface="Calibri" pitchFamily="34" charset="-120"/>
               </a:rPr>
-              <a:t>Fuente: Data_NCR31082026.xlsx — hoja «Observaciones» · Corte 31-08-2026 · 502 registros desde 10-02-2023</a:t>
+              <a:t>Fuente: Data_NCR07092026.xlsx — hoja «Observaciones» · Corte 07-09-2026 · 509 registros desde 10-02-2023</a:t>
             </a:r>
             <a:endParaRPr lang="en-US" sz="850" dirty="0"/>
           </a:p>
@@ -48787,7 +51723,7 @@
                 <a:ea typeface="Calibri" pitchFamily="34" charset="-122"/>
                 <a:cs typeface="Calibri" pitchFamily="34" charset="-120"/>
               </a:rPr>
-              <a:t>32 de los 39 hallazgos abiertos (82,1%) y 80,5% de cierre, contra 92,2% global. Es la ruta crítica del módulo.</a:t>
+              <a:t>38 de los 46 hallazgos abiertos (82,6%) y 77,6% de cierre, contra 91% global. Es la ruta crítica del módulo.</a:t>
             </a:r>
             <a:endParaRPr lang="en-US" sz="1100" dirty="0"/>
           </a:p>
@@ -48929,7 +51865,7 @@
                 <a:ea typeface="Calibri" pitchFamily="34" charset="-122"/>
                 <a:cs typeface="Calibri" pitchFamily="34" charset="-120"/>
               </a:rPr>
-              <a:t>Solo 21% de sus hallazgos los detecta Besalco; el mejor frente va en 66,7%. Lo que no se detecta adentro llega como observación del cliente.</a:t>
+              <a:t>Solo 20,9% de sus hallazgos los detecta Besalco; el mejor frente va en 66,7%. Lo que no se detecta adentro llega como observación del cliente.</a:t>
             </a:r>
             <a:endParaRPr lang="en-US" sz="1100" dirty="0"/>
           </a:p>
@@ -49029,7 +51965,7 @@
                 <a:ea typeface="Calibri" pitchFamily="34" charset="-122"/>
                 <a:cs typeface="Calibri" pitchFamily="34" charset="-120"/>
               </a:rPr>
-              <a:t>Sacar los 13 hallazgos sobre 180 días</a:t>
+              <a:t>Sacar los 17 hallazgos sobre 180 días</a:t>
             </a:r>
             <a:endParaRPr lang="en-US" sz="1400" dirty="0"/>
           </a:p>
@@ -49071,7 +52007,7 @@
                 <a:ea typeface="Calibri" pitchFamily="34" charset="-122"/>
                 <a:cs typeface="Calibri" pitchFamily="34" charset="-120"/>
               </a:rPr>
-              <a:t>0 de ellos superan el año abiertos. Los tienen a cargo Sin asignar (13). Es deuda antigua que no se cierra sola.</a:t>
+              <a:t>0 de ellos superan el año abiertos. Los tienen a cargo Sin asignar (17). Es deuda antigua que no se cierra sola.</a:t>
             </a:r>
             <a:endParaRPr lang="en-US" sz="1100" dirty="0"/>
           </a:p>
@@ -49171,7 +52107,7 @@
                 <a:ea typeface="Calibri" pitchFamily="34" charset="-122"/>
                 <a:cs typeface="Calibri" pitchFamily="34" charset="-120"/>
               </a:rPr>
-              <a:t>Responder las 38 que pasaron el plazo</a:t>
+              <a:t>Responder las 39 que pasaron el plazo</a:t>
             </a:r>
             <a:endParaRPr lang="en-US" sz="1400" dirty="0"/>
           </a:p>
@@ -49213,7 +52149,7 @@
                 <a:ea typeface="Calibri" pitchFamily="34" charset="-122"/>
                 <a:cs typeface="Calibri" pitchFamily="34" charset="-120"/>
               </a:rPr>
-              <a:t>El plazo es de 10 días desde la emisión y hoy lo incumplen 97,4% de los abiertos. Solo 1 siguen dentro de plazo.</a:t>
+              <a:t>El plazo es de 10 días desde la emisión y hoy lo incumplen 84,8% de los abiertos. Solo 7 siguen dentro de plazo.</a:t>
             </a:r>
             <a:endParaRPr lang="en-US" sz="1100" dirty="0"/>
           </a:p>
@@ -49252,7 +52188,7 @@
                 <a:ea typeface="Calibri" pitchFamily="34" charset="-122"/>
                 <a:cs typeface="Calibri" pitchFamily="34" charset="-120"/>
               </a:rPr>
-              <a:t>Fuente: Data_NCR31082026.xlsx — hoja «Observaciones» · Corte 31-08-2026 · 502 registros desde 10-02-2023</a:t>
+              <a:t>Fuente: Data_NCR07092026.xlsx — hoja «Observaciones» · Corte 07-09-2026 · 509 registros desde 10-02-2023</a:t>
             </a:r>
             <a:endParaRPr lang="en-US" sz="850" dirty="0"/>
           </a:p>
@@ -49976,7 +52912,7 @@
                 <a:ea typeface="Calibri" pitchFamily="34" charset="-122"/>
                 <a:cs typeface="Calibri" pitchFamily="34" charset="-120"/>
               </a:rPr>
-              <a:t>Corte: 31-08-2026</a:t>
+              <a:t>Corte: 07-09-2026</a:t>
             </a:r>
             <a:endParaRPr lang="en-US" sz="1100" dirty="0"/>
           </a:p>
@@ -50015,7 +52951,7 @@
                 <a:ea typeface="Calibri" pitchFamily="34" charset="-122"/>
                 <a:cs typeface="Calibri" pitchFamily="34" charset="-120"/>
               </a:rPr>
-              <a:t>Fuente: Data_NCR31082026.xlsx — hoja «Observaciones» · Corte 31-08-2026 · 502 registros desde 10-02-2023</a:t>
+              <a:t>Fuente: Data_NCR07092026.xlsx — hoja «Observaciones» · Corte 07-09-2026 · 509 registros desde 10-02-2023</a:t>
             </a:r>
             <a:endParaRPr lang="en-US" sz="850" dirty="0"/>
           </a:p>

</xml_diff>